<commit_message>
Change 有人対応 to AI音声 in Kill Chain diagram
The attacker-side voice interactions are more likely AI-generated
than human-operated given the cost efficiency of scaling attacks.

https://claude.ai/code/session_01F7t8LKifK43o6sCdF2a3gQ
</commit_message>
<xml_diff>
--- a/Fraud_Kill_Chain.pptx
+++ b/Fraud_Kill_Chain.pptx
@@ -5787,7 +5787,7 @@
                 </a:solidFill>
                 <a:latin typeface="Meiryo"/>
               </a:rPr>
-              <a:t>【有人対応】
+              <a:t>【AI音声】
 「パソコン環境の更新が必要。現在口座の利用制限をしています。手続きを郵送していますが、届いてますか。更新されていないので電話しました」</a:t>
             </a:r>
           </a:p>
@@ -5927,7 +5927,7 @@
                 </a:solidFill>
                 <a:latin typeface="Meiryo"/>
               </a:rPr>
-              <a:t>【未済の場合】
+              <a:t>【AI音声・未済の場合】
 「手続きをメールで案内するので、メールアドレスを教えてください」</a:t>
             </a:r>
           </a:p>
@@ -6253,7 +6253,7 @@
                 </a:solidFill>
                 <a:latin typeface="Meiryo"/>
               </a:rPr>
-              <a:t>【有人対応】
+              <a:t>【AI音声】
 「セキュリティ強化のためソフトインストールが必要です。メールのボタンをクリックしてください」</a:t>
             </a:r>
           </a:p>

</xml_diff>

<commit_message>
Add corporate banking target banners to Kill Chain diagram
Highlight that this attack specifically targets corporate IB
(BizSTATION), the attacker knows the full auth flow, and
corporate accounts carry multi-million yen transfer limits.

https://claude.ai/code/session_01F7t8LKifK43o6sCdF2a3gQ
</commit_message>
<xml_diff>
--- a/Fraud_Kill_Chain.pptx
+++ b/Fraud_Kill_Chain.pptx
@@ -3170,14 +3170,14 @@
         </p:nvSpPr>
         <p:spPr>
           <a:xfrm>
-            <a:off x="1225296" y="822960"/>
-            <a:ext cx="5248656" cy="320040"/>
-          </a:xfrm>
-          <a:prstGeom prst="rect">
-            <a:avLst/>
-          </a:prstGeom>
-          <a:solidFill>
-            <a:srgbClr val="222222"/>
+            <a:off x="457200" y="804672"/>
+            <a:ext cx="2926080" cy="274320"/>
+          </a:xfrm>
+          <a:prstGeom prst="rect">
+            <a:avLst/>
+          </a:prstGeom>
+          <a:solidFill>
+            <a:srgbClr val="C0392B"/>
           </a:solidFill>
           <a:ln>
             <a:noFill/>
@@ -3203,13 +3203,13 @@
           <a:p>
             <a:pPr algn="ctr"/>
             <a:r>
-              <a:rPr sz="1100" b="1">
+              <a:rPr sz="1000" b="1">
                 <a:solidFill>
                   <a:srgbClr val="FFFFFF"/>
                 </a:solidFill>
                 <a:latin typeface="Meiryo"/>
               </a:rPr>
-              <a:t>犯人サイド</a:t>
+              <a:t>対象：法人向けIB（BizSTATION）</a:t>
             </a:r>
           </a:p>
         </p:txBody>
@@ -3222,14 +3222,14 @@
         </p:nvSpPr>
         <p:spPr>
           <a:xfrm>
-            <a:off x="6510528" y="822960"/>
-            <a:ext cx="7891272" cy="320040"/>
-          </a:xfrm>
-          <a:prstGeom prst="rect">
-            <a:avLst/>
-          </a:prstGeom>
-          <a:solidFill>
-            <a:srgbClr val="E67E22"/>
+            <a:off x="3520440" y="804672"/>
+            <a:ext cx="6217920" cy="274320"/>
+          </a:xfrm>
+          <a:prstGeom prst="rect">
+            <a:avLst/>
+          </a:prstGeom>
+          <a:solidFill>
+            <a:srgbClr val="222222"/>
           </a:solidFill>
           <a:ln>
             <a:noFill/>
@@ -3255,13 +3255,13 @@
           <a:p>
             <a:pPr algn="ctr"/>
             <a:r>
-              <a:rPr sz="1100" b="1">
+              <a:rPr sz="800" b="0">
                 <a:solidFill>
                   <a:srgbClr val="FFFFFF"/>
                 </a:solidFill>
                 <a:latin typeface="Meiryo"/>
               </a:rPr>
-              <a:t>被害企業サイド</a:t>
+              <a:t>犯人はBizSTATIONの認証フロー（契約者番号→利用者ID→ログインPW→取引実行PW→OTP）を完全に把握</a:t>
             </a:r>
           </a:p>
         </p:txBody>
@@ -3274,14 +3274,14 @@
         </p:nvSpPr>
         <p:spPr>
           <a:xfrm>
-            <a:off x="182880" y="1179576"/>
-            <a:ext cx="1005840" cy="274320"/>
-          </a:xfrm>
-          <a:prstGeom prst="rect">
-            <a:avLst/>
-          </a:prstGeom>
-          <a:solidFill>
-            <a:srgbClr val="EEEEEE"/>
+            <a:off x="9875520" y="804672"/>
+            <a:ext cx="4754880" cy="274320"/>
+          </a:xfrm>
+          <a:prstGeom prst="rect">
+            <a:avLst/>
+          </a:prstGeom>
+          <a:solidFill>
+            <a:srgbClr val="E67E22"/>
           </a:solidFill>
           <a:ln>
             <a:noFill/>
@@ -3307,13 +3307,13 @@
           <a:p>
             <a:pPr algn="ctr"/>
             <a:r>
-              <a:rPr sz="900" b="1">
-                <a:solidFill>
-                  <a:srgbClr val="222222"/>
-                </a:solidFill>
-                <a:latin typeface="Meiryo"/>
-              </a:rPr>
-              <a:t>フェーズ</a:t>
+              <a:rPr sz="800" b="0">
+                <a:solidFill>
+                  <a:srgbClr val="FFFFFF"/>
+                </a:solidFill>
+                <a:latin typeface="Meiryo"/>
+              </a:rPr>
+              <a:t>法人IBは送金限度額が高く、1件で数千万〜数億円の被害リスク</a:t>
             </a:r>
           </a:p>
         </p:txBody>
@@ -3326,14 +3326,14 @@
         </p:nvSpPr>
         <p:spPr>
           <a:xfrm>
-            <a:off x="1225296" y="1179576"/>
-            <a:ext cx="2606040" cy="274320"/>
-          </a:xfrm>
-          <a:prstGeom prst="rect">
-            <a:avLst/>
-          </a:prstGeom>
-          <a:solidFill>
-            <a:srgbClr val="EEEEEE"/>
+            <a:off x="1225296" y="1143000"/>
+            <a:ext cx="5248656" cy="320040"/>
+          </a:xfrm>
+          <a:prstGeom prst="rect">
+            <a:avLst/>
+          </a:prstGeom>
+          <a:solidFill>
+            <a:srgbClr val="222222"/>
           </a:solidFill>
           <a:ln>
             <a:noFill/>
@@ -3359,13 +3359,13 @@
           <a:p>
             <a:pPr algn="ctr"/>
             <a:r>
-              <a:rPr sz="900" b="1">
-                <a:solidFill>
-                  <a:srgbClr val="222222"/>
-                </a:solidFill>
-                <a:latin typeface="Meiryo"/>
-              </a:rPr>
-              <a:t>情報・インフラ</a:t>
+              <a:rPr sz="1100" b="1">
+                <a:solidFill>
+                  <a:srgbClr val="FFFFFF"/>
+                </a:solidFill>
+                <a:latin typeface="Meiryo"/>
+              </a:rPr>
+              <a:t>犯人サイド</a:t>
             </a:r>
           </a:p>
         </p:txBody>
@@ -3378,14 +3378,14 @@
         </p:nvSpPr>
         <p:spPr>
           <a:xfrm>
-            <a:off x="3867912" y="1179576"/>
-            <a:ext cx="2606040" cy="274320"/>
-          </a:xfrm>
-          <a:prstGeom prst="rect">
-            <a:avLst/>
-          </a:prstGeom>
-          <a:solidFill>
-            <a:srgbClr val="EEEEEE"/>
+            <a:off x="6510528" y="1143000"/>
+            <a:ext cx="7891272" cy="320040"/>
+          </a:xfrm>
+          <a:prstGeom prst="rect">
+            <a:avLst/>
+          </a:prstGeom>
+          <a:solidFill>
+            <a:srgbClr val="E67E22"/>
           </a:solidFill>
           <a:ln>
             <a:noFill/>
@@ -3411,13 +3411,13 @@
           <a:p>
             <a:pPr algn="ctr"/>
             <a:r>
-              <a:rPr sz="900" b="1">
-                <a:solidFill>
-                  <a:srgbClr val="222222"/>
-                </a:solidFill>
-                <a:latin typeface="Meiryo"/>
-              </a:rPr>
-              <a:t>架電</a:t>
+              <a:rPr sz="1100" b="1">
+                <a:solidFill>
+                  <a:srgbClr val="FFFFFF"/>
+                </a:solidFill>
+                <a:latin typeface="Meiryo"/>
+              </a:rPr>
+              <a:t>被害企業サイド</a:t>
             </a:r>
           </a:p>
         </p:txBody>
@@ -3430,8 +3430,8 @@
         </p:nvSpPr>
         <p:spPr>
           <a:xfrm>
-            <a:off x="6510528" y="1179576"/>
-            <a:ext cx="2606040" cy="274320"/>
+            <a:off x="182880" y="1499616"/>
+            <a:ext cx="1005840" cy="274320"/>
           </a:xfrm>
           <a:prstGeom prst="rect">
             <a:avLst/>
@@ -3469,7 +3469,7 @@
                 </a:solidFill>
                 <a:latin typeface="Meiryo"/>
               </a:rPr>
-              <a:t>受電</a:t>
+              <a:t>フェーズ</a:t>
             </a:r>
           </a:p>
         </p:txBody>
@@ -3482,7 +3482,7 @@
         </p:nvSpPr>
         <p:spPr>
           <a:xfrm>
-            <a:off x="9153144" y="1179576"/>
+            <a:off x="1225296" y="1499616"/>
             <a:ext cx="2606040" cy="274320"/>
           </a:xfrm>
           <a:prstGeom prst="rect">
@@ -3521,7 +3521,7 @@
                 </a:solidFill>
                 <a:latin typeface="Meiryo"/>
               </a:rPr>
-              <a:t>会社のPC</a:t>
+              <a:t>情報・インフラ</a:t>
             </a:r>
           </a:p>
         </p:txBody>
@@ -3534,7 +3534,7 @@
         </p:nvSpPr>
         <p:spPr>
           <a:xfrm>
-            <a:off x="11795760" y="1179576"/>
+            <a:off x="3867912" y="1499616"/>
             <a:ext cx="2606040" cy="274320"/>
           </a:xfrm>
           <a:prstGeom prst="rect">
@@ -3573,7 +3573,7 @@
                 </a:solidFill>
                 <a:latin typeface="Meiryo"/>
               </a:rPr>
-              <a:t>個人スマホ</a:t>
+              <a:t>架電</a:t>
             </a:r>
           </a:p>
         </p:txBody>
@@ -3586,14 +3586,14 @@
         </p:nvSpPr>
         <p:spPr>
           <a:xfrm>
-            <a:off x="182880" y="1051560"/>
-            <a:ext cx="1005840" cy="960120"/>
-          </a:xfrm>
-          <a:prstGeom prst="rect">
-            <a:avLst/>
-          </a:prstGeom>
-          <a:solidFill>
-            <a:srgbClr val="C0392B"/>
+            <a:off x="6510528" y="1499616"/>
+            <a:ext cx="2606040" cy="274320"/>
+          </a:xfrm>
+          <a:prstGeom prst="rect">
+            <a:avLst/>
+          </a:prstGeom>
+          <a:solidFill>
+            <a:srgbClr val="EEEEEE"/>
           </a:solidFill>
           <a:ln>
             <a:noFill/>
@@ -3619,14 +3619,13 @@
           <a:p>
             <a:pPr algn="ctr"/>
             <a:r>
-              <a:rPr sz="1000" b="1">
-                <a:solidFill>
-                  <a:srgbClr val="FFFFFF"/>
-                </a:solidFill>
-                <a:latin typeface="Meiryo"/>
-              </a:rPr>
-              <a:t>① 犯行準備
-（偵察など）</a:t>
+              <a:rPr sz="900" b="1">
+                <a:solidFill>
+                  <a:srgbClr val="222222"/>
+                </a:solidFill>
+                <a:latin typeface="Meiryo"/>
+              </a:rPr>
+              <a:t>受電</a:t>
             </a:r>
           </a:p>
         </p:txBody>
@@ -3639,14 +3638,14 @@
         </p:nvSpPr>
         <p:spPr>
           <a:xfrm>
-            <a:off x="182880" y="2048256"/>
-            <a:ext cx="1005840" cy="1051560"/>
-          </a:xfrm>
-          <a:prstGeom prst="rect">
-            <a:avLst/>
-          </a:prstGeom>
-          <a:solidFill>
-            <a:srgbClr val="C0392B"/>
+            <a:off x="9153144" y="1499616"/>
+            <a:ext cx="2606040" cy="274320"/>
+          </a:xfrm>
+          <a:prstGeom prst="rect">
+            <a:avLst/>
+          </a:prstGeom>
+          <a:solidFill>
+            <a:srgbClr val="EEEEEE"/>
           </a:solidFill>
           <a:ln>
             <a:noFill/>
@@ -3672,14 +3671,13 @@
           <a:p>
             <a:pPr algn="ctr"/>
             <a:r>
-              <a:rPr sz="1000" b="1">
-                <a:solidFill>
-                  <a:srgbClr val="FFFFFF"/>
-                </a:solidFill>
-                <a:latin typeface="Meiryo"/>
-              </a:rPr>
-              <a:t>② 被害者への
-接触</a:t>
+              <a:rPr sz="900" b="1">
+                <a:solidFill>
+                  <a:srgbClr val="222222"/>
+                </a:solidFill>
+                <a:latin typeface="Meiryo"/>
+              </a:rPr>
+              <a:t>会社のPC</a:t>
             </a:r>
           </a:p>
         </p:txBody>
@@ -3692,14 +3690,14 @@
         </p:nvSpPr>
         <p:spPr>
           <a:xfrm>
-            <a:off x="182880" y="3136392"/>
-            <a:ext cx="1005840" cy="2331720"/>
-          </a:xfrm>
-          <a:prstGeom prst="rect">
-            <a:avLst/>
-          </a:prstGeom>
-          <a:solidFill>
-            <a:srgbClr val="C0392B"/>
+            <a:off x="11795760" y="1499616"/>
+            <a:ext cx="2606040" cy="274320"/>
+          </a:xfrm>
+          <a:prstGeom prst="rect">
+            <a:avLst/>
+          </a:prstGeom>
+          <a:solidFill>
+            <a:srgbClr val="EEEEEE"/>
           </a:solidFill>
           <a:ln>
             <a:noFill/>
@@ -3725,13 +3723,13 @@
           <a:p>
             <a:pPr algn="ctr"/>
             <a:r>
-              <a:rPr sz="1000" b="1">
-                <a:solidFill>
-                  <a:srgbClr val="FFFFFF"/>
-                </a:solidFill>
-                <a:latin typeface="Meiryo"/>
-              </a:rPr>
-              <a:t>③ 心理的操作</a:t>
+              <a:rPr sz="900" b="1">
+                <a:solidFill>
+                  <a:srgbClr val="222222"/>
+                </a:solidFill>
+                <a:latin typeface="Meiryo"/>
+              </a:rPr>
+              <a:t>個人スマホ</a:t>
             </a:r>
           </a:p>
         </p:txBody>
@@ -3744,8 +3742,8 @@
         </p:nvSpPr>
         <p:spPr>
           <a:xfrm>
-            <a:off x="182880" y="5504688"/>
-            <a:ext cx="1005840" cy="2377440"/>
+            <a:off x="182880" y="1371600"/>
+            <a:ext cx="1005840" cy="868680"/>
           </a:xfrm>
           <a:prstGeom prst="rect">
             <a:avLst/>
@@ -3783,8 +3781,8 @@
                 </a:solidFill>
                 <a:latin typeface="Meiryo"/>
               </a:rPr>
-              <a:t>④ システムや
-機能の侵害</a:t>
+              <a:t>① 犯行準備
+（偵察など）</a:t>
             </a:r>
           </a:p>
         </p:txBody>
@@ -3797,8 +3795,8 @@
         </p:nvSpPr>
         <p:spPr>
           <a:xfrm>
-            <a:off x="182880" y="7918704"/>
-            <a:ext cx="1005840" cy="2423160"/>
+            <a:off x="182880" y="2276856"/>
+            <a:ext cx="1005840" cy="960120"/>
           </a:xfrm>
           <a:prstGeom prst="rect">
             <a:avLst/>
@@ -3836,8 +3834,8 @@
                 </a:solidFill>
                 <a:latin typeface="Meiryo"/>
               </a:rPr>
-              <a:t>⑤ 侵害に使用
-する認証情報</a:t>
+              <a:t>② 被害者への
+接触</a:t>
             </a:r>
           </a:p>
         </p:txBody>
@@ -3850,8 +3848,8 @@
         </p:nvSpPr>
         <p:spPr>
           <a:xfrm>
-            <a:off x="182880" y="10378440"/>
-            <a:ext cx="1005840" cy="594360"/>
+            <a:off x="182880" y="3273552"/>
+            <a:ext cx="1005840" cy="2148840"/>
           </a:xfrm>
           <a:prstGeom prst="rect">
             <a:avLst/>
@@ -3889,8 +3887,7 @@
                 </a:solidFill>
                 <a:latin typeface="Meiryo"/>
               </a:rPr>
-              <a:t>⑥ 収益化
-／マネロン</a:t>
+              <a:t>③ 心理的操作</a:t>
             </a:r>
           </a:p>
         </p:txBody>
@@ -3903,14 +3900,14 @@
         </p:nvSpPr>
         <p:spPr>
           <a:xfrm>
-            <a:off x="1225296" y="1051560"/>
-            <a:ext cx="2606040" cy="960120"/>
-          </a:xfrm>
-          <a:prstGeom prst="rect">
-            <a:avLst/>
-          </a:prstGeom>
-          <a:solidFill>
-            <a:srgbClr val="FFFFFF"/>
+            <a:off x="182880" y="5458968"/>
+            <a:ext cx="1005840" cy="2240280"/>
+          </a:xfrm>
+          <a:prstGeom prst="rect">
+            <a:avLst/>
+          </a:prstGeom>
+          <a:solidFill>
+            <a:srgbClr val="C0392B"/>
           </a:solidFill>
           <a:ln>
             <a:noFill/>
@@ -3936,13 +3933,14 @@
           <a:p>
             <a:pPr algn="ctr"/>
             <a:r>
-              <a:rPr sz="100" b="1">
+              <a:rPr sz="1000" b="1">
                 <a:solidFill>
                   <a:srgbClr val="FFFFFF"/>
                 </a:solidFill>
                 <a:latin typeface="Meiryo"/>
               </a:rPr>
-              <a:t/>
+              <a:t>④ システムや
+機能の侵害</a:t>
             </a:r>
           </a:p>
         </p:txBody>
@@ -3955,14 +3953,14 @@
         </p:nvSpPr>
         <p:spPr>
           <a:xfrm>
-            <a:off x="3867912" y="1051560"/>
-            <a:ext cx="2606040" cy="960120"/>
-          </a:xfrm>
-          <a:prstGeom prst="rect">
-            <a:avLst/>
-          </a:prstGeom>
-          <a:solidFill>
-            <a:srgbClr val="FFFFFF"/>
+            <a:off x="182880" y="7735824"/>
+            <a:ext cx="1005840" cy="2286000"/>
+          </a:xfrm>
+          <a:prstGeom prst="rect">
+            <a:avLst/>
+          </a:prstGeom>
+          <a:solidFill>
+            <a:srgbClr val="C0392B"/>
           </a:solidFill>
           <a:ln>
             <a:noFill/>
@@ -3988,13 +3986,14 @@
           <a:p>
             <a:pPr algn="ctr"/>
             <a:r>
-              <a:rPr sz="100" b="1">
+              <a:rPr sz="1000" b="1">
                 <a:solidFill>
                   <a:srgbClr val="FFFFFF"/>
                 </a:solidFill>
                 <a:latin typeface="Meiryo"/>
               </a:rPr>
-              <a:t/>
+              <a:t>⑤ 侵害に使用
+する認証情報</a:t>
             </a:r>
           </a:p>
         </p:txBody>
@@ -4007,14 +4006,14 @@
         </p:nvSpPr>
         <p:spPr>
           <a:xfrm>
-            <a:off x="6510528" y="1051560"/>
-            <a:ext cx="2606040" cy="960120"/>
-          </a:xfrm>
-          <a:prstGeom prst="rect">
-            <a:avLst/>
-          </a:prstGeom>
-          <a:solidFill>
-            <a:srgbClr val="FFFFFF"/>
+            <a:off x="182880" y="10058400"/>
+            <a:ext cx="1005840" cy="502920"/>
+          </a:xfrm>
+          <a:prstGeom prst="rect">
+            <a:avLst/>
+          </a:prstGeom>
+          <a:solidFill>
+            <a:srgbClr val="C0392B"/>
           </a:solidFill>
           <a:ln>
             <a:noFill/>
@@ -4040,13 +4039,14 @@
           <a:p>
             <a:pPr algn="ctr"/>
             <a:r>
-              <a:rPr sz="100" b="1">
+              <a:rPr sz="1000" b="1">
                 <a:solidFill>
                   <a:srgbClr val="FFFFFF"/>
                 </a:solidFill>
                 <a:latin typeface="Meiryo"/>
               </a:rPr>
-              <a:t/>
+              <a:t>⑥ 収益化
+／マネロン</a:t>
             </a:r>
           </a:p>
         </p:txBody>
@@ -4059,8 +4059,8 @@
         </p:nvSpPr>
         <p:spPr>
           <a:xfrm>
-            <a:off x="9153144" y="1051560"/>
-            <a:ext cx="2606040" cy="960120"/>
+            <a:off x="1225296" y="1371600"/>
+            <a:ext cx="2606040" cy="868680"/>
           </a:xfrm>
           <a:prstGeom prst="rect">
             <a:avLst/>
@@ -4111,8 +4111,8 @@
         </p:nvSpPr>
         <p:spPr>
           <a:xfrm>
-            <a:off x="11795760" y="1051560"/>
-            <a:ext cx="2606040" cy="960120"/>
+            <a:off x="3867912" y="1371600"/>
+            <a:ext cx="2606040" cy="868680"/>
           </a:xfrm>
           <a:prstGeom prst="rect">
             <a:avLst/>
@@ -4163,8 +4163,8 @@
         </p:nvSpPr>
         <p:spPr>
           <a:xfrm>
-            <a:off x="1225296" y="2048256"/>
-            <a:ext cx="2606040" cy="1051560"/>
+            <a:off x="6510528" y="1371600"/>
+            <a:ext cx="2606040" cy="868680"/>
           </a:xfrm>
           <a:prstGeom prst="rect">
             <a:avLst/>
@@ -4215,8 +4215,8 @@
         </p:nvSpPr>
         <p:spPr>
           <a:xfrm>
-            <a:off x="3867912" y="2048256"/>
-            <a:ext cx="2606040" cy="1051560"/>
+            <a:off x="9153144" y="1371600"/>
+            <a:ext cx="2606040" cy="868680"/>
           </a:xfrm>
           <a:prstGeom prst="rect">
             <a:avLst/>
@@ -4267,8 +4267,8 @@
         </p:nvSpPr>
         <p:spPr>
           <a:xfrm>
-            <a:off x="6510528" y="2048256"/>
-            <a:ext cx="2606040" cy="1051560"/>
+            <a:off x="11795760" y="1371600"/>
+            <a:ext cx="2606040" cy="868680"/>
           </a:xfrm>
           <a:prstGeom prst="rect">
             <a:avLst/>
@@ -4319,8 +4319,8 @@
         </p:nvSpPr>
         <p:spPr>
           <a:xfrm>
-            <a:off x="9153144" y="2048256"/>
-            <a:ext cx="2606040" cy="1051560"/>
+            <a:off x="1225296" y="2276856"/>
+            <a:ext cx="2606040" cy="960120"/>
           </a:xfrm>
           <a:prstGeom prst="rect">
             <a:avLst/>
@@ -4371,8 +4371,8 @@
         </p:nvSpPr>
         <p:spPr>
           <a:xfrm>
-            <a:off x="11795760" y="2048256"/>
-            <a:ext cx="2606040" cy="1051560"/>
+            <a:off x="3867912" y="2276856"/>
+            <a:ext cx="2606040" cy="960120"/>
           </a:xfrm>
           <a:prstGeom prst="rect">
             <a:avLst/>
@@ -4423,8 +4423,8 @@
         </p:nvSpPr>
         <p:spPr>
           <a:xfrm>
-            <a:off x="1225296" y="3136392"/>
-            <a:ext cx="2606040" cy="2331720"/>
+            <a:off x="6510528" y="2276856"/>
+            <a:ext cx="2606040" cy="960120"/>
           </a:xfrm>
           <a:prstGeom prst="rect">
             <a:avLst/>
@@ -4475,8 +4475,8 @@
         </p:nvSpPr>
         <p:spPr>
           <a:xfrm>
-            <a:off x="3867912" y="3136392"/>
-            <a:ext cx="2606040" cy="2331720"/>
+            <a:off x="9153144" y="2276856"/>
+            <a:ext cx="2606040" cy="960120"/>
           </a:xfrm>
           <a:prstGeom prst="rect">
             <a:avLst/>
@@ -4527,8 +4527,8 @@
         </p:nvSpPr>
         <p:spPr>
           <a:xfrm>
-            <a:off x="6510528" y="3136392"/>
-            <a:ext cx="2606040" cy="2331720"/>
+            <a:off x="11795760" y="2276856"/>
+            <a:ext cx="2606040" cy="960120"/>
           </a:xfrm>
           <a:prstGeom prst="rect">
             <a:avLst/>
@@ -4579,8 +4579,8 @@
         </p:nvSpPr>
         <p:spPr>
           <a:xfrm>
-            <a:off x="9153144" y="3136392"/>
-            <a:ext cx="2606040" cy="2331720"/>
+            <a:off x="1225296" y="3273552"/>
+            <a:ext cx="2606040" cy="2148840"/>
           </a:xfrm>
           <a:prstGeom prst="rect">
             <a:avLst/>
@@ -4631,8 +4631,8 @@
         </p:nvSpPr>
         <p:spPr>
           <a:xfrm>
-            <a:off x="11795760" y="3136392"/>
-            <a:ext cx="2606040" cy="2331720"/>
+            <a:off x="3867912" y="3273552"/>
+            <a:ext cx="2606040" cy="2148840"/>
           </a:xfrm>
           <a:prstGeom prst="rect">
             <a:avLst/>
@@ -4683,8 +4683,8 @@
         </p:nvSpPr>
         <p:spPr>
           <a:xfrm>
-            <a:off x="1225296" y="5504688"/>
-            <a:ext cx="2606040" cy="2377440"/>
+            <a:off x="6510528" y="3273552"/>
+            <a:ext cx="2606040" cy="2148840"/>
           </a:xfrm>
           <a:prstGeom prst="rect">
             <a:avLst/>
@@ -4735,8 +4735,8 @@
         </p:nvSpPr>
         <p:spPr>
           <a:xfrm>
-            <a:off x="3867912" y="5504688"/>
-            <a:ext cx="2606040" cy="2377440"/>
+            <a:off x="9153144" y="3273552"/>
+            <a:ext cx="2606040" cy="2148840"/>
           </a:xfrm>
           <a:prstGeom prst="rect">
             <a:avLst/>
@@ -4787,8 +4787,8 @@
         </p:nvSpPr>
         <p:spPr>
           <a:xfrm>
-            <a:off x="6510528" y="5504688"/>
-            <a:ext cx="2606040" cy="2377440"/>
+            <a:off x="11795760" y="3273552"/>
+            <a:ext cx="2606040" cy="2148840"/>
           </a:xfrm>
           <a:prstGeom prst="rect">
             <a:avLst/>
@@ -4839,8 +4839,8 @@
         </p:nvSpPr>
         <p:spPr>
           <a:xfrm>
-            <a:off x="9153144" y="5504688"/>
-            <a:ext cx="2606040" cy="2377440"/>
+            <a:off x="1225296" y="5458968"/>
+            <a:ext cx="2606040" cy="2240280"/>
           </a:xfrm>
           <a:prstGeom prst="rect">
             <a:avLst/>
@@ -4891,8 +4891,8 @@
         </p:nvSpPr>
         <p:spPr>
           <a:xfrm>
-            <a:off x="11795760" y="5504688"/>
-            <a:ext cx="2606040" cy="2377440"/>
+            <a:off x="3867912" y="5458968"/>
+            <a:ext cx="2606040" cy="2240280"/>
           </a:xfrm>
           <a:prstGeom prst="rect">
             <a:avLst/>
@@ -4943,8 +4943,8 @@
         </p:nvSpPr>
         <p:spPr>
           <a:xfrm>
-            <a:off x="1225296" y="7918704"/>
-            <a:ext cx="2606040" cy="2423160"/>
+            <a:off x="6510528" y="5458968"/>
+            <a:ext cx="2606040" cy="2240280"/>
           </a:xfrm>
           <a:prstGeom prst="rect">
             <a:avLst/>
@@ -4995,8 +4995,8 @@
         </p:nvSpPr>
         <p:spPr>
           <a:xfrm>
-            <a:off x="3867912" y="7918704"/>
-            <a:ext cx="2606040" cy="2423160"/>
+            <a:off x="9153144" y="5458968"/>
+            <a:ext cx="2606040" cy="2240280"/>
           </a:xfrm>
           <a:prstGeom prst="rect">
             <a:avLst/>
@@ -5047,8 +5047,8 @@
         </p:nvSpPr>
         <p:spPr>
           <a:xfrm>
-            <a:off x="6510528" y="7918704"/>
-            <a:ext cx="2606040" cy="2423160"/>
+            <a:off x="11795760" y="5458968"/>
+            <a:ext cx="2606040" cy="2240280"/>
           </a:xfrm>
           <a:prstGeom prst="rect">
             <a:avLst/>
@@ -5099,8 +5099,8 @@
         </p:nvSpPr>
         <p:spPr>
           <a:xfrm>
-            <a:off x="9153144" y="7918704"/>
-            <a:ext cx="2606040" cy="2423160"/>
+            <a:off x="1225296" y="7735824"/>
+            <a:ext cx="2606040" cy="2286000"/>
           </a:xfrm>
           <a:prstGeom prst="rect">
             <a:avLst/>
@@ -5151,8 +5151,8 @@
         </p:nvSpPr>
         <p:spPr>
           <a:xfrm>
-            <a:off x="11795760" y="7918704"/>
-            <a:ext cx="2606040" cy="2423160"/>
+            <a:off x="3867912" y="7735824"/>
+            <a:ext cx="2606040" cy="2286000"/>
           </a:xfrm>
           <a:prstGeom prst="rect">
             <a:avLst/>
@@ -5203,8 +5203,8 @@
         </p:nvSpPr>
         <p:spPr>
           <a:xfrm>
-            <a:off x="1225296" y="10378440"/>
-            <a:ext cx="2606040" cy="594360"/>
+            <a:off x="6510528" y="7735824"/>
+            <a:ext cx="2606040" cy="2286000"/>
           </a:xfrm>
           <a:prstGeom prst="rect">
             <a:avLst/>
@@ -5255,8 +5255,8 @@
         </p:nvSpPr>
         <p:spPr>
           <a:xfrm>
-            <a:off x="3867912" y="10378440"/>
-            <a:ext cx="2606040" cy="594360"/>
+            <a:off x="9153144" y="7735824"/>
+            <a:ext cx="2606040" cy="2286000"/>
           </a:xfrm>
           <a:prstGeom prst="rect">
             <a:avLst/>
@@ -5307,8 +5307,8 @@
         </p:nvSpPr>
         <p:spPr>
           <a:xfrm>
-            <a:off x="6510528" y="10378440"/>
-            <a:ext cx="2606040" cy="594360"/>
+            <a:off x="11795760" y="7735824"/>
+            <a:ext cx="2606040" cy="2286000"/>
           </a:xfrm>
           <a:prstGeom prst="rect">
             <a:avLst/>
@@ -5359,8 +5359,8 @@
         </p:nvSpPr>
         <p:spPr>
           <a:xfrm>
-            <a:off x="9153144" y="10378440"/>
-            <a:ext cx="2606040" cy="594360"/>
+            <a:off x="1225296" y="10058400"/>
+            <a:ext cx="2606040" cy="502920"/>
           </a:xfrm>
           <a:prstGeom prst="rect">
             <a:avLst/>
@@ -5411,8 +5411,8 @@
         </p:nvSpPr>
         <p:spPr>
           <a:xfrm>
-            <a:off x="11795760" y="10378440"/>
-            <a:ext cx="2606040" cy="594360"/>
+            <a:off x="3867912" y="10058400"/>
+            <a:ext cx="2606040" cy="502920"/>
           </a:xfrm>
           <a:prstGeom prst="rect">
             <a:avLst/>
@@ -5463,7 +5463,163 @@
         </p:nvSpPr>
         <p:spPr>
           <a:xfrm>
-            <a:off x="1316736" y="1188719"/>
+            <a:off x="6510528" y="10058400"/>
+            <a:ext cx="2606040" cy="502920"/>
+          </a:xfrm>
+          <a:prstGeom prst="rect">
+            <a:avLst/>
+          </a:prstGeom>
+          <a:solidFill>
+            <a:srgbClr val="FFFFFF"/>
+          </a:solidFill>
+          <a:ln>
+            <a:noFill/>
+          </a:ln>
+        </p:spPr>
+        <p:style>
+          <a:lnRef idx="1">
+            <a:schemeClr val="accent1"/>
+          </a:lnRef>
+          <a:fillRef idx="3">
+            <a:schemeClr val="accent1"/>
+          </a:fillRef>
+          <a:effectRef idx="2">
+            <a:schemeClr val="accent1"/>
+          </a:effectRef>
+          <a:fontRef idx="minor">
+            <a:schemeClr val="lt1"/>
+          </a:fontRef>
+        </p:style>
+        <p:txBody>
+          <a:bodyPr rtlCol="0" anchor="ctr" wrap="square" lIns="50800" rIns="50800" tIns="25400" bIns="25400"/>
+          <a:lstStyle/>
+          <a:p>
+            <a:pPr algn="ctr"/>
+            <a:r>
+              <a:rPr sz="100" b="1">
+                <a:solidFill>
+                  <a:srgbClr val="FFFFFF"/>
+                </a:solidFill>
+                <a:latin typeface="Meiryo"/>
+              </a:rPr>
+              <a:t/>
+            </a:r>
+          </a:p>
+        </p:txBody>
+      </p:sp>
+      <p:sp>
+        <p:nvSpPr>
+          <p:cNvPr id="49" name="Rectangle 48"/>
+          <p:cNvSpPr/>
+          <p:nvPr/>
+        </p:nvSpPr>
+        <p:spPr>
+          <a:xfrm>
+            <a:off x="9153144" y="10058400"/>
+            <a:ext cx="2606040" cy="502920"/>
+          </a:xfrm>
+          <a:prstGeom prst="rect">
+            <a:avLst/>
+          </a:prstGeom>
+          <a:solidFill>
+            <a:srgbClr val="FFFFFF"/>
+          </a:solidFill>
+          <a:ln>
+            <a:noFill/>
+          </a:ln>
+        </p:spPr>
+        <p:style>
+          <a:lnRef idx="1">
+            <a:schemeClr val="accent1"/>
+          </a:lnRef>
+          <a:fillRef idx="3">
+            <a:schemeClr val="accent1"/>
+          </a:fillRef>
+          <a:effectRef idx="2">
+            <a:schemeClr val="accent1"/>
+          </a:effectRef>
+          <a:fontRef idx="minor">
+            <a:schemeClr val="lt1"/>
+          </a:fontRef>
+        </p:style>
+        <p:txBody>
+          <a:bodyPr rtlCol="0" anchor="ctr" wrap="square" lIns="50800" rIns="50800" tIns="25400" bIns="25400"/>
+          <a:lstStyle/>
+          <a:p>
+            <a:pPr algn="ctr"/>
+            <a:r>
+              <a:rPr sz="100" b="1">
+                <a:solidFill>
+                  <a:srgbClr val="FFFFFF"/>
+                </a:solidFill>
+                <a:latin typeface="Meiryo"/>
+              </a:rPr>
+              <a:t/>
+            </a:r>
+          </a:p>
+        </p:txBody>
+      </p:sp>
+      <p:sp>
+        <p:nvSpPr>
+          <p:cNvPr id="50" name="Rectangle 49"/>
+          <p:cNvSpPr/>
+          <p:nvPr/>
+        </p:nvSpPr>
+        <p:spPr>
+          <a:xfrm>
+            <a:off x="11795760" y="10058400"/>
+            <a:ext cx="2606040" cy="502920"/>
+          </a:xfrm>
+          <a:prstGeom prst="rect">
+            <a:avLst/>
+          </a:prstGeom>
+          <a:solidFill>
+            <a:srgbClr val="FFFFFF"/>
+          </a:solidFill>
+          <a:ln>
+            <a:noFill/>
+          </a:ln>
+        </p:spPr>
+        <p:style>
+          <a:lnRef idx="1">
+            <a:schemeClr val="accent1"/>
+          </a:lnRef>
+          <a:fillRef idx="3">
+            <a:schemeClr val="accent1"/>
+          </a:fillRef>
+          <a:effectRef idx="2">
+            <a:schemeClr val="accent1"/>
+          </a:effectRef>
+          <a:fontRef idx="minor">
+            <a:schemeClr val="lt1"/>
+          </a:fontRef>
+        </p:style>
+        <p:txBody>
+          <a:bodyPr rtlCol="0" anchor="ctr" wrap="square" lIns="50800" rIns="50800" tIns="25400" bIns="25400"/>
+          <a:lstStyle/>
+          <a:p>
+            <a:pPr algn="ctr"/>
+            <a:r>
+              <a:rPr sz="100" b="1">
+                <a:solidFill>
+                  <a:srgbClr val="FFFFFF"/>
+                </a:solidFill>
+                <a:latin typeface="Meiryo"/>
+              </a:rPr>
+              <a:t/>
+            </a:r>
+          </a:p>
+        </p:txBody>
+      </p:sp>
+      <p:sp>
+        <p:nvSpPr>
+          <p:cNvPr id="51" name="Rectangle 50"/>
+          <p:cNvSpPr/>
+          <p:nvPr/>
+        </p:nvSpPr>
+        <p:spPr>
+          <a:xfrm>
+            <a:off x="1316736" y="1508760"/>
             <a:ext cx="2423160" cy="502920"/>
           </a:xfrm>
           <a:prstGeom prst="rect">
@@ -5511,13 +5667,13 @@
       </p:sp>
       <p:sp>
         <p:nvSpPr>
-          <p:cNvPr id="49" name="Rectangle 48"/>
+          <p:cNvPr id="52" name="Rectangle 51"/>
           <p:cNvSpPr/>
           <p:nvPr/>
         </p:nvSpPr>
         <p:spPr>
           <a:xfrm>
-            <a:off x="3959352" y="1188719"/>
+            <a:off x="3959352" y="1508760"/>
             <a:ext cx="2423160" cy="320040"/>
           </a:xfrm>
           <a:prstGeom prst="rect">
@@ -5565,13 +5721,13 @@
       </p:sp>
       <p:sp>
         <p:nvSpPr>
-          <p:cNvPr id="50" name="TextBox 49"/>
+          <p:cNvPr id="53" name="TextBox 52"/>
           <p:cNvSpPr txBox="1"/>
           <p:nvPr/>
         </p:nvSpPr>
         <p:spPr>
           <a:xfrm>
-            <a:off x="3959352" y="1554480"/>
+            <a:off x="3959352" y="1874519"/>
             <a:ext cx="2423160" cy="274320"/>
           </a:xfrm>
           <a:prstGeom prst="rect">
@@ -5598,13 +5754,13 @@
       </p:sp>
       <p:sp>
         <p:nvSpPr>
-          <p:cNvPr id="51" name="Rectangle 50"/>
+          <p:cNvPr id="54" name="Rectangle 53"/>
           <p:cNvSpPr/>
           <p:nvPr/>
         </p:nvSpPr>
         <p:spPr>
           <a:xfrm>
-            <a:off x="3959352" y="2121408"/>
+            <a:off x="3959352" y="2350008"/>
             <a:ext cx="2423160" cy="777240"/>
           </a:xfrm>
           <a:prstGeom prst="rect">
@@ -5653,13 +5809,13 @@
       </p:sp>
       <p:sp>
         <p:nvSpPr>
-          <p:cNvPr id="52" name="Rectangle 51"/>
+          <p:cNvPr id="55" name="Rectangle 54"/>
           <p:cNvSpPr/>
           <p:nvPr/>
         </p:nvSpPr>
         <p:spPr>
           <a:xfrm>
-            <a:off x="6601968" y="2121408"/>
+            <a:off x="6601968" y="2350008"/>
             <a:ext cx="2423160" cy="320040"/>
           </a:xfrm>
           <a:prstGeom prst="rect">
@@ -5707,13 +5863,13 @@
       </p:sp>
       <p:sp>
         <p:nvSpPr>
-          <p:cNvPr id="53" name="TextBox 52"/>
+          <p:cNvPr id="56" name="TextBox 55"/>
           <p:cNvSpPr txBox="1"/>
           <p:nvPr/>
         </p:nvSpPr>
         <p:spPr>
           <a:xfrm>
-            <a:off x="6601968" y="2505456"/>
+            <a:off x="6601968" y="2734056"/>
             <a:ext cx="2423160" cy="502920"/>
           </a:xfrm>
           <a:prstGeom prst="rect">
@@ -5740,13 +5896,13 @@
       </p:sp>
       <p:sp>
         <p:nvSpPr>
-          <p:cNvPr id="54" name="Rectangle 53"/>
+          <p:cNvPr id="57" name="Rectangle 56"/>
           <p:cNvSpPr/>
           <p:nvPr/>
         </p:nvSpPr>
         <p:spPr>
           <a:xfrm>
-            <a:off x="3959352" y="3182112"/>
+            <a:off x="3959352" y="3319272"/>
             <a:ext cx="2423160" cy="640080"/>
           </a:xfrm>
           <a:prstGeom prst="rect">
@@ -5795,13 +5951,13 @@
       </p:sp>
       <p:sp>
         <p:nvSpPr>
-          <p:cNvPr id="55" name="TextBox 54"/>
+          <p:cNvPr id="58" name="TextBox 57"/>
           <p:cNvSpPr txBox="1"/>
           <p:nvPr/>
         </p:nvSpPr>
         <p:spPr>
           <a:xfrm>
-            <a:off x="3959352" y="3849624"/>
+            <a:off x="3959352" y="3986784"/>
             <a:ext cx="2423160" cy="182880"/>
           </a:xfrm>
           <a:prstGeom prst="rect">
@@ -5828,13 +5984,13 @@
       </p:sp>
       <p:sp>
         <p:nvSpPr>
-          <p:cNvPr id="56" name="TextBox 55"/>
+          <p:cNvPr id="59" name="TextBox 58"/>
           <p:cNvSpPr txBox="1"/>
           <p:nvPr/>
         </p:nvSpPr>
         <p:spPr>
           <a:xfrm>
-            <a:off x="3959352" y="3959352"/>
+            <a:off x="3959352" y="4096512"/>
             <a:ext cx="2423160" cy="182880"/>
           </a:xfrm>
           <a:prstGeom prst="rect">
@@ -5861,13 +6017,13 @@
       </p:sp>
       <p:sp>
         <p:nvSpPr>
-          <p:cNvPr id="57" name="Diamond 56"/>
+          <p:cNvPr id="60" name="Diamond 59"/>
           <p:cNvSpPr/>
           <p:nvPr/>
         </p:nvSpPr>
         <p:spPr>
           <a:xfrm>
-            <a:off x="4507992" y="4032504"/>
+            <a:off x="4507992" y="4169664"/>
             <a:ext cx="1280160" cy="457200"/>
           </a:xfrm>
           <a:prstGeom prst="diamond">
@@ -5913,13 +6069,13 @@
       </p:sp>
       <p:sp>
         <p:nvSpPr>
-          <p:cNvPr id="58" name="Rectangle 57"/>
+          <p:cNvPr id="61" name="Rectangle 60"/>
           <p:cNvSpPr/>
           <p:nvPr/>
         </p:nvSpPr>
         <p:spPr>
           <a:xfrm>
-            <a:off x="3959352" y="4526280"/>
+            <a:off x="3959352" y="4663440"/>
             <a:ext cx="2423160" cy="365760"/>
           </a:xfrm>
           <a:prstGeom prst="rect">
@@ -5968,13 +6124,13 @@
       </p:sp>
       <p:sp>
         <p:nvSpPr>
-          <p:cNvPr id="59" name="Rectangle 58"/>
+          <p:cNvPr id="62" name="Rectangle 61"/>
           <p:cNvSpPr/>
           <p:nvPr/>
         </p:nvSpPr>
         <p:spPr>
           <a:xfrm>
-            <a:off x="3959352" y="4928616"/>
+            <a:off x="3959352" y="5065776"/>
             <a:ext cx="2423160" cy="201168"/>
           </a:xfrm>
           <a:prstGeom prst="rect">
@@ -6022,13 +6178,13 @@
       </p:sp>
       <p:sp>
         <p:nvSpPr>
-          <p:cNvPr id="60" name="Rectangle 59"/>
+          <p:cNvPr id="63" name="Rectangle 62"/>
           <p:cNvSpPr/>
           <p:nvPr/>
         </p:nvSpPr>
         <p:spPr>
           <a:xfrm>
-            <a:off x="3959352" y="5148072"/>
+            <a:off x="3959352" y="5285232"/>
             <a:ext cx="2423160" cy="137160"/>
           </a:xfrm>
           <a:prstGeom prst="rect">
@@ -6076,13 +6232,13 @@
       </p:sp>
       <p:sp>
         <p:nvSpPr>
-          <p:cNvPr id="61" name="Rectangle 60"/>
+          <p:cNvPr id="64" name="Rectangle 63"/>
           <p:cNvSpPr/>
           <p:nvPr/>
         </p:nvSpPr>
         <p:spPr>
           <a:xfrm>
-            <a:off x="3959352" y="5303520"/>
+            <a:off x="3959352" y="5440680"/>
             <a:ext cx="2423160" cy="137160"/>
           </a:xfrm>
           <a:prstGeom prst="rect">
@@ -6130,13 +6286,13 @@
       </p:sp>
       <p:sp>
         <p:nvSpPr>
-          <p:cNvPr id="62" name="Rectangle 61"/>
+          <p:cNvPr id="65" name="Rectangle 64"/>
           <p:cNvSpPr/>
           <p:nvPr/>
         </p:nvSpPr>
         <p:spPr>
           <a:xfrm>
-            <a:off x="6601968" y="4526280"/>
+            <a:off x="6601968" y="4663440"/>
             <a:ext cx="2423160" cy="274320"/>
           </a:xfrm>
           <a:prstGeom prst="rect">
@@ -6184,13 +6340,13 @@
       </p:sp>
       <p:sp>
         <p:nvSpPr>
-          <p:cNvPr id="63" name="Rectangle 62"/>
+          <p:cNvPr id="66" name="Rectangle 65"/>
           <p:cNvSpPr/>
           <p:nvPr/>
         </p:nvSpPr>
         <p:spPr>
           <a:xfrm>
-            <a:off x="9244584" y="5010912"/>
+            <a:off x="9244584" y="5148072"/>
             <a:ext cx="2423160" cy="320040"/>
           </a:xfrm>
           <a:prstGeom prst="rect">
@@ -6239,13 +6395,13 @@
       </p:sp>
       <p:sp>
         <p:nvSpPr>
-          <p:cNvPr id="64" name="Rectangle 63"/>
+          <p:cNvPr id="67" name="Rectangle 66"/>
           <p:cNvSpPr/>
           <p:nvPr/>
         </p:nvSpPr>
         <p:spPr>
           <a:xfrm>
-            <a:off x="3959352" y="5550407"/>
+            <a:off x="3959352" y="5504688"/>
             <a:ext cx="2423160" cy="457200"/>
           </a:xfrm>
           <a:prstGeom prst="rect">
@@ -6294,13 +6450,13 @@
       </p:sp>
       <p:sp>
         <p:nvSpPr>
-          <p:cNvPr id="65" name="Rectangle 64"/>
+          <p:cNvPr id="68" name="Rectangle 67"/>
           <p:cNvSpPr/>
           <p:nvPr/>
         </p:nvSpPr>
         <p:spPr>
           <a:xfrm>
-            <a:off x="3959352" y="6053327"/>
+            <a:off x="3959352" y="6007608"/>
             <a:ext cx="2423160" cy="274320"/>
           </a:xfrm>
           <a:prstGeom prst="rect">
@@ -6348,13 +6504,13 @@
       </p:sp>
       <p:sp>
         <p:nvSpPr>
-          <p:cNvPr id="66" name="Rectangle 65"/>
+          <p:cNvPr id="69" name="Rectangle 68"/>
           <p:cNvSpPr/>
           <p:nvPr/>
         </p:nvSpPr>
         <p:spPr>
           <a:xfrm>
-            <a:off x="3959352" y="6373368"/>
+            <a:off x="3959352" y="6327648"/>
             <a:ext cx="2423160" cy="274320"/>
           </a:xfrm>
           <a:prstGeom prst="rect">
@@ -6402,13 +6558,13 @@
       </p:sp>
       <p:sp>
         <p:nvSpPr>
-          <p:cNvPr id="67" name="Rectangle 66"/>
+          <p:cNvPr id="70" name="Rectangle 69"/>
           <p:cNvSpPr/>
           <p:nvPr/>
         </p:nvSpPr>
         <p:spPr>
           <a:xfrm>
-            <a:off x="9244584" y="5550407"/>
+            <a:off x="9244584" y="5504688"/>
             <a:ext cx="2423160" cy="320040"/>
           </a:xfrm>
           <a:prstGeom prst="rect">
@@ -6457,13 +6613,13 @@
       </p:sp>
       <p:sp>
         <p:nvSpPr>
-          <p:cNvPr id="68" name="Rectangle 67"/>
+          <p:cNvPr id="71" name="Rectangle 70"/>
           <p:cNvSpPr/>
           <p:nvPr/>
         </p:nvSpPr>
         <p:spPr>
           <a:xfrm>
-            <a:off x="9244584" y="5916168"/>
+            <a:off x="9244584" y="5870448"/>
             <a:ext cx="2423160" cy="320040"/>
           </a:xfrm>
           <a:prstGeom prst="rect">
@@ -6511,13 +6667,13 @@
       </p:sp>
       <p:sp>
         <p:nvSpPr>
-          <p:cNvPr id="69" name="Rectangle 68"/>
+          <p:cNvPr id="72" name="Rectangle 71"/>
           <p:cNvSpPr/>
           <p:nvPr/>
         </p:nvSpPr>
         <p:spPr>
           <a:xfrm>
-            <a:off x="9244584" y="6281927"/>
+            <a:off x="9244584" y="6236208"/>
             <a:ext cx="2423160" cy="365760"/>
           </a:xfrm>
           <a:prstGeom prst="rect">
@@ -6566,13 +6722,13 @@
       </p:sp>
       <p:sp>
         <p:nvSpPr>
-          <p:cNvPr id="70" name="Rectangle 69"/>
+          <p:cNvPr id="73" name="Rectangle 72"/>
           <p:cNvSpPr/>
           <p:nvPr/>
         </p:nvSpPr>
         <p:spPr>
           <a:xfrm>
-            <a:off x="9244584" y="6693407"/>
+            <a:off x="9244584" y="6647688"/>
             <a:ext cx="2423160" cy="274320"/>
           </a:xfrm>
           <a:prstGeom prst="rect">
@@ -6620,13 +6776,13 @@
       </p:sp>
       <p:sp>
         <p:nvSpPr>
-          <p:cNvPr id="71" name="Rectangle 70"/>
+          <p:cNvPr id="74" name="Rectangle 73"/>
           <p:cNvSpPr/>
           <p:nvPr/>
         </p:nvSpPr>
         <p:spPr>
           <a:xfrm>
-            <a:off x="9244584" y="7013448"/>
+            <a:off x="9244584" y="6967728"/>
             <a:ext cx="2423160" cy="777240"/>
           </a:xfrm>
           <a:prstGeom prst="rect">
@@ -6674,13 +6830,13 @@
       </p:sp>
       <p:sp>
         <p:nvSpPr>
-          <p:cNvPr id="72" name="Rectangle 71"/>
+          <p:cNvPr id="75" name="Rectangle 74"/>
           <p:cNvSpPr/>
           <p:nvPr/>
         </p:nvSpPr>
         <p:spPr>
           <a:xfrm>
-            <a:off x="3959352" y="7964424"/>
+            <a:off x="3959352" y="7781544"/>
             <a:ext cx="2423160" cy="365760"/>
           </a:xfrm>
           <a:prstGeom prst="rect">
@@ -6728,13 +6884,13 @@
       </p:sp>
       <p:sp>
         <p:nvSpPr>
-          <p:cNvPr id="73" name="Rectangle 72"/>
+          <p:cNvPr id="76" name="Rectangle 75"/>
           <p:cNvSpPr/>
           <p:nvPr/>
         </p:nvSpPr>
         <p:spPr>
           <a:xfrm>
-            <a:off x="3959352" y="8375904"/>
+            <a:off x="3959352" y="8193024"/>
             <a:ext cx="2423160" cy="201168"/>
           </a:xfrm>
           <a:prstGeom prst="rect">
@@ -6782,13 +6938,13 @@
       </p:sp>
       <p:sp>
         <p:nvSpPr>
-          <p:cNvPr id="74" name="Rectangle 73"/>
+          <p:cNvPr id="77" name="Rectangle 76"/>
           <p:cNvSpPr/>
           <p:nvPr/>
         </p:nvSpPr>
         <p:spPr>
           <a:xfrm>
-            <a:off x="3959352" y="8631936"/>
+            <a:off x="3959352" y="8449056"/>
             <a:ext cx="2423160" cy="274320"/>
           </a:xfrm>
           <a:prstGeom prst="rect">
@@ -6836,13 +6992,13 @@
       </p:sp>
       <p:sp>
         <p:nvSpPr>
-          <p:cNvPr id="75" name="Rectangle 74"/>
+          <p:cNvPr id="78" name="Rectangle 77"/>
           <p:cNvSpPr/>
           <p:nvPr/>
         </p:nvSpPr>
         <p:spPr>
           <a:xfrm>
-            <a:off x="3959352" y="8951976"/>
+            <a:off x="3959352" y="8769096"/>
             <a:ext cx="2423160" cy="411480"/>
           </a:xfrm>
           <a:prstGeom prst="rect">
@@ -6890,13 +7046,13 @@
       </p:sp>
       <p:sp>
         <p:nvSpPr>
-          <p:cNvPr id="76" name="Rectangle 75"/>
+          <p:cNvPr id="79" name="Rectangle 78"/>
           <p:cNvSpPr/>
           <p:nvPr/>
         </p:nvSpPr>
         <p:spPr>
           <a:xfrm>
-            <a:off x="3959352" y="9427464"/>
+            <a:off x="3959352" y="9244584"/>
             <a:ext cx="2423160" cy="411480"/>
           </a:xfrm>
           <a:prstGeom prst="rect">
@@ -6944,13 +7100,13 @@
       </p:sp>
       <p:sp>
         <p:nvSpPr>
-          <p:cNvPr id="77" name="Rectangle 76"/>
+          <p:cNvPr id="80" name="Rectangle 79"/>
           <p:cNvSpPr/>
           <p:nvPr/>
         </p:nvSpPr>
         <p:spPr>
           <a:xfrm>
-            <a:off x="6601968" y="7964424"/>
+            <a:off x="6601968" y="7781544"/>
             <a:ext cx="2423160" cy="274320"/>
           </a:xfrm>
           <a:prstGeom prst="rect">
@@ -6998,13 +7154,13 @@
       </p:sp>
       <p:sp>
         <p:nvSpPr>
-          <p:cNvPr id="78" name="Rectangle 77"/>
+          <p:cNvPr id="81" name="Rectangle 80"/>
           <p:cNvSpPr/>
           <p:nvPr/>
         </p:nvSpPr>
         <p:spPr>
           <a:xfrm>
-            <a:off x="11887200" y="8375904"/>
+            <a:off x="11887200" y="8193024"/>
             <a:ext cx="2423160" cy="274320"/>
           </a:xfrm>
           <a:prstGeom prst="rect">
@@ -7052,13 +7208,13 @@
       </p:sp>
       <p:sp>
         <p:nvSpPr>
-          <p:cNvPr id="79" name="Rectangle 78"/>
+          <p:cNvPr id="82" name="Rectangle 81"/>
           <p:cNvSpPr/>
           <p:nvPr/>
         </p:nvSpPr>
         <p:spPr>
           <a:xfrm>
-            <a:off x="11887200" y="8723376"/>
+            <a:off x="11887200" y="8540496"/>
             <a:ext cx="2423160" cy="640080"/>
           </a:xfrm>
           <a:prstGeom prst="rect">
@@ -7111,13 +7267,13 @@
       </p:sp>
       <p:sp>
         <p:nvSpPr>
-          <p:cNvPr id="80" name="Rectangle 79"/>
+          <p:cNvPr id="83" name="Rectangle 82"/>
           <p:cNvSpPr/>
           <p:nvPr/>
         </p:nvSpPr>
         <p:spPr>
           <a:xfrm>
-            <a:off x="3959352" y="10451592"/>
+            <a:off x="3959352" y="10131552"/>
             <a:ext cx="2423160" cy="411480"/>
           </a:xfrm>
           <a:prstGeom prst="rect">
@@ -7165,7 +7321,7 @@
       </p:sp>
       <p:sp>
         <p:nvSpPr>
-          <p:cNvPr id="81" name="TextBox 80"/>
+          <p:cNvPr id="84" name="TextBox 83"/>
           <p:cNvSpPr txBox="1"/>
           <p:nvPr/>
         </p:nvSpPr>

</xml_diff>

<commit_message>
Add comparison table: legitimate bank flow vs attack flow
Shows why customers cannot distinguish the attack from normal
banking — the attacker exploits behavioral patterns that banks
themselves trained customers to follow.

https://claude.ai/code/session_01F7t8LKifK43o6sCdF2a3gQ
</commit_message>
<xml_diff>
--- a/Fraud_Kill_Chain.pptx
+++ b/Fraud_Kill_Chain.pptx
@@ -6,6 +6,7 @@
   </p:sldMasterIdLst>
   <p:sldIdLst>
     <p:sldId id="256" r:id="rId7"/>
+    <p:sldId id="257" r:id="rId8"/>
   </p:sldIdLst>
   <p:sldSz cx="15124176" cy="10689336" type="screen4x3"/>
   <p:notesSz cx="6858000" cy="9144000"/>
@@ -7348,6 +7349,1175 @@
                 <a:latin typeface="Meiryo"/>
               </a:rPr>
               <a:t>Fraud Kill Chain — 不審な電話手口 ｜ A3横印刷対応</a:t>
+            </a:r>
+          </a:p>
+        </p:txBody>
+      </p:sp>
+    </p:spTree>
+  </p:cSld>
+  <p:clrMapOvr>
+    <a:masterClrMapping/>
+  </p:clrMapOvr>
+</p:sld>
+</file>
+
+<file path=ppt/slides/slide2.xml><?xml version="1.0" encoding="utf-8"?>
+<p:sld xmlns:a="http://schemas.openxmlformats.org/drawingml/2006/main" xmlns:p="http://schemas.openxmlformats.org/presentationml/2006/main" xmlns:r="http://schemas.openxmlformats.org/officeDocument/2006/relationships">
+  <p:cSld>
+    <p:bg>
+      <p:bgPr>
+        <a:solidFill>
+          <a:srgbClr val="F5F5F5"/>
+        </a:solidFill>
+        <a:effectLst/>
+      </p:bgPr>
+    </p:bg>
+    <p:spTree>
+      <p:nvGrpSpPr>
+        <p:cNvPr id="1" name=""/>
+        <p:cNvGrpSpPr/>
+        <p:nvPr/>
+      </p:nvGrpSpPr>
+      <p:grpSpPr/>
+      <p:sp>
+        <p:nvSpPr>
+          <p:cNvPr id="2" name="TextBox 1"/>
+          <p:cNvSpPr txBox="1"/>
+          <p:nvPr/>
+        </p:nvSpPr>
+        <p:spPr>
+          <a:xfrm>
+            <a:off x="0" y="274320"/>
+            <a:ext cx="15124176" cy="548640"/>
+          </a:xfrm>
+          <a:prstGeom prst="rect">
+            <a:avLst/>
+          </a:prstGeom>
+          <a:noFill/>
+        </p:spPr>
+        <p:txBody>
+          <a:bodyPr wrap="square" lIns="50800" rIns="50800" tIns="38100" bIns="38100"/>
+          <a:lstStyle/>
+          <a:p>
+            <a:pPr algn="ctr"/>
+            <a:r>
+              <a:rPr sz="2200" b="1">
+                <a:solidFill>
+                  <a:srgbClr val="C0392B"/>
+                </a:solidFill>
+                <a:latin typeface="Meiryo"/>
+              </a:rPr>
+              <a:t>なぜ見破れないのか — 銀行の正規フローとの類似性</a:t>
+            </a:r>
+          </a:p>
+        </p:txBody>
+      </p:sp>
+      <p:sp>
+        <p:nvSpPr>
+          <p:cNvPr id="3" name="TextBox 2"/>
+          <p:cNvSpPr txBox="1"/>
+          <p:nvPr/>
+        </p:nvSpPr>
+        <p:spPr>
+          <a:xfrm>
+            <a:off x="0" y="777240"/>
+            <a:ext cx="15124176" cy="365760"/>
+          </a:xfrm>
+          <a:prstGeom prst="rect">
+            <a:avLst/>
+          </a:prstGeom>
+          <a:noFill/>
+        </p:spPr>
+        <p:txBody>
+          <a:bodyPr wrap="square" lIns="50800" rIns="50800" tIns="38100" bIns="38100"/>
+          <a:lstStyle/>
+          <a:p>
+            <a:pPr algn="ctr"/>
+            <a:r>
+              <a:rPr sz="1200" b="0">
+                <a:solidFill>
+                  <a:srgbClr val="888888"/>
+                </a:solidFill>
+                <a:latin typeface="Meiryo"/>
+              </a:rPr>
+              <a:t>銀行自身が顧客を「自動音声の指示に従う」行動パターンに教育してきた結果、この攻撃が成立している。</a:t>
+            </a:r>
+          </a:p>
+        </p:txBody>
+      </p:sp>
+      <p:sp>
+        <p:nvSpPr>
+          <p:cNvPr id="4" name="Rectangle 3"/>
+          <p:cNvSpPr/>
+          <p:nvPr/>
+        </p:nvSpPr>
+        <p:spPr>
+          <a:xfrm>
+            <a:off x="1371600" y="1463040"/>
+            <a:ext cx="4114800" cy="502920"/>
+          </a:xfrm>
+          <a:prstGeom prst="rect">
+            <a:avLst/>
+          </a:prstGeom>
+          <a:solidFill>
+            <a:srgbClr val="222222"/>
+          </a:solidFill>
+          <a:ln>
+            <a:noFill/>
+          </a:ln>
+        </p:spPr>
+        <p:style>
+          <a:lnRef idx="1">
+            <a:schemeClr val="accent1"/>
+          </a:lnRef>
+          <a:fillRef idx="3">
+            <a:schemeClr val="accent1"/>
+          </a:fillRef>
+          <a:effectRef idx="2">
+            <a:schemeClr val="accent1"/>
+          </a:effectRef>
+          <a:fontRef idx="minor">
+            <a:schemeClr val="lt1"/>
+          </a:fontRef>
+        </p:style>
+        <p:txBody>
+          <a:bodyPr rtlCol="0" anchor="ctr" wrap="square" lIns="50800" rIns="50800" tIns="25400" bIns="25400"/>
+          <a:lstStyle/>
+          <a:p>
+            <a:pPr algn="ctr"/>
+            <a:r>
+              <a:rPr sz="1200" b="1">
+                <a:solidFill>
+                  <a:srgbClr val="FFFFFF"/>
+                </a:solidFill>
+                <a:latin typeface="Meiryo"/>
+              </a:rPr>
+              <a:t>銀行の正規フロー</a:t>
+            </a:r>
+          </a:p>
+        </p:txBody>
+      </p:sp>
+      <p:sp>
+        <p:nvSpPr>
+          <p:cNvPr id="5" name="Rectangle 4"/>
+          <p:cNvSpPr/>
+          <p:nvPr/>
+        </p:nvSpPr>
+        <p:spPr>
+          <a:xfrm>
+            <a:off x="5486400" y="1463040"/>
+            <a:ext cx="4114800" cy="502920"/>
+          </a:xfrm>
+          <a:prstGeom prst="rect">
+            <a:avLst/>
+          </a:prstGeom>
+          <a:solidFill>
+            <a:srgbClr val="222222"/>
+          </a:solidFill>
+          <a:ln>
+            <a:noFill/>
+          </a:ln>
+        </p:spPr>
+        <p:style>
+          <a:lnRef idx="1">
+            <a:schemeClr val="accent1"/>
+          </a:lnRef>
+          <a:fillRef idx="3">
+            <a:schemeClr val="accent1"/>
+          </a:fillRef>
+          <a:effectRef idx="2">
+            <a:schemeClr val="accent1"/>
+          </a:effectRef>
+          <a:fontRef idx="minor">
+            <a:schemeClr val="lt1"/>
+          </a:fontRef>
+        </p:style>
+        <p:txBody>
+          <a:bodyPr rtlCol="0" anchor="ctr" wrap="square" lIns="50800" rIns="50800" tIns="25400" bIns="25400"/>
+          <a:lstStyle/>
+          <a:p>
+            <a:pPr algn="ctr"/>
+            <a:r>
+              <a:rPr sz="1200" b="1">
+                <a:solidFill>
+                  <a:srgbClr val="FFFFFF"/>
+                </a:solidFill>
+                <a:latin typeface="Meiryo"/>
+              </a:rPr>
+              <a:t>この攻撃の手口</a:t>
+            </a:r>
+          </a:p>
+        </p:txBody>
+      </p:sp>
+      <p:sp>
+        <p:nvSpPr>
+          <p:cNvPr id="6" name="Rectangle 5"/>
+          <p:cNvSpPr/>
+          <p:nvPr/>
+        </p:nvSpPr>
+        <p:spPr>
+          <a:xfrm>
+            <a:off x="9601200" y="1463040"/>
+            <a:ext cx="4114800" cy="502920"/>
+          </a:xfrm>
+          <a:prstGeom prst="rect">
+            <a:avLst/>
+          </a:prstGeom>
+          <a:solidFill>
+            <a:srgbClr val="222222"/>
+          </a:solidFill>
+          <a:ln>
+            <a:noFill/>
+          </a:ln>
+        </p:spPr>
+        <p:style>
+          <a:lnRef idx="1">
+            <a:schemeClr val="accent1"/>
+          </a:lnRef>
+          <a:fillRef idx="3">
+            <a:schemeClr val="accent1"/>
+          </a:fillRef>
+          <a:effectRef idx="2">
+            <a:schemeClr val="accent1"/>
+          </a:effectRef>
+          <a:fontRef idx="minor">
+            <a:schemeClr val="lt1"/>
+          </a:fontRef>
+        </p:style>
+        <p:txBody>
+          <a:bodyPr rtlCol="0" anchor="ctr" wrap="square" lIns="50800" rIns="50800" tIns="25400" bIns="25400"/>
+          <a:lstStyle/>
+          <a:p>
+            <a:pPr algn="ctr"/>
+            <a:r>
+              <a:rPr sz="1200" b="1">
+                <a:solidFill>
+                  <a:srgbClr val="FFFFFF"/>
+                </a:solidFill>
+                <a:latin typeface="Meiryo"/>
+              </a:rPr>
+              <a:t>顧客の体験</a:t>
+            </a:r>
+          </a:p>
+        </p:txBody>
+      </p:sp>
+      <p:sp>
+        <p:nvSpPr>
+          <p:cNvPr id="7" name="Rectangle 6"/>
+          <p:cNvSpPr/>
+          <p:nvPr/>
+        </p:nvSpPr>
+        <p:spPr>
+          <a:xfrm>
+            <a:off x="1371600" y="1965960"/>
+            <a:ext cx="4114800" cy="502920"/>
+          </a:xfrm>
+          <a:prstGeom prst="rect">
+            <a:avLst/>
+          </a:prstGeom>
+          <a:solidFill>
+            <a:srgbClr val="FFFFFF"/>
+          </a:solidFill>
+          <a:ln w="25400">
+            <a:solidFill>
+              <a:srgbClr val="CCCCCC"/>
+            </a:solidFill>
+          </a:ln>
+        </p:spPr>
+        <p:style>
+          <a:lnRef idx="1">
+            <a:schemeClr val="accent1"/>
+          </a:lnRef>
+          <a:fillRef idx="3">
+            <a:schemeClr val="accent1"/>
+          </a:fillRef>
+          <a:effectRef idx="2">
+            <a:schemeClr val="accent1"/>
+          </a:effectRef>
+          <a:fontRef idx="minor">
+            <a:schemeClr val="lt1"/>
+          </a:fontRef>
+        </p:style>
+        <p:txBody>
+          <a:bodyPr rtlCol="0" anchor="ctr" wrap="square" lIns="63500" rIns="50800" tIns="38100" bIns="38100"/>
+          <a:lstStyle/>
+          <a:p>
+            <a:pPr algn="l"/>
+            <a:r>
+              <a:rPr sz="1100" b="0">
+                <a:solidFill>
+                  <a:srgbClr val="222222"/>
+                </a:solidFill>
+                <a:latin typeface="Meiryo"/>
+              </a:rPr>
+              <a:t>自動音声で用件を振り分け</a:t>
+            </a:r>
+          </a:p>
+        </p:txBody>
+      </p:sp>
+      <p:sp>
+        <p:nvSpPr>
+          <p:cNvPr id="8" name="Rectangle 7"/>
+          <p:cNvSpPr/>
+          <p:nvPr/>
+        </p:nvSpPr>
+        <p:spPr>
+          <a:xfrm>
+            <a:off x="5486400" y="1965960"/>
+            <a:ext cx="4114800" cy="502920"/>
+          </a:xfrm>
+          <a:prstGeom prst="rect">
+            <a:avLst/>
+          </a:prstGeom>
+          <a:solidFill>
+            <a:srgbClr val="FFFFFF"/>
+          </a:solidFill>
+          <a:ln w="25400">
+            <a:solidFill>
+              <a:srgbClr val="CCCCCC"/>
+            </a:solidFill>
+          </a:ln>
+        </p:spPr>
+        <p:style>
+          <a:lnRef idx="1">
+            <a:schemeClr val="accent1"/>
+          </a:lnRef>
+          <a:fillRef idx="3">
+            <a:schemeClr val="accent1"/>
+          </a:fillRef>
+          <a:effectRef idx="2">
+            <a:schemeClr val="accent1"/>
+          </a:effectRef>
+          <a:fontRef idx="minor">
+            <a:schemeClr val="lt1"/>
+          </a:fontRef>
+        </p:style>
+        <p:txBody>
+          <a:bodyPr rtlCol="0" anchor="ctr" wrap="square" lIns="63500" rIns="50800" tIns="38100" bIns="38100"/>
+          <a:lstStyle/>
+          <a:p>
+            <a:pPr algn="l"/>
+            <a:r>
+              <a:rPr sz="1100" b="0">
+                <a:solidFill>
+                  <a:srgbClr val="222222"/>
+                </a:solidFill>
+                <a:latin typeface="Meiryo"/>
+              </a:rPr>
+              <a:t>自動音声で権限者を選別</a:t>
+            </a:r>
+          </a:p>
+        </p:txBody>
+      </p:sp>
+      <p:sp>
+        <p:nvSpPr>
+          <p:cNvPr id="9" name="Rectangle 8"/>
+          <p:cNvSpPr/>
+          <p:nvPr/>
+        </p:nvSpPr>
+        <p:spPr>
+          <a:xfrm>
+            <a:off x="9601200" y="1965960"/>
+            <a:ext cx="4114800" cy="502920"/>
+          </a:xfrm>
+          <a:prstGeom prst="rect">
+            <a:avLst/>
+          </a:prstGeom>
+          <a:solidFill>
+            <a:srgbClr val="FFFFFF"/>
+          </a:solidFill>
+          <a:ln>
+            <a:noFill/>
+          </a:ln>
+        </p:spPr>
+        <p:style>
+          <a:lnRef idx="1">
+            <a:schemeClr val="accent1"/>
+          </a:lnRef>
+          <a:fillRef idx="3">
+            <a:schemeClr val="accent1"/>
+          </a:fillRef>
+          <a:effectRef idx="2">
+            <a:schemeClr val="accent1"/>
+          </a:effectRef>
+          <a:fontRef idx="minor">
+            <a:schemeClr val="lt1"/>
+          </a:fontRef>
+        </p:style>
+        <p:txBody>
+          <a:bodyPr rtlCol="0" anchor="ctr" wrap="square" lIns="50800" rIns="50800" tIns="25400" bIns="25400"/>
+          <a:lstStyle/>
+          <a:p>
+            <a:pPr algn="ctr"/>
+            <a:r>
+              <a:rPr sz="1400" b="1">
+                <a:solidFill>
+                  <a:srgbClr val="C0392B"/>
+                </a:solidFill>
+                <a:latin typeface="Meiryo"/>
+              </a:rPr>
+              <a:t>同じ</a:t>
+            </a:r>
+          </a:p>
+        </p:txBody>
+      </p:sp>
+      <p:sp>
+        <p:nvSpPr>
+          <p:cNvPr id="10" name="Rectangle 9"/>
+          <p:cNvSpPr/>
+          <p:nvPr/>
+        </p:nvSpPr>
+        <p:spPr>
+          <a:xfrm>
+            <a:off x="1371600" y="2468880"/>
+            <a:ext cx="4114800" cy="502920"/>
+          </a:xfrm>
+          <a:prstGeom prst="rect">
+            <a:avLst/>
+          </a:prstGeom>
+          <a:solidFill>
+            <a:srgbClr val="F9F9F9"/>
+          </a:solidFill>
+          <a:ln w="25400">
+            <a:solidFill>
+              <a:srgbClr val="CCCCCC"/>
+            </a:solidFill>
+          </a:ln>
+        </p:spPr>
+        <p:style>
+          <a:lnRef idx="1">
+            <a:schemeClr val="accent1"/>
+          </a:lnRef>
+          <a:fillRef idx="3">
+            <a:schemeClr val="accent1"/>
+          </a:fillRef>
+          <a:effectRef idx="2">
+            <a:schemeClr val="accent1"/>
+          </a:effectRef>
+          <a:fontRef idx="minor">
+            <a:schemeClr val="lt1"/>
+          </a:fontRef>
+        </p:style>
+        <p:txBody>
+          <a:bodyPr rtlCol="0" anchor="ctr" wrap="square" lIns="63500" rIns="50800" tIns="38100" bIns="38100"/>
+          <a:lstStyle/>
+          <a:p>
+            <a:pPr algn="l"/>
+            <a:r>
+              <a:rPr sz="1100" b="0">
+                <a:solidFill>
+                  <a:srgbClr val="222222"/>
+                </a:solidFill>
+                <a:latin typeface="Meiryo"/>
+              </a:rPr>
+              <a:t>番号を押して選択</a:t>
+            </a:r>
+          </a:p>
+        </p:txBody>
+      </p:sp>
+      <p:sp>
+        <p:nvSpPr>
+          <p:cNvPr id="11" name="Rectangle 10"/>
+          <p:cNvSpPr/>
+          <p:nvPr/>
+        </p:nvSpPr>
+        <p:spPr>
+          <a:xfrm>
+            <a:off x="5486400" y="2468880"/>
+            <a:ext cx="4114800" cy="502920"/>
+          </a:xfrm>
+          <a:prstGeom prst="rect">
+            <a:avLst/>
+          </a:prstGeom>
+          <a:solidFill>
+            <a:srgbClr val="F9F9F9"/>
+          </a:solidFill>
+          <a:ln w="25400">
+            <a:solidFill>
+              <a:srgbClr val="CCCCCC"/>
+            </a:solidFill>
+          </a:ln>
+        </p:spPr>
+        <p:style>
+          <a:lnRef idx="1">
+            <a:schemeClr val="accent1"/>
+          </a:lnRef>
+          <a:fillRef idx="3">
+            <a:schemeClr val="accent1"/>
+          </a:fillRef>
+          <a:effectRef idx="2">
+            <a:schemeClr val="accent1"/>
+          </a:effectRef>
+          <a:fontRef idx="minor">
+            <a:schemeClr val="lt1"/>
+          </a:fontRef>
+        </p:style>
+        <p:txBody>
+          <a:bodyPr rtlCol="0" anchor="ctr" wrap="square" lIns="63500" rIns="50800" tIns="38100" bIns="38100"/>
+          <a:lstStyle/>
+          <a:p>
+            <a:pPr algn="l"/>
+            <a:r>
+              <a:rPr sz="1100" b="0">
+                <a:solidFill>
+                  <a:srgbClr val="222222"/>
+                </a:solidFill>
+                <a:latin typeface="Meiryo"/>
+              </a:rPr>
+              <a:t>「1」を押す</a:t>
+            </a:r>
+          </a:p>
+        </p:txBody>
+      </p:sp>
+      <p:sp>
+        <p:nvSpPr>
+          <p:cNvPr id="12" name="Rectangle 11"/>
+          <p:cNvSpPr/>
+          <p:nvPr/>
+        </p:nvSpPr>
+        <p:spPr>
+          <a:xfrm>
+            <a:off x="9601200" y="2468880"/>
+            <a:ext cx="4114800" cy="502920"/>
+          </a:xfrm>
+          <a:prstGeom prst="rect">
+            <a:avLst/>
+          </a:prstGeom>
+          <a:solidFill>
+            <a:srgbClr val="F9F9F9"/>
+          </a:solidFill>
+          <a:ln>
+            <a:noFill/>
+          </a:ln>
+        </p:spPr>
+        <p:style>
+          <a:lnRef idx="1">
+            <a:schemeClr val="accent1"/>
+          </a:lnRef>
+          <a:fillRef idx="3">
+            <a:schemeClr val="accent1"/>
+          </a:fillRef>
+          <a:effectRef idx="2">
+            <a:schemeClr val="accent1"/>
+          </a:effectRef>
+          <a:fontRef idx="minor">
+            <a:schemeClr val="lt1"/>
+          </a:fontRef>
+        </p:style>
+        <p:txBody>
+          <a:bodyPr rtlCol="0" anchor="ctr" wrap="square" lIns="50800" rIns="50800" tIns="25400" bIns="25400"/>
+          <a:lstStyle/>
+          <a:p>
+            <a:pPr algn="ctr"/>
+            <a:r>
+              <a:rPr sz="1400" b="1">
+                <a:solidFill>
+                  <a:srgbClr val="C0392B"/>
+                </a:solidFill>
+                <a:latin typeface="Meiryo"/>
+              </a:rPr>
+              <a:t>同じ</a:t>
+            </a:r>
+          </a:p>
+        </p:txBody>
+      </p:sp>
+      <p:sp>
+        <p:nvSpPr>
+          <p:cNvPr id="13" name="Rectangle 12"/>
+          <p:cNvSpPr/>
+          <p:nvPr/>
+        </p:nvSpPr>
+        <p:spPr>
+          <a:xfrm>
+            <a:off x="1371600" y="2971800"/>
+            <a:ext cx="4114800" cy="502920"/>
+          </a:xfrm>
+          <a:prstGeom prst="rect">
+            <a:avLst/>
+          </a:prstGeom>
+          <a:solidFill>
+            <a:srgbClr val="FFFFFF"/>
+          </a:solidFill>
+          <a:ln w="25400">
+            <a:solidFill>
+              <a:srgbClr val="CCCCCC"/>
+            </a:solidFill>
+          </a:ln>
+        </p:spPr>
+        <p:style>
+          <a:lnRef idx="1">
+            <a:schemeClr val="accent1"/>
+          </a:lnRef>
+          <a:fillRef idx="3">
+            <a:schemeClr val="accent1"/>
+          </a:fillRef>
+          <a:effectRef idx="2">
+            <a:schemeClr val="accent1"/>
+          </a:effectRef>
+          <a:fontRef idx="minor">
+            <a:schemeClr val="lt1"/>
+          </a:fontRef>
+        </p:style>
+        <p:txBody>
+          <a:bodyPr rtlCol="0" anchor="ctr" wrap="square" lIns="63500" rIns="50800" tIns="38100" bIns="38100"/>
+          <a:lstStyle/>
+          <a:p>
+            <a:pPr algn="l"/>
+            <a:r>
+              <a:rPr sz="1100" b="0">
+                <a:solidFill>
+                  <a:srgbClr val="222222"/>
+                </a:solidFill>
+                <a:latin typeface="Meiryo"/>
+              </a:rPr>
+              <a:t>担当者と話す</a:t>
+            </a:r>
+          </a:p>
+        </p:txBody>
+      </p:sp>
+      <p:sp>
+        <p:nvSpPr>
+          <p:cNvPr id="14" name="Rectangle 13"/>
+          <p:cNvSpPr/>
+          <p:nvPr/>
+        </p:nvSpPr>
+        <p:spPr>
+          <a:xfrm>
+            <a:off x="5486400" y="2971800"/>
+            <a:ext cx="4114800" cy="502920"/>
+          </a:xfrm>
+          <a:prstGeom prst="rect">
+            <a:avLst/>
+          </a:prstGeom>
+          <a:solidFill>
+            <a:srgbClr val="FFFFFF"/>
+          </a:solidFill>
+          <a:ln w="25400">
+            <a:solidFill>
+              <a:srgbClr val="CCCCCC"/>
+            </a:solidFill>
+          </a:ln>
+        </p:spPr>
+        <p:style>
+          <a:lnRef idx="1">
+            <a:schemeClr val="accent1"/>
+          </a:lnRef>
+          <a:fillRef idx="3">
+            <a:schemeClr val="accent1"/>
+          </a:fillRef>
+          <a:effectRef idx="2">
+            <a:schemeClr val="accent1"/>
+          </a:effectRef>
+          <a:fontRef idx="minor">
+            <a:schemeClr val="lt1"/>
+          </a:fontRef>
+        </p:style>
+        <p:txBody>
+          <a:bodyPr rtlCol="0" anchor="ctr" wrap="square" lIns="63500" rIns="50800" tIns="38100" bIns="38100"/>
+          <a:lstStyle/>
+          <a:p>
+            <a:pPr algn="l"/>
+            <a:r>
+              <a:rPr sz="1100" b="0">
+                <a:solidFill>
+                  <a:srgbClr val="222222"/>
+                </a:solidFill>
+                <a:latin typeface="Meiryo"/>
+              </a:rPr>
+              <a:t>犯人（AI音声/有人）と話す</a:t>
+            </a:r>
+          </a:p>
+        </p:txBody>
+      </p:sp>
+      <p:sp>
+        <p:nvSpPr>
+          <p:cNvPr id="15" name="Rectangle 14"/>
+          <p:cNvSpPr/>
+          <p:nvPr/>
+        </p:nvSpPr>
+        <p:spPr>
+          <a:xfrm>
+            <a:off x="9601200" y="2971800"/>
+            <a:ext cx="4114800" cy="502920"/>
+          </a:xfrm>
+          <a:prstGeom prst="rect">
+            <a:avLst/>
+          </a:prstGeom>
+          <a:solidFill>
+            <a:srgbClr val="FFFFFF"/>
+          </a:solidFill>
+          <a:ln>
+            <a:noFill/>
+          </a:ln>
+        </p:spPr>
+        <p:style>
+          <a:lnRef idx="1">
+            <a:schemeClr val="accent1"/>
+          </a:lnRef>
+          <a:fillRef idx="3">
+            <a:schemeClr val="accent1"/>
+          </a:fillRef>
+          <a:effectRef idx="2">
+            <a:schemeClr val="accent1"/>
+          </a:effectRef>
+          <a:fontRef idx="minor">
+            <a:schemeClr val="lt1"/>
+          </a:fontRef>
+        </p:style>
+        <p:txBody>
+          <a:bodyPr rtlCol="0" anchor="ctr" wrap="square" lIns="50800" rIns="50800" tIns="25400" bIns="25400"/>
+          <a:lstStyle/>
+          <a:p>
+            <a:pPr algn="ctr"/>
+            <a:r>
+              <a:rPr sz="1400" b="1">
+                <a:solidFill>
+                  <a:srgbClr val="C0392B"/>
+                </a:solidFill>
+                <a:latin typeface="Meiryo"/>
+              </a:rPr>
+              <a:t>同じ</a:t>
+            </a:r>
+          </a:p>
+        </p:txBody>
+      </p:sp>
+      <p:sp>
+        <p:nvSpPr>
+          <p:cNvPr id="16" name="Rectangle 15"/>
+          <p:cNvSpPr/>
+          <p:nvPr/>
+        </p:nvSpPr>
+        <p:spPr>
+          <a:xfrm>
+            <a:off x="1371600" y="3474720"/>
+            <a:ext cx="4114800" cy="502920"/>
+          </a:xfrm>
+          <a:prstGeom prst="rect">
+            <a:avLst/>
+          </a:prstGeom>
+          <a:solidFill>
+            <a:srgbClr val="F9F9F9"/>
+          </a:solidFill>
+          <a:ln w="25400">
+            <a:solidFill>
+              <a:srgbClr val="CCCCCC"/>
+            </a:solidFill>
+          </a:ln>
+        </p:spPr>
+        <p:style>
+          <a:lnRef idx="1">
+            <a:schemeClr val="accent1"/>
+          </a:lnRef>
+          <a:fillRef idx="3">
+            <a:schemeClr val="accent1"/>
+          </a:fillRef>
+          <a:effectRef idx="2">
+            <a:schemeClr val="accent1"/>
+          </a:effectRef>
+          <a:fontRef idx="minor">
+            <a:schemeClr val="lt1"/>
+          </a:fontRef>
+        </p:style>
+        <p:txBody>
+          <a:bodyPr rtlCol="0" anchor="ctr" wrap="square" lIns="63500" rIns="50800" tIns="38100" bIns="38100"/>
+          <a:lstStyle/>
+          <a:p>
+            <a:pPr algn="l"/>
+            <a:r>
+              <a:rPr sz="1100" b="0">
+                <a:solidFill>
+                  <a:srgbClr val="222222"/>
+                </a:solidFill>
+                <a:latin typeface="Meiryo"/>
+              </a:rPr>
+              <a:t>指示に従って手続き</a:t>
+            </a:r>
+          </a:p>
+        </p:txBody>
+      </p:sp>
+      <p:sp>
+        <p:nvSpPr>
+          <p:cNvPr id="17" name="Rectangle 16"/>
+          <p:cNvSpPr/>
+          <p:nvPr/>
+        </p:nvSpPr>
+        <p:spPr>
+          <a:xfrm>
+            <a:off x="5486400" y="3474720"/>
+            <a:ext cx="4114800" cy="502920"/>
+          </a:xfrm>
+          <a:prstGeom prst="rect">
+            <a:avLst/>
+          </a:prstGeom>
+          <a:solidFill>
+            <a:srgbClr val="F9F9F9"/>
+          </a:solidFill>
+          <a:ln w="25400">
+            <a:solidFill>
+              <a:srgbClr val="CCCCCC"/>
+            </a:solidFill>
+          </a:ln>
+        </p:spPr>
+        <p:style>
+          <a:lnRef idx="1">
+            <a:schemeClr val="accent1"/>
+          </a:lnRef>
+          <a:fillRef idx="3">
+            <a:schemeClr val="accent1"/>
+          </a:fillRef>
+          <a:effectRef idx="2">
+            <a:schemeClr val="accent1"/>
+          </a:effectRef>
+          <a:fontRef idx="minor">
+            <a:schemeClr val="lt1"/>
+          </a:fontRef>
+        </p:style>
+        <p:txBody>
+          <a:bodyPr rtlCol="0" anchor="ctr" wrap="square" lIns="63500" rIns="50800" tIns="38100" bIns="38100"/>
+          <a:lstStyle/>
+          <a:p>
+            <a:pPr algn="l"/>
+            <a:r>
+              <a:rPr sz="1100" b="0">
+                <a:solidFill>
+                  <a:srgbClr val="222222"/>
+                </a:solidFill>
+                <a:latin typeface="Meiryo"/>
+              </a:rPr>
+              <a:t>指示に従ってインストール</a:t>
+            </a:r>
+          </a:p>
+        </p:txBody>
+      </p:sp>
+      <p:sp>
+        <p:nvSpPr>
+          <p:cNvPr id="18" name="Rectangle 17"/>
+          <p:cNvSpPr/>
+          <p:nvPr/>
+        </p:nvSpPr>
+        <p:spPr>
+          <a:xfrm>
+            <a:off x="9601200" y="3474720"/>
+            <a:ext cx="4114800" cy="502920"/>
+          </a:xfrm>
+          <a:prstGeom prst="rect">
+            <a:avLst/>
+          </a:prstGeom>
+          <a:solidFill>
+            <a:srgbClr val="F9F9F9"/>
+          </a:solidFill>
+          <a:ln>
+            <a:noFill/>
+          </a:ln>
+        </p:spPr>
+        <p:style>
+          <a:lnRef idx="1">
+            <a:schemeClr val="accent1"/>
+          </a:lnRef>
+          <a:fillRef idx="3">
+            <a:schemeClr val="accent1"/>
+          </a:fillRef>
+          <a:effectRef idx="2">
+            <a:schemeClr val="accent1"/>
+          </a:effectRef>
+          <a:fontRef idx="minor">
+            <a:schemeClr val="lt1"/>
+          </a:fontRef>
+        </p:style>
+        <p:txBody>
+          <a:bodyPr rtlCol="0" anchor="ctr" wrap="square" lIns="50800" rIns="50800" tIns="25400" bIns="25400"/>
+          <a:lstStyle/>
+          <a:p>
+            <a:pPr algn="ctr"/>
+            <a:r>
+              <a:rPr sz="1400" b="1">
+                <a:solidFill>
+                  <a:srgbClr val="C0392B"/>
+                </a:solidFill>
+                <a:latin typeface="Meiryo"/>
+              </a:rPr>
+              <a:t>同じ</a:t>
+            </a:r>
+          </a:p>
+        </p:txBody>
+      </p:sp>
+      <p:sp>
+        <p:nvSpPr>
+          <p:cNvPr id="19" name="Rectangle 18"/>
+          <p:cNvSpPr/>
+          <p:nvPr/>
+        </p:nvSpPr>
+        <p:spPr>
+          <a:xfrm>
+            <a:off x="1371600" y="3977639"/>
+            <a:ext cx="4114800" cy="502920"/>
+          </a:xfrm>
+          <a:prstGeom prst="rect">
+            <a:avLst/>
+          </a:prstGeom>
+          <a:solidFill>
+            <a:srgbClr val="FFFFFF"/>
+          </a:solidFill>
+          <a:ln w="25400">
+            <a:solidFill>
+              <a:srgbClr val="CCCCCC"/>
+            </a:solidFill>
+          </a:ln>
+        </p:spPr>
+        <p:style>
+          <a:lnRef idx="1">
+            <a:schemeClr val="accent1"/>
+          </a:lnRef>
+          <a:fillRef idx="3">
+            <a:schemeClr val="accent1"/>
+          </a:fillRef>
+          <a:effectRef idx="2">
+            <a:schemeClr val="accent1"/>
+          </a:effectRef>
+          <a:fontRef idx="minor">
+            <a:schemeClr val="lt1"/>
+          </a:fontRef>
+        </p:style>
+        <p:txBody>
+          <a:bodyPr rtlCol="0" anchor="ctr" wrap="square" lIns="63500" rIns="50800" tIns="38100" bIns="38100"/>
+          <a:lstStyle/>
+          <a:p>
+            <a:pPr algn="l"/>
+            <a:r>
+              <a:rPr sz="1100" b="0">
+                <a:solidFill>
+                  <a:srgbClr val="222222"/>
+                </a:solidFill>
+                <a:latin typeface="Meiryo"/>
+              </a:rPr>
+              <a:t>本人確認で情報を伝える</a:t>
+            </a:r>
+          </a:p>
+        </p:txBody>
+      </p:sp>
+      <p:sp>
+        <p:nvSpPr>
+          <p:cNvPr id="20" name="Rectangle 19"/>
+          <p:cNvSpPr/>
+          <p:nvPr/>
+        </p:nvSpPr>
+        <p:spPr>
+          <a:xfrm>
+            <a:off x="5486400" y="3977639"/>
+            <a:ext cx="4114800" cy="502920"/>
+          </a:xfrm>
+          <a:prstGeom prst="rect">
+            <a:avLst/>
+          </a:prstGeom>
+          <a:solidFill>
+            <a:srgbClr val="FFFFFF"/>
+          </a:solidFill>
+          <a:ln w="25400">
+            <a:solidFill>
+              <a:srgbClr val="CCCCCC"/>
+            </a:solidFill>
+          </a:ln>
+        </p:spPr>
+        <p:style>
+          <a:lnRef idx="1">
+            <a:schemeClr val="accent1"/>
+          </a:lnRef>
+          <a:fillRef idx="3">
+            <a:schemeClr val="accent1"/>
+          </a:fillRef>
+          <a:effectRef idx="2">
+            <a:schemeClr val="accent1"/>
+          </a:effectRef>
+          <a:fontRef idx="minor">
+            <a:schemeClr val="lt1"/>
+          </a:fontRef>
+        </p:style>
+        <p:txBody>
+          <a:bodyPr rtlCol="0" anchor="ctr" wrap="square" lIns="63500" rIns="50800" tIns="38100" bIns="38100"/>
+          <a:lstStyle/>
+          <a:p>
+            <a:pPr algn="l"/>
+            <a:r>
+              <a:rPr sz="1100" b="0">
+                <a:solidFill>
+                  <a:srgbClr val="222222"/>
+                </a:solidFill>
+                <a:latin typeface="Meiryo"/>
+              </a:rPr>
+              <a:t>認証情報をすべて入力</a:t>
+            </a:r>
+          </a:p>
+        </p:txBody>
+      </p:sp>
+      <p:sp>
+        <p:nvSpPr>
+          <p:cNvPr id="21" name="Rectangle 20"/>
+          <p:cNvSpPr/>
+          <p:nvPr/>
+        </p:nvSpPr>
+        <p:spPr>
+          <a:xfrm>
+            <a:off x="9601200" y="3977639"/>
+            <a:ext cx="4114800" cy="502920"/>
+          </a:xfrm>
+          <a:prstGeom prst="rect">
+            <a:avLst/>
+          </a:prstGeom>
+          <a:solidFill>
+            <a:srgbClr val="FFFFFF"/>
+          </a:solidFill>
+          <a:ln>
+            <a:noFill/>
+          </a:ln>
+        </p:spPr>
+        <p:style>
+          <a:lnRef idx="1">
+            <a:schemeClr val="accent1"/>
+          </a:lnRef>
+          <a:fillRef idx="3">
+            <a:schemeClr val="accent1"/>
+          </a:fillRef>
+          <a:effectRef idx="2">
+            <a:schemeClr val="accent1"/>
+          </a:effectRef>
+          <a:fontRef idx="minor">
+            <a:schemeClr val="lt1"/>
+          </a:fontRef>
+        </p:style>
+        <p:txBody>
+          <a:bodyPr rtlCol="0" anchor="ctr" wrap="square" lIns="50800" rIns="50800" tIns="25400" bIns="25400"/>
+          <a:lstStyle/>
+          <a:p>
+            <a:pPr algn="ctr"/>
+            <a:r>
+              <a:rPr sz="1400" b="1">
+                <a:solidFill>
+                  <a:srgbClr val="C0392B"/>
+                </a:solidFill>
+                <a:latin typeface="Meiryo"/>
+              </a:rPr>
+              <a:t>同じ</a:t>
+            </a:r>
+          </a:p>
+        </p:txBody>
+      </p:sp>
+      <p:sp>
+        <p:nvSpPr>
+          <p:cNvPr id="22" name="Rectangle 21"/>
+          <p:cNvSpPr/>
+          <p:nvPr/>
+        </p:nvSpPr>
+        <p:spPr>
+          <a:xfrm>
+            <a:off x="1371600" y="4754880"/>
+            <a:ext cx="12344400" cy="457200"/>
+          </a:xfrm>
+          <a:prstGeom prst="rect">
+            <a:avLst/>
+          </a:prstGeom>
+          <a:solidFill>
+            <a:srgbClr val="C0392B"/>
+          </a:solidFill>
+          <a:ln>
+            <a:noFill/>
+          </a:ln>
+        </p:spPr>
+        <p:style>
+          <a:lnRef idx="1">
+            <a:schemeClr val="accent1"/>
+          </a:lnRef>
+          <a:fillRef idx="3">
+            <a:schemeClr val="accent1"/>
+          </a:fillRef>
+          <a:effectRef idx="2">
+            <a:schemeClr val="accent1"/>
+          </a:effectRef>
+          <a:fontRef idx="minor">
+            <a:schemeClr val="lt1"/>
+          </a:fontRef>
+        </p:style>
+        <p:txBody>
+          <a:bodyPr rtlCol="0" anchor="ctr" wrap="square" lIns="50800" rIns="50800" tIns="25400" bIns="25400"/>
+          <a:lstStyle/>
+          <a:p>
+            <a:pPr algn="ctr"/>
+            <a:r>
+              <a:rPr sz="1600" b="1">
+                <a:solidFill>
+                  <a:srgbClr val="FFFFFF"/>
+                </a:solidFill>
+                <a:latin typeface="Meiryo"/>
+              </a:rPr>
+              <a:t>構造的問題：正規と詐欺の区別が顧客側ではほぼ不可能</a:t>
+            </a:r>
+          </a:p>
+        </p:txBody>
+      </p:sp>
+      <p:sp>
+        <p:nvSpPr>
+          <p:cNvPr id="23" name="TextBox 22"/>
+          <p:cNvSpPr txBox="1"/>
+          <p:nvPr/>
+        </p:nvSpPr>
+        <p:spPr>
+          <a:xfrm>
+            <a:off x="1371600" y="5486400"/>
+            <a:ext cx="12344400" cy="1645920"/>
+          </a:xfrm>
+          <a:prstGeom prst="rect">
+            <a:avLst/>
+          </a:prstGeom>
+          <a:noFill/>
+        </p:spPr>
+        <p:txBody>
+          <a:bodyPr wrap="square" lIns="50800" rIns="50800" tIns="38100" bIns="38100"/>
+          <a:lstStyle/>
+          <a:p>
+            <a:pPr algn="l"/>
+            <a:r>
+              <a:rPr sz="1300" b="0">
+                <a:solidFill>
+                  <a:srgbClr val="222222"/>
+                </a:solidFill>
+                <a:latin typeface="Meiryo"/>
+              </a:rPr>
+              <a:t>銀行側が取るべき対策：
+① 架電を原則廃止し「銀行からは電話しません」と宣言する
+② やむを得ない架電は事前にIB画面やアプリで通知してから行う
+③「電話でソフトインストールを指示することはない」を明示する（現状周知不足）</a:t>
+            </a:r>
+          </a:p>
+        </p:txBody>
+      </p:sp>
+      <p:sp>
+        <p:nvSpPr>
+          <p:cNvPr id="24" name="TextBox 23"/>
+          <p:cNvSpPr txBox="1"/>
+          <p:nvPr/>
+        </p:nvSpPr>
+        <p:spPr>
+          <a:xfrm>
+            <a:off x="9144000" y="10378440"/>
+            <a:ext cx="5943600" cy="228600"/>
+          </a:xfrm>
+          <a:prstGeom prst="rect">
+            <a:avLst/>
+          </a:prstGeom>
+          <a:noFill/>
+        </p:spPr>
+        <p:txBody>
+          <a:bodyPr wrap="square" lIns="50800" rIns="50800" tIns="38100" bIns="38100"/>
+          <a:lstStyle/>
+          <a:p>
+            <a:pPr algn="r"/>
+            <a:r>
+              <a:rPr sz="700" b="0">
+                <a:solidFill>
+                  <a:srgbClr val="888888"/>
+                </a:solidFill>
+                <a:latin typeface="Meiryo"/>
+              </a:rPr>
+              <a:t>Fraud Kill Chain — 銀行の正規フローとの類似性</a:t>
             </a:r>
           </a:p>
         </p:txBody>

</xml_diff>

<commit_message>
Add slide 3: psychological manipulation analysis of step 2
Break down the four scripted lines and their psychological goals
(foreshadowing, fear, guilt, legitimization). Show how any response
to "did you receive it?" still advances the attacker's scenario.

https://claude.ai/code/session_01F7t8LKifK43o6sCdF2a3gQ
</commit_message>
<xml_diff>
--- a/Fraud_Kill_Chain.pptx
+++ b/Fraud_Kill_Chain.pptx
@@ -7,6 +7,7 @@
   <p:sldIdLst>
     <p:sldId id="256" r:id="rId7"/>
     <p:sldId id="257" r:id="rId8"/>
+    <p:sldId id="258" r:id="rId9"/>
   </p:sldIdLst>
   <p:sldSz cx="15124176" cy="10689336" type="screen4x3"/>
   <p:notesSz cx="6858000" cy="9144000"/>
@@ -8518,6 +8519,1278 @@
                 <a:latin typeface="Meiryo"/>
               </a:rPr>
               <a:t>Fraud Kill Chain — 銀行の正規フローとの類似性</a:t>
+            </a:r>
+          </a:p>
+        </p:txBody>
+      </p:sp>
+    </p:spTree>
+  </p:cSld>
+  <p:clrMapOvr>
+    <a:masterClrMapping/>
+  </p:clrMapOvr>
+</p:sld>
+</file>
+
+<file path=ppt/slides/slide3.xml><?xml version="1.0" encoding="utf-8"?>
+<p:sld xmlns:a="http://schemas.openxmlformats.org/drawingml/2006/main" xmlns:p="http://schemas.openxmlformats.org/presentationml/2006/main" xmlns:r="http://schemas.openxmlformats.org/officeDocument/2006/relationships">
+  <p:cSld>
+    <p:bg>
+      <p:bgPr>
+        <a:solidFill>
+          <a:srgbClr val="F5F5F5"/>
+        </a:solidFill>
+        <a:effectLst/>
+      </p:bgPr>
+    </p:bg>
+    <p:spTree>
+      <p:nvGrpSpPr>
+        <p:cNvPr id="1" name=""/>
+        <p:cNvGrpSpPr/>
+        <p:nvPr/>
+      </p:nvGrpSpPr>
+      <p:grpSpPr/>
+      <p:sp>
+        <p:nvSpPr>
+          <p:cNvPr id="2" name="TextBox 1"/>
+          <p:cNvSpPr txBox="1"/>
+          <p:nvPr/>
+        </p:nvSpPr>
+        <p:spPr>
+          <a:xfrm>
+            <a:off x="0" y="274320"/>
+            <a:ext cx="15124176" cy="548640"/>
+          </a:xfrm>
+          <a:prstGeom prst="rect">
+            <a:avLst/>
+          </a:prstGeom>
+          <a:noFill/>
+        </p:spPr>
+        <p:txBody>
+          <a:bodyPr wrap="square" lIns="50800" rIns="50800" tIns="38100" bIns="38100"/>
+          <a:lstStyle/>
+          <a:p>
+            <a:pPr algn="ctr"/>
+            <a:r>
+              <a:rPr sz="2200" b="1">
+                <a:solidFill>
+                  <a:srgbClr val="E67E22"/>
+                </a:solidFill>
+                <a:latin typeface="Meiryo"/>
+              </a:rPr>
+              <a:t>手順②の心理操作 — どう答えても犯人のシナリオに乗る設計</a:t>
+            </a:r>
+          </a:p>
+        </p:txBody>
+      </p:sp>
+      <p:sp>
+        <p:nvSpPr>
+          <p:cNvPr id="3" name="TextBox 2"/>
+          <p:cNvSpPr txBox="1"/>
+          <p:nvPr/>
+        </p:nvSpPr>
+        <p:spPr>
+          <a:xfrm>
+            <a:off x="0" y="777240"/>
+            <a:ext cx="15124176" cy="365760"/>
+          </a:xfrm>
+          <a:prstGeom prst="rect">
+            <a:avLst/>
+          </a:prstGeom>
+          <a:noFill/>
+        </p:spPr>
+        <p:txBody>
+          <a:bodyPr wrap="square" lIns="50800" rIns="50800" tIns="38100" bIns="38100"/>
+          <a:lstStyle/>
+          <a:p>
+            <a:pPr algn="ctr"/>
+            <a:r>
+              <a:rPr sz="1200" b="0">
+                <a:solidFill>
+                  <a:srgbClr val="888888"/>
+                </a:solidFill>
+                <a:latin typeface="Meiryo"/>
+              </a:rPr>
+              <a:t>4つのセリフそれぞれに明確な狙いがあり、被害者の心理的退路を塞いでいる。</a:t>
+            </a:r>
+          </a:p>
+        </p:txBody>
+      </p:sp>
+      <p:sp>
+        <p:nvSpPr>
+          <p:cNvPr id="4" name="Rectangle 3"/>
+          <p:cNvSpPr/>
+          <p:nvPr/>
+        </p:nvSpPr>
+        <p:spPr>
+          <a:xfrm>
+            <a:off x="1371600" y="1371600"/>
+            <a:ext cx="4114800" cy="594360"/>
+          </a:xfrm>
+          <a:prstGeom prst="rect">
+            <a:avLst/>
+          </a:prstGeom>
+          <a:solidFill>
+            <a:srgbClr val="222222"/>
+          </a:solidFill>
+          <a:ln>
+            <a:noFill/>
+          </a:ln>
+        </p:spPr>
+        <p:style>
+          <a:lnRef idx="1">
+            <a:schemeClr val="accent1"/>
+          </a:lnRef>
+          <a:fillRef idx="3">
+            <a:schemeClr val="accent1"/>
+          </a:fillRef>
+          <a:effectRef idx="2">
+            <a:schemeClr val="accent1"/>
+          </a:effectRef>
+          <a:fontRef idx="minor">
+            <a:schemeClr val="lt1"/>
+          </a:fontRef>
+        </p:style>
+        <p:txBody>
+          <a:bodyPr rtlCol="0" anchor="ctr" wrap="square" lIns="50800" rIns="50800" tIns="25400" bIns="25400"/>
+          <a:lstStyle/>
+          <a:p>
+            <a:pPr algn="ctr"/>
+            <a:r>
+              <a:rPr sz="1200" b="1">
+                <a:solidFill>
+                  <a:srgbClr val="FFFFFF"/>
+                </a:solidFill>
+                <a:latin typeface="Meiryo"/>
+              </a:rPr>
+              <a:t>セリフ</a:t>
+            </a:r>
+          </a:p>
+        </p:txBody>
+      </p:sp>
+      <p:sp>
+        <p:nvSpPr>
+          <p:cNvPr id="5" name="Rectangle 4"/>
+          <p:cNvSpPr/>
+          <p:nvPr/>
+        </p:nvSpPr>
+        <p:spPr>
+          <a:xfrm>
+            <a:off x="5486400" y="1371600"/>
+            <a:ext cx="1828800" cy="594360"/>
+          </a:xfrm>
+          <a:prstGeom prst="rect">
+            <a:avLst/>
+          </a:prstGeom>
+          <a:solidFill>
+            <a:srgbClr val="222222"/>
+          </a:solidFill>
+          <a:ln>
+            <a:noFill/>
+          </a:ln>
+        </p:spPr>
+        <p:style>
+          <a:lnRef idx="1">
+            <a:schemeClr val="accent1"/>
+          </a:lnRef>
+          <a:fillRef idx="3">
+            <a:schemeClr val="accent1"/>
+          </a:fillRef>
+          <a:effectRef idx="2">
+            <a:schemeClr val="accent1"/>
+          </a:effectRef>
+          <a:fontRef idx="minor">
+            <a:schemeClr val="lt1"/>
+          </a:fontRef>
+        </p:style>
+        <p:txBody>
+          <a:bodyPr rtlCol="0" anchor="ctr" wrap="square" lIns="50800" rIns="50800" tIns="25400" bIns="25400"/>
+          <a:lstStyle/>
+          <a:p>
+            <a:pPr algn="ctr"/>
+            <a:r>
+              <a:rPr sz="1200" b="1">
+                <a:solidFill>
+                  <a:srgbClr val="FFFFFF"/>
+                </a:solidFill>
+                <a:latin typeface="Meiryo"/>
+              </a:rPr>
+              <a:t>狙い</a:t>
+            </a:r>
+          </a:p>
+        </p:txBody>
+      </p:sp>
+      <p:sp>
+        <p:nvSpPr>
+          <p:cNvPr id="6" name="Rectangle 5"/>
+          <p:cNvSpPr/>
+          <p:nvPr/>
+        </p:nvSpPr>
+        <p:spPr>
+          <a:xfrm>
+            <a:off x="7315200" y="1371600"/>
+            <a:ext cx="6400800" cy="594360"/>
+          </a:xfrm>
+          <a:prstGeom prst="rect">
+            <a:avLst/>
+          </a:prstGeom>
+          <a:solidFill>
+            <a:srgbClr val="222222"/>
+          </a:solidFill>
+          <a:ln>
+            <a:noFill/>
+          </a:ln>
+        </p:spPr>
+        <p:style>
+          <a:lnRef idx="1">
+            <a:schemeClr val="accent1"/>
+          </a:lnRef>
+          <a:fillRef idx="3">
+            <a:schemeClr val="accent1"/>
+          </a:fillRef>
+          <a:effectRef idx="2">
+            <a:schemeClr val="accent1"/>
+          </a:effectRef>
+          <a:fontRef idx="minor">
+            <a:schemeClr val="lt1"/>
+          </a:fontRef>
+        </p:style>
+        <p:txBody>
+          <a:bodyPr rtlCol="0" anchor="ctr" wrap="square" lIns="50800" rIns="50800" tIns="25400" bIns="25400"/>
+          <a:lstStyle/>
+          <a:p>
+            <a:pPr algn="ctr"/>
+            <a:r>
+              <a:rPr sz="1200" b="1">
+                <a:solidFill>
+                  <a:srgbClr val="FFFFFF"/>
+                </a:solidFill>
+                <a:latin typeface="Meiryo"/>
+              </a:rPr>
+              <a:t>効果</a:t>
+            </a:r>
+          </a:p>
+        </p:txBody>
+      </p:sp>
+      <p:sp>
+        <p:nvSpPr>
+          <p:cNvPr id="7" name="Rectangle 6"/>
+          <p:cNvSpPr/>
+          <p:nvPr/>
+        </p:nvSpPr>
+        <p:spPr>
+          <a:xfrm>
+            <a:off x="1371600" y="1965960"/>
+            <a:ext cx="4114800" cy="594360"/>
+          </a:xfrm>
+          <a:prstGeom prst="rect">
+            <a:avLst/>
+          </a:prstGeom>
+          <a:solidFill>
+            <a:srgbClr val="FFFFFF"/>
+          </a:solidFill>
+          <a:ln w="25400">
+            <a:solidFill>
+              <a:srgbClr val="CCCCCC"/>
+            </a:solidFill>
+          </a:ln>
+        </p:spPr>
+        <p:style>
+          <a:lnRef idx="1">
+            <a:schemeClr val="accent1"/>
+          </a:lnRef>
+          <a:fillRef idx="3">
+            <a:schemeClr val="accent1"/>
+          </a:fillRef>
+          <a:effectRef idx="2">
+            <a:schemeClr val="accent1"/>
+          </a:effectRef>
+          <a:fontRef idx="minor">
+            <a:schemeClr val="lt1"/>
+          </a:fontRef>
+        </p:style>
+        <p:txBody>
+          <a:bodyPr rtlCol="0" anchor="ctr" wrap="square" lIns="63500" rIns="50800" tIns="38100" bIns="38100"/>
+          <a:lstStyle/>
+          <a:p>
+            <a:pPr algn="l"/>
+            <a:r>
+              <a:rPr sz="1000" b="0">
+                <a:solidFill>
+                  <a:srgbClr val="222222"/>
+                </a:solidFill>
+                <a:latin typeface="Meiryo"/>
+              </a:rPr>
+              <a:t>「パソコン環境の更新が必要」</a:t>
+            </a:r>
+          </a:p>
+        </p:txBody>
+      </p:sp>
+      <p:sp>
+        <p:nvSpPr>
+          <p:cNvPr id="8" name="Rectangle 7"/>
+          <p:cNvSpPr/>
+          <p:nvPr/>
+        </p:nvSpPr>
+        <p:spPr>
+          <a:xfrm>
+            <a:off x="5486400" y="1965960"/>
+            <a:ext cx="1828800" cy="594360"/>
+          </a:xfrm>
+          <a:prstGeom prst="rect">
+            <a:avLst/>
+          </a:prstGeom>
+          <a:solidFill>
+            <a:srgbClr val="2980B9"/>
+          </a:solidFill>
+          <a:ln>
+            <a:noFill/>
+          </a:ln>
+        </p:spPr>
+        <p:style>
+          <a:lnRef idx="1">
+            <a:schemeClr val="accent1"/>
+          </a:lnRef>
+          <a:fillRef idx="3">
+            <a:schemeClr val="accent1"/>
+          </a:fillRef>
+          <a:effectRef idx="2">
+            <a:schemeClr val="accent1"/>
+          </a:effectRef>
+          <a:fontRef idx="minor">
+            <a:schemeClr val="lt1"/>
+          </a:fontRef>
+        </p:style>
+        <p:txBody>
+          <a:bodyPr rtlCol="0" anchor="ctr" wrap="square" lIns="50800" rIns="50800" tIns="25400" bIns="25400"/>
+          <a:lstStyle/>
+          <a:p>
+            <a:pPr algn="ctr"/>
+            <a:r>
+              <a:rPr sz="1200" b="1">
+                <a:solidFill>
+                  <a:srgbClr val="FFFFFF"/>
+                </a:solidFill>
+                <a:latin typeface="Meiryo"/>
+              </a:rPr>
+              <a:t>伏線</a:t>
+            </a:r>
+          </a:p>
+        </p:txBody>
+      </p:sp>
+      <p:sp>
+        <p:nvSpPr>
+          <p:cNvPr id="9" name="Rectangle 8"/>
+          <p:cNvSpPr/>
+          <p:nvPr/>
+        </p:nvSpPr>
+        <p:spPr>
+          <a:xfrm>
+            <a:off x="7315200" y="1965960"/>
+            <a:ext cx="6400800" cy="594360"/>
+          </a:xfrm>
+          <a:prstGeom prst="rect">
+            <a:avLst/>
+          </a:prstGeom>
+          <a:solidFill>
+            <a:srgbClr val="FFFFFF"/>
+          </a:solidFill>
+          <a:ln w="25400">
+            <a:solidFill>
+              <a:srgbClr val="CCCCCC"/>
+            </a:solidFill>
+          </a:ln>
+        </p:spPr>
+        <p:style>
+          <a:lnRef idx="1">
+            <a:schemeClr val="accent1"/>
+          </a:lnRef>
+          <a:fillRef idx="3">
+            <a:schemeClr val="accent1"/>
+          </a:fillRef>
+          <a:effectRef idx="2">
+            <a:schemeClr val="accent1"/>
+          </a:effectRef>
+          <a:fontRef idx="minor">
+            <a:schemeClr val="lt1"/>
+          </a:fontRef>
+        </p:style>
+        <p:txBody>
+          <a:bodyPr rtlCol="0" anchor="ctr" wrap="square" lIns="63500" rIns="50800" tIns="38100" bIns="38100"/>
+          <a:lstStyle/>
+          <a:p>
+            <a:pPr algn="l"/>
+            <a:r>
+              <a:rPr sz="1000" b="0">
+                <a:solidFill>
+                  <a:srgbClr val="222222"/>
+                </a:solidFill>
+                <a:latin typeface="Meiryo"/>
+              </a:rPr>
+              <a:t>後のソフトインストール（手順⑤⑥）を自然に受け入れさせる</a:t>
+            </a:r>
+          </a:p>
+        </p:txBody>
+      </p:sp>
+      <p:sp>
+        <p:nvSpPr>
+          <p:cNvPr id="10" name="Rectangle 9"/>
+          <p:cNvSpPr/>
+          <p:nvPr/>
+        </p:nvSpPr>
+        <p:spPr>
+          <a:xfrm>
+            <a:off x="1371600" y="2560320"/>
+            <a:ext cx="4114800" cy="594360"/>
+          </a:xfrm>
+          <a:prstGeom prst="rect">
+            <a:avLst/>
+          </a:prstGeom>
+          <a:solidFill>
+            <a:srgbClr val="F9F9F9"/>
+          </a:solidFill>
+          <a:ln w="25400">
+            <a:solidFill>
+              <a:srgbClr val="CCCCCC"/>
+            </a:solidFill>
+          </a:ln>
+        </p:spPr>
+        <p:style>
+          <a:lnRef idx="1">
+            <a:schemeClr val="accent1"/>
+          </a:lnRef>
+          <a:fillRef idx="3">
+            <a:schemeClr val="accent1"/>
+          </a:fillRef>
+          <a:effectRef idx="2">
+            <a:schemeClr val="accent1"/>
+          </a:effectRef>
+          <a:fontRef idx="minor">
+            <a:schemeClr val="lt1"/>
+          </a:fontRef>
+        </p:style>
+        <p:txBody>
+          <a:bodyPr rtlCol="0" anchor="ctr" wrap="square" lIns="63500" rIns="50800" tIns="38100" bIns="38100"/>
+          <a:lstStyle/>
+          <a:p>
+            <a:pPr algn="l"/>
+            <a:r>
+              <a:rPr sz="1000" b="0">
+                <a:solidFill>
+                  <a:srgbClr val="222222"/>
+                </a:solidFill>
+                <a:latin typeface="Meiryo"/>
+              </a:rPr>
+              <a:t>「口座の利用制限をしています」</a:t>
+            </a:r>
+          </a:p>
+        </p:txBody>
+      </p:sp>
+      <p:sp>
+        <p:nvSpPr>
+          <p:cNvPr id="11" name="Rectangle 10"/>
+          <p:cNvSpPr/>
+          <p:nvPr/>
+        </p:nvSpPr>
+        <p:spPr>
+          <a:xfrm>
+            <a:off x="5486400" y="2560320"/>
+            <a:ext cx="1828800" cy="594360"/>
+          </a:xfrm>
+          <a:prstGeom prst="rect">
+            <a:avLst/>
+          </a:prstGeom>
+          <a:solidFill>
+            <a:srgbClr val="C0392B"/>
+          </a:solidFill>
+          <a:ln>
+            <a:noFill/>
+          </a:ln>
+        </p:spPr>
+        <p:style>
+          <a:lnRef idx="1">
+            <a:schemeClr val="accent1"/>
+          </a:lnRef>
+          <a:fillRef idx="3">
+            <a:schemeClr val="accent1"/>
+          </a:fillRef>
+          <a:effectRef idx="2">
+            <a:schemeClr val="accent1"/>
+          </a:effectRef>
+          <a:fontRef idx="minor">
+            <a:schemeClr val="lt1"/>
+          </a:fontRef>
+        </p:style>
+        <p:txBody>
+          <a:bodyPr rtlCol="0" anchor="ctr" wrap="square" lIns="50800" rIns="50800" tIns="25400" bIns="25400"/>
+          <a:lstStyle/>
+          <a:p>
+            <a:pPr algn="ctr"/>
+            <a:r>
+              <a:rPr sz="1200" b="1">
+                <a:solidFill>
+                  <a:srgbClr val="FFFFFF"/>
+                </a:solidFill>
+                <a:latin typeface="Meiryo"/>
+              </a:rPr>
+              <a:t>恐怖</a:t>
+            </a:r>
+          </a:p>
+        </p:txBody>
+      </p:sp>
+      <p:sp>
+        <p:nvSpPr>
+          <p:cNvPr id="12" name="Rectangle 11"/>
+          <p:cNvSpPr/>
+          <p:nvPr/>
+        </p:nvSpPr>
+        <p:spPr>
+          <a:xfrm>
+            <a:off x="7315200" y="2560320"/>
+            <a:ext cx="6400800" cy="594360"/>
+          </a:xfrm>
+          <a:prstGeom prst="rect">
+            <a:avLst/>
+          </a:prstGeom>
+          <a:solidFill>
+            <a:srgbClr val="F9F9F9"/>
+          </a:solidFill>
+          <a:ln w="25400">
+            <a:solidFill>
+              <a:srgbClr val="CCCCCC"/>
+            </a:solidFill>
+          </a:ln>
+        </p:spPr>
+        <p:style>
+          <a:lnRef idx="1">
+            <a:schemeClr val="accent1"/>
+          </a:lnRef>
+          <a:fillRef idx="3">
+            <a:schemeClr val="accent1"/>
+          </a:fillRef>
+          <a:effectRef idx="2">
+            <a:schemeClr val="accent1"/>
+          </a:effectRef>
+          <a:fontRef idx="minor">
+            <a:schemeClr val="lt1"/>
+          </a:fontRef>
+        </p:style>
+        <p:txBody>
+          <a:bodyPr rtlCol="0" anchor="ctr" wrap="square" lIns="63500" rIns="50800" tIns="38100" bIns="38100"/>
+          <a:lstStyle/>
+          <a:p>
+            <a:pPr algn="l"/>
+            <a:r>
+              <a:rPr sz="1000" b="0">
+                <a:solidFill>
+                  <a:srgbClr val="222222"/>
+                </a:solidFill>
+                <a:latin typeface="Meiryo"/>
+              </a:rPr>
+              <a:t>「今すぐ対応しなきゃ」と焦らせ、冷静な判断を奪う</a:t>
+            </a:r>
+          </a:p>
+        </p:txBody>
+      </p:sp>
+      <p:sp>
+        <p:nvSpPr>
+          <p:cNvPr id="13" name="Rectangle 12"/>
+          <p:cNvSpPr/>
+          <p:nvPr/>
+        </p:nvSpPr>
+        <p:spPr>
+          <a:xfrm>
+            <a:off x="1371600" y="3154680"/>
+            <a:ext cx="4114800" cy="594360"/>
+          </a:xfrm>
+          <a:prstGeom prst="rect">
+            <a:avLst/>
+          </a:prstGeom>
+          <a:solidFill>
+            <a:srgbClr val="FFFFFF"/>
+          </a:solidFill>
+          <a:ln w="25400">
+            <a:solidFill>
+              <a:srgbClr val="CCCCCC"/>
+            </a:solidFill>
+          </a:ln>
+        </p:spPr>
+        <p:style>
+          <a:lnRef idx="1">
+            <a:schemeClr val="accent1"/>
+          </a:lnRef>
+          <a:fillRef idx="3">
+            <a:schemeClr val="accent1"/>
+          </a:fillRef>
+          <a:effectRef idx="2">
+            <a:schemeClr val="accent1"/>
+          </a:effectRef>
+          <a:fontRef idx="minor">
+            <a:schemeClr val="lt1"/>
+          </a:fontRef>
+        </p:style>
+        <p:txBody>
+          <a:bodyPr rtlCol="0" anchor="ctr" wrap="square" lIns="63500" rIns="50800" tIns="38100" bIns="38100"/>
+          <a:lstStyle/>
+          <a:p>
+            <a:pPr algn="l"/>
+            <a:r>
+              <a:rPr sz="1000" b="0">
+                <a:solidFill>
+                  <a:srgbClr val="222222"/>
+                </a:solidFill>
+                <a:latin typeface="Meiryo"/>
+              </a:rPr>
+              <a:t>「手続きを郵送しましたが、届いてますか」</a:t>
+            </a:r>
+          </a:p>
+        </p:txBody>
+      </p:sp>
+      <p:sp>
+        <p:nvSpPr>
+          <p:cNvPr id="14" name="Rectangle 13"/>
+          <p:cNvSpPr/>
+          <p:nvPr/>
+        </p:nvSpPr>
+        <p:spPr>
+          <a:xfrm>
+            <a:off x="5486400" y="3154680"/>
+            <a:ext cx="1828800" cy="594360"/>
+          </a:xfrm>
+          <a:prstGeom prst="rect">
+            <a:avLst/>
+          </a:prstGeom>
+          <a:solidFill>
+            <a:srgbClr val="E67E22"/>
+          </a:solidFill>
+          <a:ln>
+            <a:noFill/>
+          </a:ln>
+        </p:spPr>
+        <p:style>
+          <a:lnRef idx="1">
+            <a:schemeClr val="accent1"/>
+          </a:lnRef>
+          <a:fillRef idx="3">
+            <a:schemeClr val="accent1"/>
+          </a:fillRef>
+          <a:effectRef idx="2">
+            <a:schemeClr val="accent1"/>
+          </a:effectRef>
+          <a:fontRef idx="minor">
+            <a:schemeClr val="lt1"/>
+          </a:fontRef>
+        </p:style>
+        <p:txBody>
+          <a:bodyPr rtlCol="0" anchor="ctr" wrap="square" lIns="50800" rIns="50800" tIns="25400" bIns="25400"/>
+          <a:lstStyle/>
+          <a:p>
+            <a:pPr algn="ctr"/>
+            <a:r>
+              <a:rPr sz="1200" b="1">
+                <a:solidFill>
+                  <a:srgbClr val="FFFFFF"/>
+                </a:solidFill>
+                <a:latin typeface="Meiryo"/>
+              </a:rPr>
+              <a:t>負い目</a:t>
+            </a:r>
+          </a:p>
+        </p:txBody>
+      </p:sp>
+      <p:sp>
+        <p:nvSpPr>
+          <p:cNvPr id="15" name="Rectangle 14"/>
+          <p:cNvSpPr/>
+          <p:nvPr/>
+        </p:nvSpPr>
+        <p:spPr>
+          <a:xfrm>
+            <a:off x="7315200" y="3154680"/>
+            <a:ext cx="6400800" cy="594360"/>
+          </a:xfrm>
+          <a:prstGeom prst="rect">
+            <a:avLst/>
+          </a:prstGeom>
+          <a:solidFill>
+            <a:srgbClr val="FFFFFF"/>
+          </a:solidFill>
+          <a:ln w="25400">
+            <a:solidFill>
+              <a:srgbClr val="CCCCCC"/>
+            </a:solidFill>
+          </a:ln>
+        </p:spPr>
+        <p:style>
+          <a:lnRef idx="1">
+            <a:schemeClr val="accent1"/>
+          </a:lnRef>
+          <a:fillRef idx="3">
+            <a:schemeClr val="accent1"/>
+          </a:fillRef>
+          <a:effectRef idx="2">
+            <a:schemeClr val="accent1"/>
+          </a:effectRef>
+          <a:fontRef idx="minor">
+            <a:schemeClr val="lt1"/>
+          </a:fontRef>
+        </p:style>
+        <p:txBody>
+          <a:bodyPr rtlCol="0" anchor="ctr" wrap="square" lIns="63500" rIns="50800" tIns="38100" bIns="38100"/>
+          <a:lstStyle/>
+          <a:p>
+            <a:pPr algn="l"/>
+            <a:r>
+              <a:rPr sz="1000" b="0">
+                <a:solidFill>
+                  <a:srgbClr val="222222"/>
+                </a:solidFill>
+                <a:latin typeface="Meiryo"/>
+              </a:rPr>
+              <a:t>被害者に「自分が見落とした」と思わせ、指示に従いやすくする</a:t>
+            </a:r>
+          </a:p>
+        </p:txBody>
+      </p:sp>
+      <p:sp>
+        <p:nvSpPr>
+          <p:cNvPr id="16" name="Rectangle 15"/>
+          <p:cNvSpPr/>
+          <p:nvPr/>
+        </p:nvSpPr>
+        <p:spPr>
+          <a:xfrm>
+            <a:off x="1371600" y="3749039"/>
+            <a:ext cx="4114800" cy="594360"/>
+          </a:xfrm>
+          <a:prstGeom prst="rect">
+            <a:avLst/>
+          </a:prstGeom>
+          <a:solidFill>
+            <a:srgbClr val="F9F9F9"/>
+          </a:solidFill>
+          <a:ln w="25400">
+            <a:solidFill>
+              <a:srgbClr val="CCCCCC"/>
+            </a:solidFill>
+          </a:ln>
+        </p:spPr>
+        <p:style>
+          <a:lnRef idx="1">
+            <a:schemeClr val="accent1"/>
+          </a:lnRef>
+          <a:fillRef idx="3">
+            <a:schemeClr val="accent1"/>
+          </a:fillRef>
+          <a:effectRef idx="2">
+            <a:schemeClr val="accent1"/>
+          </a:effectRef>
+          <a:fontRef idx="minor">
+            <a:schemeClr val="lt1"/>
+          </a:fontRef>
+        </p:style>
+        <p:txBody>
+          <a:bodyPr rtlCol="0" anchor="ctr" wrap="square" lIns="63500" rIns="50800" tIns="38100" bIns="38100"/>
+          <a:lstStyle/>
+          <a:p>
+            <a:pPr algn="l"/>
+            <a:r>
+              <a:rPr sz="1000" b="0">
+                <a:solidFill>
+                  <a:srgbClr val="222222"/>
+                </a:solidFill>
+                <a:latin typeface="Meiryo"/>
+              </a:rPr>
+              <a:t>「更新されていないので電話しました」</a:t>
+            </a:r>
+          </a:p>
+        </p:txBody>
+      </p:sp>
+      <p:sp>
+        <p:nvSpPr>
+          <p:cNvPr id="17" name="Rectangle 16"/>
+          <p:cNvSpPr/>
+          <p:nvPr/>
+        </p:nvSpPr>
+        <p:spPr>
+          <a:xfrm>
+            <a:off x="5486400" y="3749039"/>
+            <a:ext cx="1828800" cy="594360"/>
+          </a:xfrm>
+          <a:prstGeom prst="rect">
+            <a:avLst/>
+          </a:prstGeom>
+          <a:solidFill>
+            <a:srgbClr val="8E44AD"/>
+          </a:solidFill>
+          <a:ln>
+            <a:noFill/>
+          </a:ln>
+        </p:spPr>
+        <p:style>
+          <a:lnRef idx="1">
+            <a:schemeClr val="accent1"/>
+          </a:lnRef>
+          <a:fillRef idx="3">
+            <a:schemeClr val="accent1"/>
+          </a:fillRef>
+          <a:effectRef idx="2">
+            <a:schemeClr val="accent1"/>
+          </a:effectRef>
+          <a:fontRef idx="minor">
+            <a:schemeClr val="lt1"/>
+          </a:fontRef>
+        </p:style>
+        <p:txBody>
+          <a:bodyPr rtlCol="0" anchor="ctr" wrap="square" lIns="50800" rIns="50800" tIns="25400" bIns="25400"/>
+          <a:lstStyle/>
+          <a:p>
+            <a:pPr algn="ctr"/>
+            <a:r>
+              <a:rPr sz="1200" b="1">
+                <a:solidFill>
+                  <a:srgbClr val="FFFFFF"/>
+                </a:solidFill>
+                <a:latin typeface="Meiryo"/>
+              </a:rPr>
+              <a:t>正当化</a:t>
+            </a:r>
+          </a:p>
+        </p:txBody>
+      </p:sp>
+      <p:sp>
+        <p:nvSpPr>
+          <p:cNvPr id="18" name="Rectangle 17"/>
+          <p:cNvSpPr/>
+          <p:nvPr/>
+        </p:nvSpPr>
+        <p:spPr>
+          <a:xfrm>
+            <a:off x="7315200" y="3749039"/>
+            <a:ext cx="6400800" cy="594360"/>
+          </a:xfrm>
+          <a:prstGeom prst="rect">
+            <a:avLst/>
+          </a:prstGeom>
+          <a:solidFill>
+            <a:srgbClr val="F9F9F9"/>
+          </a:solidFill>
+          <a:ln w="25400">
+            <a:solidFill>
+              <a:srgbClr val="CCCCCC"/>
+            </a:solidFill>
+          </a:ln>
+        </p:spPr>
+        <p:style>
+          <a:lnRef idx="1">
+            <a:schemeClr val="accent1"/>
+          </a:lnRef>
+          <a:fillRef idx="3">
+            <a:schemeClr val="accent1"/>
+          </a:fillRef>
+          <a:effectRef idx="2">
+            <a:schemeClr val="accent1"/>
+          </a:effectRef>
+          <a:fontRef idx="minor">
+            <a:schemeClr val="lt1"/>
+          </a:fontRef>
+        </p:style>
+        <p:txBody>
+          <a:bodyPr rtlCol="0" anchor="ctr" wrap="square" lIns="63500" rIns="50800" tIns="38100" bIns="38100"/>
+          <a:lstStyle/>
+          <a:p>
+            <a:pPr algn="l"/>
+            <a:r>
+              <a:rPr sz="1000" b="0">
+                <a:solidFill>
+                  <a:srgbClr val="222222"/>
+                </a:solidFill>
+                <a:latin typeface="Meiryo"/>
+              </a:rPr>
+              <a:t>架電がフォローアップに見え、銀行の丁寧な対応と錯覚させる</a:t>
+            </a:r>
+          </a:p>
+        </p:txBody>
+      </p:sp>
+      <p:sp>
+        <p:nvSpPr>
+          <p:cNvPr id="19" name="Rectangle 18"/>
+          <p:cNvSpPr/>
+          <p:nvPr/>
+        </p:nvSpPr>
+        <p:spPr>
+          <a:xfrm>
+            <a:off x="1371600" y="4617720"/>
+            <a:ext cx="12344400" cy="411480"/>
+          </a:xfrm>
+          <a:prstGeom prst="rect">
+            <a:avLst/>
+          </a:prstGeom>
+          <a:solidFill>
+            <a:srgbClr val="FFF3CD"/>
+          </a:solidFill>
+          <a:ln>
+            <a:noFill/>
+          </a:ln>
+        </p:spPr>
+        <p:style>
+          <a:lnRef idx="1">
+            <a:schemeClr val="accent1"/>
+          </a:lnRef>
+          <a:fillRef idx="3">
+            <a:schemeClr val="accent1"/>
+          </a:fillRef>
+          <a:effectRef idx="2">
+            <a:schemeClr val="accent1"/>
+          </a:effectRef>
+          <a:fontRef idx="minor">
+            <a:schemeClr val="lt1"/>
+          </a:fontRef>
+        </p:style>
+        <p:txBody>
+          <a:bodyPr rtlCol="0" anchor="ctr" wrap="square" lIns="50800" rIns="50800" tIns="25400" bIns="25400"/>
+          <a:lstStyle/>
+          <a:p>
+            <a:pPr algn="l"/>
+            <a:r>
+              <a:rPr sz="1300" b="1">
+                <a:solidFill>
+                  <a:srgbClr val="222222"/>
+                </a:solidFill>
+                <a:latin typeface="Meiryo"/>
+              </a:rPr>
+              <a:t>「届いてますか？」への回答パターン</a:t>
+            </a:r>
+          </a:p>
+        </p:txBody>
+      </p:sp>
+      <p:sp>
+        <p:nvSpPr>
+          <p:cNvPr id="20" name="Rectangle 19"/>
+          <p:cNvSpPr/>
+          <p:nvPr/>
+        </p:nvSpPr>
+        <p:spPr>
+          <a:xfrm>
+            <a:off x="1371600" y="5074920"/>
+            <a:ext cx="5943600" cy="457200"/>
+          </a:xfrm>
+          <a:prstGeom prst="rect">
+            <a:avLst/>
+          </a:prstGeom>
+          <a:solidFill>
+            <a:srgbClr val="FFFFFF"/>
+          </a:solidFill>
+          <a:ln w="25400">
+            <a:solidFill>
+              <a:srgbClr val="E67E22"/>
+            </a:solidFill>
+          </a:ln>
+        </p:spPr>
+        <p:style>
+          <a:lnRef idx="1">
+            <a:schemeClr val="accent1"/>
+          </a:lnRef>
+          <a:fillRef idx="3">
+            <a:schemeClr val="accent1"/>
+          </a:fillRef>
+          <a:effectRef idx="2">
+            <a:schemeClr val="accent1"/>
+          </a:effectRef>
+          <a:fontRef idx="minor">
+            <a:schemeClr val="lt1"/>
+          </a:fontRef>
+        </p:style>
+        <p:txBody>
+          <a:bodyPr rtlCol="0" anchor="ctr" wrap="square" lIns="63500" rIns="50800" tIns="38100" bIns="38100"/>
+          <a:lstStyle/>
+          <a:p>
+            <a:pPr algn="l"/>
+            <a:r>
+              <a:rPr sz="1000" b="0">
+                <a:solidFill>
+                  <a:srgbClr val="222222"/>
+                </a:solidFill>
+                <a:latin typeface="Meiryo"/>
+              </a:rPr>
+              <a:t>「届いてない」（大多数）
+→「届いていないなら仕方ない、電話で手続きしましょう」</a:t>
+            </a:r>
+          </a:p>
+        </p:txBody>
+      </p:sp>
+      <p:sp>
+        <p:nvSpPr>
+          <p:cNvPr id="21" name="Rectangle 20"/>
+          <p:cNvSpPr/>
+          <p:nvPr/>
+        </p:nvSpPr>
+        <p:spPr>
+          <a:xfrm>
+            <a:off x="7406640" y="5074920"/>
+            <a:ext cx="1371600" cy="457200"/>
+          </a:xfrm>
+          <a:prstGeom prst="rect">
+            <a:avLst/>
+          </a:prstGeom>
+          <a:solidFill>
+            <a:srgbClr val="C0392B"/>
+          </a:solidFill>
+          <a:ln>
+            <a:noFill/>
+          </a:ln>
+        </p:spPr>
+        <p:style>
+          <a:lnRef idx="1">
+            <a:schemeClr val="accent1"/>
+          </a:lnRef>
+          <a:fillRef idx="3">
+            <a:schemeClr val="accent1"/>
+          </a:fillRef>
+          <a:effectRef idx="2">
+            <a:schemeClr val="accent1"/>
+          </a:effectRef>
+          <a:fontRef idx="minor">
+            <a:schemeClr val="lt1"/>
+          </a:fontRef>
+        </p:style>
+        <p:txBody>
+          <a:bodyPr rtlCol="0" anchor="ctr" wrap="square" lIns="50800" rIns="50800" tIns="25400" bIns="25400"/>
+          <a:lstStyle/>
+          <a:p>
+            <a:pPr algn="ctr"/>
+            <a:r>
+              <a:rPr sz="1000" b="1">
+                <a:solidFill>
+                  <a:srgbClr val="FFFFFF"/>
+                </a:solidFill>
+                <a:latin typeface="Meiryo"/>
+              </a:rPr>
+              <a:t>→ シナリオ続行</a:t>
+            </a:r>
+          </a:p>
+        </p:txBody>
+      </p:sp>
+      <p:sp>
+        <p:nvSpPr>
+          <p:cNvPr id="22" name="Rectangle 21"/>
+          <p:cNvSpPr/>
+          <p:nvPr/>
+        </p:nvSpPr>
+        <p:spPr>
+          <a:xfrm>
+            <a:off x="8961120" y="5074920"/>
+            <a:ext cx="3474720" cy="457200"/>
+          </a:xfrm>
+          <a:prstGeom prst="rect">
+            <a:avLst/>
+          </a:prstGeom>
+          <a:solidFill>
+            <a:srgbClr val="FFFFFF"/>
+          </a:solidFill>
+          <a:ln w="25400">
+            <a:solidFill>
+              <a:srgbClr val="E67E22"/>
+            </a:solidFill>
+          </a:ln>
+        </p:spPr>
+        <p:style>
+          <a:lnRef idx="1">
+            <a:schemeClr val="accent1"/>
+          </a:lnRef>
+          <a:fillRef idx="3">
+            <a:schemeClr val="accent1"/>
+          </a:fillRef>
+          <a:effectRef idx="2">
+            <a:schemeClr val="accent1"/>
+          </a:effectRef>
+          <a:fontRef idx="minor">
+            <a:schemeClr val="lt1"/>
+          </a:fontRef>
+        </p:style>
+        <p:txBody>
+          <a:bodyPr rtlCol="0" anchor="ctr" wrap="square" lIns="63500" rIns="50800" tIns="38100" bIns="38100"/>
+          <a:lstStyle/>
+          <a:p>
+            <a:pPr algn="l"/>
+            <a:r>
+              <a:rPr sz="1000" b="0">
+                <a:solidFill>
+                  <a:srgbClr val="222222"/>
+                </a:solidFill>
+                <a:latin typeface="Meiryo"/>
+              </a:rPr>
+              <a:t>「届いてる」（稀）
+→「では確認しながら進めましょう」</a:t>
+            </a:r>
+          </a:p>
+        </p:txBody>
+      </p:sp>
+      <p:sp>
+        <p:nvSpPr>
+          <p:cNvPr id="23" name="Rectangle 22"/>
+          <p:cNvSpPr/>
+          <p:nvPr/>
+        </p:nvSpPr>
+        <p:spPr>
+          <a:xfrm>
+            <a:off x="12527280" y="5074920"/>
+            <a:ext cx="1188720" cy="457200"/>
+          </a:xfrm>
+          <a:prstGeom prst="rect">
+            <a:avLst/>
+          </a:prstGeom>
+          <a:solidFill>
+            <a:srgbClr val="C0392B"/>
+          </a:solidFill>
+          <a:ln>
+            <a:noFill/>
+          </a:ln>
+        </p:spPr>
+        <p:style>
+          <a:lnRef idx="1">
+            <a:schemeClr val="accent1"/>
+          </a:lnRef>
+          <a:fillRef idx="3">
+            <a:schemeClr val="accent1"/>
+          </a:fillRef>
+          <a:effectRef idx="2">
+            <a:schemeClr val="accent1"/>
+          </a:effectRef>
+          <a:fontRef idx="minor">
+            <a:schemeClr val="lt1"/>
+          </a:fontRef>
+        </p:style>
+        <p:txBody>
+          <a:bodyPr rtlCol="0" anchor="ctr" wrap="square" lIns="50800" rIns="50800" tIns="25400" bIns="25400"/>
+          <a:lstStyle/>
+          <a:p>
+            <a:pPr algn="ctr"/>
+            <a:r>
+              <a:rPr sz="1000" b="1">
+                <a:solidFill>
+                  <a:srgbClr val="FFFFFF"/>
+                </a:solidFill>
+                <a:latin typeface="Meiryo"/>
+              </a:rPr>
+              <a:t>→ シナリオ続行</a:t>
+            </a:r>
+          </a:p>
+        </p:txBody>
+      </p:sp>
+      <p:sp>
+        <p:nvSpPr>
+          <p:cNvPr id="24" name="Rectangle 23"/>
+          <p:cNvSpPr/>
+          <p:nvPr/>
+        </p:nvSpPr>
+        <p:spPr>
+          <a:xfrm>
+            <a:off x="1371600" y="5715000"/>
+            <a:ext cx="12344400" cy="457200"/>
+          </a:xfrm>
+          <a:prstGeom prst="rect">
+            <a:avLst/>
+          </a:prstGeom>
+          <a:solidFill>
+            <a:srgbClr val="C0392B"/>
+          </a:solidFill>
+          <a:ln>
+            <a:noFill/>
+          </a:ln>
+        </p:spPr>
+        <p:style>
+          <a:lnRef idx="1">
+            <a:schemeClr val="accent1"/>
+          </a:lnRef>
+          <a:fillRef idx="3">
+            <a:schemeClr val="accent1"/>
+          </a:fillRef>
+          <a:effectRef idx="2">
+            <a:schemeClr val="accent1"/>
+          </a:effectRef>
+          <a:fontRef idx="minor">
+            <a:schemeClr val="lt1"/>
+          </a:fontRef>
+        </p:style>
+        <p:txBody>
+          <a:bodyPr rtlCol="0" anchor="ctr" wrap="square" lIns="50800" rIns="50800" tIns="25400" bIns="25400"/>
+          <a:lstStyle/>
+          <a:p>
+            <a:pPr algn="ctr"/>
+            <a:r>
+              <a:rPr sz="1500" b="1">
+                <a:solidFill>
+                  <a:srgbClr val="FFFFFF"/>
+                </a:solidFill>
+                <a:latin typeface="Meiryo"/>
+              </a:rPr>
+              <a:t>どう答えても犯人のシナリオから逸脱できない — 顧客には見破れない</a:t>
+            </a:r>
+          </a:p>
+        </p:txBody>
+      </p:sp>
+      <p:sp>
+        <p:nvSpPr>
+          <p:cNvPr id="25" name="TextBox 24"/>
+          <p:cNvSpPr txBox="1"/>
+          <p:nvPr/>
+        </p:nvSpPr>
+        <p:spPr>
+          <a:xfrm>
+            <a:off x="1371600" y="6355079"/>
+            <a:ext cx="12344400" cy="548640"/>
+          </a:xfrm>
+          <a:prstGeom prst="rect">
+            <a:avLst/>
+          </a:prstGeom>
+          <a:noFill/>
+        </p:spPr>
+        <p:txBody>
+          <a:bodyPr wrap="square" lIns="50800" rIns="50800" tIns="38100" bIns="38100"/>
+          <a:lstStyle/>
+          <a:p>
+            <a:pPr algn="l"/>
+            <a:r>
+              <a:rPr sz="1200" b="0">
+                <a:solidFill>
+                  <a:srgbClr val="222222"/>
+                </a:solidFill>
+                <a:latin typeface="Meiryo"/>
+              </a:rPr>
+              <a:t>これも銀行が日常的に行う「書類を郵送しました → 届きましたか → 未対応なのでお電話」と同一パターンであり、顧客には見破れない</a:t>
+            </a:r>
+          </a:p>
+        </p:txBody>
+      </p:sp>
+      <p:sp>
+        <p:nvSpPr>
+          <p:cNvPr id="26" name="TextBox 25"/>
+          <p:cNvSpPr txBox="1"/>
+          <p:nvPr/>
+        </p:nvSpPr>
+        <p:spPr>
+          <a:xfrm>
+            <a:off x="9144000" y="10378440"/>
+            <a:ext cx="5943600" cy="228600"/>
+          </a:xfrm>
+          <a:prstGeom prst="rect">
+            <a:avLst/>
+          </a:prstGeom>
+          <a:noFill/>
+        </p:spPr>
+        <p:txBody>
+          <a:bodyPr wrap="square" lIns="50800" rIns="50800" tIns="38100" bIns="38100"/>
+          <a:lstStyle/>
+          <a:p>
+            <a:pPr algn="r"/>
+            <a:r>
+              <a:rPr sz="700" b="0">
+                <a:solidFill>
+                  <a:srgbClr val="888888"/>
+                </a:solidFill>
+                <a:latin typeface="Meiryo"/>
+              </a:rPr>
+              <a:t>Fraud Kill Chain — 手順②の心理操作テクニック</a:t>
             </a:r>
           </a:p>
         </p:txBody>

</xml_diff>

<commit_message>
Add slide 4: can customers detect this attack? (conclusion: no)
Full detection analysis per step shows only steps 5-6 offer a
slim chance, but victims are psychologically committed by then.
Concludes that only bank-side system controls can stop this.

https://claude.ai/code/session_01F7t8LKifK43o6sCdF2a3gQ
</commit_message>
<xml_diff>
--- a/Fraud_Kill_Chain.pptx
+++ b/Fraud_Kill_Chain.pptx
@@ -8,6 +8,7 @@
     <p:sldId id="256" r:id="rId7"/>
     <p:sldId id="257" r:id="rId8"/>
     <p:sldId id="258" r:id="rId9"/>
+    <p:sldId id="259" r:id="rId10"/>
   </p:sldIdLst>
   <p:sldSz cx="15124176" cy="10689336" type="screen4x3"/>
   <p:notesSz cx="6858000" cy="9144000"/>
@@ -9791,6 +9792,2322 @@
                 <a:latin typeface="Meiryo"/>
               </a:rPr>
               <a:t>Fraud Kill Chain — 手順②の心理操作テクニック</a:t>
+            </a:r>
+          </a:p>
+        </p:txBody>
+      </p:sp>
+    </p:spTree>
+  </p:cSld>
+  <p:clrMapOvr>
+    <a:masterClrMapping/>
+  </p:clrMapOvr>
+</p:sld>
+</file>
+
+<file path=ppt/slides/slide4.xml><?xml version="1.0" encoding="utf-8"?>
+<p:sld xmlns:a="http://schemas.openxmlformats.org/drawingml/2006/main" xmlns:p="http://schemas.openxmlformats.org/presentationml/2006/main" xmlns:r="http://schemas.openxmlformats.org/officeDocument/2006/relationships">
+  <p:cSld>
+    <p:bg>
+      <p:bgPr>
+        <a:solidFill>
+          <a:srgbClr val="F5F5F5"/>
+        </a:solidFill>
+        <a:effectLst/>
+      </p:bgPr>
+    </p:bg>
+    <p:spTree>
+      <p:nvGrpSpPr>
+        <p:cNvPr id="1" name=""/>
+        <p:cNvGrpSpPr/>
+        <p:nvPr/>
+      </p:nvGrpSpPr>
+      <p:grpSpPr/>
+      <p:sp>
+        <p:nvSpPr>
+          <p:cNvPr id="2" name="TextBox 1"/>
+          <p:cNvSpPr txBox="1"/>
+          <p:nvPr/>
+        </p:nvSpPr>
+        <p:spPr>
+          <a:xfrm>
+            <a:off x="0" y="182880"/>
+            <a:ext cx="15124176" cy="548640"/>
+          </a:xfrm>
+          <a:prstGeom prst="rect">
+            <a:avLst/>
+          </a:prstGeom>
+          <a:noFill/>
+        </p:spPr>
+        <p:txBody>
+          <a:bodyPr wrap="square" lIns="50800" rIns="50800" tIns="38100" bIns="38100"/>
+          <a:lstStyle/>
+          <a:p>
+            <a:pPr algn="ctr"/>
+            <a:r>
+              <a:rPr sz="2400" b="1">
+                <a:solidFill>
+                  <a:srgbClr val="C0392B"/>
+                </a:solidFill>
+                <a:latin typeface="Meiryo"/>
+              </a:rPr>
+              <a:t>顧客はこの攻撃を見破れるか？</a:t>
+            </a:r>
+          </a:p>
+        </p:txBody>
+      </p:sp>
+      <p:sp>
+        <p:nvSpPr>
+          <p:cNvPr id="3" name="Rectangle 2"/>
+          <p:cNvSpPr/>
+          <p:nvPr/>
+        </p:nvSpPr>
+        <p:spPr>
+          <a:xfrm>
+            <a:off x="731520" y="914400"/>
+            <a:ext cx="914400" cy="457200"/>
+          </a:xfrm>
+          <a:prstGeom prst="rect">
+            <a:avLst/>
+          </a:prstGeom>
+          <a:solidFill>
+            <a:srgbClr val="222222"/>
+          </a:solidFill>
+          <a:ln>
+            <a:noFill/>
+          </a:ln>
+        </p:spPr>
+        <p:style>
+          <a:lnRef idx="1">
+            <a:schemeClr val="accent1"/>
+          </a:lnRef>
+          <a:fillRef idx="3">
+            <a:schemeClr val="accent1"/>
+          </a:fillRef>
+          <a:effectRef idx="2">
+            <a:schemeClr val="accent1"/>
+          </a:effectRef>
+          <a:fontRef idx="minor">
+            <a:schemeClr val="lt1"/>
+          </a:fontRef>
+        </p:style>
+        <p:txBody>
+          <a:bodyPr rtlCol="0" anchor="ctr" wrap="square" lIns="50800" rIns="50800" tIns="25400" bIns="25400"/>
+          <a:lstStyle/>
+          <a:p>
+            <a:pPr algn="ctr"/>
+            <a:r>
+              <a:rPr sz="1000" b="1">
+                <a:solidFill>
+                  <a:srgbClr val="FFFFFF"/>
+                </a:solidFill>
+                <a:latin typeface="Meiryo"/>
+              </a:rPr>
+              <a:t>手順</a:t>
+            </a:r>
+          </a:p>
+        </p:txBody>
+      </p:sp>
+      <p:sp>
+        <p:nvSpPr>
+          <p:cNvPr id="4" name="Rectangle 3"/>
+          <p:cNvSpPr/>
+          <p:nvPr/>
+        </p:nvSpPr>
+        <p:spPr>
+          <a:xfrm>
+            <a:off x="1645920" y="914400"/>
+            <a:ext cx="3474720" cy="457200"/>
+          </a:xfrm>
+          <a:prstGeom prst="rect">
+            <a:avLst/>
+          </a:prstGeom>
+          <a:solidFill>
+            <a:srgbClr val="222222"/>
+          </a:solidFill>
+          <a:ln>
+            <a:noFill/>
+          </a:ln>
+        </p:spPr>
+        <p:style>
+          <a:lnRef idx="1">
+            <a:schemeClr val="accent1"/>
+          </a:lnRef>
+          <a:fillRef idx="3">
+            <a:schemeClr val="accent1"/>
+          </a:fillRef>
+          <a:effectRef idx="2">
+            <a:schemeClr val="accent1"/>
+          </a:effectRef>
+          <a:fontRef idx="minor">
+            <a:schemeClr val="lt1"/>
+          </a:fontRef>
+        </p:style>
+        <p:txBody>
+          <a:bodyPr rtlCol="0" anchor="ctr" wrap="square" lIns="50800" rIns="50800" tIns="25400" bIns="25400"/>
+          <a:lstStyle/>
+          <a:p>
+            <a:pPr algn="ctr"/>
+            <a:r>
+              <a:rPr sz="1000" b="1">
+                <a:solidFill>
+                  <a:srgbClr val="FFFFFF"/>
+                </a:solidFill>
+                <a:latin typeface="Meiryo"/>
+              </a:rPr>
+              <a:t>内容</a:t>
+            </a:r>
+          </a:p>
+        </p:txBody>
+      </p:sp>
+      <p:sp>
+        <p:nvSpPr>
+          <p:cNvPr id="5" name="Rectangle 4"/>
+          <p:cNvSpPr/>
+          <p:nvPr/>
+        </p:nvSpPr>
+        <p:spPr>
+          <a:xfrm>
+            <a:off x="5120640" y="914400"/>
+            <a:ext cx="1645920" cy="457200"/>
+          </a:xfrm>
+          <a:prstGeom prst="rect">
+            <a:avLst/>
+          </a:prstGeom>
+          <a:solidFill>
+            <a:srgbClr val="222222"/>
+          </a:solidFill>
+          <a:ln>
+            <a:noFill/>
+          </a:ln>
+        </p:spPr>
+        <p:style>
+          <a:lnRef idx="1">
+            <a:schemeClr val="accent1"/>
+          </a:lnRef>
+          <a:fillRef idx="3">
+            <a:schemeClr val="accent1"/>
+          </a:fillRef>
+          <a:effectRef idx="2">
+            <a:schemeClr val="accent1"/>
+          </a:effectRef>
+          <a:fontRef idx="minor">
+            <a:schemeClr val="lt1"/>
+          </a:fontRef>
+        </p:style>
+        <p:txBody>
+          <a:bodyPr rtlCol="0" anchor="ctr" wrap="square" lIns="50800" rIns="50800" tIns="25400" bIns="25400"/>
+          <a:lstStyle/>
+          <a:p>
+            <a:pPr algn="ctr"/>
+            <a:r>
+              <a:rPr sz="1000" b="1">
+                <a:solidFill>
+                  <a:srgbClr val="FFFFFF"/>
+                </a:solidFill>
+                <a:latin typeface="Meiryo"/>
+              </a:rPr>
+              <a:t>見破れるか</a:t>
+            </a:r>
+          </a:p>
+        </p:txBody>
+      </p:sp>
+      <p:sp>
+        <p:nvSpPr>
+          <p:cNvPr id="6" name="Rectangle 5"/>
+          <p:cNvSpPr/>
+          <p:nvPr/>
+        </p:nvSpPr>
+        <p:spPr>
+          <a:xfrm>
+            <a:off x="6766559" y="914400"/>
+            <a:ext cx="5943600" cy="457200"/>
+          </a:xfrm>
+          <a:prstGeom prst="rect">
+            <a:avLst/>
+          </a:prstGeom>
+          <a:solidFill>
+            <a:srgbClr val="222222"/>
+          </a:solidFill>
+          <a:ln>
+            <a:noFill/>
+          </a:ln>
+        </p:spPr>
+        <p:style>
+          <a:lnRef idx="1">
+            <a:schemeClr val="accent1"/>
+          </a:lnRef>
+          <a:fillRef idx="3">
+            <a:schemeClr val="accent1"/>
+          </a:fillRef>
+          <a:effectRef idx="2">
+            <a:schemeClr val="accent1"/>
+          </a:effectRef>
+          <a:fontRef idx="minor">
+            <a:schemeClr val="lt1"/>
+          </a:fontRef>
+        </p:style>
+        <p:txBody>
+          <a:bodyPr rtlCol="0" anchor="ctr" wrap="square" lIns="50800" rIns="50800" tIns="25400" bIns="25400"/>
+          <a:lstStyle/>
+          <a:p>
+            <a:pPr algn="ctr"/>
+            <a:r>
+              <a:rPr sz="1000" b="1">
+                <a:solidFill>
+                  <a:srgbClr val="FFFFFF"/>
+                </a:solidFill>
+                <a:latin typeface="Meiryo"/>
+              </a:rPr>
+              <a:t>理由</a:t>
+            </a:r>
+          </a:p>
+        </p:txBody>
+      </p:sp>
+      <p:sp>
+        <p:nvSpPr>
+          <p:cNvPr id="7" name="Rectangle 6"/>
+          <p:cNvSpPr/>
+          <p:nvPr/>
+        </p:nvSpPr>
+        <p:spPr>
+          <a:xfrm>
+            <a:off x="731520" y="1371600"/>
+            <a:ext cx="914400" cy="457200"/>
+          </a:xfrm>
+          <a:prstGeom prst="rect">
+            <a:avLst/>
+          </a:prstGeom>
+          <a:solidFill>
+            <a:srgbClr val="FFFFFF"/>
+          </a:solidFill>
+          <a:ln>
+            <a:noFill/>
+          </a:ln>
+        </p:spPr>
+        <p:style>
+          <a:lnRef idx="1">
+            <a:schemeClr val="accent1"/>
+          </a:lnRef>
+          <a:fillRef idx="3">
+            <a:schemeClr val="accent1"/>
+          </a:fillRef>
+          <a:effectRef idx="2">
+            <a:schemeClr val="accent1"/>
+          </a:effectRef>
+          <a:fontRef idx="minor">
+            <a:schemeClr val="lt1"/>
+          </a:fontRef>
+        </p:style>
+        <p:txBody>
+          <a:bodyPr rtlCol="0" anchor="ctr" wrap="square" lIns="50800" rIns="50800" tIns="25400" bIns="25400"/>
+          <a:lstStyle/>
+          <a:p>
+            <a:pPr algn="ctr"/>
+            <a:r>
+              <a:rPr sz="1100" b="1">
+                <a:solidFill>
+                  <a:srgbClr val="222222"/>
+                </a:solidFill>
+                <a:latin typeface="Meiryo"/>
+              </a:rPr>
+              <a:t>①</a:t>
+            </a:r>
+          </a:p>
+        </p:txBody>
+      </p:sp>
+      <p:sp>
+        <p:nvSpPr>
+          <p:cNvPr id="8" name="Rectangle 7"/>
+          <p:cNvSpPr/>
+          <p:nvPr/>
+        </p:nvSpPr>
+        <p:spPr>
+          <a:xfrm>
+            <a:off x="1645920" y="1371600"/>
+            <a:ext cx="3474720" cy="457200"/>
+          </a:xfrm>
+          <a:prstGeom prst="rect">
+            <a:avLst/>
+          </a:prstGeom>
+          <a:solidFill>
+            <a:srgbClr val="FFFFFF"/>
+          </a:solidFill>
+          <a:ln w="25400">
+            <a:solidFill>
+              <a:srgbClr val="DDDDDD"/>
+            </a:solidFill>
+          </a:ln>
+        </p:spPr>
+        <p:style>
+          <a:lnRef idx="1">
+            <a:schemeClr val="accent1"/>
+          </a:lnRef>
+          <a:fillRef idx="3">
+            <a:schemeClr val="accent1"/>
+          </a:fillRef>
+          <a:effectRef idx="2">
+            <a:schemeClr val="accent1"/>
+          </a:effectRef>
+          <a:fontRef idx="minor">
+            <a:schemeClr val="lt1"/>
+          </a:fontRef>
+        </p:style>
+        <p:txBody>
+          <a:bodyPr rtlCol="0" anchor="ctr" wrap="square" lIns="63500" rIns="50800" tIns="38100" bIns="38100"/>
+          <a:lstStyle/>
+          <a:p>
+            <a:pPr algn="l"/>
+            <a:r>
+              <a:rPr sz="900" b="0">
+                <a:solidFill>
+                  <a:srgbClr val="222222"/>
+                </a:solidFill>
+                <a:latin typeface="Meiryo"/>
+              </a:rPr>
+              <a:t>自動音声「1を押してください」</a:t>
+            </a:r>
+          </a:p>
+        </p:txBody>
+      </p:sp>
+      <p:sp>
+        <p:nvSpPr>
+          <p:cNvPr id="9" name="Rectangle 8"/>
+          <p:cNvSpPr/>
+          <p:nvPr/>
+        </p:nvSpPr>
+        <p:spPr>
+          <a:xfrm>
+            <a:off x="5120640" y="1371600"/>
+            <a:ext cx="1645920" cy="457200"/>
+          </a:xfrm>
+          <a:prstGeom prst="rect">
+            <a:avLst/>
+          </a:prstGeom>
+          <a:solidFill>
+            <a:srgbClr val="C0392B"/>
+          </a:solidFill>
+          <a:ln>
+            <a:noFill/>
+          </a:ln>
+        </p:spPr>
+        <p:style>
+          <a:lnRef idx="1">
+            <a:schemeClr val="accent1"/>
+          </a:lnRef>
+          <a:fillRef idx="3">
+            <a:schemeClr val="accent1"/>
+          </a:fillRef>
+          <a:effectRef idx="2">
+            <a:schemeClr val="accent1"/>
+          </a:effectRef>
+          <a:fontRef idx="minor">
+            <a:schemeClr val="lt1"/>
+          </a:fontRef>
+        </p:style>
+        <p:txBody>
+          <a:bodyPr rtlCol="0" anchor="ctr" wrap="square" lIns="50800" rIns="50800" tIns="25400" bIns="25400"/>
+          <a:lstStyle/>
+          <a:p>
+            <a:pPr algn="ctr"/>
+            <a:r>
+              <a:rPr sz="900" b="1">
+                <a:solidFill>
+                  <a:srgbClr val="FFFFFF"/>
+                </a:solidFill>
+                <a:latin typeface="Meiryo"/>
+              </a:rPr>
+              <a:t>不可能</a:t>
+            </a:r>
+          </a:p>
+        </p:txBody>
+      </p:sp>
+      <p:sp>
+        <p:nvSpPr>
+          <p:cNvPr id="10" name="Rectangle 9"/>
+          <p:cNvSpPr/>
+          <p:nvPr/>
+        </p:nvSpPr>
+        <p:spPr>
+          <a:xfrm>
+            <a:off x="6766559" y="1371600"/>
+            <a:ext cx="5943600" cy="457200"/>
+          </a:xfrm>
+          <a:prstGeom prst="rect">
+            <a:avLst/>
+          </a:prstGeom>
+          <a:solidFill>
+            <a:srgbClr val="FFFFFF"/>
+          </a:solidFill>
+          <a:ln w="25400">
+            <a:solidFill>
+              <a:srgbClr val="DDDDDD"/>
+            </a:solidFill>
+          </a:ln>
+        </p:spPr>
+        <p:style>
+          <a:lnRef idx="1">
+            <a:schemeClr val="accent1"/>
+          </a:lnRef>
+          <a:fillRef idx="3">
+            <a:schemeClr val="accent1"/>
+          </a:fillRef>
+          <a:effectRef idx="2">
+            <a:schemeClr val="accent1"/>
+          </a:effectRef>
+          <a:fontRef idx="minor">
+            <a:schemeClr val="lt1"/>
+          </a:fontRef>
+        </p:style>
+        <p:txBody>
+          <a:bodyPr rtlCol="0" anchor="ctr" wrap="square" lIns="63500" rIns="50800" tIns="38100" bIns="38100"/>
+          <a:lstStyle/>
+          <a:p>
+            <a:pPr algn="l"/>
+            <a:r>
+              <a:rPr sz="900" b="0">
+                <a:solidFill>
+                  <a:srgbClr val="222222"/>
+                </a:solidFill>
+                <a:latin typeface="Meiryo"/>
+              </a:rPr>
+              <a:t>銀行も同じことをする</a:t>
+            </a:r>
+          </a:p>
+        </p:txBody>
+      </p:sp>
+      <p:sp>
+        <p:nvSpPr>
+          <p:cNvPr id="11" name="Rectangle 10"/>
+          <p:cNvSpPr/>
+          <p:nvPr/>
+        </p:nvSpPr>
+        <p:spPr>
+          <a:xfrm>
+            <a:off x="731520" y="1828800"/>
+            <a:ext cx="914400" cy="457200"/>
+          </a:xfrm>
+          <a:prstGeom prst="rect">
+            <a:avLst/>
+          </a:prstGeom>
+          <a:solidFill>
+            <a:srgbClr val="F9F9F9"/>
+          </a:solidFill>
+          <a:ln>
+            <a:noFill/>
+          </a:ln>
+        </p:spPr>
+        <p:style>
+          <a:lnRef idx="1">
+            <a:schemeClr val="accent1"/>
+          </a:lnRef>
+          <a:fillRef idx="3">
+            <a:schemeClr val="accent1"/>
+          </a:fillRef>
+          <a:effectRef idx="2">
+            <a:schemeClr val="accent1"/>
+          </a:effectRef>
+          <a:fontRef idx="minor">
+            <a:schemeClr val="lt1"/>
+          </a:fontRef>
+        </p:style>
+        <p:txBody>
+          <a:bodyPr rtlCol="0" anchor="ctr" wrap="square" lIns="50800" rIns="50800" tIns="25400" bIns="25400"/>
+          <a:lstStyle/>
+          <a:p>
+            <a:pPr algn="ctr"/>
+            <a:r>
+              <a:rPr sz="1100" b="1">
+                <a:solidFill>
+                  <a:srgbClr val="222222"/>
+                </a:solidFill>
+                <a:latin typeface="Meiryo"/>
+              </a:rPr>
+              <a:t>②</a:t>
+            </a:r>
+          </a:p>
+        </p:txBody>
+      </p:sp>
+      <p:sp>
+        <p:nvSpPr>
+          <p:cNvPr id="12" name="Rectangle 11"/>
+          <p:cNvSpPr/>
+          <p:nvPr/>
+        </p:nvSpPr>
+        <p:spPr>
+          <a:xfrm>
+            <a:off x="1645920" y="1828800"/>
+            <a:ext cx="3474720" cy="457200"/>
+          </a:xfrm>
+          <a:prstGeom prst="rect">
+            <a:avLst/>
+          </a:prstGeom>
+          <a:solidFill>
+            <a:srgbClr val="F9F9F9"/>
+          </a:solidFill>
+          <a:ln w="25400">
+            <a:solidFill>
+              <a:srgbClr val="DDDDDD"/>
+            </a:solidFill>
+          </a:ln>
+        </p:spPr>
+        <p:style>
+          <a:lnRef idx="1">
+            <a:schemeClr val="accent1"/>
+          </a:lnRef>
+          <a:fillRef idx="3">
+            <a:schemeClr val="accent1"/>
+          </a:fillRef>
+          <a:effectRef idx="2">
+            <a:schemeClr val="accent1"/>
+          </a:effectRef>
+          <a:fontRef idx="minor">
+            <a:schemeClr val="lt1"/>
+          </a:fontRef>
+        </p:style>
+        <p:txBody>
+          <a:bodyPr rtlCol="0" anchor="ctr" wrap="square" lIns="63500" rIns="50800" tIns="38100" bIns="38100"/>
+          <a:lstStyle/>
+          <a:p>
+            <a:pPr algn="l"/>
+            <a:r>
+              <a:rPr sz="900" b="0">
+                <a:solidFill>
+                  <a:srgbClr val="222222"/>
+                </a:solidFill>
+                <a:latin typeface="Meiryo"/>
+              </a:rPr>
+              <a:t>「口座制限中、郵送したが届いてますか」</a:t>
+            </a:r>
+          </a:p>
+        </p:txBody>
+      </p:sp>
+      <p:sp>
+        <p:nvSpPr>
+          <p:cNvPr id="13" name="Rectangle 12"/>
+          <p:cNvSpPr/>
+          <p:nvPr/>
+        </p:nvSpPr>
+        <p:spPr>
+          <a:xfrm>
+            <a:off x="5120640" y="1828800"/>
+            <a:ext cx="1645920" cy="457200"/>
+          </a:xfrm>
+          <a:prstGeom prst="rect">
+            <a:avLst/>
+          </a:prstGeom>
+          <a:solidFill>
+            <a:srgbClr val="C0392B"/>
+          </a:solidFill>
+          <a:ln>
+            <a:noFill/>
+          </a:ln>
+        </p:spPr>
+        <p:style>
+          <a:lnRef idx="1">
+            <a:schemeClr val="accent1"/>
+          </a:lnRef>
+          <a:fillRef idx="3">
+            <a:schemeClr val="accent1"/>
+          </a:fillRef>
+          <a:effectRef idx="2">
+            <a:schemeClr val="accent1"/>
+          </a:effectRef>
+          <a:fontRef idx="minor">
+            <a:schemeClr val="lt1"/>
+          </a:fontRef>
+        </p:style>
+        <p:txBody>
+          <a:bodyPr rtlCol="0" anchor="ctr" wrap="square" lIns="50800" rIns="50800" tIns="25400" bIns="25400"/>
+          <a:lstStyle/>
+          <a:p>
+            <a:pPr algn="ctr"/>
+            <a:r>
+              <a:rPr sz="900" b="1">
+                <a:solidFill>
+                  <a:srgbClr val="FFFFFF"/>
+                </a:solidFill>
+                <a:latin typeface="Meiryo"/>
+              </a:rPr>
+              <a:t>不可能</a:t>
+            </a:r>
+          </a:p>
+        </p:txBody>
+      </p:sp>
+      <p:sp>
+        <p:nvSpPr>
+          <p:cNvPr id="14" name="Rectangle 13"/>
+          <p:cNvSpPr/>
+          <p:nvPr/>
+        </p:nvSpPr>
+        <p:spPr>
+          <a:xfrm>
+            <a:off x="6766559" y="1828800"/>
+            <a:ext cx="5943600" cy="457200"/>
+          </a:xfrm>
+          <a:prstGeom prst="rect">
+            <a:avLst/>
+          </a:prstGeom>
+          <a:solidFill>
+            <a:srgbClr val="F9F9F9"/>
+          </a:solidFill>
+          <a:ln w="25400">
+            <a:solidFill>
+              <a:srgbClr val="DDDDDD"/>
+            </a:solidFill>
+          </a:ln>
+        </p:spPr>
+        <p:style>
+          <a:lnRef idx="1">
+            <a:schemeClr val="accent1"/>
+          </a:lnRef>
+          <a:fillRef idx="3">
+            <a:schemeClr val="accent1"/>
+          </a:fillRef>
+          <a:effectRef idx="2">
+            <a:schemeClr val="accent1"/>
+          </a:effectRef>
+          <a:fontRef idx="minor">
+            <a:schemeClr val="lt1"/>
+          </a:fontRef>
+        </p:style>
+        <p:txBody>
+          <a:bodyPr rtlCol="0" anchor="ctr" wrap="square" lIns="63500" rIns="50800" tIns="38100" bIns="38100"/>
+          <a:lstStyle/>
+          <a:p>
+            <a:pPr algn="l"/>
+            <a:r>
+              <a:rPr sz="900" b="0">
+                <a:solidFill>
+                  <a:srgbClr val="222222"/>
+                </a:solidFill>
+                <a:latin typeface="Meiryo"/>
+              </a:rPr>
+              <a:t>銀行も同じことを言う</a:t>
+            </a:r>
+          </a:p>
+        </p:txBody>
+      </p:sp>
+      <p:sp>
+        <p:nvSpPr>
+          <p:cNvPr id="15" name="Rectangle 14"/>
+          <p:cNvSpPr/>
+          <p:nvPr/>
+        </p:nvSpPr>
+        <p:spPr>
+          <a:xfrm>
+            <a:off x="731520" y="2286000"/>
+            <a:ext cx="914400" cy="457200"/>
+          </a:xfrm>
+          <a:prstGeom prst="rect">
+            <a:avLst/>
+          </a:prstGeom>
+          <a:solidFill>
+            <a:srgbClr val="FFFFFF"/>
+          </a:solidFill>
+          <a:ln>
+            <a:noFill/>
+          </a:ln>
+        </p:spPr>
+        <p:style>
+          <a:lnRef idx="1">
+            <a:schemeClr val="accent1"/>
+          </a:lnRef>
+          <a:fillRef idx="3">
+            <a:schemeClr val="accent1"/>
+          </a:fillRef>
+          <a:effectRef idx="2">
+            <a:schemeClr val="accent1"/>
+          </a:effectRef>
+          <a:fontRef idx="minor">
+            <a:schemeClr val="lt1"/>
+          </a:fontRef>
+        </p:style>
+        <p:txBody>
+          <a:bodyPr rtlCol="0" anchor="ctr" wrap="square" lIns="50800" rIns="50800" tIns="25400" bIns="25400"/>
+          <a:lstStyle/>
+          <a:p>
+            <a:pPr algn="ctr"/>
+            <a:r>
+              <a:rPr sz="1100" b="1">
+                <a:solidFill>
+                  <a:srgbClr val="222222"/>
+                </a:solidFill>
+                <a:latin typeface="Meiryo"/>
+              </a:rPr>
+              <a:t>③</a:t>
+            </a:r>
+          </a:p>
+        </p:txBody>
+      </p:sp>
+      <p:sp>
+        <p:nvSpPr>
+          <p:cNvPr id="16" name="Rectangle 15"/>
+          <p:cNvSpPr/>
+          <p:nvPr/>
+        </p:nvSpPr>
+        <p:spPr>
+          <a:xfrm>
+            <a:off x="1645920" y="2286000"/>
+            <a:ext cx="3474720" cy="457200"/>
+          </a:xfrm>
+          <a:prstGeom prst="rect">
+            <a:avLst/>
+          </a:prstGeom>
+          <a:solidFill>
+            <a:srgbClr val="FFFFFF"/>
+          </a:solidFill>
+          <a:ln w="25400">
+            <a:solidFill>
+              <a:srgbClr val="DDDDDD"/>
+            </a:solidFill>
+          </a:ln>
+        </p:spPr>
+        <p:style>
+          <a:lnRef idx="1">
+            <a:schemeClr val="accent1"/>
+          </a:lnRef>
+          <a:fillRef idx="3">
+            <a:schemeClr val="accent1"/>
+          </a:fillRef>
+          <a:effectRef idx="2">
+            <a:schemeClr val="accent1"/>
+          </a:effectRef>
+          <a:fontRef idx="minor">
+            <a:schemeClr val="lt1"/>
+          </a:fontRef>
+        </p:style>
+        <p:txBody>
+          <a:bodyPr rtlCol="0" anchor="ctr" wrap="square" lIns="63500" rIns="50800" tIns="38100" bIns="38100"/>
+          <a:lstStyle/>
+          <a:p>
+            <a:pPr algn="l"/>
+            <a:r>
+              <a:rPr sz="900" b="0">
+                <a:solidFill>
+                  <a:srgbClr val="222222"/>
+                </a:solidFill>
+                <a:latin typeface="Meiryo"/>
+              </a:rPr>
+              <a:t>「メールで案内します」メアド聞き出し</a:t>
+            </a:r>
+          </a:p>
+        </p:txBody>
+      </p:sp>
+      <p:sp>
+        <p:nvSpPr>
+          <p:cNvPr id="17" name="Rectangle 16"/>
+          <p:cNvSpPr/>
+          <p:nvPr/>
+        </p:nvSpPr>
+        <p:spPr>
+          <a:xfrm>
+            <a:off x="5120640" y="2286000"/>
+            <a:ext cx="1645920" cy="457200"/>
+          </a:xfrm>
+          <a:prstGeom prst="rect">
+            <a:avLst/>
+          </a:prstGeom>
+          <a:solidFill>
+            <a:srgbClr val="C0392B"/>
+          </a:solidFill>
+          <a:ln>
+            <a:noFill/>
+          </a:ln>
+        </p:spPr>
+        <p:style>
+          <a:lnRef idx="1">
+            <a:schemeClr val="accent1"/>
+          </a:lnRef>
+          <a:fillRef idx="3">
+            <a:schemeClr val="accent1"/>
+          </a:fillRef>
+          <a:effectRef idx="2">
+            <a:schemeClr val="accent1"/>
+          </a:effectRef>
+          <a:fontRef idx="minor">
+            <a:schemeClr val="lt1"/>
+          </a:fontRef>
+        </p:style>
+        <p:txBody>
+          <a:bodyPr rtlCol="0" anchor="ctr" wrap="square" lIns="50800" rIns="50800" tIns="25400" bIns="25400"/>
+          <a:lstStyle/>
+          <a:p>
+            <a:pPr algn="ctr"/>
+            <a:r>
+              <a:rPr sz="900" b="1">
+                <a:solidFill>
+                  <a:srgbClr val="FFFFFF"/>
+                </a:solidFill>
+                <a:latin typeface="Meiryo"/>
+              </a:rPr>
+              <a:t>ほぼ不可能</a:t>
+            </a:r>
+          </a:p>
+        </p:txBody>
+      </p:sp>
+      <p:sp>
+        <p:nvSpPr>
+          <p:cNvPr id="18" name="Rectangle 17"/>
+          <p:cNvSpPr/>
+          <p:nvPr/>
+        </p:nvSpPr>
+        <p:spPr>
+          <a:xfrm>
+            <a:off x="6766559" y="2286000"/>
+            <a:ext cx="5943600" cy="457200"/>
+          </a:xfrm>
+          <a:prstGeom prst="rect">
+            <a:avLst/>
+          </a:prstGeom>
+          <a:solidFill>
+            <a:srgbClr val="FFFFFF"/>
+          </a:solidFill>
+          <a:ln w="25400">
+            <a:solidFill>
+              <a:srgbClr val="DDDDDD"/>
+            </a:solidFill>
+          </a:ln>
+        </p:spPr>
+        <p:style>
+          <a:lnRef idx="1">
+            <a:schemeClr val="accent1"/>
+          </a:lnRef>
+          <a:fillRef idx="3">
+            <a:schemeClr val="accent1"/>
+          </a:fillRef>
+          <a:effectRef idx="2">
+            <a:schemeClr val="accent1"/>
+          </a:effectRef>
+          <a:fontRef idx="minor">
+            <a:schemeClr val="lt1"/>
+          </a:fontRef>
+        </p:style>
+        <p:txBody>
+          <a:bodyPr rtlCol="0" anchor="ctr" wrap="square" lIns="63500" rIns="50800" tIns="38100" bIns="38100"/>
+          <a:lstStyle/>
+          <a:p>
+            <a:pPr algn="l"/>
+            <a:r>
+              <a:rPr sz="900" b="0">
+                <a:solidFill>
+                  <a:srgbClr val="222222"/>
+                </a:solidFill>
+                <a:latin typeface="Meiryo"/>
+              </a:rPr>
+              <a:t>銀行も確認することがある</a:t>
+            </a:r>
+          </a:p>
+        </p:txBody>
+      </p:sp>
+      <p:sp>
+        <p:nvSpPr>
+          <p:cNvPr id="19" name="Rectangle 18"/>
+          <p:cNvSpPr/>
+          <p:nvPr/>
+        </p:nvSpPr>
+        <p:spPr>
+          <a:xfrm>
+            <a:off x="731520" y="2743200"/>
+            <a:ext cx="914400" cy="457200"/>
+          </a:xfrm>
+          <a:prstGeom prst="rect">
+            <a:avLst/>
+          </a:prstGeom>
+          <a:solidFill>
+            <a:srgbClr val="F9F9F9"/>
+          </a:solidFill>
+          <a:ln>
+            <a:noFill/>
+          </a:ln>
+        </p:spPr>
+        <p:style>
+          <a:lnRef idx="1">
+            <a:schemeClr val="accent1"/>
+          </a:lnRef>
+          <a:fillRef idx="3">
+            <a:schemeClr val="accent1"/>
+          </a:fillRef>
+          <a:effectRef idx="2">
+            <a:schemeClr val="accent1"/>
+          </a:effectRef>
+          <a:fontRef idx="minor">
+            <a:schemeClr val="lt1"/>
+          </a:fontRef>
+        </p:style>
+        <p:txBody>
+          <a:bodyPr rtlCol="0" anchor="ctr" wrap="square" lIns="50800" rIns="50800" tIns="25400" bIns="25400"/>
+          <a:lstStyle/>
+          <a:p>
+            <a:pPr algn="ctr"/>
+            <a:r>
+              <a:rPr sz="1100" b="1">
+                <a:solidFill>
+                  <a:srgbClr val="222222"/>
+                </a:solidFill>
+                <a:latin typeface="Meiryo"/>
+              </a:rPr>
+              <a:t>④</a:t>
+            </a:r>
+          </a:p>
+        </p:txBody>
+      </p:sp>
+      <p:sp>
+        <p:nvSpPr>
+          <p:cNvPr id="20" name="Rectangle 19"/>
+          <p:cNvSpPr/>
+          <p:nvPr/>
+        </p:nvSpPr>
+        <p:spPr>
+          <a:xfrm>
+            <a:off x="1645920" y="2743200"/>
+            <a:ext cx="3474720" cy="457200"/>
+          </a:xfrm>
+          <a:prstGeom prst="rect">
+            <a:avLst/>
+          </a:prstGeom>
+          <a:solidFill>
+            <a:srgbClr val="F9F9F9"/>
+          </a:solidFill>
+          <a:ln w="25400">
+            <a:solidFill>
+              <a:srgbClr val="DDDDDD"/>
+            </a:solidFill>
+          </a:ln>
+        </p:spPr>
+        <p:style>
+          <a:lnRef idx="1">
+            <a:schemeClr val="accent1"/>
+          </a:lnRef>
+          <a:fillRef idx="3">
+            <a:schemeClr val="accent1"/>
+          </a:fillRef>
+          <a:effectRef idx="2">
+            <a:schemeClr val="accent1"/>
+          </a:effectRef>
+          <a:fontRef idx="minor">
+            <a:schemeClr val="lt1"/>
+          </a:fontRef>
+        </p:style>
+        <p:txBody>
+          <a:bodyPr rtlCol="0" anchor="ctr" wrap="square" lIns="63500" rIns="50800" tIns="38100" bIns="38100"/>
+          <a:lstStyle/>
+          <a:p>
+            <a:pPr algn="l"/>
+            <a:r>
+              <a:rPr sz="900" b="0">
+                <a:solidFill>
+                  <a:srgbClr val="222222"/>
+                </a:solidFill>
+                <a:latin typeface="Meiryo"/>
+              </a:rPr>
+              <a:t>Bizデザインの偽メール送付</a:t>
+            </a:r>
+          </a:p>
+        </p:txBody>
+      </p:sp>
+      <p:sp>
+        <p:nvSpPr>
+          <p:cNvPr id="21" name="Rectangle 20"/>
+          <p:cNvSpPr/>
+          <p:nvPr/>
+        </p:nvSpPr>
+        <p:spPr>
+          <a:xfrm>
+            <a:off x="5120640" y="2743200"/>
+            <a:ext cx="1645920" cy="457200"/>
+          </a:xfrm>
+          <a:prstGeom prst="rect">
+            <a:avLst/>
+          </a:prstGeom>
+          <a:solidFill>
+            <a:srgbClr val="E67E22"/>
+          </a:solidFill>
+          <a:ln>
+            <a:noFill/>
+          </a:ln>
+        </p:spPr>
+        <p:style>
+          <a:lnRef idx="1">
+            <a:schemeClr val="accent1"/>
+          </a:lnRef>
+          <a:fillRef idx="3">
+            <a:schemeClr val="accent1"/>
+          </a:fillRef>
+          <a:effectRef idx="2">
+            <a:schemeClr val="accent1"/>
+          </a:effectRef>
+          <a:fontRef idx="minor">
+            <a:schemeClr val="lt1"/>
+          </a:fontRef>
+        </p:style>
+        <p:txBody>
+          <a:bodyPr rtlCol="0" anchor="ctr" wrap="square" lIns="50800" rIns="50800" tIns="25400" bIns="25400"/>
+          <a:lstStyle/>
+          <a:p>
+            <a:pPr algn="ctr"/>
+            <a:r>
+              <a:rPr sz="900" b="1">
+                <a:solidFill>
+                  <a:srgbClr val="FFFFFF"/>
+                </a:solidFill>
+                <a:latin typeface="Meiryo"/>
+              </a:rPr>
+              <a:t>困難</a:t>
+            </a:r>
+          </a:p>
+        </p:txBody>
+      </p:sp>
+      <p:sp>
+        <p:nvSpPr>
+          <p:cNvPr id="22" name="Rectangle 21"/>
+          <p:cNvSpPr/>
+          <p:nvPr/>
+        </p:nvSpPr>
+        <p:spPr>
+          <a:xfrm>
+            <a:off x="6766559" y="2743200"/>
+            <a:ext cx="5943600" cy="457200"/>
+          </a:xfrm>
+          <a:prstGeom prst="rect">
+            <a:avLst/>
+          </a:prstGeom>
+          <a:solidFill>
+            <a:srgbClr val="F9F9F9"/>
+          </a:solidFill>
+          <a:ln w="25400">
+            <a:solidFill>
+              <a:srgbClr val="DDDDDD"/>
+            </a:solidFill>
+          </a:ln>
+        </p:spPr>
+        <p:style>
+          <a:lnRef idx="1">
+            <a:schemeClr val="accent1"/>
+          </a:lnRef>
+          <a:fillRef idx="3">
+            <a:schemeClr val="accent1"/>
+          </a:fillRef>
+          <a:effectRef idx="2">
+            <a:schemeClr val="accent1"/>
+          </a:effectRef>
+          <a:fontRef idx="minor">
+            <a:schemeClr val="lt1"/>
+          </a:fontRef>
+        </p:style>
+        <p:txBody>
+          <a:bodyPr rtlCol="0" anchor="ctr" wrap="square" lIns="63500" rIns="50800" tIns="38100" bIns="38100"/>
+          <a:lstStyle/>
+          <a:p>
+            <a:pPr algn="l"/>
+            <a:r>
+              <a:rPr sz="900" b="0">
+                <a:solidFill>
+                  <a:srgbClr val="222222"/>
+                </a:solidFill>
+                <a:latin typeface="Meiryo"/>
+              </a:rPr>
+              <a:t>精巧に模倣されている</a:t>
+            </a:r>
+          </a:p>
+        </p:txBody>
+      </p:sp>
+      <p:sp>
+        <p:nvSpPr>
+          <p:cNvPr id="23" name="Rectangle 22"/>
+          <p:cNvSpPr/>
+          <p:nvPr/>
+        </p:nvSpPr>
+        <p:spPr>
+          <a:xfrm>
+            <a:off x="731520" y="3200400"/>
+            <a:ext cx="914400" cy="457200"/>
+          </a:xfrm>
+          <a:prstGeom prst="rect">
+            <a:avLst/>
+          </a:prstGeom>
+          <a:solidFill>
+            <a:srgbClr val="FFFFFF"/>
+          </a:solidFill>
+          <a:ln>
+            <a:noFill/>
+          </a:ln>
+        </p:spPr>
+        <p:style>
+          <a:lnRef idx="1">
+            <a:schemeClr val="accent1"/>
+          </a:lnRef>
+          <a:fillRef idx="3">
+            <a:schemeClr val="accent1"/>
+          </a:fillRef>
+          <a:effectRef idx="2">
+            <a:schemeClr val="accent1"/>
+          </a:effectRef>
+          <a:fontRef idx="minor">
+            <a:schemeClr val="lt1"/>
+          </a:fontRef>
+        </p:style>
+        <p:txBody>
+          <a:bodyPr rtlCol="0" anchor="ctr" wrap="square" lIns="50800" rIns="50800" tIns="25400" bIns="25400"/>
+          <a:lstStyle/>
+          <a:p>
+            <a:pPr algn="ctr"/>
+            <a:r>
+              <a:rPr sz="1100" b="1">
+                <a:solidFill>
+                  <a:srgbClr val="222222"/>
+                </a:solidFill>
+                <a:latin typeface="Meiryo"/>
+              </a:rPr>
+              <a:t>⑤</a:t>
+            </a:r>
+          </a:p>
+        </p:txBody>
+      </p:sp>
+      <p:sp>
+        <p:nvSpPr>
+          <p:cNvPr id="24" name="Rectangle 23"/>
+          <p:cNvSpPr/>
+          <p:nvPr/>
+        </p:nvSpPr>
+        <p:spPr>
+          <a:xfrm>
+            <a:off x="1645920" y="3200400"/>
+            <a:ext cx="3474720" cy="457200"/>
+          </a:xfrm>
+          <a:prstGeom prst="rect">
+            <a:avLst/>
+          </a:prstGeom>
+          <a:solidFill>
+            <a:srgbClr val="FFFFFF"/>
+          </a:solidFill>
+          <a:ln w="25400">
+            <a:solidFill>
+              <a:srgbClr val="DDDDDD"/>
+            </a:solidFill>
+          </a:ln>
+        </p:spPr>
+        <p:style>
+          <a:lnRef idx="1">
+            <a:schemeClr val="accent1"/>
+          </a:lnRef>
+          <a:fillRef idx="3">
+            <a:schemeClr val="accent1"/>
+          </a:fillRef>
+          <a:effectRef idx="2">
+            <a:schemeClr val="accent1"/>
+          </a:effectRef>
+          <a:fontRef idx="minor">
+            <a:schemeClr val="lt1"/>
+          </a:fontRef>
+        </p:style>
+        <p:txBody>
+          <a:bodyPr rtlCol="0" anchor="ctr" wrap="square" lIns="63500" rIns="50800" tIns="38100" bIns="38100"/>
+          <a:lstStyle/>
+          <a:p>
+            <a:pPr algn="l"/>
+            <a:r>
+              <a:rPr sz="900" b="0">
+                <a:solidFill>
+                  <a:srgbClr val="222222"/>
+                </a:solidFill>
+                <a:latin typeface="Meiryo"/>
+              </a:rPr>
+              <a:t>「ソフトをインストールしてください」</a:t>
+            </a:r>
+          </a:p>
+        </p:txBody>
+      </p:sp>
+      <p:sp>
+        <p:nvSpPr>
+          <p:cNvPr id="25" name="Rectangle 24"/>
+          <p:cNvSpPr/>
+          <p:nvPr/>
+        </p:nvSpPr>
+        <p:spPr>
+          <a:xfrm>
+            <a:off x="5120640" y="3200400"/>
+            <a:ext cx="1645920" cy="457200"/>
+          </a:xfrm>
+          <a:prstGeom prst="rect">
+            <a:avLst/>
+          </a:prstGeom>
+          <a:solidFill>
+            <a:srgbClr val="27AE60"/>
+          </a:solidFill>
+          <a:ln>
+            <a:noFill/>
+          </a:ln>
+        </p:spPr>
+        <p:style>
+          <a:lnRef idx="1">
+            <a:schemeClr val="accent1"/>
+          </a:lnRef>
+          <a:fillRef idx="3">
+            <a:schemeClr val="accent1"/>
+          </a:fillRef>
+          <a:effectRef idx="2">
+            <a:schemeClr val="accent1"/>
+          </a:effectRef>
+          <a:fontRef idx="minor">
+            <a:schemeClr val="lt1"/>
+          </a:fontRef>
+        </p:style>
+        <p:txBody>
+          <a:bodyPr rtlCol="0" anchor="ctr" wrap="square" lIns="50800" rIns="50800" tIns="25400" bIns="25400"/>
+          <a:lstStyle/>
+          <a:p>
+            <a:pPr algn="ctr"/>
+            <a:r>
+              <a:rPr sz="900" b="1">
+                <a:solidFill>
+                  <a:srgbClr val="FFFFFF"/>
+                </a:solidFill>
+                <a:latin typeface="Meiryo"/>
+              </a:rPr>
+              <a:t>唯一のチャンス</a:t>
+            </a:r>
+          </a:p>
+        </p:txBody>
+      </p:sp>
+      <p:sp>
+        <p:nvSpPr>
+          <p:cNvPr id="26" name="Rectangle 25"/>
+          <p:cNvSpPr/>
+          <p:nvPr/>
+        </p:nvSpPr>
+        <p:spPr>
+          <a:xfrm>
+            <a:off x="6766559" y="3200400"/>
+            <a:ext cx="5943600" cy="457200"/>
+          </a:xfrm>
+          <a:prstGeom prst="rect">
+            <a:avLst/>
+          </a:prstGeom>
+          <a:solidFill>
+            <a:srgbClr val="FFFFFF"/>
+          </a:solidFill>
+          <a:ln w="25400">
+            <a:solidFill>
+              <a:srgbClr val="DDDDDD"/>
+            </a:solidFill>
+          </a:ln>
+        </p:spPr>
+        <p:style>
+          <a:lnRef idx="1">
+            <a:schemeClr val="accent1"/>
+          </a:lnRef>
+          <a:fillRef idx="3">
+            <a:schemeClr val="accent1"/>
+          </a:fillRef>
+          <a:effectRef idx="2">
+            <a:schemeClr val="accent1"/>
+          </a:effectRef>
+          <a:fontRef idx="minor">
+            <a:schemeClr val="lt1"/>
+          </a:fontRef>
+        </p:style>
+        <p:txBody>
+          <a:bodyPr rtlCol="0" anchor="ctr" wrap="square" lIns="63500" rIns="50800" tIns="38100" bIns="38100"/>
+          <a:lstStyle/>
+          <a:p>
+            <a:pPr algn="l"/>
+            <a:r>
+              <a:rPr sz="900" b="0">
+                <a:solidFill>
+                  <a:srgbClr val="222222"/>
+                </a:solidFill>
+                <a:latin typeface="Meiryo"/>
+              </a:rPr>
+              <a:t>ただし既に心理的に従う状態</a:t>
+            </a:r>
+          </a:p>
+        </p:txBody>
+      </p:sp>
+      <p:sp>
+        <p:nvSpPr>
+          <p:cNvPr id="27" name="Rectangle 26"/>
+          <p:cNvSpPr/>
+          <p:nvPr/>
+        </p:nvSpPr>
+        <p:spPr>
+          <a:xfrm>
+            <a:off x="731520" y="3657600"/>
+            <a:ext cx="914400" cy="457200"/>
+          </a:xfrm>
+          <a:prstGeom prst="rect">
+            <a:avLst/>
+          </a:prstGeom>
+          <a:solidFill>
+            <a:srgbClr val="F9F9F9"/>
+          </a:solidFill>
+          <a:ln>
+            <a:noFill/>
+          </a:ln>
+        </p:spPr>
+        <p:style>
+          <a:lnRef idx="1">
+            <a:schemeClr val="accent1"/>
+          </a:lnRef>
+          <a:fillRef idx="3">
+            <a:schemeClr val="accent1"/>
+          </a:fillRef>
+          <a:effectRef idx="2">
+            <a:schemeClr val="accent1"/>
+          </a:effectRef>
+          <a:fontRef idx="minor">
+            <a:schemeClr val="lt1"/>
+          </a:fontRef>
+        </p:style>
+        <p:txBody>
+          <a:bodyPr rtlCol="0" anchor="ctr" wrap="square" lIns="50800" rIns="50800" tIns="25400" bIns="25400"/>
+          <a:lstStyle/>
+          <a:p>
+            <a:pPr algn="ctr"/>
+            <a:r>
+              <a:rPr sz="1100" b="1">
+                <a:solidFill>
+                  <a:srgbClr val="222222"/>
+                </a:solidFill>
+                <a:latin typeface="Meiryo"/>
+              </a:rPr>
+              <a:t>⑥</a:t>
+            </a:r>
+          </a:p>
+        </p:txBody>
+      </p:sp>
+      <p:sp>
+        <p:nvSpPr>
+          <p:cNvPr id="28" name="Rectangle 27"/>
+          <p:cNvSpPr/>
+          <p:nvPr/>
+        </p:nvSpPr>
+        <p:spPr>
+          <a:xfrm>
+            <a:off x="1645920" y="3657600"/>
+            <a:ext cx="3474720" cy="457200"/>
+          </a:xfrm>
+          <a:prstGeom prst="rect">
+            <a:avLst/>
+          </a:prstGeom>
+          <a:solidFill>
+            <a:srgbClr val="F9F9F9"/>
+          </a:solidFill>
+          <a:ln w="25400">
+            <a:solidFill>
+              <a:srgbClr val="DDDDDD"/>
+            </a:solidFill>
+          </a:ln>
+        </p:spPr>
+        <p:style>
+          <a:lnRef idx="1">
+            <a:schemeClr val="accent1"/>
+          </a:lnRef>
+          <a:fillRef idx="3">
+            <a:schemeClr val="accent1"/>
+          </a:fillRef>
+          <a:effectRef idx="2">
+            <a:schemeClr val="accent1"/>
+          </a:effectRef>
+          <a:fontRef idx="minor">
+            <a:schemeClr val="lt1"/>
+          </a:fontRef>
+        </p:style>
+        <p:txBody>
+          <a:bodyPr rtlCol="0" anchor="ctr" wrap="square" lIns="63500" rIns="50800" tIns="38100" bIns="38100"/>
+          <a:lstStyle/>
+          <a:p>
+            <a:pPr algn="l"/>
+            <a:r>
+              <a:rPr sz="900" b="0">
+                <a:solidFill>
+                  <a:srgbClr val="222222"/>
+                </a:solidFill>
+                <a:latin typeface="Meiryo"/>
+              </a:rPr>
+              <a:t>msi実行「不明な発行元」の警告</a:t>
+            </a:r>
+          </a:p>
+        </p:txBody>
+      </p:sp>
+      <p:sp>
+        <p:nvSpPr>
+          <p:cNvPr id="29" name="Rectangle 28"/>
+          <p:cNvSpPr/>
+          <p:nvPr/>
+        </p:nvSpPr>
+        <p:spPr>
+          <a:xfrm>
+            <a:off x="5120640" y="3657600"/>
+            <a:ext cx="1645920" cy="457200"/>
+          </a:xfrm>
+          <a:prstGeom prst="rect">
+            <a:avLst/>
+          </a:prstGeom>
+          <a:solidFill>
+            <a:srgbClr val="E67E22"/>
+          </a:solidFill>
+          <a:ln>
+            <a:noFill/>
+          </a:ln>
+        </p:spPr>
+        <p:style>
+          <a:lnRef idx="1">
+            <a:schemeClr val="accent1"/>
+          </a:lnRef>
+          <a:fillRef idx="3">
+            <a:schemeClr val="accent1"/>
+          </a:fillRef>
+          <a:effectRef idx="2">
+            <a:schemeClr val="accent1"/>
+          </a:effectRef>
+          <a:fontRef idx="minor">
+            <a:schemeClr val="lt1"/>
+          </a:fontRef>
+        </p:style>
+        <p:txBody>
+          <a:bodyPr rtlCol="0" anchor="ctr" wrap="square" lIns="50800" rIns="50800" tIns="25400" bIns="25400"/>
+          <a:lstStyle/>
+          <a:p>
+            <a:pPr algn="ctr"/>
+            <a:r>
+              <a:rPr sz="900" b="1">
+                <a:solidFill>
+                  <a:srgbClr val="FFFFFF"/>
+                </a:solidFill>
+                <a:latin typeface="Meiryo"/>
+              </a:rPr>
+              <a:t>技術的には可能</a:t>
+            </a:r>
+          </a:p>
+        </p:txBody>
+      </p:sp>
+      <p:sp>
+        <p:nvSpPr>
+          <p:cNvPr id="30" name="Rectangle 29"/>
+          <p:cNvSpPr/>
+          <p:nvPr/>
+        </p:nvSpPr>
+        <p:spPr>
+          <a:xfrm>
+            <a:off x="6766559" y="3657600"/>
+            <a:ext cx="5943600" cy="457200"/>
+          </a:xfrm>
+          <a:prstGeom prst="rect">
+            <a:avLst/>
+          </a:prstGeom>
+          <a:solidFill>
+            <a:srgbClr val="F9F9F9"/>
+          </a:solidFill>
+          <a:ln w="25400">
+            <a:solidFill>
+              <a:srgbClr val="DDDDDD"/>
+            </a:solidFill>
+          </a:ln>
+        </p:spPr>
+        <p:style>
+          <a:lnRef idx="1">
+            <a:schemeClr val="accent1"/>
+          </a:lnRef>
+          <a:fillRef idx="3">
+            <a:schemeClr val="accent1"/>
+          </a:fillRef>
+          <a:effectRef idx="2">
+            <a:schemeClr val="accent1"/>
+          </a:effectRef>
+          <a:fontRef idx="minor">
+            <a:schemeClr val="lt1"/>
+          </a:fontRef>
+        </p:style>
+        <p:txBody>
+          <a:bodyPr rtlCol="0" anchor="ctr" wrap="square" lIns="63500" rIns="50800" tIns="38100" bIns="38100"/>
+          <a:lstStyle/>
+          <a:p>
+            <a:pPr algn="l"/>
+            <a:r>
+              <a:rPr sz="900" b="0">
+                <a:solidFill>
+                  <a:srgbClr val="222222"/>
+                </a:solidFill>
+                <a:latin typeface="Meiryo"/>
+              </a:rPr>
+              <a:t>電話で「実行して」と言われ突破される</a:t>
+            </a:r>
+          </a:p>
+        </p:txBody>
+      </p:sp>
+      <p:sp>
+        <p:nvSpPr>
+          <p:cNvPr id="31" name="Rectangle 30"/>
+          <p:cNvSpPr/>
+          <p:nvPr/>
+        </p:nvSpPr>
+        <p:spPr>
+          <a:xfrm>
+            <a:off x="731520" y="4114800"/>
+            <a:ext cx="914400" cy="457200"/>
+          </a:xfrm>
+          <a:prstGeom prst="rect">
+            <a:avLst/>
+          </a:prstGeom>
+          <a:solidFill>
+            <a:srgbClr val="FFFFFF"/>
+          </a:solidFill>
+          <a:ln>
+            <a:noFill/>
+          </a:ln>
+        </p:spPr>
+        <p:style>
+          <a:lnRef idx="1">
+            <a:schemeClr val="accent1"/>
+          </a:lnRef>
+          <a:fillRef idx="3">
+            <a:schemeClr val="accent1"/>
+          </a:fillRef>
+          <a:effectRef idx="2">
+            <a:schemeClr val="accent1"/>
+          </a:effectRef>
+          <a:fontRef idx="minor">
+            <a:schemeClr val="lt1"/>
+          </a:fontRef>
+        </p:style>
+        <p:txBody>
+          <a:bodyPr rtlCol="0" anchor="ctr" wrap="square" lIns="50800" rIns="50800" tIns="25400" bIns="25400"/>
+          <a:lstStyle/>
+          <a:p>
+            <a:pPr algn="ctr"/>
+            <a:r>
+              <a:rPr sz="1100" b="1">
+                <a:solidFill>
+                  <a:srgbClr val="222222"/>
+                </a:solidFill>
+                <a:latin typeface="Meiryo"/>
+              </a:rPr>
+              <a:t>⑦</a:t>
+            </a:r>
+          </a:p>
+        </p:txBody>
+      </p:sp>
+      <p:sp>
+        <p:nvSpPr>
+          <p:cNvPr id="32" name="Rectangle 31"/>
+          <p:cNvSpPr/>
+          <p:nvPr/>
+        </p:nvSpPr>
+        <p:spPr>
+          <a:xfrm>
+            <a:off x="1645920" y="4114800"/>
+            <a:ext cx="3474720" cy="457200"/>
+          </a:xfrm>
+          <a:prstGeom prst="rect">
+            <a:avLst/>
+          </a:prstGeom>
+          <a:solidFill>
+            <a:srgbClr val="FFFFFF"/>
+          </a:solidFill>
+          <a:ln w="25400">
+            <a:solidFill>
+              <a:srgbClr val="DDDDDD"/>
+            </a:solidFill>
+          </a:ln>
+        </p:spPr>
+        <p:style>
+          <a:lnRef idx="1">
+            <a:schemeClr val="accent1"/>
+          </a:lnRef>
+          <a:fillRef idx="3">
+            <a:schemeClr val="accent1"/>
+          </a:fillRef>
+          <a:effectRef idx="2">
+            <a:schemeClr val="accent1"/>
+          </a:effectRef>
+          <a:fontRef idx="minor">
+            <a:schemeClr val="lt1"/>
+          </a:fontRef>
+        </p:style>
+        <p:txBody>
+          <a:bodyPr rtlCol="0" anchor="ctr" wrap="square" lIns="63500" rIns="50800" tIns="38100" bIns="38100"/>
+          <a:lstStyle/>
+          <a:p>
+            <a:pPr algn="l"/>
+            <a:r>
+              <a:rPr sz="900" b="0">
+                <a:solidFill>
+                  <a:srgbClr val="222222"/>
+                </a:solidFill>
+                <a:latin typeface="Meiryo"/>
+              </a:rPr>
+              <a:t>赤い画面「お待ちください」</a:t>
+            </a:r>
+          </a:p>
+        </p:txBody>
+      </p:sp>
+      <p:sp>
+        <p:nvSpPr>
+          <p:cNvPr id="33" name="Rectangle 32"/>
+          <p:cNvSpPr/>
+          <p:nvPr/>
+        </p:nvSpPr>
+        <p:spPr>
+          <a:xfrm>
+            <a:off x="5120640" y="4114800"/>
+            <a:ext cx="1645920" cy="457200"/>
+          </a:xfrm>
+          <a:prstGeom prst="rect">
+            <a:avLst/>
+          </a:prstGeom>
+          <a:solidFill>
+            <a:srgbClr val="E67E22"/>
+          </a:solidFill>
+          <a:ln>
+            <a:noFill/>
+          </a:ln>
+        </p:spPr>
+        <p:style>
+          <a:lnRef idx="1">
+            <a:schemeClr val="accent1"/>
+          </a:lnRef>
+          <a:fillRef idx="3">
+            <a:schemeClr val="accent1"/>
+          </a:fillRef>
+          <a:effectRef idx="2">
+            <a:schemeClr val="accent1"/>
+          </a:effectRef>
+          <a:fontRef idx="minor">
+            <a:schemeClr val="lt1"/>
+          </a:fontRef>
+        </p:style>
+        <p:txBody>
+          <a:bodyPr rtlCol="0" anchor="ctr" wrap="square" lIns="50800" rIns="50800" tIns="25400" bIns="25400"/>
+          <a:lstStyle/>
+          <a:p>
+            <a:pPr algn="ctr"/>
+            <a:r>
+              <a:rPr sz="900" b="1">
+                <a:solidFill>
+                  <a:srgbClr val="FFFFFF"/>
+                </a:solidFill>
+                <a:latin typeface="Meiryo"/>
+              </a:rPr>
+              <a:t>困難</a:t>
+            </a:r>
+          </a:p>
+        </p:txBody>
+      </p:sp>
+      <p:sp>
+        <p:nvSpPr>
+          <p:cNvPr id="34" name="Rectangle 33"/>
+          <p:cNvSpPr/>
+          <p:nvPr/>
+        </p:nvSpPr>
+        <p:spPr>
+          <a:xfrm>
+            <a:off x="6766559" y="4114800"/>
+            <a:ext cx="5943600" cy="457200"/>
+          </a:xfrm>
+          <a:prstGeom prst="rect">
+            <a:avLst/>
+          </a:prstGeom>
+          <a:solidFill>
+            <a:srgbClr val="FFFFFF"/>
+          </a:solidFill>
+          <a:ln w="25400">
+            <a:solidFill>
+              <a:srgbClr val="DDDDDD"/>
+            </a:solidFill>
+          </a:ln>
+        </p:spPr>
+        <p:style>
+          <a:lnRef idx="1">
+            <a:schemeClr val="accent1"/>
+          </a:lnRef>
+          <a:fillRef idx="3">
+            <a:schemeClr val="accent1"/>
+          </a:fillRef>
+          <a:effectRef idx="2">
+            <a:schemeClr val="accent1"/>
+          </a:effectRef>
+          <a:fontRef idx="minor">
+            <a:schemeClr val="lt1"/>
+          </a:fontRef>
+        </p:style>
+        <p:txBody>
+          <a:bodyPr rtlCol="0" anchor="ctr" wrap="square" lIns="63500" rIns="50800" tIns="38100" bIns="38100"/>
+          <a:lstStyle/>
+          <a:p>
+            <a:pPr algn="l"/>
+            <a:r>
+              <a:rPr sz="900" b="0">
+                <a:solidFill>
+                  <a:srgbClr val="222222"/>
+                </a:solidFill>
+                <a:latin typeface="Meiryo"/>
+              </a:rPr>
+              <a:t>もう完全に信用している</a:t>
+            </a:r>
+          </a:p>
+        </p:txBody>
+      </p:sp>
+      <p:sp>
+        <p:nvSpPr>
+          <p:cNvPr id="35" name="Rectangle 34"/>
+          <p:cNvSpPr/>
+          <p:nvPr/>
+        </p:nvSpPr>
+        <p:spPr>
+          <a:xfrm>
+            <a:off x="731520" y="4572000"/>
+            <a:ext cx="914400" cy="457200"/>
+          </a:xfrm>
+          <a:prstGeom prst="rect">
+            <a:avLst/>
+          </a:prstGeom>
+          <a:solidFill>
+            <a:srgbClr val="F9F9F9"/>
+          </a:solidFill>
+          <a:ln>
+            <a:noFill/>
+          </a:ln>
+        </p:spPr>
+        <p:style>
+          <a:lnRef idx="1">
+            <a:schemeClr val="accent1"/>
+          </a:lnRef>
+          <a:fillRef idx="3">
+            <a:schemeClr val="accent1"/>
+          </a:fillRef>
+          <a:effectRef idx="2">
+            <a:schemeClr val="accent1"/>
+          </a:effectRef>
+          <a:fontRef idx="minor">
+            <a:schemeClr val="lt1"/>
+          </a:fontRef>
+        </p:style>
+        <p:txBody>
+          <a:bodyPr rtlCol="0" anchor="ctr" wrap="square" lIns="50800" rIns="50800" tIns="25400" bIns="25400"/>
+          <a:lstStyle/>
+          <a:p>
+            <a:pPr algn="ctr"/>
+            <a:r>
+              <a:rPr sz="1100" b="1">
+                <a:solidFill>
+                  <a:srgbClr val="222222"/>
+                </a:solidFill>
+                <a:latin typeface="Meiryo"/>
+              </a:rPr>
+              <a:t>⑧</a:t>
+            </a:r>
+          </a:p>
+        </p:txBody>
+      </p:sp>
+      <p:sp>
+        <p:nvSpPr>
+          <p:cNvPr id="36" name="Rectangle 35"/>
+          <p:cNvSpPr/>
+          <p:nvPr/>
+        </p:nvSpPr>
+        <p:spPr>
+          <a:xfrm>
+            <a:off x="1645920" y="4572000"/>
+            <a:ext cx="3474720" cy="457200"/>
+          </a:xfrm>
+          <a:prstGeom prst="rect">
+            <a:avLst/>
+          </a:prstGeom>
+          <a:solidFill>
+            <a:srgbClr val="F9F9F9"/>
+          </a:solidFill>
+          <a:ln w="25400">
+            <a:solidFill>
+              <a:srgbClr val="DDDDDD"/>
+            </a:solidFill>
+          </a:ln>
+        </p:spPr>
+        <p:style>
+          <a:lnRef idx="1">
+            <a:schemeClr val="accent1"/>
+          </a:lnRef>
+          <a:fillRef idx="3">
+            <a:schemeClr val="accent1"/>
+          </a:fillRef>
+          <a:effectRef idx="2">
+            <a:schemeClr val="accent1"/>
+          </a:effectRef>
+          <a:fontRef idx="minor">
+            <a:schemeClr val="lt1"/>
+          </a:fontRef>
+        </p:style>
+        <p:txBody>
+          <a:bodyPr rtlCol="0" anchor="ctr" wrap="square" lIns="63500" rIns="50800" tIns="38100" bIns="38100"/>
+          <a:lstStyle/>
+          <a:p>
+            <a:pPr algn="l"/>
+            <a:r>
+              <a:rPr sz="900" b="0">
+                <a:solidFill>
+                  <a:srgbClr val="222222"/>
+                </a:solidFill>
+                <a:latin typeface="Meiryo"/>
+              </a:rPr>
+              <a:t>認証情報5要素を一画面で入力</a:t>
+            </a:r>
+          </a:p>
+        </p:txBody>
+      </p:sp>
+      <p:sp>
+        <p:nvSpPr>
+          <p:cNvPr id="37" name="Rectangle 36"/>
+          <p:cNvSpPr/>
+          <p:nvPr/>
+        </p:nvSpPr>
+        <p:spPr>
+          <a:xfrm>
+            <a:off x="5120640" y="4572000"/>
+            <a:ext cx="1645920" cy="457200"/>
+          </a:xfrm>
+          <a:prstGeom prst="rect">
+            <a:avLst/>
+          </a:prstGeom>
+          <a:solidFill>
+            <a:srgbClr val="E67E22"/>
+          </a:solidFill>
+          <a:ln>
+            <a:noFill/>
+          </a:ln>
+        </p:spPr>
+        <p:style>
+          <a:lnRef idx="1">
+            <a:schemeClr val="accent1"/>
+          </a:lnRef>
+          <a:fillRef idx="3">
+            <a:schemeClr val="accent1"/>
+          </a:fillRef>
+          <a:effectRef idx="2">
+            <a:schemeClr val="accent1"/>
+          </a:effectRef>
+          <a:fontRef idx="minor">
+            <a:schemeClr val="lt1"/>
+          </a:fontRef>
+        </p:style>
+        <p:txBody>
+          <a:bodyPr rtlCol="0" anchor="ctr" wrap="square" lIns="50800" rIns="50800" tIns="25400" bIns="25400"/>
+          <a:lstStyle/>
+          <a:p>
+            <a:pPr algn="ctr"/>
+            <a:r>
+              <a:rPr sz="900" b="1">
+                <a:solidFill>
+                  <a:srgbClr val="FFFFFF"/>
+                </a:solidFill>
+                <a:latin typeface="Meiryo"/>
+              </a:rPr>
+              <a:t>本来は異常</a:t>
+            </a:r>
+          </a:p>
+        </p:txBody>
+      </p:sp>
+      <p:sp>
+        <p:nvSpPr>
+          <p:cNvPr id="38" name="Rectangle 37"/>
+          <p:cNvSpPr/>
+          <p:nvPr/>
+        </p:nvSpPr>
+        <p:spPr>
+          <a:xfrm>
+            <a:off x="6766559" y="4572000"/>
+            <a:ext cx="5943600" cy="457200"/>
+          </a:xfrm>
+          <a:prstGeom prst="rect">
+            <a:avLst/>
+          </a:prstGeom>
+          <a:solidFill>
+            <a:srgbClr val="F9F9F9"/>
+          </a:solidFill>
+          <a:ln w="25400">
+            <a:solidFill>
+              <a:srgbClr val="DDDDDD"/>
+            </a:solidFill>
+          </a:ln>
+        </p:spPr>
+        <p:style>
+          <a:lnRef idx="1">
+            <a:schemeClr val="accent1"/>
+          </a:lnRef>
+          <a:fillRef idx="3">
+            <a:schemeClr val="accent1"/>
+          </a:fillRef>
+          <a:effectRef idx="2">
+            <a:schemeClr val="accent1"/>
+          </a:effectRef>
+          <a:fontRef idx="minor">
+            <a:schemeClr val="lt1"/>
+          </a:fontRef>
+        </p:style>
+        <p:txBody>
+          <a:bodyPr rtlCol="0" anchor="ctr" wrap="square" lIns="63500" rIns="50800" tIns="38100" bIns="38100"/>
+          <a:lstStyle/>
+          <a:p>
+            <a:pPr algn="l"/>
+            <a:r>
+              <a:rPr sz="900" b="0">
+                <a:solidFill>
+                  <a:srgbClr val="222222"/>
+                </a:solidFill>
+                <a:latin typeface="Meiryo"/>
+              </a:rPr>
+              <a:t>焦りと電話指示で気づく余裕がない</a:t>
+            </a:r>
+          </a:p>
+        </p:txBody>
+      </p:sp>
+      <p:sp>
+        <p:nvSpPr>
+          <p:cNvPr id="39" name="Rectangle 38"/>
+          <p:cNvSpPr/>
+          <p:nvPr/>
+        </p:nvSpPr>
+        <p:spPr>
+          <a:xfrm>
+            <a:off x="731520" y="5257800"/>
+            <a:ext cx="11978640" cy="502920"/>
+          </a:xfrm>
+          <a:prstGeom prst="rect">
+            <a:avLst/>
+          </a:prstGeom>
+          <a:solidFill>
+            <a:srgbClr val="C0392B"/>
+          </a:solidFill>
+          <a:ln>
+            <a:noFill/>
+          </a:ln>
+        </p:spPr>
+        <p:style>
+          <a:lnRef idx="1">
+            <a:schemeClr val="accent1"/>
+          </a:lnRef>
+          <a:fillRef idx="3">
+            <a:schemeClr val="accent1"/>
+          </a:fillRef>
+          <a:effectRef idx="2">
+            <a:schemeClr val="accent1"/>
+          </a:effectRef>
+          <a:fontRef idx="minor">
+            <a:schemeClr val="lt1"/>
+          </a:fontRef>
+        </p:style>
+        <p:txBody>
+          <a:bodyPr rtlCol="0" anchor="ctr" wrap="square" lIns="50800" rIns="50800" tIns="25400" bIns="25400"/>
+          <a:lstStyle/>
+          <a:p>
+            <a:pPr algn="ctr"/>
+            <a:r>
+              <a:rPr sz="1400" b="1">
+                <a:solidFill>
+                  <a:srgbClr val="FFFFFF"/>
+                </a:solidFill>
+                <a:latin typeface="Meiryo"/>
+              </a:rPr>
+              <a:t>唯一の見破りポイント（手順⑤⑥）に到達した時点で、冷静に判断できる心理状態ではない</a:t>
+            </a:r>
+          </a:p>
+        </p:txBody>
+      </p:sp>
+      <p:sp>
+        <p:nvSpPr>
+          <p:cNvPr id="40" name="Rectangle 39"/>
+          <p:cNvSpPr/>
+          <p:nvPr/>
+        </p:nvSpPr>
+        <p:spPr>
+          <a:xfrm>
+            <a:off x="731520" y="5943600"/>
+            <a:ext cx="5852160" cy="365760"/>
+          </a:xfrm>
+          <a:prstGeom prst="rect">
+            <a:avLst/>
+          </a:prstGeom>
+          <a:solidFill>
+            <a:srgbClr val="EEEEEE"/>
+          </a:solidFill>
+          <a:ln>
+            <a:noFill/>
+          </a:ln>
+        </p:spPr>
+        <p:style>
+          <a:lnRef idx="1">
+            <a:schemeClr val="accent1"/>
+          </a:lnRef>
+          <a:fillRef idx="3">
+            <a:schemeClr val="accent1"/>
+          </a:fillRef>
+          <a:effectRef idx="2">
+            <a:schemeClr val="accent1"/>
+          </a:effectRef>
+          <a:fontRef idx="minor">
+            <a:schemeClr val="lt1"/>
+          </a:fontRef>
+        </p:style>
+        <p:txBody>
+          <a:bodyPr rtlCol="0" anchor="ctr" wrap="square" lIns="50800" rIns="50800" tIns="25400" bIns="25400"/>
+          <a:lstStyle/>
+          <a:p>
+            <a:pPr algn="ctr"/>
+            <a:r>
+              <a:rPr sz="1200" b="1">
+                <a:solidFill>
+                  <a:srgbClr val="222222"/>
+                </a:solidFill>
+                <a:latin typeface="Meiryo"/>
+              </a:rPr>
+              <a:t>顧客側（ほぼ無力）</a:t>
+            </a:r>
+          </a:p>
+        </p:txBody>
+      </p:sp>
+      <p:sp>
+        <p:nvSpPr>
+          <p:cNvPr id="41" name="Rectangle 40"/>
+          <p:cNvSpPr/>
+          <p:nvPr/>
+        </p:nvSpPr>
+        <p:spPr>
+          <a:xfrm>
+            <a:off x="731520" y="6309360"/>
+            <a:ext cx="5852160" cy="457200"/>
+          </a:xfrm>
+          <a:prstGeom prst="rect">
+            <a:avLst/>
+          </a:prstGeom>
+          <a:solidFill>
+            <a:srgbClr val="FFFFFF"/>
+          </a:solidFill>
+          <a:ln w="25400">
+            <a:solidFill>
+              <a:srgbClr val="DDDDDD"/>
+            </a:solidFill>
+          </a:ln>
+        </p:spPr>
+        <p:style>
+          <a:lnRef idx="1">
+            <a:schemeClr val="accent1"/>
+          </a:lnRef>
+          <a:fillRef idx="3">
+            <a:schemeClr val="accent1"/>
+          </a:fillRef>
+          <a:effectRef idx="2">
+            <a:schemeClr val="accent1"/>
+          </a:effectRef>
+          <a:fontRef idx="minor">
+            <a:schemeClr val="lt1"/>
+          </a:fontRef>
+        </p:style>
+        <p:txBody>
+          <a:bodyPr rtlCol="0" anchor="ctr" wrap="square" lIns="63500" rIns="50800" tIns="38100" bIns="38100"/>
+          <a:lstStyle/>
+          <a:p>
+            <a:pPr algn="l"/>
+            <a:r>
+              <a:rPr sz="1000" b="0">
+                <a:solidFill>
+                  <a:srgbClr val="888888"/>
+                </a:solidFill>
+                <a:latin typeface="Meiryo"/>
+              </a:rPr>
+              <a:t>「気をつける」「注意喚起」では構造的に防げない</a:t>
+            </a:r>
+          </a:p>
+        </p:txBody>
+      </p:sp>
+      <p:sp>
+        <p:nvSpPr>
+          <p:cNvPr id="42" name="Rectangle 41"/>
+          <p:cNvSpPr/>
+          <p:nvPr/>
+        </p:nvSpPr>
+        <p:spPr>
+          <a:xfrm>
+            <a:off x="6858000" y="5943600"/>
+            <a:ext cx="5852160" cy="365760"/>
+          </a:xfrm>
+          <a:prstGeom prst="rect">
+            <a:avLst/>
+          </a:prstGeom>
+          <a:solidFill>
+            <a:srgbClr val="C0392B"/>
+          </a:solidFill>
+          <a:ln>
+            <a:noFill/>
+          </a:ln>
+        </p:spPr>
+        <p:style>
+          <a:lnRef idx="1">
+            <a:schemeClr val="accent1"/>
+          </a:lnRef>
+          <a:fillRef idx="3">
+            <a:schemeClr val="accent1"/>
+          </a:fillRef>
+          <a:effectRef idx="2">
+            <a:schemeClr val="accent1"/>
+          </a:effectRef>
+          <a:fontRef idx="minor">
+            <a:schemeClr val="lt1"/>
+          </a:fontRef>
+        </p:style>
+        <p:txBody>
+          <a:bodyPr rtlCol="0" anchor="ctr" wrap="square" lIns="50800" rIns="50800" tIns="25400" bIns="25400"/>
+          <a:lstStyle/>
+          <a:p>
+            <a:pPr algn="ctr"/>
+            <a:r>
+              <a:rPr sz="1200" b="1">
+                <a:solidFill>
+                  <a:srgbClr val="FFFFFF"/>
+                </a:solidFill>
+                <a:latin typeface="Meiryo"/>
+              </a:rPr>
+              <a:t>銀行/企業側（ここでしか止められない）</a:t>
+            </a:r>
+          </a:p>
+        </p:txBody>
+      </p:sp>
+      <p:sp>
+        <p:nvSpPr>
+          <p:cNvPr id="43" name="Rectangle 42"/>
+          <p:cNvSpPr/>
+          <p:nvPr/>
+        </p:nvSpPr>
+        <p:spPr>
+          <a:xfrm>
+            <a:off x="6858000" y="6309360"/>
+            <a:ext cx="5852160" cy="1463040"/>
+          </a:xfrm>
+          <a:prstGeom prst="rect">
+            <a:avLst/>
+          </a:prstGeom>
+          <a:solidFill>
+            <a:srgbClr val="FFFFFF"/>
+          </a:solidFill>
+          <a:ln w="25400">
+            <a:solidFill>
+              <a:srgbClr val="C0392B"/>
+            </a:solidFill>
+          </a:ln>
+        </p:spPr>
+        <p:style>
+          <a:lnRef idx="1">
+            <a:schemeClr val="accent1"/>
+          </a:lnRef>
+          <a:fillRef idx="3">
+            <a:schemeClr val="accent1"/>
+          </a:fillRef>
+          <a:effectRef idx="2">
+            <a:schemeClr val="accent1"/>
+          </a:effectRef>
+          <a:fontRef idx="minor">
+            <a:schemeClr val="lt1"/>
+          </a:fontRef>
+        </p:style>
+        <p:txBody>
+          <a:bodyPr rtlCol="0" anchor="ctr" wrap="square" lIns="63500" rIns="50800" tIns="38100" bIns="38100"/>
+          <a:lstStyle/>
+          <a:p>
+            <a:pPr algn="l"/>
+            <a:r>
+              <a:rPr sz="1000" b="0">
+                <a:solidFill>
+                  <a:srgbClr val="222222"/>
+                </a:solidFill>
+                <a:latin typeface="Meiryo"/>
+              </a:rPr>
+              <a:t>① ScreenConnectの通信をNWで検知
+② 送金時の振る舞い検知（時間帯、金額、送金先）
+③ 架電を廃止し「電話では手続きしない」と宣言
+④ リモートツール実行をEDRでブロック
+⑤ SMS認証のリンク先ドメインをホワイトリスト化</a:t>
+            </a:r>
+          </a:p>
+        </p:txBody>
+      </p:sp>
+      <p:sp>
+        <p:nvSpPr>
+          <p:cNvPr id="44" name="Rectangle 43"/>
+          <p:cNvSpPr/>
+          <p:nvPr/>
+        </p:nvSpPr>
+        <p:spPr>
+          <a:xfrm>
+            <a:off x="731520" y="7955279"/>
+            <a:ext cx="11978640" cy="457200"/>
+          </a:xfrm>
+          <a:prstGeom prst="rect">
+            <a:avLst/>
+          </a:prstGeom>
+          <a:solidFill>
+            <a:srgbClr val="222222"/>
+          </a:solidFill>
+          <a:ln>
+            <a:noFill/>
+          </a:ln>
+        </p:spPr>
+        <p:style>
+          <a:lnRef idx="1">
+            <a:schemeClr val="accent1"/>
+          </a:lnRef>
+          <a:fillRef idx="3">
+            <a:schemeClr val="accent1"/>
+          </a:fillRef>
+          <a:effectRef idx="2">
+            <a:schemeClr val="accent1"/>
+          </a:effectRef>
+          <a:fontRef idx="minor">
+            <a:schemeClr val="lt1"/>
+          </a:fontRef>
+        </p:style>
+        <p:txBody>
+          <a:bodyPr rtlCol="0" anchor="ctr" wrap="square" lIns="50800" rIns="50800" tIns="25400" bIns="25400"/>
+          <a:lstStyle/>
+          <a:p>
+            <a:pPr algn="ctr"/>
+            <a:r>
+              <a:rPr sz="1400" b="1">
+                <a:solidFill>
+                  <a:srgbClr val="FFFFFF"/>
+                </a:solidFill>
+                <a:latin typeface="Meiryo"/>
+              </a:rPr>
+              <a:t>結論：「顧客が気をつければ防げる」は幻想 — 銀行側のシステム対策でしか止められない</a:t>
+            </a:r>
+          </a:p>
+        </p:txBody>
+      </p:sp>
+      <p:sp>
+        <p:nvSpPr>
+          <p:cNvPr id="45" name="TextBox 44"/>
+          <p:cNvSpPr txBox="1"/>
+          <p:nvPr/>
+        </p:nvSpPr>
+        <p:spPr>
+          <a:xfrm>
+            <a:off x="9144000" y="10378440"/>
+            <a:ext cx="5943600" cy="228600"/>
+          </a:xfrm>
+          <a:prstGeom prst="rect">
+            <a:avLst/>
+          </a:prstGeom>
+          <a:noFill/>
+        </p:spPr>
+        <p:txBody>
+          <a:bodyPr wrap="square" lIns="50800" rIns="50800" tIns="38100" bIns="38100"/>
+          <a:lstStyle/>
+          <a:p>
+            <a:pPr algn="r"/>
+            <a:r>
+              <a:rPr sz="700" b="0">
+                <a:solidFill>
+                  <a:srgbClr val="888888"/>
+                </a:solidFill>
+                <a:latin typeface="Meiryo"/>
+              </a:rPr>
+              <a:t>Fraud Kill Chain — 顧客は見破れるか</a:t>
             </a:r>
           </a:p>
         </p:txBody>

</xml_diff>

<commit_message>
Add slide 5: one continuous phone call controls the entire attack
Shows that all 9 steps happen within a single unbroken phone call,
preventing the victim from thinking, consulting others, or verifying.
Lists 5 effects of keeping the line open and what happens if it drops.

https://claude.ai/code/session_01F7t8LKifK43o6sCdF2a3gQ
</commit_message>
<xml_diff>
--- a/Fraud_Kill_Chain.pptx
+++ b/Fraud_Kill_Chain.pptx
@@ -9,6 +9,7 @@
     <p:sldId id="257" r:id="rId8"/>
     <p:sldId id="258" r:id="rId9"/>
     <p:sldId id="259" r:id="rId10"/>
+    <p:sldId id="260" r:id="rId11"/>
   </p:sldIdLst>
   <p:sldSz cx="15124176" cy="10689336" type="screen4x3"/>
   <p:notesSz cx="6858000" cy="9144000"/>
@@ -12108,6 +12109,1532 @@
                 <a:latin typeface="Meiryo"/>
               </a:rPr>
               <a:t>Fraud Kill Chain — 顧客は見破れるか</a:t>
+            </a:r>
+          </a:p>
+        </p:txBody>
+      </p:sp>
+    </p:spTree>
+  </p:cSld>
+  <p:clrMapOvr>
+    <a:masterClrMapping/>
+  </p:clrMapOvr>
+</p:sld>
+</file>
+
+<file path=ppt/slides/slide5.xml><?xml version="1.0" encoding="utf-8"?>
+<p:sld xmlns:a="http://schemas.openxmlformats.org/drawingml/2006/main" xmlns:p="http://schemas.openxmlformats.org/presentationml/2006/main" xmlns:r="http://schemas.openxmlformats.org/officeDocument/2006/relationships">
+  <p:cSld>
+    <p:bg>
+      <p:bgPr>
+        <a:solidFill>
+          <a:srgbClr val="F5F5F5"/>
+        </a:solidFill>
+        <a:effectLst/>
+      </p:bgPr>
+    </p:bg>
+    <p:spTree>
+      <p:nvGrpSpPr>
+        <p:cNvPr id="1" name=""/>
+        <p:cNvGrpSpPr/>
+        <p:nvPr/>
+      </p:nvGrpSpPr>
+      <p:grpSpPr/>
+      <p:sp>
+        <p:nvSpPr>
+          <p:cNvPr id="2" name="TextBox 1"/>
+          <p:cNvSpPr txBox="1"/>
+          <p:nvPr/>
+        </p:nvSpPr>
+        <p:spPr>
+          <a:xfrm>
+            <a:off x="0" y="182880"/>
+            <a:ext cx="15124176" cy="548640"/>
+          </a:xfrm>
+          <a:prstGeom prst="rect">
+            <a:avLst/>
+          </a:prstGeom>
+          <a:noFill/>
+        </p:spPr>
+        <p:txBody>
+          <a:bodyPr wrap="square" lIns="50800" rIns="50800" tIns="38100" bIns="38100"/>
+          <a:lstStyle/>
+          <a:p>
+            <a:pPr algn="ctr"/>
+            <a:r>
+              <a:rPr sz="2400" b="1">
+                <a:solidFill>
+                  <a:srgbClr val="C0392B"/>
+                </a:solidFill>
+                <a:latin typeface="Meiryo"/>
+              </a:rPr>
+              <a:t>1本の電話 — つないだまま全手順を完了させる</a:t>
+            </a:r>
+          </a:p>
+        </p:txBody>
+      </p:sp>
+      <p:sp>
+        <p:nvSpPr>
+          <p:cNvPr id="3" name="TextBox 2"/>
+          <p:cNvSpPr txBox="1"/>
+          <p:nvPr/>
+        </p:nvSpPr>
+        <p:spPr>
+          <a:xfrm>
+            <a:off x="0" y="685800"/>
+            <a:ext cx="15124176" cy="365760"/>
+          </a:xfrm>
+          <a:prstGeom prst="rect">
+            <a:avLst/>
+          </a:prstGeom>
+          <a:noFill/>
+        </p:spPr>
+        <p:txBody>
+          <a:bodyPr wrap="square" lIns="50800" rIns="50800" tIns="38100" bIns="38100"/>
+          <a:lstStyle/>
+          <a:p>
+            <a:pPr algn="ctr"/>
+            <a:r>
+              <a:rPr sz="1200" b="0">
+                <a:solidFill>
+                  <a:srgbClr val="888888"/>
+                </a:solidFill>
+                <a:latin typeface="Meiryo"/>
+              </a:rPr>
+              <a:t>この攻撃は「9つの手順」ではなく、1本の電話の中で起きる1つの連続した攻撃である。</a:t>
+            </a:r>
+          </a:p>
+        </p:txBody>
+      </p:sp>
+      <p:sp>
+        <p:nvSpPr>
+          <p:cNvPr id="4" name="Rectangle 3"/>
+          <p:cNvSpPr/>
+          <p:nvPr/>
+        </p:nvSpPr>
+        <p:spPr>
+          <a:xfrm>
+            <a:off x="914400" y="1188720"/>
+            <a:ext cx="5029200" cy="384048"/>
+          </a:xfrm>
+          <a:prstGeom prst="rect">
+            <a:avLst/>
+          </a:prstGeom>
+          <a:solidFill>
+            <a:srgbClr val="FFFFFF"/>
+          </a:solidFill>
+          <a:ln w="25400">
+            <a:solidFill>
+              <a:srgbClr val="CCCCCC"/>
+            </a:solidFill>
+          </a:ln>
+        </p:spPr>
+        <p:style>
+          <a:lnRef idx="1">
+            <a:schemeClr val="accent1"/>
+          </a:lnRef>
+          <a:fillRef idx="3">
+            <a:schemeClr val="accent1"/>
+          </a:fillRef>
+          <a:effectRef idx="2">
+            <a:schemeClr val="accent1"/>
+          </a:effectRef>
+          <a:fontRef idx="minor">
+            <a:schemeClr val="lt1"/>
+          </a:fontRef>
+        </p:style>
+        <p:txBody>
+          <a:bodyPr rtlCol="0" anchor="ctr" wrap="square" lIns="63500" rIns="50800" tIns="38100" bIns="38100"/>
+          <a:lstStyle/>
+          <a:p>
+            <a:pPr algn="l"/>
+            <a:r>
+              <a:rPr sz="1000" b="0">
+                <a:solidFill>
+                  <a:srgbClr val="222222"/>
+                </a:solidFill>
+                <a:latin typeface="Meiryo"/>
+              </a:rPr>
+              <a:t>①  自動音声で架電</a:t>
+            </a:r>
+          </a:p>
+        </p:txBody>
+      </p:sp>
+      <p:sp>
+        <p:nvSpPr>
+          <p:cNvPr id="5" name="Rectangle 4"/>
+          <p:cNvSpPr/>
+          <p:nvPr/>
+        </p:nvSpPr>
+        <p:spPr>
+          <a:xfrm>
+            <a:off x="914400" y="1600200"/>
+            <a:ext cx="5029200" cy="384048"/>
+          </a:xfrm>
+          <a:prstGeom prst="rect">
+            <a:avLst/>
+          </a:prstGeom>
+          <a:solidFill>
+            <a:srgbClr val="FFFFFF"/>
+          </a:solidFill>
+          <a:ln w="25400">
+            <a:solidFill>
+              <a:srgbClr val="CCCCCC"/>
+            </a:solidFill>
+          </a:ln>
+        </p:spPr>
+        <p:style>
+          <a:lnRef idx="1">
+            <a:schemeClr val="accent1"/>
+          </a:lnRef>
+          <a:fillRef idx="3">
+            <a:schemeClr val="accent1"/>
+          </a:fillRef>
+          <a:effectRef idx="2">
+            <a:schemeClr val="accent1"/>
+          </a:effectRef>
+          <a:fontRef idx="minor">
+            <a:schemeClr val="lt1"/>
+          </a:fontRef>
+        </p:style>
+        <p:txBody>
+          <a:bodyPr rtlCol="0" anchor="ctr" wrap="square" lIns="63500" rIns="50800" tIns="38100" bIns="38100"/>
+          <a:lstStyle/>
+          <a:p>
+            <a:pPr algn="l"/>
+            <a:r>
+              <a:rPr sz="1000" b="0">
+                <a:solidFill>
+                  <a:srgbClr val="222222"/>
+                </a:solidFill>
+                <a:latin typeface="Meiryo"/>
+              </a:rPr>
+              <a:t>②  心理操作（口座制限中）</a:t>
+            </a:r>
+          </a:p>
+        </p:txBody>
+      </p:sp>
+      <p:sp>
+        <p:nvSpPr>
+          <p:cNvPr id="6" name="Rectangle 5"/>
+          <p:cNvSpPr/>
+          <p:nvPr/>
+        </p:nvSpPr>
+        <p:spPr>
+          <a:xfrm>
+            <a:off x="914400" y="2011680"/>
+            <a:ext cx="5029200" cy="384048"/>
+          </a:xfrm>
+          <a:prstGeom prst="rect">
+            <a:avLst/>
+          </a:prstGeom>
+          <a:solidFill>
+            <a:srgbClr val="FFFFFF"/>
+          </a:solidFill>
+          <a:ln w="25400">
+            <a:solidFill>
+              <a:srgbClr val="CCCCCC"/>
+            </a:solidFill>
+          </a:ln>
+        </p:spPr>
+        <p:style>
+          <a:lnRef idx="1">
+            <a:schemeClr val="accent1"/>
+          </a:lnRef>
+          <a:fillRef idx="3">
+            <a:schemeClr val="accent1"/>
+          </a:fillRef>
+          <a:effectRef idx="2">
+            <a:schemeClr val="accent1"/>
+          </a:effectRef>
+          <a:fontRef idx="minor">
+            <a:schemeClr val="lt1"/>
+          </a:fontRef>
+        </p:style>
+        <p:txBody>
+          <a:bodyPr rtlCol="0" anchor="ctr" wrap="square" lIns="63500" rIns="50800" tIns="38100" bIns="38100"/>
+          <a:lstStyle/>
+          <a:p>
+            <a:pPr algn="l"/>
+            <a:r>
+              <a:rPr sz="1000" b="0">
+                <a:solidFill>
+                  <a:srgbClr val="222222"/>
+                </a:solidFill>
+                <a:latin typeface="Meiryo"/>
+              </a:rPr>
+              <a:t>③  メアド聞き出し＋メール送付</a:t>
+            </a:r>
+          </a:p>
+        </p:txBody>
+      </p:sp>
+      <p:sp>
+        <p:nvSpPr>
+          <p:cNvPr id="7" name="Rectangle 6"/>
+          <p:cNvSpPr/>
+          <p:nvPr/>
+        </p:nvSpPr>
+        <p:spPr>
+          <a:xfrm>
+            <a:off x="914400" y="2423160"/>
+            <a:ext cx="5029200" cy="384048"/>
+          </a:xfrm>
+          <a:prstGeom prst="rect">
+            <a:avLst/>
+          </a:prstGeom>
+          <a:solidFill>
+            <a:srgbClr val="FFFFFF"/>
+          </a:solidFill>
+          <a:ln w="25400">
+            <a:solidFill>
+              <a:srgbClr val="CCCCCC"/>
+            </a:solidFill>
+          </a:ln>
+        </p:spPr>
+        <p:style>
+          <a:lnRef idx="1">
+            <a:schemeClr val="accent1"/>
+          </a:lnRef>
+          <a:fillRef idx="3">
+            <a:schemeClr val="accent1"/>
+          </a:fillRef>
+          <a:effectRef idx="2">
+            <a:schemeClr val="accent1"/>
+          </a:effectRef>
+          <a:fontRef idx="minor">
+            <a:schemeClr val="lt1"/>
+          </a:fontRef>
+        </p:style>
+        <p:txBody>
+          <a:bodyPr rtlCol="0" anchor="ctr" wrap="square" lIns="63500" rIns="50800" tIns="38100" bIns="38100"/>
+          <a:lstStyle/>
+          <a:p>
+            <a:pPr algn="l"/>
+            <a:r>
+              <a:rPr sz="1000" b="0">
+                <a:solidFill>
+                  <a:srgbClr val="222222"/>
+                </a:solidFill>
+                <a:latin typeface="Meiryo"/>
+              </a:rPr>
+              <a:t>④  「メールを開いてください」</a:t>
+            </a:r>
+          </a:p>
+        </p:txBody>
+      </p:sp>
+      <p:sp>
+        <p:nvSpPr>
+          <p:cNvPr id="8" name="Rectangle 7"/>
+          <p:cNvSpPr/>
+          <p:nvPr/>
+        </p:nvSpPr>
+        <p:spPr>
+          <a:xfrm>
+            <a:off x="914400" y="2834639"/>
+            <a:ext cx="5029200" cy="384048"/>
+          </a:xfrm>
+          <a:prstGeom prst="rect">
+            <a:avLst/>
+          </a:prstGeom>
+          <a:solidFill>
+            <a:srgbClr val="FFFFFF"/>
+          </a:solidFill>
+          <a:ln w="25400">
+            <a:solidFill>
+              <a:srgbClr val="CCCCCC"/>
+            </a:solidFill>
+          </a:ln>
+        </p:spPr>
+        <p:style>
+          <a:lnRef idx="1">
+            <a:schemeClr val="accent1"/>
+          </a:lnRef>
+          <a:fillRef idx="3">
+            <a:schemeClr val="accent1"/>
+          </a:fillRef>
+          <a:effectRef idx="2">
+            <a:schemeClr val="accent1"/>
+          </a:effectRef>
+          <a:fontRef idx="minor">
+            <a:schemeClr val="lt1"/>
+          </a:fontRef>
+        </p:style>
+        <p:txBody>
+          <a:bodyPr rtlCol="0" anchor="ctr" wrap="square" lIns="63500" rIns="50800" tIns="38100" bIns="38100"/>
+          <a:lstStyle/>
+          <a:p>
+            <a:pPr algn="l"/>
+            <a:r>
+              <a:rPr sz="1000" b="0">
+                <a:solidFill>
+                  <a:srgbClr val="222222"/>
+                </a:solidFill>
+                <a:latin typeface="Meiryo"/>
+              </a:rPr>
+              <a:t>⑤  「インストールしてください」</a:t>
+            </a:r>
+          </a:p>
+        </p:txBody>
+      </p:sp>
+      <p:sp>
+        <p:nvSpPr>
+          <p:cNvPr id="9" name="Rectangle 8"/>
+          <p:cNvSpPr/>
+          <p:nvPr/>
+        </p:nvSpPr>
+        <p:spPr>
+          <a:xfrm>
+            <a:off x="914400" y="3246120"/>
+            <a:ext cx="5029200" cy="384048"/>
+          </a:xfrm>
+          <a:prstGeom prst="rect">
+            <a:avLst/>
+          </a:prstGeom>
+          <a:solidFill>
+            <a:srgbClr val="FFFFFF"/>
+          </a:solidFill>
+          <a:ln w="25400">
+            <a:solidFill>
+              <a:srgbClr val="CCCCCC"/>
+            </a:solidFill>
+          </a:ln>
+        </p:spPr>
+        <p:style>
+          <a:lnRef idx="1">
+            <a:schemeClr val="accent1"/>
+          </a:lnRef>
+          <a:fillRef idx="3">
+            <a:schemeClr val="accent1"/>
+          </a:fillRef>
+          <a:effectRef idx="2">
+            <a:schemeClr val="accent1"/>
+          </a:effectRef>
+          <a:fontRef idx="minor">
+            <a:schemeClr val="lt1"/>
+          </a:fontRef>
+        </p:style>
+        <p:txBody>
+          <a:bodyPr rtlCol="0" anchor="ctr" wrap="square" lIns="63500" rIns="50800" tIns="38100" bIns="38100"/>
+          <a:lstStyle/>
+          <a:p>
+            <a:pPr algn="l"/>
+            <a:r>
+              <a:rPr sz="1000" b="0">
+                <a:solidFill>
+                  <a:srgbClr val="222222"/>
+                </a:solidFill>
+                <a:latin typeface="Meiryo"/>
+              </a:rPr>
+              <a:t>⑥  「実行してください」</a:t>
+            </a:r>
+          </a:p>
+        </p:txBody>
+      </p:sp>
+      <p:sp>
+        <p:nvSpPr>
+          <p:cNvPr id="10" name="Rectangle 9"/>
+          <p:cNvSpPr/>
+          <p:nvPr/>
+        </p:nvSpPr>
+        <p:spPr>
+          <a:xfrm>
+            <a:off x="914400" y="3657600"/>
+            <a:ext cx="5029200" cy="384048"/>
+          </a:xfrm>
+          <a:prstGeom prst="rect">
+            <a:avLst/>
+          </a:prstGeom>
+          <a:solidFill>
+            <a:srgbClr val="FFFFFF"/>
+          </a:solidFill>
+          <a:ln w="25400">
+            <a:solidFill>
+              <a:srgbClr val="CCCCCC"/>
+            </a:solidFill>
+          </a:ln>
+        </p:spPr>
+        <p:style>
+          <a:lnRef idx="1">
+            <a:schemeClr val="accent1"/>
+          </a:lnRef>
+          <a:fillRef idx="3">
+            <a:schemeClr val="accent1"/>
+          </a:fillRef>
+          <a:effectRef idx="2">
+            <a:schemeClr val="accent1"/>
+          </a:effectRef>
+          <a:fontRef idx="minor">
+            <a:schemeClr val="lt1"/>
+          </a:fontRef>
+        </p:style>
+        <p:txBody>
+          <a:bodyPr rtlCol="0" anchor="ctr" wrap="square" lIns="63500" rIns="50800" tIns="38100" bIns="38100"/>
+          <a:lstStyle/>
+          <a:p>
+            <a:pPr algn="l"/>
+            <a:r>
+              <a:rPr sz="1000" b="0">
+                <a:solidFill>
+                  <a:srgbClr val="222222"/>
+                </a:solidFill>
+                <a:latin typeface="Meiryo"/>
+              </a:rPr>
+              <a:t>⑦  赤い画面表示</a:t>
+            </a:r>
+          </a:p>
+        </p:txBody>
+      </p:sp>
+      <p:sp>
+        <p:nvSpPr>
+          <p:cNvPr id="11" name="Rectangle 10"/>
+          <p:cNvSpPr/>
+          <p:nvPr/>
+        </p:nvSpPr>
+        <p:spPr>
+          <a:xfrm>
+            <a:off x="914400" y="4069079"/>
+            <a:ext cx="5029200" cy="384048"/>
+          </a:xfrm>
+          <a:prstGeom prst="rect">
+            <a:avLst/>
+          </a:prstGeom>
+          <a:solidFill>
+            <a:srgbClr val="FFFFFF"/>
+          </a:solidFill>
+          <a:ln w="25400">
+            <a:solidFill>
+              <a:srgbClr val="CCCCCC"/>
+            </a:solidFill>
+          </a:ln>
+        </p:spPr>
+        <p:style>
+          <a:lnRef idx="1">
+            <a:schemeClr val="accent1"/>
+          </a:lnRef>
+          <a:fillRef idx="3">
+            <a:schemeClr val="accent1"/>
+          </a:fillRef>
+          <a:effectRef idx="2">
+            <a:schemeClr val="accent1"/>
+          </a:effectRef>
+          <a:fontRef idx="minor">
+            <a:schemeClr val="lt1"/>
+          </a:fontRef>
+        </p:style>
+        <p:txBody>
+          <a:bodyPr rtlCol="0" anchor="ctr" wrap="square" lIns="63500" rIns="50800" tIns="38100" bIns="38100"/>
+          <a:lstStyle/>
+          <a:p>
+            <a:pPr algn="l"/>
+            <a:r>
+              <a:rPr sz="1000" b="0">
+                <a:solidFill>
+                  <a:srgbClr val="222222"/>
+                </a:solidFill>
+                <a:latin typeface="Meiryo"/>
+              </a:rPr>
+              <a:t>⑧  「携帯番号を教えて」</a:t>
+            </a:r>
+          </a:p>
+        </p:txBody>
+      </p:sp>
+      <p:sp>
+        <p:nvSpPr>
+          <p:cNvPr id="12" name="Rectangle 11"/>
+          <p:cNvSpPr/>
+          <p:nvPr/>
+        </p:nvSpPr>
+        <p:spPr>
+          <a:xfrm>
+            <a:off x="914400" y="4480559"/>
+            <a:ext cx="5029200" cy="384048"/>
+          </a:xfrm>
+          <a:prstGeom prst="rect">
+            <a:avLst/>
+          </a:prstGeom>
+          <a:solidFill>
+            <a:srgbClr val="FFFFFF"/>
+          </a:solidFill>
+          <a:ln w="25400">
+            <a:solidFill>
+              <a:srgbClr val="CCCCCC"/>
+            </a:solidFill>
+          </a:ln>
+        </p:spPr>
+        <p:style>
+          <a:lnRef idx="1">
+            <a:schemeClr val="accent1"/>
+          </a:lnRef>
+          <a:fillRef idx="3">
+            <a:schemeClr val="accent1"/>
+          </a:fillRef>
+          <a:effectRef idx="2">
+            <a:schemeClr val="accent1"/>
+          </a:effectRef>
+          <a:fontRef idx="minor">
+            <a:schemeClr val="lt1"/>
+          </a:fontRef>
+        </p:style>
+        <p:txBody>
+          <a:bodyPr rtlCol="0" anchor="ctr" wrap="square" lIns="63500" rIns="50800" tIns="38100" bIns="38100"/>
+          <a:lstStyle/>
+          <a:p>
+            <a:pPr algn="l"/>
+            <a:r>
+              <a:rPr sz="1000" b="0">
+                <a:solidFill>
+                  <a:srgbClr val="222222"/>
+                </a:solidFill>
+                <a:latin typeface="Meiryo"/>
+              </a:rPr>
+              <a:t>⑨  「認証情報を入力して」</a:t>
+            </a:r>
+          </a:p>
+        </p:txBody>
+      </p:sp>
+      <p:sp>
+        <p:nvSpPr>
+          <p:cNvPr id="13" name="Rectangle 12"/>
+          <p:cNvSpPr/>
+          <p:nvPr/>
+        </p:nvSpPr>
+        <p:spPr>
+          <a:xfrm>
+            <a:off x="914400" y="4892040"/>
+            <a:ext cx="5029200" cy="384048"/>
+          </a:xfrm>
+          <a:prstGeom prst="rect">
+            <a:avLst/>
+          </a:prstGeom>
+          <a:solidFill>
+            <a:srgbClr val="C0392B"/>
+          </a:solidFill>
+          <a:ln>
+            <a:noFill/>
+          </a:ln>
+        </p:spPr>
+        <p:style>
+          <a:lnRef idx="1">
+            <a:schemeClr val="accent1"/>
+          </a:lnRef>
+          <a:fillRef idx="3">
+            <a:schemeClr val="accent1"/>
+          </a:fillRef>
+          <a:effectRef idx="2">
+            <a:schemeClr val="accent1"/>
+          </a:effectRef>
+          <a:fontRef idx="minor">
+            <a:schemeClr val="lt1"/>
+          </a:fontRef>
+        </p:style>
+        <p:txBody>
+          <a:bodyPr rtlCol="0" anchor="ctr" wrap="square" lIns="50800" rIns="50800" tIns="25400" bIns="25400"/>
+          <a:lstStyle/>
+          <a:p>
+            <a:pPr algn="l"/>
+            <a:r>
+              <a:rPr sz="1100" b="1">
+                <a:solidFill>
+                  <a:srgbClr val="FFFFFF"/>
+                </a:solidFill>
+                <a:latin typeface="Meiryo"/>
+              </a:rPr>
+              <a:t>  不正送金</a:t>
+            </a:r>
+          </a:p>
+        </p:txBody>
+      </p:sp>
+      <p:sp>
+        <p:nvSpPr>
+          <p:cNvPr id="14" name="Rectangle 13"/>
+          <p:cNvSpPr/>
+          <p:nvPr/>
+        </p:nvSpPr>
+        <p:spPr>
+          <a:xfrm>
+            <a:off x="6126480" y="1188720"/>
+            <a:ext cx="457200" cy="4087368"/>
+          </a:xfrm>
+          <a:prstGeom prst="rect">
+            <a:avLst/>
+          </a:prstGeom>
+          <a:solidFill>
+            <a:srgbClr val="C0392B"/>
+          </a:solidFill>
+          <a:ln>
+            <a:noFill/>
+          </a:ln>
+        </p:spPr>
+        <p:style>
+          <a:lnRef idx="1">
+            <a:schemeClr val="accent1"/>
+          </a:lnRef>
+          <a:fillRef idx="3">
+            <a:schemeClr val="accent1"/>
+          </a:fillRef>
+          <a:effectRef idx="2">
+            <a:schemeClr val="accent1"/>
+          </a:effectRef>
+          <a:fontRef idx="minor">
+            <a:schemeClr val="lt1"/>
+          </a:fontRef>
+        </p:style>
+        <p:txBody>
+          <a:bodyPr rtlCol="0" anchor="ctr" wrap="square" lIns="50800" rIns="50800" tIns="25400" bIns="25400"/>
+          <a:lstStyle/>
+          <a:p>
+            <a:pPr algn="ctr"/>
+            <a:r>
+              <a:rPr sz="100" b="1">
+                <a:solidFill>
+                  <a:srgbClr val="FFFFFF"/>
+                </a:solidFill>
+                <a:latin typeface="Meiryo"/>
+              </a:rPr>
+              <a:t/>
+            </a:r>
+          </a:p>
+        </p:txBody>
+      </p:sp>
+      <p:sp>
+        <p:nvSpPr>
+          <p:cNvPr id="15" name="TextBox 14"/>
+          <p:cNvSpPr txBox="1"/>
+          <p:nvPr/>
+        </p:nvSpPr>
+        <p:spPr>
+          <a:xfrm>
+            <a:off x="6035040" y="1280160"/>
+            <a:ext cx="640080" cy="274320"/>
+          </a:xfrm>
+          <a:prstGeom prst="rect">
+            <a:avLst/>
+          </a:prstGeom>
+          <a:noFill/>
+        </p:spPr>
+        <p:txBody>
+          <a:bodyPr wrap="square" lIns="50800" rIns="50800" tIns="38100" bIns="38100"/>
+          <a:lstStyle/>
+          <a:p>
+            <a:pPr algn="ctr"/>
+            <a:r>
+              <a:rPr sz="800" b="1">
+                <a:solidFill>
+                  <a:srgbClr val="FFFFFF"/>
+                </a:solidFill>
+                <a:latin typeface="Meiryo"/>
+              </a:rPr>
+              <a:t>電話接続</a:t>
+            </a:r>
+          </a:p>
+        </p:txBody>
+      </p:sp>
+      <p:sp>
+        <p:nvSpPr>
+          <p:cNvPr id="16" name="TextBox 15"/>
+          <p:cNvSpPr txBox="1"/>
+          <p:nvPr/>
+        </p:nvSpPr>
+        <p:spPr>
+          <a:xfrm>
+            <a:off x="5852160" y="2823667"/>
+            <a:ext cx="1005840" cy="457200"/>
+          </a:xfrm>
+          <a:prstGeom prst="rect">
+            <a:avLst/>
+          </a:prstGeom>
+          <a:noFill/>
+        </p:spPr>
+        <p:txBody>
+          <a:bodyPr wrap="square" lIns="50800" rIns="50800" tIns="38100" bIns="38100"/>
+          <a:lstStyle/>
+          <a:p>
+            <a:pPr algn="ctr"/>
+            <a:r>
+              <a:rPr sz="900" b="1">
+                <a:solidFill>
+                  <a:srgbClr val="FFFFFF"/>
+                </a:solidFill>
+                <a:latin typeface="Meiryo"/>
+              </a:rPr>
+              <a:t>ずっと
+電話が
+つながっている</a:t>
+            </a:r>
+          </a:p>
+        </p:txBody>
+      </p:sp>
+      <p:sp>
+        <p:nvSpPr>
+          <p:cNvPr id="17" name="Rectangle 16"/>
+          <p:cNvSpPr/>
+          <p:nvPr/>
+        </p:nvSpPr>
+        <p:spPr>
+          <a:xfrm>
+            <a:off x="7315200" y="1188720"/>
+            <a:ext cx="6858000" cy="502920"/>
+          </a:xfrm>
+          <a:prstGeom prst="rect">
+            <a:avLst/>
+          </a:prstGeom>
+          <a:solidFill>
+            <a:srgbClr val="222222"/>
+          </a:solidFill>
+          <a:ln>
+            <a:noFill/>
+          </a:ln>
+        </p:spPr>
+        <p:style>
+          <a:lnRef idx="1">
+            <a:schemeClr val="accent1"/>
+          </a:lnRef>
+          <a:fillRef idx="3">
+            <a:schemeClr val="accent1"/>
+          </a:fillRef>
+          <a:effectRef idx="2">
+            <a:schemeClr val="accent1"/>
+          </a:effectRef>
+          <a:fontRef idx="minor">
+            <a:schemeClr val="lt1"/>
+          </a:fontRef>
+        </p:style>
+        <p:txBody>
+          <a:bodyPr rtlCol="0" anchor="ctr" wrap="square" lIns="50800" rIns="50800" tIns="25400" bIns="25400"/>
+          <a:lstStyle/>
+          <a:p>
+            <a:pPr algn="ctr"/>
+            <a:r>
+              <a:rPr sz="1300" b="1">
+                <a:solidFill>
+                  <a:srgbClr val="FFFFFF"/>
+                </a:solidFill>
+                <a:latin typeface="Meiryo"/>
+              </a:rPr>
+              <a:t>電話をつないだままにする5つの効果</a:t>
+            </a:r>
+          </a:p>
+        </p:txBody>
+      </p:sp>
+      <p:sp>
+        <p:nvSpPr>
+          <p:cNvPr id="18" name="Rectangle 17"/>
+          <p:cNvSpPr/>
+          <p:nvPr/>
+        </p:nvSpPr>
+        <p:spPr>
+          <a:xfrm>
+            <a:off x="7315200" y="1691640"/>
+            <a:ext cx="2286000" cy="502920"/>
+          </a:xfrm>
+          <a:prstGeom prst="rect">
+            <a:avLst/>
+          </a:prstGeom>
+          <a:solidFill>
+            <a:srgbClr val="C0392B"/>
+          </a:solidFill>
+          <a:ln>
+            <a:noFill/>
+          </a:ln>
+        </p:spPr>
+        <p:style>
+          <a:lnRef idx="1">
+            <a:schemeClr val="accent1"/>
+          </a:lnRef>
+          <a:fillRef idx="3">
+            <a:schemeClr val="accent1"/>
+          </a:fillRef>
+          <a:effectRef idx="2">
+            <a:schemeClr val="accent1"/>
+          </a:effectRef>
+          <a:fontRef idx="minor">
+            <a:schemeClr val="lt1"/>
+          </a:fontRef>
+        </p:style>
+        <p:txBody>
+          <a:bodyPr rtlCol="0" anchor="ctr" wrap="square" lIns="50800" rIns="50800" tIns="25400" bIns="25400"/>
+          <a:lstStyle/>
+          <a:p>
+            <a:pPr algn="ctr"/>
+            <a:r>
+              <a:rPr sz="1000" b="1">
+                <a:solidFill>
+                  <a:srgbClr val="FFFFFF"/>
+                </a:solidFill>
+                <a:latin typeface="Meiryo"/>
+              </a:rPr>
+              <a:t>考える隙を与えない</a:t>
+            </a:r>
+          </a:p>
+        </p:txBody>
+      </p:sp>
+      <p:sp>
+        <p:nvSpPr>
+          <p:cNvPr id="19" name="Rectangle 18"/>
+          <p:cNvSpPr/>
+          <p:nvPr/>
+        </p:nvSpPr>
+        <p:spPr>
+          <a:xfrm>
+            <a:off x="9601200" y="1691640"/>
+            <a:ext cx="4572000" cy="502920"/>
+          </a:xfrm>
+          <a:prstGeom prst="rect">
+            <a:avLst/>
+          </a:prstGeom>
+          <a:solidFill>
+            <a:srgbClr val="FFFFFF"/>
+          </a:solidFill>
+          <a:ln w="25400">
+            <a:solidFill>
+              <a:srgbClr val="DDDDDD"/>
+            </a:solidFill>
+          </a:ln>
+        </p:spPr>
+        <p:style>
+          <a:lnRef idx="1">
+            <a:schemeClr val="accent1"/>
+          </a:lnRef>
+          <a:fillRef idx="3">
+            <a:schemeClr val="accent1"/>
+          </a:fillRef>
+          <a:effectRef idx="2">
+            <a:schemeClr val="accent1"/>
+          </a:effectRef>
+          <a:fontRef idx="minor">
+            <a:schemeClr val="lt1"/>
+          </a:fontRef>
+        </p:style>
+        <p:txBody>
+          <a:bodyPr rtlCol="0" anchor="ctr" wrap="square" lIns="63500" rIns="50800" tIns="38100" bIns="38100"/>
+          <a:lstStyle/>
+          <a:p>
+            <a:pPr algn="l"/>
+            <a:r>
+              <a:rPr sz="1000" b="0">
+                <a:solidFill>
+                  <a:srgbClr val="222222"/>
+                </a:solidFill>
+                <a:latin typeface="Meiryo"/>
+              </a:rPr>
+              <a:t>電話を切ったら冷静になる。切らせない</a:t>
+            </a:r>
+          </a:p>
+        </p:txBody>
+      </p:sp>
+      <p:sp>
+        <p:nvSpPr>
+          <p:cNvPr id="20" name="Rectangle 19"/>
+          <p:cNvSpPr/>
+          <p:nvPr/>
+        </p:nvSpPr>
+        <p:spPr>
+          <a:xfrm>
+            <a:off x="7315200" y="2194560"/>
+            <a:ext cx="2286000" cy="502920"/>
+          </a:xfrm>
+          <a:prstGeom prst="rect">
+            <a:avLst/>
+          </a:prstGeom>
+          <a:solidFill>
+            <a:srgbClr val="E67E22"/>
+          </a:solidFill>
+          <a:ln>
+            <a:noFill/>
+          </a:ln>
+        </p:spPr>
+        <p:style>
+          <a:lnRef idx="1">
+            <a:schemeClr val="accent1"/>
+          </a:lnRef>
+          <a:fillRef idx="3">
+            <a:schemeClr val="accent1"/>
+          </a:fillRef>
+          <a:effectRef idx="2">
+            <a:schemeClr val="accent1"/>
+          </a:effectRef>
+          <a:fontRef idx="minor">
+            <a:schemeClr val="lt1"/>
+          </a:fontRef>
+        </p:style>
+        <p:txBody>
+          <a:bodyPr rtlCol="0" anchor="ctr" wrap="square" lIns="50800" rIns="50800" tIns="25400" bIns="25400"/>
+          <a:lstStyle/>
+          <a:p>
+            <a:pPr algn="ctr"/>
+            <a:r>
+              <a:rPr sz="1000" b="1">
+                <a:solidFill>
+                  <a:srgbClr val="FFFFFF"/>
+                </a:solidFill>
+                <a:latin typeface="Meiryo"/>
+              </a:rPr>
+              <a:t>リアルタイム制御</a:t>
+            </a:r>
+          </a:p>
+        </p:txBody>
+      </p:sp>
+      <p:sp>
+        <p:nvSpPr>
+          <p:cNvPr id="21" name="Rectangle 20"/>
+          <p:cNvSpPr/>
+          <p:nvPr/>
+        </p:nvSpPr>
+        <p:spPr>
+          <a:xfrm>
+            <a:off x="9601200" y="2194560"/>
+            <a:ext cx="4572000" cy="502920"/>
+          </a:xfrm>
+          <a:prstGeom prst="rect">
+            <a:avLst/>
+          </a:prstGeom>
+          <a:solidFill>
+            <a:srgbClr val="F9F9F9"/>
+          </a:solidFill>
+          <a:ln w="25400">
+            <a:solidFill>
+              <a:srgbClr val="DDDDDD"/>
+            </a:solidFill>
+          </a:ln>
+        </p:spPr>
+        <p:style>
+          <a:lnRef idx="1">
+            <a:schemeClr val="accent1"/>
+          </a:lnRef>
+          <a:fillRef idx="3">
+            <a:schemeClr val="accent1"/>
+          </a:fillRef>
+          <a:effectRef idx="2">
+            <a:schemeClr val="accent1"/>
+          </a:effectRef>
+          <a:fontRef idx="minor">
+            <a:schemeClr val="lt1"/>
+          </a:fontRef>
+        </p:style>
+        <p:txBody>
+          <a:bodyPr rtlCol="0" anchor="ctr" wrap="square" lIns="63500" rIns="50800" tIns="38100" bIns="38100"/>
+          <a:lstStyle/>
+          <a:p>
+            <a:pPr algn="l"/>
+            <a:r>
+              <a:rPr sz="1000" b="0">
+                <a:solidFill>
+                  <a:srgbClr val="222222"/>
+                </a:solidFill>
+                <a:latin typeface="Meiryo"/>
+              </a:rPr>
+              <a:t>被害者の画面状況に合わせて次の指示を出せる</a:t>
+            </a:r>
+          </a:p>
+        </p:txBody>
+      </p:sp>
+      <p:sp>
+        <p:nvSpPr>
+          <p:cNvPr id="22" name="Rectangle 21"/>
+          <p:cNvSpPr/>
+          <p:nvPr/>
+        </p:nvSpPr>
+        <p:spPr>
+          <a:xfrm>
+            <a:off x="7315200" y="2697480"/>
+            <a:ext cx="2286000" cy="502920"/>
+          </a:xfrm>
+          <a:prstGeom prst="rect">
+            <a:avLst/>
+          </a:prstGeom>
+          <a:solidFill>
+            <a:srgbClr val="2980B9"/>
+          </a:solidFill>
+          <a:ln>
+            <a:noFill/>
+          </a:ln>
+        </p:spPr>
+        <p:style>
+          <a:lnRef idx="1">
+            <a:schemeClr val="accent1"/>
+          </a:lnRef>
+          <a:fillRef idx="3">
+            <a:schemeClr val="accent1"/>
+          </a:fillRef>
+          <a:effectRef idx="2">
+            <a:schemeClr val="accent1"/>
+          </a:effectRef>
+          <a:fontRef idx="minor">
+            <a:schemeClr val="lt1"/>
+          </a:fontRef>
+        </p:style>
+        <p:txBody>
+          <a:bodyPr rtlCol="0" anchor="ctr" wrap="square" lIns="50800" rIns="50800" tIns="25400" bIns="25400"/>
+          <a:lstStyle/>
+          <a:p>
+            <a:pPr algn="ctr"/>
+            <a:r>
+              <a:rPr sz="1000" b="1">
+                <a:solidFill>
+                  <a:srgbClr val="FFFFFF"/>
+                </a:solidFill>
+                <a:latin typeface="Meiryo"/>
+              </a:rPr>
+              <a:t>離脱防止</a:t>
+            </a:r>
+          </a:p>
+        </p:txBody>
+      </p:sp>
+      <p:sp>
+        <p:nvSpPr>
+          <p:cNvPr id="23" name="Rectangle 22"/>
+          <p:cNvSpPr/>
+          <p:nvPr/>
+        </p:nvSpPr>
+        <p:spPr>
+          <a:xfrm>
+            <a:off x="9601200" y="2697480"/>
+            <a:ext cx="4572000" cy="502920"/>
+          </a:xfrm>
+          <a:prstGeom prst="rect">
+            <a:avLst/>
+          </a:prstGeom>
+          <a:solidFill>
+            <a:srgbClr val="FFFFFF"/>
+          </a:solidFill>
+          <a:ln w="25400">
+            <a:solidFill>
+              <a:srgbClr val="DDDDDD"/>
+            </a:solidFill>
+          </a:ln>
+        </p:spPr>
+        <p:style>
+          <a:lnRef idx="1">
+            <a:schemeClr val="accent1"/>
+          </a:lnRef>
+          <a:fillRef idx="3">
+            <a:schemeClr val="accent1"/>
+          </a:fillRef>
+          <a:effectRef idx="2">
+            <a:schemeClr val="accent1"/>
+          </a:effectRef>
+          <a:fontRef idx="minor">
+            <a:schemeClr val="lt1"/>
+          </a:fontRef>
+        </p:style>
+        <p:txBody>
+          <a:bodyPr rtlCol="0" anchor="ctr" wrap="square" lIns="63500" rIns="50800" tIns="38100" bIns="38100"/>
+          <a:lstStyle/>
+          <a:p>
+            <a:pPr algn="l"/>
+            <a:r>
+              <a:rPr sz="1000" b="0">
+                <a:solidFill>
+                  <a:srgbClr val="222222"/>
+                </a:solidFill>
+                <a:latin typeface="Meiryo"/>
+              </a:rPr>
+              <a:t>「このままお待ちください」で引き留められる</a:t>
+            </a:r>
+          </a:p>
+        </p:txBody>
+      </p:sp>
+      <p:sp>
+        <p:nvSpPr>
+          <p:cNvPr id="24" name="Rectangle 23"/>
+          <p:cNvSpPr/>
+          <p:nvPr/>
+        </p:nvSpPr>
+        <p:spPr>
+          <a:xfrm>
+            <a:off x="7315200" y="3200400"/>
+            <a:ext cx="2286000" cy="502920"/>
+          </a:xfrm>
+          <a:prstGeom prst="rect">
+            <a:avLst/>
+          </a:prstGeom>
+          <a:solidFill>
+            <a:srgbClr val="8E44AD"/>
+          </a:solidFill>
+          <a:ln>
+            <a:noFill/>
+          </a:ln>
+        </p:spPr>
+        <p:style>
+          <a:lnRef idx="1">
+            <a:schemeClr val="accent1"/>
+          </a:lnRef>
+          <a:fillRef idx="3">
+            <a:schemeClr val="accent1"/>
+          </a:fillRef>
+          <a:effectRef idx="2">
+            <a:schemeClr val="accent1"/>
+          </a:effectRef>
+          <a:fontRef idx="minor">
+            <a:schemeClr val="lt1"/>
+          </a:fontRef>
+        </p:style>
+        <p:txBody>
+          <a:bodyPr rtlCol="0" anchor="ctr" wrap="square" lIns="50800" rIns="50800" tIns="25400" bIns="25400"/>
+          <a:lstStyle/>
+          <a:p>
+            <a:pPr algn="ctr"/>
+            <a:r>
+              <a:rPr sz="1000" b="1">
+                <a:solidFill>
+                  <a:srgbClr val="FFFFFF"/>
+                </a:solidFill>
+                <a:latin typeface="Meiryo"/>
+              </a:rPr>
+              <a:t>第三者への相談を防ぐ</a:t>
+            </a:r>
+          </a:p>
+        </p:txBody>
+      </p:sp>
+      <p:sp>
+        <p:nvSpPr>
+          <p:cNvPr id="25" name="Rectangle 24"/>
+          <p:cNvSpPr/>
+          <p:nvPr/>
+        </p:nvSpPr>
+        <p:spPr>
+          <a:xfrm>
+            <a:off x="9601200" y="3200400"/>
+            <a:ext cx="4572000" cy="502920"/>
+          </a:xfrm>
+          <a:prstGeom prst="rect">
+            <a:avLst/>
+          </a:prstGeom>
+          <a:solidFill>
+            <a:srgbClr val="F9F9F9"/>
+          </a:solidFill>
+          <a:ln w="25400">
+            <a:solidFill>
+              <a:srgbClr val="DDDDDD"/>
+            </a:solidFill>
+          </a:ln>
+        </p:spPr>
+        <p:style>
+          <a:lnRef idx="1">
+            <a:schemeClr val="accent1"/>
+          </a:lnRef>
+          <a:fillRef idx="3">
+            <a:schemeClr val="accent1"/>
+          </a:fillRef>
+          <a:effectRef idx="2">
+            <a:schemeClr val="accent1"/>
+          </a:effectRef>
+          <a:fontRef idx="minor">
+            <a:schemeClr val="lt1"/>
+          </a:fontRef>
+        </p:style>
+        <p:txBody>
+          <a:bodyPr rtlCol="0" anchor="ctr" wrap="square" lIns="63500" rIns="50800" tIns="38100" bIns="38100"/>
+          <a:lstStyle/>
+          <a:p>
+            <a:pPr algn="l"/>
+            <a:r>
+              <a:rPr sz="1000" b="0">
+                <a:solidFill>
+                  <a:srgbClr val="222222"/>
+                </a:solidFill>
+                <a:latin typeface="Meiryo"/>
+              </a:rPr>
+              <a:t>電話中なので同僚や家族に相談できない</a:t>
+            </a:r>
+          </a:p>
+        </p:txBody>
+      </p:sp>
+      <p:sp>
+        <p:nvSpPr>
+          <p:cNvPr id="26" name="Rectangle 25"/>
+          <p:cNvSpPr/>
+          <p:nvPr/>
+        </p:nvSpPr>
+        <p:spPr>
+          <a:xfrm>
+            <a:off x="7315200" y="3703320"/>
+            <a:ext cx="2286000" cy="502920"/>
+          </a:xfrm>
+          <a:prstGeom prst="rect">
+            <a:avLst/>
+          </a:prstGeom>
+          <a:solidFill>
+            <a:srgbClr val="27AE60"/>
+          </a:solidFill>
+          <a:ln>
+            <a:noFill/>
+          </a:ln>
+        </p:spPr>
+        <p:style>
+          <a:lnRef idx="1">
+            <a:schemeClr val="accent1"/>
+          </a:lnRef>
+          <a:fillRef idx="3">
+            <a:schemeClr val="accent1"/>
+          </a:fillRef>
+          <a:effectRef idx="2">
+            <a:schemeClr val="accent1"/>
+          </a:effectRef>
+          <a:fontRef idx="minor">
+            <a:schemeClr val="lt1"/>
+          </a:fontRef>
+        </p:style>
+        <p:txBody>
+          <a:bodyPr rtlCol="0" anchor="ctr" wrap="square" lIns="50800" rIns="50800" tIns="25400" bIns="25400"/>
+          <a:lstStyle/>
+          <a:p>
+            <a:pPr algn="ctr"/>
+            <a:r>
+              <a:rPr sz="1000" b="1">
+                <a:solidFill>
+                  <a:srgbClr val="FFFFFF"/>
+                </a:solidFill>
+                <a:latin typeface="Meiryo"/>
+              </a:rPr>
+              <a:t>信頼の維持</a:t>
+            </a:r>
+          </a:p>
+        </p:txBody>
+      </p:sp>
+      <p:sp>
+        <p:nvSpPr>
+          <p:cNvPr id="27" name="Rectangle 26"/>
+          <p:cNvSpPr/>
+          <p:nvPr/>
+        </p:nvSpPr>
+        <p:spPr>
+          <a:xfrm>
+            <a:off x="9601200" y="3703320"/>
+            <a:ext cx="4572000" cy="502920"/>
+          </a:xfrm>
+          <a:prstGeom prst="rect">
+            <a:avLst/>
+          </a:prstGeom>
+          <a:solidFill>
+            <a:srgbClr val="FFFFFF"/>
+          </a:solidFill>
+          <a:ln w="25400">
+            <a:solidFill>
+              <a:srgbClr val="DDDDDD"/>
+            </a:solidFill>
+          </a:ln>
+        </p:spPr>
+        <p:style>
+          <a:lnRef idx="1">
+            <a:schemeClr val="accent1"/>
+          </a:lnRef>
+          <a:fillRef idx="3">
+            <a:schemeClr val="accent1"/>
+          </a:fillRef>
+          <a:effectRef idx="2">
+            <a:schemeClr val="accent1"/>
+          </a:effectRef>
+          <a:fontRef idx="minor">
+            <a:schemeClr val="lt1"/>
+          </a:fontRef>
+        </p:style>
+        <p:txBody>
+          <a:bodyPr rtlCol="0" anchor="ctr" wrap="square" lIns="63500" rIns="50800" tIns="38100" bIns="38100"/>
+          <a:lstStyle/>
+          <a:p>
+            <a:pPr algn="l"/>
+            <a:r>
+              <a:rPr sz="1000" b="0">
+                <a:solidFill>
+                  <a:srgbClr val="222222"/>
+                </a:solidFill>
+                <a:latin typeface="Meiryo"/>
+              </a:rPr>
+              <a:t>銀行員が丁寧に付き添ってくれている感覚</a:t>
+            </a:r>
+          </a:p>
+        </p:txBody>
+      </p:sp>
+      <p:sp>
+        <p:nvSpPr>
+          <p:cNvPr id="28" name="Rectangle 27"/>
+          <p:cNvSpPr/>
+          <p:nvPr/>
+        </p:nvSpPr>
+        <p:spPr>
+          <a:xfrm>
+            <a:off x="7315200" y="4434840"/>
+            <a:ext cx="6858000" cy="365760"/>
+          </a:xfrm>
+          <a:prstGeom prst="rect">
+            <a:avLst/>
+          </a:prstGeom>
+          <a:solidFill>
+            <a:srgbClr val="27AE60"/>
+          </a:solidFill>
+          <a:ln>
+            <a:noFill/>
+          </a:ln>
+        </p:spPr>
+        <p:style>
+          <a:lnRef idx="1">
+            <a:schemeClr val="accent1"/>
+          </a:lnRef>
+          <a:fillRef idx="3">
+            <a:schemeClr val="accent1"/>
+          </a:fillRef>
+          <a:effectRef idx="2">
+            <a:schemeClr val="accent1"/>
+          </a:effectRef>
+          <a:fontRef idx="minor">
+            <a:schemeClr val="lt1"/>
+          </a:fontRef>
+        </p:style>
+        <p:txBody>
+          <a:bodyPr rtlCol="0" anchor="ctr" wrap="square" lIns="50800" rIns="50800" tIns="25400" bIns="25400"/>
+          <a:lstStyle/>
+          <a:p>
+            <a:pPr algn="ctr"/>
+            <a:r>
+              <a:rPr sz="1100" b="1">
+                <a:solidFill>
+                  <a:srgbClr val="FFFFFF"/>
+                </a:solidFill>
+                <a:latin typeface="Meiryo"/>
+              </a:rPr>
+              <a:t>もし電話が切れたら（攻撃失敗）</a:t>
+            </a:r>
+          </a:p>
+        </p:txBody>
+      </p:sp>
+      <p:sp>
+        <p:nvSpPr>
+          <p:cNvPr id="29" name="Rectangle 28"/>
+          <p:cNvSpPr/>
+          <p:nvPr/>
+        </p:nvSpPr>
+        <p:spPr>
+          <a:xfrm>
+            <a:off x="7315200" y="4800600"/>
+            <a:ext cx="6858000" cy="822960"/>
+          </a:xfrm>
+          <a:prstGeom prst="rect">
+            <a:avLst/>
+          </a:prstGeom>
+          <a:solidFill>
+            <a:srgbClr val="FFFFFF"/>
+          </a:solidFill>
+          <a:ln w="25400">
+            <a:solidFill>
+              <a:srgbClr val="27AE60"/>
+            </a:solidFill>
+          </a:ln>
+        </p:spPr>
+        <p:style>
+          <a:lnRef idx="1">
+            <a:schemeClr val="accent1"/>
+          </a:lnRef>
+          <a:fillRef idx="3">
+            <a:schemeClr val="accent1"/>
+          </a:fillRef>
+          <a:effectRef idx="2">
+            <a:schemeClr val="accent1"/>
+          </a:effectRef>
+          <a:fontRef idx="minor">
+            <a:schemeClr val="lt1"/>
+          </a:fontRef>
+        </p:style>
+        <p:txBody>
+          <a:bodyPr rtlCol="0" anchor="ctr" wrap="square" lIns="63500" rIns="50800" tIns="38100" bIns="38100"/>
+          <a:lstStyle/>
+          <a:p>
+            <a:pPr algn="l"/>
+            <a:r>
+              <a:rPr sz="1000" b="0">
+                <a:solidFill>
+                  <a:srgbClr val="222222"/>
+                </a:solidFill>
+                <a:latin typeface="Meiryo"/>
+              </a:rPr>
+              <a:t>→ 「本当に銀行からの電話だったのか？」と疑問に思う
+→ 銀行の公式番号にかけ直す
+→ 同僚や上司に相談する
+→ ネットで調べる</a:t>
+            </a:r>
+          </a:p>
+        </p:txBody>
+      </p:sp>
+      <p:sp>
+        <p:nvSpPr>
+          <p:cNvPr id="30" name="Rectangle 29"/>
+          <p:cNvSpPr/>
+          <p:nvPr/>
+        </p:nvSpPr>
+        <p:spPr>
+          <a:xfrm>
+            <a:off x="914400" y="5806440"/>
+            <a:ext cx="13258800" cy="457200"/>
+          </a:xfrm>
+          <a:prstGeom prst="rect">
+            <a:avLst/>
+          </a:prstGeom>
+          <a:solidFill>
+            <a:srgbClr val="222222"/>
+          </a:solidFill>
+          <a:ln>
+            <a:noFill/>
+          </a:ln>
+        </p:spPr>
+        <p:style>
+          <a:lnRef idx="1">
+            <a:schemeClr val="accent1"/>
+          </a:lnRef>
+          <a:fillRef idx="3">
+            <a:schemeClr val="accent1"/>
+          </a:fillRef>
+          <a:effectRef idx="2">
+            <a:schemeClr val="accent1"/>
+          </a:effectRef>
+          <a:fontRef idx="minor">
+            <a:schemeClr val="lt1"/>
+          </a:fontRef>
+        </p:style>
+        <p:txBody>
+          <a:bodyPr rtlCol="0" anchor="ctr" wrap="square" lIns="50800" rIns="50800" tIns="25400" bIns="25400"/>
+          <a:lstStyle/>
+          <a:p>
+            <a:pPr algn="ctr"/>
+            <a:r>
+              <a:rPr sz="1300" b="1">
+                <a:solidFill>
+                  <a:srgbClr val="FFFFFF"/>
+                </a:solidFill>
+                <a:latin typeface="Meiryo"/>
+              </a:rPr>
+              <a:t>被害者の体験：「銀行の担当者に電話で付き添ってもらいながら手続きをした」— それが攻撃だったとは気づかない</a:t>
+            </a:r>
+          </a:p>
+        </p:txBody>
+      </p:sp>
+      <p:sp>
+        <p:nvSpPr>
+          <p:cNvPr id="31" name="TextBox 30"/>
+          <p:cNvSpPr txBox="1"/>
+          <p:nvPr/>
+        </p:nvSpPr>
+        <p:spPr>
+          <a:xfrm>
+            <a:off x="9144000" y="10378440"/>
+            <a:ext cx="5943600" cy="228600"/>
+          </a:xfrm>
+          <a:prstGeom prst="rect">
+            <a:avLst/>
+          </a:prstGeom>
+          <a:noFill/>
+        </p:spPr>
+        <p:txBody>
+          <a:bodyPr wrap="square" lIns="50800" rIns="50800" tIns="38100" bIns="38100"/>
+          <a:lstStyle/>
+          <a:p>
+            <a:pPr algn="r"/>
+            <a:r>
+              <a:rPr sz="700" b="0">
+                <a:solidFill>
+                  <a:srgbClr val="888888"/>
+                </a:solidFill>
+                <a:latin typeface="Meiryo"/>
+              </a:rPr>
+              <a:t>Fraud Kill Chain — 1本の電話の構造</a:t>
             </a:r>
           </a:p>
         </p:txBody>

</xml_diff>

<commit_message>
Add key annotations: step 2 as attack linchpin, step 3 flaw point
Step 2's fear tactic ("account restricted") is the key that disables
victim judgment for all subsequent steps. Step 3's email ask is a
structural flaw (bank already has it) but goes unnoticed due to panic.

https://claude.ai/code/session_01F7t8LKifK43o6sCdF2a3gQ
</commit_message>
<xml_diff>
--- a/Fraud_Kill_Chain.pptx
+++ b/Fraud_Kill_Chain.pptx
@@ -3853,7 +3853,7 @@
         <p:spPr>
           <a:xfrm>
             <a:off x="182880" y="3273552"/>
-            <a:ext cx="1005840" cy="2148840"/>
+            <a:ext cx="1005840" cy="2606040"/>
           </a:xfrm>
           <a:prstGeom prst="rect">
             <a:avLst/>
@@ -3904,7 +3904,7 @@
         </p:nvSpPr>
         <p:spPr>
           <a:xfrm>
-            <a:off x="182880" y="5458968"/>
+            <a:off x="182880" y="5916168"/>
             <a:ext cx="1005840" cy="2240280"/>
           </a:xfrm>
           <a:prstGeom prst="rect">
@@ -3957,7 +3957,7 @@
         </p:nvSpPr>
         <p:spPr>
           <a:xfrm>
-            <a:off x="182880" y="7735824"/>
+            <a:off x="182880" y="8193024"/>
             <a:ext cx="1005840" cy="2286000"/>
           </a:xfrm>
           <a:prstGeom prst="rect">
@@ -4010,7 +4010,7 @@
         </p:nvSpPr>
         <p:spPr>
           <a:xfrm>
-            <a:off x="182880" y="10058400"/>
+            <a:off x="182880" y="10515600"/>
             <a:ext cx="1005840" cy="502920"/>
           </a:xfrm>
           <a:prstGeom prst="rect">
@@ -4584,7 +4584,7 @@
         <p:spPr>
           <a:xfrm>
             <a:off x="1225296" y="3273552"/>
-            <a:ext cx="2606040" cy="2148840"/>
+            <a:ext cx="2606040" cy="2606040"/>
           </a:xfrm>
           <a:prstGeom prst="rect">
             <a:avLst/>
@@ -4636,7 +4636,7 @@
         <p:spPr>
           <a:xfrm>
             <a:off x="3867912" y="3273552"/>
-            <a:ext cx="2606040" cy="2148840"/>
+            <a:ext cx="2606040" cy="2606040"/>
           </a:xfrm>
           <a:prstGeom prst="rect">
             <a:avLst/>
@@ -4688,7 +4688,7 @@
         <p:spPr>
           <a:xfrm>
             <a:off x="6510528" y="3273552"/>
-            <a:ext cx="2606040" cy="2148840"/>
+            <a:ext cx="2606040" cy="2606040"/>
           </a:xfrm>
           <a:prstGeom prst="rect">
             <a:avLst/>
@@ -4740,7 +4740,7 @@
         <p:spPr>
           <a:xfrm>
             <a:off x="9153144" y="3273552"/>
-            <a:ext cx="2606040" cy="2148840"/>
+            <a:ext cx="2606040" cy="2606040"/>
           </a:xfrm>
           <a:prstGeom prst="rect">
             <a:avLst/>
@@ -4792,7 +4792,7 @@
         <p:spPr>
           <a:xfrm>
             <a:off x="11795760" y="3273552"/>
-            <a:ext cx="2606040" cy="2148840"/>
+            <a:ext cx="2606040" cy="2606040"/>
           </a:xfrm>
           <a:prstGeom prst="rect">
             <a:avLst/>
@@ -4843,7 +4843,7 @@
         </p:nvSpPr>
         <p:spPr>
           <a:xfrm>
-            <a:off x="1225296" y="5458968"/>
+            <a:off x="1225296" y="5916168"/>
             <a:ext cx="2606040" cy="2240280"/>
           </a:xfrm>
           <a:prstGeom prst="rect">
@@ -4895,7 +4895,7 @@
         </p:nvSpPr>
         <p:spPr>
           <a:xfrm>
-            <a:off x="3867912" y="5458968"/>
+            <a:off x="3867912" y="5916168"/>
             <a:ext cx="2606040" cy="2240280"/>
           </a:xfrm>
           <a:prstGeom prst="rect">
@@ -4947,7 +4947,7 @@
         </p:nvSpPr>
         <p:spPr>
           <a:xfrm>
-            <a:off x="6510528" y="5458968"/>
+            <a:off x="6510528" y="5916168"/>
             <a:ext cx="2606040" cy="2240280"/>
           </a:xfrm>
           <a:prstGeom prst="rect">
@@ -4999,7 +4999,7 @@
         </p:nvSpPr>
         <p:spPr>
           <a:xfrm>
-            <a:off x="9153144" y="5458968"/>
+            <a:off x="9153144" y="5916168"/>
             <a:ext cx="2606040" cy="2240280"/>
           </a:xfrm>
           <a:prstGeom prst="rect">
@@ -5051,7 +5051,7 @@
         </p:nvSpPr>
         <p:spPr>
           <a:xfrm>
-            <a:off x="11795760" y="5458968"/>
+            <a:off x="11795760" y="5916168"/>
             <a:ext cx="2606040" cy="2240280"/>
           </a:xfrm>
           <a:prstGeom prst="rect">
@@ -5103,7 +5103,7 @@
         </p:nvSpPr>
         <p:spPr>
           <a:xfrm>
-            <a:off x="1225296" y="7735824"/>
+            <a:off x="1225296" y="8193024"/>
             <a:ext cx="2606040" cy="2286000"/>
           </a:xfrm>
           <a:prstGeom prst="rect">
@@ -5155,7 +5155,7 @@
         </p:nvSpPr>
         <p:spPr>
           <a:xfrm>
-            <a:off x="3867912" y="7735824"/>
+            <a:off x="3867912" y="8193024"/>
             <a:ext cx="2606040" cy="2286000"/>
           </a:xfrm>
           <a:prstGeom prst="rect">
@@ -5207,7 +5207,7 @@
         </p:nvSpPr>
         <p:spPr>
           <a:xfrm>
-            <a:off x="6510528" y="7735824"/>
+            <a:off x="6510528" y="8193024"/>
             <a:ext cx="2606040" cy="2286000"/>
           </a:xfrm>
           <a:prstGeom prst="rect">
@@ -5259,7 +5259,7 @@
         </p:nvSpPr>
         <p:spPr>
           <a:xfrm>
-            <a:off x="9153144" y="7735824"/>
+            <a:off x="9153144" y="8193024"/>
             <a:ext cx="2606040" cy="2286000"/>
           </a:xfrm>
           <a:prstGeom prst="rect">
@@ -5311,7 +5311,7 @@
         </p:nvSpPr>
         <p:spPr>
           <a:xfrm>
-            <a:off x="11795760" y="7735824"/>
+            <a:off x="11795760" y="8193024"/>
             <a:ext cx="2606040" cy="2286000"/>
           </a:xfrm>
           <a:prstGeom prst="rect">
@@ -5363,7 +5363,7 @@
         </p:nvSpPr>
         <p:spPr>
           <a:xfrm>
-            <a:off x="1225296" y="10058400"/>
+            <a:off x="1225296" y="10515600"/>
             <a:ext cx="2606040" cy="502920"/>
           </a:xfrm>
           <a:prstGeom prst="rect">
@@ -5415,7 +5415,7 @@
         </p:nvSpPr>
         <p:spPr>
           <a:xfrm>
-            <a:off x="3867912" y="10058400"/>
+            <a:off x="3867912" y="10515600"/>
             <a:ext cx="2606040" cy="502920"/>
           </a:xfrm>
           <a:prstGeom prst="rect">
@@ -5467,7 +5467,7 @@
         </p:nvSpPr>
         <p:spPr>
           <a:xfrm>
-            <a:off x="6510528" y="10058400"/>
+            <a:off x="6510528" y="10515600"/>
             <a:ext cx="2606040" cy="502920"/>
           </a:xfrm>
           <a:prstGeom prst="rect">
@@ -5519,7 +5519,7 @@
         </p:nvSpPr>
         <p:spPr>
           <a:xfrm>
-            <a:off x="9153144" y="10058400"/>
+            <a:off x="9153144" y="10515600"/>
             <a:ext cx="2606040" cy="502920"/>
           </a:xfrm>
           <a:prstGeom prst="rect">
@@ -5571,7 +5571,7 @@
         </p:nvSpPr>
         <p:spPr>
           <a:xfrm>
-            <a:off x="11795760" y="10058400"/>
+            <a:off x="11795760" y="10515600"/>
             <a:ext cx="2606040" cy="502920"/>
           </a:xfrm>
           <a:prstGeom prst="rect">
@@ -6021,13 +6021,67 @@
       </p:sp>
       <p:sp>
         <p:nvSpPr>
-          <p:cNvPr id="60" name="Diamond 59"/>
-          <p:cNvSpPr/>
-          <p:nvPr/>
-        </p:nvSpPr>
-        <p:spPr>
-          <a:xfrm>
-            <a:off x="4507992" y="4169664"/>
+          <p:cNvPr id="60" name="Rectangle 59"/>
+          <p:cNvSpPr/>
+          <p:nvPr/>
+        </p:nvSpPr>
+        <p:spPr>
+          <a:xfrm>
+            <a:off x="3959352" y="4206240"/>
+            <a:ext cx="2423160" cy="201168"/>
+          </a:xfrm>
+          <a:prstGeom prst="rect">
+            <a:avLst/>
+          </a:prstGeom>
+          <a:solidFill>
+            <a:srgbClr val="222222"/>
+          </a:solidFill>
+          <a:ln w="25400">
+            <a:solidFill>
+              <a:srgbClr val="222222"/>
+            </a:solidFill>
+          </a:ln>
+        </p:spPr>
+        <p:style>
+          <a:lnRef idx="1">
+            <a:schemeClr val="accent1"/>
+          </a:lnRef>
+          <a:fillRef idx="3">
+            <a:schemeClr val="accent1"/>
+          </a:fillRef>
+          <a:effectRef idx="2">
+            <a:schemeClr val="accent1"/>
+          </a:effectRef>
+          <a:fontRef idx="minor">
+            <a:schemeClr val="lt1"/>
+          </a:fontRef>
+        </p:style>
+        <p:txBody>
+          <a:bodyPr rtlCol="0" anchor="ctr" wrap="square" lIns="63500" rIns="50800" tIns="38100" bIns="38100"/>
+          <a:lstStyle/>
+          <a:p>
+            <a:pPr algn="l"/>
+            <a:r>
+              <a:rPr sz="600" b="1">
+                <a:solidFill>
+                  <a:srgbClr val="FFFFFF"/>
+                </a:solidFill>
+                <a:latin typeface="Meiryo"/>
+              </a:rPr>
+              <a:t>🔑 攻撃の鍵：「口座制限」で恐怖→以降の判断力を奪う</a:t>
+            </a:r>
+          </a:p>
+        </p:txBody>
+      </p:sp>
+      <p:sp>
+        <p:nvSpPr>
+          <p:cNvPr id="61" name="Diamond 60"/>
+          <p:cNvSpPr/>
+          <p:nvPr/>
+        </p:nvSpPr>
+        <p:spPr>
+          <a:xfrm>
+            <a:off x="4507992" y="4443984"/>
             <a:ext cx="1280160" cy="457200"/>
           </a:xfrm>
           <a:prstGeom prst="diamond">
@@ -6073,13 +6127,13 @@
       </p:sp>
       <p:sp>
         <p:nvSpPr>
-          <p:cNvPr id="61" name="Rectangle 60"/>
-          <p:cNvSpPr/>
-          <p:nvPr/>
-        </p:nvSpPr>
-        <p:spPr>
-          <a:xfrm>
-            <a:off x="3959352" y="4663440"/>
+          <p:cNvPr id="62" name="Rectangle 61"/>
+          <p:cNvSpPr/>
+          <p:nvPr/>
+        </p:nvSpPr>
+        <p:spPr>
+          <a:xfrm>
+            <a:off x="3959352" y="4937760"/>
             <a:ext cx="2423160" cy="365760"/>
           </a:xfrm>
           <a:prstGeom prst="rect">
@@ -6128,13 +6182,67 @@
       </p:sp>
       <p:sp>
         <p:nvSpPr>
-          <p:cNvPr id="62" name="Rectangle 61"/>
-          <p:cNvSpPr/>
-          <p:nvPr/>
-        </p:nvSpPr>
-        <p:spPr>
-          <a:xfrm>
-            <a:off x="3959352" y="5065776"/>
+          <p:cNvPr id="63" name="Rectangle 62"/>
+          <p:cNvSpPr/>
+          <p:nvPr/>
+        </p:nvSpPr>
+        <p:spPr>
+          <a:xfrm>
+            <a:off x="3959352" y="5321808"/>
+            <a:ext cx="2423160" cy="274320"/>
+          </a:xfrm>
+          <a:prstGeom prst="rect">
+            <a:avLst/>
+          </a:prstGeom>
+          <a:solidFill>
+            <a:srgbClr val="FDEDEC"/>
+          </a:solidFill>
+          <a:ln w="25400">
+            <a:solidFill>
+              <a:srgbClr val="C0392B"/>
+            </a:solidFill>
+          </a:ln>
+        </p:spPr>
+        <p:style>
+          <a:lnRef idx="1">
+            <a:schemeClr val="accent1"/>
+          </a:lnRef>
+          <a:fillRef idx="3">
+            <a:schemeClr val="accent1"/>
+          </a:fillRef>
+          <a:effectRef idx="2">
+            <a:schemeClr val="accent1"/>
+          </a:effectRef>
+          <a:fontRef idx="minor">
+            <a:schemeClr val="lt1"/>
+          </a:fontRef>
+        </p:style>
+        <p:txBody>
+          <a:bodyPr rtlCol="0" anchor="ctr" wrap="square" lIns="63500" rIns="50800" tIns="38100" bIns="38100"/>
+          <a:lstStyle/>
+          <a:p>
+            <a:pPr algn="l"/>
+            <a:r>
+              <a:rPr sz="600" b="0">
+                <a:solidFill>
+                  <a:srgbClr val="222222"/>
+                </a:solidFill>
+                <a:latin typeface="Meiryo"/>
+              </a:rPr>
+              <a:t>⚠ 破綻ポイント：BizSTATION契約時にメアド登録済み。銀行が聞く必要はない→手順②の恐怖で気づけない</a:t>
+            </a:r>
+          </a:p>
+        </p:txBody>
+      </p:sp>
+      <p:sp>
+        <p:nvSpPr>
+          <p:cNvPr id="64" name="Rectangle 63"/>
+          <p:cNvSpPr/>
+          <p:nvPr/>
+        </p:nvSpPr>
+        <p:spPr>
+          <a:xfrm>
+            <a:off x="3959352" y="5614416"/>
             <a:ext cx="2423160" cy="201168"/>
           </a:xfrm>
           <a:prstGeom prst="rect">
@@ -6182,13 +6290,13 @@
       </p:sp>
       <p:sp>
         <p:nvSpPr>
-          <p:cNvPr id="63" name="Rectangle 62"/>
-          <p:cNvSpPr/>
-          <p:nvPr/>
-        </p:nvSpPr>
-        <p:spPr>
-          <a:xfrm>
-            <a:off x="3959352" y="5285232"/>
+          <p:cNvPr id="65" name="Rectangle 64"/>
+          <p:cNvSpPr/>
+          <p:nvPr/>
+        </p:nvSpPr>
+        <p:spPr>
+          <a:xfrm>
+            <a:off x="3959352" y="5833872"/>
             <a:ext cx="2423160" cy="137160"/>
           </a:xfrm>
           <a:prstGeom prst="rect">
@@ -6236,13 +6344,13 @@
       </p:sp>
       <p:sp>
         <p:nvSpPr>
-          <p:cNvPr id="64" name="Rectangle 63"/>
-          <p:cNvSpPr/>
-          <p:nvPr/>
-        </p:nvSpPr>
-        <p:spPr>
-          <a:xfrm>
-            <a:off x="3959352" y="5440680"/>
+          <p:cNvPr id="66" name="Rectangle 65"/>
+          <p:cNvSpPr/>
+          <p:nvPr/>
+        </p:nvSpPr>
+        <p:spPr>
+          <a:xfrm>
+            <a:off x="3959352" y="5989320"/>
             <a:ext cx="2423160" cy="137160"/>
           </a:xfrm>
           <a:prstGeom prst="rect">
@@ -6290,13 +6398,13 @@
       </p:sp>
       <p:sp>
         <p:nvSpPr>
-          <p:cNvPr id="65" name="Rectangle 64"/>
-          <p:cNvSpPr/>
-          <p:nvPr/>
-        </p:nvSpPr>
-        <p:spPr>
-          <a:xfrm>
-            <a:off x="6601968" y="4663440"/>
+          <p:cNvPr id="67" name="Rectangle 66"/>
+          <p:cNvSpPr/>
+          <p:nvPr/>
+        </p:nvSpPr>
+        <p:spPr>
+          <a:xfrm>
+            <a:off x="6601968" y="4937760"/>
             <a:ext cx="2423160" cy="274320"/>
           </a:xfrm>
           <a:prstGeom prst="rect">
@@ -6344,13 +6452,13 @@
       </p:sp>
       <p:sp>
         <p:nvSpPr>
-          <p:cNvPr id="66" name="Rectangle 65"/>
-          <p:cNvSpPr/>
-          <p:nvPr/>
-        </p:nvSpPr>
-        <p:spPr>
-          <a:xfrm>
-            <a:off x="9244584" y="5148072"/>
+          <p:cNvPr id="68" name="Rectangle 67"/>
+          <p:cNvSpPr/>
+          <p:nvPr/>
+        </p:nvSpPr>
+        <p:spPr>
+          <a:xfrm>
+            <a:off x="9244584" y="5614416"/>
             <a:ext cx="2423160" cy="320040"/>
           </a:xfrm>
           <a:prstGeom prst="rect">
@@ -6399,13 +6507,13 @@
       </p:sp>
       <p:sp>
         <p:nvSpPr>
-          <p:cNvPr id="67" name="Rectangle 66"/>
-          <p:cNvSpPr/>
-          <p:nvPr/>
-        </p:nvSpPr>
-        <p:spPr>
-          <a:xfrm>
-            <a:off x="3959352" y="5504688"/>
+          <p:cNvPr id="69" name="Rectangle 68"/>
+          <p:cNvSpPr/>
+          <p:nvPr/>
+        </p:nvSpPr>
+        <p:spPr>
+          <a:xfrm>
+            <a:off x="3959352" y="5961888"/>
             <a:ext cx="2423160" cy="457200"/>
           </a:xfrm>
           <a:prstGeom prst="rect">
@@ -6454,13 +6562,13 @@
       </p:sp>
       <p:sp>
         <p:nvSpPr>
-          <p:cNvPr id="68" name="Rectangle 67"/>
-          <p:cNvSpPr/>
-          <p:nvPr/>
-        </p:nvSpPr>
-        <p:spPr>
-          <a:xfrm>
-            <a:off x="3959352" y="6007608"/>
+          <p:cNvPr id="70" name="Rectangle 69"/>
+          <p:cNvSpPr/>
+          <p:nvPr/>
+        </p:nvSpPr>
+        <p:spPr>
+          <a:xfrm>
+            <a:off x="3959352" y="6464808"/>
             <a:ext cx="2423160" cy="274320"/>
           </a:xfrm>
           <a:prstGeom prst="rect">
@@ -6508,13 +6616,13 @@
       </p:sp>
       <p:sp>
         <p:nvSpPr>
-          <p:cNvPr id="69" name="Rectangle 68"/>
-          <p:cNvSpPr/>
-          <p:nvPr/>
-        </p:nvSpPr>
-        <p:spPr>
-          <a:xfrm>
-            <a:off x="3959352" y="6327648"/>
+          <p:cNvPr id="71" name="Rectangle 70"/>
+          <p:cNvSpPr/>
+          <p:nvPr/>
+        </p:nvSpPr>
+        <p:spPr>
+          <a:xfrm>
+            <a:off x="3959352" y="6784848"/>
             <a:ext cx="2423160" cy="274320"/>
           </a:xfrm>
           <a:prstGeom prst="rect">
@@ -6562,13 +6670,13 @@
       </p:sp>
       <p:sp>
         <p:nvSpPr>
-          <p:cNvPr id="70" name="Rectangle 69"/>
-          <p:cNvSpPr/>
-          <p:nvPr/>
-        </p:nvSpPr>
-        <p:spPr>
-          <a:xfrm>
-            <a:off x="9244584" y="5504688"/>
+          <p:cNvPr id="72" name="Rectangle 71"/>
+          <p:cNvSpPr/>
+          <p:nvPr/>
+        </p:nvSpPr>
+        <p:spPr>
+          <a:xfrm>
+            <a:off x="9244584" y="5961888"/>
             <a:ext cx="2423160" cy="320040"/>
           </a:xfrm>
           <a:prstGeom prst="rect">
@@ -6617,13 +6725,13 @@
       </p:sp>
       <p:sp>
         <p:nvSpPr>
-          <p:cNvPr id="71" name="Rectangle 70"/>
-          <p:cNvSpPr/>
-          <p:nvPr/>
-        </p:nvSpPr>
-        <p:spPr>
-          <a:xfrm>
-            <a:off x="9244584" y="5870448"/>
+          <p:cNvPr id="73" name="Rectangle 72"/>
+          <p:cNvSpPr/>
+          <p:nvPr/>
+        </p:nvSpPr>
+        <p:spPr>
+          <a:xfrm>
+            <a:off x="9244584" y="6327648"/>
             <a:ext cx="2423160" cy="320040"/>
           </a:xfrm>
           <a:prstGeom prst="rect">
@@ -6671,13 +6779,13 @@
       </p:sp>
       <p:sp>
         <p:nvSpPr>
-          <p:cNvPr id="72" name="Rectangle 71"/>
-          <p:cNvSpPr/>
-          <p:nvPr/>
-        </p:nvSpPr>
-        <p:spPr>
-          <a:xfrm>
-            <a:off x="9244584" y="6236208"/>
+          <p:cNvPr id="74" name="Rectangle 73"/>
+          <p:cNvSpPr/>
+          <p:nvPr/>
+        </p:nvSpPr>
+        <p:spPr>
+          <a:xfrm>
+            <a:off x="9244584" y="6693408"/>
             <a:ext cx="2423160" cy="365760"/>
           </a:xfrm>
           <a:prstGeom prst="rect">
@@ -6726,13 +6834,13 @@
       </p:sp>
       <p:sp>
         <p:nvSpPr>
-          <p:cNvPr id="73" name="Rectangle 72"/>
-          <p:cNvSpPr/>
-          <p:nvPr/>
-        </p:nvSpPr>
-        <p:spPr>
-          <a:xfrm>
-            <a:off x="9244584" y="6647688"/>
+          <p:cNvPr id="75" name="Rectangle 74"/>
+          <p:cNvSpPr/>
+          <p:nvPr/>
+        </p:nvSpPr>
+        <p:spPr>
+          <a:xfrm>
+            <a:off x="9244584" y="7104888"/>
             <a:ext cx="2423160" cy="274320"/>
           </a:xfrm>
           <a:prstGeom prst="rect">
@@ -6780,13 +6888,13 @@
       </p:sp>
       <p:sp>
         <p:nvSpPr>
-          <p:cNvPr id="74" name="Rectangle 73"/>
-          <p:cNvSpPr/>
-          <p:nvPr/>
-        </p:nvSpPr>
-        <p:spPr>
-          <a:xfrm>
-            <a:off x="9244584" y="6967728"/>
+          <p:cNvPr id="76" name="Rectangle 75"/>
+          <p:cNvSpPr/>
+          <p:nvPr/>
+        </p:nvSpPr>
+        <p:spPr>
+          <a:xfrm>
+            <a:off x="9244584" y="7424928"/>
             <a:ext cx="2423160" cy="777240"/>
           </a:xfrm>
           <a:prstGeom prst="rect">
@@ -6834,13 +6942,13 @@
       </p:sp>
       <p:sp>
         <p:nvSpPr>
-          <p:cNvPr id="75" name="Rectangle 74"/>
-          <p:cNvSpPr/>
-          <p:nvPr/>
-        </p:nvSpPr>
-        <p:spPr>
-          <a:xfrm>
-            <a:off x="3959352" y="7781544"/>
+          <p:cNvPr id="77" name="Rectangle 76"/>
+          <p:cNvSpPr/>
+          <p:nvPr/>
+        </p:nvSpPr>
+        <p:spPr>
+          <a:xfrm>
+            <a:off x="3959352" y="8238744"/>
             <a:ext cx="2423160" cy="365760"/>
           </a:xfrm>
           <a:prstGeom prst="rect">
@@ -6888,13 +6996,13 @@
       </p:sp>
       <p:sp>
         <p:nvSpPr>
-          <p:cNvPr id="76" name="Rectangle 75"/>
-          <p:cNvSpPr/>
-          <p:nvPr/>
-        </p:nvSpPr>
-        <p:spPr>
-          <a:xfrm>
-            <a:off x="3959352" y="8193024"/>
+          <p:cNvPr id="78" name="Rectangle 77"/>
+          <p:cNvSpPr/>
+          <p:nvPr/>
+        </p:nvSpPr>
+        <p:spPr>
+          <a:xfrm>
+            <a:off x="3959352" y="8650224"/>
             <a:ext cx="2423160" cy="201168"/>
           </a:xfrm>
           <a:prstGeom prst="rect">
@@ -6942,13 +7050,13 @@
       </p:sp>
       <p:sp>
         <p:nvSpPr>
-          <p:cNvPr id="77" name="Rectangle 76"/>
-          <p:cNvSpPr/>
-          <p:nvPr/>
-        </p:nvSpPr>
-        <p:spPr>
-          <a:xfrm>
-            <a:off x="3959352" y="8449056"/>
+          <p:cNvPr id="79" name="Rectangle 78"/>
+          <p:cNvSpPr/>
+          <p:nvPr/>
+        </p:nvSpPr>
+        <p:spPr>
+          <a:xfrm>
+            <a:off x="3959352" y="8906256"/>
             <a:ext cx="2423160" cy="274320"/>
           </a:xfrm>
           <a:prstGeom prst="rect">
@@ -6996,13 +7104,13 @@
       </p:sp>
       <p:sp>
         <p:nvSpPr>
-          <p:cNvPr id="78" name="Rectangle 77"/>
-          <p:cNvSpPr/>
-          <p:nvPr/>
-        </p:nvSpPr>
-        <p:spPr>
-          <a:xfrm>
-            <a:off x="3959352" y="8769096"/>
+          <p:cNvPr id="80" name="Rectangle 79"/>
+          <p:cNvSpPr/>
+          <p:nvPr/>
+        </p:nvSpPr>
+        <p:spPr>
+          <a:xfrm>
+            <a:off x="3959352" y="9226296"/>
             <a:ext cx="2423160" cy="411480"/>
           </a:xfrm>
           <a:prstGeom prst="rect">
@@ -7050,13 +7158,13 @@
       </p:sp>
       <p:sp>
         <p:nvSpPr>
-          <p:cNvPr id="79" name="Rectangle 78"/>
-          <p:cNvSpPr/>
-          <p:nvPr/>
-        </p:nvSpPr>
-        <p:spPr>
-          <a:xfrm>
-            <a:off x="3959352" y="9244584"/>
+          <p:cNvPr id="81" name="Rectangle 80"/>
+          <p:cNvSpPr/>
+          <p:nvPr/>
+        </p:nvSpPr>
+        <p:spPr>
+          <a:xfrm>
+            <a:off x="3959352" y="9701784"/>
             <a:ext cx="2423160" cy="411480"/>
           </a:xfrm>
           <a:prstGeom prst="rect">
@@ -7104,13 +7212,13 @@
       </p:sp>
       <p:sp>
         <p:nvSpPr>
-          <p:cNvPr id="80" name="Rectangle 79"/>
-          <p:cNvSpPr/>
-          <p:nvPr/>
-        </p:nvSpPr>
-        <p:spPr>
-          <a:xfrm>
-            <a:off x="6601968" y="7781544"/>
+          <p:cNvPr id="82" name="Rectangle 81"/>
+          <p:cNvSpPr/>
+          <p:nvPr/>
+        </p:nvSpPr>
+        <p:spPr>
+          <a:xfrm>
+            <a:off x="6601968" y="8238744"/>
             <a:ext cx="2423160" cy="274320"/>
           </a:xfrm>
           <a:prstGeom prst="rect">
@@ -7158,13 +7266,13 @@
       </p:sp>
       <p:sp>
         <p:nvSpPr>
-          <p:cNvPr id="81" name="Rectangle 80"/>
-          <p:cNvSpPr/>
-          <p:nvPr/>
-        </p:nvSpPr>
-        <p:spPr>
-          <a:xfrm>
-            <a:off x="11887200" y="8193024"/>
+          <p:cNvPr id="83" name="Rectangle 82"/>
+          <p:cNvSpPr/>
+          <p:nvPr/>
+        </p:nvSpPr>
+        <p:spPr>
+          <a:xfrm>
+            <a:off x="11887200" y="8650224"/>
             <a:ext cx="2423160" cy="274320"/>
           </a:xfrm>
           <a:prstGeom prst="rect">
@@ -7212,13 +7320,13 @@
       </p:sp>
       <p:sp>
         <p:nvSpPr>
-          <p:cNvPr id="82" name="Rectangle 81"/>
-          <p:cNvSpPr/>
-          <p:nvPr/>
-        </p:nvSpPr>
-        <p:spPr>
-          <a:xfrm>
-            <a:off x="11887200" y="8540496"/>
+          <p:cNvPr id="84" name="Rectangle 83"/>
+          <p:cNvSpPr/>
+          <p:nvPr/>
+        </p:nvSpPr>
+        <p:spPr>
+          <a:xfrm>
+            <a:off x="11887200" y="8997696"/>
             <a:ext cx="2423160" cy="640080"/>
           </a:xfrm>
           <a:prstGeom prst="rect">
@@ -7271,13 +7379,13 @@
       </p:sp>
       <p:sp>
         <p:nvSpPr>
-          <p:cNvPr id="83" name="Rectangle 82"/>
-          <p:cNvSpPr/>
-          <p:nvPr/>
-        </p:nvSpPr>
-        <p:spPr>
-          <a:xfrm>
-            <a:off x="3959352" y="10131552"/>
+          <p:cNvPr id="85" name="Rectangle 84"/>
+          <p:cNvSpPr/>
+          <p:nvPr/>
+        </p:nvSpPr>
+        <p:spPr>
+          <a:xfrm>
+            <a:off x="3959352" y="10588752"/>
             <a:ext cx="2423160" cy="411480"/>
           </a:xfrm>
           <a:prstGeom prst="rect">
@@ -7325,7 +7433,7 @@
       </p:sp>
       <p:sp>
         <p:nvSpPr>
-          <p:cNvPr id="84" name="TextBox 83"/>
+          <p:cNvPr id="86" name="TextBox 85"/>
           <p:cNvSpPr txBox="1"/>
           <p:nvPr/>
         </p:nvSpPr>

</xml_diff>

<commit_message>
Add slide 6: phishing email bypasses spam filters via phone
The phone call neutralizes email security: attacker tells victim
to check spam folder, and finding the email there reinforces
the narrative that important bank notices were being missed.

https://claude.ai/code/session_01F7t8LKifK43o6sCdF2a3gQ
</commit_message>
<xml_diff>
--- a/Fraud_Kill_Chain.pptx
+++ b/Fraud_Kill_Chain.pptx
@@ -10,6 +10,7 @@
     <p:sldId id="258" r:id="rId9"/>
     <p:sldId id="259" r:id="rId10"/>
     <p:sldId id="260" r:id="rId11"/>
+    <p:sldId id="261" r:id="rId12"/>
   </p:sldIdLst>
   <p:sldSz cx="15124176" cy="10689336" type="screen4x3"/>
   <p:notesSz cx="6858000" cy="9144000"/>
@@ -13743,6 +13744,1271 @@
                 <a:latin typeface="Meiryo"/>
               </a:rPr>
               <a:t>Fraud Kill Chain — 1本の電話の構造</a:t>
+            </a:r>
+          </a:p>
+        </p:txBody>
+      </p:sp>
+    </p:spTree>
+  </p:cSld>
+  <p:clrMapOvr>
+    <a:masterClrMapping/>
+  </p:clrMapOvr>
+</p:sld>
+</file>
+
+<file path=ppt/slides/slide6.xml><?xml version="1.0" encoding="utf-8"?>
+<p:sld xmlns:a="http://schemas.openxmlformats.org/drawingml/2006/main" xmlns:p="http://schemas.openxmlformats.org/presentationml/2006/main" xmlns:r="http://schemas.openxmlformats.org/officeDocument/2006/relationships">
+  <p:cSld>
+    <p:bg>
+      <p:bgPr>
+        <a:solidFill>
+          <a:srgbClr val="F5F5F5"/>
+        </a:solidFill>
+        <a:effectLst/>
+      </p:bgPr>
+    </p:bg>
+    <p:spTree>
+      <p:nvGrpSpPr>
+        <p:cNvPr id="1" name=""/>
+        <p:cNvGrpSpPr/>
+        <p:nvPr/>
+      </p:nvGrpSpPr>
+      <p:grpSpPr/>
+      <p:sp>
+        <p:nvSpPr>
+          <p:cNvPr id="2" name="TextBox 1"/>
+          <p:cNvSpPr txBox="1"/>
+          <p:nvPr/>
+        </p:nvSpPr>
+        <p:spPr>
+          <a:xfrm>
+            <a:off x="0" y="182880"/>
+            <a:ext cx="15124176" cy="548640"/>
+          </a:xfrm>
+          <a:prstGeom prst="rect">
+            <a:avLst/>
+          </a:prstGeom>
+          <a:noFill/>
+        </p:spPr>
+        <p:txBody>
+          <a:bodyPr wrap="square" lIns="50800" rIns="50800" tIns="38100" bIns="38100"/>
+          <a:lstStyle/>
+          <a:p>
+            <a:pPr algn="ctr"/>
+            <a:r>
+              <a:rPr sz="2200" b="1">
+                <a:solidFill>
+                  <a:srgbClr val="C0392B"/>
+                </a:solidFill>
+                <a:latin typeface="Meiryo"/>
+              </a:rPr>
+              <a:t>手順④ フィッシングメール — セキュリティ対策も電話1本で無力化</a:t>
+            </a:r>
+          </a:p>
+        </p:txBody>
+      </p:sp>
+      <p:sp>
+        <p:nvSpPr>
+          <p:cNvPr id="3" name="TextBox 2"/>
+          <p:cNvSpPr txBox="1"/>
+          <p:nvPr/>
+        </p:nvSpPr>
+        <p:spPr>
+          <a:xfrm>
+            <a:off x="0" y="685800"/>
+            <a:ext cx="15124176" cy="365760"/>
+          </a:xfrm>
+          <a:prstGeom prst="rect">
+            <a:avLst/>
+          </a:prstGeom>
+          <a:noFill/>
+        </p:spPr>
+        <p:txBody>
+          <a:bodyPr wrap="square" lIns="50800" rIns="50800" tIns="38100" bIns="38100"/>
+          <a:lstStyle/>
+          <a:p>
+            <a:pPr algn="ctr"/>
+            <a:r>
+              <a:rPr sz="1200" b="0">
+                <a:solidFill>
+                  <a:srgbClr val="888888"/>
+                </a:solidFill>
+                <a:latin typeface="Meiryo"/>
+              </a:rPr>
+              <a:t>電話で予告してからメールを送る。通常のフィッシングとは根本的に異なる構造。</a:t>
+            </a:r>
+          </a:p>
+        </p:txBody>
+      </p:sp>
+      <p:sp>
+        <p:nvSpPr>
+          <p:cNvPr id="4" name="Rectangle 3"/>
+          <p:cNvSpPr/>
+          <p:nvPr/>
+        </p:nvSpPr>
+        <p:spPr>
+          <a:xfrm>
+            <a:off x="914400" y="1188720"/>
+            <a:ext cx="6400800" cy="411480"/>
+          </a:xfrm>
+          <a:prstGeom prst="rect">
+            <a:avLst/>
+          </a:prstGeom>
+          <a:solidFill>
+            <a:srgbClr val="EEEEEE"/>
+          </a:solidFill>
+          <a:ln>
+            <a:noFill/>
+          </a:ln>
+        </p:spPr>
+        <p:style>
+          <a:lnRef idx="1">
+            <a:schemeClr val="accent1"/>
+          </a:lnRef>
+          <a:fillRef idx="3">
+            <a:schemeClr val="accent1"/>
+          </a:fillRef>
+          <a:effectRef idx="2">
+            <a:schemeClr val="accent1"/>
+          </a:effectRef>
+          <a:fontRef idx="minor">
+            <a:schemeClr val="lt1"/>
+          </a:fontRef>
+        </p:style>
+        <p:txBody>
+          <a:bodyPr rtlCol="0" anchor="ctr" wrap="square" lIns="50800" rIns="50800" tIns="25400" bIns="25400"/>
+          <a:lstStyle/>
+          <a:p>
+            <a:pPr algn="ctr"/>
+            <a:r>
+              <a:rPr sz="1400" b="1">
+                <a:solidFill>
+                  <a:srgbClr val="222222"/>
+                </a:solidFill>
+                <a:latin typeface="Meiryo"/>
+              </a:rPr>
+              <a:t>通常のフィッシング</a:t>
+            </a:r>
+          </a:p>
+        </p:txBody>
+      </p:sp>
+      <p:sp>
+        <p:nvSpPr>
+          <p:cNvPr id="5" name="Rectangle 4"/>
+          <p:cNvSpPr/>
+          <p:nvPr/>
+        </p:nvSpPr>
+        <p:spPr>
+          <a:xfrm>
+            <a:off x="914400" y="1645920"/>
+            <a:ext cx="6400800" cy="411480"/>
+          </a:xfrm>
+          <a:prstGeom prst="rect">
+            <a:avLst/>
+          </a:prstGeom>
+          <a:solidFill>
+            <a:srgbClr val="FFFFFF"/>
+          </a:solidFill>
+          <a:ln w="25400">
+            <a:solidFill>
+              <a:srgbClr val="CCCCCC"/>
+            </a:solidFill>
+          </a:ln>
+        </p:spPr>
+        <p:style>
+          <a:lnRef idx="1">
+            <a:schemeClr val="accent1"/>
+          </a:lnRef>
+          <a:fillRef idx="3">
+            <a:schemeClr val="accent1"/>
+          </a:fillRef>
+          <a:effectRef idx="2">
+            <a:schemeClr val="accent1"/>
+          </a:effectRef>
+          <a:fontRef idx="minor">
+            <a:schemeClr val="lt1"/>
+          </a:fontRef>
+        </p:style>
+        <p:txBody>
+          <a:bodyPr rtlCol="0" anchor="ctr" wrap="square" lIns="63500" rIns="50800" tIns="38100" bIns="38100"/>
+          <a:lstStyle/>
+          <a:p>
+            <a:pPr algn="l"/>
+            <a:r>
+              <a:rPr sz="1200" b="0">
+                <a:solidFill>
+                  <a:srgbClr val="222222"/>
+                </a:solidFill>
+                <a:latin typeface="Meiryo"/>
+              </a:rPr>
+              <a:t>メールが突然届く</a:t>
+            </a:r>
+          </a:p>
+        </p:txBody>
+      </p:sp>
+      <p:sp>
+        <p:nvSpPr>
+          <p:cNvPr id="6" name="Rectangle 5"/>
+          <p:cNvSpPr/>
+          <p:nvPr/>
+        </p:nvSpPr>
+        <p:spPr>
+          <a:xfrm>
+            <a:off x="2286000" y="2103120"/>
+            <a:ext cx="3657600" cy="365760"/>
+          </a:xfrm>
+          <a:prstGeom prst="rect">
+            <a:avLst/>
+          </a:prstGeom>
+          <a:solidFill>
+            <a:srgbClr val="EEEEEE"/>
+          </a:solidFill>
+          <a:ln>
+            <a:noFill/>
+          </a:ln>
+        </p:spPr>
+        <p:style>
+          <a:lnRef idx="1">
+            <a:schemeClr val="accent1"/>
+          </a:lnRef>
+          <a:fillRef idx="3">
+            <a:schemeClr val="accent1"/>
+          </a:fillRef>
+          <a:effectRef idx="2">
+            <a:schemeClr val="accent1"/>
+          </a:effectRef>
+          <a:fontRef idx="minor">
+            <a:schemeClr val="lt1"/>
+          </a:fontRef>
+        </p:style>
+        <p:txBody>
+          <a:bodyPr rtlCol="0" anchor="ctr" wrap="square" lIns="50800" rIns="50800" tIns="25400" bIns="25400"/>
+          <a:lstStyle/>
+          <a:p>
+            <a:pPr algn="ctr"/>
+            <a:r>
+              <a:rPr sz="1400" b="1">
+                <a:solidFill>
+                  <a:srgbClr val="222222"/>
+                </a:solidFill>
+                <a:latin typeface="Meiryo"/>
+              </a:rPr>
+              <a:t>↓</a:t>
+            </a:r>
+          </a:p>
+        </p:txBody>
+      </p:sp>
+      <p:sp>
+        <p:nvSpPr>
+          <p:cNvPr id="7" name="Rectangle 6"/>
+          <p:cNvSpPr/>
+          <p:nvPr/>
+        </p:nvSpPr>
+        <p:spPr>
+          <a:xfrm>
+            <a:off x="914400" y="2514600"/>
+            <a:ext cx="6400800" cy="411480"/>
+          </a:xfrm>
+          <a:prstGeom prst="rect">
+            <a:avLst/>
+          </a:prstGeom>
+          <a:solidFill>
+            <a:srgbClr val="FFFFFF"/>
+          </a:solidFill>
+          <a:ln w="25400">
+            <a:solidFill>
+              <a:srgbClr val="CCCCCC"/>
+            </a:solidFill>
+          </a:ln>
+        </p:spPr>
+        <p:style>
+          <a:lnRef idx="1">
+            <a:schemeClr val="accent1"/>
+          </a:lnRef>
+          <a:fillRef idx="3">
+            <a:schemeClr val="accent1"/>
+          </a:fillRef>
+          <a:effectRef idx="2">
+            <a:schemeClr val="accent1"/>
+          </a:effectRef>
+          <a:fontRef idx="minor">
+            <a:schemeClr val="lt1"/>
+          </a:fontRef>
+        </p:style>
+        <p:txBody>
+          <a:bodyPr rtlCol="0" anchor="ctr" wrap="square" lIns="63500" rIns="50800" tIns="38100" bIns="38100"/>
+          <a:lstStyle/>
+          <a:p>
+            <a:pPr algn="l"/>
+            <a:r>
+              <a:rPr sz="1200" b="0">
+                <a:solidFill>
+                  <a:srgbClr val="222222"/>
+                </a:solidFill>
+                <a:latin typeface="Meiryo"/>
+              </a:rPr>
+              <a:t>「怪しいかも？」と思う余地あり</a:t>
+            </a:r>
+          </a:p>
+        </p:txBody>
+      </p:sp>
+      <p:sp>
+        <p:nvSpPr>
+          <p:cNvPr id="8" name="Rectangle 7"/>
+          <p:cNvSpPr/>
+          <p:nvPr/>
+        </p:nvSpPr>
+        <p:spPr>
+          <a:xfrm>
+            <a:off x="2286000" y="2971800"/>
+            <a:ext cx="3657600" cy="365760"/>
+          </a:xfrm>
+          <a:prstGeom prst="rect">
+            <a:avLst/>
+          </a:prstGeom>
+          <a:solidFill>
+            <a:srgbClr val="EEEEEE"/>
+          </a:solidFill>
+          <a:ln>
+            <a:noFill/>
+          </a:ln>
+        </p:spPr>
+        <p:style>
+          <a:lnRef idx="1">
+            <a:schemeClr val="accent1"/>
+          </a:lnRef>
+          <a:fillRef idx="3">
+            <a:schemeClr val="accent1"/>
+          </a:fillRef>
+          <a:effectRef idx="2">
+            <a:schemeClr val="accent1"/>
+          </a:effectRef>
+          <a:fontRef idx="minor">
+            <a:schemeClr val="lt1"/>
+          </a:fontRef>
+        </p:style>
+        <p:txBody>
+          <a:bodyPr rtlCol="0" anchor="ctr" wrap="square" lIns="50800" rIns="50800" tIns="25400" bIns="25400"/>
+          <a:lstStyle/>
+          <a:p>
+            <a:pPr algn="ctr"/>
+            <a:r>
+              <a:rPr sz="1400" b="1">
+                <a:solidFill>
+                  <a:srgbClr val="222222"/>
+                </a:solidFill>
+                <a:latin typeface="Meiryo"/>
+              </a:rPr>
+              <a:t>↓</a:t>
+            </a:r>
+          </a:p>
+        </p:txBody>
+      </p:sp>
+      <p:sp>
+        <p:nvSpPr>
+          <p:cNvPr id="9" name="Rectangle 8"/>
+          <p:cNvSpPr/>
+          <p:nvPr/>
+        </p:nvSpPr>
+        <p:spPr>
+          <a:xfrm>
+            <a:off x="914400" y="3383280"/>
+            <a:ext cx="6400800" cy="411480"/>
+          </a:xfrm>
+          <a:prstGeom prst="rect">
+            <a:avLst/>
+          </a:prstGeom>
+          <a:solidFill>
+            <a:srgbClr val="27AE60"/>
+          </a:solidFill>
+          <a:ln>
+            <a:noFill/>
+          </a:ln>
+        </p:spPr>
+        <p:style>
+          <a:lnRef idx="1">
+            <a:schemeClr val="accent1"/>
+          </a:lnRef>
+          <a:fillRef idx="3">
+            <a:schemeClr val="accent1"/>
+          </a:fillRef>
+          <a:effectRef idx="2">
+            <a:schemeClr val="accent1"/>
+          </a:effectRef>
+          <a:fontRef idx="minor">
+            <a:schemeClr val="lt1"/>
+          </a:fontRef>
+        </p:style>
+        <p:txBody>
+          <a:bodyPr rtlCol="0" anchor="ctr" wrap="square" lIns="50800" rIns="50800" tIns="25400" bIns="25400"/>
+          <a:lstStyle/>
+          <a:p>
+            <a:pPr algn="ctr"/>
+            <a:r>
+              <a:rPr sz="1100" b="1">
+                <a:solidFill>
+                  <a:srgbClr val="FFFFFF"/>
+                </a:solidFill>
+                <a:latin typeface="Meiryo"/>
+              </a:rPr>
+              <a:t>迷惑メールフィルタが防いでくれる可能性あり</a:t>
+            </a:r>
+          </a:p>
+        </p:txBody>
+      </p:sp>
+      <p:sp>
+        <p:nvSpPr>
+          <p:cNvPr id="10" name="Rectangle 9"/>
+          <p:cNvSpPr/>
+          <p:nvPr/>
+        </p:nvSpPr>
+        <p:spPr>
+          <a:xfrm>
+            <a:off x="7772400" y="1188720"/>
+            <a:ext cx="6400800" cy="411480"/>
+          </a:xfrm>
+          <a:prstGeom prst="rect">
+            <a:avLst/>
+          </a:prstGeom>
+          <a:solidFill>
+            <a:srgbClr val="C0392B"/>
+          </a:solidFill>
+          <a:ln>
+            <a:noFill/>
+          </a:ln>
+        </p:spPr>
+        <p:style>
+          <a:lnRef idx="1">
+            <a:schemeClr val="accent1"/>
+          </a:lnRef>
+          <a:fillRef idx="3">
+            <a:schemeClr val="accent1"/>
+          </a:fillRef>
+          <a:effectRef idx="2">
+            <a:schemeClr val="accent1"/>
+          </a:effectRef>
+          <a:fontRef idx="minor">
+            <a:schemeClr val="lt1"/>
+          </a:fontRef>
+        </p:style>
+        <p:txBody>
+          <a:bodyPr rtlCol="0" anchor="ctr" wrap="square" lIns="50800" rIns="50800" tIns="25400" bIns="25400"/>
+          <a:lstStyle/>
+          <a:p>
+            <a:pPr algn="ctr"/>
+            <a:r>
+              <a:rPr sz="1400" b="1">
+                <a:solidFill>
+                  <a:srgbClr val="FFFFFF"/>
+                </a:solidFill>
+                <a:latin typeface="Meiryo"/>
+              </a:rPr>
+              <a:t>この攻撃</a:t>
+            </a:r>
+          </a:p>
+        </p:txBody>
+      </p:sp>
+      <p:sp>
+        <p:nvSpPr>
+          <p:cNvPr id="11" name="Rectangle 10"/>
+          <p:cNvSpPr/>
+          <p:nvPr/>
+        </p:nvSpPr>
+        <p:spPr>
+          <a:xfrm>
+            <a:off x="7772400" y="1645920"/>
+            <a:ext cx="6400800" cy="411480"/>
+          </a:xfrm>
+          <a:prstGeom prst="rect">
+            <a:avLst/>
+          </a:prstGeom>
+          <a:solidFill>
+            <a:srgbClr val="FFFFFF"/>
+          </a:solidFill>
+          <a:ln w="25400">
+            <a:solidFill>
+              <a:srgbClr val="C0392B"/>
+            </a:solidFill>
+          </a:ln>
+        </p:spPr>
+        <p:style>
+          <a:lnRef idx="1">
+            <a:schemeClr val="accent1"/>
+          </a:lnRef>
+          <a:fillRef idx="3">
+            <a:schemeClr val="accent1"/>
+          </a:fillRef>
+          <a:effectRef idx="2">
+            <a:schemeClr val="accent1"/>
+          </a:effectRef>
+          <a:fontRef idx="minor">
+            <a:schemeClr val="lt1"/>
+          </a:fontRef>
+        </p:style>
+        <p:txBody>
+          <a:bodyPr rtlCol="0" anchor="ctr" wrap="square" lIns="63500" rIns="50800" tIns="38100" bIns="38100"/>
+          <a:lstStyle/>
+          <a:p>
+            <a:pPr algn="l"/>
+            <a:r>
+              <a:rPr sz="1200" b="1">
+                <a:solidFill>
+                  <a:srgbClr val="222222"/>
+                </a:solidFill>
+                <a:latin typeface="Meiryo"/>
+              </a:rPr>
+              <a:t>電話で「今からメール送ります」と予告</a:t>
+            </a:r>
+          </a:p>
+        </p:txBody>
+      </p:sp>
+      <p:sp>
+        <p:nvSpPr>
+          <p:cNvPr id="12" name="Rectangle 11"/>
+          <p:cNvSpPr/>
+          <p:nvPr/>
+        </p:nvSpPr>
+        <p:spPr>
+          <a:xfrm>
+            <a:off x="9144000" y="2103120"/>
+            <a:ext cx="3657600" cy="365760"/>
+          </a:xfrm>
+          <a:prstGeom prst="rect">
+            <a:avLst/>
+          </a:prstGeom>
+          <a:solidFill>
+            <a:srgbClr val="FDEDEC"/>
+          </a:solidFill>
+          <a:ln>
+            <a:noFill/>
+          </a:ln>
+        </p:spPr>
+        <p:style>
+          <a:lnRef idx="1">
+            <a:schemeClr val="accent1"/>
+          </a:lnRef>
+          <a:fillRef idx="3">
+            <a:schemeClr val="accent1"/>
+          </a:fillRef>
+          <a:effectRef idx="2">
+            <a:schemeClr val="accent1"/>
+          </a:effectRef>
+          <a:fontRef idx="minor">
+            <a:schemeClr val="lt1"/>
+          </a:fontRef>
+        </p:style>
+        <p:txBody>
+          <a:bodyPr rtlCol="0" anchor="ctr" wrap="square" lIns="50800" rIns="50800" tIns="25400" bIns="25400"/>
+          <a:lstStyle/>
+          <a:p>
+            <a:pPr algn="ctr"/>
+            <a:r>
+              <a:rPr sz="1400" b="1">
+                <a:solidFill>
+                  <a:srgbClr val="C0392B"/>
+                </a:solidFill>
+                <a:latin typeface="Meiryo"/>
+              </a:rPr>
+              <a:t>↓</a:t>
+            </a:r>
+          </a:p>
+        </p:txBody>
+      </p:sp>
+      <p:sp>
+        <p:nvSpPr>
+          <p:cNvPr id="13" name="Rectangle 12"/>
+          <p:cNvSpPr/>
+          <p:nvPr/>
+        </p:nvSpPr>
+        <p:spPr>
+          <a:xfrm>
+            <a:off x="7772400" y="2514600"/>
+            <a:ext cx="6400800" cy="411480"/>
+          </a:xfrm>
+          <a:prstGeom prst="rect">
+            <a:avLst/>
+          </a:prstGeom>
+          <a:solidFill>
+            <a:srgbClr val="FFFFFF"/>
+          </a:solidFill>
+          <a:ln w="25400">
+            <a:solidFill>
+              <a:srgbClr val="C0392B"/>
+            </a:solidFill>
+          </a:ln>
+        </p:spPr>
+        <p:style>
+          <a:lnRef idx="1">
+            <a:schemeClr val="accent1"/>
+          </a:lnRef>
+          <a:fillRef idx="3">
+            <a:schemeClr val="accent1"/>
+          </a:fillRef>
+          <a:effectRef idx="2">
+            <a:schemeClr val="accent1"/>
+          </a:effectRef>
+          <a:fontRef idx="minor">
+            <a:schemeClr val="lt1"/>
+          </a:fontRef>
+        </p:style>
+        <p:txBody>
+          <a:bodyPr rtlCol="0" anchor="ctr" wrap="square" lIns="63500" rIns="50800" tIns="38100" bIns="38100"/>
+          <a:lstStyle/>
+          <a:p>
+            <a:pPr algn="l"/>
+            <a:r>
+              <a:rPr sz="1200" b="1">
+                <a:solidFill>
+                  <a:srgbClr val="222222"/>
+                </a:solidFill>
+                <a:latin typeface="Meiryo"/>
+              </a:rPr>
+              <a:t>メール到着 →「本物だ」と確信（予告通り来たから）</a:t>
+            </a:r>
+          </a:p>
+        </p:txBody>
+      </p:sp>
+      <p:sp>
+        <p:nvSpPr>
+          <p:cNvPr id="14" name="Rectangle 13"/>
+          <p:cNvSpPr/>
+          <p:nvPr/>
+        </p:nvSpPr>
+        <p:spPr>
+          <a:xfrm>
+            <a:off x="9144000" y="2971800"/>
+            <a:ext cx="3657600" cy="365760"/>
+          </a:xfrm>
+          <a:prstGeom prst="rect">
+            <a:avLst/>
+          </a:prstGeom>
+          <a:solidFill>
+            <a:srgbClr val="FDEDEC"/>
+          </a:solidFill>
+          <a:ln>
+            <a:noFill/>
+          </a:ln>
+        </p:spPr>
+        <p:style>
+          <a:lnRef idx="1">
+            <a:schemeClr val="accent1"/>
+          </a:lnRef>
+          <a:fillRef idx="3">
+            <a:schemeClr val="accent1"/>
+          </a:fillRef>
+          <a:effectRef idx="2">
+            <a:schemeClr val="accent1"/>
+          </a:effectRef>
+          <a:fontRef idx="minor">
+            <a:schemeClr val="lt1"/>
+          </a:fontRef>
+        </p:style>
+        <p:txBody>
+          <a:bodyPr rtlCol="0" anchor="ctr" wrap="square" lIns="50800" rIns="50800" tIns="25400" bIns="25400"/>
+          <a:lstStyle/>
+          <a:p>
+            <a:pPr algn="ctr"/>
+            <a:r>
+              <a:rPr sz="1400" b="1">
+                <a:solidFill>
+                  <a:srgbClr val="C0392B"/>
+                </a:solidFill>
+                <a:latin typeface="Meiryo"/>
+              </a:rPr>
+              <a:t>↓</a:t>
+            </a:r>
+          </a:p>
+        </p:txBody>
+      </p:sp>
+      <p:sp>
+        <p:nvSpPr>
+          <p:cNvPr id="15" name="Rectangle 14"/>
+          <p:cNvSpPr/>
+          <p:nvPr/>
+        </p:nvSpPr>
+        <p:spPr>
+          <a:xfrm>
+            <a:off x="7772400" y="3383280"/>
+            <a:ext cx="6400800" cy="411480"/>
+          </a:xfrm>
+          <a:prstGeom prst="rect">
+            <a:avLst/>
+          </a:prstGeom>
+          <a:solidFill>
+            <a:srgbClr val="C0392B"/>
+          </a:solidFill>
+          <a:ln>
+            <a:noFill/>
+          </a:ln>
+        </p:spPr>
+        <p:style>
+          <a:lnRef idx="1">
+            <a:schemeClr val="accent1"/>
+          </a:lnRef>
+          <a:fillRef idx="3">
+            <a:schemeClr val="accent1"/>
+          </a:fillRef>
+          <a:effectRef idx="2">
+            <a:schemeClr val="accent1"/>
+          </a:effectRef>
+          <a:fontRef idx="minor">
+            <a:schemeClr val="lt1"/>
+          </a:fontRef>
+        </p:style>
+        <p:txBody>
+          <a:bodyPr rtlCol="0" anchor="ctr" wrap="square" lIns="50800" rIns="50800" tIns="25400" bIns="25400"/>
+          <a:lstStyle/>
+          <a:p>
+            <a:pPr algn="ctr"/>
+            <a:r>
+              <a:rPr sz="1100" b="1">
+                <a:solidFill>
+                  <a:srgbClr val="FFFFFF"/>
+                </a:solidFill>
+                <a:latin typeface="Meiryo"/>
+              </a:rPr>
+              <a:t>電話 × メールの二重チャネルが相互に信頼性を補強</a:t>
+            </a:r>
+          </a:p>
+        </p:txBody>
+      </p:sp>
+      <p:sp>
+        <p:nvSpPr>
+          <p:cNvPr id="16" name="Rectangle 15"/>
+          <p:cNvSpPr/>
+          <p:nvPr/>
+        </p:nvSpPr>
+        <p:spPr>
+          <a:xfrm>
+            <a:off x="914400" y="4114800"/>
+            <a:ext cx="13258800" cy="457200"/>
+          </a:xfrm>
+          <a:prstGeom prst="rect">
+            <a:avLst/>
+          </a:prstGeom>
+          <a:solidFill>
+            <a:srgbClr val="222222"/>
+          </a:solidFill>
+          <a:ln>
+            <a:noFill/>
+          </a:ln>
+        </p:spPr>
+        <p:style>
+          <a:lnRef idx="1">
+            <a:schemeClr val="accent1"/>
+          </a:lnRef>
+          <a:fillRef idx="3">
+            <a:schemeClr val="accent1"/>
+          </a:fillRef>
+          <a:effectRef idx="2">
+            <a:schemeClr val="accent1"/>
+          </a:effectRef>
+          <a:fontRef idx="minor">
+            <a:schemeClr val="lt1"/>
+          </a:fontRef>
+        </p:style>
+        <p:txBody>
+          <a:bodyPr rtlCol="0" anchor="ctr" wrap="square" lIns="50800" rIns="50800" tIns="25400" bIns="25400"/>
+          <a:lstStyle/>
+          <a:p>
+            <a:pPr algn="ctr"/>
+            <a:r>
+              <a:rPr sz="1400" b="1">
+                <a:solidFill>
+                  <a:srgbClr val="FFFFFF"/>
+                </a:solidFill>
+                <a:latin typeface="Meiryo"/>
+              </a:rPr>
+              <a:t>迷惑メールフィルタに入った場合も、電話1本で無力化される</a:t>
+            </a:r>
+          </a:p>
+        </p:txBody>
+      </p:sp>
+      <p:sp>
+        <p:nvSpPr>
+          <p:cNvPr id="17" name="Rectangle 16"/>
+          <p:cNvSpPr/>
+          <p:nvPr/>
+        </p:nvSpPr>
+        <p:spPr>
+          <a:xfrm>
+            <a:off x="914400" y="4663440"/>
+            <a:ext cx="3017520" cy="502920"/>
+          </a:xfrm>
+          <a:prstGeom prst="rect">
+            <a:avLst/>
+          </a:prstGeom>
+          <a:solidFill>
+            <a:srgbClr val="FFFFFF"/>
+          </a:solidFill>
+          <a:ln w="25400">
+            <a:solidFill>
+              <a:srgbClr val="E67E22"/>
+            </a:solidFill>
+          </a:ln>
+        </p:spPr>
+        <p:style>
+          <a:lnRef idx="1">
+            <a:schemeClr val="accent1"/>
+          </a:lnRef>
+          <a:fillRef idx="3">
+            <a:schemeClr val="accent1"/>
+          </a:fillRef>
+          <a:effectRef idx="2">
+            <a:schemeClr val="accent1"/>
+          </a:effectRef>
+          <a:fontRef idx="minor">
+            <a:schemeClr val="lt1"/>
+          </a:fontRef>
+        </p:style>
+        <p:txBody>
+          <a:bodyPr rtlCol="0" anchor="ctr" wrap="square" lIns="63500" rIns="50800" tIns="38100" bIns="38100"/>
+          <a:lstStyle/>
+          <a:p>
+            <a:pPr algn="ctr"/>
+            <a:r>
+              <a:rPr sz="1000" b="1">
+                <a:solidFill>
+                  <a:srgbClr val="222222"/>
+                </a:solidFill>
+                <a:latin typeface="Meiryo"/>
+              </a:rPr>
+              <a:t>メールが迷惑フォルダへ</a:t>
+            </a:r>
+          </a:p>
+        </p:txBody>
+      </p:sp>
+      <p:sp>
+        <p:nvSpPr>
+          <p:cNvPr id="18" name="TextBox 17"/>
+          <p:cNvSpPr txBox="1"/>
+          <p:nvPr/>
+        </p:nvSpPr>
+        <p:spPr>
+          <a:xfrm>
+            <a:off x="3977639" y="4736592"/>
+            <a:ext cx="365760" cy="365760"/>
+          </a:xfrm>
+          <a:prstGeom prst="rect">
+            <a:avLst/>
+          </a:prstGeom>
+          <a:noFill/>
+        </p:spPr>
+        <p:txBody>
+          <a:bodyPr wrap="square" lIns="50800" rIns="50800" tIns="38100" bIns="38100"/>
+          <a:lstStyle/>
+          <a:p>
+            <a:pPr algn="ctr"/>
+            <a:r>
+              <a:rPr sz="1600" b="1">
+                <a:solidFill>
+                  <a:srgbClr val="C0392B"/>
+                </a:solidFill>
+                <a:latin typeface="Meiryo"/>
+              </a:rPr>
+              <a:t>→</a:t>
+            </a:r>
+          </a:p>
+        </p:txBody>
+      </p:sp>
+      <p:sp>
+        <p:nvSpPr>
+          <p:cNvPr id="19" name="Rectangle 18"/>
+          <p:cNvSpPr/>
+          <p:nvPr/>
+        </p:nvSpPr>
+        <p:spPr>
+          <a:xfrm>
+            <a:off x="4389120" y="4663440"/>
+            <a:ext cx="3017520" cy="502920"/>
+          </a:xfrm>
+          <a:prstGeom prst="rect">
+            <a:avLst/>
+          </a:prstGeom>
+          <a:solidFill>
+            <a:srgbClr val="FFFFFF"/>
+          </a:solidFill>
+          <a:ln w="25400">
+            <a:solidFill>
+              <a:srgbClr val="E67E22"/>
+            </a:solidFill>
+          </a:ln>
+        </p:spPr>
+        <p:style>
+          <a:lnRef idx="1">
+            <a:schemeClr val="accent1"/>
+          </a:lnRef>
+          <a:fillRef idx="3">
+            <a:schemeClr val="accent1"/>
+          </a:fillRef>
+          <a:effectRef idx="2">
+            <a:schemeClr val="accent1"/>
+          </a:effectRef>
+          <a:fontRef idx="minor">
+            <a:schemeClr val="lt1"/>
+          </a:fontRef>
+        </p:style>
+        <p:txBody>
+          <a:bodyPr rtlCol="0" anchor="ctr" wrap="square" lIns="63500" rIns="50800" tIns="38100" bIns="38100"/>
+          <a:lstStyle/>
+          <a:p>
+            <a:pPr algn="ctr"/>
+            <a:r>
+              <a:rPr sz="1000" b="0">
+                <a:solidFill>
+                  <a:srgbClr val="222222"/>
+                </a:solidFill>
+                <a:latin typeface="Meiryo"/>
+              </a:rPr>
+              <a:t>被害者「メール来てません」</a:t>
+            </a:r>
+          </a:p>
+        </p:txBody>
+      </p:sp>
+      <p:sp>
+        <p:nvSpPr>
+          <p:cNvPr id="20" name="TextBox 19"/>
+          <p:cNvSpPr txBox="1"/>
+          <p:nvPr/>
+        </p:nvSpPr>
+        <p:spPr>
+          <a:xfrm>
+            <a:off x="7452360" y="4736592"/>
+            <a:ext cx="365760" cy="365760"/>
+          </a:xfrm>
+          <a:prstGeom prst="rect">
+            <a:avLst/>
+          </a:prstGeom>
+          <a:noFill/>
+        </p:spPr>
+        <p:txBody>
+          <a:bodyPr wrap="square" lIns="50800" rIns="50800" tIns="38100" bIns="38100"/>
+          <a:lstStyle/>
+          <a:p>
+            <a:pPr algn="ctr"/>
+            <a:r>
+              <a:rPr sz="1600" b="1">
+                <a:solidFill>
+                  <a:srgbClr val="C0392B"/>
+                </a:solidFill>
+                <a:latin typeface="Meiryo"/>
+              </a:rPr>
+              <a:t>→</a:t>
+            </a:r>
+          </a:p>
+        </p:txBody>
+      </p:sp>
+      <p:sp>
+        <p:nvSpPr>
+          <p:cNvPr id="21" name="Rectangle 20"/>
+          <p:cNvSpPr/>
+          <p:nvPr/>
+        </p:nvSpPr>
+        <p:spPr>
+          <a:xfrm>
+            <a:off x="7863840" y="4663440"/>
+            <a:ext cx="3200400" cy="502920"/>
+          </a:xfrm>
+          <a:prstGeom prst="rect">
+            <a:avLst/>
+          </a:prstGeom>
+          <a:solidFill>
+            <a:srgbClr val="FDF2E9"/>
+          </a:solidFill>
+          <a:ln w="25400">
+            <a:solidFill>
+              <a:srgbClr val="E67E22"/>
+            </a:solidFill>
+          </a:ln>
+        </p:spPr>
+        <p:style>
+          <a:lnRef idx="1">
+            <a:schemeClr val="accent1"/>
+          </a:lnRef>
+          <a:fillRef idx="3">
+            <a:schemeClr val="accent1"/>
+          </a:fillRef>
+          <a:effectRef idx="2">
+            <a:schemeClr val="accent1"/>
+          </a:effectRef>
+          <a:fontRef idx="minor">
+            <a:schemeClr val="lt1"/>
+          </a:fontRef>
+        </p:style>
+        <p:txBody>
+          <a:bodyPr rtlCol="0" anchor="ctr" wrap="square" lIns="63500" rIns="50800" tIns="38100" bIns="38100"/>
+          <a:lstStyle/>
+          <a:p>
+            <a:pPr algn="ctr"/>
+            <a:r>
+              <a:rPr sz="1000" b="0">
+                <a:solidFill>
+                  <a:srgbClr val="222222"/>
+                </a:solidFill>
+                <a:latin typeface="Meiryo"/>
+              </a:rPr>
+              <a:t>犯人「迷惑メールフォルダを
+確認してください」</a:t>
+            </a:r>
+          </a:p>
+        </p:txBody>
+      </p:sp>
+      <p:sp>
+        <p:nvSpPr>
+          <p:cNvPr id="22" name="TextBox 21"/>
+          <p:cNvSpPr txBox="1"/>
+          <p:nvPr/>
+        </p:nvSpPr>
+        <p:spPr>
+          <a:xfrm>
+            <a:off x="11109960" y="4736592"/>
+            <a:ext cx="365760" cy="365760"/>
+          </a:xfrm>
+          <a:prstGeom prst="rect">
+            <a:avLst/>
+          </a:prstGeom>
+          <a:noFill/>
+        </p:spPr>
+        <p:txBody>
+          <a:bodyPr wrap="square" lIns="50800" rIns="50800" tIns="38100" bIns="38100"/>
+          <a:lstStyle/>
+          <a:p>
+            <a:pPr algn="ctr"/>
+            <a:r>
+              <a:rPr sz="1600" b="1">
+                <a:solidFill>
+                  <a:srgbClr val="C0392B"/>
+                </a:solidFill>
+                <a:latin typeface="Meiryo"/>
+              </a:rPr>
+              <a:t>→</a:t>
+            </a:r>
+          </a:p>
+        </p:txBody>
+      </p:sp>
+      <p:sp>
+        <p:nvSpPr>
+          <p:cNvPr id="23" name="Rectangle 22"/>
+          <p:cNvSpPr/>
+          <p:nvPr/>
+        </p:nvSpPr>
+        <p:spPr>
+          <a:xfrm>
+            <a:off x="11521440" y="4663440"/>
+            <a:ext cx="2651760" cy="502920"/>
+          </a:xfrm>
+          <a:prstGeom prst="rect">
+            <a:avLst/>
+          </a:prstGeom>
+          <a:solidFill>
+            <a:srgbClr val="FDEDEC"/>
+          </a:solidFill>
+          <a:ln w="25400">
+            <a:solidFill>
+              <a:srgbClr val="C0392B"/>
+            </a:solidFill>
+          </a:ln>
+        </p:spPr>
+        <p:style>
+          <a:lnRef idx="1">
+            <a:schemeClr val="accent1"/>
+          </a:lnRef>
+          <a:fillRef idx="3">
+            <a:schemeClr val="accent1"/>
+          </a:fillRef>
+          <a:effectRef idx="2">
+            <a:schemeClr val="accent1"/>
+          </a:effectRef>
+          <a:fontRef idx="minor">
+            <a:schemeClr val="lt1"/>
+          </a:fontRef>
+        </p:style>
+        <p:txBody>
+          <a:bodyPr rtlCol="0" anchor="ctr" wrap="square" lIns="63500" rIns="50800" tIns="38100" bIns="38100"/>
+          <a:lstStyle/>
+          <a:p>
+            <a:pPr algn="ctr"/>
+            <a:r>
+              <a:rPr sz="1000" b="1">
+                <a:solidFill>
+                  <a:srgbClr val="222222"/>
+                </a:solidFill>
+                <a:latin typeface="Meiryo"/>
+              </a:rPr>
+              <a:t>被害者が自ら発見
+→ 攻撃続行</a:t>
+            </a:r>
+          </a:p>
+        </p:txBody>
+      </p:sp>
+      <p:sp>
+        <p:nvSpPr>
+          <p:cNvPr id="24" name="Rectangle 23"/>
+          <p:cNvSpPr/>
+          <p:nvPr/>
+        </p:nvSpPr>
+        <p:spPr>
+          <a:xfrm>
+            <a:off x="914400" y="5349240"/>
+            <a:ext cx="13258800" cy="640080"/>
+          </a:xfrm>
+          <a:prstGeom prst="rect">
+            <a:avLst/>
+          </a:prstGeom>
+          <a:solidFill>
+            <a:srgbClr val="FFF3CD"/>
+          </a:solidFill>
+          <a:ln>
+            <a:noFill/>
+          </a:ln>
+        </p:spPr>
+        <p:style>
+          <a:lnRef idx="1">
+            <a:schemeClr val="accent1"/>
+          </a:lnRef>
+          <a:fillRef idx="3">
+            <a:schemeClr val="accent1"/>
+          </a:fillRef>
+          <a:effectRef idx="2">
+            <a:schemeClr val="accent1"/>
+          </a:effectRef>
+          <a:fontRef idx="minor">
+            <a:schemeClr val="lt1"/>
+          </a:fontRef>
+        </p:style>
+        <p:txBody>
+          <a:bodyPr rtlCol="0" anchor="ctr" wrap="square" lIns="50800" rIns="50800" tIns="25400" bIns="25400"/>
+          <a:lstStyle/>
+          <a:p>
+            <a:pPr algn="ctr"/>
+            <a:r>
+              <a:rPr sz="100" b="1">
+                <a:solidFill>
+                  <a:srgbClr val="222222"/>
+                </a:solidFill>
+                <a:latin typeface="Meiryo"/>
+              </a:rPr>
+              <a:t/>
+            </a:r>
+          </a:p>
+        </p:txBody>
+      </p:sp>
+      <p:sp>
+        <p:nvSpPr>
+          <p:cNvPr id="25" name="TextBox 24"/>
+          <p:cNvSpPr txBox="1"/>
+          <p:nvPr/>
+        </p:nvSpPr>
+        <p:spPr>
+          <a:xfrm>
+            <a:off x="1097280" y="5376672"/>
+            <a:ext cx="12801600" cy="594360"/>
+          </a:xfrm>
+          <a:prstGeom prst="rect">
+            <a:avLst/>
+          </a:prstGeom>
+          <a:noFill/>
+        </p:spPr>
+        <p:txBody>
+          <a:bodyPr wrap="square" lIns="50800" rIns="50800" tIns="38100" bIns="38100"/>
+          <a:lstStyle/>
+          <a:p>
+            <a:pPr algn="l"/>
+            <a:r>
+              <a:rPr sz="1100" b="0">
+                <a:solidFill>
+                  <a:srgbClr val="222222"/>
+                </a:solidFill>
+                <a:latin typeface="Meiryo"/>
+              </a:rPr>
+              <a:t>さらに悪いことに：迷惑フォルダに入っていたことが、手順②の話を補強してしまう
+「重要なメールがフィルタに引っかかっていた → だから口座更新の案内に気づけなかったんだ」
+→ 被害者はますます犯人の話を信じる</a:t>
+            </a:r>
+          </a:p>
+        </p:txBody>
+      </p:sp>
+      <p:sp>
+        <p:nvSpPr>
+          <p:cNvPr id="26" name="Rectangle 25"/>
+          <p:cNvSpPr/>
+          <p:nvPr/>
+        </p:nvSpPr>
+        <p:spPr>
+          <a:xfrm>
+            <a:off x="914400" y="6172200"/>
+            <a:ext cx="13258800" cy="457200"/>
+          </a:xfrm>
+          <a:prstGeom prst="rect">
+            <a:avLst/>
+          </a:prstGeom>
+          <a:solidFill>
+            <a:srgbClr val="C0392B"/>
+          </a:solidFill>
+          <a:ln>
+            <a:noFill/>
+          </a:ln>
+        </p:spPr>
+        <p:style>
+          <a:lnRef idx="1">
+            <a:schemeClr val="accent1"/>
+          </a:lnRef>
+          <a:fillRef idx="3">
+            <a:schemeClr val="accent1"/>
+          </a:fillRef>
+          <a:effectRef idx="2">
+            <a:schemeClr val="accent1"/>
+          </a:effectRef>
+          <a:fontRef idx="minor">
+            <a:schemeClr val="lt1"/>
+          </a:fontRef>
+        </p:style>
+        <p:txBody>
+          <a:bodyPr rtlCol="0" anchor="ctr" wrap="square" lIns="50800" rIns="50800" tIns="25400" bIns="25400"/>
+          <a:lstStyle/>
+          <a:p>
+            <a:pPr algn="ctr"/>
+            <a:r>
+              <a:rPr sz="1400" b="1">
+                <a:solidFill>
+                  <a:srgbClr val="FFFFFF"/>
+                </a:solidFill>
+                <a:latin typeface="Meiryo"/>
+              </a:rPr>
+              <a:t>メールセキュリティの最後の砦である迷惑メールフィルタも、電話1本で無力化される</a:t>
+            </a:r>
+          </a:p>
+        </p:txBody>
+      </p:sp>
+      <p:sp>
+        <p:nvSpPr>
+          <p:cNvPr id="27" name="TextBox 26"/>
+          <p:cNvSpPr txBox="1"/>
+          <p:nvPr/>
+        </p:nvSpPr>
+        <p:spPr>
+          <a:xfrm>
+            <a:off x="9144000" y="10378440"/>
+            <a:ext cx="5943600" cy="228600"/>
+          </a:xfrm>
+          <a:prstGeom prst="rect">
+            <a:avLst/>
+          </a:prstGeom>
+          <a:noFill/>
+        </p:spPr>
+        <p:txBody>
+          <a:bodyPr wrap="square" lIns="50800" rIns="50800" tIns="38100" bIns="38100"/>
+          <a:lstStyle/>
+          <a:p>
+            <a:pPr algn="r"/>
+            <a:r>
+              <a:rPr sz="700" b="0">
+                <a:solidFill>
+                  <a:srgbClr val="888888"/>
+                </a:solidFill>
+                <a:latin typeface="Meiryo"/>
+              </a:rPr>
+              <a:t>Fraud Kill Chain — 手順④ フィッシングメールと迷惑メールフィルタ回避</a:t>
             </a:r>
           </a:p>
         </p:txBody>

</xml_diff>

<commit_message>
Fix slide 6: fake email never reaches inbox (SPF/DKIM/DMARC fail)
"Check your spam folder" is a phrase a real bank would never say,
making it a structural flaw point - but step 2's fear prevents
victims from noticing. Both step 3 and 4 flaws share this pattern.

https://claude.ai/code/session_01F7t8LKifK43o6sCdF2a3gQ
</commit_message>
<xml_diff>
--- a/Fraud_Kill_Chain.pptx
+++ b/Fraud_Kill_Chain.pptx
@@ -14513,13 +14513,13 @@
           <a:p>
             <a:pPr algn="ctr"/>
             <a:r>
-              <a:rPr sz="1400" b="1">
+              <a:rPr sz="1200" b="1">
                 <a:solidFill>
                   <a:srgbClr val="FFFFFF"/>
                 </a:solidFill>
                 <a:latin typeface="Meiryo"/>
               </a:rPr>
-              <a:t>迷惑メールフィルタに入った場合も、電話1本で無力化される</a:t>
+              <a:t>偽メールは正規フォルダに入らない（SPF/DKIM/DMARC不通過）→ ほぼ確実に迷惑フォルダ行き</a:t>
             </a:r>
           </a:p>
         </p:txBody>
@@ -14849,14 +14849,14 @@
         </p:nvSpPr>
         <p:spPr>
           <a:xfrm>
-            <a:off x="914400" y="5349240"/>
-            <a:ext cx="13258800" cy="640080"/>
-          </a:xfrm>
-          <a:prstGeom prst="rect">
-            <a:avLst/>
-          </a:prstGeom>
-          <a:solidFill>
-            <a:srgbClr val="FFF3CD"/>
+            <a:off x="914400" y="5303520"/>
+            <a:ext cx="13258800" cy="457200"/>
+          </a:xfrm>
+          <a:prstGeom prst="rect">
+            <a:avLst/>
+          </a:prstGeom>
+          <a:solidFill>
+            <a:srgbClr val="C0392B"/>
           </a:solidFill>
           <a:ln>
             <a:noFill/>
@@ -14882,6 +14882,58 @@
           <a:p>
             <a:pPr algn="ctr"/>
             <a:r>
+              <a:rPr sz="1300" b="1">
+                <a:solidFill>
+                  <a:srgbClr val="FFFFFF"/>
+                </a:solidFill>
+                <a:latin typeface="Meiryo"/>
+              </a:rPr>
+              <a:t>⚠ 破綻ポイント：「迷惑フォルダを確認して」＝ 銀行が絶対に言わないセリフ ＝ 100%詐欺</a:t>
+            </a:r>
+          </a:p>
+        </p:txBody>
+      </p:sp>
+      <p:sp>
+        <p:nvSpPr>
+          <p:cNvPr id="25" name="Rectangle 24"/>
+          <p:cNvSpPr/>
+          <p:nvPr/>
+        </p:nvSpPr>
+        <p:spPr>
+          <a:xfrm>
+            <a:off x="914400" y="5852160"/>
+            <a:ext cx="13258800" cy="640080"/>
+          </a:xfrm>
+          <a:prstGeom prst="rect">
+            <a:avLst/>
+          </a:prstGeom>
+          <a:solidFill>
+            <a:srgbClr val="FFF3CD"/>
+          </a:solidFill>
+          <a:ln>
+            <a:noFill/>
+          </a:ln>
+        </p:spPr>
+        <p:style>
+          <a:lnRef idx="1">
+            <a:schemeClr val="accent1"/>
+          </a:lnRef>
+          <a:fillRef idx="3">
+            <a:schemeClr val="accent1"/>
+          </a:fillRef>
+          <a:effectRef idx="2">
+            <a:schemeClr val="accent1"/>
+          </a:effectRef>
+          <a:fontRef idx="minor">
+            <a:schemeClr val="lt1"/>
+          </a:fontRef>
+        </p:style>
+        <p:txBody>
+          <a:bodyPr rtlCol="0" anchor="ctr" wrap="square" lIns="50800" rIns="50800" tIns="25400" bIns="25400"/>
+          <a:lstStyle/>
+          <a:p>
+            <a:pPr algn="ctr"/>
+            <a:r>
               <a:rPr sz="100" b="1">
                 <a:solidFill>
                   <a:srgbClr val="222222"/>
@@ -14895,13 +14947,13 @@
       </p:sp>
       <p:sp>
         <p:nvSpPr>
-          <p:cNvPr id="25" name="TextBox 24"/>
+          <p:cNvPr id="26" name="TextBox 25"/>
           <p:cNvSpPr txBox="1"/>
           <p:nvPr/>
         </p:nvSpPr>
         <p:spPr>
           <a:xfrm>
-            <a:off x="1097280" y="5376672"/>
+            <a:off x="1097280" y="5879592"/>
             <a:ext cx="12801600" cy="594360"/>
           </a:xfrm>
           <a:prstGeom prst="rect">
@@ -14921,7 +14973,7 @@
                 </a:solidFill>
                 <a:latin typeface="Meiryo"/>
               </a:rPr>
-              <a:t>さらに悪いことに：迷惑フォルダに入っていたことが、手順②の話を補強してしまう
+              <a:t>しかし気づけない。さらに悪いことに、迷惑フォルダに入っていたことが手順②の話を補強してしまう
 「重要なメールがフィルタに引っかかっていた → だから口座更新の案内に気づけなかったんだ」
 → 被害者はますます犯人の話を信じる</a:t>
             </a:r>
@@ -14930,20 +14982,20 @@
       </p:sp>
       <p:sp>
         <p:nvSpPr>
-          <p:cNvPr id="26" name="Rectangle 25"/>
-          <p:cNvSpPr/>
-          <p:nvPr/>
-        </p:nvSpPr>
-        <p:spPr>
-          <a:xfrm>
-            <a:off x="914400" y="6172200"/>
+          <p:cNvPr id="27" name="Rectangle 26"/>
+          <p:cNvSpPr/>
+          <p:nvPr/>
+        </p:nvSpPr>
+        <p:spPr>
+          <a:xfrm>
+            <a:off x="914400" y="6675120"/>
             <a:ext cx="13258800" cy="457200"/>
           </a:xfrm>
           <a:prstGeom prst="rect">
             <a:avLst/>
           </a:prstGeom>
           <a:solidFill>
-            <a:srgbClr val="C0392B"/>
+            <a:srgbClr val="222222"/>
           </a:solidFill>
           <a:ln>
             <a:noFill/>
@@ -14975,14 +15027,14 @@
                 </a:solidFill>
                 <a:latin typeface="Meiryo"/>
               </a:rPr>
-              <a:t>メールセキュリティの最後の砦である迷惑メールフィルタも、電話1本で無力化される</a:t>
-            </a:r>
-          </a:p>
-        </p:txBody>
-      </p:sp>
-      <p:sp>
-        <p:nvSpPr>
-          <p:cNvPr id="27" name="TextBox 26"/>
+              <a:t>手順②の恐怖が全ての破綻ポイント（③メアド、④迷惑フォルダ）を無効化している</a:t>
+            </a:r>
+          </a:p>
+        </p:txBody>
+      </p:sp>
+      <p:sp>
+        <p:nvSpPr>
+          <p:cNvPr id="28" name="TextBox 27"/>
           <p:cNvSpPr txBox="1"/>
           <p:nvPr/>
         </p:nvSpPr>

</xml_diff>

<commit_message>
Add slide 7: DMARC + DNS countermeasures to cut kill chain at step 4
DMARC p=reject blocks domain spoofing. Defensive domain registration,
NRD blocking, SPF/DKIM enforcement, and GW whitelisting cover
lookalike domains too. Technically solvable — just needs to be done.

https://claude.ai/code/session_01F7t8LKifK43o6sCdF2a3gQ
</commit_message>
<xml_diff>
--- a/Fraud_Kill_Chain.pptx
+++ b/Fraud_Kill_Chain.pptx
@@ -11,6 +11,7 @@
     <p:sldId id="259" r:id="rId10"/>
     <p:sldId id="260" r:id="rId11"/>
     <p:sldId id="261" r:id="rId12"/>
+    <p:sldId id="262" r:id="rId13"/>
   </p:sldIdLst>
   <p:sldSz cx="15124176" cy="10689336" type="screen4x3"/>
   <p:notesSz cx="6858000" cy="9144000"/>
@@ -15061,6 +15062,2723 @@
                 <a:latin typeface="Meiryo"/>
               </a:rPr>
               <a:t>Fraud Kill Chain — 手順④ フィッシングメールと迷惑メールフィルタ回避</a:t>
+            </a:r>
+          </a:p>
+        </p:txBody>
+      </p:sp>
+    </p:spTree>
+  </p:cSld>
+  <p:clrMapOvr>
+    <a:masterClrMapping/>
+  </p:clrMapOvr>
+</p:sld>
+</file>
+
+<file path=ppt/slides/slide7.xml><?xml version="1.0" encoding="utf-8"?>
+<p:sld xmlns:a="http://schemas.openxmlformats.org/drawingml/2006/main" xmlns:p="http://schemas.openxmlformats.org/presentationml/2006/main" xmlns:r="http://schemas.openxmlformats.org/officeDocument/2006/relationships">
+  <p:cSld>
+    <p:bg>
+      <p:bgPr>
+        <a:solidFill>
+          <a:srgbClr val="F5F5F5"/>
+        </a:solidFill>
+        <a:effectLst/>
+      </p:bgPr>
+    </p:bg>
+    <p:spTree>
+      <p:nvGrpSpPr>
+        <p:cNvPr id="1" name=""/>
+        <p:cNvGrpSpPr/>
+        <p:nvPr/>
+      </p:nvGrpSpPr>
+      <p:grpSpPr/>
+      <p:sp>
+        <p:nvSpPr>
+          <p:cNvPr id="2" name="TextBox 1"/>
+          <p:cNvSpPr txBox="1"/>
+          <p:nvPr/>
+        </p:nvSpPr>
+        <p:spPr>
+          <a:xfrm>
+            <a:off x="0" y="182880"/>
+            <a:ext cx="15124176" cy="548640"/>
+          </a:xfrm>
+          <a:prstGeom prst="rect">
+            <a:avLst/>
+          </a:prstGeom>
+          <a:noFill/>
+        </p:spPr>
+        <p:txBody>
+          <a:bodyPr wrap="square" lIns="50800" rIns="50800" tIns="38100" bIns="38100"/>
+          <a:lstStyle/>
+          <a:p>
+            <a:pPr algn="ctr"/>
+            <a:r>
+              <a:rPr sz="2200" b="1">
+                <a:solidFill>
+                  <a:srgbClr val="27AE60"/>
+                </a:solidFill>
+                <a:latin typeface="Meiryo"/>
+              </a:rPr>
+              <a:t>技術的対策：DMARC＋DNSで手順④を確実に遮断できる</a:t>
+            </a:r>
+          </a:p>
+        </p:txBody>
+      </p:sp>
+      <p:sp>
+        <p:nvSpPr>
+          <p:cNvPr id="3" name="TextBox 2"/>
+          <p:cNvSpPr txBox="1"/>
+          <p:nvPr/>
+        </p:nvSpPr>
+        <p:spPr>
+          <a:xfrm>
+            <a:off x="0" y="685800"/>
+            <a:ext cx="15124176" cy="365760"/>
+          </a:xfrm>
+          <a:prstGeom prst="rect">
+            <a:avLst/>
+          </a:prstGeom>
+          <a:noFill/>
+        </p:spPr>
+        <p:txBody>
+          <a:bodyPr wrap="square" lIns="50800" rIns="50800" tIns="38100" bIns="38100"/>
+          <a:lstStyle/>
+          <a:p>
+            <a:pPr algn="ctr"/>
+            <a:r>
+              <a:rPr sz="1200" b="0">
+                <a:solidFill>
+                  <a:srgbClr val="888888"/>
+                </a:solidFill>
+                <a:latin typeface="Meiryo"/>
+              </a:rPr>
+              <a:t>顧客の注意力に一切依存せず、銀行側の設定だけでKill Chainを切れる。技術的にはもう解決できる話。</a:t>
+            </a:r>
+          </a:p>
+        </p:txBody>
+      </p:sp>
+      <p:sp>
+        <p:nvSpPr>
+          <p:cNvPr id="4" name="Rectangle 3"/>
+          <p:cNvSpPr/>
+          <p:nvPr/>
+        </p:nvSpPr>
+        <p:spPr>
+          <a:xfrm>
+            <a:off x="731520" y="1188720"/>
+            <a:ext cx="13624560" cy="411480"/>
+          </a:xfrm>
+          <a:prstGeom prst="rect">
+            <a:avLst/>
+          </a:prstGeom>
+          <a:solidFill>
+            <a:srgbClr val="222222"/>
+          </a:solidFill>
+          <a:ln>
+            <a:noFill/>
+          </a:ln>
+        </p:spPr>
+        <p:style>
+          <a:lnRef idx="1">
+            <a:schemeClr val="accent1"/>
+          </a:lnRef>
+          <a:fillRef idx="3">
+            <a:schemeClr val="accent1"/>
+          </a:fillRef>
+          <a:effectRef idx="2">
+            <a:schemeClr val="accent1"/>
+          </a:effectRef>
+          <a:fontRef idx="minor">
+            <a:schemeClr val="lt1"/>
+          </a:fontRef>
+        </p:style>
+        <p:txBody>
+          <a:bodyPr rtlCol="0" anchor="ctr" wrap="square" lIns="50800" rIns="50800" tIns="25400" bIns="25400"/>
+          <a:lstStyle/>
+          <a:p>
+            <a:pPr algn="ctr"/>
+            <a:r>
+              <a:rPr sz="1300" b="1">
+                <a:solidFill>
+                  <a:srgbClr val="FFFFFF"/>
+                </a:solidFill>
+                <a:latin typeface="Meiryo"/>
+              </a:rPr>
+              <a:t>DMARCポリシーの違い — p=reject で正規ドメイン詐称を完全遮断</a:t>
+            </a:r>
+          </a:p>
+        </p:txBody>
+      </p:sp>
+      <p:sp>
+        <p:nvSpPr>
+          <p:cNvPr id="5" name="Rectangle 4"/>
+          <p:cNvSpPr/>
+          <p:nvPr/>
+        </p:nvSpPr>
+        <p:spPr>
+          <a:xfrm>
+            <a:off x="731520" y="1600200"/>
+            <a:ext cx="3200400" cy="457200"/>
+          </a:xfrm>
+          <a:prstGeom prst="rect">
+            <a:avLst/>
+          </a:prstGeom>
+          <a:solidFill>
+            <a:srgbClr val="FFFFFF"/>
+          </a:solidFill>
+          <a:ln w="25400">
+            <a:solidFill>
+              <a:srgbClr val="CCCCCC"/>
+            </a:solidFill>
+          </a:ln>
+        </p:spPr>
+        <p:style>
+          <a:lnRef idx="1">
+            <a:schemeClr val="accent1"/>
+          </a:lnRef>
+          <a:fillRef idx="3">
+            <a:schemeClr val="accent1"/>
+          </a:fillRef>
+          <a:effectRef idx="2">
+            <a:schemeClr val="accent1"/>
+          </a:effectRef>
+          <a:fontRef idx="minor">
+            <a:schemeClr val="lt1"/>
+          </a:fontRef>
+        </p:style>
+        <p:txBody>
+          <a:bodyPr rtlCol="0" anchor="ctr" wrap="square" lIns="63500" rIns="50800" tIns="38100" bIns="38100"/>
+          <a:lstStyle/>
+          <a:p>
+            <a:pPr algn="l"/>
+            <a:r>
+              <a:rPr sz="1000" b="1">
+                <a:solidFill>
+                  <a:srgbClr val="222222"/>
+                </a:solidFill>
+                <a:latin typeface="Meiryo"/>
+              </a:rPr>
+              <a:t>p=none（監視のみ）</a:t>
+            </a:r>
+          </a:p>
+        </p:txBody>
+      </p:sp>
+      <p:sp>
+        <p:nvSpPr>
+          <p:cNvPr id="6" name="Rectangle 5"/>
+          <p:cNvSpPr/>
+          <p:nvPr/>
+        </p:nvSpPr>
+        <p:spPr>
+          <a:xfrm>
+            <a:off x="3931920" y="1600200"/>
+            <a:ext cx="5029200" cy="457200"/>
+          </a:xfrm>
+          <a:prstGeom prst="rect">
+            <a:avLst/>
+          </a:prstGeom>
+          <a:solidFill>
+            <a:srgbClr val="FFFFFF"/>
+          </a:solidFill>
+          <a:ln w="25400">
+            <a:solidFill>
+              <a:srgbClr val="CCCCCC"/>
+            </a:solidFill>
+          </a:ln>
+        </p:spPr>
+        <p:style>
+          <a:lnRef idx="1">
+            <a:schemeClr val="accent1"/>
+          </a:lnRef>
+          <a:fillRef idx="3">
+            <a:schemeClr val="accent1"/>
+          </a:fillRef>
+          <a:effectRef idx="2">
+            <a:schemeClr val="accent1"/>
+          </a:effectRef>
+          <a:fontRef idx="minor">
+            <a:schemeClr val="lt1"/>
+          </a:fontRef>
+        </p:style>
+        <p:txBody>
+          <a:bodyPr rtlCol="0" anchor="ctr" wrap="square" lIns="63500" rIns="50800" tIns="38100" bIns="38100"/>
+          <a:lstStyle/>
+          <a:p>
+            <a:pPr algn="l"/>
+            <a:r>
+              <a:rPr sz="1000" b="0">
+                <a:solidFill>
+                  <a:srgbClr val="222222"/>
+                </a:solidFill>
+                <a:latin typeface="Meiryo"/>
+              </a:rPr>
+              <a:t>偽メールが普通に届く</a:t>
+            </a:r>
+          </a:p>
+        </p:txBody>
+      </p:sp>
+      <p:sp>
+        <p:nvSpPr>
+          <p:cNvPr id="7" name="Rectangle 6"/>
+          <p:cNvSpPr/>
+          <p:nvPr/>
+        </p:nvSpPr>
+        <p:spPr>
+          <a:xfrm>
+            <a:off x="8961120" y="1600200"/>
+            <a:ext cx="3200400" cy="457200"/>
+          </a:xfrm>
+          <a:prstGeom prst="rect">
+            <a:avLst/>
+          </a:prstGeom>
+          <a:solidFill>
+            <a:srgbClr val="C0392B"/>
+          </a:solidFill>
+          <a:ln>
+            <a:noFill/>
+          </a:ln>
+        </p:spPr>
+        <p:style>
+          <a:lnRef idx="1">
+            <a:schemeClr val="accent1"/>
+          </a:lnRef>
+          <a:fillRef idx="3">
+            <a:schemeClr val="accent1"/>
+          </a:fillRef>
+          <a:effectRef idx="2">
+            <a:schemeClr val="accent1"/>
+          </a:effectRef>
+          <a:fontRef idx="minor">
+            <a:schemeClr val="lt1"/>
+          </a:fontRef>
+        </p:style>
+        <p:txBody>
+          <a:bodyPr rtlCol="0" anchor="ctr" wrap="square" lIns="50800" rIns="50800" tIns="25400" bIns="25400"/>
+          <a:lstStyle/>
+          <a:p>
+            <a:pPr algn="ctr"/>
+            <a:r>
+              <a:rPr sz="1000" b="1">
+                <a:solidFill>
+                  <a:srgbClr val="FFFFFF"/>
+                </a:solidFill>
+                <a:latin typeface="Meiryo"/>
+              </a:rPr>
+              <a:t>攻撃成立</a:t>
+            </a:r>
+          </a:p>
+        </p:txBody>
+      </p:sp>
+      <p:sp>
+        <p:nvSpPr>
+          <p:cNvPr id="8" name="Rectangle 7"/>
+          <p:cNvSpPr/>
+          <p:nvPr/>
+        </p:nvSpPr>
+        <p:spPr>
+          <a:xfrm>
+            <a:off x="731520" y="2057400"/>
+            <a:ext cx="3200400" cy="457200"/>
+          </a:xfrm>
+          <a:prstGeom prst="rect">
+            <a:avLst/>
+          </a:prstGeom>
+          <a:solidFill>
+            <a:srgbClr val="F9F9F9"/>
+          </a:solidFill>
+          <a:ln w="25400">
+            <a:solidFill>
+              <a:srgbClr val="CCCCCC"/>
+            </a:solidFill>
+          </a:ln>
+        </p:spPr>
+        <p:style>
+          <a:lnRef idx="1">
+            <a:schemeClr val="accent1"/>
+          </a:lnRef>
+          <a:fillRef idx="3">
+            <a:schemeClr val="accent1"/>
+          </a:fillRef>
+          <a:effectRef idx="2">
+            <a:schemeClr val="accent1"/>
+          </a:effectRef>
+          <a:fontRef idx="minor">
+            <a:schemeClr val="lt1"/>
+          </a:fontRef>
+        </p:style>
+        <p:txBody>
+          <a:bodyPr rtlCol="0" anchor="ctr" wrap="square" lIns="63500" rIns="50800" tIns="38100" bIns="38100"/>
+          <a:lstStyle/>
+          <a:p>
+            <a:pPr algn="l"/>
+            <a:r>
+              <a:rPr sz="1000" b="1">
+                <a:solidFill>
+                  <a:srgbClr val="222222"/>
+                </a:solidFill>
+                <a:latin typeface="Meiryo"/>
+              </a:rPr>
+              <a:t>p=quarantine（隔離）</a:t>
+            </a:r>
+          </a:p>
+        </p:txBody>
+      </p:sp>
+      <p:sp>
+        <p:nvSpPr>
+          <p:cNvPr id="9" name="Rectangle 8"/>
+          <p:cNvSpPr/>
+          <p:nvPr/>
+        </p:nvSpPr>
+        <p:spPr>
+          <a:xfrm>
+            <a:off x="3931920" y="2057400"/>
+            <a:ext cx="5029200" cy="457200"/>
+          </a:xfrm>
+          <a:prstGeom prst="rect">
+            <a:avLst/>
+          </a:prstGeom>
+          <a:solidFill>
+            <a:srgbClr val="F9F9F9"/>
+          </a:solidFill>
+          <a:ln w="25400">
+            <a:solidFill>
+              <a:srgbClr val="CCCCCC"/>
+            </a:solidFill>
+          </a:ln>
+        </p:spPr>
+        <p:style>
+          <a:lnRef idx="1">
+            <a:schemeClr val="accent1"/>
+          </a:lnRef>
+          <a:fillRef idx="3">
+            <a:schemeClr val="accent1"/>
+          </a:fillRef>
+          <a:effectRef idx="2">
+            <a:schemeClr val="accent1"/>
+          </a:effectRef>
+          <a:fontRef idx="minor">
+            <a:schemeClr val="lt1"/>
+          </a:fontRef>
+        </p:style>
+        <p:txBody>
+          <a:bodyPr rtlCol="0" anchor="ctr" wrap="square" lIns="63500" rIns="50800" tIns="38100" bIns="38100"/>
+          <a:lstStyle/>
+          <a:p>
+            <a:pPr algn="l"/>
+            <a:r>
+              <a:rPr sz="1000" b="0">
+                <a:solidFill>
+                  <a:srgbClr val="222222"/>
+                </a:solidFill>
+                <a:latin typeface="Meiryo"/>
+              </a:rPr>
+              <a:t>迷惑フォルダに入る</a:t>
+            </a:r>
+          </a:p>
+        </p:txBody>
+      </p:sp>
+      <p:sp>
+        <p:nvSpPr>
+          <p:cNvPr id="10" name="Rectangle 9"/>
+          <p:cNvSpPr/>
+          <p:nvPr/>
+        </p:nvSpPr>
+        <p:spPr>
+          <a:xfrm>
+            <a:off x="8961120" y="2057400"/>
+            <a:ext cx="3200400" cy="457200"/>
+          </a:xfrm>
+          <a:prstGeom prst="rect">
+            <a:avLst/>
+          </a:prstGeom>
+          <a:solidFill>
+            <a:srgbClr val="E67E22"/>
+          </a:solidFill>
+          <a:ln>
+            <a:noFill/>
+          </a:ln>
+        </p:spPr>
+        <p:style>
+          <a:lnRef idx="1">
+            <a:schemeClr val="accent1"/>
+          </a:lnRef>
+          <a:fillRef idx="3">
+            <a:schemeClr val="accent1"/>
+          </a:fillRef>
+          <a:effectRef idx="2">
+            <a:schemeClr val="accent1"/>
+          </a:effectRef>
+          <a:fontRef idx="minor">
+            <a:schemeClr val="lt1"/>
+          </a:fontRef>
+        </p:style>
+        <p:txBody>
+          <a:bodyPr rtlCol="0" anchor="ctr" wrap="square" lIns="50800" rIns="50800" tIns="25400" bIns="25400"/>
+          <a:lstStyle/>
+          <a:p>
+            <a:pPr algn="ctr"/>
+            <a:r>
+              <a:rPr sz="1000" b="1">
+                <a:solidFill>
+                  <a:srgbClr val="FFFFFF"/>
+                </a:solidFill>
+                <a:latin typeface="Meiryo"/>
+              </a:rPr>
+              <a:t>電話で突破される</a:t>
+            </a:r>
+          </a:p>
+        </p:txBody>
+      </p:sp>
+      <p:sp>
+        <p:nvSpPr>
+          <p:cNvPr id="11" name="Rectangle 10"/>
+          <p:cNvSpPr/>
+          <p:nvPr/>
+        </p:nvSpPr>
+        <p:spPr>
+          <a:xfrm>
+            <a:off x="731520" y="2514600"/>
+            <a:ext cx="3200400" cy="457200"/>
+          </a:xfrm>
+          <a:prstGeom prst="rect">
+            <a:avLst/>
+          </a:prstGeom>
+          <a:solidFill>
+            <a:srgbClr val="FFFFFF"/>
+          </a:solidFill>
+          <a:ln w="25400">
+            <a:solidFill>
+              <a:srgbClr val="CCCCCC"/>
+            </a:solidFill>
+          </a:ln>
+        </p:spPr>
+        <p:style>
+          <a:lnRef idx="1">
+            <a:schemeClr val="accent1"/>
+          </a:lnRef>
+          <a:fillRef idx="3">
+            <a:schemeClr val="accent1"/>
+          </a:fillRef>
+          <a:effectRef idx="2">
+            <a:schemeClr val="accent1"/>
+          </a:effectRef>
+          <a:fontRef idx="minor">
+            <a:schemeClr val="lt1"/>
+          </a:fontRef>
+        </p:style>
+        <p:txBody>
+          <a:bodyPr rtlCol="0" anchor="ctr" wrap="square" lIns="63500" rIns="50800" tIns="38100" bIns="38100"/>
+          <a:lstStyle/>
+          <a:p>
+            <a:pPr algn="l"/>
+            <a:r>
+              <a:rPr sz="1000" b="1">
+                <a:solidFill>
+                  <a:srgbClr val="222222"/>
+                </a:solidFill>
+                <a:latin typeface="Meiryo"/>
+              </a:rPr>
+              <a:t>p=reject（拒否）★</a:t>
+            </a:r>
+          </a:p>
+        </p:txBody>
+      </p:sp>
+      <p:sp>
+        <p:nvSpPr>
+          <p:cNvPr id="12" name="Rectangle 11"/>
+          <p:cNvSpPr/>
+          <p:nvPr/>
+        </p:nvSpPr>
+        <p:spPr>
+          <a:xfrm>
+            <a:off x="3931920" y="2514600"/>
+            <a:ext cx="5029200" cy="457200"/>
+          </a:xfrm>
+          <a:prstGeom prst="rect">
+            <a:avLst/>
+          </a:prstGeom>
+          <a:solidFill>
+            <a:srgbClr val="FFFFFF"/>
+          </a:solidFill>
+          <a:ln w="25400">
+            <a:solidFill>
+              <a:srgbClr val="CCCCCC"/>
+            </a:solidFill>
+          </a:ln>
+        </p:spPr>
+        <p:style>
+          <a:lnRef idx="1">
+            <a:schemeClr val="accent1"/>
+          </a:lnRef>
+          <a:fillRef idx="3">
+            <a:schemeClr val="accent1"/>
+          </a:fillRef>
+          <a:effectRef idx="2">
+            <a:schemeClr val="accent1"/>
+          </a:effectRef>
+          <a:fontRef idx="minor">
+            <a:schemeClr val="lt1"/>
+          </a:fontRef>
+        </p:style>
+        <p:txBody>
+          <a:bodyPr rtlCol="0" anchor="ctr" wrap="square" lIns="63500" rIns="50800" tIns="38100" bIns="38100"/>
+          <a:lstStyle/>
+          <a:p>
+            <a:pPr algn="l"/>
+            <a:r>
+              <a:rPr sz="1000" b="0">
+                <a:solidFill>
+                  <a:srgbClr val="222222"/>
+                </a:solidFill>
+                <a:latin typeface="Meiryo"/>
+              </a:rPr>
+              <a:t>メールサーバが受信拒否。配信されない。</a:t>
+            </a:r>
+          </a:p>
+        </p:txBody>
+      </p:sp>
+      <p:sp>
+        <p:nvSpPr>
+          <p:cNvPr id="13" name="Rectangle 12"/>
+          <p:cNvSpPr/>
+          <p:nvPr/>
+        </p:nvSpPr>
+        <p:spPr>
+          <a:xfrm>
+            <a:off x="8961120" y="2514600"/>
+            <a:ext cx="3200400" cy="457200"/>
+          </a:xfrm>
+          <a:prstGeom prst="rect">
+            <a:avLst/>
+          </a:prstGeom>
+          <a:solidFill>
+            <a:srgbClr val="27AE60"/>
+          </a:solidFill>
+          <a:ln>
+            <a:noFill/>
+          </a:ln>
+        </p:spPr>
+        <p:style>
+          <a:lnRef idx="1">
+            <a:schemeClr val="accent1"/>
+          </a:lnRef>
+          <a:fillRef idx="3">
+            <a:schemeClr val="accent1"/>
+          </a:fillRef>
+          <a:effectRef idx="2">
+            <a:schemeClr val="accent1"/>
+          </a:effectRef>
+          <a:fontRef idx="minor">
+            <a:schemeClr val="lt1"/>
+          </a:fontRef>
+        </p:style>
+        <p:txBody>
+          <a:bodyPr rtlCol="0" anchor="ctr" wrap="square" lIns="50800" rIns="50800" tIns="25400" bIns="25400"/>
+          <a:lstStyle/>
+          <a:p>
+            <a:pPr algn="ctr"/>
+            <a:r>
+              <a:rPr sz="1000" b="1">
+                <a:solidFill>
+                  <a:srgbClr val="FFFFFF"/>
+                </a:solidFill>
+                <a:latin typeface="Meiryo"/>
+              </a:rPr>
+              <a:t>攻撃が止まる</a:t>
+            </a:r>
+          </a:p>
+        </p:txBody>
+      </p:sp>
+      <p:sp>
+        <p:nvSpPr>
+          <p:cNvPr id="14" name="Rectangle 13"/>
+          <p:cNvSpPr/>
+          <p:nvPr/>
+        </p:nvSpPr>
+        <p:spPr>
+          <a:xfrm>
+            <a:off x="731520" y="3108960"/>
+            <a:ext cx="13624560" cy="411480"/>
+          </a:xfrm>
+          <a:prstGeom prst="rect">
+            <a:avLst/>
+          </a:prstGeom>
+          <a:solidFill>
+            <a:srgbClr val="222222"/>
+          </a:solidFill>
+          <a:ln>
+            <a:noFill/>
+          </a:ln>
+        </p:spPr>
+        <p:style>
+          <a:lnRef idx="1">
+            <a:schemeClr val="accent1"/>
+          </a:lnRef>
+          <a:fillRef idx="3">
+            <a:schemeClr val="accent1"/>
+          </a:fillRef>
+          <a:effectRef idx="2">
+            <a:schemeClr val="accent1"/>
+          </a:effectRef>
+          <a:fontRef idx="minor">
+            <a:schemeClr val="lt1"/>
+          </a:fontRef>
+        </p:style>
+        <p:txBody>
+          <a:bodyPr rtlCol="0" anchor="ctr" wrap="square" lIns="50800" rIns="50800" tIns="25400" bIns="25400"/>
+          <a:lstStyle/>
+          <a:p>
+            <a:pPr algn="ctr"/>
+            <a:r>
+              <a:rPr sz="1300" b="1">
+                <a:solidFill>
+                  <a:srgbClr val="FFFFFF"/>
+                </a:solidFill>
+                <a:latin typeface="Meiryo"/>
+              </a:rPr>
+              <a:t>類似ドメインも含めた包括的DNS対策</a:t>
+            </a:r>
+          </a:p>
+        </p:txBody>
+      </p:sp>
+      <p:sp>
+        <p:nvSpPr>
+          <p:cNvPr id="15" name="Rectangle 14"/>
+          <p:cNvSpPr/>
+          <p:nvPr/>
+        </p:nvSpPr>
+        <p:spPr>
+          <a:xfrm>
+            <a:off x="731520" y="3566160"/>
+            <a:ext cx="3657600" cy="365760"/>
+          </a:xfrm>
+          <a:prstGeom prst="rect">
+            <a:avLst/>
+          </a:prstGeom>
+          <a:solidFill>
+            <a:srgbClr val="34495E"/>
+          </a:solidFill>
+          <a:ln>
+            <a:noFill/>
+          </a:ln>
+        </p:spPr>
+        <p:style>
+          <a:lnRef idx="1">
+            <a:schemeClr val="accent1"/>
+          </a:lnRef>
+          <a:fillRef idx="3">
+            <a:schemeClr val="accent1"/>
+          </a:fillRef>
+          <a:effectRef idx="2">
+            <a:schemeClr val="accent1"/>
+          </a:effectRef>
+          <a:fontRef idx="minor">
+            <a:schemeClr val="lt1"/>
+          </a:fontRef>
+        </p:style>
+        <p:txBody>
+          <a:bodyPr rtlCol="0" anchor="ctr" wrap="square" lIns="50800" rIns="50800" tIns="25400" bIns="25400"/>
+          <a:lstStyle/>
+          <a:p>
+            <a:pPr algn="ctr"/>
+            <a:r>
+              <a:rPr sz="1000" b="1">
+                <a:solidFill>
+                  <a:srgbClr val="FFFFFF"/>
+                </a:solidFill>
+                <a:latin typeface="Meiryo"/>
+              </a:rPr>
+              <a:t>対策</a:t>
+            </a:r>
+          </a:p>
+        </p:txBody>
+      </p:sp>
+      <p:sp>
+        <p:nvSpPr>
+          <p:cNvPr id="16" name="Rectangle 15"/>
+          <p:cNvSpPr/>
+          <p:nvPr/>
+        </p:nvSpPr>
+        <p:spPr>
+          <a:xfrm>
+            <a:off x="4389120" y="3566160"/>
+            <a:ext cx="5943600" cy="365760"/>
+          </a:xfrm>
+          <a:prstGeom prst="rect">
+            <a:avLst/>
+          </a:prstGeom>
+          <a:solidFill>
+            <a:srgbClr val="34495E"/>
+          </a:solidFill>
+          <a:ln>
+            <a:noFill/>
+          </a:ln>
+        </p:spPr>
+        <p:style>
+          <a:lnRef idx="1">
+            <a:schemeClr val="accent1"/>
+          </a:lnRef>
+          <a:fillRef idx="3">
+            <a:schemeClr val="accent1"/>
+          </a:fillRef>
+          <a:effectRef idx="2">
+            <a:schemeClr val="accent1"/>
+          </a:effectRef>
+          <a:fontRef idx="minor">
+            <a:schemeClr val="lt1"/>
+          </a:fontRef>
+        </p:style>
+        <p:txBody>
+          <a:bodyPr rtlCol="0" anchor="ctr" wrap="square" lIns="50800" rIns="50800" tIns="25400" bIns="25400"/>
+          <a:lstStyle/>
+          <a:p>
+            <a:pPr algn="ctr"/>
+            <a:r>
+              <a:rPr sz="1000" b="1">
+                <a:solidFill>
+                  <a:srgbClr val="FFFFFF"/>
+                </a:solidFill>
+                <a:latin typeface="Meiryo"/>
+              </a:rPr>
+              <a:t>内容</a:t>
+            </a:r>
+          </a:p>
+        </p:txBody>
+      </p:sp>
+      <p:sp>
+        <p:nvSpPr>
+          <p:cNvPr id="17" name="Rectangle 16"/>
+          <p:cNvSpPr/>
+          <p:nvPr/>
+        </p:nvSpPr>
+        <p:spPr>
+          <a:xfrm>
+            <a:off x="10332720" y="3566160"/>
+            <a:ext cx="4023360" cy="365760"/>
+          </a:xfrm>
+          <a:prstGeom prst="rect">
+            <a:avLst/>
+          </a:prstGeom>
+          <a:solidFill>
+            <a:srgbClr val="34495E"/>
+          </a:solidFill>
+          <a:ln>
+            <a:noFill/>
+          </a:ln>
+        </p:spPr>
+        <p:style>
+          <a:lnRef idx="1">
+            <a:schemeClr val="accent1"/>
+          </a:lnRef>
+          <a:fillRef idx="3">
+            <a:schemeClr val="accent1"/>
+          </a:fillRef>
+          <a:effectRef idx="2">
+            <a:schemeClr val="accent1"/>
+          </a:effectRef>
+          <a:fontRef idx="minor">
+            <a:schemeClr val="lt1"/>
+          </a:fontRef>
+        </p:style>
+        <p:txBody>
+          <a:bodyPr rtlCol="0" anchor="ctr" wrap="square" lIns="50800" rIns="50800" tIns="25400" bIns="25400"/>
+          <a:lstStyle/>
+          <a:p>
+            <a:pPr algn="ctr"/>
+            <a:r>
+              <a:rPr sz="1000" b="1">
+                <a:solidFill>
+                  <a:srgbClr val="FFFFFF"/>
+                </a:solidFill>
+                <a:latin typeface="Meiryo"/>
+              </a:rPr>
+              <a:t>効果</a:t>
+            </a:r>
+          </a:p>
+        </p:txBody>
+      </p:sp>
+      <p:sp>
+        <p:nvSpPr>
+          <p:cNvPr id="18" name="Rectangle 17"/>
+          <p:cNvSpPr/>
+          <p:nvPr/>
+        </p:nvSpPr>
+        <p:spPr>
+          <a:xfrm>
+            <a:off x="731520" y="3931920"/>
+            <a:ext cx="3657600" cy="457200"/>
+          </a:xfrm>
+          <a:prstGeom prst="rect">
+            <a:avLst/>
+          </a:prstGeom>
+          <a:solidFill>
+            <a:srgbClr val="FFFFFF"/>
+          </a:solidFill>
+          <a:ln w="25400">
+            <a:solidFill>
+              <a:srgbClr val="CCCCCC"/>
+            </a:solidFill>
+          </a:ln>
+        </p:spPr>
+        <p:style>
+          <a:lnRef idx="1">
+            <a:schemeClr val="accent1"/>
+          </a:lnRef>
+          <a:fillRef idx="3">
+            <a:schemeClr val="accent1"/>
+          </a:fillRef>
+          <a:effectRef idx="2">
+            <a:schemeClr val="accent1"/>
+          </a:effectRef>
+          <a:fontRef idx="minor">
+            <a:schemeClr val="lt1"/>
+          </a:fontRef>
+        </p:style>
+        <p:txBody>
+          <a:bodyPr rtlCol="0" anchor="ctr" wrap="square" lIns="63500" rIns="50800" tIns="38100" bIns="38100"/>
+          <a:lstStyle/>
+          <a:p>
+            <a:pPr algn="l"/>
+            <a:r>
+              <a:rPr sz="900" b="1">
+                <a:solidFill>
+                  <a:srgbClr val="222222"/>
+                </a:solidFill>
+                <a:latin typeface="Meiryo"/>
+              </a:rPr>
+              <a:t>① 類似ドメインの防御的登録</a:t>
+            </a:r>
+          </a:p>
+        </p:txBody>
+      </p:sp>
+      <p:sp>
+        <p:nvSpPr>
+          <p:cNvPr id="19" name="Rectangle 18"/>
+          <p:cNvSpPr/>
+          <p:nvPr/>
+        </p:nvSpPr>
+        <p:spPr>
+          <a:xfrm>
+            <a:off x="4389120" y="3931920"/>
+            <a:ext cx="5943600" cy="457200"/>
+          </a:xfrm>
+          <a:prstGeom prst="rect">
+            <a:avLst/>
+          </a:prstGeom>
+          <a:solidFill>
+            <a:srgbClr val="FFFFFF"/>
+          </a:solidFill>
+          <a:ln w="25400">
+            <a:solidFill>
+              <a:srgbClr val="CCCCCC"/>
+            </a:solidFill>
+          </a:ln>
+        </p:spPr>
+        <p:style>
+          <a:lnRef idx="1">
+            <a:schemeClr val="accent1"/>
+          </a:lnRef>
+          <a:fillRef idx="3">
+            <a:schemeClr val="accent1"/>
+          </a:fillRef>
+          <a:effectRef idx="2">
+            <a:schemeClr val="accent1"/>
+          </a:effectRef>
+          <a:fontRef idx="minor">
+            <a:schemeClr val="lt1"/>
+          </a:fontRef>
+        </p:style>
+        <p:txBody>
+          <a:bodyPr rtlCol="0" anchor="ctr" wrap="square" lIns="63500" rIns="50800" tIns="38100" bIns="38100"/>
+          <a:lstStyle/>
+          <a:p>
+            <a:pPr algn="l"/>
+            <a:r>
+              <a:rPr sz="900" b="0">
+                <a:solidFill>
+                  <a:srgbClr val="222222"/>
+                </a:solidFill>
+                <a:latin typeface="Meiryo"/>
+              </a:rPr>
+              <a:t>mufg-security.com, bizstation-update.jp 等を銀行が先に取得</a:t>
+            </a:r>
+          </a:p>
+        </p:txBody>
+      </p:sp>
+      <p:sp>
+        <p:nvSpPr>
+          <p:cNvPr id="20" name="Rectangle 19"/>
+          <p:cNvSpPr/>
+          <p:nvPr/>
+        </p:nvSpPr>
+        <p:spPr>
+          <a:xfrm>
+            <a:off x="10332720" y="3931920"/>
+            <a:ext cx="4023360" cy="457200"/>
+          </a:xfrm>
+          <a:prstGeom prst="rect">
+            <a:avLst/>
+          </a:prstGeom>
+          <a:solidFill>
+            <a:srgbClr val="FFFFFF"/>
+          </a:solidFill>
+          <a:ln w="25400">
+            <a:solidFill>
+              <a:srgbClr val="27AE60"/>
+            </a:solidFill>
+          </a:ln>
+        </p:spPr>
+        <p:style>
+          <a:lnRef idx="1">
+            <a:schemeClr val="accent1"/>
+          </a:lnRef>
+          <a:fillRef idx="3">
+            <a:schemeClr val="accent1"/>
+          </a:fillRef>
+          <a:effectRef idx="2">
+            <a:schemeClr val="accent1"/>
+          </a:effectRef>
+          <a:fontRef idx="minor">
+            <a:schemeClr val="lt1"/>
+          </a:fontRef>
+        </p:style>
+        <p:txBody>
+          <a:bodyPr rtlCol="0" anchor="ctr" wrap="square" lIns="63500" rIns="50800" tIns="38100" bIns="38100"/>
+          <a:lstStyle/>
+          <a:p>
+            <a:pPr algn="l"/>
+            <a:r>
+              <a:rPr sz="900" b="1">
+                <a:solidFill>
+                  <a:srgbClr val="222222"/>
+                </a:solidFill>
+                <a:latin typeface="Meiryo"/>
+              </a:rPr>
+              <a:t>犯人が使えるドメインを潰す</a:t>
+            </a:r>
+          </a:p>
+        </p:txBody>
+      </p:sp>
+      <p:sp>
+        <p:nvSpPr>
+          <p:cNvPr id="21" name="Rectangle 20"/>
+          <p:cNvSpPr/>
+          <p:nvPr/>
+        </p:nvSpPr>
+        <p:spPr>
+          <a:xfrm>
+            <a:off x="731520" y="4389120"/>
+            <a:ext cx="3657600" cy="457200"/>
+          </a:xfrm>
+          <a:prstGeom prst="rect">
+            <a:avLst/>
+          </a:prstGeom>
+          <a:solidFill>
+            <a:srgbClr val="F9F9F9"/>
+          </a:solidFill>
+          <a:ln w="25400">
+            <a:solidFill>
+              <a:srgbClr val="CCCCCC"/>
+            </a:solidFill>
+          </a:ln>
+        </p:spPr>
+        <p:style>
+          <a:lnRef idx="1">
+            <a:schemeClr val="accent1"/>
+          </a:lnRef>
+          <a:fillRef idx="3">
+            <a:schemeClr val="accent1"/>
+          </a:fillRef>
+          <a:effectRef idx="2">
+            <a:schemeClr val="accent1"/>
+          </a:effectRef>
+          <a:fontRef idx="minor">
+            <a:schemeClr val="lt1"/>
+          </a:fontRef>
+        </p:style>
+        <p:txBody>
+          <a:bodyPr rtlCol="0" anchor="ctr" wrap="square" lIns="63500" rIns="50800" tIns="38100" bIns="38100"/>
+          <a:lstStyle/>
+          <a:p>
+            <a:pPr algn="l"/>
+            <a:r>
+              <a:rPr sz="900" b="1">
+                <a:solidFill>
+                  <a:srgbClr val="222222"/>
+                </a:solidFill>
+                <a:latin typeface="Meiryo"/>
+              </a:rPr>
+              <a:t>② 新規登録ドメイン（NRD）ブロック</a:t>
+            </a:r>
+          </a:p>
+        </p:txBody>
+      </p:sp>
+      <p:sp>
+        <p:nvSpPr>
+          <p:cNvPr id="22" name="Rectangle 21"/>
+          <p:cNvSpPr/>
+          <p:nvPr/>
+        </p:nvSpPr>
+        <p:spPr>
+          <a:xfrm>
+            <a:off x="4389120" y="4389120"/>
+            <a:ext cx="5943600" cy="457200"/>
+          </a:xfrm>
+          <a:prstGeom prst="rect">
+            <a:avLst/>
+          </a:prstGeom>
+          <a:solidFill>
+            <a:srgbClr val="F9F9F9"/>
+          </a:solidFill>
+          <a:ln w="25400">
+            <a:solidFill>
+              <a:srgbClr val="CCCCCC"/>
+            </a:solidFill>
+          </a:ln>
+        </p:spPr>
+        <p:style>
+          <a:lnRef idx="1">
+            <a:schemeClr val="accent1"/>
+          </a:lnRef>
+          <a:fillRef idx="3">
+            <a:schemeClr val="accent1"/>
+          </a:fillRef>
+          <a:effectRef idx="2">
+            <a:schemeClr val="accent1"/>
+          </a:effectRef>
+          <a:fontRef idx="minor">
+            <a:schemeClr val="lt1"/>
+          </a:fontRef>
+        </p:style>
+        <p:txBody>
+          <a:bodyPr rtlCol="0" anchor="ctr" wrap="square" lIns="63500" rIns="50800" tIns="38100" bIns="38100"/>
+          <a:lstStyle/>
+          <a:p>
+            <a:pPr algn="l"/>
+            <a:r>
+              <a:rPr sz="900" b="0">
+                <a:solidFill>
+                  <a:srgbClr val="222222"/>
+                </a:solidFill>
+                <a:latin typeface="Meiryo"/>
+              </a:rPr>
+              <a:t>登録から日が浅いドメインを受信側で高リスク判定・ブロック</a:t>
+            </a:r>
+          </a:p>
+        </p:txBody>
+      </p:sp>
+      <p:sp>
+        <p:nvSpPr>
+          <p:cNvPr id="23" name="Rectangle 22"/>
+          <p:cNvSpPr/>
+          <p:nvPr/>
+        </p:nvSpPr>
+        <p:spPr>
+          <a:xfrm>
+            <a:off x="10332720" y="4389120"/>
+            <a:ext cx="4023360" cy="457200"/>
+          </a:xfrm>
+          <a:prstGeom prst="rect">
+            <a:avLst/>
+          </a:prstGeom>
+          <a:solidFill>
+            <a:srgbClr val="F9F9F9"/>
+          </a:solidFill>
+          <a:ln w="25400">
+            <a:solidFill>
+              <a:srgbClr val="27AE60"/>
+            </a:solidFill>
+          </a:ln>
+        </p:spPr>
+        <p:style>
+          <a:lnRef idx="1">
+            <a:schemeClr val="accent1"/>
+          </a:lnRef>
+          <a:fillRef idx="3">
+            <a:schemeClr val="accent1"/>
+          </a:fillRef>
+          <a:effectRef idx="2">
+            <a:schemeClr val="accent1"/>
+          </a:effectRef>
+          <a:fontRef idx="minor">
+            <a:schemeClr val="lt1"/>
+          </a:fontRef>
+        </p:style>
+        <p:txBody>
+          <a:bodyPr rtlCol="0" anchor="ctr" wrap="square" lIns="63500" rIns="50800" tIns="38100" bIns="38100"/>
+          <a:lstStyle/>
+          <a:p>
+            <a:pPr algn="l"/>
+            <a:r>
+              <a:rPr sz="900" b="1">
+                <a:solidFill>
+                  <a:srgbClr val="222222"/>
+                </a:solidFill>
+                <a:latin typeface="Meiryo"/>
+              </a:rPr>
+              <a:t>犯人が新ドメインを取得しても即座に使えない</a:t>
+            </a:r>
+          </a:p>
+        </p:txBody>
+      </p:sp>
+      <p:sp>
+        <p:nvSpPr>
+          <p:cNvPr id="24" name="Rectangle 23"/>
+          <p:cNvSpPr/>
+          <p:nvPr/>
+        </p:nvSpPr>
+        <p:spPr>
+          <a:xfrm>
+            <a:off x="731520" y="4846320"/>
+            <a:ext cx="3657600" cy="457200"/>
+          </a:xfrm>
+          <a:prstGeom prst="rect">
+            <a:avLst/>
+          </a:prstGeom>
+          <a:solidFill>
+            <a:srgbClr val="FFFFFF"/>
+          </a:solidFill>
+          <a:ln w="25400">
+            <a:solidFill>
+              <a:srgbClr val="CCCCCC"/>
+            </a:solidFill>
+          </a:ln>
+        </p:spPr>
+        <p:style>
+          <a:lnRef idx="1">
+            <a:schemeClr val="accent1"/>
+          </a:lnRef>
+          <a:fillRef idx="3">
+            <a:schemeClr val="accent1"/>
+          </a:fillRef>
+          <a:effectRef idx="2">
+            <a:schemeClr val="accent1"/>
+          </a:effectRef>
+          <a:fontRef idx="minor">
+            <a:schemeClr val="lt1"/>
+          </a:fontRef>
+        </p:style>
+        <p:txBody>
+          <a:bodyPr rtlCol="0" anchor="ctr" wrap="square" lIns="63500" rIns="50800" tIns="38100" bIns="38100"/>
+          <a:lstStyle/>
+          <a:p>
+            <a:pPr algn="l"/>
+            <a:r>
+              <a:rPr sz="900" b="1">
+                <a:solidFill>
+                  <a:srgbClr val="222222"/>
+                </a:solidFill>
+                <a:latin typeface="Meiryo"/>
+              </a:rPr>
+              <a:t>③ 正規送信ドメインの公開＋GW制御</a:t>
+            </a:r>
+          </a:p>
+        </p:txBody>
+      </p:sp>
+      <p:sp>
+        <p:nvSpPr>
+          <p:cNvPr id="25" name="Rectangle 24"/>
+          <p:cNvSpPr/>
+          <p:nvPr/>
+        </p:nvSpPr>
+        <p:spPr>
+          <a:xfrm>
+            <a:off x="4389120" y="4846320"/>
+            <a:ext cx="5943600" cy="457200"/>
+          </a:xfrm>
+          <a:prstGeom prst="rect">
+            <a:avLst/>
+          </a:prstGeom>
+          <a:solidFill>
+            <a:srgbClr val="FFFFFF"/>
+          </a:solidFill>
+          <a:ln w="25400">
+            <a:solidFill>
+              <a:srgbClr val="CCCCCC"/>
+            </a:solidFill>
+          </a:ln>
+        </p:spPr>
+        <p:style>
+          <a:lnRef idx="1">
+            <a:schemeClr val="accent1"/>
+          </a:lnRef>
+          <a:fillRef idx="3">
+            <a:schemeClr val="accent1"/>
+          </a:fillRef>
+          <a:effectRef idx="2">
+            <a:schemeClr val="accent1"/>
+          </a:effectRef>
+          <a:fontRef idx="minor">
+            <a:schemeClr val="lt1"/>
+          </a:fontRef>
+        </p:style>
+        <p:txBody>
+          <a:bodyPr rtlCol="0" anchor="ctr" wrap="square" lIns="63500" rIns="50800" tIns="38100" bIns="38100"/>
+          <a:lstStyle/>
+          <a:p>
+            <a:pPr algn="l"/>
+            <a:r>
+              <a:rPr sz="900" b="0">
+                <a:solidFill>
+                  <a:srgbClr val="222222"/>
+                </a:solidFill>
+                <a:latin typeface="Meiryo"/>
+              </a:rPr>
+              <a:t>銀行が「当行のメールは @mufg.jp, @bk.mufg.co.jp のみ」と宣言</a:t>
+            </a:r>
+          </a:p>
+        </p:txBody>
+      </p:sp>
+      <p:sp>
+        <p:nvSpPr>
+          <p:cNvPr id="26" name="Rectangle 25"/>
+          <p:cNvSpPr/>
+          <p:nvPr/>
+        </p:nvSpPr>
+        <p:spPr>
+          <a:xfrm>
+            <a:off x="10332720" y="4846320"/>
+            <a:ext cx="4023360" cy="457200"/>
+          </a:xfrm>
+          <a:prstGeom prst="rect">
+            <a:avLst/>
+          </a:prstGeom>
+          <a:solidFill>
+            <a:srgbClr val="FFFFFF"/>
+          </a:solidFill>
+          <a:ln w="25400">
+            <a:solidFill>
+              <a:srgbClr val="27AE60"/>
+            </a:solidFill>
+          </a:ln>
+        </p:spPr>
+        <p:style>
+          <a:lnRef idx="1">
+            <a:schemeClr val="accent1"/>
+          </a:lnRef>
+          <a:fillRef idx="3">
+            <a:schemeClr val="accent1"/>
+          </a:fillRef>
+          <a:effectRef idx="2">
+            <a:schemeClr val="accent1"/>
+          </a:effectRef>
+          <a:fontRef idx="minor">
+            <a:schemeClr val="lt1"/>
+          </a:fontRef>
+        </p:style>
+        <p:txBody>
+          <a:bodyPr rtlCol="0" anchor="ctr" wrap="square" lIns="63500" rIns="50800" tIns="38100" bIns="38100"/>
+          <a:lstStyle/>
+          <a:p>
+            <a:pPr algn="l"/>
+            <a:r>
+              <a:rPr sz="900" b="1">
+                <a:solidFill>
+                  <a:srgbClr val="222222"/>
+                </a:solidFill>
+                <a:latin typeface="Meiryo"/>
+              </a:rPr>
+              <a:t>企業のメールGWで上記以外を自動ブロック</a:t>
+            </a:r>
+          </a:p>
+        </p:txBody>
+      </p:sp>
+      <p:sp>
+        <p:nvSpPr>
+          <p:cNvPr id="27" name="Rectangle 26"/>
+          <p:cNvSpPr/>
+          <p:nvPr/>
+        </p:nvSpPr>
+        <p:spPr>
+          <a:xfrm>
+            <a:off x="731520" y="5303520"/>
+            <a:ext cx="3657600" cy="457200"/>
+          </a:xfrm>
+          <a:prstGeom prst="rect">
+            <a:avLst/>
+          </a:prstGeom>
+          <a:solidFill>
+            <a:srgbClr val="F9F9F9"/>
+          </a:solidFill>
+          <a:ln w="25400">
+            <a:solidFill>
+              <a:srgbClr val="CCCCCC"/>
+            </a:solidFill>
+          </a:ln>
+        </p:spPr>
+        <p:style>
+          <a:lnRef idx="1">
+            <a:schemeClr val="accent1"/>
+          </a:lnRef>
+          <a:fillRef idx="3">
+            <a:schemeClr val="accent1"/>
+          </a:fillRef>
+          <a:effectRef idx="2">
+            <a:schemeClr val="accent1"/>
+          </a:effectRef>
+          <a:fontRef idx="minor">
+            <a:schemeClr val="lt1"/>
+          </a:fontRef>
+        </p:style>
+        <p:txBody>
+          <a:bodyPr rtlCol="0" anchor="ctr" wrap="square" lIns="63500" rIns="50800" tIns="38100" bIns="38100"/>
+          <a:lstStyle/>
+          <a:p>
+            <a:pPr algn="l"/>
+            <a:r>
+              <a:rPr sz="900" b="1">
+                <a:solidFill>
+                  <a:srgbClr val="222222"/>
+                </a:solidFill>
+                <a:latin typeface="Meiryo"/>
+              </a:rPr>
+              <a:t>④ SPF/DKIM未設定ドメインの拒否</a:t>
+            </a:r>
+          </a:p>
+        </p:txBody>
+      </p:sp>
+      <p:sp>
+        <p:nvSpPr>
+          <p:cNvPr id="28" name="Rectangle 27"/>
+          <p:cNvSpPr/>
+          <p:nvPr/>
+        </p:nvSpPr>
+        <p:spPr>
+          <a:xfrm>
+            <a:off x="4389120" y="5303520"/>
+            <a:ext cx="5943600" cy="457200"/>
+          </a:xfrm>
+          <a:prstGeom prst="rect">
+            <a:avLst/>
+          </a:prstGeom>
+          <a:solidFill>
+            <a:srgbClr val="F9F9F9"/>
+          </a:solidFill>
+          <a:ln w="25400">
+            <a:solidFill>
+              <a:srgbClr val="CCCCCC"/>
+            </a:solidFill>
+          </a:ln>
+        </p:spPr>
+        <p:style>
+          <a:lnRef idx="1">
+            <a:schemeClr val="accent1"/>
+          </a:lnRef>
+          <a:fillRef idx="3">
+            <a:schemeClr val="accent1"/>
+          </a:fillRef>
+          <a:effectRef idx="2">
+            <a:schemeClr val="accent1"/>
+          </a:effectRef>
+          <a:fontRef idx="minor">
+            <a:schemeClr val="lt1"/>
+          </a:fontRef>
+        </p:style>
+        <p:txBody>
+          <a:bodyPr rtlCol="0" anchor="ctr" wrap="square" lIns="63500" rIns="50800" tIns="38100" bIns="38100"/>
+          <a:lstStyle/>
+          <a:p>
+            <a:pPr algn="l"/>
+            <a:r>
+              <a:rPr sz="900" b="0">
+                <a:solidFill>
+                  <a:srgbClr val="222222"/>
+                </a:solidFill>
+                <a:latin typeface="Meiryo"/>
+              </a:rPr>
+              <a:t>受信側で認証未設定のドメインからのメールを拒否</a:t>
+            </a:r>
+          </a:p>
+        </p:txBody>
+      </p:sp>
+      <p:sp>
+        <p:nvSpPr>
+          <p:cNvPr id="29" name="Rectangle 28"/>
+          <p:cNvSpPr/>
+          <p:nvPr/>
+        </p:nvSpPr>
+        <p:spPr>
+          <a:xfrm>
+            <a:off x="10332720" y="5303520"/>
+            <a:ext cx="4023360" cy="457200"/>
+          </a:xfrm>
+          <a:prstGeom prst="rect">
+            <a:avLst/>
+          </a:prstGeom>
+          <a:solidFill>
+            <a:srgbClr val="F9F9F9"/>
+          </a:solidFill>
+          <a:ln w="25400">
+            <a:solidFill>
+              <a:srgbClr val="27AE60"/>
+            </a:solidFill>
+          </a:ln>
+        </p:spPr>
+        <p:style>
+          <a:lnRef idx="1">
+            <a:schemeClr val="accent1"/>
+          </a:lnRef>
+          <a:fillRef idx="3">
+            <a:schemeClr val="accent1"/>
+          </a:fillRef>
+          <a:effectRef idx="2">
+            <a:schemeClr val="accent1"/>
+          </a:effectRef>
+          <a:fontRef idx="minor">
+            <a:schemeClr val="lt1"/>
+          </a:fontRef>
+        </p:style>
+        <p:txBody>
+          <a:bodyPr rtlCol="0" anchor="ctr" wrap="square" lIns="63500" rIns="50800" tIns="38100" bIns="38100"/>
+          <a:lstStyle/>
+          <a:p>
+            <a:pPr algn="l"/>
+            <a:r>
+              <a:rPr sz="900" b="1">
+                <a:solidFill>
+                  <a:srgbClr val="222222"/>
+                </a:solidFill>
+                <a:latin typeface="Meiryo"/>
+              </a:rPr>
+              <a:t>犯人の急造ドメインは認証が通らない</a:t>
+            </a:r>
+          </a:p>
+        </p:txBody>
+      </p:sp>
+      <p:sp>
+        <p:nvSpPr>
+          <p:cNvPr id="30" name="Rectangle 29"/>
+          <p:cNvSpPr/>
+          <p:nvPr/>
+        </p:nvSpPr>
+        <p:spPr>
+          <a:xfrm>
+            <a:off x="731520" y="5943600"/>
+            <a:ext cx="13624560" cy="365760"/>
+          </a:xfrm>
+          <a:prstGeom prst="rect">
+            <a:avLst/>
+          </a:prstGeom>
+          <a:solidFill>
+            <a:srgbClr val="222222"/>
+          </a:solidFill>
+          <a:ln>
+            <a:noFill/>
+          </a:ln>
+        </p:spPr>
+        <p:style>
+          <a:lnRef idx="1">
+            <a:schemeClr val="accent1"/>
+          </a:lnRef>
+          <a:fillRef idx="3">
+            <a:schemeClr val="accent1"/>
+          </a:fillRef>
+          <a:effectRef idx="2">
+            <a:schemeClr val="accent1"/>
+          </a:effectRef>
+          <a:fontRef idx="minor">
+            <a:schemeClr val="lt1"/>
+          </a:fontRef>
+        </p:style>
+        <p:txBody>
+          <a:bodyPr rtlCol="0" anchor="ctr" wrap="square" lIns="50800" rIns="50800" tIns="25400" bIns="25400"/>
+          <a:lstStyle/>
+          <a:p>
+            <a:pPr algn="ctr"/>
+            <a:r>
+              <a:rPr sz="1200" b="1">
+                <a:solidFill>
+                  <a:srgbClr val="FFFFFF"/>
+                </a:solidFill>
+                <a:latin typeface="Meiryo"/>
+              </a:rPr>
+              <a:t>対策カバレッジ</a:t>
+            </a:r>
+          </a:p>
+        </p:txBody>
+      </p:sp>
+      <p:sp>
+        <p:nvSpPr>
+          <p:cNvPr id="31" name="Rectangle 30"/>
+          <p:cNvSpPr/>
+          <p:nvPr/>
+        </p:nvSpPr>
+        <p:spPr>
+          <a:xfrm>
+            <a:off x="731520" y="6309360"/>
+            <a:ext cx="4572000" cy="365760"/>
+          </a:xfrm>
+          <a:prstGeom prst="rect">
+            <a:avLst/>
+          </a:prstGeom>
+          <a:solidFill>
+            <a:srgbClr val="34495E"/>
+          </a:solidFill>
+          <a:ln>
+            <a:noFill/>
+          </a:ln>
+        </p:spPr>
+        <p:style>
+          <a:lnRef idx="1">
+            <a:schemeClr val="accent1"/>
+          </a:lnRef>
+          <a:fillRef idx="3">
+            <a:schemeClr val="accent1"/>
+          </a:fillRef>
+          <a:effectRef idx="2">
+            <a:schemeClr val="accent1"/>
+          </a:effectRef>
+          <a:fontRef idx="minor">
+            <a:schemeClr val="lt1"/>
+          </a:fontRef>
+        </p:style>
+        <p:txBody>
+          <a:bodyPr rtlCol="0" anchor="ctr" wrap="square" lIns="50800" rIns="50800" tIns="25400" bIns="25400"/>
+          <a:lstStyle/>
+          <a:p>
+            <a:pPr algn="ctr"/>
+            <a:r>
+              <a:rPr sz="900" b="1">
+                <a:solidFill>
+                  <a:srgbClr val="FFFFFF"/>
+                </a:solidFill>
+                <a:latin typeface="Meiryo"/>
+              </a:rPr>
+              <a:t>対策</a:t>
+            </a:r>
+          </a:p>
+        </p:txBody>
+      </p:sp>
+      <p:sp>
+        <p:nvSpPr>
+          <p:cNvPr id="32" name="Rectangle 31"/>
+          <p:cNvSpPr/>
+          <p:nvPr/>
+        </p:nvSpPr>
+        <p:spPr>
+          <a:xfrm>
+            <a:off x="5303520" y="6309360"/>
+            <a:ext cx="3017520" cy="365760"/>
+          </a:xfrm>
+          <a:prstGeom prst="rect">
+            <a:avLst/>
+          </a:prstGeom>
+          <a:solidFill>
+            <a:srgbClr val="34495E"/>
+          </a:solidFill>
+          <a:ln>
+            <a:noFill/>
+          </a:ln>
+        </p:spPr>
+        <p:style>
+          <a:lnRef idx="1">
+            <a:schemeClr val="accent1"/>
+          </a:lnRef>
+          <a:fillRef idx="3">
+            <a:schemeClr val="accent1"/>
+          </a:fillRef>
+          <a:effectRef idx="2">
+            <a:schemeClr val="accent1"/>
+          </a:effectRef>
+          <a:fontRef idx="minor">
+            <a:schemeClr val="lt1"/>
+          </a:fontRef>
+        </p:style>
+        <p:txBody>
+          <a:bodyPr rtlCol="0" anchor="ctr" wrap="square" lIns="50800" rIns="50800" tIns="25400" bIns="25400"/>
+          <a:lstStyle/>
+          <a:p>
+            <a:pPr algn="ctr"/>
+            <a:r>
+              <a:rPr sz="900" b="1">
+                <a:solidFill>
+                  <a:srgbClr val="FFFFFF"/>
+                </a:solidFill>
+                <a:latin typeface="Meiryo"/>
+              </a:rPr>
+              <a:t>正規ドメイン詐称</a:t>
+            </a:r>
+          </a:p>
+        </p:txBody>
+      </p:sp>
+      <p:sp>
+        <p:nvSpPr>
+          <p:cNvPr id="33" name="Rectangle 32"/>
+          <p:cNvSpPr/>
+          <p:nvPr/>
+        </p:nvSpPr>
+        <p:spPr>
+          <a:xfrm>
+            <a:off x="8321040" y="6309360"/>
+            <a:ext cx="3017520" cy="365760"/>
+          </a:xfrm>
+          <a:prstGeom prst="rect">
+            <a:avLst/>
+          </a:prstGeom>
+          <a:solidFill>
+            <a:srgbClr val="34495E"/>
+          </a:solidFill>
+          <a:ln>
+            <a:noFill/>
+          </a:ln>
+        </p:spPr>
+        <p:style>
+          <a:lnRef idx="1">
+            <a:schemeClr val="accent1"/>
+          </a:lnRef>
+          <a:fillRef idx="3">
+            <a:schemeClr val="accent1"/>
+          </a:fillRef>
+          <a:effectRef idx="2">
+            <a:schemeClr val="accent1"/>
+          </a:effectRef>
+          <a:fontRef idx="minor">
+            <a:schemeClr val="lt1"/>
+          </a:fontRef>
+        </p:style>
+        <p:txBody>
+          <a:bodyPr rtlCol="0" anchor="ctr" wrap="square" lIns="50800" rIns="50800" tIns="25400" bIns="25400"/>
+          <a:lstStyle/>
+          <a:p>
+            <a:pPr algn="ctr"/>
+            <a:r>
+              <a:rPr sz="900" b="1">
+                <a:solidFill>
+                  <a:srgbClr val="FFFFFF"/>
+                </a:solidFill>
+                <a:latin typeface="Meiryo"/>
+              </a:rPr>
+              <a:t>類似ドメイン</a:t>
+            </a:r>
+          </a:p>
+        </p:txBody>
+      </p:sp>
+      <p:sp>
+        <p:nvSpPr>
+          <p:cNvPr id="34" name="Rectangle 33"/>
+          <p:cNvSpPr/>
+          <p:nvPr/>
+        </p:nvSpPr>
+        <p:spPr>
+          <a:xfrm>
+            <a:off x="11338559" y="6309360"/>
+            <a:ext cx="3017520" cy="365760"/>
+          </a:xfrm>
+          <a:prstGeom prst="rect">
+            <a:avLst/>
+          </a:prstGeom>
+          <a:solidFill>
+            <a:srgbClr val="34495E"/>
+          </a:solidFill>
+          <a:ln>
+            <a:noFill/>
+          </a:ln>
+        </p:spPr>
+        <p:style>
+          <a:lnRef idx="1">
+            <a:schemeClr val="accent1"/>
+          </a:lnRef>
+          <a:fillRef idx="3">
+            <a:schemeClr val="accent1"/>
+          </a:fillRef>
+          <a:effectRef idx="2">
+            <a:schemeClr val="accent1"/>
+          </a:effectRef>
+          <a:fontRef idx="minor">
+            <a:schemeClr val="lt1"/>
+          </a:fontRef>
+        </p:style>
+        <p:txBody>
+          <a:bodyPr rtlCol="0" anchor="ctr" wrap="square" lIns="50800" rIns="50800" tIns="25400" bIns="25400"/>
+          <a:lstStyle/>
+          <a:p>
+            <a:pPr algn="ctr"/>
+            <a:r>
+              <a:rPr sz="900" b="1">
+                <a:solidFill>
+                  <a:srgbClr val="FFFFFF"/>
+                </a:solidFill>
+                <a:latin typeface="Meiryo"/>
+              </a:rPr>
+              <a:t>新規ドメイン</a:t>
+            </a:r>
+          </a:p>
+        </p:txBody>
+      </p:sp>
+      <p:sp>
+        <p:nvSpPr>
+          <p:cNvPr id="35" name="Rectangle 34"/>
+          <p:cNvSpPr/>
+          <p:nvPr/>
+        </p:nvSpPr>
+        <p:spPr>
+          <a:xfrm>
+            <a:off x="731520" y="6675120"/>
+            <a:ext cx="4572000" cy="365760"/>
+          </a:xfrm>
+          <a:prstGeom prst="rect">
+            <a:avLst/>
+          </a:prstGeom>
+          <a:solidFill>
+            <a:srgbClr val="FFFFFF"/>
+          </a:solidFill>
+          <a:ln w="25400">
+            <a:solidFill>
+              <a:srgbClr val="CCCCCC"/>
+            </a:solidFill>
+          </a:ln>
+        </p:spPr>
+        <p:style>
+          <a:lnRef idx="1">
+            <a:schemeClr val="accent1"/>
+          </a:lnRef>
+          <a:fillRef idx="3">
+            <a:schemeClr val="accent1"/>
+          </a:fillRef>
+          <a:effectRef idx="2">
+            <a:schemeClr val="accent1"/>
+          </a:effectRef>
+          <a:fontRef idx="minor">
+            <a:schemeClr val="lt1"/>
+          </a:fontRef>
+        </p:style>
+        <p:txBody>
+          <a:bodyPr rtlCol="0" anchor="ctr" wrap="square" lIns="63500" rIns="50800" tIns="38100" bIns="38100"/>
+          <a:lstStyle/>
+          <a:p>
+            <a:pPr algn="l"/>
+            <a:r>
+              <a:rPr sz="800" b="1">
+                <a:solidFill>
+                  <a:srgbClr val="222222"/>
+                </a:solidFill>
+                <a:latin typeface="Meiryo"/>
+              </a:rPr>
+              <a:t>DMARC p=reject のみ</a:t>
+            </a:r>
+          </a:p>
+        </p:txBody>
+      </p:sp>
+      <p:sp>
+        <p:nvSpPr>
+          <p:cNvPr id="36" name="Rectangle 35"/>
+          <p:cNvSpPr/>
+          <p:nvPr/>
+        </p:nvSpPr>
+        <p:spPr>
+          <a:xfrm>
+            <a:off x="5303520" y="6675120"/>
+            <a:ext cx="3017520" cy="365760"/>
+          </a:xfrm>
+          <a:prstGeom prst="rect">
+            <a:avLst/>
+          </a:prstGeom>
+          <a:solidFill>
+            <a:srgbClr val="EAFAF1"/>
+          </a:solidFill>
+          <a:ln>
+            <a:noFill/>
+          </a:ln>
+        </p:spPr>
+        <p:style>
+          <a:lnRef idx="1">
+            <a:schemeClr val="accent1"/>
+          </a:lnRef>
+          <a:fillRef idx="3">
+            <a:schemeClr val="accent1"/>
+          </a:fillRef>
+          <a:effectRef idx="2">
+            <a:schemeClr val="accent1"/>
+          </a:effectRef>
+          <a:fontRef idx="minor">
+            <a:schemeClr val="lt1"/>
+          </a:fontRef>
+        </p:style>
+        <p:txBody>
+          <a:bodyPr rtlCol="0" anchor="ctr" wrap="square" lIns="50800" rIns="50800" tIns="25400" bIns="25400"/>
+          <a:lstStyle/>
+          <a:p>
+            <a:pPr algn="ctr"/>
+            <a:r>
+              <a:rPr sz="900" b="1">
+                <a:solidFill>
+                  <a:srgbClr val="27AE60"/>
+                </a:solidFill>
+                <a:latin typeface="Meiryo"/>
+              </a:rPr>
+              <a:t>✅ 防げる</a:t>
+            </a:r>
+          </a:p>
+        </p:txBody>
+      </p:sp>
+      <p:sp>
+        <p:nvSpPr>
+          <p:cNvPr id="37" name="Rectangle 36"/>
+          <p:cNvSpPr/>
+          <p:nvPr/>
+        </p:nvSpPr>
+        <p:spPr>
+          <a:xfrm>
+            <a:off x="8321040" y="6675120"/>
+            <a:ext cx="3017520" cy="365760"/>
+          </a:xfrm>
+          <a:prstGeom prst="rect">
+            <a:avLst/>
+          </a:prstGeom>
+          <a:solidFill>
+            <a:srgbClr val="FDEDEC"/>
+          </a:solidFill>
+          <a:ln>
+            <a:noFill/>
+          </a:ln>
+        </p:spPr>
+        <p:style>
+          <a:lnRef idx="1">
+            <a:schemeClr val="accent1"/>
+          </a:lnRef>
+          <a:fillRef idx="3">
+            <a:schemeClr val="accent1"/>
+          </a:fillRef>
+          <a:effectRef idx="2">
+            <a:schemeClr val="accent1"/>
+          </a:effectRef>
+          <a:fontRef idx="minor">
+            <a:schemeClr val="lt1"/>
+          </a:fontRef>
+        </p:style>
+        <p:txBody>
+          <a:bodyPr rtlCol="0" anchor="ctr" wrap="square" lIns="50800" rIns="50800" tIns="25400" bIns="25400"/>
+          <a:lstStyle/>
+          <a:p>
+            <a:pPr algn="ctr"/>
+            <a:r>
+              <a:rPr sz="900" b="1">
+                <a:solidFill>
+                  <a:srgbClr val="C0392B"/>
+                </a:solidFill>
+                <a:latin typeface="Meiryo"/>
+              </a:rPr>
+              <a:t>❌ 防げない</a:t>
+            </a:r>
+          </a:p>
+        </p:txBody>
+      </p:sp>
+      <p:sp>
+        <p:nvSpPr>
+          <p:cNvPr id="38" name="Rectangle 37"/>
+          <p:cNvSpPr/>
+          <p:nvPr/>
+        </p:nvSpPr>
+        <p:spPr>
+          <a:xfrm>
+            <a:off x="11338559" y="6675120"/>
+            <a:ext cx="3017520" cy="365760"/>
+          </a:xfrm>
+          <a:prstGeom prst="rect">
+            <a:avLst/>
+          </a:prstGeom>
+          <a:solidFill>
+            <a:srgbClr val="FDEDEC"/>
+          </a:solidFill>
+          <a:ln>
+            <a:noFill/>
+          </a:ln>
+        </p:spPr>
+        <p:style>
+          <a:lnRef idx="1">
+            <a:schemeClr val="accent1"/>
+          </a:lnRef>
+          <a:fillRef idx="3">
+            <a:schemeClr val="accent1"/>
+          </a:fillRef>
+          <a:effectRef idx="2">
+            <a:schemeClr val="accent1"/>
+          </a:effectRef>
+          <a:fontRef idx="minor">
+            <a:schemeClr val="lt1"/>
+          </a:fontRef>
+        </p:style>
+        <p:txBody>
+          <a:bodyPr rtlCol="0" anchor="ctr" wrap="square" lIns="50800" rIns="50800" tIns="25400" bIns="25400"/>
+          <a:lstStyle/>
+          <a:p>
+            <a:pPr algn="ctr"/>
+            <a:r>
+              <a:rPr sz="900" b="1">
+                <a:solidFill>
+                  <a:srgbClr val="C0392B"/>
+                </a:solidFill>
+                <a:latin typeface="Meiryo"/>
+              </a:rPr>
+              <a:t>❌ 防げない</a:t>
+            </a:r>
+          </a:p>
+        </p:txBody>
+      </p:sp>
+      <p:sp>
+        <p:nvSpPr>
+          <p:cNvPr id="39" name="Rectangle 38"/>
+          <p:cNvSpPr/>
+          <p:nvPr/>
+        </p:nvSpPr>
+        <p:spPr>
+          <a:xfrm>
+            <a:off x="731520" y="7040880"/>
+            <a:ext cx="4572000" cy="365760"/>
+          </a:xfrm>
+          <a:prstGeom prst="rect">
+            <a:avLst/>
+          </a:prstGeom>
+          <a:solidFill>
+            <a:srgbClr val="F9F9F9"/>
+          </a:solidFill>
+          <a:ln w="25400">
+            <a:solidFill>
+              <a:srgbClr val="CCCCCC"/>
+            </a:solidFill>
+          </a:ln>
+        </p:spPr>
+        <p:style>
+          <a:lnRef idx="1">
+            <a:schemeClr val="accent1"/>
+          </a:lnRef>
+          <a:fillRef idx="3">
+            <a:schemeClr val="accent1"/>
+          </a:fillRef>
+          <a:effectRef idx="2">
+            <a:schemeClr val="accent1"/>
+          </a:effectRef>
+          <a:fontRef idx="minor">
+            <a:schemeClr val="lt1"/>
+          </a:fontRef>
+        </p:style>
+        <p:txBody>
+          <a:bodyPr rtlCol="0" anchor="ctr" wrap="square" lIns="63500" rIns="50800" tIns="38100" bIns="38100"/>
+          <a:lstStyle/>
+          <a:p>
+            <a:pPr algn="l"/>
+            <a:r>
+              <a:rPr sz="800" b="1">
+                <a:solidFill>
+                  <a:srgbClr val="222222"/>
+                </a:solidFill>
+                <a:latin typeface="Meiryo"/>
+              </a:rPr>
+              <a:t>＋ 類似ドメイン防御的登録</a:t>
+            </a:r>
+          </a:p>
+        </p:txBody>
+      </p:sp>
+      <p:sp>
+        <p:nvSpPr>
+          <p:cNvPr id="40" name="Rectangle 39"/>
+          <p:cNvSpPr/>
+          <p:nvPr/>
+        </p:nvSpPr>
+        <p:spPr>
+          <a:xfrm>
+            <a:off x="5303520" y="7040880"/>
+            <a:ext cx="3017520" cy="365760"/>
+          </a:xfrm>
+          <a:prstGeom prst="rect">
+            <a:avLst/>
+          </a:prstGeom>
+          <a:solidFill>
+            <a:srgbClr val="EAFAF1"/>
+          </a:solidFill>
+          <a:ln>
+            <a:noFill/>
+          </a:ln>
+        </p:spPr>
+        <p:style>
+          <a:lnRef idx="1">
+            <a:schemeClr val="accent1"/>
+          </a:lnRef>
+          <a:fillRef idx="3">
+            <a:schemeClr val="accent1"/>
+          </a:fillRef>
+          <a:effectRef idx="2">
+            <a:schemeClr val="accent1"/>
+          </a:effectRef>
+          <a:fontRef idx="minor">
+            <a:schemeClr val="lt1"/>
+          </a:fontRef>
+        </p:style>
+        <p:txBody>
+          <a:bodyPr rtlCol="0" anchor="ctr" wrap="square" lIns="50800" rIns="50800" tIns="25400" bIns="25400"/>
+          <a:lstStyle/>
+          <a:p>
+            <a:pPr algn="ctr"/>
+            <a:r>
+              <a:rPr sz="900" b="1">
+                <a:solidFill>
+                  <a:srgbClr val="27AE60"/>
+                </a:solidFill>
+                <a:latin typeface="Meiryo"/>
+              </a:rPr>
+              <a:t>✅ 防げる</a:t>
+            </a:r>
+          </a:p>
+        </p:txBody>
+      </p:sp>
+      <p:sp>
+        <p:nvSpPr>
+          <p:cNvPr id="41" name="Rectangle 40"/>
+          <p:cNvSpPr/>
+          <p:nvPr/>
+        </p:nvSpPr>
+        <p:spPr>
+          <a:xfrm>
+            <a:off x="8321040" y="7040880"/>
+            <a:ext cx="3017520" cy="365760"/>
+          </a:xfrm>
+          <a:prstGeom prst="rect">
+            <a:avLst/>
+          </a:prstGeom>
+          <a:solidFill>
+            <a:srgbClr val="EAFAF1"/>
+          </a:solidFill>
+          <a:ln>
+            <a:noFill/>
+          </a:ln>
+        </p:spPr>
+        <p:style>
+          <a:lnRef idx="1">
+            <a:schemeClr val="accent1"/>
+          </a:lnRef>
+          <a:fillRef idx="3">
+            <a:schemeClr val="accent1"/>
+          </a:fillRef>
+          <a:effectRef idx="2">
+            <a:schemeClr val="accent1"/>
+          </a:effectRef>
+          <a:fontRef idx="minor">
+            <a:schemeClr val="lt1"/>
+          </a:fontRef>
+        </p:style>
+        <p:txBody>
+          <a:bodyPr rtlCol="0" anchor="ctr" wrap="square" lIns="50800" rIns="50800" tIns="25400" bIns="25400"/>
+          <a:lstStyle/>
+          <a:p>
+            <a:pPr algn="ctr"/>
+            <a:r>
+              <a:rPr sz="900" b="1">
+                <a:solidFill>
+                  <a:srgbClr val="27AE60"/>
+                </a:solidFill>
+                <a:latin typeface="Meiryo"/>
+              </a:rPr>
+              <a:t>✅ 防げる</a:t>
+            </a:r>
+          </a:p>
+        </p:txBody>
+      </p:sp>
+      <p:sp>
+        <p:nvSpPr>
+          <p:cNvPr id="42" name="Rectangle 41"/>
+          <p:cNvSpPr/>
+          <p:nvPr/>
+        </p:nvSpPr>
+        <p:spPr>
+          <a:xfrm>
+            <a:off x="11338559" y="7040880"/>
+            <a:ext cx="3017520" cy="365760"/>
+          </a:xfrm>
+          <a:prstGeom prst="rect">
+            <a:avLst/>
+          </a:prstGeom>
+          <a:solidFill>
+            <a:srgbClr val="FDEDEC"/>
+          </a:solidFill>
+          <a:ln>
+            <a:noFill/>
+          </a:ln>
+        </p:spPr>
+        <p:style>
+          <a:lnRef idx="1">
+            <a:schemeClr val="accent1"/>
+          </a:lnRef>
+          <a:fillRef idx="3">
+            <a:schemeClr val="accent1"/>
+          </a:fillRef>
+          <a:effectRef idx="2">
+            <a:schemeClr val="accent1"/>
+          </a:effectRef>
+          <a:fontRef idx="minor">
+            <a:schemeClr val="lt1"/>
+          </a:fontRef>
+        </p:style>
+        <p:txBody>
+          <a:bodyPr rtlCol="0" anchor="ctr" wrap="square" lIns="50800" rIns="50800" tIns="25400" bIns="25400"/>
+          <a:lstStyle/>
+          <a:p>
+            <a:pPr algn="ctr"/>
+            <a:r>
+              <a:rPr sz="900" b="1">
+                <a:solidFill>
+                  <a:srgbClr val="C0392B"/>
+                </a:solidFill>
+                <a:latin typeface="Meiryo"/>
+              </a:rPr>
+              <a:t>❌ 防げない</a:t>
+            </a:r>
+          </a:p>
+        </p:txBody>
+      </p:sp>
+      <p:sp>
+        <p:nvSpPr>
+          <p:cNvPr id="43" name="Rectangle 42"/>
+          <p:cNvSpPr/>
+          <p:nvPr/>
+        </p:nvSpPr>
+        <p:spPr>
+          <a:xfrm>
+            <a:off x="731520" y="7406640"/>
+            <a:ext cx="4572000" cy="365760"/>
+          </a:xfrm>
+          <a:prstGeom prst="rect">
+            <a:avLst/>
+          </a:prstGeom>
+          <a:solidFill>
+            <a:srgbClr val="FFFFFF"/>
+          </a:solidFill>
+          <a:ln w="25400">
+            <a:solidFill>
+              <a:srgbClr val="CCCCCC"/>
+            </a:solidFill>
+          </a:ln>
+        </p:spPr>
+        <p:style>
+          <a:lnRef idx="1">
+            <a:schemeClr val="accent1"/>
+          </a:lnRef>
+          <a:fillRef idx="3">
+            <a:schemeClr val="accent1"/>
+          </a:fillRef>
+          <a:effectRef idx="2">
+            <a:schemeClr val="accent1"/>
+          </a:effectRef>
+          <a:fontRef idx="minor">
+            <a:schemeClr val="lt1"/>
+          </a:fontRef>
+        </p:style>
+        <p:txBody>
+          <a:bodyPr rtlCol="0" anchor="ctr" wrap="square" lIns="63500" rIns="50800" tIns="38100" bIns="38100"/>
+          <a:lstStyle/>
+          <a:p>
+            <a:pPr algn="l"/>
+            <a:r>
+              <a:rPr sz="800" b="1">
+                <a:solidFill>
+                  <a:srgbClr val="222222"/>
+                </a:solidFill>
+                <a:latin typeface="Meiryo"/>
+              </a:rPr>
+              <a:t>＋ NRDブロック＋SPF/DKIM必須化</a:t>
+            </a:r>
+          </a:p>
+        </p:txBody>
+      </p:sp>
+      <p:sp>
+        <p:nvSpPr>
+          <p:cNvPr id="44" name="Rectangle 43"/>
+          <p:cNvSpPr/>
+          <p:nvPr/>
+        </p:nvSpPr>
+        <p:spPr>
+          <a:xfrm>
+            <a:off x="5303520" y="7406640"/>
+            <a:ext cx="3017520" cy="365760"/>
+          </a:xfrm>
+          <a:prstGeom prst="rect">
+            <a:avLst/>
+          </a:prstGeom>
+          <a:solidFill>
+            <a:srgbClr val="EAFAF1"/>
+          </a:solidFill>
+          <a:ln>
+            <a:noFill/>
+          </a:ln>
+        </p:spPr>
+        <p:style>
+          <a:lnRef idx="1">
+            <a:schemeClr val="accent1"/>
+          </a:lnRef>
+          <a:fillRef idx="3">
+            <a:schemeClr val="accent1"/>
+          </a:fillRef>
+          <a:effectRef idx="2">
+            <a:schemeClr val="accent1"/>
+          </a:effectRef>
+          <a:fontRef idx="minor">
+            <a:schemeClr val="lt1"/>
+          </a:fontRef>
+        </p:style>
+        <p:txBody>
+          <a:bodyPr rtlCol="0" anchor="ctr" wrap="square" lIns="50800" rIns="50800" tIns="25400" bIns="25400"/>
+          <a:lstStyle/>
+          <a:p>
+            <a:pPr algn="ctr"/>
+            <a:r>
+              <a:rPr sz="900" b="1">
+                <a:solidFill>
+                  <a:srgbClr val="27AE60"/>
+                </a:solidFill>
+                <a:latin typeface="Meiryo"/>
+              </a:rPr>
+              <a:t>✅ 防げる</a:t>
+            </a:r>
+          </a:p>
+        </p:txBody>
+      </p:sp>
+      <p:sp>
+        <p:nvSpPr>
+          <p:cNvPr id="45" name="Rectangle 44"/>
+          <p:cNvSpPr/>
+          <p:nvPr/>
+        </p:nvSpPr>
+        <p:spPr>
+          <a:xfrm>
+            <a:off x="8321040" y="7406640"/>
+            <a:ext cx="3017520" cy="365760"/>
+          </a:xfrm>
+          <a:prstGeom prst="rect">
+            <a:avLst/>
+          </a:prstGeom>
+          <a:solidFill>
+            <a:srgbClr val="EAFAF1"/>
+          </a:solidFill>
+          <a:ln>
+            <a:noFill/>
+          </a:ln>
+        </p:spPr>
+        <p:style>
+          <a:lnRef idx="1">
+            <a:schemeClr val="accent1"/>
+          </a:lnRef>
+          <a:fillRef idx="3">
+            <a:schemeClr val="accent1"/>
+          </a:fillRef>
+          <a:effectRef idx="2">
+            <a:schemeClr val="accent1"/>
+          </a:effectRef>
+          <a:fontRef idx="minor">
+            <a:schemeClr val="lt1"/>
+          </a:fontRef>
+        </p:style>
+        <p:txBody>
+          <a:bodyPr rtlCol="0" anchor="ctr" wrap="square" lIns="50800" rIns="50800" tIns="25400" bIns="25400"/>
+          <a:lstStyle/>
+          <a:p>
+            <a:pPr algn="ctr"/>
+            <a:r>
+              <a:rPr sz="900" b="1">
+                <a:solidFill>
+                  <a:srgbClr val="27AE60"/>
+                </a:solidFill>
+                <a:latin typeface="Meiryo"/>
+              </a:rPr>
+              <a:t>✅ 防げる</a:t>
+            </a:r>
+          </a:p>
+        </p:txBody>
+      </p:sp>
+      <p:sp>
+        <p:nvSpPr>
+          <p:cNvPr id="46" name="Rectangle 45"/>
+          <p:cNvSpPr/>
+          <p:nvPr/>
+        </p:nvSpPr>
+        <p:spPr>
+          <a:xfrm>
+            <a:off x="11338559" y="7406640"/>
+            <a:ext cx="3017520" cy="365760"/>
+          </a:xfrm>
+          <a:prstGeom prst="rect">
+            <a:avLst/>
+          </a:prstGeom>
+          <a:solidFill>
+            <a:srgbClr val="EAFAF1"/>
+          </a:solidFill>
+          <a:ln>
+            <a:noFill/>
+          </a:ln>
+        </p:spPr>
+        <p:style>
+          <a:lnRef idx="1">
+            <a:schemeClr val="accent1"/>
+          </a:lnRef>
+          <a:fillRef idx="3">
+            <a:schemeClr val="accent1"/>
+          </a:fillRef>
+          <a:effectRef idx="2">
+            <a:schemeClr val="accent1"/>
+          </a:effectRef>
+          <a:fontRef idx="minor">
+            <a:schemeClr val="lt1"/>
+          </a:fontRef>
+        </p:style>
+        <p:txBody>
+          <a:bodyPr rtlCol="0" anchor="ctr" wrap="square" lIns="50800" rIns="50800" tIns="25400" bIns="25400"/>
+          <a:lstStyle/>
+          <a:p>
+            <a:pPr algn="ctr"/>
+            <a:r>
+              <a:rPr sz="900" b="1">
+                <a:solidFill>
+                  <a:srgbClr val="27AE60"/>
+                </a:solidFill>
+                <a:latin typeface="Meiryo"/>
+              </a:rPr>
+              <a:t>✅ 防げる</a:t>
+            </a:r>
+          </a:p>
+        </p:txBody>
+      </p:sp>
+      <p:sp>
+        <p:nvSpPr>
+          <p:cNvPr id="47" name="Rectangle 46"/>
+          <p:cNvSpPr/>
+          <p:nvPr/>
+        </p:nvSpPr>
+        <p:spPr>
+          <a:xfrm>
+            <a:off x="731520" y="7772400"/>
+            <a:ext cx="4572000" cy="365760"/>
+          </a:xfrm>
+          <a:prstGeom prst="rect">
+            <a:avLst/>
+          </a:prstGeom>
+          <a:solidFill>
+            <a:srgbClr val="F9F9F9"/>
+          </a:solidFill>
+          <a:ln w="25400">
+            <a:solidFill>
+              <a:srgbClr val="CCCCCC"/>
+            </a:solidFill>
+          </a:ln>
+        </p:spPr>
+        <p:style>
+          <a:lnRef idx="1">
+            <a:schemeClr val="accent1"/>
+          </a:lnRef>
+          <a:fillRef idx="3">
+            <a:schemeClr val="accent1"/>
+          </a:fillRef>
+          <a:effectRef idx="2">
+            <a:schemeClr val="accent1"/>
+          </a:effectRef>
+          <a:fontRef idx="minor">
+            <a:schemeClr val="lt1"/>
+          </a:fontRef>
+        </p:style>
+        <p:txBody>
+          <a:bodyPr rtlCol="0" anchor="ctr" wrap="square" lIns="63500" rIns="50800" tIns="38100" bIns="38100"/>
+          <a:lstStyle/>
+          <a:p>
+            <a:pPr algn="l"/>
+            <a:r>
+              <a:rPr sz="800" b="1">
+                <a:solidFill>
+                  <a:srgbClr val="222222"/>
+                </a:solidFill>
+                <a:latin typeface="Meiryo"/>
+              </a:rPr>
+              <a:t>＋ 正規ドメイン公開＋GW制御（全部）</a:t>
+            </a:r>
+          </a:p>
+        </p:txBody>
+      </p:sp>
+      <p:sp>
+        <p:nvSpPr>
+          <p:cNvPr id="48" name="Rectangle 47"/>
+          <p:cNvSpPr/>
+          <p:nvPr/>
+        </p:nvSpPr>
+        <p:spPr>
+          <a:xfrm>
+            <a:off x="5303520" y="7772400"/>
+            <a:ext cx="3017520" cy="365760"/>
+          </a:xfrm>
+          <a:prstGeom prst="rect">
+            <a:avLst/>
+          </a:prstGeom>
+          <a:solidFill>
+            <a:srgbClr val="EAFAF1"/>
+          </a:solidFill>
+          <a:ln>
+            <a:noFill/>
+          </a:ln>
+        </p:spPr>
+        <p:style>
+          <a:lnRef idx="1">
+            <a:schemeClr val="accent1"/>
+          </a:lnRef>
+          <a:fillRef idx="3">
+            <a:schemeClr val="accent1"/>
+          </a:fillRef>
+          <a:effectRef idx="2">
+            <a:schemeClr val="accent1"/>
+          </a:effectRef>
+          <a:fontRef idx="minor">
+            <a:schemeClr val="lt1"/>
+          </a:fontRef>
+        </p:style>
+        <p:txBody>
+          <a:bodyPr rtlCol="0" anchor="ctr" wrap="square" lIns="50800" rIns="50800" tIns="25400" bIns="25400"/>
+          <a:lstStyle/>
+          <a:p>
+            <a:pPr algn="ctr"/>
+            <a:r>
+              <a:rPr sz="900" b="1">
+                <a:solidFill>
+                  <a:srgbClr val="27AE60"/>
+                </a:solidFill>
+                <a:latin typeface="Meiryo"/>
+              </a:rPr>
+              <a:t>✅ 防げる</a:t>
+            </a:r>
+          </a:p>
+        </p:txBody>
+      </p:sp>
+      <p:sp>
+        <p:nvSpPr>
+          <p:cNvPr id="49" name="Rectangle 48"/>
+          <p:cNvSpPr/>
+          <p:nvPr/>
+        </p:nvSpPr>
+        <p:spPr>
+          <a:xfrm>
+            <a:off x="8321040" y="7772400"/>
+            <a:ext cx="3017520" cy="365760"/>
+          </a:xfrm>
+          <a:prstGeom prst="rect">
+            <a:avLst/>
+          </a:prstGeom>
+          <a:solidFill>
+            <a:srgbClr val="EAFAF1"/>
+          </a:solidFill>
+          <a:ln>
+            <a:noFill/>
+          </a:ln>
+        </p:spPr>
+        <p:style>
+          <a:lnRef idx="1">
+            <a:schemeClr val="accent1"/>
+          </a:lnRef>
+          <a:fillRef idx="3">
+            <a:schemeClr val="accent1"/>
+          </a:fillRef>
+          <a:effectRef idx="2">
+            <a:schemeClr val="accent1"/>
+          </a:effectRef>
+          <a:fontRef idx="minor">
+            <a:schemeClr val="lt1"/>
+          </a:fontRef>
+        </p:style>
+        <p:txBody>
+          <a:bodyPr rtlCol="0" anchor="ctr" wrap="square" lIns="50800" rIns="50800" tIns="25400" bIns="25400"/>
+          <a:lstStyle/>
+          <a:p>
+            <a:pPr algn="ctr"/>
+            <a:r>
+              <a:rPr sz="900" b="1">
+                <a:solidFill>
+                  <a:srgbClr val="27AE60"/>
+                </a:solidFill>
+                <a:latin typeface="Meiryo"/>
+              </a:rPr>
+              <a:t>✅ 防げる</a:t>
+            </a:r>
+          </a:p>
+        </p:txBody>
+      </p:sp>
+      <p:sp>
+        <p:nvSpPr>
+          <p:cNvPr id="50" name="Rectangle 49"/>
+          <p:cNvSpPr/>
+          <p:nvPr/>
+        </p:nvSpPr>
+        <p:spPr>
+          <a:xfrm>
+            <a:off x="11338559" y="7772400"/>
+            <a:ext cx="3017520" cy="365760"/>
+          </a:xfrm>
+          <a:prstGeom prst="rect">
+            <a:avLst/>
+          </a:prstGeom>
+          <a:solidFill>
+            <a:srgbClr val="EAFAF1"/>
+          </a:solidFill>
+          <a:ln>
+            <a:noFill/>
+          </a:ln>
+        </p:spPr>
+        <p:style>
+          <a:lnRef idx="1">
+            <a:schemeClr val="accent1"/>
+          </a:lnRef>
+          <a:fillRef idx="3">
+            <a:schemeClr val="accent1"/>
+          </a:fillRef>
+          <a:effectRef idx="2">
+            <a:schemeClr val="accent1"/>
+          </a:effectRef>
+          <a:fontRef idx="minor">
+            <a:schemeClr val="lt1"/>
+          </a:fontRef>
+        </p:style>
+        <p:txBody>
+          <a:bodyPr rtlCol="0" anchor="ctr" wrap="square" lIns="50800" rIns="50800" tIns="25400" bIns="25400"/>
+          <a:lstStyle/>
+          <a:p>
+            <a:pPr algn="ctr"/>
+            <a:r>
+              <a:rPr sz="900" b="1">
+                <a:solidFill>
+                  <a:srgbClr val="27AE60"/>
+                </a:solidFill>
+                <a:latin typeface="Meiryo"/>
+              </a:rPr>
+              <a:t>✅ 防げる</a:t>
+            </a:r>
+          </a:p>
+        </p:txBody>
+      </p:sp>
+      <p:sp>
+        <p:nvSpPr>
+          <p:cNvPr id="51" name="Rectangle 50"/>
+          <p:cNvSpPr/>
+          <p:nvPr/>
+        </p:nvSpPr>
+        <p:spPr>
+          <a:xfrm>
+            <a:off x="731520" y="8229600"/>
+            <a:ext cx="13624560" cy="502920"/>
+          </a:xfrm>
+          <a:prstGeom prst="rect">
+            <a:avLst/>
+          </a:prstGeom>
+          <a:solidFill>
+            <a:srgbClr val="27AE60"/>
+          </a:solidFill>
+          <a:ln>
+            <a:noFill/>
+          </a:ln>
+        </p:spPr>
+        <p:style>
+          <a:lnRef idx="1">
+            <a:schemeClr val="accent1"/>
+          </a:lnRef>
+          <a:fillRef idx="3">
+            <a:schemeClr val="accent1"/>
+          </a:fillRef>
+          <a:effectRef idx="2">
+            <a:schemeClr val="accent1"/>
+          </a:effectRef>
+          <a:fontRef idx="minor">
+            <a:schemeClr val="lt1"/>
+          </a:fontRef>
+        </p:style>
+        <p:txBody>
+          <a:bodyPr rtlCol="0" anchor="ctr" wrap="square" lIns="50800" rIns="50800" tIns="25400" bIns="25400"/>
+          <a:lstStyle/>
+          <a:p>
+            <a:pPr algn="ctr"/>
+            <a:r>
+              <a:rPr sz="1300" b="1">
+                <a:solidFill>
+                  <a:srgbClr val="FFFFFF"/>
+                </a:solidFill>
+                <a:latin typeface="Meiryo"/>
+              </a:rPr>
+              <a:t>全部やれば手順④のメールは顧客に届かない。Kill Chainはここで切れる。顧客の注意力に一切依存しない。</a:t>
+            </a:r>
+          </a:p>
+        </p:txBody>
+      </p:sp>
+      <p:sp>
+        <p:nvSpPr>
+          <p:cNvPr id="52" name="Rectangle 51"/>
+          <p:cNvSpPr/>
+          <p:nvPr/>
+        </p:nvSpPr>
+        <p:spPr>
+          <a:xfrm>
+            <a:off x="731520" y="8778240"/>
+            <a:ext cx="13624560" cy="411480"/>
+          </a:xfrm>
+          <a:prstGeom prst="rect">
+            <a:avLst/>
+          </a:prstGeom>
+          <a:solidFill>
+            <a:srgbClr val="222222"/>
+          </a:solidFill>
+          <a:ln>
+            <a:noFill/>
+          </a:ln>
+        </p:spPr>
+        <p:style>
+          <a:lnRef idx="1">
+            <a:schemeClr val="accent1"/>
+          </a:lnRef>
+          <a:fillRef idx="3">
+            <a:schemeClr val="accent1"/>
+          </a:fillRef>
+          <a:effectRef idx="2">
+            <a:schemeClr val="accent1"/>
+          </a:effectRef>
+          <a:fontRef idx="minor">
+            <a:schemeClr val="lt1"/>
+          </a:fontRef>
+        </p:style>
+        <p:txBody>
+          <a:bodyPr rtlCol="0" anchor="ctr" wrap="square" lIns="50800" rIns="50800" tIns="25400" bIns="25400"/>
+          <a:lstStyle/>
+          <a:p>
+            <a:pPr algn="ctr"/>
+            <a:r>
+              <a:rPr sz="1400" b="1">
+                <a:solidFill>
+                  <a:srgbClr val="FFFFFF"/>
+                </a:solidFill>
+                <a:latin typeface="Meiryo"/>
+              </a:rPr>
+              <a:t>技術的にはもう解決できる話。やるかやらないかだけ。</a:t>
+            </a:r>
+          </a:p>
+        </p:txBody>
+      </p:sp>
+      <p:sp>
+        <p:nvSpPr>
+          <p:cNvPr id="53" name="TextBox 52"/>
+          <p:cNvSpPr txBox="1"/>
+          <p:nvPr/>
+        </p:nvSpPr>
+        <p:spPr>
+          <a:xfrm>
+            <a:off x="9144000" y="10378440"/>
+            <a:ext cx="5943600" cy="228600"/>
+          </a:xfrm>
+          <a:prstGeom prst="rect">
+            <a:avLst/>
+          </a:prstGeom>
+          <a:noFill/>
+        </p:spPr>
+        <p:txBody>
+          <a:bodyPr wrap="square" lIns="50800" rIns="50800" tIns="38100" bIns="38100"/>
+          <a:lstStyle/>
+          <a:p>
+            <a:pPr algn="r"/>
+            <a:r>
+              <a:rPr sz="700" b="0">
+                <a:solidFill>
+                  <a:srgbClr val="888888"/>
+                </a:solidFill>
+                <a:latin typeface="Meiryo"/>
+              </a:rPr>
+              <a:t>Fraud Kill Chain — DMARC＋DNSによる技術的遮断</a:t>
             </a:r>
           </a:p>
         </p:txBody>

</xml_diff>

<commit_message>
Add slide 8: email URL violates bank policy and FSA directive
Step 5 is the strongest flaw point — banks prohibit URLs in emails
per FSA directive, yet victims click anyway. The attacker's UX is
ironically better than the bank's, and step 2's fear overrides all
prior knowledge.

https://claude.ai/code/session_01F7t8LKifK43o6sCdF2a3gQ
</commit_message>
<xml_diff>
--- a/Fraud_Kill_Chain.pptx
+++ b/Fraud_Kill_Chain.pptx
@@ -12,6 +12,7 @@
     <p:sldId id="260" r:id="rId11"/>
     <p:sldId id="261" r:id="rId12"/>
     <p:sldId id="262" r:id="rId13"/>
+    <p:sldId id="263" r:id="rId14"/>
   </p:sldIdLst>
   <p:sldSz cx="15124176" cy="10689336" type="screen4x3"/>
   <p:notesSz cx="6858000" cy="9144000"/>
@@ -17779,6 +17780,1640 @@
                 <a:latin typeface="Meiryo"/>
               </a:rPr>
               <a:t>Fraud Kill Chain — DMARC＋DNSによる技術的遮断</a:t>
+            </a:r>
+          </a:p>
+        </p:txBody>
+      </p:sp>
+    </p:spTree>
+  </p:cSld>
+  <p:clrMapOvr>
+    <a:masterClrMapping/>
+  </p:clrMapOvr>
+</p:sld>
+</file>
+
+<file path=ppt/slides/slide8.xml><?xml version="1.0" encoding="utf-8"?>
+<p:sld xmlns:a="http://schemas.openxmlformats.org/drawingml/2006/main" xmlns:p="http://schemas.openxmlformats.org/presentationml/2006/main" xmlns:r="http://schemas.openxmlformats.org/officeDocument/2006/relationships">
+  <p:cSld>
+    <p:bg>
+      <p:bgPr>
+        <a:solidFill>
+          <a:srgbClr val="F5F5F5"/>
+        </a:solidFill>
+        <a:effectLst/>
+      </p:bgPr>
+    </p:bg>
+    <p:spTree>
+      <p:nvGrpSpPr>
+        <p:cNvPr id="1" name=""/>
+        <p:cNvGrpSpPr/>
+        <p:nvPr/>
+      </p:nvGrpSpPr>
+      <p:grpSpPr/>
+      <p:sp>
+        <p:nvSpPr>
+          <p:cNvPr id="2" name="TextBox 1"/>
+          <p:cNvSpPr txBox="1"/>
+          <p:nvPr/>
+        </p:nvSpPr>
+        <p:spPr>
+          <a:xfrm>
+            <a:off x="0" y="182880"/>
+            <a:ext cx="15124176" cy="548640"/>
+          </a:xfrm>
+          <a:prstGeom prst="rect">
+            <a:avLst/>
+          </a:prstGeom>
+          <a:noFill/>
+        </p:spPr>
+        <p:txBody>
+          <a:bodyPr wrap="square" lIns="50800" rIns="50800" tIns="38100" bIns="38100"/>
+          <a:lstStyle/>
+          <a:p>
+            <a:pPr algn="ctr"/>
+            <a:r>
+              <a:rPr sz="2200" b="1">
+                <a:solidFill>
+                  <a:srgbClr val="8E44AD"/>
+                </a:solidFill>
+                <a:latin typeface="Meiryo"/>
+              </a:rPr>
+              <a:t>手順⑤「メールのボタンをクリックして」— 最大の破綻ポイント</a:t>
+            </a:r>
+          </a:p>
+        </p:txBody>
+      </p:sp>
+      <p:sp>
+        <p:nvSpPr>
+          <p:cNvPr id="3" name="TextBox 2"/>
+          <p:cNvSpPr txBox="1"/>
+          <p:nvPr/>
+        </p:nvSpPr>
+        <p:spPr>
+          <a:xfrm>
+            <a:off x="0" y="685800"/>
+            <a:ext cx="15124176" cy="365760"/>
+          </a:xfrm>
+          <a:prstGeom prst="rect">
+            <a:avLst/>
+          </a:prstGeom>
+          <a:noFill/>
+        </p:spPr>
+        <p:txBody>
+          <a:bodyPr wrap="square" lIns="50800" rIns="50800" tIns="38100" bIns="38100"/>
+          <a:lstStyle/>
+          <a:p>
+            <a:pPr algn="ctr"/>
+            <a:r>
+              <a:rPr sz="1200" b="0">
+                <a:solidFill>
+                  <a:srgbClr val="888888"/>
+                </a:solidFill>
+                <a:latin typeface="Meiryo"/>
+              </a:rPr>
+              <a:t>銀行の方針・金融庁の要請・顧客への周知、すべてに反する行為。それでも突破される。</a:t>
+            </a:r>
+          </a:p>
+        </p:txBody>
+      </p:sp>
+      <p:sp>
+        <p:nvSpPr>
+          <p:cNvPr id="4" name="Rectangle 3"/>
+          <p:cNvSpPr/>
+          <p:nvPr/>
+        </p:nvSpPr>
+        <p:spPr>
+          <a:xfrm>
+            <a:off x="731520" y="1097280"/>
+            <a:ext cx="13624560" cy="502920"/>
+          </a:xfrm>
+          <a:prstGeom prst="rect">
+            <a:avLst/>
+          </a:prstGeom>
+          <a:solidFill>
+            <a:srgbClr val="C0392B"/>
+          </a:solidFill>
+          <a:ln>
+            <a:noFill/>
+          </a:ln>
+        </p:spPr>
+        <p:style>
+          <a:lnRef idx="1">
+            <a:schemeClr val="accent1"/>
+          </a:lnRef>
+          <a:fillRef idx="3">
+            <a:schemeClr val="accent1"/>
+          </a:fillRef>
+          <a:effectRef idx="2">
+            <a:schemeClr val="accent1"/>
+          </a:effectRef>
+          <a:fontRef idx="minor">
+            <a:schemeClr val="lt1"/>
+          </a:fontRef>
+        </p:style>
+        <p:txBody>
+          <a:bodyPr rtlCol="0" anchor="ctr" wrap="square" lIns="50800" rIns="50800" tIns="25400" bIns="25400"/>
+          <a:lstStyle/>
+          <a:p>
+            <a:pPr algn="ctr"/>
+            <a:r>
+              <a:rPr sz="1300" b="1">
+                <a:solidFill>
+                  <a:srgbClr val="FFFFFF"/>
+                </a:solidFill>
+                <a:latin typeface="Meiryo"/>
+              </a:rPr>
+              <a:t>金融庁の要請：金融機関が顧客に送信するメールにURLリンクを記載しないこと</a:t>
+            </a:r>
+          </a:p>
+        </p:txBody>
+      </p:sp>
+      <p:sp>
+        <p:nvSpPr>
+          <p:cNvPr id="5" name="TextBox 4"/>
+          <p:cNvSpPr txBox="1"/>
+          <p:nvPr/>
+        </p:nvSpPr>
+        <p:spPr>
+          <a:xfrm>
+            <a:off x="731520" y="1627631"/>
+            <a:ext cx="13624560" cy="274320"/>
+          </a:xfrm>
+          <a:prstGeom prst="rect">
+            <a:avLst/>
+          </a:prstGeom>
+          <a:noFill/>
+        </p:spPr>
+        <p:txBody>
+          <a:bodyPr wrap="square" lIns="50800" rIns="50800" tIns="38100" bIns="38100"/>
+          <a:lstStyle/>
+          <a:p>
+            <a:pPr algn="l"/>
+            <a:r>
+              <a:rPr sz="900" b="0">
+                <a:solidFill>
+                  <a:srgbClr val="888888"/>
+                </a:solidFill>
+                <a:latin typeface="Meiryo"/>
+              </a:rPr>
+              <a:t>→ 多くの銀行が「メール内のリンクはクリックしないでください」と顧客に周知済み</a:t>
+            </a:r>
+          </a:p>
+        </p:txBody>
+      </p:sp>
+      <p:sp>
+        <p:nvSpPr>
+          <p:cNvPr id="6" name="Rectangle 5"/>
+          <p:cNvSpPr/>
+          <p:nvPr/>
+        </p:nvSpPr>
+        <p:spPr>
+          <a:xfrm>
+            <a:off x="731520" y="2011680"/>
+            <a:ext cx="2286000" cy="411480"/>
+          </a:xfrm>
+          <a:prstGeom prst="rect">
+            <a:avLst/>
+          </a:prstGeom>
+          <a:solidFill>
+            <a:srgbClr val="222222"/>
+          </a:solidFill>
+          <a:ln>
+            <a:noFill/>
+          </a:ln>
+        </p:spPr>
+        <p:style>
+          <a:lnRef idx="1">
+            <a:schemeClr val="accent1"/>
+          </a:lnRef>
+          <a:fillRef idx="3">
+            <a:schemeClr val="accent1"/>
+          </a:fillRef>
+          <a:effectRef idx="2">
+            <a:schemeClr val="accent1"/>
+          </a:effectRef>
+          <a:fontRef idx="minor">
+            <a:schemeClr val="lt1"/>
+          </a:fontRef>
+        </p:style>
+        <p:txBody>
+          <a:bodyPr rtlCol="0" anchor="ctr" wrap="square" lIns="50800" rIns="50800" tIns="25400" bIns="25400"/>
+          <a:lstStyle/>
+          <a:p>
+            <a:pPr algn="ctr"/>
+            <a:r>
+              <a:rPr sz="1000" b="1">
+                <a:solidFill>
+                  <a:srgbClr val="FFFFFF"/>
+                </a:solidFill>
+                <a:latin typeface="Meiryo"/>
+              </a:rPr>
+              <a:t/>
+            </a:r>
+          </a:p>
+        </p:txBody>
+      </p:sp>
+      <p:sp>
+        <p:nvSpPr>
+          <p:cNvPr id="7" name="Rectangle 6"/>
+          <p:cNvSpPr/>
+          <p:nvPr/>
+        </p:nvSpPr>
+        <p:spPr>
+          <a:xfrm>
+            <a:off x="3017520" y="2011680"/>
+            <a:ext cx="5486400" cy="411480"/>
+          </a:xfrm>
+          <a:prstGeom prst="rect">
+            <a:avLst/>
+          </a:prstGeom>
+          <a:solidFill>
+            <a:srgbClr val="222222"/>
+          </a:solidFill>
+          <a:ln>
+            <a:noFill/>
+          </a:ln>
+        </p:spPr>
+        <p:style>
+          <a:lnRef idx="1">
+            <a:schemeClr val="accent1"/>
+          </a:lnRef>
+          <a:fillRef idx="3">
+            <a:schemeClr val="accent1"/>
+          </a:fillRef>
+          <a:effectRef idx="2">
+            <a:schemeClr val="accent1"/>
+          </a:effectRef>
+          <a:fontRef idx="minor">
+            <a:schemeClr val="lt1"/>
+          </a:fontRef>
+        </p:style>
+        <p:txBody>
+          <a:bodyPr rtlCol="0" anchor="ctr" wrap="square" lIns="50800" rIns="50800" tIns="25400" bIns="25400"/>
+          <a:lstStyle/>
+          <a:p>
+            <a:pPr algn="ctr"/>
+            <a:r>
+              <a:rPr sz="1000" b="1">
+                <a:solidFill>
+                  <a:srgbClr val="FFFFFF"/>
+                </a:solidFill>
+                <a:latin typeface="Meiryo"/>
+              </a:rPr>
+              <a:t>銀行の正規誘導</a:t>
+            </a:r>
+          </a:p>
+        </p:txBody>
+      </p:sp>
+      <p:sp>
+        <p:nvSpPr>
+          <p:cNvPr id="8" name="Rectangle 7"/>
+          <p:cNvSpPr/>
+          <p:nvPr/>
+        </p:nvSpPr>
+        <p:spPr>
+          <a:xfrm>
+            <a:off x="8503920" y="2011680"/>
+            <a:ext cx="5852160" cy="411480"/>
+          </a:xfrm>
+          <a:prstGeom prst="rect">
+            <a:avLst/>
+          </a:prstGeom>
+          <a:solidFill>
+            <a:srgbClr val="222222"/>
+          </a:solidFill>
+          <a:ln>
+            <a:noFill/>
+          </a:ln>
+        </p:spPr>
+        <p:style>
+          <a:lnRef idx="1">
+            <a:schemeClr val="accent1"/>
+          </a:lnRef>
+          <a:fillRef idx="3">
+            <a:schemeClr val="accent1"/>
+          </a:fillRef>
+          <a:effectRef idx="2">
+            <a:schemeClr val="accent1"/>
+          </a:effectRef>
+          <a:fontRef idx="minor">
+            <a:schemeClr val="lt1"/>
+          </a:fontRef>
+        </p:style>
+        <p:txBody>
+          <a:bodyPr rtlCol="0" anchor="ctr" wrap="square" lIns="50800" rIns="50800" tIns="25400" bIns="25400"/>
+          <a:lstStyle/>
+          <a:p>
+            <a:pPr algn="ctr"/>
+            <a:r>
+              <a:rPr sz="1000" b="1">
+                <a:solidFill>
+                  <a:srgbClr val="FFFFFF"/>
+                </a:solidFill>
+                <a:latin typeface="Meiryo"/>
+              </a:rPr>
+              <a:t>この攻撃</a:t>
+            </a:r>
+          </a:p>
+        </p:txBody>
+      </p:sp>
+      <p:sp>
+        <p:nvSpPr>
+          <p:cNvPr id="9" name="Rectangle 8"/>
+          <p:cNvSpPr/>
+          <p:nvPr/>
+        </p:nvSpPr>
+        <p:spPr>
+          <a:xfrm>
+            <a:off x="731520" y="2423160"/>
+            <a:ext cx="2286000" cy="457200"/>
+          </a:xfrm>
+          <a:prstGeom prst="rect">
+            <a:avLst/>
+          </a:prstGeom>
+          <a:solidFill>
+            <a:srgbClr val="FFFFFF"/>
+          </a:solidFill>
+          <a:ln w="25400">
+            <a:solidFill>
+              <a:srgbClr val="CCCCCC"/>
+            </a:solidFill>
+          </a:ln>
+        </p:spPr>
+        <p:style>
+          <a:lnRef idx="1">
+            <a:schemeClr val="accent1"/>
+          </a:lnRef>
+          <a:fillRef idx="3">
+            <a:schemeClr val="accent1"/>
+          </a:fillRef>
+          <a:effectRef idx="2">
+            <a:schemeClr val="accent1"/>
+          </a:effectRef>
+          <a:fontRef idx="minor">
+            <a:schemeClr val="lt1"/>
+          </a:fontRef>
+        </p:style>
+        <p:txBody>
+          <a:bodyPr rtlCol="0" anchor="ctr" wrap="square" lIns="63500" rIns="50800" tIns="38100" bIns="38100"/>
+          <a:lstStyle/>
+          <a:p>
+            <a:pPr algn="l"/>
+            <a:r>
+              <a:rPr sz="1000" b="1">
+                <a:solidFill>
+                  <a:srgbClr val="222222"/>
+                </a:solidFill>
+                <a:latin typeface="Meiryo"/>
+              </a:rPr>
+              <a:t>方法</a:t>
+            </a:r>
+          </a:p>
+        </p:txBody>
+      </p:sp>
+      <p:sp>
+        <p:nvSpPr>
+          <p:cNvPr id="10" name="Rectangle 9"/>
+          <p:cNvSpPr/>
+          <p:nvPr/>
+        </p:nvSpPr>
+        <p:spPr>
+          <a:xfrm>
+            <a:off x="3017520" y="2423160"/>
+            <a:ext cx="5486400" cy="457200"/>
+          </a:xfrm>
+          <a:prstGeom prst="rect">
+            <a:avLst/>
+          </a:prstGeom>
+          <a:solidFill>
+            <a:srgbClr val="FFFFFF"/>
+          </a:solidFill>
+          <a:ln w="25400">
+            <a:solidFill>
+              <a:srgbClr val="CCCCCC"/>
+            </a:solidFill>
+          </a:ln>
+        </p:spPr>
+        <p:style>
+          <a:lnRef idx="1">
+            <a:schemeClr val="accent1"/>
+          </a:lnRef>
+          <a:fillRef idx="3">
+            <a:schemeClr val="accent1"/>
+          </a:fillRef>
+          <a:effectRef idx="2">
+            <a:schemeClr val="accent1"/>
+          </a:effectRef>
+          <a:fontRef idx="minor">
+            <a:schemeClr val="lt1"/>
+          </a:fontRef>
+        </p:style>
+        <p:txBody>
+          <a:bodyPr rtlCol="0" anchor="ctr" wrap="square" lIns="63500" rIns="50800" tIns="38100" bIns="38100"/>
+          <a:lstStyle/>
+          <a:p>
+            <a:pPr algn="l"/>
+            <a:r>
+              <a:rPr sz="1000" b="0">
+                <a:solidFill>
+                  <a:srgbClr val="222222"/>
+                </a:solidFill>
+                <a:latin typeface="Meiryo"/>
+              </a:rPr>
+              <a:t>ブックマーク・URL直接入力・公式アプリ</a:t>
+            </a:r>
+          </a:p>
+        </p:txBody>
+      </p:sp>
+      <p:sp>
+        <p:nvSpPr>
+          <p:cNvPr id="11" name="Rectangle 10"/>
+          <p:cNvSpPr/>
+          <p:nvPr/>
+        </p:nvSpPr>
+        <p:spPr>
+          <a:xfrm>
+            <a:off x="8503920" y="2423160"/>
+            <a:ext cx="5852160" cy="457200"/>
+          </a:xfrm>
+          <a:prstGeom prst="rect">
+            <a:avLst/>
+          </a:prstGeom>
+          <a:solidFill>
+            <a:srgbClr val="FFFFFF"/>
+          </a:solidFill>
+          <a:ln w="25400">
+            <a:solidFill>
+              <a:srgbClr val="C0392B"/>
+            </a:solidFill>
+          </a:ln>
+        </p:spPr>
+        <p:style>
+          <a:lnRef idx="1">
+            <a:schemeClr val="accent1"/>
+          </a:lnRef>
+          <a:fillRef idx="3">
+            <a:schemeClr val="accent1"/>
+          </a:fillRef>
+          <a:effectRef idx="2">
+            <a:schemeClr val="accent1"/>
+          </a:effectRef>
+          <a:fontRef idx="minor">
+            <a:schemeClr val="lt1"/>
+          </a:fontRef>
+        </p:style>
+        <p:txBody>
+          <a:bodyPr rtlCol="0" anchor="ctr" wrap="square" lIns="63500" rIns="50800" tIns="38100" bIns="38100"/>
+          <a:lstStyle/>
+          <a:p>
+            <a:pPr algn="l"/>
+            <a:r>
+              <a:rPr sz="1000" b="1">
+                <a:solidFill>
+                  <a:srgbClr val="C0392B"/>
+                </a:solidFill>
+                <a:latin typeface="Meiryo"/>
+              </a:rPr>
+              <a:t>メールのボタンをクリック</a:t>
+            </a:r>
+          </a:p>
+        </p:txBody>
+      </p:sp>
+      <p:sp>
+        <p:nvSpPr>
+          <p:cNvPr id="12" name="Rectangle 11"/>
+          <p:cNvSpPr/>
+          <p:nvPr/>
+        </p:nvSpPr>
+        <p:spPr>
+          <a:xfrm>
+            <a:off x="731520" y="2880360"/>
+            <a:ext cx="2286000" cy="457200"/>
+          </a:xfrm>
+          <a:prstGeom prst="rect">
+            <a:avLst/>
+          </a:prstGeom>
+          <a:solidFill>
+            <a:srgbClr val="F9F9F9"/>
+          </a:solidFill>
+          <a:ln w="25400">
+            <a:solidFill>
+              <a:srgbClr val="CCCCCC"/>
+            </a:solidFill>
+          </a:ln>
+        </p:spPr>
+        <p:style>
+          <a:lnRef idx="1">
+            <a:schemeClr val="accent1"/>
+          </a:lnRef>
+          <a:fillRef idx="3">
+            <a:schemeClr val="accent1"/>
+          </a:fillRef>
+          <a:effectRef idx="2">
+            <a:schemeClr val="accent1"/>
+          </a:effectRef>
+          <a:fontRef idx="minor">
+            <a:schemeClr val="lt1"/>
+          </a:fontRef>
+        </p:style>
+        <p:txBody>
+          <a:bodyPr rtlCol="0" anchor="ctr" wrap="square" lIns="63500" rIns="50800" tIns="38100" bIns="38100"/>
+          <a:lstStyle/>
+          <a:p>
+            <a:pPr algn="l"/>
+            <a:r>
+              <a:rPr sz="1000" b="1">
+                <a:solidFill>
+                  <a:srgbClr val="222222"/>
+                </a:solidFill>
+                <a:latin typeface="Meiryo"/>
+              </a:rPr>
+              <a:t>URLの出所</a:t>
+            </a:r>
+          </a:p>
+        </p:txBody>
+      </p:sp>
+      <p:sp>
+        <p:nvSpPr>
+          <p:cNvPr id="13" name="Rectangle 12"/>
+          <p:cNvSpPr/>
+          <p:nvPr/>
+        </p:nvSpPr>
+        <p:spPr>
+          <a:xfrm>
+            <a:off x="3017520" y="2880360"/>
+            <a:ext cx="5486400" cy="457200"/>
+          </a:xfrm>
+          <a:prstGeom prst="rect">
+            <a:avLst/>
+          </a:prstGeom>
+          <a:solidFill>
+            <a:srgbClr val="F9F9F9"/>
+          </a:solidFill>
+          <a:ln w="25400">
+            <a:solidFill>
+              <a:srgbClr val="CCCCCC"/>
+            </a:solidFill>
+          </a:ln>
+        </p:spPr>
+        <p:style>
+          <a:lnRef idx="1">
+            <a:schemeClr val="accent1"/>
+          </a:lnRef>
+          <a:fillRef idx="3">
+            <a:schemeClr val="accent1"/>
+          </a:fillRef>
+          <a:effectRef idx="2">
+            <a:schemeClr val="accent1"/>
+          </a:effectRef>
+          <a:fontRef idx="minor">
+            <a:schemeClr val="lt1"/>
+          </a:fontRef>
+        </p:style>
+        <p:txBody>
+          <a:bodyPr rtlCol="0" anchor="ctr" wrap="square" lIns="63500" rIns="50800" tIns="38100" bIns="38100"/>
+          <a:lstStyle/>
+          <a:p>
+            <a:pPr algn="l"/>
+            <a:r>
+              <a:rPr sz="1000" b="0">
+                <a:solidFill>
+                  <a:srgbClr val="222222"/>
+                </a:solidFill>
+                <a:latin typeface="Meiryo"/>
+              </a:rPr>
+              <a:t>顧客が自分で持っている</a:t>
+            </a:r>
+          </a:p>
+        </p:txBody>
+      </p:sp>
+      <p:sp>
+        <p:nvSpPr>
+          <p:cNvPr id="14" name="Rectangle 13"/>
+          <p:cNvSpPr/>
+          <p:nvPr/>
+        </p:nvSpPr>
+        <p:spPr>
+          <a:xfrm>
+            <a:off x="8503920" y="2880360"/>
+            <a:ext cx="5852160" cy="457200"/>
+          </a:xfrm>
+          <a:prstGeom prst="rect">
+            <a:avLst/>
+          </a:prstGeom>
+          <a:solidFill>
+            <a:srgbClr val="F9F9F9"/>
+          </a:solidFill>
+          <a:ln w="25400">
+            <a:solidFill>
+              <a:srgbClr val="C0392B"/>
+            </a:solidFill>
+          </a:ln>
+        </p:spPr>
+        <p:style>
+          <a:lnRef idx="1">
+            <a:schemeClr val="accent1"/>
+          </a:lnRef>
+          <a:fillRef idx="3">
+            <a:schemeClr val="accent1"/>
+          </a:fillRef>
+          <a:effectRef idx="2">
+            <a:schemeClr val="accent1"/>
+          </a:effectRef>
+          <a:fontRef idx="minor">
+            <a:schemeClr val="lt1"/>
+          </a:fontRef>
+        </p:style>
+        <p:txBody>
+          <a:bodyPr rtlCol="0" anchor="ctr" wrap="square" lIns="63500" rIns="50800" tIns="38100" bIns="38100"/>
+          <a:lstStyle/>
+          <a:p>
+            <a:pPr algn="l"/>
+            <a:r>
+              <a:rPr sz="1000" b="1">
+                <a:solidFill>
+                  <a:srgbClr val="C0392B"/>
+                </a:solidFill>
+                <a:latin typeface="Meiryo"/>
+              </a:rPr>
+              <a:t>犯人が送りつけた</a:t>
+            </a:r>
+          </a:p>
+        </p:txBody>
+      </p:sp>
+      <p:sp>
+        <p:nvSpPr>
+          <p:cNvPr id="15" name="Rectangle 14"/>
+          <p:cNvSpPr/>
+          <p:nvPr/>
+        </p:nvSpPr>
+        <p:spPr>
+          <a:xfrm>
+            <a:off x="731520" y="3337560"/>
+            <a:ext cx="2286000" cy="457200"/>
+          </a:xfrm>
+          <a:prstGeom prst="rect">
+            <a:avLst/>
+          </a:prstGeom>
+          <a:solidFill>
+            <a:srgbClr val="FFFFFF"/>
+          </a:solidFill>
+          <a:ln w="25400">
+            <a:solidFill>
+              <a:srgbClr val="CCCCCC"/>
+            </a:solidFill>
+          </a:ln>
+        </p:spPr>
+        <p:style>
+          <a:lnRef idx="1">
+            <a:schemeClr val="accent1"/>
+          </a:lnRef>
+          <a:fillRef idx="3">
+            <a:schemeClr val="accent1"/>
+          </a:fillRef>
+          <a:effectRef idx="2">
+            <a:schemeClr val="accent1"/>
+          </a:effectRef>
+          <a:fontRef idx="minor">
+            <a:schemeClr val="lt1"/>
+          </a:fontRef>
+        </p:style>
+        <p:txBody>
+          <a:bodyPr rtlCol="0" anchor="ctr" wrap="square" lIns="63500" rIns="50800" tIns="38100" bIns="38100"/>
+          <a:lstStyle/>
+          <a:p>
+            <a:pPr algn="l"/>
+            <a:r>
+              <a:rPr sz="1000" b="1">
+                <a:solidFill>
+                  <a:srgbClr val="222222"/>
+                </a:solidFill>
+                <a:latin typeface="Meiryo"/>
+              </a:rPr>
+              <a:t>顧客の行動</a:t>
+            </a:r>
+          </a:p>
+        </p:txBody>
+      </p:sp>
+      <p:sp>
+        <p:nvSpPr>
+          <p:cNvPr id="16" name="Rectangle 15"/>
+          <p:cNvSpPr/>
+          <p:nvPr/>
+        </p:nvSpPr>
+        <p:spPr>
+          <a:xfrm>
+            <a:off x="3017520" y="3337560"/>
+            <a:ext cx="5486400" cy="457200"/>
+          </a:xfrm>
+          <a:prstGeom prst="rect">
+            <a:avLst/>
+          </a:prstGeom>
+          <a:solidFill>
+            <a:srgbClr val="FFFFFF"/>
+          </a:solidFill>
+          <a:ln w="25400">
+            <a:solidFill>
+              <a:srgbClr val="CCCCCC"/>
+            </a:solidFill>
+          </a:ln>
+        </p:spPr>
+        <p:style>
+          <a:lnRef idx="1">
+            <a:schemeClr val="accent1"/>
+          </a:lnRef>
+          <a:fillRef idx="3">
+            <a:schemeClr val="accent1"/>
+          </a:fillRef>
+          <a:effectRef idx="2">
+            <a:schemeClr val="accent1"/>
+          </a:effectRef>
+          <a:fontRef idx="minor">
+            <a:schemeClr val="lt1"/>
+          </a:fontRef>
+        </p:style>
+        <p:txBody>
+          <a:bodyPr rtlCol="0" anchor="ctr" wrap="square" lIns="63500" rIns="50800" tIns="38100" bIns="38100"/>
+          <a:lstStyle/>
+          <a:p>
+            <a:pPr algn="l"/>
+            <a:r>
+              <a:rPr sz="1000" b="0">
+                <a:solidFill>
+                  <a:srgbClr val="222222"/>
+                </a:solidFill>
+                <a:latin typeface="Meiryo"/>
+              </a:rPr>
+              <a:t>能動的（自分でアクセス）</a:t>
+            </a:r>
+          </a:p>
+        </p:txBody>
+      </p:sp>
+      <p:sp>
+        <p:nvSpPr>
+          <p:cNvPr id="17" name="Rectangle 16"/>
+          <p:cNvSpPr/>
+          <p:nvPr/>
+        </p:nvSpPr>
+        <p:spPr>
+          <a:xfrm>
+            <a:off x="8503920" y="3337560"/>
+            <a:ext cx="5852160" cy="457200"/>
+          </a:xfrm>
+          <a:prstGeom prst="rect">
+            <a:avLst/>
+          </a:prstGeom>
+          <a:solidFill>
+            <a:srgbClr val="FFFFFF"/>
+          </a:solidFill>
+          <a:ln w="25400">
+            <a:solidFill>
+              <a:srgbClr val="C0392B"/>
+            </a:solidFill>
+          </a:ln>
+        </p:spPr>
+        <p:style>
+          <a:lnRef idx="1">
+            <a:schemeClr val="accent1"/>
+          </a:lnRef>
+          <a:fillRef idx="3">
+            <a:schemeClr val="accent1"/>
+          </a:fillRef>
+          <a:effectRef idx="2">
+            <a:schemeClr val="accent1"/>
+          </a:effectRef>
+          <a:fontRef idx="minor">
+            <a:schemeClr val="lt1"/>
+          </a:fontRef>
+        </p:style>
+        <p:txBody>
+          <a:bodyPr rtlCol="0" anchor="ctr" wrap="square" lIns="63500" rIns="50800" tIns="38100" bIns="38100"/>
+          <a:lstStyle/>
+          <a:p>
+            <a:pPr algn="l"/>
+            <a:r>
+              <a:rPr sz="1000" b="1">
+                <a:solidFill>
+                  <a:srgbClr val="C0392B"/>
+                </a:solidFill>
+                <a:latin typeface="Meiryo"/>
+              </a:rPr>
+              <a:t>受動的（指示されてクリック）</a:t>
+            </a:r>
+          </a:p>
+        </p:txBody>
+      </p:sp>
+      <p:sp>
+        <p:nvSpPr>
+          <p:cNvPr id="18" name="Rectangle 17"/>
+          <p:cNvSpPr/>
+          <p:nvPr/>
+        </p:nvSpPr>
+        <p:spPr>
+          <a:xfrm>
+            <a:off x="731520" y="3794760"/>
+            <a:ext cx="2286000" cy="457200"/>
+          </a:xfrm>
+          <a:prstGeom prst="rect">
+            <a:avLst/>
+          </a:prstGeom>
+          <a:solidFill>
+            <a:srgbClr val="F9F9F9"/>
+          </a:solidFill>
+          <a:ln w="25400">
+            <a:solidFill>
+              <a:srgbClr val="CCCCCC"/>
+            </a:solidFill>
+          </a:ln>
+        </p:spPr>
+        <p:style>
+          <a:lnRef idx="1">
+            <a:schemeClr val="accent1"/>
+          </a:lnRef>
+          <a:fillRef idx="3">
+            <a:schemeClr val="accent1"/>
+          </a:fillRef>
+          <a:effectRef idx="2">
+            <a:schemeClr val="accent1"/>
+          </a:effectRef>
+          <a:fontRef idx="minor">
+            <a:schemeClr val="lt1"/>
+          </a:fontRef>
+        </p:style>
+        <p:txBody>
+          <a:bodyPr rtlCol="0" anchor="ctr" wrap="square" lIns="63500" rIns="50800" tIns="38100" bIns="38100"/>
+          <a:lstStyle/>
+          <a:p>
+            <a:pPr algn="l"/>
+            <a:r>
+              <a:rPr sz="1000" b="1">
+                <a:solidFill>
+                  <a:srgbClr val="222222"/>
+                </a:solidFill>
+                <a:latin typeface="Meiryo"/>
+              </a:rPr>
+              <a:t>利便性</a:t>
+            </a:r>
+          </a:p>
+        </p:txBody>
+      </p:sp>
+      <p:sp>
+        <p:nvSpPr>
+          <p:cNvPr id="19" name="Rectangle 18"/>
+          <p:cNvSpPr/>
+          <p:nvPr/>
+        </p:nvSpPr>
+        <p:spPr>
+          <a:xfrm>
+            <a:off x="3017520" y="3794760"/>
+            <a:ext cx="5486400" cy="457200"/>
+          </a:xfrm>
+          <a:prstGeom prst="rect">
+            <a:avLst/>
+          </a:prstGeom>
+          <a:solidFill>
+            <a:srgbClr val="F9F9F9"/>
+          </a:solidFill>
+          <a:ln w="25400">
+            <a:solidFill>
+              <a:srgbClr val="CCCCCC"/>
+            </a:solidFill>
+          </a:ln>
+        </p:spPr>
+        <p:style>
+          <a:lnRef idx="1">
+            <a:schemeClr val="accent1"/>
+          </a:lnRef>
+          <a:fillRef idx="3">
+            <a:schemeClr val="accent1"/>
+          </a:fillRef>
+          <a:effectRef idx="2">
+            <a:schemeClr val="accent1"/>
+          </a:effectRef>
+          <a:fontRef idx="minor">
+            <a:schemeClr val="lt1"/>
+          </a:fontRef>
+        </p:style>
+        <p:txBody>
+          <a:bodyPr rtlCol="0" anchor="ctr" wrap="square" lIns="63500" rIns="50800" tIns="38100" bIns="38100"/>
+          <a:lstStyle/>
+          <a:p>
+            <a:pPr algn="l"/>
+            <a:r>
+              <a:rPr sz="1000" b="0">
+                <a:solidFill>
+                  <a:srgbClr val="222222"/>
+                </a:solidFill>
+                <a:latin typeface="Meiryo"/>
+              </a:rPr>
+              <a:t>面倒（ブックマーク探す、URL入力）</a:t>
+            </a:r>
+          </a:p>
+        </p:txBody>
+      </p:sp>
+      <p:sp>
+        <p:nvSpPr>
+          <p:cNvPr id="20" name="Rectangle 19"/>
+          <p:cNvSpPr/>
+          <p:nvPr/>
+        </p:nvSpPr>
+        <p:spPr>
+          <a:xfrm>
+            <a:off x="8503920" y="3794760"/>
+            <a:ext cx="5852160" cy="457200"/>
+          </a:xfrm>
+          <a:prstGeom prst="rect">
+            <a:avLst/>
+          </a:prstGeom>
+          <a:solidFill>
+            <a:srgbClr val="F9F9F9"/>
+          </a:solidFill>
+          <a:ln w="25400">
+            <a:solidFill>
+              <a:srgbClr val="C0392B"/>
+            </a:solidFill>
+          </a:ln>
+        </p:spPr>
+        <p:style>
+          <a:lnRef idx="1">
+            <a:schemeClr val="accent1"/>
+          </a:lnRef>
+          <a:fillRef idx="3">
+            <a:schemeClr val="accent1"/>
+          </a:fillRef>
+          <a:effectRef idx="2">
+            <a:schemeClr val="accent1"/>
+          </a:effectRef>
+          <a:fontRef idx="minor">
+            <a:schemeClr val="lt1"/>
+          </a:fontRef>
+        </p:style>
+        <p:txBody>
+          <a:bodyPr rtlCol="0" anchor="ctr" wrap="square" lIns="63500" rIns="50800" tIns="38100" bIns="38100"/>
+          <a:lstStyle/>
+          <a:p>
+            <a:pPr algn="l"/>
+            <a:r>
+              <a:rPr sz="1000" b="1">
+                <a:solidFill>
+                  <a:srgbClr val="C0392B"/>
+                </a:solidFill>
+                <a:latin typeface="Meiryo"/>
+              </a:rPr>
+              <a:t>楽（ボタン1つ押すだけ）</a:t>
+            </a:r>
+          </a:p>
+        </p:txBody>
+      </p:sp>
+      <p:sp>
+        <p:nvSpPr>
+          <p:cNvPr id="21" name="Rectangle 20"/>
+          <p:cNvSpPr/>
+          <p:nvPr/>
+        </p:nvSpPr>
+        <p:spPr>
+          <a:xfrm>
+            <a:off x="731520" y="4343400"/>
+            <a:ext cx="13624560" cy="822960"/>
+          </a:xfrm>
+          <a:prstGeom prst="rect">
+            <a:avLst/>
+          </a:prstGeom>
+          <a:solidFill>
+            <a:srgbClr val="8E44AD"/>
+          </a:solidFill>
+          <a:ln>
+            <a:noFill/>
+          </a:ln>
+        </p:spPr>
+        <p:style>
+          <a:lnRef idx="1">
+            <a:schemeClr val="accent1"/>
+          </a:lnRef>
+          <a:fillRef idx="3">
+            <a:schemeClr val="accent1"/>
+          </a:fillRef>
+          <a:effectRef idx="2">
+            <a:schemeClr val="accent1"/>
+          </a:effectRef>
+          <a:fontRef idx="minor">
+            <a:schemeClr val="lt1"/>
+          </a:fontRef>
+        </p:style>
+        <p:txBody>
+          <a:bodyPr rtlCol="0" anchor="ctr" wrap="square" lIns="50800" rIns="50800" tIns="25400" bIns="25400"/>
+          <a:lstStyle/>
+          <a:p>
+            <a:pPr algn="ctr"/>
+            <a:r>
+              <a:rPr sz="100" b="1">
+                <a:solidFill>
+                  <a:srgbClr val="FFFFFF"/>
+                </a:solidFill>
+                <a:latin typeface="Meiryo"/>
+              </a:rPr>
+              <a:t/>
+            </a:r>
+          </a:p>
+        </p:txBody>
+      </p:sp>
+      <p:sp>
+        <p:nvSpPr>
+          <p:cNvPr id="22" name="TextBox 21"/>
+          <p:cNvSpPr txBox="1"/>
+          <p:nvPr/>
+        </p:nvSpPr>
+        <p:spPr>
+          <a:xfrm>
+            <a:off x="1005840" y="4389120"/>
+            <a:ext cx="13075920" cy="777240"/>
+          </a:xfrm>
+          <a:prstGeom prst="rect">
+            <a:avLst/>
+          </a:prstGeom>
+          <a:noFill/>
+        </p:spPr>
+        <p:txBody>
+          <a:bodyPr wrap="square" lIns="50800" rIns="50800" tIns="38100" bIns="38100"/>
+          <a:lstStyle/>
+          <a:p>
+            <a:pPr algn="l"/>
+            <a:r>
+              <a:rPr sz="1100" b="1">
+                <a:solidFill>
+                  <a:srgbClr val="FFFFFF"/>
+                </a:solidFill>
+                <a:latin typeface="Meiryo"/>
+              </a:rPr>
+              <a:t>皮肉：犯人のほうが「ユーザー体験が良い」
+正規の銀行：「ブックマークからアクセスしてください」（面倒）
+犯人：「ボタンをクリックするだけです」（簡単）
+→ 焦っている被害者がどちらに従いたくなるかは明白</a:t>
+            </a:r>
+          </a:p>
+        </p:txBody>
+      </p:sp>
+      <p:sp>
+        <p:nvSpPr>
+          <p:cNvPr id="23" name="Rectangle 22"/>
+          <p:cNvSpPr/>
+          <p:nvPr/>
+        </p:nvSpPr>
+        <p:spPr>
+          <a:xfrm>
+            <a:off x="731520" y="5349240"/>
+            <a:ext cx="13624560" cy="365760"/>
+          </a:xfrm>
+          <a:prstGeom prst="rect">
+            <a:avLst/>
+          </a:prstGeom>
+          <a:solidFill>
+            <a:srgbClr val="222222"/>
+          </a:solidFill>
+          <a:ln>
+            <a:noFill/>
+          </a:ln>
+        </p:spPr>
+        <p:style>
+          <a:lnRef idx="1">
+            <a:schemeClr val="accent1"/>
+          </a:lnRef>
+          <a:fillRef idx="3">
+            <a:schemeClr val="accent1"/>
+          </a:fillRef>
+          <a:effectRef idx="2">
+            <a:schemeClr val="accent1"/>
+          </a:effectRef>
+          <a:fontRef idx="minor">
+            <a:schemeClr val="lt1"/>
+          </a:fontRef>
+        </p:style>
+        <p:txBody>
+          <a:bodyPr rtlCol="0" anchor="ctr" wrap="square" lIns="50800" rIns="50800" tIns="25400" bIns="25400"/>
+          <a:lstStyle/>
+          <a:p>
+            <a:pPr algn="ctr"/>
+            <a:r>
+              <a:rPr sz="1200" b="1">
+                <a:solidFill>
+                  <a:srgbClr val="FFFFFF"/>
+                </a:solidFill>
+                <a:latin typeface="Meiryo"/>
+              </a:rPr>
+              <a:t>手順⑤の破綻ポイントまとめ</a:t>
+            </a:r>
+          </a:p>
+        </p:txBody>
+      </p:sp>
+      <p:sp>
+        <p:nvSpPr>
+          <p:cNvPr id="24" name="Rectangle 23"/>
+          <p:cNvSpPr/>
+          <p:nvPr/>
+        </p:nvSpPr>
+        <p:spPr>
+          <a:xfrm>
+            <a:off x="731520" y="5715000"/>
+            <a:ext cx="3657600" cy="365760"/>
+          </a:xfrm>
+          <a:prstGeom prst="rect">
+            <a:avLst/>
+          </a:prstGeom>
+          <a:solidFill>
+            <a:srgbClr val="FFFFFF"/>
+          </a:solidFill>
+          <a:ln w="25400">
+            <a:solidFill>
+              <a:srgbClr val="CCCCCC"/>
+            </a:solidFill>
+          </a:ln>
+        </p:spPr>
+        <p:style>
+          <a:lnRef idx="1">
+            <a:schemeClr val="accent1"/>
+          </a:lnRef>
+          <a:fillRef idx="3">
+            <a:schemeClr val="accent1"/>
+          </a:fillRef>
+          <a:effectRef idx="2">
+            <a:schemeClr val="accent1"/>
+          </a:effectRef>
+          <a:fontRef idx="minor">
+            <a:schemeClr val="lt1"/>
+          </a:fontRef>
+        </p:style>
+        <p:txBody>
+          <a:bodyPr rtlCol="0" anchor="ctr" wrap="square" lIns="63500" rIns="50800" tIns="38100" bIns="38100"/>
+          <a:lstStyle/>
+          <a:p>
+            <a:pPr algn="l"/>
+            <a:r>
+              <a:rPr sz="1000" b="1">
+                <a:solidFill>
+                  <a:srgbClr val="222222"/>
+                </a:solidFill>
+                <a:latin typeface="Meiryo"/>
+              </a:rPr>
+              <a:t>銀行の方針</a:t>
+            </a:r>
+          </a:p>
+        </p:txBody>
+      </p:sp>
+      <p:sp>
+        <p:nvSpPr>
+          <p:cNvPr id="25" name="Rectangle 24"/>
+          <p:cNvSpPr/>
+          <p:nvPr/>
+        </p:nvSpPr>
+        <p:spPr>
+          <a:xfrm>
+            <a:off x="4389120" y="5715000"/>
+            <a:ext cx="9966960" cy="365760"/>
+          </a:xfrm>
+          <a:prstGeom prst="rect">
+            <a:avLst/>
+          </a:prstGeom>
+          <a:solidFill>
+            <a:srgbClr val="FFFFFF"/>
+          </a:solidFill>
+          <a:ln w="25400">
+            <a:solidFill>
+              <a:srgbClr val="CCCCCC"/>
+            </a:solidFill>
+          </a:ln>
+        </p:spPr>
+        <p:style>
+          <a:lnRef idx="1">
+            <a:schemeClr val="accent1"/>
+          </a:lnRef>
+          <a:fillRef idx="3">
+            <a:schemeClr val="accent1"/>
+          </a:fillRef>
+          <a:effectRef idx="2">
+            <a:schemeClr val="accent1"/>
+          </a:effectRef>
+          <a:fontRef idx="minor">
+            <a:schemeClr val="lt1"/>
+          </a:fontRef>
+        </p:style>
+        <p:txBody>
+          <a:bodyPr rtlCol="0" anchor="ctr" wrap="square" lIns="63500" rIns="50800" tIns="38100" bIns="38100"/>
+          <a:lstStyle/>
+          <a:p>
+            <a:pPr algn="l"/>
+            <a:r>
+              <a:rPr sz="1000" b="0">
+                <a:solidFill>
+                  <a:srgbClr val="222222"/>
+                </a:solidFill>
+                <a:latin typeface="Meiryo"/>
+              </a:rPr>
+              <a:t>メールにURLリンクを載せない</a:t>
+            </a:r>
+          </a:p>
+        </p:txBody>
+      </p:sp>
+      <p:sp>
+        <p:nvSpPr>
+          <p:cNvPr id="26" name="Rectangle 25"/>
+          <p:cNvSpPr/>
+          <p:nvPr/>
+        </p:nvSpPr>
+        <p:spPr>
+          <a:xfrm>
+            <a:off x="731520" y="6080760"/>
+            <a:ext cx="3657600" cy="365760"/>
+          </a:xfrm>
+          <a:prstGeom prst="rect">
+            <a:avLst/>
+          </a:prstGeom>
+          <a:solidFill>
+            <a:srgbClr val="F9F9F9"/>
+          </a:solidFill>
+          <a:ln w="25400">
+            <a:solidFill>
+              <a:srgbClr val="CCCCCC"/>
+            </a:solidFill>
+          </a:ln>
+        </p:spPr>
+        <p:style>
+          <a:lnRef idx="1">
+            <a:schemeClr val="accent1"/>
+          </a:lnRef>
+          <a:fillRef idx="3">
+            <a:schemeClr val="accent1"/>
+          </a:fillRef>
+          <a:effectRef idx="2">
+            <a:schemeClr val="accent1"/>
+          </a:effectRef>
+          <a:fontRef idx="minor">
+            <a:schemeClr val="lt1"/>
+          </a:fontRef>
+        </p:style>
+        <p:txBody>
+          <a:bodyPr rtlCol="0" anchor="ctr" wrap="square" lIns="63500" rIns="50800" tIns="38100" bIns="38100"/>
+          <a:lstStyle/>
+          <a:p>
+            <a:pPr algn="l"/>
+            <a:r>
+              <a:rPr sz="1000" b="1">
+                <a:solidFill>
+                  <a:srgbClr val="222222"/>
+                </a:solidFill>
+                <a:latin typeface="Meiryo"/>
+              </a:rPr>
+              <a:t>金融庁の要請</a:t>
+            </a:r>
+          </a:p>
+        </p:txBody>
+      </p:sp>
+      <p:sp>
+        <p:nvSpPr>
+          <p:cNvPr id="27" name="Rectangle 26"/>
+          <p:cNvSpPr/>
+          <p:nvPr/>
+        </p:nvSpPr>
+        <p:spPr>
+          <a:xfrm>
+            <a:off x="4389120" y="6080760"/>
+            <a:ext cx="9966960" cy="365760"/>
+          </a:xfrm>
+          <a:prstGeom prst="rect">
+            <a:avLst/>
+          </a:prstGeom>
+          <a:solidFill>
+            <a:srgbClr val="F9F9F9"/>
+          </a:solidFill>
+          <a:ln w="25400">
+            <a:solidFill>
+              <a:srgbClr val="CCCCCC"/>
+            </a:solidFill>
+          </a:ln>
+        </p:spPr>
+        <p:style>
+          <a:lnRef idx="1">
+            <a:schemeClr val="accent1"/>
+          </a:lnRef>
+          <a:fillRef idx="3">
+            <a:schemeClr val="accent1"/>
+          </a:fillRef>
+          <a:effectRef idx="2">
+            <a:schemeClr val="accent1"/>
+          </a:effectRef>
+          <a:fontRef idx="minor">
+            <a:schemeClr val="lt1"/>
+          </a:fontRef>
+        </p:style>
+        <p:txBody>
+          <a:bodyPr rtlCol="0" anchor="ctr" wrap="square" lIns="63500" rIns="50800" tIns="38100" bIns="38100"/>
+          <a:lstStyle/>
+          <a:p>
+            <a:pPr algn="l"/>
+            <a:r>
+              <a:rPr sz="1000" b="0">
+                <a:solidFill>
+                  <a:srgbClr val="222222"/>
+                </a:solidFill>
+                <a:latin typeface="Meiryo"/>
+              </a:rPr>
+              <a:t>金融機関のメールにURL記載禁止</a:t>
+            </a:r>
+          </a:p>
+        </p:txBody>
+      </p:sp>
+      <p:sp>
+        <p:nvSpPr>
+          <p:cNvPr id="28" name="Rectangle 27"/>
+          <p:cNvSpPr/>
+          <p:nvPr/>
+        </p:nvSpPr>
+        <p:spPr>
+          <a:xfrm>
+            <a:off x="731520" y="6446520"/>
+            <a:ext cx="3657600" cy="365760"/>
+          </a:xfrm>
+          <a:prstGeom prst="rect">
+            <a:avLst/>
+          </a:prstGeom>
+          <a:solidFill>
+            <a:srgbClr val="FFFFFF"/>
+          </a:solidFill>
+          <a:ln w="25400">
+            <a:solidFill>
+              <a:srgbClr val="CCCCCC"/>
+            </a:solidFill>
+          </a:ln>
+        </p:spPr>
+        <p:style>
+          <a:lnRef idx="1">
+            <a:schemeClr val="accent1"/>
+          </a:lnRef>
+          <a:fillRef idx="3">
+            <a:schemeClr val="accent1"/>
+          </a:fillRef>
+          <a:effectRef idx="2">
+            <a:schemeClr val="accent1"/>
+          </a:effectRef>
+          <a:fontRef idx="minor">
+            <a:schemeClr val="lt1"/>
+          </a:fontRef>
+        </p:style>
+        <p:txBody>
+          <a:bodyPr rtlCol="0" anchor="ctr" wrap="square" lIns="63500" rIns="50800" tIns="38100" bIns="38100"/>
+          <a:lstStyle/>
+          <a:p>
+            <a:pPr algn="l"/>
+            <a:r>
+              <a:rPr sz="1000" b="1">
+                <a:solidFill>
+                  <a:srgbClr val="222222"/>
+                </a:solidFill>
+                <a:latin typeface="Meiryo"/>
+              </a:rPr>
+              <a:t>顧客への周知</a:t>
+            </a:r>
+          </a:p>
+        </p:txBody>
+      </p:sp>
+      <p:sp>
+        <p:nvSpPr>
+          <p:cNvPr id="29" name="Rectangle 28"/>
+          <p:cNvSpPr/>
+          <p:nvPr/>
+        </p:nvSpPr>
+        <p:spPr>
+          <a:xfrm>
+            <a:off x="4389120" y="6446520"/>
+            <a:ext cx="9966960" cy="365760"/>
+          </a:xfrm>
+          <a:prstGeom prst="rect">
+            <a:avLst/>
+          </a:prstGeom>
+          <a:solidFill>
+            <a:srgbClr val="FFFFFF"/>
+          </a:solidFill>
+          <a:ln w="25400">
+            <a:solidFill>
+              <a:srgbClr val="CCCCCC"/>
+            </a:solidFill>
+          </a:ln>
+        </p:spPr>
+        <p:style>
+          <a:lnRef idx="1">
+            <a:schemeClr val="accent1"/>
+          </a:lnRef>
+          <a:fillRef idx="3">
+            <a:schemeClr val="accent1"/>
+          </a:fillRef>
+          <a:effectRef idx="2">
+            <a:schemeClr val="accent1"/>
+          </a:effectRef>
+          <a:fontRef idx="minor">
+            <a:schemeClr val="lt1"/>
+          </a:fontRef>
+        </p:style>
+        <p:txBody>
+          <a:bodyPr rtlCol="0" anchor="ctr" wrap="square" lIns="63500" rIns="50800" tIns="38100" bIns="38100"/>
+          <a:lstStyle/>
+          <a:p>
+            <a:pPr algn="l"/>
+            <a:r>
+              <a:rPr sz="1000" b="0">
+                <a:solidFill>
+                  <a:srgbClr val="222222"/>
+                </a:solidFill>
+                <a:latin typeface="Meiryo"/>
+              </a:rPr>
+              <a:t>「メールのリンクをクリックしないで」と案内済み</a:t>
+            </a:r>
+          </a:p>
+        </p:txBody>
+      </p:sp>
+      <p:sp>
+        <p:nvSpPr>
+          <p:cNvPr id="30" name="Rectangle 29"/>
+          <p:cNvSpPr/>
+          <p:nvPr/>
+        </p:nvSpPr>
+        <p:spPr>
+          <a:xfrm>
+            <a:off x="731520" y="6812280"/>
+            <a:ext cx="3657600" cy="365760"/>
+          </a:xfrm>
+          <a:prstGeom prst="rect">
+            <a:avLst/>
+          </a:prstGeom>
+          <a:solidFill>
+            <a:srgbClr val="C0392B"/>
+          </a:solidFill>
+          <a:ln>
+            <a:noFill/>
+          </a:ln>
+        </p:spPr>
+        <p:style>
+          <a:lnRef idx="1">
+            <a:schemeClr val="accent1"/>
+          </a:lnRef>
+          <a:fillRef idx="3">
+            <a:schemeClr val="accent1"/>
+          </a:fillRef>
+          <a:effectRef idx="2">
+            <a:schemeClr val="accent1"/>
+          </a:effectRef>
+          <a:fontRef idx="minor">
+            <a:schemeClr val="lt1"/>
+          </a:fontRef>
+        </p:style>
+        <p:txBody>
+          <a:bodyPr rtlCol="0" anchor="ctr" wrap="square" lIns="50800" rIns="50800" tIns="25400" bIns="25400"/>
+          <a:lstStyle/>
+          <a:p>
+            <a:pPr algn="ctr"/>
+            <a:r>
+              <a:rPr sz="1000" b="1">
+                <a:solidFill>
+                  <a:srgbClr val="FFFFFF"/>
+                </a:solidFill>
+                <a:latin typeface="Meiryo"/>
+              </a:rPr>
+              <a:t>それでも突破される理由</a:t>
+            </a:r>
+          </a:p>
+        </p:txBody>
+      </p:sp>
+      <p:sp>
+        <p:nvSpPr>
+          <p:cNvPr id="31" name="Rectangle 30"/>
+          <p:cNvSpPr/>
+          <p:nvPr/>
+        </p:nvSpPr>
+        <p:spPr>
+          <a:xfrm>
+            <a:off x="4389120" y="6812280"/>
+            <a:ext cx="9966960" cy="365760"/>
+          </a:xfrm>
+          <a:prstGeom prst="rect">
+            <a:avLst/>
+          </a:prstGeom>
+          <a:solidFill>
+            <a:srgbClr val="C0392B"/>
+          </a:solidFill>
+          <a:ln>
+            <a:noFill/>
+          </a:ln>
+        </p:spPr>
+        <p:style>
+          <a:lnRef idx="1">
+            <a:schemeClr val="accent1"/>
+          </a:lnRef>
+          <a:fillRef idx="3">
+            <a:schemeClr val="accent1"/>
+          </a:fillRef>
+          <a:effectRef idx="2">
+            <a:schemeClr val="accent1"/>
+          </a:effectRef>
+          <a:fontRef idx="minor">
+            <a:schemeClr val="lt1"/>
+          </a:fontRef>
+        </p:style>
+        <p:txBody>
+          <a:bodyPr rtlCol="0" anchor="ctr" wrap="square" lIns="50800" rIns="50800" tIns="25400" bIns="25400"/>
+          <a:lstStyle/>
+          <a:p>
+            <a:pPr algn="ctr"/>
+            <a:r>
+              <a:rPr sz="1000" b="1">
+                <a:solidFill>
+                  <a:srgbClr val="FFFFFF"/>
+                </a:solidFill>
+                <a:latin typeface="Meiryo"/>
+              </a:rPr>
+              <a:t>手順②の恐怖 ＋ 電話でのリアルタイム指示 ＋ 犯人のほうがUXが良い</a:t>
+            </a:r>
+          </a:p>
+        </p:txBody>
+      </p:sp>
+      <p:sp>
+        <p:nvSpPr>
+          <p:cNvPr id="32" name="Rectangle 31"/>
+          <p:cNvSpPr/>
+          <p:nvPr/>
+        </p:nvSpPr>
+        <p:spPr>
+          <a:xfrm>
+            <a:off x="731520" y="7223759"/>
+            <a:ext cx="13624560" cy="502920"/>
+          </a:xfrm>
+          <a:prstGeom prst="rect">
+            <a:avLst/>
+          </a:prstGeom>
+          <a:solidFill>
+            <a:srgbClr val="222222"/>
+          </a:solidFill>
+          <a:ln>
+            <a:noFill/>
+          </a:ln>
+        </p:spPr>
+        <p:style>
+          <a:lnRef idx="1">
+            <a:schemeClr val="accent1"/>
+          </a:lnRef>
+          <a:fillRef idx="3">
+            <a:schemeClr val="accent1"/>
+          </a:fillRef>
+          <a:effectRef idx="2">
+            <a:schemeClr val="accent1"/>
+          </a:effectRef>
+          <a:fontRef idx="minor">
+            <a:schemeClr val="lt1"/>
+          </a:fontRef>
+        </p:style>
+        <p:txBody>
+          <a:bodyPr rtlCol="0" anchor="ctr" wrap="square" lIns="50800" rIns="50800" tIns="25400" bIns="25400"/>
+          <a:lstStyle/>
+          <a:p>
+            <a:pPr algn="ctr"/>
+            <a:r>
+              <a:rPr sz="1200" b="1">
+                <a:solidFill>
+                  <a:srgbClr val="FFFFFF"/>
+                </a:solidFill>
+                <a:latin typeface="Meiryo"/>
+              </a:rPr>
+              <a:t>注意喚起・ガイドライン・金融庁の要請 — すべてが「冷静な時の判断力」を前提にしている。この攻撃は、その前提自体を手順②で破壊している。</a:t>
+            </a:r>
+          </a:p>
+        </p:txBody>
+      </p:sp>
+      <p:sp>
+        <p:nvSpPr>
+          <p:cNvPr id="33" name="TextBox 32"/>
+          <p:cNvSpPr txBox="1"/>
+          <p:nvPr/>
+        </p:nvSpPr>
+        <p:spPr>
+          <a:xfrm>
+            <a:off x="9144000" y="10378440"/>
+            <a:ext cx="5943600" cy="228600"/>
+          </a:xfrm>
+          <a:prstGeom prst="rect">
+            <a:avLst/>
+          </a:prstGeom>
+          <a:noFill/>
+        </p:spPr>
+        <p:txBody>
+          <a:bodyPr wrap="square" lIns="50800" rIns="50800" tIns="38100" bIns="38100"/>
+          <a:lstStyle/>
+          <a:p>
+            <a:pPr algn="r"/>
+            <a:r>
+              <a:rPr sz="700" b="0">
+                <a:solidFill>
+                  <a:srgbClr val="888888"/>
+                </a:solidFill>
+                <a:latin typeface="Meiryo"/>
+              </a:rPr>
+              <a:t>Fraud Kill Chain — 手順⑤ メールURLと金融庁要請</a:t>
             </a:r>
           </a:p>
         </p:txBody>

</xml_diff>

<commit_message>
Add slide 9: bookmark-based URL guidance doesn't work in practice
Banks tell customers to bookmark URLs, but customers must register
bookmarks themselves and most don't. Banks should control the access
path directly via apps or dedicated clients instead.

https://claude.ai/code/session_01F7t8LKifK43o6sCdF2a3gQ
</commit_message>
<xml_diff>
--- a/Fraud_Kill_Chain.pptx
+++ b/Fraud_Kill_Chain.pptx
@@ -13,6 +13,7 @@
     <p:sldId id="261" r:id="rId12"/>
     <p:sldId id="262" r:id="rId13"/>
     <p:sldId id="263" r:id="rId14"/>
+    <p:sldId id="264" r:id="rId15"/>
   </p:sldIdLst>
   <p:sldSz cx="15124176" cy="10689336" type="screen4x3"/>
   <p:notesSz cx="6858000" cy="9144000"/>
@@ -19414,6 +19415,1605 @@
                 <a:latin typeface="Meiryo"/>
               </a:rPr>
               <a:t>Fraud Kill Chain — 手順⑤ メールURLと金融庁要請</a:t>
+            </a:r>
+          </a:p>
+        </p:txBody>
+      </p:sp>
+    </p:spTree>
+  </p:cSld>
+  <p:clrMapOvr>
+    <a:masterClrMapping/>
+  </p:clrMapOvr>
+</p:sld>
+</file>
+
+<file path=ppt/slides/slide9.xml><?xml version="1.0" encoding="utf-8"?>
+<p:sld xmlns:a="http://schemas.openxmlformats.org/drawingml/2006/main" xmlns:p="http://schemas.openxmlformats.org/presentationml/2006/main" xmlns:r="http://schemas.openxmlformats.org/officeDocument/2006/relationships">
+  <p:cSld>
+    <p:bg>
+      <p:bgPr>
+        <a:solidFill>
+          <a:srgbClr val="F5F5F5"/>
+        </a:solidFill>
+        <a:effectLst/>
+      </p:bgPr>
+    </p:bg>
+    <p:spTree>
+      <p:nvGrpSpPr>
+        <p:cNvPr id="1" name=""/>
+        <p:cNvGrpSpPr/>
+        <p:nvPr/>
+      </p:nvGrpSpPr>
+      <p:grpSpPr/>
+      <p:sp>
+        <p:nvSpPr>
+          <p:cNvPr id="2" name="TextBox 1"/>
+          <p:cNvSpPr txBox="1"/>
+          <p:nvPr/>
+        </p:nvSpPr>
+        <p:spPr>
+          <a:xfrm>
+            <a:off x="0" y="182880"/>
+            <a:ext cx="15124176" cy="548640"/>
+          </a:xfrm>
+          <a:prstGeom prst="rect">
+            <a:avLst/>
+          </a:prstGeom>
+          <a:noFill/>
+        </p:spPr>
+        <p:txBody>
+          <a:bodyPr wrap="square" lIns="50800" rIns="50800" tIns="38100" bIns="38100"/>
+          <a:lstStyle/>
+          <a:p>
+            <a:pPr algn="ctr"/>
+            <a:r>
+              <a:rPr sz="2400" b="1">
+                <a:solidFill>
+                  <a:srgbClr val="E67E22"/>
+                </a:solidFill>
+                <a:latin typeface="Meiryo"/>
+              </a:rPr>
+              <a:t>「ブックマークからアクセスして」は機能しない</a:t>
+            </a:r>
+          </a:p>
+        </p:txBody>
+      </p:sp>
+      <p:sp>
+        <p:nvSpPr>
+          <p:cNvPr id="3" name="TextBox 2"/>
+          <p:cNvSpPr txBox="1"/>
+          <p:nvPr/>
+        </p:nvSpPr>
+        <p:spPr>
+          <a:xfrm>
+            <a:off x="0" y="685800"/>
+            <a:ext cx="15124176" cy="365760"/>
+          </a:xfrm>
+          <a:prstGeom prst="rect">
+            <a:avLst/>
+          </a:prstGeom>
+          <a:noFill/>
+        </p:spPr>
+        <p:txBody>
+          <a:bodyPr wrap="square" lIns="50800" rIns="50800" tIns="38100" bIns="38100"/>
+          <a:lstStyle/>
+          <a:p>
+            <a:pPr algn="ctr"/>
+            <a:r>
+              <a:rPr sz="1200" b="0">
+                <a:solidFill>
+                  <a:srgbClr val="888888"/>
+                </a:solidFill>
+                <a:latin typeface="Meiryo"/>
+              </a:rPr>
+              <a:t>ブックマーク登録を顧客に任せている時点で、対策として成立していない。</a:t>
+            </a:r>
+          </a:p>
+        </p:txBody>
+      </p:sp>
+      <p:sp>
+        <p:nvSpPr>
+          <p:cNvPr id="4" name="Rectangle 3"/>
+          <p:cNvSpPr/>
+          <p:nvPr/>
+        </p:nvSpPr>
+        <p:spPr>
+          <a:xfrm>
+            <a:off x="731520" y="1188720"/>
+            <a:ext cx="6583680" cy="411480"/>
+          </a:xfrm>
+          <a:prstGeom prst="rect">
+            <a:avLst/>
+          </a:prstGeom>
+          <a:solidFill>
+            <a:srgbClr val="222222"/>
+          </a:solidFill>
+          <a:ln>
+            <a:noFill/>
+          </a:ln>
+        </p:spPr>
+        <p:style>
+          <a:lnRef idx="1">
+            <a:schemeClr val="accent1"/>
+          </a:lnRef>
+          <a:fillRef idx="3">
+            <a:schemeClr val="accent1"/>
+          </a:fillRef>
+          <a:effectRef idx="2">
+            <a:schemeClr val="accent1"/>
+          </a:effectRef>
+          <a:fontRef idx="minor">
+            <a:schemeClr val="lt1"/>
+          </a:fontRef>
+        </p:style>
+        <p:txBody>
+          <a:bodyPr rtlCol="0" anchor="ctr" wrap="square" lIns="50800" rIns="50800" tIns="25400" bIns="25400"/>
+          <a:lstStyle/>
+          <a:p>
+            <a:pPr algn="ctr"/>
+            <a:r>
+              <a:rPr sz="1200" b="1">
+                <a:solidFill>
+                  <a:srgbClr val="FFFFFF"/>
+                </a:solidFill>
+                <a:latin typeface="Meiryo"/>
+              </a:rPr>
+              <a:t>銀行のURL伝達方法（法人IB）</a:t>
+            </a:r>
+          </a:p>
+        </p:txBody>
+      </p:sp>
+      <p:sp>
+        <p:nvSpPr>
+          <p:cNvPr id="5" name="Rectangle 4"/>
+          <p:cNvSpPr/>
+          <p:nvPr/>
+        </p:nvSpPr>
+        <p:spPr>
+          <a:xfrm>
+            <a:off x="731520" y="1600200"/>
+            <a:ext cx="2286000" cy="411480"/>
+          </a:xfrm>
+          <a:prstGeom prst="rect">
+            <a:avLst/>
+          </a:prstGeom>
+          <a:solidFill>
+            <a:srgbClr val="FFFFFF"/>
+          </a:solidFill>
+          <a:ln w="25400">
+            <a:solidFill>
+              <a:srgbClr val="CCCCCC"/>
+            </a:solidFill>
+          </a:ln>
+        </p:spPr>
+        <p:style>
+          <a:lnRef idx="1">
+            <a:schemeClr val="accent1"/>
+          </a:lnRef>
+          <a:fillRef idx="3">
+            <a:schemeClr val="accent1"/>
+          </a:fillRef>
+          <a:effectRef idx="2">
+            <a:schemeClr val="accent1"/>
+          </a:effectRef>
+          <a:fontRef idx="minor">
+            <a:schemeClr val="lt1"/>
+          </a:fontRef>
+        </p:style>
+        <p:txBody>
+          <a:bodyPr rtlCol="0" anchor="ctr" wrap="square" lIns="63500" rIns="50800" tIns="38100" bIns="38100"/>
+          <a:lstStyle/>
+          <a:p>
+            <a:pPr algn="l"/>
+            <a:r>
+              <a:rPr sz="1000" b="1">
+                <a:solidFill>
+                  <a:srgbClr val="222222"/>
+                </a:solidFill>
+                <a:latin typeface="Meiryo"/>
+              </a:rPr>
+              <a:t>① 契約時の書面</a:t>
+            </a:r>
+          </a:p>
+        </p:txBody>
+      </p:sp>
+      <p:sp>
+        <p:nvSpPr>
+          <p:cNvPr id="6" name="Rectangle 5"/>
+          <p:cNvSpPr/>
+          <p:nvPr/>
+        </p:nvSpPr>
+        <p:spPr>
+          <a:xfrm>
+            <a:off x="3017520" y="1600200"/>
+            <a:ext cx="4297680" cy="411480"/>
+          </a:xfrm>
+          <a:prstGeom prst="rect">
+            <a:avLst/>
+          </a:prstGeom>
+          <a:solidFill>
+            <a:srgbClr val="FFFFFF"/>
+          </a:solidFill>
+          <a:ln w="25400">
+            <a:solidFill>
+              <a:srgbClr val="CCCCCC"/>
+            </a:solidFill>
+          </a:ln>
+        </p:spPr>
+        <p:style>
+          <a:lnRef idx="1">
+            <a:schemeClr val="accent1"/>
+          </a:lnRef>
+          <a:fillRef idx="3">
+            <a:schemeClr val="accent1"/>
+          </a:fillRef>
+          <a:effectRef idx="2">
+            <a:schemeClr val="accent1"/>
+          </a:effectRef>
+          <a:fontRef idx="minor">
+            <a:schemeClr val="lt1"/>
+          </a:fontRef>
+        </p:style>
+        <p:txBody>
+          <a:bodyPr rtlCol="0" anchor="ctr" wrap="square" lIns="63500" rIns="50800" tIns="38100" bIns="38100"/>
+          <a:lstStyle/>
+          <a:p>
+            <a:pPr algn="l"/>
+            <a:r>
+              <a:rPr sz="1000" b="0">
+                <a:solidFill>
+                  <a:srgbClr val="222222"/>
+                </a:solidFill>
+                <a:latin typeface="Meiryo"/>
+              </a:rPr>
+              <a:t>紙にURLが記載されている</a:t>
+            </a:r>
+          </a:p>
+        </p:txBody>
+      </p:sp>
+      <p:sp>
+        <p:nvSpPr>
+          <p:cNvPr id="7" name="Rectangle 6"/>
+          <p:cNvSpPr/>
+          <p:nvPr/>
+        </p:nvSpPr>
+        <p:spPr>
+          <a:xfrm>
+            <a:off x="731520" y="2011680"/>
+            <a:ext cx="2286000" cy="411480"/>
+          </a:xfrm>
+          <a:prstGeom prst="rect">
+            <a:avLst/>
+          </a:prstGeom>
+          <a:solidFill>
+            <a:srgbClr val="F9F9F9"/>
+          </a:solidFill>
+          <a:ln w="25400">
+            <a:solidFill>
+              <a:srgbClr val="CCCCCC"/>
+            </a:solidFill>
+          </a:ln>
+        </p:spPr>
+        <p:style>
+          <a:lnRef idx="1">
+            <a:schemeClr val="accent1"/>
+          </a:lnRef>
+          <a:fillRef idx="3">
+            <a:schemeClr val="accent1"/>
+          </a:fillRef>
+          <a:effectRef idx="2">
+            <a:schemeClr val="accent1"/>
+          </a:effectRef>
+          <a:fontRef idx="minor">
+            <a:schemeClr val="lt1"/>
+          </a:fontRef>
+        </p:style>
+        <p:txBody>
+          <a:bodyPr rtlCol="0" anchor="ctr" wrap="square" lIns="63500" rIns="50800" tIns="38100" bIns="38100"/>
+          <a:lstStyle/>
+          <a:p>
+            <a:pPr algn="l"/>
+            <a:r>
+              <a:rPr sz="1000" b="1">
+                <a:solidFill>
+                  <a:srgbClr val="222222"/>
+                </a:solidFill>
+                <a:latin typeface="Meiryo"/>
+              </a:rPr>
+              <a:t>② 銀行の窓口</a:t>
+            </a:r>
+          </a:p>
+        </p:txBody>
+      </p:sp>
+      <p:sp>
+        <p:nvSpPr>
+          <p:cNvPr id="8" name="Rectangle 7"/>
+          <p:cNvSpPr/>
+          <p:nvPr/>
+        </p:nvSpPr>
+        <p:spPr>
+          <a:xfrm>
+            <a:off x="3017520" y="2011680"/>
+            <a:ext cx="4297680" cy="411480"/>
+          </a:xfrm>
+          <a:prstGeom prst="rect">
+            <a:avLst/>
+          </a:prstGeom>
+          <a:solidFill>
+            <a:srgbClr val="F9F9F9"/>
+          </a:solidFill>
+          <a:ln w="25400">
+            <a:solidFill>
+              <a:srgbClr val="CCCCCC"/>
+            </a:solidFill>
+          </a:ln>
+        </p:spPr>
+        <p:style>
+          <a:lnRef idx="1">
+            <a:schemeClr val="accent1"/>
+          </a:lnRef>
+          <a:fillRef idx="3">
+            <a:schemeClr val="accent1"/>
+          </a:fillRef>
+          <a:effectRef idx="2">
+            <a:schemeClr val="accent1"/>
+          </a:effectRef>
+          <a:fontRef idx="minor">
+            <a:schemeClr val="lt1"/>
+          </a:fontRef>
+        </p:style>
+        <p:txBody>
+          <a:bodyPr rtlCol="0" anchor="ctr" wrap="square" lIns="63500" rIns="50800" tIns="38100" bIns="38100"/>
+          <a:lstStyle/>
+          <a:p>
+            <a:pPr algn="l"/>
+            <a:r>
+              <a:rPr sz="1000" b="0">
+                <a:solidFill>
+                  <a:srgbClr val="222222"/>
+                </a:solidFill>
+                <a:latin typeface="Meiryo"/>
+              </a:rPr>
+              <a:t>担当者から口頭で案内</a:t>
+            </a:r>
+          </a:p>
+        </p:txBody>
+      </p:sp>
+      <p:sp>
+        <p:nvSpPr>
+          <p:cNvPr id="9" name="Rectangle 8"/>
+          <p:cNvSpPr/>
+          <p:nvPr/>
+        </p:nvSpPr>
+        <p:spPr>
+          <a:xfrm>
+            <a:off x="731520" y="2423160"/>
+            <a:ext cx="2286000" cy="411480"/>
+          </a:xfrm>
+          <a:prstGeom prst="rect">
+            <a:avLst/>
+          </a:prstGeom>
+          <a:solidFill>
+            <a:srgbClr val="FFFFFF"/>
+          </a:solidFill>
+          <a:ln w="25400">
+            <a:solidFill>
+              <a:srgbClr val="CCCCCC"/>
+            </a:solidFill>
+          </a:ln>
+        </p:spPr>
+        <p:style>
+          <a:lnRef idx="1">
+            <a:schemeClr val="accent1"/>
+          </a:lnRef>
+          <a:fillRef idx="3">
+            <a:schemeClr val="accent1"/>
+          </a:fillRef>
+          <a:effectRef idx="2">
+            <a:schemeClr val="accent1"/>
+          </a:effectRef>
+          <a:fontRef idx="minor">
+            <a:schemeClr val="lt1"/>
+          </a:fontRef>
+        </p:style>
+        <p:txBody>
+          <a:bodyPr rtlCol="0" anchor="ctr" wrap="square" lIns="63500" rIns="50800" tIns="38100" bIns="38100"/>
+          <a:lstStyle/>
+          <a:p>
+            <a:pPr algn="l"/>
+            <a:r>
+              <a:rPr sz="1000" b="1">
+                <a:solidFill>
+                  <a:srgbClr val="222222"/>
+                </a:solidFill>
+                <a:latin typeface="Meiryo"/>
+              </a:rPr>
+              <a:t>③ 銀行の公式HP</a:t>
+            </a:r>
+          </a:p>
+        </p:txBody>
+      </p:sp>
+      <p:sp>
+        <p:nvSpPr>
+          <p:cNvPr id="10" name="Rectangle 9"/>
+          <p:cNvSpPr/>
+          <p:nvPr/>
+        </p:nvSpPr>
+        <p:spPr>
+          <a:xfrm>
+            <a:off x="3017520" y="2423160"/>
+            <a:ext cx="4297680" cy="411480"/>
+          </a:xfrm>
+          <a:prstGeom prst="rect">
+            <a:avLst/>
+          </a:prstGeom>
+          <a:solidFill>
+            <a:srgbClr val="FFFFFF"/>
+          </a:solidFill>
+          <a:ln w="25400">
+            <a:solidFill>
+              <a:srgbClr val="CCCCCC"/>
+            </a:solidFill>
+          </a:ln>
+        </p:spPr>
+        <p:style>
+          <a:lnRef idx="1">
+            <a:schemeClr val="accent1"/>
+          </a:lnRef>
+          <a:fillRef idx="3">
+            <a:schemeClr val="accent1"/>
+          </a:fillRef>
+          <a:effectRef idx="2">
+            <a:schemeClr val="accent1"/>
+          </a:effectRef>
+          <a:fontRef idx="minor">
+            <a:schemeClr val="lt1"/>
+          </a:fontRef>
+        </p:style>
+        <p:txBody>
+          <a:bodyPr rtlCol="0" anchor="ctr" wrap="square" lIns="63500" rIns="50800" tIns="38100" bIns="38100"/>
+          <a:lstStyle/>
+          <a:p>
+            <a:pPr algn="l"/>
+            <a:r>
+              <a:rPr sz="1000" b="0">
+                <a:solidFill>
+                  <a:srgbClr val="222222"/>
+                </a:solidFill>
+                <a:latin typeface="Meiryo"/>
+              </a:rPr>
+              <a:t>検索 → HP → IBログインページ</a:t>
+            </a:r>
+          </a:p>
+        </p:txBody>
+      </p:sp>
+      <p:sp>
+        <p:nvSpPr>
+          <p:cNvPr id="11" name="TextBox 10"/>
+          <p:cNvSpPr txBox="1"/>
+          <p:nvPr/>
+        </p:nvSpPr>
+        <p:spPr>
+          <a:xfrm>
+            <a:off x="731520" y="2880360"/>
+            <a:ext cx="6583680" cy="274320"/>
+          </a:xfrm>
+          <a:prstGeom prst="rect">
+            <a:avLst/>
+          </a:prstGeom>
+          <a:noFill/>
+        </p:spPr>
+        <p:txBody>
+          <a:bodyPr wrap="square" lIns="50800" rIns="50800" tIns="38100" bIns="38100"/>
+          <a:lstStyle/>
+          <a:p>
+            <a:pPr algn="l"/>
+            <a:r>
+              <a:rPr sz="1000" b="1">
+                <a:solidFill>
+                  <a:srgbClr val="C0392B"/>
+                </a:solidFill>
+                <a:latin typeface="Meiryo"/>
+              </a:rPr>
+              <a:t>→ 顧客が自分でブックマーク登録する必要がある</a:t>
+            </a:r>
+          </a:p>
+        </p:txBody>
+      </p:sp>
+      <p:sp>
+        <p:nvSpPr>
+          <p:cNvPr id="12" name="Rectangle 11"/>
+          <p:cNvSpPr/>
+          <p:nvPr/>
+        </p:nvSpPr>
+        <p:spPr>
+          <a:xfrm>
+            <a:off x="7772400" y="1188720"/>
+            <a:ext cx="6400800" cy="411480"/>
+          </a:xfrm>
+          <a:prstGeom prst="rect">
+            <a:avLst/>
+          </a:prstGeom>
+          <a:solidFill>
+            <a:srgbClr val="222222"/>
+          </a:solidFill>
+          <a:ln>
+            <a:noFill/>
+          </a:ln>
+        </p:spPr>
+        <p:style>
+          <a:lnRef idx="1">
+            <a:schemeClr val="accent1"/>
+          </a:lnRef>
+          <a:fillRef idx="3">
+            <a:schemeClr val="accent1"/>
+          </a:fillRef>
+          <a:effectRef idx="2">
+            <a:schemeClr val="accent1"/>
+          </a:effectRef>
+          <a:fontRef idx="minor">
+            <a:schemeClr val="lt1"/>
+          </a:fontRef>
+        </p:style>
+        <p:txBody>
+          <a:bodyPr rtlCol="0" anchor="ctr" wrap="square" lIns="50800" rIns="50800" tIns="25400" bIns="25400"/>
+          <a:lstStyle/>
+          <a:p>
+            <a:pPr algn="ctr"/>
+            <a:r>
+              <a:rPr sz="1200" b="1">
+                <a:solidFill>
+                  <a:srgbClr val="FFFFFF"/>
+                </a:solidFill>
+                <a:latin typeface="Meiryo"/>
+              </a:rPr>
+              <a:t>銀行の想定 vs 現実</a:t>
+            </a:r>
+          </a:p>
+        </p:txBody>
+      </p:sp>
+      <p:sp>
+        <p:nvSpPr>
+          <p:cNvPr id="13" name="Rectangle 12"/>
+          <p:cNvSpPr/>
+          <p:nvPr/>
+        </p:nvSpPr>
+        <p:spPr>
+          <a:xfrm>
+            <a:off x="7772400" y="1600200"/>
+            <a:ext cx="2926080" cy="411480"/>
+          </a:xfrm>
+          <a:prstGeom prst="rect">
+            <a:avLst/>
+          </a:prstGeom>
+          <a:solidFill>
+            <a:srgbClr val="FFFFFF"/>
+          </a:solidFill>
+          <a:ln w="25400">
+            <a:solidFill>
+              <a:srgbClr val="CCCCCC"/>
+            </a:solidFill>
+          </a:ln>
+        </p:spPr>
+        <p:style>
+          <a:lnRef idx="1">
+            <a:schemeClr val="accent1"/>
+          </a:lnRef>
+          <a:fillRef idx="3">
+            <a:schemeClr val="accent1"/>
+          </a:fillRef>
+          <a:effectRef idx="2">
+            <a:schemeClr val="accent1"/>
+          </a:effectRef>
+          <a:fontRef idx="minor">
+            <a:schemeClr val="lt1"/>
+          </a:fontRef>
+        </p:style>
+        <p:txBody>
+          <a:bodyPr rtlCol="0" anchor="ctr" wrap="square" lIns="63500" rIns="50800" tIns="38100" bIns="38100"/>
+          <a:lstStyle/>
+          <a:p>
+            <a:pPr algn="l"/>
+            <a:r>
+              <a:rPr sz="900" b="0">
+                <a:solidFill>
+                  <a:srgbClr val="222222"/>
+                </a:solidFill>
+                <a:latin typeface="Meiryo"/>
+              </a:rPr>
+              <a:t>契約時の書面を保管</a:t>
+            </a:r>
+          </a:p>
+        </p:txBody>
+      </p:sp>
+      <p:sp>
+        <p:nvSpPr>
+          <p:cNvPr id="14" name="Rectangle 13"/>
+          <p:cNvSpPr/>
+          <p:nvPr/>
+        </p:nvSpPr>
+        <p:spPr>
+          <a:xfrm>
+            <a:off x="10698480" y="1600200"/>
+            <a:ext cx="3474720" cy="411480"/>
+          </a:xfrm>
+          <a:prstGeom prst="rect">
+            <a:avLst/>
+          </a:prstGeom>
+          <a:solidFill>
+            <a:srgbClr val="FDEDEC"/>
+          </a:solidFill>
+          <a:ln>
+            <a:noFill/>
+          </a:ln>
+        </p:spPr>
+        <p:style>
+          <a:lnRef idx="1">
+            <a:schemeClr val="accent1"/>
+          </a:lnRef>
+          <a:fillRef idx="3">
+            <a:schemeClr val="accent1"/>
+          </a:fillRef>
+          <a:effectRef idx="2">
+            <a:schemeClr val="accent1"/>
+          </a:effectRef>
+          <a:fontRef idx="minor">
+            <a:schemeClr val="lt1"/>
+          </a:fontRef>
+        </p:style>
+        <p:txBody>
+          <a:bodyPr rtlCol="0" anchor="ctr" wrap="square" lIns="50800" rIns="50800" tIns="25400" bIns="25400"/>
+          <a:lstStyle/>
+          <a:p>
+            <a:pPr algn="l"/>
+            <a:r>
+              <a:rPr sz="900" b="1">
+                <a:solidFill>
+                  <a:srgbClr val="C0392B"/>
+                </a:solidFill>
+                <a:latin typeface="Meiryo"/>
+              </a:rPr>
+              <a:t>どこにしまったかわからない</a:t>
+            </a:r>
+          </a:p>
+        </p:txBody>
+      </p:sp>
+      <p:sp>
+        <p:nvSpPr>
+          <p:cNvPr id="15" name="Rectangle 14"/>
+          <p:cNvSpPr/>
+          <p:nvPr/>
+        </p:nvSpPr>
+        <p:spPr>
+          <a:xfrm>
+            <a:off x="7772400" y="2011680"/>
+            <a:ext cx="2926080" cy="411480"/>
+          </a:xfrm>
+          <a:prstGeom prst="rect">
+            <a:avLst/>
+          </a:prstGeom>
+          <a:solidFill>
+            <a:srgbClr val="FFFFFF"/>
+          </a:solidFill>
+          <a:ln w="25400">
+            <a:solidFill>
+              <a:srgbClr val="CCCCCC"/>
+            </a:solidFill>
+          </a:ln>
+        </p:spPr>
+        <p:style>
+          <a:lnRef idx="1">
+            <a:schemeClr val="accent1"/>
+          </a:lnRef>
+          <a:fillRef idx="3">
+            <a:schemeClr val="accent1"/>
+          </a:fillRef>
+          <a:effectRef idx="2">
+            <a:schemeClr val="accent1"/>
+          </a:effectRef>
+          <a:fontRef idx="minor">
+            <a:schemeClr val="lt1"/>
+          </a:fontRef>
+        </p:style>
+        <p:txBody>
+          <a:bodyPr rtlCol="0" anchor="ctr" wrap="square" lIns="63500" rIns="50800" tIns="38100" bIns="38100"/>
+          <a:lstStyle/>
+          <a:p>
+            <a:pPr algn="l"/>
+            <a:r>
+              <a:rPr sz="900" b="0">
+                <a:solidFill>
+                  <a:srgbClr val="222222"/>
+                </a:solidFill>
+                <a:latin typeface="Meiryo"/>
+              </a:rPr>
+              <a:t>ブックマークに登録済み</a:t>
+            </a:r>
+          </a:p>
+        </p:txBody>
+      </p:sp>
+      <p:sp>
+        <p:nvSpPr>
+          <p:cNvPr id="16" name="Rectangle 15"/>
+          <p:cNvSpPr/>
+          <p:nvPr/>
+        </p:nvSpPr>
+        <p:spPr>
+          <a:xfrm>
+            <a:off x="10698480" y="2011680"/>
+            <a:ext cx="3474720" cy="411480"/>
+          </a:xfrm>
+          <a:prstGeom prst="rect">
+            <a:avLst/>
+          </a:prstGeom>
+          <a:solidFill>
+            <a:srgbClr val="FDEDEC"/>
+          </a:solidFill>
+          <a:ln>
+            <a:noFill/>
+          </a:ln>
+        </p:spPr>
+        <p:style>
+          <a:lnRef idx="1">
+            <a:schemeClr val="accent1"/>
+          </a:lnRef>
+          <a:fillRef idx="3">
+            <a:schemeClr val="accent1"/>
+          </a:fillRef>
+          <a:effectRef idx="2">
+            <a:schemeClr val="accent1"/>
+          </a:effectRef>
+          <a:fontRef idx="minor">
+            <a:schemeClr val="lt1"/>
+          </a:fontRef>
+        </p:style>
+        <p:txBody>
+          <a:bodyPr rtlCol="0" anchor="ctr" wrap="square" lIns="50800" rIns="50800" tIns="25400" bIns="25400"/>
+          <a:lstStyle/>
+          <a:p>
+            <a:pPr algn="l"/>
+            <a:r>
+              <a:rPr sz="900" b="1">
+                <a:solidFill>
+                  <a:srgbClr val="C0392B"/>
+                </a:solidFill>
+                <a:latin typeface="Meiryo"/>
+              </a:rPr>
+              <a:t>登録していない人が多い</a:t>
+            </a:r>
+          </a:p>
+        </p:txBody>
+      </p:sp>
+      <p:sp>
+        <p:nvSpPr>
+          <p:cNvPr id="17" name="Rectangle 16"/>
+          <p:cNvSpPr/>
+          <p:nvPr/>
+        </p:nvSpPr>
+        <p:spPr>
+          <a:xfrm>
+            <a:off x="7772400" y="2423160"/>
+            <a:ext cx="2926080" cy="411480"/>
+          </a:xfrm>
+          <a:prstGeom prst="rect">
+            <a:avLst/>
+          </a:prstGeom>
+          <a:solidFill>
+            <a:srgbClr val="FFFFFF"/>
+          </a:solidFill>
+          <a:ln w="25400">
+            <a:solidFill>
+              <a:srgbClr val="CCCCCC"/>
+            </a:solidFill>
+          </a:ln>
+        </p:spPr>
+        <p:style>
+          <a:lnRef idx="1">
+            <a:schemeClr val="accent1"/>
+          </a:lnRef>
+          <a:fillRef idx="3">
+            <a:schemeClr val="accent1"/>
+          </a:fillRef>
+          <a:effectRef idx="2">
+            <a:schemeClr val="accent1"/>
+          </a:effectRef>
+          <a:fontRef idx="minor">
+            <a:schemeClr val="lt1"/>
+          </a:fontRef>
+        </p:style>
+        <p:txBody>
+          <a:bodyPr rtlCol="0" anchor="ctr" wrap="square" lIns="63500" rIns="50800" tIns="38100" bIns="38100"/>
+          <a:lstStyle/>
+          <a:p>
+            <a:pPr algn="l"/>
+            <a:r>
+              <a:rPr sz="900" b="0">
+                <a:solidFill>
+                  <a:srgbClr val="222222"/>
+                </a:solidFill>
+                <a:latin typeface="Meiryo"/>
+              </a:rPr>
+              <a:t>毎回ブックマークからアクセス</a:t>
+            </a:r>
+          </a:p>
+        </p:txBody>
+      </p:sp>
+      <p:sp>
+        <p:nvSpPr>
+          <p:cNvPr id="18" name="Rectangle 17"/>
+          <p:cNvSpPr/>
+          <p:nvPr/>
+        </p:nvSpPr>
+        <p:spPr>
+          <a:xfrm>
+            <a:off x="10698480" y="2423160"/>
+            <a:ext cx="3474720" cy="411480"/>
+          </a:xfrm>
+          <a:prstGeom prst="rect">
+            <a:avLst/>
+          </a:prstGeom>
+          <a:solidFill>
+            <a:srgbClr val="FDEDEC"/>
+          </a:solidFill>
+          <a:ln>
+            <a:noFill/>
+          </a:ln>
+        </p:spPr>
+        <p:style>
+          <a:lnRef idx="1">
+            <a:schemeClr val="accent1"/>
+          </a:lnRef>
+          <a:fillRef idx="3">
+            <a:schemeClr val="accent1"/>
+          </a:fillRef>
+          <a:effectRef idx="2">
+            <a:schemeClr val="accent1"/>
+          </a:effectRef>
+          <a:fontRef idx="minor">
+            <a:schemeClr val="lt1"/>
+          </a:fontRef>
+        </p:style>
+        <p:txBody>
+          <a:bodyPr rtlCol="0" anchor="ctr" wrap="square" lIns="50800" rIns="50800" tIns="25400" bIns="25400"/>
+          <a:lstStyle/>
+          <a:p>
+            <a:pPr algn="l"/>
+            <a:r>
+              <a:rPr sz="900" b="1">
+                <a:solidFill>
+                  <a:srgbClr val="C0392B"/>
+                </a:solidFill>
+                <a:latin typeface="Meiryo"/>
+              </a:rPr>
+              <a:t>毎回「BizSTATION」で検索している</a:t>
+            </a:r>
+          </a:p>
+        </p:txBody>
+      </p:sp>
+      <p:sp>
+        <p:nvSpPr>
+          <p:cNvPr id="19" name="Rectangle 18"/>
+          <p:cNvSpPr/>
+          <p:nvPr/>
+        </p:nvSpPr>
+        <p:spPr>
+          <a:xfrm>
+            <a:off x="731520" y="3383280"/>
+            <a:ext cx="13624560" cy="411480"/>
+          </a:xfrm>
+          <a:prstGeom prst="rect">
+            <a:avLst/>
+          </a:prstGeom>
+          <a:solidFill>
+            <a:srgbClr val="222222"/>
+          </a:solidFill>
+          <a:ln>
+            <a:noFill/>
+          </a:ln>
+        </p:spPr>
+        <p:style>
+          <a:lnRef idx="1">
+            <a:schemeClr val="accent1"/>
+          </a:lnRef>
+          <a:fillRef idx="3">
+            <a:schemeClr val="accent1"/>
+          </a:fillRef>
+          <a:effectRef idx="2">
+            <a:schemeClr val="accent1"/>
+          </a:effectRef>
+          <a:fontRef idx="minor">
+            <a:schemeClr val="lt1"/>
+          </a:fontRef>
+        </p:style>
+        <p:txBody>
+          <a:bodyPr rtlCol="0" anchor="ctr" wrap="square" lIns="50800" rIns="50800" tIns="25400" bIns="25400"/>
+          <a:lstStyle/>
+          <a:p>
+            <a:pPr algn="ctr"/>
+            <a:r>
+              <a:rPr sz="1200" b="1">
+                <a:solidFill>
+                  <a:srgbClr val="FFFFFF"/>
+                </a:solidFill>
+                <a:latin typeface="Meiryo"/>
+              </a:rPr>
+              <a:t>ブックマーク登録の有無が攻撃成功率を左右する</a:t>
+            </a:r>
+          </a:p>
+        </p:txBody>
+      </p:sp>
+      <p:sp>
+        <p:nvSpPr>
+          <p:cNvPr id="20" name="Rectangle 19"/>
+          <p:cNvSpPr/>
+          <p:nvPr/>
+        </p:nvSpPr>
+        <p:spPr>
+          <a:xfrm>
+            <a:off x="731520" y="3840480"/>
+            <a:ext cx="6583680" cy="365760"/>
+          </a:xfrm>
+          <a:prstGeom prst="rect">
+            <a:avLst/>
+          </a:prstGeom>
+          <a:solidFill>
+            <a:srgbClr val="27AE60"/>
+          </a:solidFill>
+          <a:ln>
+            <a:noFill/>
+          </a:ln>
+        </p:spPr>
+        <p:style>
+          <a:lnRef idx="1">
+            <a:schemeClr val="accent1"/>
+          </a:lnRef>
+          <a:fillRef idx="3">
+            <a:schemeClr val="accent1"/>
+          </a:fillRef>
+          <a:effectRef idx="2">
+            <a:schemeClr val="accent1"/>
+          </a:effectRef>
+          <a:fontRef idx="minor">
+            <a:schemeClr val="lt1"/>
+          </a:fontRef>
+        </p:style>
+        <p:txBody>
+          <a:bodyPr rtlCol="0" anchor="ctr" wrap="square" lIns="50800" rIns="50800" tIns="25400" bIns="25400"/>
+          <a:lstStyle/>
+          <a:p>
+            <a:pPr algn="ctr"/>
+            <a:r>
+              <a:rPr sz="1000" b="1">
+                <a:solidFill>
+                  <a:srgbClr val="FFFFFF"/>
+                </a:solidFill>
+                <a:latin typeface="Meiryo"/>
+              </a:rPr>
+              <a:t>ブックマーク登録済みの人（少数）</a:t>
+            </a:r>
+          </a:p>
+        </p:txBody>
+      </p:sp>
+      <p:sp>
+        <p:nvSpPr>
+          <p:cNvPr id="21" name="Rectangle 20"/>
+          <p:cNvSpPr/>
+          <p:nvPr/>
+        </p:nvSpPr>
+        <p:spPr>
+          <a:xfrm>
+            <a:off x="731520" y="4206240"/>
+            <a:ext cx="6583680" cy="640080"/>
+          </a:xfrm>
+          <a:prstGeom prst="rect">
+            <a:avLst/>
+          </a:prstGeom>
+          <a:solidFill>
+            <a:srgbClr val="FFFFFF"/>
+          </a:solidFill>
+          <a:ln w="25400">
+            <a:solidFill>
+              <a:srgbClr val="27AE60"/>
+            </a:solidFill>
+          </a:ln>
+        </p:spPr>
+        <p:style>
+          <a:lnRef idx="1">
+            <a:schemeClr val="accent1"/>
+          </a:lnRef>
+          <a:fillRef idx="3">
+            <a:schemeClr val="accent1"/>
+          </a:fillRef>
+          <a:effectRef idx="2">
+            <a:schemeClr val="accent1"/>
+          </a:effectRef>
+          <a:fontRef idx="minor">
+            <a:schemeClr val="lt1"/>
+          </a:fontRef>
+        </p:style>
+        <p:txBody>
+          <a:bodyPr rtlCol="0" anchor="ctr" wrap="square" lIns="63500" rIns="50800" tIns="38100" bIns="38100"/>
+          <a:lstStyle/>
+          <a:p>
+            <a:pPr algn="l"/>
+            <a:r>
+              <a:rPr sz="1000" b="0">
+                <a:solidFill>
+                  <a:srgbClr val="222222"/>
+                </a:solidFill>
+                <a:latin typeface="Meiryo"/>
+              </a:rPr>
+              <a:t>→ 「自分のブックマークと違うURLだ」と気づける可能性がある
+→ でも電話中なので確認しない</a:t>
+            </a:r>
+          </a:p>
+        </p:txBody>
+      </p:sp>
+      <p:sp>
+        <p:nvSpPr>
+          <p:cNvPr id="22" name="Rectangle 21"/>
+          <p:cNvSpPr/>
+          <p:nvPr/>
+        </p:nvSpPr>
+        <p:spPr>
+          <a:xfrm>
+            <a:off x="7772400" y="3840480"/>
+            <a:ext cx="6400800" cy="365760"/>
+          </a:xfrm>
+          <a:prstGeom prst="rect">
+            <a:avLst/>
+          </a:prstGeom>
+          <a:solidFill>
+            <a:srgbClr val="C0392B"/>
+          </a:solidFill>
+          <a:ln>
+            <a:noFill/>
+          </a:ln>
+        </p:spPr>
+        <p:style>
+          <a:lnRef idx="1">
+            <a:schemeClr val="accent1"/>
+          </a:lnRef>
+          <a:fillRef idx="3">
+            <a:schemeClr val="accent1"/>
+          </a:fillRef>
+          <a:effectRef idx="2">
+            <a:schemeClr val="accent1"/>
+          </a:effectRef>
+          <a:fontRef idx="minor">
+            <a:schemeClr val="lt1"/>
+          </a:fontRef>
+        </p:style>
+        <p:txBody>
+          <a:bodyPr rtlCol="0" anchor="ctr" wrap="square" lIns="50800" rIns="50800" tIns="25400" bIns="25400"/>
+          <a:lstStyle/>
+          <a:p>
+            <a:pPr algn="ctr"/>
+            <a:r>
+              <a:rPr sz="1000" b="1">
+                <a:solidFill>
+                  <a:srgbClr val="FFFFFF"/>
+                </a:solidFill>
+                <a:latin typeface="Meiryo"/>
+              </a:rPr>
+              <a:t>ブックマーク未登録の人（多数）</a:t>
+            </a:r>
+          </a:p>
+        </p:txBody>
+      </p:sp>
+      <p:sp>
+        <p:nvSpPr>
+          <p:cNvPr id="23" name="Rectangle 22"/>
+          <p:cNvSpPr/>
+          <p:nvPr/>
+        </p:nvSpPr>
+        <p:spPr>
+          <a:xfrm>
+            <a:off x="7772400" y="4206240"/>
+            <a:ext cx="6400800" cy="640080"/>
+          </a:xfrm>
+          <a:prstGeom prst="rect">
+            <a:avLst/>
+          </a:prstGeom>
+          <a:solidFill>
+            <a:srgbClr val="FFFFFF"/>
+          </a:solidFill>
+          <a:ln w="25400">
+            <a:solidFill>
+              <a:srgbClr val="C0392B"/>
+            </a:solidFill>
+          </a:ln>
+        </p:spPr>
+        <p:style>
+          <a:lnRef idx="1">
+            <a:schemeClr val="accent1"/>
+          </a:lnRef>
+          <a:fillRef idx="3">
+            <a:schemeClr val="accent1"/>
+          </a:fillRef>
+          <a:effectRef idx="2">
+            <a:schemeClr val="accent1"/>
+          </a:effectRef>
+          <a:fontRef idx="minor">
+            <a:schemeClr val="lt1"/>
+          </a:fontRef>
+        </p:style>
+        <p:txBody>
+          <a:bodyPr rtlCol="0" anchor="ctr" wrap="square" lIns="63500" rIns="50800" tIns="38100" bIns="38100"/>
+          <a:lstStyle/>
+          <a:p>
+            <a:pPr algn="l"/>
+            <a:r>
+              <a:rPr sz="1000" b="0">
+                <a:solidFill>
+                  <a:srgbClr val="222222"/>
+                </a:solidFill>
+                <a:latin typeface="Meiryo"/>
+              </a:rPr>
+              <a:t>→ 普段から検索やメールリンクでアクセスしている
+→ メールのボタンをクリックすることに抵抗がない
+→ 攻撃にそのまま乗ってしまう</a:t>
+            </a:r>
+          </a:p>
+        </p:txBody>
+      </p:sp>
+      <p:sp>
+        <p:nvSpPr>
+          <p:cNvPr id="24" name="Rectangle 23"/>
+          <p:cNvSpPr/>
+          <p:nvPr/>
+        </p:nvSpPr>
+        <p:spPr>
+          <a:xfrm>
+            <a:off x="731520" y="5074920"/>
+            <a:ext cx="13624560" cy="411480"/>
+          </a:xfrm>
+          <a:prstGeom prst="rect">
+            <a:avLst/>
+          </a:prstGeom>
+          <a:solidFill>
+            <a:srgbClr val="27AE60"/>
+          </a:solidFill>
+          <a:ln>
+            <a:noFill/>
+          </a:ln>
+        </p:spPr>
+        <p:style>
+          <a:lnRef idx="1">
+            <a:schemeClr val="accent1"/>
+          </a:lnRef>
+          <a:fillRef idx="3">
+            <a:schemeClr val="accent1"/>
+          </a:fillRef>
+          <a:effectRef idx="2">
+            <a:schemeClr val="accent1"/>
+          </a:effectRef>
+          <a:fontRef idx="minor">
+            <a:schemeClr val="lt1"/>
+          </a:fontRef>
+        </p:style>
+        <p:txBody>
+          <a:bodyPr rtlCol="0" anchor="ctr" wrap="square" lIns="50800" rIns="50800" tIns="25400" bIns="25400"/>
+          <a:lstStyle/>
+          <a:p>
+            <a:pPr algn="ctr"/>
+            <a:r>
+              <a:rPr sz="1200" b="1">
+                <a:solidFill>
+                  <a:srgbClr val="FFFFFF"/>
+                </a:solidFill>
+                <a:latin typeface="Meiryo"/>
+              </a:rPr>
+              <a:t>銀行がやるべきだったこと</a:t>
+            </a:r>
+          </a:p>
+        </p:txBody>
+      </p:sp>
+      <p:sp>
+        <p:nvSpPr>
+          <p:cNvPr id="25" name="Rectangle 24"/>
+          <p:cNvSpPr/>
+          <p:nvPr/>
+        </p:nvSpPr>
+        <p:spPr>
+          <a:xfrm>
+            <a:off x="731520" y="5486400"/>
+            <a:ext cx="5029200" cy="411480"/>
+          </a:xfrm>
+          <a:prstGeom prst="rect">
+            <a:avLst/>
+          </a:prstGeom>
+          <a:solidFill>
+            <a:srgbClr val="FFFFFF"/>
+          </a:solidFill>
+          <a:ln w="25400">
+            <a:solidFill>
+              <a:srgbClr val="27AE60"/>
+            </a:solidFill>
+          </a:ln>
+        </p:spPr>
+        <p:style>
+          <a:lnRef idx="1">
+            <a:schemeClr val="accent1"/>
+          </a:lnRef>
+          <a:fillRef idx="3">
+            <a:schemeClr val="accent1"/>
+          </a:fillRef>
+          <a:effectRef idx="2">
+            <a:schemeClr val="accent1"/>
+          </a:effectRef>
+          <a:fontRef idx="minor">
+            <a:schemeClr val="lt1"/>
+          </a:fontRef>
+        </p:style>
+        <p:txBody>
+          <a:bodyPr rtlCol="0" anchor="ctr" wrap="square" lIns="63500" rIns="50800" tIns="38100" bIns="38100"/>
+          <a:lstStyle/>
+          <a:p>
+            <a:pPr algn="l"/>
+            <a:r>
+              <a:rPr sz="900" b="1">
+                <a:solidFill>
+                  <a:srgbClr val="222222"/>
+                </a:solidFill>
+                <a:latin typeface="Meiryo"/>
+              </a:rPr>
+              <a:t>① 契約時にブックマークを設定してあげる</a:t>
+            </a:r>
+          </a:p>
+        </p:txBody>
+      </p:sp>
+      <p:sp>
+        <p:nvSpPr>
+          <p:cNvPr id="26" name="Rectangle 25"/>
+          <p:cNvSpPr/>
+          <p:nvPr/>
+        </p:nvSpPr>
+        <p:spPr>
+          <a:xfrm>
+            <a:off x="5760720" y="5486400"/>
+            <a:ext cx="8595360" cy="411480"/>
+          </a:xfrm>
+          <a:prstGeom prst="rect">
+            <a:avLst/>
+          </a:prstGeom>
+          <a:solidFill>
+            <a:srgbClr val="FFFFFF"/>
+          </a:solidFill>
+          <a:ln w="25400">
+            <a:solidFill>
+              <a:srgbClr val="CCCCCC"/>
+            </a:solidFill>
+          </a:ln>
+        </p:spPr>
+        <p:style>
+          <a:lnRef idx="1">
+            <a:schemeClr val="accent1"/>
+          </a:lnRef>
+          <a:fillRef idx="3">
+            <a:schemeClr val="accent1"/>
+          </a:fillRef>
+          <a:effectRef idx="2">
+            <a:schemeClr val="accent1"/>
+          </a:effectRef>
+          <a:fontRef idx="minor">
+            <a:schemeClr val="lt1"/>
+          </a:fontRef>
+        </p:style>
+        <p:txBody>
+          <a:bodyPr rtlCol="0" anchor="ctr" wrap="square" lIns="63500" rIns="50800" tIns="38100" bIns="38100"/>
+          <a:lstStyle/>
+          <a:p>
+            <a:pPr algn="l"/>
+            <a:r>
+              <a:rPr sz="900" b="0">
+                <a:solidFill>
+                  <a:srgbClr val="222222"/>
+                </a:solidFill>
+                <a:latin typeface="Meiryo"/>
+              </a:rPr>
+              <a:t>窓口対応 or 初期設定ツールで銀行側が登録</a:t>
+            </a:r>
+          </a:p>
+        </p:txBody>
+      </p:sp>
+      <p:sp>
+        <p:nvSpPr>
+          <p:cNvPr id="27" name="Rectangle 26"/>
+          <p:cNvSpPr/>
+          <p:nvPr/>
+        </p:nvSpPr>
+        <p:spPr>
+          <a:xfrm>
+            <a:off x="731520" y="5897880"/>
+            <a:ext cx="5029200" cy="411480"/>
+          </a:xfrm>
+          <a:prstGeom prst="rect">
+            <a:avLst/>
+          </a:prstGeom>
+          <a:solidFill>
+            <a:srgbClr val="F9F9F9"/>
+          </a:solidFill>
+          <a:ln w="25400">
+            <a:solidFill>
+              <a:srgbClr val="27AE60"/>
+            </a:solidFill>
+          </a:ln>
+        </p:spPr>
+        <p:style>
+          <a:lnRef idx="1">
+            <a:schemeClr val="accent1"/>
+          </a:lnRef>
+          <a:fillRef idx="3">
+            <a:schemeClr val="accent1"/>
+          </a:fillRef>
+          <a:effectRef idx="2">
+            <a:schemeClr val="accent1"/>
+          </a:effectRef>
+          <a:fontRef idx="minor">
+            <a:schemeClr val="lt1"/>
+          </a:fontRef>
+        </p:style>
+        <p:txBody>
+          <a:bodyPr rtlCol="0" anchor="ctr" wrap="square" lIns="63500" rIns="50800" tIns="38100" bIns="38100"/>
+          <a:lstStyle/>
+          <a:p>
+            <a:pPr algn="l"/>
+            <a:r>
+              <a:rPr sz="900" b="1">
+                <a:solidFill>
+                  <a:srgbClr val="222222"/>
+                </a:solidFill>
+                <a:latin typeface="Meiryo"/>
+              </a:rPr>
+              <a:t>② 公式アプリでしかアクセスできない仕組み</a:t>
+            </a:r>
+          </a:p>
+        </p:txBody>
+      </p:sp>
+      <p:sp>
+        <p:nvSpPr>
+          <p:cNvPr id="28" name="Rectangle 27"/>
+          <p:cNvSpPr/>
+          <p:nvPr/>
+        </p:nvSpPr>
+        <p:spPr>
+          <a:xfrm>
+            <a:off x="5760720" y="5897880"/>
+            <a:ext cx="8595360" cy="411480"/>
+          </a:xfrm>
+          <a:prstGeom prst="rect">
+            <a:avLst/>
+          </a:prstGeom>
+          <a:solidFill>
+            <a:srgbClr val="F9F9F9"/>
+          </a:solidFill>
+          <a:ln w="25400">
+            <a:solidFill>
+              <a:srgbClr val="CCCCCC"/>
+            </a:solidFill>
+          </a:ln>
+        </p:spPr>
+        <p:style>
+          <a:lnRef idx="1">
+            <a:schemeClr val="accent1"/>
+          </a:lnRef>
+          <a:fillRef idx="3">
+            <a:schemeClr val="accent1"/>
+          </a:fillRef>
+          <a:effectRef idx="2">
+            <a:schemeClr val="accent1"/>
+          </a:effectRef>
+          <a:fontRef idx="minor">
+            <a:schemeClr val="lt1"/>
+          </a:fontRef>
+        </p:style>
+        <p:txBody>
+          <a:bodyPr rtlCol="0" anchor="ctr" wrap="square" lIns="63500" rIns="50800" tIns="38100" bIns="38100"/>
+          <a:lstStyle/>
+          <a:p>
+            <a:pPr algn="l"/>
+            <a:r>
+              <a:rPr sz="900" b="0">
+                <a:solidFill>
+                  <a:srgbClr val="222222"/>
+                </a:solidFill>
+                <a:latin typeface="Meiryo"/>
+              </a:rPr>
+              <a:t>ブラウザ経由のアクセスを廃止</a:t>
+            </a:r>
+          </a:p>
+        </p:txBody>
+      </p:sp>
+      <p:sp>
+        <p:nvSpPr>
+          <p:cNvPr id="29" name="Rectangle 28"/>
+          <p:cNvSpPr/>
+          <p:nvPr/>
+        </p:nvSpPr>
+        <p:spPr>
+          <a:xfrm>
+            <a:off x="731520" y="6309360"/>
+            <a:ext cx="5029200" cy="411480"/>
+          </a:xfrm>
+          <a:prstGeom prst="rect">
+            <a:avLst/>
+          </a:prstGeom>
+          <a:solidFill>
+            <a:srgbClr val="FFFFFF"/>
+          </a:solidFill>
+          <a:ln w="25400">
+            <a:solidFill>
+              <a:srgbClr val="27AE60"/>
+            </a:solidFill>
+          </a:ln>
+        </p:spPr>
+        <p:style>
+          <a:lnRef idx="1">
+            <a:schemeClr val="accent1"/>
+          </a:lnRef>
+          <a:fillRef idx="3">
+            <a:schemeClr val="accent1"/>
+          </a:fillRef>
+          <a:effectRef idx="2">
+            <a:schemeClr val="accent1"/>
+          </a:effectRef>
+          <a:fontRef idx="minor">
+            <a:schemeClr val="lt1"/>
+          </a:fontRef>
+        </p:style>
+        <p:txBody>
+          <a:bodyPr rtlCol="0" anchor="ctr" wrap="square" lIns="63500" rIns="50800" tIns="38100" bIns="38100"/>
+          <a:lstStyle/>
+          <a:p>
+            <a:pPr algn="l"/>
+            <a:r>
+              <a:rPr sz="900" b="1">
+                <a:solidFill>
+                  <a:srgbClr val="222222"/>
+                </a:solidFill>
+                <a:latin typeface="Meiryo"/>
+              </a:rPr>
+              <a:t>③ 専用クライアントに統一</a:t>
+            </a:r>
+          </a:p>
+        </p:txBody>
+      </p:sp>
+      <p:sp>
+        <p:nvSpPr>
+          <p:cNvPr id="30" name="Rectangle 29"/>
+          <p:cNvSpPr/>
+          <p:nvPr/>
+        </p:nvSpPr>
+        <p:spPr>
+          <a:xfrm>
+            <a:off x="5760720" y="6309360"/>
+            <a:ext cx="8595360" cy="411480"/>
+          </a:xfrm>
+          <a:prstGeom prst="rect">
+            <a:avLst/>
+          </a:prstGeom>
+          <a:solidFill>
+            <a:srgbClr val="FFFFFF"/>
+          </a:solidFill>
+          <a:ln w="25400">
+            <a:solidFill>
+              <a:srgbClr val="CCCCCC"/>
+            </a:solidFill>
+          </a:ln>
+        </p:spPr>
+        <p:style>
+          <a:lnRef idx="1">
+            <a:schemeClr val="accent1"/>
+          </a:lnRef>
+          <a:fillRef idx="3">
+            <a:schemeClr val="accent1"/>
+          </a:fillRef>
+          <a:effectRef idx="2">
+            <a:schemeClr val="accent1"/>
+          </a:effectRef>
+          <a:fontRef idx="minor">
+            <a:schemeClr val="lt1"/>
+          </a:fontRef>
+        </p:style>
+        <p:txBody>
+          <a:bodyPr rtlCol="0" anchor="ctr" wrap="square" lIns="63500" rIns="50800" tIns="38100" bIns="38100"/>
+          <a:lstStyle/>
+          <a:p>
+            <a:pPr algn="l"/>
+            <a:r>
+              <a:rPr sz="900" b="0">
+                <a:solidFill>
+                  <a:srgbClr val="222222"/>
+                </a:solidFill>
+                <a:latin typeface="Meiryo"/>
+              </a:rPr>
+              <a:t>ブラウザを使わせないことでフィッシング自体を不可能にする</a:t>
+            </a:r>
+          </a:p>
+        </p:txBody>
+      </p:sp>
+      <p:sp>
+        <p:nvSpPr>
+          <p:cNvPr id="31" name="Rectangle 30"/>
+          <p:cNvSpPr/>
+          <p:nvPr/>
+        </p:nvSpPr>
+        <p:spPr>
+          <a:xfrm>
+            <a:off x="731520" y="6766560"/>
+            <a:ext cx="13624560" cy="457200"/>
+          </a:xfrm>
+          <a:prstGeom prst="rect">
+            <a:avLst/>
+          </a:prstGeom>
+          <a:solidFill>
+            <a:srgbClr val="222222"/>
+          </a:solidFill>
+          <a:ln>
+            <a:noFill/>
+          </a:ln>
+        </p:spPr>
+        <p:style>
+          <a:lnRef idx="1">
+            <a:schemeClr val="accent1"/>
+          </a:lnRef>
+          <a:fillRef idx="3">
+            <a:schemeClr val="accent1"/>
+          </a:fillRef>
+          <a:effectRef idx="2">
+            <a:schemeClr val="accent1"/>
+          </a:effectRef>
+          <a:fontRef idx="minor">
+            <a:schemeClr val="lt1"/>
+          </a:fontRef>
+        </p:style>
+        <p:txBody>
+          <a:bodyPr rtlCol="0" anchor="ctr" wrap="square" lIns="50800" rIns="50800" tIns="25400" bIns="25400"/>
+          <a:lstStyle/>
+          <a:p>
+            <a:pPr algn="ctr"/>
+            <a:r>
+              <a:rPr sz="1300" b="1">
+                <a:solidFill>
+                  <a:srgbClr val="FFFFFF"/>
+                </a:solidFill>
+                <a:latin typeface="Meiryo"/>
+              </a:rPr>
+              <a:t>「自分でブックマーク登録してね」では対策にならない — 銀行側がアクセス経路を制御すべき</a:t>
+            </a:r>
+          </a:p>
+        </p:txBody>
+      </p:sp>
+      <p:sp>
+        <p:nvSpPr>
+          <p:cNvPr id="32" name="TextBox 31"/>
+          <p:cNvSpPr txBox="1"/>
+          <p:nvPr/>
+        </p:nvSpPr>
+        <p:spPr>
+          <a:xfrm>
+            <a:off x="9144000" y="10378440"/>
+            <a:ext cx="5943600" cy="228600"/>
+          </a:xfrm>
+          <a:prstGeom prst="rect">
+            <a:avLst/>
+          </a:prstGeom>
+          <a:noFill/>
+        </p:spPr>
+        <p:txBody>
+          <a:bodyPr wrap="square" lIns="50800" rIns="50800" tIns="38100" bIns="38100"/>
+          <a:lstStyle/>
+          <a:p>
+            <a:pPr algn="r"/>
+            <a:r>
+              <a:rPr sz="700" b="0">
+                <a:solidFill>
+                  <a:srgbClr val="888888"/>
+                </a:solidFill>
+                <a:latin typeface="Meiryo"/>
+              </a:rPr>
+              <a:t>Fraud Kill Chain — ブックマーク対策の限界</a:t>
             </a:r>
           </a:p>
         </p:txBody>

</xml_diff>

<commit_message>
Add slide 10: unknown publisher is not a real defense
"Unknown publisher" is the clearest red flag but attackers can
eliminate it by purchasing/stealing code signing certificates.
Only whitelist-based app control (AppLocker/WDAC) stops all cases.

https://claude.ai/code/session_01F7t8LKifK43o6sCdF2a3gQ
</commit_message>
<xml_diff>
--- a/Fraud_Kill_Chain.pptx
+++ b/Fraud_Kill_Chain.pptx
@@ -14,6 +14,7 @@
     <p:sldId id="262" r:id="rId13"/>
     <p:sldId id="263" r:id="rId14"/>
     <p:sldId id="264" r:id="rId15"/>
+    <p:sldId id="265" r:id="rId16"/>
   </p:sldIdLst>
   <p:sldSz cx="15124176" cy="10689336" type="screen4x3"/>
   <p:notesSz cx="6858000" cy="9144000"/>
@@ -7464,6 +7465,2945 @@
                 <a:latin typeface="Meiryo"/>
               </a:rPr>
               <a:t>Fraud Kill Chain — 不審な電話手口 ｜ A3横印刷対応</a:t>
+            </a:r>
+          </a:p>
+        </p:txBody>
+      </p:sp>
+    </p:spTree>
+  </p:cSld>
+  <p:clrMapOvr>
+    <a:masterClrMapping/>
+  </p:clrMapOvr>
+</p:sld>
+</file>
+
+<file path=ppt/slides/slide10.xml><?xml version="1.0" encoding="utf-8"?>
+<p:sld xmlns:a="http://schemas.openxmlformats.org/drawingml/2006/main" xmlns:p="http://schemas.openxmlformats.org/presentationml/2006/main" xmlns:r="http://schemas.openxmlformats.org/officeDocument/2006/relationships">
+  <p:cSld>
+    <p:bg>
+      <p:bgPr>
+        <a:solidFill>
+          <a:srgbClr val="F5F5F5"/>
+        </a:solidFill>
+        <a:effectLst/>
+      </p:bgPr>
+    </p:bg>
+    <p:spTree>
+      <p:nvGrpSpPr>
+        <p:cNvPr id="1" name=""/>
+        <p:cNvGrpSpPr/>
+        <p:nvPr/>
+      </p:nvGrpSpPr>
+      <p:grpSpPr/>
+      <p:sp>
+        <p:nvSpPr>
+          <p:cNvPr id="2" name="TextBox 1"/>
+          <p:cNvSpPr txBox="1"/>
+          <p:nvPr/>
+        </p:nvSpPr>
+        <p:spPr>
+          <a:xfrm>
+            <a:off x="0" y="182880"/>
+            <a:ext cx="15124176" cy="548640"/>
+          </a:xfrm>
+          <a:prstGeom prst="rect">
+            <a:avLst/>
+          </a:prstGeom>
+          <a:noFill/>
+        </p:spPr>
+        <p:txBody>
+          <a:bodyPr wrap="square" lIns="50800" rIns="50800" tIns="38100" bIns="38100"/>
+          <a:lstStyle/>
+          <a:p>
+            <a:pPr algn="ctr"/>
+            <a:r>
+              <a:rPr sz="2000" b="1">
+                <a:solidFill>
+                  <a:srgbClr val="C0392B"/>
+                </a:solidFill>
+                <a:latin typeface="Meiryo"/>
+              </a:rPr>
+              <a:t>手順⑥「不明な発行元」— 極めつけの証拠だが、本質的な防壁ではない</a:t>
+            </a:r>
+          </a:p>
+        </p:txBody>
+      </p:sp>
+      <p:sp>
+        <p:nvSpPr>
+          <p:cNvPr id="3" name="TextBox 2"/>
+          <p:cNvSpPr txBox="1"/>
+          <p:nvPr/>
+        </p:nvSpPr>
+        <p:spPr>
+          <a:xfrm>
+            <a:off x="0" y="640080"/>
+            <a:ext cx="15124176" cy="365760"/>
+          </a:xfrm>
+          <a:prstGeom prst="rect">
+            <a:avLst/>
+          </a:prstGeom>
+          <a:noFill/>
+        </p:spPr>
+        <p:txBody>
+          <a:bodyPr wrap="square" lIns="50800" rIns="50800" tIns="38100" bIns="38100"/>
+          <a:lstStyle/>
+          <a:p>
+            <a:pPr algn="ctr"/>
+            <a:r>
+              <a:rPr sz="1100" b="0">
+                <a:solidFill>
+                  <a:srgbClr val="888888"/>
+                </a:solidFill>
+                <a:latin typeface="Meiryo"/>
+              </a:rPr>
+              <a:t>OSが画面に大きく警告。知識不要、誰でも読める。それでも突破され、犯人のレベルアップで消滅する。</a:t>
+            </a:r>
+          </a:p>
+        </p:txBody>
+      </p:sp>
+      <p:sp>
+        <p:nvSpPr>
+          <p:cNvPr id="4" name="Rectangle 3"/>
+          <p:cNvSpPr/>
+          <p:nvPr/>
+        </p:nvSpPr>
+        <p:spPr>
+          <a:xfrm>
+            <a:off x="731520" y="1051560"/>
+            <a:ext cx="13624560" cy="365760"/>
+          </a:xfrm>
+          <a:prstGeom prst="rect">
+            <a:avLst/>
+          </a:prstGeom>
+          <a:solidFill>
+            <a:srgbClr val="222222"/>
+          </a:solidFill>
+          <a:ln>
+            <a:noFill/>
+          </a:ln>
+        </p:spPr>
+        <p:style>
+          <a:lnRef idx="1">
+            <a:schemeClr val="accent1"/>
+          </a:lnRef>
+          <a:fillRef idx="3">
+            <a:schemeClr val="accent1"/>
+          </a:fillRef>
+          <a:effectRef idx="2">
+            <a:schemeClr val="accent1"/>
+          </a:effectRef>
+          <a:fontRef idx="minor">
+            <a:schemeClr val="lt1"/>
+          </a:fontRef>
+        </p:style>
+        <p:txBody>
+          <a:bodyPr rtlCol="0" anchor="ctr" wrap="square" lIns="50800" rIns="50800" tIns="25400" bIns="25400"/>
+          <a:lstStyle/>
+          <a:p>
+            <a:pPr algn="ctr"/>
+            <a:r>
+              <a:rPr sz="1200" b="1">
+                <a:solidFill>
+                  <a:srgbClr val="FFFFFF"/>
+                </a:solidFill>
+                <a:latin typeface="Meiryo"/>
+              </a:rPr>
+              <a:t>正規ソフト vs この攻撃の署名状態</a:t>
+            </a:r>
+          </a:p>
+        </p:txBody>
+      </p:sp>
+      <p:sp>
+        <p:nvSpPr>
+          <p:cNvPr id="5" name="Rectangle 4"/>
+          <p:cNvSpPr/>
+          <p:nvPr/>
+        </p:nvSpPr>
+        <p:spPr>
+          <a:xfrm>
+            <a:off x="731520" y="1417319"/>
+            <a:ext cx="3200400" cy="411480"/>
+          </a:xfrm>
+          <a:prstGeom prst="rect">
+            <a:avLst/>
+          </a:prstGeom>
+          <a:solidFill>
+            <a:srgbClr val="FFFFFF"/>
+          </a:solidFill>
+          <a:ln w="25400">
+            <a:solidFill>
+              <a:srgbClr val="CCCCCC"/>
+            </a:solidFill>
+          </a:ln>
+        </p:spPr>
+        <p:style>
+          <a:lnRef idx="1">
+            <a:schemeClr val="accent1"/>
+          </a:lnRef>
+          <a:fillRef idx="3">
+            <a:schemeClr val="accent1"/>
+          </a:fillRef>
+          <a:effectRef idx="2">
+            <a:schemeClr val="accent1"/>
+          </a:effectRef>
+          <a:fontRef idx="minor">
+            <a:schemeClr val="lt1"/>
+          </a:fontRef>
+        </p:style>
+        <p:txBody>
+          <a:bodyPr rtlCol="0" anchor="ctr" wrap="square" lIns="63500" rIns="50800" tIns="38100" bIns="38100"/>
+          <a:lstStyle/>
+          <a:p>
+            <a:pPr algn="l"/>
+            <a:r>
+              <a:rPr sz="1000" b="1">
+                <a:solidFill>
+                  <a:srgbClr val="222222"/>
+                </a:solidFill>
+                <a:latin typeface="Meiryo"/>
+              </a:rPr>
+              <a:t>Rapport（IBM推奨）</a:t>
+            </a:r>
+          </a:p>
+        </p:txBody>
+      </p:sp>
+      <p:sp>
+        <p:nvSpPr>
+          <p:cNvPr id="6" name="Rectangle 5"/>
+          <p:cNvSpPr/>
+          <p:nvPr/>
+        </p:nvSpPr>
+        <p:spPr>
+          <a:xfrm>
+            <a:off x="3931920" y="1417319"/>
+            <a:ext cx="3657600" cy="411480"/>
+          </a:xfrm>
+          <a:prstGeom prst="rect">
+            <a:avLst/>
+          </a:prstGeom>
+          <a:solidFill>
+            <a:srgbClr val="FFFFFF"/>
+          </a:solidFill>
+          <a:ln w="25400">
+            <a:solidFill>
+              <a:srgbClr val="27AE60"/>
+            </a:solidFill>
+          </a:ln>
+        </p:spPr>
+        <p:style>
+          <a:lnRef idx="1">
+            <a:schemeClr val="accent1"/>
+          </a:lnRef>
+          <a:fillRef idx="3">
+            <a:schemeClr val="accent1"/>
+          </a:fillRef>
+          <a:effectRef idx="2">
+            <a:schemeClr val="accent1"/>
+          </a:effectRef>
+          <a:fontRef idx="minor">
+            <a:schemeClr val="lt1"/>
+          </a:fontRef>
+        </p:style>
+        <p:txBody>
+          <a:bodyPr rtlCol="0" anchor="ctr" wrap="square" lIns="63500" rIns="50800" tIns="38100" bIns="38100"/>
+          <a:lstStyle/>
+          <a:p>
+            <a:pPr algn="l"/>
+            <a:r>
+              <a:rPr sz="1000" b="1">
+                <a:solidFill>
+                  <a:srgbClr val="27AE60"/>
+                </a:solidFill>
+                <a:latin typeface="Meiryo"/>
+              </a:rPr>
+              <a:t>IBM Corporation ✅</a:t>
+            </a:r>
+          </a:p>
+        </p:txBody>
+      </p:sp>
+      <p:sp>
+        <p:nvSpPr>
+          <p:cNvPr id="7" name="Rectangle 6"/>
+          <p:cNvSpPr/>
+          <p:nvPr/>
+        </p:nvSpPr>
+        <p:spPr>
+          <a:xfrm>
+            <a:off x="7589520" y="1417319"/>
+            <a:ext cx="4572000" cy="411480"/>
+          </a:xfrm>
+          <a:prstGeom prst="rect">
+            <a:avLst/>
+          </a:prstGeom>
+          <a:solidFill>
+            <a:srgbClr val="FFFFFF"/>
+          </a:solidFill>
+          <a:ln w="25400">
+            <a:solidFill>
+              <a:srgbClr val="CCCCCC"/>
+            </a:solidFill>
+          </a:ln>
+        </p:spPr>
+        <p:style>
+          <a:lnRef idx="1">
+            <a:schemeClr val="accent1"/>
+          </a:lnRef>
+          <a:fillRef idx="3">
+            <a:schemeClr val="accent1"/>
+          </a:fillRef>
+          <a:effectRef idx="2">
+            <a:schemeClr val="accent1"/>
+          </a:effectRef>
+          <a:fontRef idx="minor">
+            <a:schemeClr val="lt1"/>
+          </a:fontRef>
+        </p:style>
+        <p:txBody>
+          <a:bodyPr rtlCol="0" anchor="ctr" wrap="square" lIns="63500" rIns="50800" tIns="38100" bIns="38100"/>
+          <a:lstStyle/>
+          <a:p>
+            <a:pPr algn="l"/>
+            <a:r>
+              <a:rPr sz="900" b="0">
+                <a:solidFill>
+                  <a:srgbClr val="222222"/>
+                </a:solidFill>
+                <a:latin typeface="Meiryo"/>
+              </a:rPr>
+              <a:t>信頼されたCAで署名済み</a:t>
+            </a:r>
+          </a:p>
+        </p:txBody>
+      </p:sp>
+      <p:sp>
+        <p:nvSpPr>
+          <p:cNvPr id="8" name="Rectangle 7"/>
+          <p:cNvSpPr/>
+          <p:nvPr/>
+        </p:nvSpPr>
+        <p:spPr>
+          <a:xfrm>
+            <a:off x="731520" y="1828799"/>
+            <a:ext cx="3200400" cy="411480"/>
+          </a:xfrm>
+          <a:prstGeom prst="rect">
+            <a:avLst/>
+          </a:prstGeom>
+          <a:solidFill>
+            <a:srgbClr val="F9F9F9"/>
+          </a:solidFill>
+          <a:ln w="25400">
+            <a:solidFill>
+              <a:srgbClr val="CCCCCC"/>
+            </a:solidFill>
+          </a:ln>
+        </p:spPr>
+        <p:style>
+          <a:lnRef idx="1">
+            <a:schemeClr val="accent1"/>
+          </a:lnRef>
+          <a:fillRef idx="3">
+            <a:schemeClr val="accent1"/>
+          </a:fillRef>
+          <a:effectRef idx="2">
+            <a:schemeClr val="accent1"/>
+          </a:effectRef>
+          <a:fontRef idx="minor">
+            <a:schemeClr val="lt1"/>
+          </a:fontRef>
+        </p:style>
+        <p:txBody>
+          <a:bodyPr rtlCol="0" anchor="ctr" wrap="square" lIns="63500" rIns="50800" tIns="38100" bIns="38100"/>
+          <a:lstStyle/>
+          <a:p>
+            <a:pPr algn="l"/>
+            <a:r>
+              <a:rPr sz="1000" b="1">
+                <a:solidFill>
+                  <a:srgbClr val="222222"/>
+                </a:solidFill>
+                <a:latin typeface="Meiryo"/>
+              </a:rPr>
+              <a:t>PhishWall（SecureBrain）</a:t>
+            </a:r>
+          </a:p>
+        </p:txBody>
+      </p:sp>
+      <p:sp>
+        <p:nvSpPr>
+          <p:cNvPr id="9" name="Rectangle 8"/>
+          <p:cNvSpPr/>
+          <p:nvPr/>
+        </p:nvSpPr>
+        <p:spPr>
+          <a:xfrm>
+            <a:off x="3931920" y="1828799"/>
+            <a:ext cx="3657600" cy="411480"/>
+          </a:xfrm>
+          <a:prstGeom prst="rect">
+            <a:avLst/>
+          </a:prstGeom>
+          <a:solidFill>
+            <a:srgbClr val="F9F9F9"/>
+          </a:solidFill>
+          <a:ln w="25400">
+            <a:solidFill>
+              <a:srgbClr val="27AE60"/>
+            </a:solidFill>
+          </a:ln>
+        </p:spPr>
+        <p:style>
+          <a:lnRef idx="1">
+            <a:schemeClr val="accent1"/>
+          </a:lnRef>
+          <a:fillRef idx="3">
+            <a:schemeClr val="accent1"/>
+          </a:fillRef>
+          <a:effectRef idx="2">
+            <a:schemeClr val="accent1"/>
+          </a:effectRef>
+          <a:fontRef idx="minor">
+            <a:schemeClr val="lt1"/>
+          </a:fontRef>
+        </p:style>
+        <p:txBody>
+          <a:bodyPr rtlCol="0" anchor="ctr" wrap="square" lIns="63500" rIns="50800" tIns="38100" bIns="38100"/>
+          <a:lstStyle/>
+          <a:p>
+            <a:pPr algn="l"/>
+            <a:r>
+              <a:rPr sz="1000" b="1">
+                <a:solidFill>
+                  <a:srgbClr val="27AE60"/>
+                </a:solidFill>
+                <a:latin typeface="Meiryo"/>
+              </a:rPr>
+              <a:t>SecureBrain Corporation ✅</a:t>
+            </a:r>
+          </a:p>
+        </p:txBody>
+      </p:sp>
+      <p:sp>
+        <p:nvSpPr>
+          <p:cNvPr id="10" name="Rectangle 9"/>
+          <p:cNvSpPr/>
+          <p:nvPr/>
+        </p:nvSpPr>
+        <p:spPr>
+          <a:xfrm>
+            <a:off x="7589520" y="1828799"/>
+            <a:ext cx="4572000" cy="411480"/>
+          </a:xfrm>
+          <a:prstGeom prst="rect">
+            <a:avLst/>
+          </a:prstGeom>
+          <a:solidFill>
+            <a:srgbClr val="F9F9F9"/>
+          </a:solidFill>
+          <a:ln w="25400">
+            <a:solidFill>
+              <a:srgbClr val="CCCCCC"/>
+            </a:solidFill>
+          </a:ln>
+        </p:spPr>
+        <p:style>
+          <a:lnRef idx="1">
+            <a:schemeClr val="accent1"/>
+          </a:lnRef>
+          <a:fillRef idx="3">
+            <a:schemeClr val="accent1"/>
+          </a:fillRef>
+          <a:effectRef idx="2">
+            <a:schemeClr val="accent1"/>
+          </a:effectRef>
+          <a:fontRef idx="minor">
+            <a:schemeClr val="lt1"/>
+          </a:fontRef>
+        </p:style>
+        <p:txBody>
+          <a:bodyPr rtlCol="0" anchor="ctr" wrap="square" lIns="63500" rIns="50800" tIns="38100" bIns="38100"/>
+          <a:lstStyle/>
+          <a:p>
+            <a:pPr algn="l"/>
+            <a:r>
+              <a:rPr sz="900" b="0">
+                <a:solidFill>
+                  <a:srgbClr val="222222"/>
+                </a:solidFill>
+                <a:latin typeface="Meiryo"/>
+              </a:rPr>
+              <a:t>信頼されたCAで署名済み</a:t>
+            </a:r>
+          </a:p>
+        </p:txBody>
+      </p:sp>
+      <p:sp>
+        <p:nvSpPr>
+          <p:cNvPr id="11" name="Rectangle 10"/>
+          <p:cNvSpPr/>
+          <p:nvPr/>
+        </p:nvSpPr>
+        <p:spPr>
+          <a:xfrm>
+            <a:off x="731520" y="2240279"/>
+            <a:ext cx="3200400" cy="411480"/>
+          </a:xfrm>
+          <a:prstGeom prst="rect">
+            <a:avLst/>
+          </a:prstGeom>
+          <a:solidFill>
+            <a:srgbClr val="FFFFFF"/>
+          </a:solidFill>
+          <a:ln w="25400">
+            <a:solidFill>
+              <a:srgbClr val="CCCCCC"/>
+            </a:solidFill>
+          </a:ln>
+        </p:spPr>
+        <p:style>
+          <a:lnRef idx="1">
+            <a:schemeClr val="accent1"/>
+          </a:lnRef>
+          <a:fillRef idx="3">
+            <a:schemeClr val="accent1"/>
+          </a:fillRef>
+          <a:effectRef idx="2">
+            <a:schemeClr val="accent1"/>
+          </a:effectRef>
+          <a:fontRef idx="minor">
+            <a:schemeClr val="lt1"/>
+          </a:fontRef>
+        </p:style>
+        <p:txBody>
+          <a:bodyPr rtlCol="0" anchor="ctr" wrap="square" lIns="63500" rIns="50800" tIns="38100" bIns="38100"/>
+          <a:lstStyle/>
+          <a:p>
+            <a:pPr algn="l"/>
+            <a:r>
+              <a:rPr sz="1000" b="1">
+                <a:solidFill>
+                  <a:srgbClr val="222222"/>
+                </a:solidFill>
+                <a:latin typeface="Meiryo"/>
+              </a:rPr>
+              <a:t>この攻撃のsetup.msi</a:t>
+            </a:r>
+          </a:p>
+        </p:txBody>
+      </p:sp>
+      <p:sp>
+        <p:nvSpPr>
+          <p:cNvPr id="12" name="Rectangle 11"/>
+          <p:cNvSpPr/>
+          <p:nvPr/>
+        </p:nvSpPr>
+        <p:spPr>
+          <a:xfrm>
+            <a:off x="3931920" y="2240279"/>
+            <a:ext cx="3657600" cy="411480"/>
+          </a:xfrm>
+          <a:prstGeom prst="rect">
+            <a:avLst/>
+          </a:prstGeom>
+          <a:solidFill>
+            <a:srgbClr val="FFFFFF"/>
+          </a:solidFill>
+          <a:ln w="25400">
+            <a:solidFill>
+              <a:srgbClr val="C0392B"/>
+            </a:solidFill>
+          </a:ln>
+        </p:spPr>
+        <p:style>
+          <a:lnRef idx="1">
+            <a:schemeClr val="accent1"/>
+          </a:lnRef>
+          <a:fillRef idx="3">
+            <a:schemeClr val="accent1"/>
+          </a:fillRef>
+          <a:effectRef idx="2">
+            <a:schemeClr val="accent1"/>
+          </a:effectRef>
+          <a:fontRef idx="minor">
+            <a:schemeClr val="lt1"/>
+          </a:fontRef>
+        </p:style>
+        <p:txBody>
+          <a:bodyPr rtlCol="0" anchor="ctr" wrap="square" lIns="63500" rIns="50800" tIns="38100" bIns="38100"/>
+          <a:lstStyle/>
+          <a:p>
+            <a:pPr algn="l"/>
+            <a:r>
+              <a:rPr sz="1000" b="1">
+                <a:solidFill>
+                  <a:srgbClr val="C0392B"/>
+                </a:solidFill>
+                <a:latin typeface="Meiryo"/>
+              </a:rPr>
+              <a:t>不明 ❌</a:t>
+            </a:r>
+          </a:p>
+        </p:txBody>
+      </p:sp>
+      <p:sp>
+        <p:nvSpPr>
+          <p:cNvPr id="13" name="Rectangle 12"/>
+          <p:cNvSpPr/>
+          <p:nvPr/>
+        </p:nvSpPr>
+        <p:spPr>
+          <a:xfrm>
+            <a:off x="7589520" y="2240279"/>
+            <a:ext cx="4572000" cy="411480"/>
+          </a:xfrm>
+          <a:prstGeom prst="rect">
+            <a:avLst/>
+          </a:prstGeom>
+          <a:solidFill>
+            <a:srgbClr val="FFFFFF"/>
+          </a:solidFill>
+          <a:ln w="25400">
+            <a:solidFill>
+              <a:srgbClr val="CCCCCC"/>
+            </a:solidFill>
+          </a:ln>
+        </p:spPr>
+        <p:style>
+          <a:lnRef idx="1">
+            <a:schemeClr val="accent1"/>
+          </a:lnRef>
+          <a:fillRef idx="3">
+            <a:schemeClr val="accent1"/>
+          </a:fillRef>
+          <a:effectRef idx="2">
+            <a:schemeClr val="accent1"/>
+          </a:effectRef>
+          <a:fontRef idx="minor">
+            <a:schemeClr val="lt1"/>
+          </a:fontRef>
+        </p:style>
+        <p:txBody>
+          <a:bodyPr rtlCol="0" anchor="ctr" wrap="square" lIns="63500" rIns="50800" tIns="38100" bIns="38100"/>
+          <a:lstStyle/>
+          <a:p>
+            <a:pPr algn="l"/>
+            <a:r>
+              <a:rPr sz="900" b="0">
+                <a:solidFill>
+                  <a:srgbClr val="222222"/>
+                </a:solidFill>
+                <a:latin typeface="Meiryo"/>
+              </a:rPr>
+              <a:t>署名なし＝誰が作ったか不明</a:t>
+            </a:r>
+          </a:p>
+        </p:txBody>
+      </p:sp>
+      <p:sp>
+        <p:nvSpPr>
+          <p:cNvPr id="14" name="Rectangle 13"/>
+          <p:cNvSpPr/>
+          <p:nvPr/>
+        </p:nvSpPr>
+        <p:spPr>
+          <a:xfrm>
+            <a:off x="731520" y="2743200"/>
+            <a:ext cx="13624560" cy="365760"/>
+          </a:xfrm>
+          <a:prstGeom prst="rect">
+            <a:avLst/>
+          </a:prstGeom>
+          <a:solidFill>
+            <a:srgbClr val="C0392B"/>
+          </a:solidFill>
+          <a:ln>
+            <a:noFill/>
+          </a:ln>
+        </p:spPr>
+        <p:style>
+          <a:lnRef idx="1">
+            <a:schemeClr val="accent1"/>
+          </a:lnRef>
+          <a:fillRef idx="3">
+            <a:schemeClr val="accent1"/>
+          </a:fillRef>
+          <a:effectRef idx="2">
+            <a:schemeClr val="accent1"/>
+          </a:effectRef>
+          <a:fontRef idx="minor">
+            <a:schemeClr val="lt1"/>
+          </a:fontRef>
+        </p:style>
+        <p:txBody>
+          <a:bodyPr rtlCol="0" anchor="ctr" wrap="square" lIns="50800" rIns="50800" tIns="25400" bIns="25400"/>
+          <a:lstStyle/>
+          <a:p>
+            <a:pPr algn="ctr"/>
+            <a:r>
+              <a:rPr sz="1200" b="1">
+                <a:solidFill>
+                  <a:srgbClr val="FFFFFF"/>
+                </a:solidFill>
+                <a:latin typeface="Meiryo"/>
+              </a:rPr>
+              <a:t>なぜ「極めつけ」か — 他の破綻ポイントとの比較</a:t>
+            </a:r>
+          </a:p>
+        </p:txBody>
+      </p:sp>
+      <p:sp>
+        <p:nvSpPr>
+          <p:cNvPr id="15" name="Rectangle 14"/>
+          <p:cNvSpPr/>
+          <p:nvPr/>
+        </p:nvSpPr>
+        <p:spPr>
+          <a:xfrm>
+            <a:off x="731520" y="3108960"/>
+            <a:ext cx="2743200" cy="384048"/>
+          </a:xfrm>
+          <a:prstGeom prst="rect">
+            <a:avLst/>
+          </a:prstGeom>
+          <a:solidFill>
+            <a:srgbClr val="FFFFFF"/>
+          </a:solidFill>
+          <a:ln w="25400">
+            <a:solidFill>
+              <a:srgbClr val="CCCCCC"/>
+            </a:solidFill>
+          </a:ln>
+        </p:spPr>
+        <p:style>
+          <a:lnRef idx="1">
+            <a:schemeClr val="accent1"/>
+          </a:lnRef>
+          <a:fillRef idx="3">
+            <a:schemeClr val="accent1"/>
+          </a:fillRef>
+          <a:effectRef idx="2">
+            <a:schemeClr val="accent1"/>
+          </a:effectRef>
+          <a:fontRef idx="minor">
+            <a:schemeClr val="lt1"/>
+          </a:fontRef>
+        </p:style>
+        <p:txBody>
+          <a:bodyPr rtlCol="0" anchor="ctr" wrap="square" lIns="63500" rIns="50800" tIns="38100" bIns="38100"/>
+          <a:lstStyle/>
+          <a:p>
+            <a:pPr algn="l"/>
+            <a:r>
+              <a:rPr sz="900" b="1">
+                <a:solidFill>
+                  <a:srgbClr val="222222"/>
+                </a:solidFill>
+                <a:latin typeface="Meiryo"/>
+              </a:rPr>
+              <a:t>③ メアドを聞く</a:t>
+            </a:r>
+          </a:p>
+        </p:txBody>
+      </p:sp>
+      <p:sp>
+        <p:nvSpPr>
+          <p:cNvPr id="16" name="Rectangle 15"/>
+          <p:cNvSpPr/>
+          <p:nvPr/>
+        </p:nvSpPr>
+        <p:spPr>
+          <a:xfrm>
+            <a:off x="3474720" y="3108960"/>
+            <a:ext cx="7772400" cy="384048"/>
+          </a:xfrm>
+          <a:prstGeom prst="rect">
+            <a:avLst/>
+          </a:prstGeom>
+          <a:solidFill>
+            <a:srgbClr val="FFFFFF"/>
+          </a:solidFill>
+          <a:ln w="25400">
+            <a:solidFill>
+              <a:srgbClr val="CCCCCC"/>
+            </a:solidFill>
+          </a:ln>
+        </p:spPr>
+        <p:style>
+          <a:lnRef idx="1">
+            <a:schemeClr val="accent1"/>
+          </a:lnRef>
+          <a:fillRef idx="3">
+            <a:schemeClr val="accent1"/>
+          </a:fillRef>
+          <a:effectRef idx="2">
+            <a:schemeClr val="accent1"/>
+          </a:effectRef>
+          <a:fontRef idx="minor">
+            <a:schemeClr val="lt1"/>
+          </a:fontRef>
+        </p:style>
+        <p:txBody>
+          <a:bodyPr rtlCol="0" anchor="ctr" wrap="square" lIns="63500" rIns="50800" tIns="38100" bIns="38100"/>
+          <a:lstStyle/>
+          <a:p>
+            <a:pPr algn="l"/>
+            <a:r>
+              <a:rPr sz="900" b="0">
+                <a:solidFill>
+                  <a:srgbClr val="222222"/>
+                </a:solidFill>
+                <a:latin typeface="Meiryo"/>
+              </a:rPr>
+              <a:t>BizSTATIONの契約プロセスを知っている必要</a:t>
+            </a:r>
+          </a:p>
+        </p:txBody>
+      </p:sp>
+      <p:sp>
+        <p:nvSpPr>
+          <p:cNvPr id="17" name="Rectangle 16"/>
+          <p:cNvSpPr/>
+          <p:nvPr/>
+        </p:nvSpPr>
+        <p:spPr>
+          <a:xfrm>
+            <a:off x="11247120" y="3108960"/>
+            <a:ext cx="3108960" cy="384048"/>
+          </a:xfrm>
+          <a:prstGeom prst="rect">
+            <a:avLst/>
+          </a:prstGeom>
+          <a:solidFill>
+            <a:srgbClr val="FFFFFF"/>
+          </a:solidFill>
+          <a:ln>
+            <a:noFill/>
+          </a:ln>
+        </p:spPr>
+        <p:style>
+          <a:lnRef idx="1">
+            <a:schemeClr val="accent1"/>
+          </a:lnRef>
+          <a:fillRef idx="3">
+            <a:schemeClr val="accent1"/>
+          </a:fillRef>
+          <a:effectRef idx="2">
+            <a:schemeClr val="accent1"/>
+          </a:effectRef>
+          <a:fontRef idx="minor">
+            <a:schemeClr val="lt1"/>
+          </a:fontRef>
+        </p:style>
+        <p:txBody>
+          <a:bodyPr rtlCol="0" anchor="ctr" wrap="square" lIns="50800" rIns="50800" tIns="25400" bIns="25400"/>
+          <a:lstStyle/>
+          <a:p>
+            <a:pPr algn="ctr"/>
+            <a:r>
+              <a:rPr sz="900" b="0">
+                <a:solidFill>
+                  <a:srgbClr val="222222"/>
+                </a:solidFill>
+                <a:latin typeface="Meiryo"/>
+              </a:rPr>
+              <a:t>知識が必要</a:t>
+            </a:r>
+          </a:p>
+        </p:txBody>
+      </p:sp>
+      <p:sp>
+        <p:nvSpPr>
+          <p:cNvPr id="18" name="Rectangle 17"/>
+          <p:cNvSpPr/>
+          <p:nvPr/>
+        </p:nvSpPr>
+        <p:spPr>
+          <a:xfrm>
+            <a:off x="731520" y="3493008"/>
+            <a:ext cx="2743200" cy="384048"/>
+          </a:xfrm>
+          <a:prstGeom prst="rect">
+            <a:avLst/>
+          </a:prstGeom>
+          <a:solidFill>
+            <a:srgbClr val="F9F9F9"/>
+          </a:solidFill>
+          <a:ln w="25400">
+            <a:solidFill>
+              <a:srgbClr val="CCCCCC"/>
+            </a:solidFill>
+          </a:ln>
+        </p:spPr>
+        <p:style>
+          <a:lnRef idx="1">
+            <a:schemeClr val="accent1"/>
+          </a:lnRef>
+          <a:fillRef idx="3">
+            <a:schemeClr val="accent1"/>
+          </a:fillRef>
+          <a:effectRef idx="2">
+            <a:schemeClr val="accent1"/>
+          </a:effectRef>
+          <a:fontRef idx="minor">
+            <a:schemeClr val="lt1"/>
+          </a:fontRef>
+        </p:style>
+        <p:txBody>
+          <a:bodyPr rtlCol="0" anchor="ctr" wrap="square" lIns="63500" rIns="50800" tIns="38100" bIns="38100"/>
+          <a:lstStyle/>
+          <a:p>
+            <a:pPr algn="l"/>
+            <a:r>
+              <a:rPr sz="900" b="1">
+                <a:solidFill>
+                  <a:srgbClr val="222222"/>
+                </a:solidFill>
+                <a:latin typeface="Meiryo"/>
+              </a:rPr>
+              <a:t>④ 迷惑フォルダを見て</a:t>
+            </a:r>
+          </a:p>
+        </p:txBody>
+      </p:sp>
+      <p:sp>
+        <p:nvSpPr>
+          <p:cNvPr id="19" name="Rectangle 18"/>
+          <p:cNvSpPr/>
+          <p:nvPr/>
+        </p:nvSpPr>
+        <p:spPr>
+          <a:xfrm>
+            <a:off x="3474720" y="3493008"/>
+            <a:ext cx="7772400" cy="384048"/>
+          </a:xfrm>
+          <a:prstGeom prst="rect">
+            <a:avLst/>
+          </a:prstGeom>
+          <a:solidFill>
+            <a:srgbClr val="F9F9F9"/>
+          </a:solidFill>
+          <a:ln w="25400">
+            <a:solidFill>
+              <a:srgbClr val="CCCCCC"/>
+            </a:solidFill>
+          </a:ln>
+        </p:spPr>
+        <p:style>
+          <a:lnRef idx="1">
+            <a:schemeClr val="accent1"/>
+          </a:lnRef>
+          <a:fillRef idx="3">
+            <a:schemeClr val="accent1"/>
+          </a:fillRef>
+          <a:effectRef idx="2">
+            <a:schemeClr val="accent1"/>
+          </a:effectRef>
+          <a:fontRef idx="minor">
+            <a:schemeClr val="lt1"/>
+          </a:fontRef>
+        </p:style>
+        <p:txBody>
+          <a:bodyPr rtlCol="0" anchor="ctr" wrap="square" lIns="63500" rIns="50800" tIns="38100" bIns="38100"/>
+          <a:lstStyle/>
+          <a:p>
+            <a:pPr algn="l"/>
+            <a:r>
+              <a:rPr sz="900" b="0">
+                <a:solidFill>
+                  <a:srgbClr val="222222"/>
+                </a:solidFill>
+                <a:latin typeface="Meiryo"/>
+              </a:rPr>
+              <a:t>メール認証の仕組みを知っている必要</a:t>
+            </a:r>
+          </a:p>
+        </p:txBody>
+      </p:sp>
+      <p:sp>
+        <p:nvSpPr>
+          <p:cNvPr id="20" name="Rectangle 19"/>
+          <p:cNvSpPr/>
+          <p:nvPr/>
+        </p:nvSpPr>
+        <p:spPr>
+          <a:xfrm>
+            <a:off x="11247120" y="3493008"/>
+            <a:ext cx="3108960" cy="384048"/>
+          </a:xfrm>
+          <a:prstGeom prst="rect">
+            <a:avLst/>
+          </a:prstGeom>
+          <a:solidFill>
+            <a:srgbClr val="F9F9F9"/>
+          </a:solidFill>
+          <a:ln>
+            <a:noFill/>
+          </a:ln>
+        </p:spPr>
+        <p:style>
+          <a:lnRef idx="1">
+            <a:schemeClr val="accent1"/>
+          </a:lnRef>
+          <a:fillRef idx="3">
+            <a:schemeClr val="accent1"/>
+          </a:fillRef>
+          <a:effectRef idx="2">
+            <a:schemeClr val="accent1"/>
+          </a:effectRef>
+          <a:fontRef idx="minor">
+            <a:schemeClr val="lt1"/>
+          </a:fontRef>
+        </p:style>
+        <p:txBody>
+          <a:bodyPr rtlCol="0" anchor="ctr" wrap="square" lIns="50800" rIns="50800" tIns="25400" bIns="25400"/>
+          <a:lstStyle/>
+          <a:p>
+            <a:pPr algn="ctr"/>
+            <a:r>
+              <a:rPr sz="900" b="0">
+                <a:solidFill>
+                  <a:srgbClr val="222222"/>
+                </a:solidFill>
+                <a:latin typeface="Meiryo"/>
+              </a:rPr>
+              <a:t>知識が必要</a:t>
+            </a:r>
+          </a:p>
+        </p:txBody>
+      </p:sp>
+      <p:sp>
+        <p:nvSpPr>
+          <p:cNvPr id="21" name="Rectangle 20"/>
+          <p:cNvSpPr/>
+          <p:nvPr/>
+        </p:nvSpPr>
+        <p:spPr>
+          <a:xfrm>
+            <a:off x="731520" y="3877056"/>
+            <a:ext cx="2743200" cy="384048"/>
+          </a:xfrm>
+          <a:prstGeom prst="rect">
+            <a:avLst/>
+          </a:prstGeom>
+          <a:solidFill>
+            <a:srgbClr val="FFFFFF"/>
+          </a:solidFill>
+          <a:ln w="25400">
+            <a:solidFill>
+              <a:srgbClr val="CCCCCC"/>
+            </a:solidFill>
+          </a:ln>
+        </p:spPr>
+        <p:style>
+          <a:lnRef idx="1">
+            <a:schemeClr val="accent1"/>
+          </a:lnRef>
+          <a:fillRef idx="3">
+            <a:schemeClr val="accent1"/>
+          </a:fillRef>
+          <a:effectRef idx="2">
+            <a:schemeClr val="accent1"/>
+          </a:effectRef>
+          <a:fontRef idx="minor">
+            <a:schemeClr val="lt1"/>
+          </a:fontRef>
+        </p:style>
+        <p:txBody>
+          <a:bodyPr rtlCol="0" anchor="ctr" wrap="square" lIns="63500" rIns="50800" tIns="38100" bIns="38100"/>
+          <a:lstStyle/>
+          <a:p>
+            <a:pPr algn="l"/>
+            <a:r>
+              <a:rPr sz="900" b="1">
+                <a:solidFill>
+                  <a:srgbClr val="222222"/>
+                </a:solidFill>
+                <a:latin typeface="Meiryo"/>
+              </a:rPr>
+              <a:t>⑤ メールにURLリンク</a:t>
+            </a:r>
+          </a:p>
+        </p:txBody>
+      </p:sp>
+      <p:sp>
+        <p:nvSpPr>
+          <p:cNvPr id="22" name="Rectangle 21"/>
+          <p:cNvSpPr/>
+          <p:nvPr/>
+        </p:nvSpPr>
+        <p:spPr>
+          <a:xfrm>
+            <a:off x="3474720" y="3877056"/>
+            <a:ext cx="7772400" cy="384048"/>
+          </a:xfrm>
+          <a:prstGeom prst="rect">
+            <a:avLst/>
+          </a:prstGeom>
+          <a:solidFill>
+            <a:srgbClr val="FFFFFF"/>
+          </a:solidFill>
+          <a:ln w="25400">
+            <a:solidFill>
+              <a:srgbClr val="CCCCCC"/>
+            </a:solidFill>
+          </a:ln>
+        </p:spPr>
+        <p:style>
+          <a:lnRef idx="1">
+            <a:schemeClr val="accent1"/>
+          </a:lnRef>
+          <a:fillRef idx="3">
+            <a:schemeClr val="accent1"/>
+          </a:fillRef>
+          <a:effectRef idx="2">
+            <a:schemeClr val="accent1"/>
+          </a:effectRef>
+          <a:fontRef idx="minor">
+            <a:schemeClr val="lt1"/>
+          </a:fontRef>
+        </p:style>
+        <p:txBody>
+          <a:bodyPr rtlCol="0" anchor="ctr" wrap="square" lIns="63500" rIns="50800" tIns="38100" bIns="38100"/>
+          <a:lstStyle/>
+          <a:p>
+            <a:pPr algn="l"/>
+            <a:r>
+              <a:rPr sz="900" b="0">
+                <a:solidFill>
+                  <a:srgbClr val="222222"/>
+                </a:solidFill>
+                <a:latin typeface="Meiryo"/>
+              </a:rPr>
+              <a:t>金融庁の方針を知っている必要</a:t>
+            </a:r>
+          </a:p>
+        </p:txBody>
+      </p:sp>
+      <p:sp>
+        <p:nvSpPr>
+          <p:cNvPr id="23" name="Rectangle 22"/>
+          <p:cNvSpPr/>
+          <p:nvPr/>
+        </p:nvSpPr>
+        <p:spPr>
+          <a:xfrm>
+            <a:off x="11247120" y="3877056"/>
+            <a:ext cx="3108960" cy="384048"/>
+          </a:xfrm>
+          <a:prstGeom prst="rect">
+            <a:avLst/>
+          </a:prstGeom>
+          <a:solidFill>
+            <a:srgbClr val="FFFFFF"/>
+          </a:solidFill>
+          <a:ln>
+            <a:noFill/>
+          </a:ln>
+        </p:spPr>
+        <p:style>
+          <a:lnRef idx="1">
+            <a:schemeClr val="accent1"/>
+          </a:lnRef>
+          <a:fillRef idx="3">
+            <a:schemeClr val="accent1"/>
+          </a:fillRef>
+          <a:effectRef idx="2">
+            <a:schemeClr val="accent1"/>
+          </a:effectRef>
+          <a:fontRef idx="minor">
+            <a:schemeClr val="lt1"/>
+          </a:fontRef>
+        </p:style>
+        <p:txBody>
+          <a:bodyPr rtlCol="0" anchor="ctr" wrap="square" lIns="50800" rIns="50800" tIns="25400" bIns="25400"/>
+          <a:lstStyle/>
+          <a:p>
+            <a:pPr algn="ctr"/>
+            <a:r>
+              <a:rPr sz="900" b="0">
+                <a:solidFill>
+                  <a:srgbClr val="222222"/>
+                </a:solidFill>
+                <a:latin typeface="Meiryo"/>
+              </a:rPr>
+              <a:t>知識が必要</a:t>
+            </a:r>
+          </a:p>
+        </p:txBody>
+      </p:sp>
+      <p:sp>
+        <p:nvSpPr>
+          <p:cNvPr id="24" name="Rectangle 23"/>
+          <p:cNvSpPr/>
+          <p:nvPr/>
+        </p:nvSpPr>
+        <p:spPr>
+          <a:xfrm>
+            <a:off x="731520" y="4261104"/>
+            <a:ext cx="2743200" cy="384048"/>
+          </a:xfrm>
+          <a:prstGeom prst="rect">
+            <a:avLst/>
+          </a:prstGeom>
+          <a:solidFill>
+            <a:srgbClr val="F9F9F9"/>
+          </a:solidFill>
+          <a:ln w="25400">
+            <a:solidFill>
+              <a:srgbClr val="CCCCCC"/>
+            </a:solidFill>
+          </a:ln>
+        </p:spPr>
+        <p:style>
+          <a:lnRef idx="1">
+            <a:schemeClr val="accent1"/>
+          </a:lnRef>
+          <a:fillRef idx="3">
+            <a:schemeClr val="accent1"/>
+          </a:fillRef>
+          <a:effectRef idx="2">
+            <a:schemeClr val="accent1"/>
+          </a:effectRef>
+          <a:fontRef idx="minor">
+            <a:schemeClr val="lt1"/>
+          </a:fontRef>
+        </p:style>
+        <p:txBody>
+          <a:bodyPr rtlCol="0" anchor="ctr" wrap="square" lIns="63500" rIns="50800" tIns="38100" bIns="38100"/>
+          <a:lstStyle/>
+          <a:p>
+            <a:pPr algn="l"/>
+            <a:r>
+              <a:rPr sz="900" b="1">
+                <a:solidFill>
+                  <a:srgbClr val="222222"/>
+                </a:solidFill>
+                <a:latin typeface="Meiryo"/>
+              </a:rPr>
+              <a:t>⑥ 「不明な発行元」</a:t>
+            </a:r>
+          </a:p>
+        </p:txBody>
+      </p:sp>
+      <p:sp>
+        <p:nvSpPr>
+          <p:cNvPr id="25" name="Rectangle 24"/>
+          <p:cNvSpPr/>
+          <p:nvPr/>
+        </p:nvSpPr>
+        <p:spPr>
+          <a:xfrm>
+            <a:off x="3474720" y="4261104"/>
+            <a:ext cx="7772400" cy="384048"/>
+          </a:xfrm>
+          <a:prstGeom prst="rect">
+            <a:avLst/>
+          </a:prstGeom>
+          <a:solidFill>
+            <a:srgbClr val="F9F9F9"/>
+          </a:solidFill>
+          <a:ln w="25400">
+            <a:solidFill>
+              <a:srgbClr val="CCCCCC"/>
+            </a:solidFill>
+          </a:ln>
+        </p:spPr>
+        <p:style>
+          <a:lnRef idx="1">
+            <a:schemeClr val="accent1"/>
+          </a:lnRef>
+          <a:fillRef idx="3">
+            <a:schemeClr val="accent1"/>
+          </a:fillRef>
+          <a:effectRef idx="2">
+            <a:schemeClr val="accent1"/>
+          </a:effectRef>
+          <a:fontRef idx="minor">
+            <a:schemeClr val="lt1"/>
+          </a:fontRef>
+        </p:style>
+        <p:txBody>
+          <a:bodyPr rtlCol="0" anchor="ctr" wrap="square" lIns="63500" rIns="50800" tIns="38100" bIns="38100"/>
+          <a:lstStyle/>
+          <a:p>
+            <a:pPr algn="l"/>
+            <a:r>
+              <a:rPr sz="900" b="0">
+                <a:solidFill>
+                  <a:srgbClr val="222222"/>
+                </a:solidFill>
+                <a:latin typeface="Meiryo"/>
+              </a:rPr>
+              <a:t>画面に書いてある。知識不要。誰でも読める。</a:t>
+            </a:r>
+          </a:p>
+        </p:txBody>
+      </p:sp>
+      <p:sp>
+        <p:nvSpPr>
+          <p:cNvPr id="26" name="Rectangle 25"/>
+          <p:cNvSpPr/>
+          <p:nvPr/>
+        </p:nvSpPr>
+        <p:spPr>
+          <a:xfrm>
+            <a:off x="11247120" y="4261104"/>
+            <a:ext cx="3108960" cy="384048"/>
+          </a:xfrm>
+          <a:prstGeom prst="rect">
+            <a:avLst/>
+          </a:prstGeom>
+          <a:solidFill>
+            <a:srgbClr val="C0392B"/>
+          </a:solidFill>
+          <a:ln>
+            <a:noFill/>
+          </a:ln>
+        </p:spPr>
+        <p:style>
+          <a:lnRef idx="1">
+            <a:schemeClr val="accent1"/>
+          </a:lnRef>
+          <a:fillRef idx="3">
+            <a:schemeClr val="accent1"/>
+          </a:fillRef>
+          <a:effectRef idx="2">
+            <a:schemeClr val="accent1"/>
+          </a:effectRef>
+          <a:fontRef idx="minor">
+            <a:schemeClr val="lt1"/>
+          </a:fontRef>
+        </p:style>
+        <p:txBody>
+          <a:bodyPr rtlCol="0" anchor="ctr" wrap="square" lIns="50800" rIns="50800" tIns="25400" bIns="25400"/>
+          <a:lstStyle/>
+          <a:p>
+            <a:pPr algn="ctr"/>
+            <a:r>
+              <a:rPr sz="900" b="1">
+                <a:solidFill>
+                  <a:srgbClr val="FFFFFF"/>
+                </a:solidFill>
+                <a:latin typeface="Meiryo"/>
+              </a:rPr>
+              <a:t>知識不要 ★</a:t>
+            </a:r>
+          </a:p>
+        </p:txBody>
+      </p:sp>
+      <p:sp>
+        <p:nvSpPr>
+          <p:cNvPr id="27" name="Rectangle 26"/>
+          <p:cNvSpPr/>
+          <p:nvPr/>
+        </p:nvSpPr>
+        <p:spPr>
+          <a:xfrm>
+            <a:off x="731520" y="4754880"/>
+            <a:ext cx="13624560" cy="365760"/>
+          </a:xfrm>
+          <a:prstGeom prst="rect">
+            <a:avLst/>
+          </a:prstGeom>
+          <a:solidFill>
+            <a:srgbClr val="E67E22"/>
+          </a:solidFill>
+          <a:ln>
+            <a:noFill/>
+          </a:ln>
+        </p:spPr>
+        <p:style>
+          <a:lnRef idx="1">
+            <a:schemeClr val="accent1"/>
+          </a:lnRef>
+          <a:fillRef idx="3">
+            <a:schemeClr val="accent1"/>
+          </a:fillRef>
+          <a:effectRef idx="2">
+            <a:schemeClr val="accent1"/>
+          </a:effectRef>
+          <a:fontRef idx="minor">
+            <a:schemeClr val="lt1"/>
+          </a:fontRef>
+        </p:style>
+        <p:txBody>
+          <a:bodyPr rtlCol="0" anchor="ctr" wrap="square" lIns="50800" rIns="50800" tIns="25400" bIns="25400"/>
+          <a:lstStyle/>
+          <a:p>
+            <a:pPr algn="ctr"/>
+            <a:r>
+              <a:rPr sz="1200" b="1">
+                <a:solidFill>
+                  <a:srgbClr val="FFFFFF"/>
+                </a:solidFill>
+                <a:latin typeface="Meiryo"/>
+              </a:rPr>
+              <a:t>しかし犯人がレベルアップすれば「不明な発行元」は消せる</a:t>
+            </a:r>
+          </a:p>
+        </p:txBody>
+      </p:sp>
+      <p:sp>
+        <p:nvSpPr>
+          <p:cNvPr id="28" name="Rectangle 27"/>
+          <p:cNvSpPr/>
+          <p:nvPr/>
+        </p:nvSpPr>
+        <p:spPr>
+          <a:xfrm>
+            <a:off x="731520" y="5120640"/>
+            <a:ext cx="3200400" cy="365760"/>
+          </a:xfrm>
+          <a:prstGeom prst="rect">
+            <a:avLst/>
+          </a:prstGeom>
+          <a:solidFill>
+            <a:srgbClr val="FFFFFF"/>
+          </a:solidFill>
+          <a:ln w="25400">
+            <a:solidFill>
+              <a:srgbClr val="CCCCCC"/>
+            </a:solidFill>
+          </a:ln>
+        </p:spPr>
+        <p:style>
+          <a:lnRef idx="1">
+            <a:schemeClr val="accent1"/>
+          </a:lnRef>
+          <a:fillRef idx="3">
+            <a:schemeClr val="accent1"/>
+          </a:fillRef>
+          <a:effectRef idx="2">
+            <a:schemeClr val="accent1"/>
+          </a:effectRef>
+          <a:fontRef idx="minor">
+            <a:schemeClr val="lt1"/>
+          </a:fontRef>
+        </p:style>
+        <p:txBody>
+          <a:bodyPr rtlCol="0" anchor="ctr" wrap="square" lIns="63500" rIns="50800" tIns="38100" bIns="38100"/>
+          <a:lstStyle/>
+          <a:p>
+            <a:pPr algn="l"/>
+            <a:r>
+              <a:rPr sz="900" b="1">
+                <a:solidFill>
+                  <a:srgbClr val="222222"/>
+                </a:solidFill>
+                <a:latin typeface="Meiryo"/>
+              </a:rPr>
+              <a:t>証明書なし（現状）</a:t>
+            </a:r>
+          </a:p>
+        </p:txBody>
+      </p:sp>
+      <p:sp>
+        <p:nvSpPr>
+          <p:cNvPr id="29" name="Rectangle 28"/>
+          <p:cNvSpPr/>
+          <p:nvPr/>
+        </p:nvSpPr>
+        <p:spPr>
+          <a:xfrm>
+            <a:off x="3931920" y="5120640"/>
+            <a:ext cx="5029200" cy="365760"/>
+          </a:xfrm>
+          <a:prstGeom prst="rect">
+            <a:avLst/>
+          </a:prstGeom>
+          <a:solidFill>
+            <a:srgbClr val="FFFFFF"/>
+          </a:solidFill>
+          <a:ln w="25400">
+            <a:solidFill>
+              <a:srgbClr val="CCCCCC"/>
+            </a:solidFill>
+          </a:ln>
+        </p:spPr>
+        <p:style>
+          <a:lnRef idx="1">
+            <a:schemeClr val="accent1"/>
+          </a:lnRef>
+          <a:fillRef idx="3">
+            <a:schemeClr val="accent1"/>
+          </a:fillRef>
+          <a:effectRef idx="2">
+            <a:schemeClr val="accent1"/>
+          </a:effectRef>
+          <a:fontRef idx="minor">
+            <a:schemeClr val="lt1"/>
+          </a:fontRef>
+        </p:style>
+        <p:txBody>
+          <a:bodyPr rtlCol="0" anchor="ctr" wrap="square" lIns="63500" rIns="50800" tIns="38100" bIns="38100"/>
+          <a:lstStyle/>
+          <a:p>
+            <a:pPr algn="l"/>
+            <a:r>
+              <a:rPr sz="900" b="0">
+                <a:solidFill>
+                  <a:srgbClr val="222222"/>
+                </a:solidFill>
+                <a:latin typeface="Meiryo"/>
+              </a:rPr>
+              <a:t>「不明な発行元」</a:t>
+            </a:r>
+          </a:p>
+        </p:txBody>
+      </p:sp>
+      <p:sp>
+        <p:nvSpPr>
+          <p:cNvPr id="30" name="Rectangle 29"/>
+          <p:cNvSpPr/>
+          <p:nvPr/>
+        </p:nvSpPr>
+        <p:spPr>
+          <a:xfrm>
+            <a:off x="8961120" y="5120640"/>
+            <a:ext cx="1828800" cy="365760"/>
+          </a:xfrm>
+          <a:prstGeom prst="rect">
+            <a:avLst/>
+          </a:prstGeom>
+          <a:solidFill>
+            <a:srgbClr val="C0392B"/>
+          </a:solidFill>
+          <a:ln>
+            <a:noFill/>
+          </a:ln>
+        </p:spPr>
+        <p:style>
+          <a:lnRef idx="1">
+            <a:schemeClr val="accent1"/>
+          </a:lnRef>
+          <a:fillRef idx="3">
+            <a:schemeClr val="accent1"/>
+          </a:fillRef>
+          <a:effectRef idx="2">
+            <a:schemeClr val="accent1"/>
+          </a:effectRef>
+          <a:fontRef idx="minor">
+            <a:schemeClr val="lt1"/>
+          </a:fontRef>
+        </p:style>
+        <p:txBody>
+          <a:bodyPr rtlCol="0" anchor="ctr" wrap="square" lIns="50800" rIns="50800" tIns="25400" bIns="25400"/>
+          <a:lstStyle/>
+          <a:p>
+            <a:pPr algn="ctr"/>
+            <a:r>
+              <a:rPr sz="900" b="1">
+                <a:solidFill>
+                  <a:srgbClr val="FFFFFF"/>
+                </a:solidFill>
+                <a:latin typeface="Meiryo"/>
+              </a:rPr>
+              <a:t>簡単</a:t>
+            </a:r>
+          </a:p>
+        </p:txBody>
+      </p:sp>
+      <p:sp>
+        <p:nvSpPr>
+          <p:cNvPr id="31" name="Rectangle 30"/>
+          <p:cNvSpPr/>
+          <p:nvPr/>
+        </p:nvSpPr>
+        <p:spPr>
+          <a:xfrm>
+            <a:off x="731520" y="5486400"/>
+            <a:ext cx="3200400" cy="365760"/>
+          </a:xfrm>
+          <a:prstGeom prst="rect">
+            <a:avLst/>
+          </a:prstGeom>
+          <a:solidFill>
+            <a:srgbClr val="F9F9F9"/>
+          </a:solidFill>
+          <a:ln w="25400">
+            <a:solidFill>
+              <a:srgbClr val="CCCCCC"/>
+            </a:solidFill>
+          </a:ln>
+        </p:spPr>
+        <p:style>
+          <a:lnRef idx="1">
+            <a:schemeClr val="accent1"/>
+          </a:lnRef>
+          <a:fillRef idx="3">
+            <a:schemeClr val="accent1"/>
+          </a:fillRef>
+          <a:effectRef idx="2">
+            <a:schemeClr val="accent1"/>
+          </a:effectRef>
+          <a:fontRef idx="minor">
+            <a:schemeClr val="lt1"/>
+          </a:fontRef>
+        </p:style>
+        <p:txBody>
+          <a:bodyPr rtlCol="0" anchor="ctr" wrap="square" lIns="63500" rIns="50800" tIns="38100" bIns="38100"/>
+          <a:lstStyle/>
+          <a:p>
+            <a:pPr algn="l"/>
+            <a:r>
+              <a:rPr sz="900" b="1">
+                <a:solidFill>
+                  <a:srgbClr val="222222"/>
+                </a:solidFill>
+                <a:latin typeface="Meiryo"/>
+              </a:rPr>
+              <a:t>自己署名証明書</a:t>
+            </a:r>
+          </a:p>
+        </p:txBody>
+      </p:sp>
+      <p:sp>
+        <p:nvSpPr>
+          <p:cNvPr id="32" name="Rectangle 31"/>
+          <p:cNvSpPr/>
+          <p:nvPr/>
+        </p:nvSpPr>
+        <p:spPr>
+          <a:xfrm>
+            <a:off x="3931920" y="5486400"/>
+            <a:ext cx="5029200" cy="365760"/>
+          </a:xfrm>
+          <a:prstGeom prst="rect">
+            <a:avLst/>
+          </a:prstGeom>
+          <a:solidFill>
+            <a:srgbClr val="F9F9F9"/>
+          </a:solidFill>
+          <a:ln w="25400">
+            <a:solidFill>
+              <a:srgbClr val="CCCCCC"/>
+            </a:solidFill>
+          </a:ln>
+        </p:spPr>
+        <p:style>
+          <a:lnRef idx="1">
+            <a:schemeClr val="accent1"/>
+          </a:lnRef>
+          <a:fillRef idx="3">
+            <a:schemeClr val="accent1"/>
+          </a:fillRef>
+          <a:effectRef idx="2">
+            <a:schemeClr val="accent1"/>
+          </a:effectRef>
+          <a:fontRef idx="minor">
+            <a:schemeClr val="lt1"/>
+          </a:fontRef>
+        </p:style>
+        <p:txBody>
+          <a:bodyPr rtlCol="0" anchor="ctr" wrap="square" lIns="63500" rIns="50800" tIns="38100" bIns="38100"/>
+          <a:lstStyle/>
+          <a:p>
+            <a:pPr algn="l"/>
+            <a:r>
+              <a:rPr sz="900" b="0">
+                <a:solidFill>
+                  <a:srgbClr val="222222"/>
+                </a:solidFill>
+                <a:latin typeface="Meiryo"/>
+              </a:rPr>
+              <a:t>「不明な発行元」のまま</a:t>
+            </a:r>
+          </a:p>
+        </p:txBody>
+      </p:sp>
+      <p:sp>
+        <p:nvSpPr>
+          <p:cNvPr id="33" name="Rectangle 32"/>
+          <p:cNvSpPr/>
+          <p:nvPr/>
+        </p:nvSpPr>
+        <p:spPr>
+          <a:xfrm>
+            <a:off x="8961120" y="5486400"/>
+            <a:ext cx="1828800" cy="365760"/>
+          </a:xfrm>
+          <a:prstGeom prst="rect">
+            <a:avLst/>
+          </a:prstGeom>
+          <a:solidFill>
+            <a:srgbClr val="C0392B"/>
+          </a:solidFill>
+          <a:ln>
+            <a:noFill/>
+          </a:ln>
+        </p:spPr>
+        <p:style>
+          <a:lnRef idx="1">
+            <a:schemeClr val="accent1"/>
+          </a:lnRef>
+          <a:fillRef idx="3">
+            <a:schemeClr val="accent1"/>
+          </a:fillRef>
+          <a:effectRef idx="2">
+            <a:schemeClr val="accent1"/>
+          </a:effectRef>
+          <a:fontRef idx="minor">
+            <a:schemeClr val="lt1"/>
+          </a:fontRef>
+        </p:style>
+        <p:txBody>
+          <a:bodyPr rtlCol="0" anchor="ctr" wrap="square" lIns="50800" rIns="50800" tIns="25400" bIns="25400"/>
+          <a:lstStyle/>
+          <a:p>
+            <a:pPr algn="ctr"/>
+            <a:r>
+              <a:rPr sz="900" b="1">
+                <a:solidFill>
+                  <a:srgbClr val="FFFFFF"/>
+                </a:solidFill>
+                <a:latin typeface="Meiryo"/>
+              </a:rPr>
+              <a:t>簡単</a:t>
+            </a:r>
+          </a:p>
+        </p:txBody>
+      </p:sp>
+      <p:sp>
+        <p:nvSpPr>
+          <p:cNvPr id="34" name="Rectangle 33"/>
+          <p:cNvSpPr/>
+          <p:nvPr/>
+        </p:nvSpPr>
+        <p:spPr>
+          <a:xfrm>
+            <a:off x="731520" y="5852160"/>
+            <a:ext cx="3200400" cy="365760"/>
+          </a:xfrm>
+          <a:prstGeom prst="rect">
+            <a:avLst/>
+          </a:prstGeom>
+          <a:solidFill>
+            <a:srgbClr val="FFFFFF"/>
+          </a:solidFill>
+          <a:ln w="25400">
+            <a:solidFill>
+              <a:srgbClr val="CCCCCC"/>
+            </a:solidFill>
+          </a:ln>
+        </p:spPr>
+        <p:style>
+          <a:lnRef idx="1">
+            <a:schemeClr val="accent1"/>
+          </a:lnRef>
+          <a:fillRef idx="3">
+            <a:schemeClr val="accent1"/>
+          </a:fillRef>
+          <a:effectRef idx="2">
+            <a:schemeClr val="accent1"/>
+          </a:effectRef>
+          <a:fontRef idx="minor">
+            <a:schemeClr val="lt1"/>
+          </a:fontRef>
+        </p:style>
+        <p:txBody>
+          <a:bodyPr rtlCol="0" anchor="ctr" wrap="square" lIns="63500" rIns="50800" tIns="38100" bIns="38100"/>
+          <a:lstStyle/>
+          <a:p>
+            <a:pPr algn="l"/>
+            <a:r>
+              <a:rPr sz="900" b="1">
+                <a:solidFill>
+                  <a:srgbClr val="222222"/>
+                </a:solidFill>
+                <a:latin typeface="Meiryo"/>
+              </a:rPr>
+              <a:t>偽会社名でCA購入</a:t>
+            </a:r>
+          </a:p>
+        </p:txBody>
+      </p:sp>
+      <p:sp>
+        <p:nvSpPr>
+          <p:cNvPr id="35" name="Rectangle 34"/>
+          <p:cNvSpPr/>
+          <p:nvPr/>
+        </p:nvSpPr>
+        <p:spPr>
+          <a:xfrm>
+            <a:off x="3931920" y="5852160"/>
+            <a:ext cx="5029200" cy="365760"/>
+          </a:xfrm>
+          <a:prstGeom prst="rect">
+            <a:avLst/>
+          </a:prstGeom>
+          <a:solidFill>
+            <a:srgbClr val="FFFFFF"/>
+          </a:solidFill>
+          <a:ln w="25400">
+            <a:solidFill>
+              <a:srgbClr val="CCCCCC"/>
+            </a:solidFill>
+          </a:ln>
+        </p:spPr>
+        <p:style>
+          <a:lnRef idx="1">
+            <a:schemeClr val="accent1"/>
+          </a:lnRef>
+          <a:fillRef idx="3">
+            <a:schemeClr val="accent1"/>
+          </a:fillRef>
+          <a:effectRef idx="2">
+            <a:schemeClr val="accent1"/>
+          </a:effectRef>
+          <a:fontRef idx="minor">
+            <a:schemeClr val="lt1"/>
+          </a:fontRef>
+        </p:style>
+        <p:txBody>
+          <a:bodyPr rtlCol="0" anchor="ctr" wrap="square" lIns="63500" rIns="50800" tIns="38100" bIns="38100"/>
+          <a:lstStyle/>
+          <a:p>
+            <a:pPr algn="l"/>
+            <a:r>
+              <a:rPr sz="900" b="0">
+                <a:solidFill>
+                  <a:srgbClr val="222222"/>
+                </a:solidFill>
+                <a:latin typeface="Meiryo"/>
+              </a:rPr>
+              <a:t>「MUFGセキュリティ(株)」等が表示</a:t>
+            </a:r>
+          </a:p>
+        </p:txBody>
+      </p:sp>
+      <p:sp>
+        <p:nvSpPr>
+          <p:cNvPr id="36" name="Rectangle 35"/>
+          <p:cNvSpPr/>
+          <p:nvPr/>
+        </p:nvSpPr>
+        <p:spPr>
+          <a:xfrm>
+            <a:off x="8961120" y="5852160"/>
+            <a:ext cx="1828800" cy="365760"/>
+          </a:xfrm>
+          <a:prstGeom prst="rect">
+            <a:avLst/>
+          </a:prstGeom>
+          <a:solidFill>
+            <a:srgbClr val="E67E22"/>
+          </a:solidFill>
+          <a:ln>
+            <a:noFill/>
+          </a:ln>
+        </p:spPr>
+        <p:style>
+          <a:lnRef idx="1">
+            <a:schemeClr val="accent1"/>
+          </a:lnRef>
+          <a:fillRef idx="3">
+            <a:schemeClr val="accent1"/>
+          </a:fillRef>
+          <a:effectRef idx="2">
+            <a:schemeClr val="accent1"/>
+          </a:effectRef>
+          <a:fontRef idx="minor">
+            <a:schemeClr val="lt1"/>
+          </a:fontRef>
+        </p:style>
+        <p:txBody>
+          <a:bodyPr rtlCol="0" anchor="ctr" wrap="square" lIns="50800" rIns="50800" tIns="25400" bIns="25400"/>
+          <a:lstStyle/>
+          <a:p>
+            <a:pPr algn="ctr"/>
+            <a:r>
+              <a:rPr sz="900" b="1">
+                <a:solidFill>
+                  <a:srgbClr val="FFFFFF"/>
+                </a:solidFill>
+                <a:latin typeface="Meiryo"/>
+              </a:rPr>
+              <a:t>中程度</a:t>
+            </a:r>
+          </a:p>
+        </p:txBody>
+      </p:sp>
+      <p:sp>
+        <p:nvSpPr>
+          <p:cNvPr id="37" name="Rectangle 36"/>
+          <p:cNvSpPr/>
+          <p:nvPr/>
+        </p:nvSpPr>
+        <p:spPr>
+          <a:xfrm>
+            <a:off x="731520" y="6217920"/>
+            <a:ext cx="3200400" cy="365760"/>
+          </a:xfrm>
+          <a:prstGeom prst="rect">
+            <a:avLst/>
+          </a:prstGeom>
+          <a:solidFill>
+            <a:srgbClr val="F9F9F9"/>
+          </a:solidFill>
+          <a:ln w="25400">
+            <a:solidFill>
+              <a:srgbClr val="CCCCCC"/>
+            </a:solidFill>
+          </a:ln>
+        </p:spPr>
+        <p:style>
+          <a:lnRef idx="1">
+            <a:schemeClr val="accent1"/>
+          </a:lnRef>
+          <a:fillRef idx="3">
+            <a:schemeClr val="accent1"/>
+          </a:fillRef>
+          <a:effectRef idx="2">
+            <a:schemeClr val="accent1"/>
+          </a:effectRef>
+          <a:fontRef idx="minor">
+            <a:schemeClr val="lt1"/>
+          </a:fontRef>
+        </p:style>
+        <p:txBody>
+          <a:bodyPr rtlCol="0" anchor="ctr" wrap="square" lIns="63500" rIns="50800" tIns="38100" bIns="38100"/>
+          <a:lstStyle/>
+          <a:p>
+            <a:pPr algn="l"/>
+            <a:r>
+              <a:rPr sz="900" b="1">
+                <a:solidFill>
+                  <a:srgbClr val="222222"/>
+                </a:solidFill>
+                <a:latin typeface="Meiryo"/>
+              </a:rPr>
+              <a:t>正規企業の証明書窃取</a:t>
+            </a:r>
+          </a:p>
+        </p:txBody>
+      </p:sp>
+      <p:sp>
+        <p:nvSpPr>
+          <p:cNvPr id="38" name="Rectangle 37"/>
+          <p:cNvSpPr/>
+          <p:nvPr/>
+        </p:nvSpPr>
+        <p:spPr>
+          <a:xfrm>
+            <a:off x="3931920" y="6217920"/>
+            <a:ext cx="5029200" cy="365760"/>
+          </a:xfrm>
+          <a:prstGeom prst="rect">
+            <a:avLst/>
+          </a:prstGeom>
+          <a:solidFill>
+            <a:srgbClr val="F9F9F9"/>
+          </a:solidFill>
+          <a:ln w="25400">
+            <a:solidFill>
+              <a:srgbClr val="CCCCCC"/>
+            </a:solidFill>
+          </a:ln>
+        </p:spPr>
+        <p:style>
+          <a:lnRef idx="1">
+            <a:schemeClr val="accent1"/>
+          </a:lnRef>
+          <a:fillRef idx="3">
+            <a:schemeClr val="accent1"/>
+          </a:fillRef>
+          <a:effectRef idx="2">
+            <a:schemeClr val="accent1"/>
+          </a:effectRef>
+          <a:fontRef idx="minor">
+            <a:schemeClr val="lt1"/>
+          </a:fontRef>
+        </p:style>
+        <p:txBody>
+          <a:bodyPr rtlCol="0" anchor="ctr" wrap="square" lIns="63500" rIns="50800" tIns="38100" bIns="38100"/>
+          <a:lstStyle/>
+          <a:p>
+            <a:pPr algn="l"/>
+            <a:r>
+              <a:rPr sz="900" b="0">
+                <a:solidFill>
+                  <a:srgbClr val="222222"/>
+                </a:solidFill>
+                <a:latin typeface="Meiryo"/>
+              </a:rPr>
+              <a:t>実在企業名が表示</a:t>
+            </a:r>
+          </a:p>
+        </p:txBody>
+      </p:sp>
+      <p:sp>
+        <p:nvSpPr>
+          <p:cNvPr id="39" name="Rectangle 38"/>
+          <p:cNvSpPr/>
+          <p:nvPr/>
+        </p:nvSpPr>
+        <p:spPr>
+          <a:xfrm>
+            <a:off x="8961120" y="6217920"/>
+            <a:ext cx="1828800" cy="365760"/>
+          </a:xfrm>
+          <a:prstGeom prst="rect">
+            <a:avLst/>
+          </a:prstGeom>
+          <a:solidFill>
+            <a:srgbClr val="E67E22"/>
+          </a:solidFill>
+          <a:ln>
+            <a:noFill/>
+          </a:ln>
+        </p:spPr>
+        <p:style>
+          <a:lnRef idx="1">
+            <a:schemeClr val="accent1"/>
+          </a:lnRef>
+          <a:fillRef idx="3">
+            <a:schemeClr val="accent1"/>
+          </a:fillRef>
+          <a:effectRef idx="2">
+            <a:schemeClr val="accent1"/>
+          </a:effectRef>
+          <a:fontRef idx="minor">
+            <a:schemeClr val="lt1"/>
+          </a:fontRef>
+        </p:style>
+        <p:txBody>
+          <a:bodyPr rtlCol="0" anchor="ctr" wrap="square" lIns="50800" rIns="50800" tIns="25400" bIns="25400"/>
+          <a:lstStyle/>
+          <a:p>
+            <a:pPr algn="ctr"/>
+            <a:r>
+              <a:rPr sz="900" b="1">
+                <a:solidFill>
+                  <a:srgbClr val="FFFFFF"/>
+                </a:solidFill>
+                <a:latin typeface="Meiryo"/>
+              </a:rPr>
+              <a:t>高難度</a:t>
+            </a:r>
+          </a:p>
+        </p:txBody>
+      </p:sp>
+      <p:sp>
+        <p:nvSpPr>
+          <p:cNvPr id="40" name="Rectangle 39"/>
+          <p:cNvSpPr/>
+          <p:nvPr/>
+        </p:nvSpPr>
+        <p:spPr>
+          <a:xfrm>
+            <a:off x="731520" y="6583680"/>
+            <a:ext cx="3200400" cy="365760"/>
+          </a:xfrm>
+          <a:prstGeom prst="rect">
+            <a:avLst/>
+          </a:prstGeom>
+          <a:solidFill>
+            <a:srgbClr val="FFFFFF"/>
+          </a:solidFill>
+          <a:ln w="25400">
+            <a:solidFill>
+              <a:srgbClr val="CCCCCC"/>
+            </a:solidFill>
+          </a:ln>
+        </p:spPr>
+        <p:style>
+          <a:lnRef idx="1">
+            <a:schemeClr val="accent1"/>
+          </a:lnRef>
+          <a:fillRef idx="3">
+            <a:schemeClr val="accent1"/>
+          </a:fillRef>
+          <a:effectRef idx="2">
+            <a:schemeClr val="accent1"/>
+          </a:effectRef>
+          <a:fontRef idx="minor">
+            <a:schemeClr val="lt1"/>
+          </a:fontRef>
+        </p:style>
+        <p:txBody>
+          <a:bodyPr rtlCol="0" anchor="ctr" wrap="square" lIns="63500" rIns="50800" tIns="38100" bIns="38100"/>
+          <a:lstStyle/>
+          <a:p>
+            <a:pPr algn="l"/>
+            <a:r>
+              <a:rPr sz="900" b="1">
+                <a:solidFill>
+                  <a:srgbClr val="222222"/>
+                </a:solidFill>
+                <a:latin typeface="Meiryo"/>
+              </a:rPr>
+              <a:t>EV証明書を偽造取得</a:t>
+            </a:r>
+          </a:p>
+        </p:txBody>
+      </p:sp>
+      <p:sp>
+        <p:nvSpPr>
+          <p:cNvPr id="41" name="Rectangle 40"/>
+          <p:cNvSpPr/>
+          <p:nvPr/>
+        </p:nvSpPr>
+        <p:spPr>
+          <a:xfrm>
+            <a:off x="3931920" y="6583680"/>
+            <a:ext cx="5029200" cy="365760"/>
+          </a:xfrm>
+          <a:prstGeom prst="rect">
+            <a:avLst/>
+          </a:prstGeom>
+          <a:solidFill>
+            <a:srgbClr val="FFFFFF"/>
+          </a:solidFill>
+          <a:ln w="25400">
+            <a:solidFill>
+              <a:srgbClr val="CCCCCC"/>
+            </a:solidFill>
+          </a:ln>
+        </p:spPr>
+        <p:style>
+          <a:lnRef idx="1">
+            <a:schemeClr val="accent1"/>
+          </a:lnRef>
+          <a:fillRef idx="3">
+            <a:schemeClr val="accent1"/>
+          </a:fillRef>
+          <a:effectRef idx="2">
+            <a:schemeClr val="accent1"/>
+          </a:effectRef>
+          <a:fontRef idx="minor">
+            <a:schemeClr val="lt1"/>
+          </a:fontRef>
+        </p:style>
+        <p:txBody>
+          <a:bodyPr rtlCol="0" anchor="ctr" wrap="square" lIns="63500" rIns="50800" tIns="38100" bIns="38100"/>
+          <a:lstStyle/>
+          <a:p>
+            <a:pPr algn="l"/>
+            <a:r>
+              <a:rPr sz="900" b="0">
+                <a:solidFill>
+                  <a:srgbClr val="222222"/>
+                </a:solidFill>
+                <a:latin typeface="Meiryo"/>
+              </a:rPr>
+              <a:t>SmartScreen警告も消える</a:t>
+            </a:r>
+          </a:p>
+        </p:txBody>
+      </p:sp>
+      <p:sp>
+        <p:nvSpPr>
+          <p:cNvPr id="42" name="Rectangle 41"/>
+          <p:cNvSpPr/>
+          <p:nvPr/>
+        </p:nvSpPr>
+        <p:spPr>
+          <a:xfrm>
+            <a:off x="8961120" y="6583680"/>
+            <a:ext cx="1828800" cy="365760"/>
+          </a:xfrm>
+          <a:prstGeom prst="rect">
+            <a:avLst/>
+          </a:prstGeom>
+          <a:solidFill>
+            <a:srgbClr val="FDEDEC"/>
+          </a:solidFill>
+          <a:ln>
+            <a:noFill/>
+          </a:ln>
+        </p:spPr>
+        <p:style>
+          <a:lnRef idx="1">
+            <a:schemeClr val="accent1"/>
+          </a:lnRef>
+          <a:fillRef idx="3">
+            <a:schemeClr val="accent1"/>
+          </a:fillRef>
+          <a:effectRef idx="2">
+            <a:schemeClr val="accent1"/>
+          </a:effectRef>
+          <a:fontRef idx="minor">
+            <a:schemeClr val="lt1"/>
+          </a:fontRef>
+        </p:style>
+        <p:txBody>
+          <a:bodyPr rtlCol="0" anchor="ctr" wrap="square" lIns="50800" rIns="50800" tIns="25400" bIns="25400"/>
+          <a:lstStyle/>
+          <a:p>
+            <a:pPr algn="ctr"/>
+            <a:r>
+              <a:rPr sz="900" b="1">
+                <a:solidFill>
+                  <a:srgbClr val="FFFFFF"/>
+                </a:solidFill>
+                <a:latin typeface="Meiryo"/>
+              </a:rPr>
+              <a:t>高難度</a:t>
+            </a:r>
+          </a:p>
+        </p:txBody>
+      </p:sp>
+      <p:sp>
+        <p:nvSpPr>
+          <p:cNvPr id="43" name="Rectangle 42"/>
+          <p:cNvSpPr/>
+          <p:nvPr/>
+        </p:nvSpPr>
+        <p:spPr>
+          <a:xfrm>
+            <a:off x="731520" y="7040880"/>
+            <a:ext cx="13624560" cy="365760"/>
+          </a:xfrm>
+          <a:prstGeom prst="rect">
+            <a:avLst/>
+          </a:prstGeom>
+          <a:solidFill>
+            <a:srgbClr val="222222"/>
+          </a:solidFill>
+          <a:ln>
+            <a:noFill/>
+          </a:ln>
+        </p:spPr>
+        <p:style>
+          <a:lnRef idx="1">
+            <a:schemeClr val="accent1"/>
+          </a:lnRef>
+          <a:fillRef idx="3">
+            <a:schemeClr val="accent1"/>
+          </a:fillRef>
+          <a:effectRef idx="2">
+            <a:schemeClr val="accent1"/>
+          </a:effectRef>
+          <a:fontRef idx="minor">
+            <a:schemeClr val="lt1"/>
+          </a:fontRef>
+        </p:style>
+        <p:txBody>
+          <a:bodyPr rtlCol="0" anchor="ctr" wrap="square" lIns="50800" rIns="50800" tIns="25400" bIns="25400"/>
+          <a:lstStyle/>
+          <a:p>
+            <a:pPr algn="ctr"/>
+            <a:r>
+              <a:rPr sz="1200" b="1">
+                <a:solidFill>
+                  <a:srgbClr val="FFFFFF"/>
+                </a:solidFill>
+                <a:latin typeface="Meiryo"/>
+              </a:rPr>
+              <a:t>確実な対策：ホワイトリスト型アプリ制御</a:t>
+            </a:r>
+          </a:p>
+        </p:txBody>
+      </p:sp>
+      <p:sp>
+        <p:nvSpPr>
+          <p:cNvPr id="44" name="Rectangle 43"/>
+          <p:cNvSpPr/>
+          <p:nvPr/>
+        </p:nvSpPr>
+        <p:spPr>
+          <a:xfrm>
+            <a:off x="731520" y="7406640"/>
+            <a:ext cx="4114800" cy="365760"/>
+          </a:xfrm>
+          <a:prstGeom prst="rect">
+            <a:avLst/>
+          </a:prstGeom>
+          <a:solidFill>
+            <a:srgbClr val="34495E"/>
+          </a:solidFill>
+          <a:ln>
+            <a:noFill/>
+          </a:ln>
+        </p:spPr>
+        <p:style>
+          <a:lnRef idx="1">
+            <a:schemeClr val="accent1"/>
+          </a:lnRef>
+          <a:fillRef idx="3">
+            <a:schemeClr val="accent1"/>
+          </a:fillRef>
+          <a:effectRef idx="2">
+            <a:schemeClr val="accent1"/>
+          </a:effectRef>
+          <a:fontRef idx="minor">
+            <a:schemeClr val="lt1"/>
+          </a:fontRef>
+        </p:style>
+        <p:txBody>
+          <a:bodyPr rtlCol="0" anchor="ctr" wrap="square" lIns="50800" rIns="50800" tIns="25400" bIns="25400"/>
+          <a:lstStyle/>
+          <a:p>
+            <a:pPr algn="ctr"/>
+            <a:r>
+              <a:rPr sz="900" b="1">
+                <a:solidFill>
+                  <a:srgbClr val="FFFFFF"/>
+                </a:solidFill>
+                <a:latin typeface="Meiryo"/>
+              </a:rPr>
+              <a:t>対策</a:t>
+            </a:r>
+          </a:p>
+        </p:txBody>
+      </p:sp>
+      <p:sp>
+        <p:nvSpPr>
+          <p:cNvPr id="45" name="Rectangle 44"/>
+          <p:cNvSpPr/>
+          <p:nvPr/>
+        </p:nvSpPr>
+        <p:spPr>
+          <a:xfrm>
+            <a:off x="4846320" y="7406640"/>
+            <a:ext cx="3017520" cy="365760"/>
+          </a:xfrm>
+          <a:prstGeom prst="rect">
+            <a:avLst/>
+          </a:prstGeom>
+          <a:solidFill>
+            <a:srgbClr val="34495E"/>
+          </a:solidFill>
+          <a:ln>
+            <a:noFill/>
+          </a:ln>
+        </p:spPr>
+        <p:style>
+          <a:lnRef idx="1">
+            <a:schemeClr val="accent1"/>
+          </a:lnRef>
+          <a:fillRef idx="3">
+            <a:schemeClr val="accent1"/>
+          </a:fillRef>
+          <a:effectRef idx="2">
+            <a:schemeClr val="accent1"/>
+          </a:effectRef>
+          <a:fontRef idx="minor">
+            <a:schemeClr val="lt1"/>
+          </a:fontRef>
+        </p:style>
+        <p:txBody>
+          <a:bodyPr rtlCol="0" anchor="ctr" wrap="square" lIns="50800" rIns="50800" tIns="25400" bIns="25400"/>
+          <a:lstStyle/>
+          <a:p>
+            <a:pPr algn="ctr"/>
+            <a:r>
+              <a:rPr sz="900" b="1">
+                <a:solidFill>
+                  <a:srgbClr val="FFFFFF"/>
+                </a:solidFill>
+                <a:latin typeface="Meiryo"/>
+              </a:rPr>
+              <a:t>未署名</a:t>
+            </a:r>
+          </a:p>
+        </p:txBody>
+      </p:sp>
+      <p:sp>
+        <p:nvSpPr>
+          <p:cNvPr id="46" name="Rectangle 45"/>
+          <p:cNvSpPr/>
+          <p:nvPr/>
+        </p:nvSpPr>
+        <p:spPr>
+          <a:xfrm>
+            <a:off x="7863840" y="7406640"/>
+            <a:ext cx="3017520" cy="365760"/>
+          </a:xfrm>
+          <a:prstGeom prst="rect">
+            <a:avLst/>
+          </a:prstGeom>
+          <a:solidFill>
+            <a:srgbClr val="34495E"/>
+          </a:solidFill>
+          <a:ln>
+            <a:noFill/>
+          </a:ln>
+        </p:spPr>
+        <p:style>
+          <a:lnRef idx="1">
+            <a:schemeClr val="accent1"/>
+          </a:lnRef>
+          <a:fillRef idx="3">
+            <a:schemeClr val="accent1"/>
+          </a:fillRef>
+          <a:effectRef idx="2">
+            <a:schemeClr val="accent1"/>
+          </a:effectRef>
+          <a:fontRef idx="minor">
+            <a:schemeClr val="lt1"/>
+          </a:fontRef>
+        </p:style>
+        <p:txBody>
+          <a:bodyPr rtlCol="0" anchor="ctr" wrap="square" lIns="50800" rIns="50800" tIns="25400" bIns="25400"/>
+          <a:lstStyle/>
+          <a:p>
+            <a:pPr algn="ctr"/>
+            <a:r>
+              <a:rPr sz="900" b="1">
+                <a:solidFill>
+                  <a:srgbClr val="FFFFFF"/>
+                </a:solidFill>
+                <a:latin typeface="Meiryo"/>
+              </a:rPr>
+              <a:t>偽証明書</a:t>
+            </a:r>
+          </a:p>
+        </p:txBody>
+      </p:sp>
+      <p:sp>
+        <p:nvSpPr>
+          <p:cNvPr id="47" name="Rectangle 46"/>
+          <p:cNvSpPr/>
+          <p:nvPr/>
+        </p:nvSpPr>
+        <p:spPr>
+          <a:xfrm>
+            <a:off x="10881359" y="7406640"/>
+            <a:ext cx="3474720" cy="365760"/>
+          </a:xfrm>
+          <a:prstGeom prst="rect">
+            <a:avLst/>
+          </a:prstGeom>
+          <a:solidFill>
+            <a:srgbClr val="34495E"/>
+          </a:solidFill>
+          <a:ln>
+            <a:noFill/>
+          </a:ln>
+        </p:spPr>
+        <p:style>
+          <a:lnRef idx="1">
+            <a:schemeClr val="accent1"/>
+          </a:lnRef>
+          <a:fillRef idx="3">
+            <a:schemeClr val="accent1"/>
+          </a:fillRef>
+          <a:effectRef idx="2">
+            <a:schemeClr val="accent1"/>
+          </a:effectRef>
+          <a:fontRef idx="minor">
+            <a:schemeClr val="lt1"/>
+          </a:fontRef>
+        </p:style>
+        <p:txBody>
+          <a:bodyPr rtlCol="0" anchor="ctr" wrap="square" lIns="50800" rIns="50800" tIns="25400" bIns="25400"/>
+          <a:lstStyle/>
+          <a:p>
+            <a:pPr algn="ctr"/>
+            <a:r>
+              <a:rPr sz="900" b="1">
+                <a:solidFill>
+                  <a:srgbClr val="FFFFFF"/>
+                </a:solidFill>
+                <a:latin typeface="Meiryo"/>
+              </a:rPr>
+              <a:t>窃取証明書</a:t>
+            </a:r>
+          </a:p>
+        </p:txBody>
+      </p:sp>
+      <p:sp>
+        <p:nvSpPr>
+          <p:cNvPr id="48" name="Rectangle 47"/>
+          <p:cNvSpPr/>
+          <p:nvPr/>
+        </p:nvSpPr>
+        <p:spPr>
+          <a:xfrm>
+            <a:off x="731520" y="7772400"/>
+            <a:ext cx="4114800" cy="365760"/>
+          </a:xfrm>
+          <a:prstGeom prst="rect">
+            <a:avLst/>
+          </a:prstGeom>
+          <a:solidFill>
+            <a:srgbClr val="FFFFFF"/>
+          </a:solidFill>
+          <a:ln w="25400">
+            <a:solidFill>
+              <a:srgbClr val="CCCCCC"/>
+            </a:solidFill>
+          </a:ln>
+        </p:spPr>
+        <p:style>
+          <a:lnRef idx="1">
+            <a:schemeClr val="accent1"/>
+          </a:lnRef>
+          <a:fillRef idx="3">
+            <a:schemeClr val="accent1"/>
+          </a:fillRef>
+          <a:effectRef idx="2">
+            <a:schemeClr val="accent1"/>
+          </a:effectRef>
+          <a:fontRef idx="minor">
+            <a:schemeClr val="lt1"/>
+          </a:fontRef>
+        </p:style>
+        <p:txBody>
+          <a:bodyPr rtlCol="0" anchor="ctr" wrap="square" lIns="63500" rIns="50800" tIns="38100" bIns="38100"/>
+          <a:lstStyle/>
+          <a:p>
+            <a:pPr algn="l"/>
+            <a:r>
+              <a:rPr sz="900" b="1">
+                <a:solidFill>
+                  <a:srgbClr val="222222"/>
+                </a:solidFill>
+                <a:latin typeface="Meiryo"/>
+              </a:rPr>
+              <a:t>「不明な発行元」に注意</a:t>
+            </a:r>
+          </a:p>
+        </p:txBody>
+      </p:sp>
+      <p:sp>
+        <p:nvSpPr>
+          <p:cNvPr id="49" name="Rectangle 48"/>
+          <p:cNvSpPr/>
+          <p:nvPr/>
+        </p:nvSpPr>
+        <p:spPr>
+          <a:xfrm>
+            <a:off x="4846320" y="7772400"/>
+            <a:ext cx="3017520" cy="365760"/>
+          </a:xfrm>
+          <a:prstGeom prst="rect">
+            <a:avLst/>
+          </a:prstGeom>
+          <a:solidFill>
+            <a:srgbClr val="FDEDEC"/>
+          </a:solidFill>
+          <a:ln>
+            <a:noFill/>
+          </a:ln>
+        </p:spPr>
+        <p:style>
+          <a:lnRef idx="1">
+            <a:schemeClr val="accent1"/>
+          </a:lnRef>
+          <a:fillRef idx="3">
+            <a:schemeClr val="accent1"/>
+          </a:fillRef>
+          <a:effectRef idx="2">
+            <a:schemeClr val="accent1"/>
+          </a:effectRef>
+          <a:fontRef idx="minor">
+            <a:schemeClr val="lt1"/>
+          </a:fontRef>
+        </p:style>
+        <p:txBody>
+          <a:bodyPr rtlCol="0" anchor="ctr" wrap="square" lIns="50800" rIns="50800" tIns="25400" bIns="25400"/>
+          <a:lstStyle/>
+          <a:p>
+            <a:pPr algn="ctr"/>
+            <a:r>
+              <a:rPr sz="900" b="1">
+                <a:solidFill>
+                  <a:srgbClr val="C0392B"/>
+                </a:solidFill>
+                <a:latin typeface="Meiryo"/>
+              </a:rPr>
+              <a:t>気づける</a:t>
+            </a:r>
+          </a:p>
+        </p:txBody>
+      </p:sp>
+      <p:sp>
+        <p:nvSpPr>
+          <p:cNvPr id="50" name="Rectangle 49"/>
+          <p:cNvSpPr/>
+          <p:nvPr/>
+        </p:nvSpPr>
+        <p:spPr>
+          <a:xfrm>
+            <a:off x="7863840" y="7772400"/>
+            <a:ext cx="3017520" cy="365760"/>
+          </a:xfrm>
+          <a:prstGeom prst="rect">
+            <a:avLst/>
+          </a:prstGeom>
+          <a:solidFill>
+            <a:srgbClr val="FDEDEC"/>
+          </a:solidFill>
+          <a:ln>
+            <a:noFill/>
+          </a:ln>
+        </p:spPr>
+        <p:style>
+          <a:lnRef idx="1">
+            <a:schemeClr val="accent1"/>
+          </a:lnRef>
+          <a:fillRef idx="3">
+            <a:schemeClr val="accent1"/>
+          </a:fillRef>
+          <a:effectRef idx="2">
+            <a:schemeClr val="accent1"/>
+          </a:effectRef>
+          <a:fontRef idx="minor">
+            <a:schemeClr val="lt1"/>
+          </a:fontRef>
+        </p:style>
+        <p:txBody>
+          <a:bodyPr rtlCol="0" anchor="ctr" wrap="square" lIns="50800" rIns="50800" tIns="25400" bIns="25400"/>
+          <a:lstStyle/>
+          <a:p>
+            <a:pPr algn="ctr"/>
+            <a:r>
+              <a:rPr sz="900" b="1">
+                <a:solidFill>
+                  <a:srgbClr val="C0392B"/>
+                </a:solidFill>
+                <a:latin typeface="Meiryo"/>
+              </a:rPr>
+              <a:t>突破される</a:t>
+            </a:r>
+          </a:p>
+        </p:txBody>
+      </p:sp>
+      <p:sp>
+        <p:nvSpPr>
+          <p:cNvPr id="51" name="Rectangle 50"/>
+          <p:cNvSpPr/>
+          <p:nvPr/>
+        </p:nvSpPr>
+        <p:spPr>
+          <a:xfrm>
+            <a:off x="10881359" y="7772400"/>
+            <a:ext cx="3474720" cy="365760"/>
+          </a:xfrm>
+          <a:prstGeom prst="rect">
+            <a:avLst/>
+          </a:prstGeom>
+          <a:solidFill>
+            <a:srgbClr val="FDEDEC"/>
+          </a:solidFill>
+          <a:ln>
+            <a:noFill/>
+          </a:ln>
+        </p:spPr>
+        <p:style>
+          <a:lnRef idx="1">
+            <a:schemeClr val="accent1"/>
+          </a:lnRef>
+          <a:fillRef idx="3">
+            <a:schemeClr val="accent1"/>
+          </a:fillRef>
+          <a:effectRef idx="2">
+            <a:schemeClr val="accent1"/>
+          </a:effectRef>
+          <a:fontRef idx="minor">
+            <a:schemeClr val="lt1"/>
+          </a:fontRef>
+        </p:style>
+        <p:txBody>
+          <a:bodyPr rtlCol="0" anchor="ctr" wrap="square" lIns="50800" rIns="50800" tIns="25400" bIns="25400"/>
+          <a:lstStyle/>
+          <a:p>
+            <a:pPr algn="ctr"/>
+            <a:r>
+              <a:rPr sz="900" b="1">
+                <a:solidFill>
+                  <a:srgbClr val="C0392B"/>
+                </a:solidFill>
+                <a:latin typeface="Meiryo"/>
+              </a:rPr>
+              <a:t>突破される</a:t>
+            </a:r>
+          </a:p>
+        </p:txBody>
+      </p:sp>
+      <p:sp>
+        <p:nvSpPr>
+          <p:cNvPr id="52" name="Rectangle 51"/>
+          <p:cNvSpPr/>
+          <p:nvPr/>
+        </p:nvSpPr>
+        <p:spPr>
+          <a:xfrm>
+            <a:off x="731520" y="8138160"/>
+            <a:ext cx="4114800" cy="365760"/>
+          </a:xfrm>
+          <a:prstGeom prst="rect">
+            <a:avLst/>
+          </a:prstGeom>
+          <a:solidFill>
+            <a:srgbClr val="F9F9F9"/>
+          </a:solidFill>
+          <a:ln w="25400">
+            <a:solidFill>
+              <a:srgbClr val="CCCCCC"/>
+            </a:solidFill>
+          </a:ln>
+        </p:spPr>
+        <p:style>
+          <a:lnRef idx="1">
+            <a:schemeClr val="accent1"/>
+          </a:lnRef>
+          <a:fillRef idx="3">
+            <a:schemeClr val="accent1"/>
+          </a:fillRef>
+          <a:effectRef idx="2">
+            <a:schemeClr val="accent1"/>
+          </a:effectRef>
+          <a:fontRef idx="minor">
+            <a:schemeClr val="lt1"/>
+          </a:fontRef>
+        </p:style>
+        <p:txBody>
+          <a:bodyPr rtlCol="0" anchor="ctr" wrap="square" lIns="63500" rIns="50800" tIns="38100" bIns="38100"/>
+          <a:lstStyle/>
+          <a:p>
+            <a:pPr algn="l"/>
+            <a:r>
+              <a:rPr sz="900" b="1">
+                <a:solidFill>
+                  <a:srgbClr val="222222"/>
+                </a:solidFill>
+                <a:latin typeface="Meiryo"/>
+              </a:rPr>
+              <a:t>AppLocker / WDAC ★</a:t>
+            </a:r>
+          </a:p>
+        </p:txBody>
+      </p:sp>
+      <p:sp>
+        <p:nvSpPr>
+          <p:cNvPr id="53" name="Rectangle 52"/>
+          <p:cNvSpPr/>
+          <p:nvPr/>
+        </p:nvSpPr>
+        <p:spPr>
+          <a:xfrm>
+            <a:off x="4846320" y="8138160"/>
+            <a:ext cx="3017520" cy="365760"/>
+          </a:xfrm>
+          <a:prstGeom prst="rect">
+            <a:avLst/>
+          </a:prstGeom>
+          <a:solidFill>
+            <a:srgbClr val="EAFAF1"/>
+          </a:solidFill>
+          <a:ln>
+            <a:noFill/>
+          </a:ln>
+        </p:spPr>
+        <p:style>
+          <a:lnRef idx="1">
+            <a:schemeClr val="accent1"/>
+          </a:lnRef>
+          <a:fillRef idx="3">
+            <a:schemeClr val="accent1"/>
+          </a:fillRef>
+          <a:effectRef idx="2">
+            <a:schemeClr val="accent1"/>
+          </a:effectRef>
+          <a:fontRef idx="minor">
+            <a:schemeClr val="lt1"/>
+          </a:fontRef>
+        </p:style>
+        <p:txBody>
+          <a:bodyPr rtlCol="0" anchor="ctr" wrap="square" lIns="50800" rIns="50800" tIns="25400" bIns="25400"/>
+          <a:lstStyle/>
+          <a:p>
+            <a:pPr algn="ctr"/>
+            <a:r>
+              <a:rPr sz="900" b="1">
+                <a:solidFill>
+                  <a:srgbClr val="27AE60"/>
+                </a:solidFill>
+                <a:latin typeface="Meiryo"/>
+              </a:rPr>
+              <a:t>止まる</a:t>
+            </a:r>
+          </a:p>
+        </p:txBody>
+      </p:sp>
+      <p:sp>
+        <p:nvSpPr>
+          <p:cNvPr id="54" name="Rectangle 53"/>
+          <p:cNvSpPr/>
+          <p:nvPr/>
+        </p:nvSpPr>
+        <p:spPr>
+          <a:xfrm>
+            <a:off x="7863840" y="8138160"/>
+            <a:ext cx="3017520" cy="365760"/>
+          </a:xfrm>
+          <a:prstGeom prst="rect">
+            <a:avLst/>
+          </a:prstGeom>
+          <a:solidFill>
+            <a:srgbClr val="EAFAF1"/>
+          </a:solidFill>
+          <a:ln>
+            <a:noFill/>
+          </a:ln>
+        </p:spPr>
+        <p:style>
+          <a:lnRef idx="1">
+            <a:schemeClr val="accent1"/>
+          </a:lnRef>
+          <a:fillRef idx="3">
+            <a:schemeClr val="accent1"/>
+          </a:fillRef>
+          <a:effectRef idx="2">
+            <a:schemeClr val="accent1"/>
+          </a:effectRef>
+          <a:fontRef idx="minor">
+            <a:schemeClr val="lt1"/>
+          </a:fontRef>
+        </p:style>
+        <p:txBody>
+          <a:bodyPr rtlCol="0" anchor="ctr" wrap="square" lIns="50800" rIns="50800" tIns="25400" bIns="25400"/>
+          <a:lstStyle/>
+          <a:p>
+            <a:pPr algn="ctr"/>
+            <a:r>
+              <a:rPr sz="900" b="1">
+                <a:solidFill>
+                  <a:srgbClr val="27AE60"/>
+                </a:solidFill>
+                <a:latin typeface="Meiryo"/>
+              </a:rPr>
+              <a:t>止まる</a:t>
+            </a:r>
+          </a:p>
+        </p:txBody>
+      </p:sp>
+      <p:sp>
+        <p:nvSpPr>
+          <p:cNvPr id="55" name="Rectangle 54"/>
+          <p:cNvSpPr/>
+          <p:nvPr/>
+        </p:nvSpPr>
+        <p:spPr>
+          <a:xfrm>
+            <a:off x="10881359" y="8138160"/>
+            <a:ext cx="3474720" cy="365760"/>
+          </a:xfrm>
+          <a:prstGeom prst="rect">
+            <a:avLst/>
+          </a:prstGeom>
+          <a:solidFill>
+            <a:srgbClr val="EAFAF1"/>
+          </a:solidFill>
+          <a:ln>
+            <a:noFill/>
+          </a:ln>
+        </p:spPr>
+        <p:style>
+          <a:lnRef idx="1">
+            <a:schemeClr val="accent1"/>
+          </a:lnRef>
+          <a:fillRef idx="3">
+            <a:schemeClr val="accent1"/>
+          </a:fillRef>
+          <a:effectRef idx="2">
+            <a:schemeClr val="accent1"/>
+          </a:effectRef>
+          <a:fontRef idx="minor">
+            <a:schemeClr val="lt1"/>
+          </a:fontRef>
+        </p:style>
+        <p:txBody>
+          <a:bodyPr rtlCol="0" anchor="ctr" wrap="square" lIns="50800" rIns="50800" tIns="25400" bIns="25400"/>
+          <a:lstStyle/>
+          <a:p>
+            <a:pPr algn="ctr"/>
+            <a:r>
+              <a:rPr sz="900" b="1">
+                <a:solidFill>
+                  <a:srgbClr val="27AE60"/>
+                </a:solidFill>
+                <a:latin typeface="Meiryo"/>
+              </a:rPr>
+              <a:t>止まる</a:t>
+            </a:r>
+          </a:p>
+        </p:txBody>
+      </p:sp>
+      <p:sp>
+        <p:nvSpPr>
+          <p:cNvPr id="56" name="Rectangle 55"/>
+          <p:cNvSpPr/>
+          <p:nvPr/>
+        </p:nvSpPr>
+        <p:spPr>
+          <a:xfrm>
+            <a:off x="731520" y="8641080"/>
+            <a:ext cx="13624560" cy="457200"/>
+          </a:xfrm>
+          <a:prstGeom prst="rect">
+            <a:avLst/>
+          </a:prstGeom>
+          <a:solidFill>
+            <a:srgbClr val="222222"/>
+          </a:solidFill>
+          <a:ln>
+            <a:noFill/>
+          </a:ln>
+        </p:spPr>
+        <p:style>
+          <a:lnRef idx="1">
+            <a:schemeClr val="accent1"/>
+          </a:lnRef>
+          <a:fillRef idx="3">
+            <a:schemeClr val="accent1"/>
+          </a:fillRef>
+          <a:effectRef idx="2">
+            <a:schemeClr val="accent1"/>
+          </a:effectRef>
+          <a:fontRef idx="minor">
+            <a:schemeClr val="lt1"/>
+          </a:fontRef>
+        </p:style>
+        <p:txBody>
+          <a:bodyPr rtlCol="0" anchor="ctr" wrap="square" lIns="50800" rIns="50800" tIns="25400" bIns="25400"/>
+          <a:lstStyle/>
+          <a:p>
+            <a:pPr algn="ctr"/>
+            <a:r>
+              <a:rPr sz="1200" b="1">
+                <a:solidFill>
+                  <a:srgbClr val="FFFFFF"/>
+                </a:solidFill>
+                <a:latin typeface="Meiryo"/>
+              </a:rPr>
+              <a:t>証明書ベースの防御は犯人のレベル次第で突破される。ホワイトリスト型アプリ制御（AppLocker/WDAC）が唯一の確実な対策。</a:t>
+            </a:r>
+          </a:p>
+        </p:txBody>
+      </p:sp>
+      <p:sp>
+        <p:nvSpPr>
+          <p:cNvPr id="57" name="TextBox 56"/>
+          <p:cNvSpPr txBox="1"/>
+          <p:nvPr/>
+        </p:nvSpPr>
+        <p:spPr>
+          <a:xfrm>
+            <a:off x="9144000" y="10378440"/>
+            <a:ext cx="5943600" cy="228600"/>
+          </a:xfrm>
+          <a:prstGeom prst="rect">
+            <a:avLst/>
+          </a:prstGeom>
+          <a:noFill/>
+        </p:spPr>
+        <p:txBody>
+          <a:bodyPr wrap="square" lIns="50800" rIns="50800" tIns="38100" bIns="38100"/>
+          <a:lstStyle/>
+          <a:p>
+            <a:pPr algn="r"/>
+            <a:r>
+              <a:rPr sz="700" b="0">
+                <a:solidFill>
+                  <a:srgbClr val="888888"/>
+                </a:solidFill>
+                <a:latin typeface="Meiryo"/>
+              </a:rPr>
+              <a:t>Fraud Kill Chain — 手順⑥「不明な発行元」とアプリ制御</a:t>
             </a:r>
           </a:p>
         </p:txBody>

</xml_diff>

<commit_message>
Add slide 11: whitelist app control detail (AppLocker/WDAC)
Both tools are built into Windows at zero cost. Combined with
DMARC p=reject, they provide two technical kill chain cut points
that require no customer awareness — just configuration.

https://claude.ai/code/session_01F7t8LKifK43o6sCdF2a3gQ
</commit_message>
<xml_diff>
--- a/Fraud_Kill_Chain.pptx
+++ b/Fraud_Kill_Chain.pptx
@@ -15,6 +15,7 @@
     <p:sldId id="263" r:id="rId14"/>
     <p:sldId id="264" r:id="rId15"/>
     <p:sldId id="265" r:id="rId16"/>
+    <p:sldId id="266" r:id="rId17"/>
   </p:sldIdLst>
   <p:sldSz cx="15124176" cy="10689336" type="screen4x3"/>
   <p:notesSz cx="6858000" cy="9144000"/>
@@ -10404,6 +10405,2370 @@
                 <a:latin typeface="Meiryo"/>
               </a:rPr>
               <a:t>Fraud Kill Chain — 手順⑥「不明な発行元」とアプリ制御</a:t>
+            </a:r>
+          </a:p>
+        </p:txBody>
+      </p:sp>
+    </p:spTree>
+  </p:cSld>
+  <p:clrMapOvr>
+    <a:masterClrMapping/>
+  </p:clrMapOvr>
+</p:sld>
+</file>
+
+<file path=ppt/slides/slide11.xml><?xml version="1.0" encoding="utf-8"?>
+<p:sld xmlns:a="http://schemas.openxmlformats.org/drawingml/2006/main" xmlns:p="http://schemas.openxmlformats.org/presentationml/2006/main" xmlns:r="http://schemas.openxmlformats.org/officeDocument/2006/relationships">
+  <p:cSld>
+    <p:bg>
+      <p:bgPr>
+        <a:solidFill>
+          <a:srgbClr val="F5F5F5"/>
+        </a:solidFill>
+        <a:effectLst/>
+      </p:bgPr>
+    </p:bg>
+    <p:spTree>
+      <p:nvGrpSpPr>
+        <p:cNvPr id="1" name=""/>
+        <p:cNvGrpSpPr/>
+        <p:nvPr/>
+      </p:nvGrpSpPr>
+      <p:grpSpPr/>
+      <p:sp>
+        <p:nvSpPr>
+          <p:cNvPr id="2" name="TextBox 1"/>
+          <p:cNvSpPr txBox="1"/>
+          <p:nvPr/>
+        </p:nvSpPr>
+        <p:spPr>
+          <a:xfrm>
+            <a:off x="0" y="182880"/>
+            <a:ext cx="15124176" cy="548640"/>
+          </a:xfrm>
+          <a:prstGeom prst="rect">
+            <a:avLst/>
+          </a:prstGeom>
+          <a:noFill/>
+        </p:spPr>
+        <p:txBody>
+          <a:bodyPr wrap="square" lIns="50800" rIns="50800" tIns="38100" bIns="38100"/>
+          <a:lstStyle/>
+          <a:p>
+            <a:pPr algn="ctr"/>
+            <a:r>
+              <a:rPr sz="2000" b="1">
+                <a:solidFill>
+                  <a:srgbClr val="27AE60"/>
+                </a:solidFill>
+                <a:latin typeface="Meiryo"/>
+              </a:rPr>
+              <a:t>ホワイトリスト型アプリ制御 — Windowsに標準搭載、追加コストゼロ</a:t>
+            </a:r>
+          </a:p>
+        </p:txBody>
+      </p:sp>
+      <p:sp>
+        <p:nvSpPr>
+          <p:cNvPr id="3" name="TextBox 2"/>
+          <p:cNvSpPr txBox="1"/>
+          <p:nvPr/>
+        </p:nvSpPr>
+        <p:spPr>
+          <a:xfrm>
+            <a:off x="0" y="640080"/>
+            <a:ext cx="15124176" cy="365760"/>
+          </a:xfrm>
+          <a:prstGeom prst="rect">
+            <a:avLst/>
+          </a:prstGeom>
+          <a:noFill/>
+        </p:spPr>
+        <p:txBody>
+          <a:bodyPr wrap="square" lIns="50800" rIns="50800" tIns="38100" bIns="38100"/>
+          <a:lstStyle/>
+          <a:p>
+            <a:pPr algn="ctr"/>
+            <a:r>
+              <a:rPr sz="1100" b="0">
+                <a:solidFill>
+                  <a:srgbClr val="888888"/>
+                </a:solidFill>
+                <a:latin typeface="Meiryo"/>
+              </a:rPr>
+              <a:t>DMARCと同じ構図：使えるのに使っていない。設定するだけで手順⑥を確実に止められる。</a:t>
+            </a:r>
+          </a:p>
+        </p:txBody>
+      </p:sp>
+      <p:sp>
+        <p:nvSpPr>
+          <p:cNvPr id="4" name="Rectangle 3"/>
+          <p:cNvSpPr/>
+          <p:nvPr/>
+        </p:nvSpPr>
+        <p:spPr>
+          <a:xfrm>
+            <a:off x="731520" y="1051560"/>
+            <a:ext cx="6583680" cy="411480"/>
+          </a:xfrm>
+          <a:prstGeom prst="rect">
+            <a:avLst/>
+          </a:prstGeom>
+          <a:solidFill>
+            <a:srgbClr val="C0392B"/>
+          </a:solidFill>
+          <a:ln>
+            <a:noFill/>
+          </a:ln>
+        </p:spPr>
+        <p:style>
+          <a:lnRef idx="1">
+            <a:schemeClr val="accent1"/>
+          </a:lnRef>
+          <a:fillRef idx="3">
+            <a:schemeClr val="accent1"/>
+          </a:fillRef>
+          <a:effectRef idx="2">
+            <a:schemeClr val="accent1"/>
+          </a:effectRef>
+          <a:fontRef idx="minor">
+            <a:schemeClr val="lt1"/>
+          </a:fontRef>
+        </p:style>
+        <p:txBody>
+          <a:bodyPr rtlCol="0" anchor="ctr" wrap="square" lIns="50800" rIns="50800" tIns="25400" bIns="25400"/>
+          <a:lstStyle/>
+          <a:p>
+            <a:pPr algn="ctr"/>
+            <a:r>
+              <a:rPr sz="1100" b="1">
+                <a:solidFill>
+                  <a:srgbClr val="FFFFFF"/>
+                </a:solidFill>
+                <a:latin typeface="Meiryo"/>
+              </a:rPr>
+              <a:t>ブラックリスト型（従来のアンチウイルス）</a:t>
+            </a:r>
+          </a:p>
+        </p:txBody>
+      </p:sp>
+      <p:sp>
+        <p:nvSpPr>
+          <p:cNvPr id="5" name="Rectangle 4"/>
+          <p:cNvSpPr/>
+          <p:nvPr/>
+        </p:nvSpPr>
+        <p:spPr>
+          <a:xfrm>
+            <a:off x="731520" y="1463039"/>
+            <a:ext cx="6583680" cy="731520"/>
+          </a:xfrm>
+          <a:prstGeom prst="rect">
+            <a:avLst/>
+          </a:prstGeom>
+          <a:solidFill>
+            <a:srgbClr val="FFFFFF"/>
+          </a:solidFill>
+          <a:ln w="25400">
+            <a:solidFill>
+              <a:srgbClr val="C0392B"/>
+            </a:solidFill>
+          </a:ln>
+        </p:spPr>
+        <p:style>
+          <a:lnRef idx="1">
+            <a:schemeClr val="accent1"/>
+          </a:lnRef>
+          <a:fillRef idx="3">
+            <a:schemeClr val="accent1"/>
+          </a:fillRef>
+          <a:effectRef idx="2">
+            <a:schemeClr val="accent1"/>
+          </a:effectRef>
+          <a:fontRef idx="minor">
+            <a:schemeClr val="lt1"/>
+          </a:fontRef>
+        </p:style>
+        <p:txBody>
+          <a:bodyPr rtlCol="0" anchor="ctr" wrap="square" lIns="63500" rIns="50800" tIns="38100" bIns="38100"/>
+          <a:lstStyle/>
+          <a:p>
+            <a:pPr algn="l"/>
+            <a:r>
+              <a:rPr sz="1000" b="0">
+                <a:solidFill>
+                  <a:srgbClr val="222222"/>
+                </a:solidFill>
+                <a:latin typeface="Meiryo"/>
+              </a:rPr>
+              <a:t>「既知の悪いもの」をブロック
+→ 未知の攻撃は素通り
+→ ScreenConnectは正規ツール → ブロックされない</a:t>
+            </a:r>
+          </a:p>
+        </p:txBody>
+      </p:sp>
+      <p:sp>
+        <p:nvSpPr>
+          <p:cNvPr id="6" name="Rectangle 5"/>
+          <p:cNvSpPr/>
+          <p:nvPr/>
+        </p:nvSpPr>
+        <p:spPr>
+          <a:xfrm>
+            <a:off x="7772400" y="1051560"/>
+            <a:ext cx="6400800" cy="411480"/>
+          </a:xfrm>
+          <a:prstGeom prst="rect">
+            <a:avLst/>
+          </a:prstGeom>
+          <a:solidFill>
+            <a:srgbClr val="27AE60"/>
+          </a:solidFill>
+          <a:ln>
+            <a:noFill/>
+          </a:ln>
+        </p:spPr>
+        <p:style>
+          <a:lnRef idx="1">
+            <a:schemeClr val="accent1"/>
+          </a:lnRef>
+          <a:fillRef idx="3">
+            <a:schemeClr val="accent1"/>
+          </a:fillRef>
+          <a:effectRef idx="2">
+            <a:schemeClr val="accent1"/>
+          </a:effectRef>
+          <a:fontRef idx="minor">
+            <a:schemeClr val="lt1"/>
+          </a:fontRef>
+        </p:style>
+        <p:txBody>
+          <a:bodyPr rtlCol="0" anchor="ctr" wrap="square" lIns="50800" rIns="50800" tIns="25400" bIns="25400"/>
+          <a:lstStyle/>
+          <a:p>
+            <a:pPr algn="ctr"/>
+            <a:r>
+              <a:rPr sz="1100" b="1">
+                <a:solidFill>
+                  <a:srgbClr val="FFFFFF"/>
+                </a:solidFill>
+                <a:latin typeface="Meiryo"/>
+              </a:rPr>
+              <a:t>ホワイトリスト型（AppLocker / WDAC）</a:t>
+            </a:r>
+          </a:p>
+        </p:txBody>
+      </p:sp>
+      <p:sp>
+        <p:nvSpPr>
+          <p:cNvPr id="7" name="Rectangle 6"/>
+          <p:cNvSpPr/>
+          <p:nvPr/>
+        </p:nvSpPr>
+        <p:spPr>
+          <a:xfrm>
+            <a:off x="7772400" y="1463039"/>
+            <a:ext cx="6400800" cy="731520"/>
+          </a:xfrm>
+          <a:prstGeom prst="rect">
+            <a:avLst/>
+          </a:prstGeom>
+          <a:solidFill>
+            <a:srgbClr val="FFFFFF"/>
+          </a:solidFill>
+          <a:ln w="25400">
+            <a:solidFill>
+              <a:srgbClr val="27AE60"/>
+            </a:solidFill>
+          </a:ln>
+        </p:spPr>
+        <p:style>
+          <a:lnRef idx="1">
+            <a:schemeClr val="accent1"/>
+          </a:lnRef>
+          <a:fillRef idx="3">
+            <a:schemeClr val="accent1"/>
+          </a:fillRef>
+          <a:effectRef idx="2">
+            <a:schemeClr val="accent1"/>
+          </a:effectRef>
+          <a:fontRef idx="minor">
+            <a:schemeClr val="lt1"/>
+          </a:fontRef>
+        </p:style>
+        <p:txBody>
+          <a:bodyPr rtlCol="0" anchor="ctr" wrap="square" lIns="63500" rIns="50800" tIns="38100" bIns="38100"/>
+          <a:lstStyle/>
+          <a:p>
+            <a:pPr algn="l"/>
+            <a:r>
+              <a:rPr sz="1000" b="0">
+                <a:solidFill>
+                  <a:srgbClr val="222222"/>
+                </a:solidFill>
+                <a:latin typeface="Meiryo"/>
+              </a:rPr>
+              <a:t>「許可されたものだけ」実行可能
+→ 許可リストにないものは全部止まる
+→ ScreenConnectが許可リストにない → 実行できない</a:t>
+            </a:r>
+          </a:p>
+        </p:txBody>
+      </p:sp>
+      <p:sp>
+        <p:nvSpPr>
+          <p:cNvPr id="8" name="Rectangle 7"/>
+          <p:cNvSpPr/>
+          <p:nvPr/>
+        </p:nvSpPr>
+        <p:spPr>
+          <a:xfrm>
+            <a:off x="731520" y="2423160"/>
+            <a:ext cx="13624560" cy="365760"/>
+          </a:xfrm>
+          <a:prstGeom prst="rect">
+            <a:avLst/>
+          </a:prstGeom>
+          <a:solidFill>
+            <a:srgbClr val="222222"/>
+          </a:solidFill>
+          <a:ln>
+            <a:noFill/>
+          </a:ln>
+        </p:spPr>
+        <p:style>
+          <a:lnRef idx="1">
+            <a:schemeClr val="accent1"/>
+          </a:lnRef>
+          <a:fillRef idx="3">
+            <a:schemeClr val="accent1"/>
+          </a:fillRef>
+          <a:effectRef idx="2">
+            <a:schemeClr val="accent1"/>
+          </a:effectRef>
+          <a:fontRef idx="minor">
+            <a:schemeClr val="lt1"/>
+          </a:fontRef>
+        </p:style>
+        <p:txBody>
+          <a:bodyPr rtlCol="0" anchor="ctr" wrap="square" lIns="50800" rIns="50800" tIns="25400" bIns="25400"/>
+          <a:lstStyle/>
+          <a:p>
+            <a:pPr algn="ctr"/>
+            <a:r>
+              <a:rPr sz="1200" b="1">
+                <a:solidFill>
+                  <a:srgbClr val="FFFFFF"/>
+                </a:solidFill>
+                <a:latin typeface="Meiryo"/>
+              </a:rPr>
+              <a:t>Windowsに標準搭載されているツール</a:t>
+            </a:r>
+          </a:p>
+        </p:txBody>
+      </p:sp>
+      <p:sp>
+        <p:nvSpPr>
+          <p:cNvPr id="9" name="Rectangle 8"/>
+          <p:cNvSpPr/>
+          <p:nvPr/>
+        </p:nvSpPr>
+        <p:spPr>
+          <a:xfrm>
+            <a:off x="731520" y="2788920"/>
+            <a:ext cx="1828800" cy="365760"/>
+          </a:xfrm>
+          <a:prstGeom prst="rect">
+            <a:avLst/>
+          </a:prstGeom>
+          <a:solidFill>
+            <a:srgbClr val="34495E"/>
+          </a:solidFill>
+          <a:ln>
+            <a:noFill/>
+          </a:ln>
+        </p:spPr>
+        <p:style>
+          <a:lnRef idx="1">
+            <a:schemeClr val="accent1"/>
+          </a:lnRef>
+          <a:fillRef idx="3">
+            <a:schemeClr val="accent1"/>
+          </a:fillRef>
+          <a:effectRef idx="2">
+            <a:schemeClr val="accent1"/>
+          </a:effectRef>
+          <a:fontRef idx="minor">
+            <a:schemeClr val="lt1"/>
+          </a:fontRef>
+        </p:style>
+        <p:txBody>
+          <a:bodyPr rtlCol="0" anchor="ctr" wrap="square" lIns="50800" rIns="50800" tIns="25400" bIns="25400"/>
+          <a:lstStyle/>
+          <a:p>
+            <a:pPr algn="ctr"/>
+            <a:r>
+              <a:rPr sz="900" b="1">
+                <a:solidFill>
+                  <a:srgbClr val="FFFFFF"/>
+                </a:solidFill>
+                <a:latin typeface="Meiryo"/>
+              </a:rPr>
+              <a:t>ツール</a:t>
+            </a:r>
+          </a:p>
+        </p:txBody>
+      </p:sp>
+      <p:sp>
+        <p:nvSpPr>
+          <p:cNvPr id="10" name="Rectangle 9"/>
+          <p:cNvSpPr/>
+          <p:nvPr/>
+        </p:nvSpPr>
+        <p:spPr>
+          <a:xfrm>
+            <a:off x="2560320" y="2788920"/>
+            <a:ext cx="1645920" cy="365760"/>
+          </a:xfrm>
+          <a:prstGeom prst="rect">
+            <a:avLst/>
+          </a:prstGeom>
+          <a:solidFill>
+            <a:srgbClr val="34495E"/>
+          </a:solidFill>
+          <a:ln>
+            <a:noFill/>
+          </a:ln>
+        </p:spPr>
+        <p:style>
+          <a:lnRef idx="1">
+            <a:schemeClr val="accent1"/>
+          </a:lnRef>
+          <a:fillRef idx="3">
+            <a:schemeClr val="accent1"/>
+          </a:fillRef>
+          <a:effectRef idx="2">
+            <a:schemeClr val="accent1"/>
+          </a:effectRef>
+          <a:fontRef idx="minor">
+            <a:schemeClr val="lt1"/>
+          </a:fontRef>
+        </p:style>
+        <p:txBody>
+          <a:bodyPr rtlCol="0" anchor="ctr" wrap="square" lIns="50800" rIns="50800" tIns="25400" bIns="25400"/>
+          <a:lstStyle/>
+          <a:p>
+            <a:pPr algn="ctr"/>
+            <a:r>
+              <a:rPr sz="900" b="1">
+                <a:solidFill>
+                  <a:srgbClr val="FFFFFF"/>
+                </a:solidFill>
+                <a:latin typeface="Meiryo"/>
+              </a:rPr>
+              <a:t>提供元</a:t>
+            </a:r>
+          </a:p>
+        </p:txBody>
+      </p:sp>
+      <p:sp>
+        <p:nvSpPr>
+          <p:cNvPr id="11" name="Rectangle 10"/>
+          <p:cNvSpPr/>
+          <p:nvPr/>
+        </p:nvSpPr>
+        <p:spPr>
+          <a:xfrm>
+            <a:off x="4206240" y="2788920"/>
+            <a:ext cx="3474720" cy="365760"/>
+          </a:xfrm>
+          <a:prstGeom prst="rect">
+            <a:avLst/>
+          </a:prstGeom>
+          <a:solidFill>
+            <a:srgbClr val="34495E"/>
+          </a:solidFill>
+          <a:ln>
+            <a:noFill/>
+          </a:ln>
+        </p:spPr>
+        <p:style>
+          <a:lnRef idx="1">
+            <a:schemeClr val="accent1"/>
+          </a:lnRef>
+          <a:fillRef idx="3">
+            <a:schemeClr val="accent1"/>
+          </a:fillRef>
+          <a:effectRef idx="2">
+            <a:schemeClr val="accent1"/>
+          </a:effectRef>
+          <a:fontRef idx="minor">
+            <a:schemeClr val="lt1"/>
+          </a:fontRef>
+        </p:style>
+        <p:txBody>
+          <a:bodyPr rtlCol="0" anchor="ctr" wrap="square" lIns="50800" rIns="50800" tIns="25400" bIns="25400"/>
+          <a:lstStyle/>
+          <a:p>
+            <a:pPr algn="ctr"/>
+            <a:r>
+              <a:rPr sz="900" b="1">
+                <a:solidFill>
+                  <a:srgbClr val="FFFFFF"/>
+                </a:solidFill>
+                <a:latin typeface="Meiryo"/>
+              </a:rPr>
+              <a:t>対象OS</a:t>
+            </a:r>
+          </a:p>
+        </p:txBody>
+      </p:sp>
+      <p:sp>
+        <p:nvSpPr>
+          <p:cNvPr id="12" name="Rectangle 11"/>
+          <p:cNvSpPr/>
+          <p:nvPr/>
+        </p:nvSpPr>
+        <p:spPr>
+          <a:xfrm>
+            <a:off x="7680959" y="2788920"/>
+            <a:ext cx="3657600" cy="365760"/>
+          </a:xfrm>
+          <a:prstGeom prst="rect">
+            <a:avLst/>
+          </a:prstGeom>
+          <a:solidFill>
+            <a:srgbClr val="34495E"/>
+          </a:solidFill>
+          <a:ln>
+            <a:noFill/>
+          </a:ln>
+        </p:spPr>
+        <p:style>
+          <a:lnRef idx="1">
+            <a:schemeClr val="accent1"/>
+          </a:lnRef>
+          <a:fillRef idx="3">
+            <a:schemeClr val="accent1"/>
+          </a:fillRef>
+          <a:effectRef idx="2">
+            <a:schemeClr val="accent1"/>
+          </a:effectRef>
+          <a:fontRef idx="minor">
+            <a:schemeClr val="lt1"/>
+          </a:fontRef>
+        </p:style>
+        <p:txBody>
+          <a:bodyPr rtlCol="0" anchor="ctr" wrap="square" lIns="50800" rIns="50800" tIns="25400" bIns="25400"/>
+          <a:lstStyle/>
+          <a:p>
+            <a:pPr algn="ctr"/>
+            <a:r>
+              <a:rPr sz="900" b="1">
+                <a:solidFill>
+                  <a:srgbClr val="FFFFFF"/>
+                </a:solidFill>
+                <a:latin typeface="Meiryo"/>
+              </a:rPr>
+              <a:t>制御範囲</a:t>
+            </a:r>
+          </a:p>
+        </p:txBody>
+      </p:sp>
+      <p:sp>
+        <p:nvSpPr>
+          <p:cNvPr id="13" name="Rectangle 12"/>
+          <p:cNvSpPr/>
+          <p:nvPr/>
+        </p:nvSpPr>
+        <p:spPr>
+          <a:xfrm>
+            <a:off x="11338559" y="2788920"/>
+            <a:ext cx="3017520" cy="365760"/>
+          </a:xfrm>
+          <a:prstGeom prst="rect">
+            <a:avLst/>
+          </a:prstGeom>
+          <a:solidFill>
+            <a:srgbClr val="34495E"/>
+          </a:solidFill>
+          <a:ln>
+            <a:noFill/>
+          </a:ln>
+        </p:spPr>
+        <p:style>
+          <a:lnRef idx="1">
+            <a:schemeClr val="accent1"/>
+          </a:lnRef>
+          <a:fillRef idx="3">
+            <a:schemeClr val="accent1"/>
+          </a:fillRef>
+          <a:effectRef idx="2">
+            <a:schemeClr val="accent1"/>
+          </a:effectRef>
+          <a:fontRef idx="minor">
+            <a:schemeClr val="lt1"/>
+          </a:fontRef>
+        </p:style>
+        <p:txBody>
+          <a:bodyPr rtlCol="0" anchor="ctr" wrap="square" lIns="50800" rIns="50800" tIns="25400" bIns="25400"/>
+          <a:lstStyle/>
+          <a:p>
+            <a:pPr algn="ctr"/>
+            <a:r>
+              <a:rPr sz="900" b="1">
+                <a:solidFill>
+                  <a:srgbClr val="FFFFFF"/>
+                </a:solidFill>
+                <a:latin typeface="Meiryo"/>
+              </a:rPr>
+              <a:t>設定方法</a:t>
+            </a:r>
+          </a:p>
+        </p:txBody>
+      </p:sp>
+      <p:sp>
+        <p:nvSpPr>
+          <p:cNvPr id="14" name="Rectangle 13"/>
+          <p:cNvSpPr/>
+          <p:nvPr/>
+        </p:nvSpPr>
+        <p:spPr>
+          <a:xfrm>
+            <a:off x="731520" y="3154680"/>
+            <a:ext cx="1828800" cy="411480"/>
+          </a:xfrm>
+          <a:prstGeom prst="rect">
+            <a:avLst/>
+          </a:prstGeom>
+          <a:solidFill>
+            <a:srgbClr val="FFFFFF"/>
+          </a:solidFill>
+          <a:ln w="25400">
+            <a:solidFill>
+              <a:srgbClr val="CCCCCC"/>
+            </a:solidFill>
+          </a:ln>
+        </p:spPr>
+        <p:style>
+          <a:lnRef idx="1">
+            <a:schemeClr val="accent1"/>
+          </a:lnRef>
+          <a:fillRef idx="3">
+            <a:schemeClr val="accent1"/>
+          </a:fillRef>
+          <a:effectRef idx="2">
+            <a:schemeClr val="accent1"/>
+          </a:effectRef>
+          <a:fontRef idx="minor">
+            <a:schemeClr val="lt1"/>
+          </a:fontRef>
+        </p:style>
+        <p:txBody>
+          <a:bodyPr rtlCol="0" anchor="ctr" wrap="square" lIns="63500" rIns="50800" tIns="38100" bIns="38100"/>
+          <a:lstStyle/>
+          <a:p>
+            <a:pPr algn="l"/>
+            <a:r>
+              <a:rPr sz="900" b="1">
+                <a:solidFill>
+                  <a:srgbClr val="222222"/>
+                </a:solidFill>
+                <a:latin typeface="Meiryo"/>
+              </a:rPr>
+              <a:t>AppLocker</a:t>
+            </a:r>
+          </a:p>
+        </p:txBody>
+      </p:sp>
+      <p:sp>
+        <p:nvSpPr>
+          <p:cNvPr id="15" name="Rectangle 14"/>
+          <p:cNvSpPr/>
+          <p:nvPr/>
+        </p:nvSpPr>
+        <p:spPr>
+          <a:xfrm>
+            <a:off x="2560320" y="3154680"/>
+            <a:ext cx="1645920" cy="411480"/>
+          </a:xfrm>
+          <a:prstGeom prst="rect">
+            <a:avLst/>
+          </a:prstGeom>
+          <a:solidFill>
+            <a:srgbClr val="FFFFFF"/>
+          </a:solidFill>
+          <a:ln w="25400">
+            <a:solidFill>
+              <a:srgbClr val="CCCCCC"/>
+            </a:solidFill>
+          </a:ln>
+        </p:spPr>
+        <p:style>
+          <a:lnRef idx="1">
+            <a:schemeClr val="accent1"/>
+          </a:lnRef>
+          <a:fillRef idx="3">
+            <a:schemeClr val="accent1"/>
+          </a:fillRef>
+          <a:effectRef idx="2">
+            <a:schemeClr val="accent1"/>
+          </a:effectRef>
+          <a:fontRef idx="minor">
+            <a:schemeClr val="lt1"/>
+          </a:fontRef>
+        </p:style>
+        <p:txBody>
+          <a:bodyPr rtlCol="0" anchor="ctr" wrap="square" lIns="63500" rIns="50800" tIns="38100" bIns="38100"/>
+          <a:lstStyle/>
+          <a:p>
+            <a:pPr algn="l"/>
+            <a:r>
+              <a:rPr sz="900" b="0">
+                <a:solidFill>
+                  <a:srgbClr val="222222"/>
+                </a:solidFill>
+                <a:latin typeface="Meiryo"/>
+              </a:rPr>
+              <a:t>Microsoft</a:t>
+            </a:r>
+          </a:p>
+        </p:txBody>
+      </p:sp>
+      <p:sp>
+        <p:nvSpPr>
+          <p:cNvPr id="16" name="Rectangle 15"/>
+          <p:cNvSpPr/>
+          <p:nvPr/>
+        </p:nvSpPr>
+        <p:spPr>
+          <a:xfrm>
+            <a:off x="4206240" y="3154680"/>
+            <a:ext cx="3474720" cy="411480"/>
+          </a:xfrm>
+          <a:prstGeom prst="rect">
+            <a:avLst/>
+          </a:prstGeom>
+          <a:solidFill>
+            <a:srgbClr val="FFFFFF"/>
+          </a:solidFill>
+          <a:ln w="25400">
+            <a:solidFill>
+              <a:srgbClr val="CCCCCC"/>
+            </a:solidFill>
+          </a:ln>
+        </p:spPr>
+        <p:style>
+          <a:lnRef idx="1">
+            <a:schemeClr val="accent1"/>
+          </a:lnRef>
+          <a:fillRef idx="3">
+            <a:schemeClr val="accent1"/>
+          </a:fillRef>
+          <a:effectRef idx="2">
+            <a:schemeClr val="accent1"/>
+          </a:effectRef>
+          <a:fontRef idx="minor">
+            <a:schemeClr val="lt1"/>
+          </a:fontRef>
+        </p:style>
+        <p:txBody>
+          <a:bodyPr rtlCol="0" anchor="ctr" wrap="square" lIns="63500" rIns="50800" tIns="38100" bIns="38100"/>
+          <a:lstStyle/>
+          <a:p>
+            <a:pPr algn="l"/>
+            <a:r>
+              <a:rPr sz="900" b="0">
+                <a:solidFill>
+                  <a:srgbClr val="222222"/>
+                </a:solidFill>
+                <a:latin typeface="Meiryo"/>
+              </a:rPr>
+              <a:t>Windows 10/11 Enterprise / Education</a:t>
+            </a:r>
+          </a:p>
+        </p:txBody>
+      </p:sp>
+      <p:sp>
+        <p:nvSpPr>
+          <p:cNvPr id="17" name="Rectangle 16"/>
+          <p:cNvSpPr/>
+          <p:nvPr/>
+        </p:nvSpPr>
+        <p:spPr>
+          <a:xfrm>
+            <a:off x="7680959" y="3154680"/>
+            <a:ext cx="3657600" cy="411480"/>
+          </a:xfrm>
+          <a:prstGeom prst="rect">
+            <a:avLst/>
+          </a:prstGeom>
+          <a:solidFill>
+            <a:srgbClr val="FFFFFF"/>
+          </a:solidFill>
+          <a:ln w="25400">
+            <a:solidFill>
+              <a:srgbClr val="CCCCCC"/>
+            </a:solidFill>
+          </a:ln>
+        </p:spPr>
+        <p:style>
+          <a:lnRef idx="1">
+            <a:schemeClr val="accent1"/>
+          </a:lnRef>
+          <a:fillRef idx="3">
+            <a:schemeClr val="accent1"/>
+          </a:fillRef>
+          <a:effectRef idx="2">
+            <a:schemeClr val="accent1"/>
+          </a:effectRef>
+          <a:fontRef idx="minor">
+            <a:schemeClr val="lt1"/>
+          </a:fontRef>
+        </p:style>
+        <p:txBody>
+          <a:bodyPr rtlCol="0" anchor="ctr" wrap="square" lIns="63500" rIns="50800" tIns="38100" bIns="38100"/>
+          <a:lstStyle/>
+          <a:p>
+            <a:pPr algn="l"/>
+            <a:r>
+              <a:rPr sz="900" b="0">
+                <a:solidFill>
+                  <a:srgbClr val="222222"/>
+                </a:solidFill>
+                <a:latin typeface="Meiryo"/>
+              </a:rPr>
+              <a:t>exe, msi, スクリプト, DLL</a:t>
+            </a:r>
+          </a:p>
+        </p:txBody>
+      </p:sp>
+      <p:sp>
+        <p:nvSpPr>
+          <p:cNvPr id="18" name="Rectangle 17"/>
+          <p:cNvSpPr/>
+          <p:nvPr/>
+        </p:nvSpPr>
+        <p:spPr>
+          <a:xfrm>
+            <a:off x="11338559" y="3154680"/>
+            <a:ext cx="3017520" cy="411480"/>
+          </a:xfrm>
+          <a:prstGeom prst="rect">
+            <a:avLst/>
+          </a:prstGeom>
+          <a:solidFill>
+            <a:srgbClr val="FFFFFF"/>
+          </a:solidFill>
+          <a:ln w="25400">
+            <a:solidFill>
+              <a:srgbClr val="CCCCCC"/>
+            </a:solidFill>
+          </a:ln>
+        </p:spPr>
+        <p:style>
+          <a:lnRef idx="1">
+            <a:schemeClr val="accent1"/>
+          </a:lnRef>
+          <a:fillRef idx="3">
+            <a:schemeClr val="accent1"/>
+          </a:fillRef>
+          <a:effectRef idx="2">
+            <a:schemeClr val="accent1"/>
+          </a:effectRef>
+          <a:fontRef idx="minor">
+            <a:schemeClr val="lt1"/>
+          </a:fontRef>
+        </p:style>
+        <p:txBody>
+          <a:bodyPr rtlCol="0" anchor="ctr" wrap="square" lIns="63500" rIns="50800" tIns="38100" bIns="38100"/>
+          <a:lstStyle/>
+          <a:p>
+            <a:pPr algn="l"/>
+            <a:r>
+              <a:rPr sz="900" b="0">
+                <a:solidFill>
+                  <a:srgbClr val="222222"/>
+                </a:solidFill>
+                <a:latin typeface="Meiryo"/>
+              </a:rPr>
+              <a:t>グループポリシーで設定</a:t>
+            </a:r>
+          </a:p>
+        </p:txBody>
+      </p:sp>
+      <p:sp>
+        <p:nvSpPr>
+          <p:cNvPr id="19" name="Rectangle 18"/>
+          <p:cNvSpPr/>
+          <p:nvPr/>
+        </p:nvSpPr>
+        <p:spPr>
+          <a:xfrm>
+            <a:off x="731520" y="3566160"/>
+            <a:ext cx="1828800" cy="411480"/>
+          </a:xfrm>
+          <a:prstGeom prst="rect">
+            <a:avLst/>
+          </a:prstGeom>
+          <a:solidFill>
+            <a:srgbClr val="F9F9F9"/>
+          </a:solidFill>
+          <a:ln w="25400">
+            <a:solidFill>
+              <a:srgbClr val="CCCCCC"/>
+            </a:solidFill>
+          </a:ln>
+        </p:spPr>
+        <p:style>
+          <a:lnRef idx="1">
+            <a:schemeClr val="accent1"/>
+          </a:lnRef>
+          <a:fillRef idx="3">
+            <a:schemeClr val="accent1"/>
+          </a:fillRef>
+          <a:effectRef idx="2">
+            <a:schemeClr val="accent1"/>
+          </a:effectRef>
+          <a:fontRef idx="minor">
+            <a:schemeClr val="lt1"/>
+          </a:fontRef>
+        </p:style>
+        <p:txBody>
+          <a:bodyPr rtlCol="0" anchor="ctr" wrap="square" lIns="63500" rIns="50800" tIns="38100" bIns="38100"/>
+          <a:lstStyle/>
+          <a:p>
+            <a:pPr algn="l"/>
+            <a:r>
+              <a:rPr sz="900" b="1">
+                <a:solidFill>
+                  <a:srgbClr val="222222"/>
+                </a:solidFill>
+                <a:latin typeface="Meiryo"/>
+              </a:rPr>
+              <a:t>WDAC</a:t>
+            </a:r>
+          </a:p>
+        </p:txBody>
+      </p:sp>
+      <p:sp>
+        <p:nvSpPr>
+          <p:cNvPr id="20" name="Rectangle 19"/>
+          <p:cNvSpPr/>
+          <p:nvPr/>
+        </p:nvSpPr>
+        <p:spPr>
+          <a:xfrm>
+            <a:off x="2560320" y="3566160"/>
+            <a:ext cx="1645920" cy="411480"/>
+          </a:xfrm>
+          <a:prstGeom prst="rect">
+            <a:avLst/>
+          </a:prstGeom>
+          <a:solidFill>
+            <a:srgbClr val="F9F9F9"/>
+          </a:solidFill>
+          <a:ln w="25400">
+            <a:solidFill>
+              <a:srgbClr val="CCCCCC"/>
+            </a:solidFill>
+          </a:ln>
+        </p:spPr>
+        <p:style>
+          <a:lnRef idx="1">
+            <a:schemeClr val="accent1"/>
+          </a:lnRef>
+          <a:fillRef idx="3">
+            <a:schemeClr val="accent1"/>
+          </a:fillRef>
+          <a:effectRef idx="2">
+            <a:schemeClr val="accent1"/>
+          </a:effectRef>
+          <a:fontRef idx="minor">
+            <a:schemeClr val="lt1"/>
+          </a:fontRef>
+        </p:style>
+        <p:txBody>
+          <a:bodyPr rtlCol="0" anchor="ctr" wrap="square" lIns="63500" rIns="50800" tIns="38100" bIns="38100"/>
+          <a:lstStyle/>
+          <a:p>
+            <a:pPr algn="l"/>
+            <a:r>
+              <a:rPr sz="900" b="0">
+                <a:solidFill>
+                  <a:srgbClr val="222222"/>
+                </a:solidFill>
+                <a:latin typeface="Meiryo"/>
+              </a:rPr>
+              <a:t>Microsoft</a:t>
+            </a:r>
+          </a:p>
+        </p:txBody>
+      </p:sp>
+      <p:sp>
+        <p:nvSpPr>
+          <p:cNvPr id="21" name="Rectangle 20"/>
+          <p:cNvSpPr/>
+          <p:nvPr/>
+        </p:nvSpPr>
+        <p:spPr>
+          <a:xfrm>
+            <a:off x="4206240" y="3566160"/>
+            <a:ext cx="3474720" cy="411480"/>
+          </a:xfrm>
+          <a:prstGeom prst="rect">
+            <a:avLst/>
+          </a:prstGeom>
+          <a:solidFill>
+            <a:srgbClr val="F9F9F9"/>
+          </a:solidFill>
+          <a:ln w="25400">
+            <a:solidFill>
+              <a:srgbClr val="CCCCCC"/>
+            </a:solidFill>
+          </a:ln>
+        </p:spPr>
+        <p:style>
+          <a:lnRef idx="1">
+            <a:schemeClr val="accent1"/>
+          </a:lnRef>
+          <a:fillRef idx="3">
+            <a:schemeClr val="accent1"/>
+          </a:fillRef>
+          <a:effectRef idx="2">
+            <a:schemeClr val="accent1"/>
+          </a:effectRef>
+          <a:fontRef idx="minor">
+            <a:schemeClr val="lt1"/>
+          </a:fontRef>
+        </p:style>
+        <p:txBody>
+          <a:bodyPr rtlCol="0" anchor="ctr" wrap="square" lIns="63500" rIns="50800" tIns="38100" bIns="38100"/>
+          <a:lstStyle/>
+          <a:p>
+            <a:pPr algn="l"/>
+            <a:r>
+              <a:rPr sz="900" b="0">
+                <a:solidFill>
+                  <a:srgbClr val="222222"/>
+                </a:solidFill>
+                <a:latin typeface="Meiryo"/>
+              </a:rPr>
+              <a:t>Windows 10/11 全エディション</a:t>
+            </a:r>
+          </a:p>
+        </p:txBody>
+      </p:sp>
+      <p:sp>
+        <p:nvSpPr>
+          <p:cNvPr id="22" name="Rectangle 21"/>
+          <p:cNvSpPr/>
+          <p:nvPr/>
+        </p:nvSpPr>
+        <p:spPr>
+          <a:xfrm>
+            <a:off x="7680959" y="3566160"/>
+            <a:ext cx="3657600" cy="411480"/>
+          </a:xfrm>
+          <a:prstGeom prst="rect">
+            <a:avLst/>
+          </a:prstGeom>
+          <a:solidFill>
+            <a:srgbClr val="F9F9F9"/>
+          </a:solidFill>
+          <a:ln w="25400">
+            <a:solidFill>
+              <a:srgbClr val="CCCCCC"/>
+            </a:solidFill>
+          </a:ln>
+        </p:spPr>
+        <p:style>
+          <a:lnRef idx="1">
+            <a:schemeClr val="accent1"/>
+          </a:lnRef>
+          <a:fillRef idx="3">
+            <a:schemeClr val="accent1"/>
+          </a:fillRef>
+          <a:effectRef idx="2">
+            <a:schemeClr val="accent1"/>
+          </a:effectRef>
+          <a:fontRef idx="minor">
+            <a:schemeClr val="lt1"/>
+          </a:fontRef>
+        </p:style>
+        <p:txBody>
+          <a:bodyPr rtlCol="0" anchor="ctr" wrap="square" lIns="63500" rIns="50800" tIns="38100" bIns="38100"/>
+          <a:lstStyle/>
+          <a:p>
+            <a:pPr algn="l"/>
+            <a:r>
+              <a:rPr sz="900" b="0">
+                <a:solidFill>
+                  <a:srgbClr val="222222"/>
+                </a:solidFill>
+                <a:latin typeface="Meiryo"/>
+              </a:rPr>
+              <a:t>カーネルレベルで制御（より強力）</a:t>
+            </a:r>
+          </a:p>
+        </p:txBody>
+      </p:sp>
+      <p:sp>
+        <p:nvSpPr>
+          <p:cNvPr id="23" name="Rectangle 22"/>
+          <p:cNvSpPr/>
+          <p:nvPr/>
+        </p:nvSpPr>
+        <p:spPr>
+          <a:xfrm>
+            <a:off x="11338559" y="3566160"/>
+            <a:ext cx="3017520" cy="411480"/>
+          </a:xfrm>
+          <a:prstGeom prst="rect">
+            <a:avLst/>
+          </a:prstGeom>
+          <a:solidFill>
+            <a:srgbClr val="F9F9F9"/>
+          </a:solidFill>
+          <a:ln w="25400">
+            <a:solidFill>
+              <a:srgbClr val="CCCCCC"/>
+            </a:solidFill>
+          </a:ln>
+        </p:spPr>
+        <p:style>
+          <a:lnRef idx="1">
+            <a:schemeClr val="accent1"/>
+          </a:lnRef>
+          <a:fillRef idx="3">
+            <a:schemeClr val="accent1"/>
+          </a:fillRef>
+          <a:effectRef idx="2">
+            <a:schemeClr val="accent1"/>
+          </a:effectRef>
+          <a:fontRef idx="minor">
+            <a:schemeClr val="lt1"/>
+          </a:fontRef>
+        </p:style>
+        <p:txBody>
+          <a:bodyPr rtlCol="0" anchor="ctr" wrap="square" lIns="63500" rIns="50800" tIns="38100" bIns="38100"/>
+          <a:lstStyle/>
+          <a:p>
+            <a:pPr algn="l"/>
+            <a:r>
+              <a:rPr sz="900" b="0">
+                <a:solidFill>
+                  <a:srgbClr val="222222"/>
+                </a:solidFill>
+                <a:latin typeface="Meiryo"/>
+              </a:rPr>
+              <a:t>PowerShell / Intune等</a:t>
+            </a:r>
+          </a:p>
+        </p:txBody>
+      </p:sp>
+      <p:sp>
+        <p:nvSpPr>
+          <p:cNvPr id="24" name="Rectangle 23"/>
+          <p:cNvSpPr/>
+          <p:nvPr/>
+        </p:nvSpPr>
+        <p:spPr>
+          <a:xfrm>
+            <a:off x="731520" y="3977640"/>
+            <a:ext cx="1828800" cy="411480"/>
+          </a:xfrm>
+          <a:prstGeom prst="rect">
+            <a:avLst/>
+          </a:prstGeom>
+          <a:solidFill>
+            <a:srgbClr val="FFFFFF"/>
+          </a:solidFill>
+          <a:ln w="25400">
+            <a:solidFill>
+              <a:srgbClr val="CCCCCC"/>
+            </a:solidFill>
+          </a:ln>
+        </p:spPr>
+        <p:style>
+          <a:lnRef idx="1">
+            <a:schemeClr val="accent1"/>
+          </a:lnRef>
+          <a:fillRef idx="3">
+            <a:schemeClr val="accent1"/>
+          </a:fillRef>
+          <a:effectRef idx="2">
+            <a:schemeClr val="accent1"/>
+          </a:effectRef>
+          <a:fontRef idx="minor">
+            <a:schemeClr val="lt1"/>
+          </a:fontRef>
+        </p:style>
+        <p:txBody>
+          <a:bodyPr rtlCol="0" anchor="ctr" wrap="square" lIns="63500" rIns="50800" tIns="38100" bIns="38100"/>
+          <a:lstStyle/>
+          <a:p>
+            <a:pPr algn="l"/>
+            <a:r>
+              <a:rPr sz="900" b="1">
+                <a:solidFill>
+                  <a:srgbClr val="222222"/>
+                </a:solidFill>
+                <a:latin typeface="Meiryo"/>
+              </a:rPr>
+              <a:t>MDM連携</a:t>
+            </a:r>
+          </a:p>
+        </p:txBody>
+      </p:sp>
+      <p:sp>
+        <p:nvSpPr>
+          <p:cNvPr id="25" name="Rectangle 24"/>
+          <p:cNvSpPr/>
+          <p:nvPr/>
+        </p:nvSpPr>
+        <p:spPr>
+          <a:xfrm>
+            <a:off x="2560320" y="3977640"/>
+            <a:ext cx="1645920" cy="411480"/>
+          </a:xfrm>
+          <a:prstGeom prst="rect">
+            <a:avLst/>
+          </a:prstGeom>
+          <a:solidFill>
+            <a:srgbClr val="FFFFFF"/>
+          </a:solidFill>
+          <a:ln w="25400">
+            <a:solidFill>
+              <a:srgbClr val="CCCCCC"/>
+            </a:solidFill>
+          </a:ln>
+        </p:spPr>
+        <p:style>
+          <a:lnRef idx="1">
+            <a:schemeClr val="accent1"/>
+          </a:lnRef>
+          <a:fillRef idx="3">
+            <a:schemeClr val="accent1"/>
+          </a:fillRef>
+          <a:effectRef idx="2">
+            <a:schemeClr val="accent1"/>
+          </a:effectRef>
+          <a:fontRef idx="minor">
+            <a:schemeClr val="lt1"/>
+          </a:fontRef>
+        </p:style>
+        <p:txBody>
+          <a:bodyPr rtlCol="0" anchor="ctr" wrap="square" lIns="63500" rIns="50800" tIns="38100" bIns="38100"/>
+          <a:lstStyle/>
+          <a:p>
+            <a:pPr algn="l"/>
+            <a:r>
+              <a:rPr sz="900" b="0">
+                <a:solidFill>
+                  <a:srgbClr val="222222"/>
+                </a:solidFill>
+                <a:latin typeface="Meiryo"/>
+              </a:rPr>
+              <a:t>Intune等</a:t>
+            </a:r>
+          </a:p>
+        </p:txBody>
+      </p:sp>
+      <p:sp>
+        <p:nvSpPr>
+          <p:cNvPr id="26" name="Rectangle 25"/>
+          <p:cNvSpPr/>
+          <p:nvPr/>
+        </p:nvSpPr>
+        <p:spPr>
+          <a:xfrm>
+            <a:off x="4206240" y="3977640"/>
+            <a:ext cx="3474720" cy="411480"/>
+          </a:xfrm>
+          <a:prstGeom prst="rect">
+            <a:avLst/>
+          </a:prstGeom>
+          <a:solidFill>
+            <a:srgbClr val="FFFFFF"/>
+          </a:solidFill>
+          <a:ln w="25400">
+            <a:solidFill>
+              <a:srgbClr val="CCCCCC"/>
+            </a:solidFill>
+          </a:ln>
+        </p:spPr>
+        <p:style>
+          <a:lnRef idx="1">
+            <a:schemeClr val="accent1"/>
+          </a:lnRef>
+          <a:fillRef idx="3">
+            <a:schemeClr val="accent1"/>
+          </a:fillRef>
+          <a:effectRef idx="2">
+            <a:schemeClr val="accent1"/>
+          </a:effectRef>
+          <a:fontRef idx="minor">
+            <a:schemeClr val="lt1"/>
+          </a:fontRef>
+        </p:style>
+        <p:txBody>
+          <a:bodyPr rtlCol="0" anchor="ctr" wrap="square" lIns="63500" rIns="50800" tIns="38100" bIns="38100"/>
+          <a:lstStyle/>
+          <a:p>
+            <a:pPr algn="l"/>
+            <a:r>
+              <a:rPr sz="900" b="0">
+                <a:solidFill>
+                  <a:srgbClr val="222222"/>
+                </a:solidFill>
+                <a:latin typeface="Meiryo"/>
+              </a:rPr>
+              <a:t>全エディション（Intune契約時）</a:t>
+            </a:r>
+          </a:p>
+        </p:txBody>
+      </p:sp>
+      <p:sp>
+        <p:nvSpPr>
+          <p:cNvPr id="27" name="Rectangle 26"/>
+          <p:cNvSpPr/>
+          <p:nvPr/>
+        </p:nvSpPr>
+        <p:spPr>
+          <a:xfrm>
+            <a:off x="7680959" y="3977640"/>
+            <a:ext cx="3657600" cy="411480"/>
+          </a:xfrm>
+          <a:prstGeom prst="rect">
+            <a:avLst/>
+          </a:prstGeom>
+          <a:solidFill>
+            <a:srgbClr val="FFFFFF"/>
+          </a:solidFill>
+          <a:ln w="25400">
+            <a:solidFill>
+              <a:srgbClr val="CCCCCC"/>
+            </a:solidFill>
+          </a:ln>
+        </p:spPr>
+        <p:style>
+          <a:lnRef idx="1">
+            <a:schemeClr val="accent1"/>
+          </a:lnRef>
+          <a:fillRef idx="3">
+            <a:schemeClr val="accent1"/>
+          </a:fillRef>
+          <a:effectRef idx="2">
+            <a:schemeClr val="accent1"/>
+          </a:effectRef>
+          <a:fontRef idx="minor">
+            <a:schemeClr val="lt1"/>
+          </a:fontRef>
+        </p:style>
+        <p:txBody>
+          <a:bodyPr rtlCol="0" anchor="ctr" wrap="square" lIns="63500" rIns="50800" tIns="38100" bIns="38100"/>
+          <a:lstStyle/>
+          <a:p>
+            <a:pPr algn="l"/>
+            <a:r>
+              <a:rPr sz="900" b="0">
+                <a:solidFill>
+                  <a:srgbClr val="222222"/>
+                </a:solidFill>
+                <a:latin typeface="Meiryo"/>
+              </a:rPr>
+              <a:t>アプリ配布・制御を一元管理</a:t>
+            </a:r>
+          </a:p>
+        </p:txBody>
+      </p:sp>
+      <p:sp>
+        <p:nvSpPr>
+          <p:cNvPr id="28" name="Rectangle 27"/>
+          <p:cNvSpPr/>
+          <p:nvPr/>
+        </p:nvSpPr>
+        <p:spPr>
+          <a:xfrm>
+            <a:off x="11338559" y="3977640"/>
+            <a:ext cx="3017520" cy="411480"/>
+          </a:xfrm>
+          <a:prstGeom prst="rect">
+            <a:avLst/>
+          </a:prstGeom>
+          <a:solidFill>
+            <a:srgbClr val="FFFFFF"/>
+          </a:solidFill>
+          <a:ln w="25400">
+            <a:solidFill>
+              <a:srgbClr val="CCCCCC"/>
+            </a:solidFill>
+          </a:ln>
+        </p:spPr>
+        <p:style>
+          <a:lnRef idx="1">
+            <a:schemeClr val="accent1"/>
+          </a:lnRef>
+          <a:fillRef idx="3">
+            <a:schemeClr val="accent1"/>
+          </a:fillRef>
+          <a:effectRef idx="2">
+            <a:schemeClr val="accent1"/>
+          </a:effectRef>
+          <a:fontRef idx="minor">
+            <a:schemeClr val="lt1"/>
+          </a:fontRef>
+        </p:style>
+        <p:txBody>
+          <a:bodyPr rtlCol="0" anchor="ctr" wrap="square" lIns="63500" rIns="50800" tIns="38100" bIns="38100"/>
+          <a:lstStyle/>
+          <a:p>
+            <a:pPr algn="l"/>
+            <a:r>
+              <a:rPr sz="900" b="0">
+                <a:solidFill>
+                  <a:srgbClr val="222222"/>
+                </a:solidFill>
+                <a:latin typeface="Meiryo"/>
+              </a:rPr>
+              <a:t>クラウドから配信</a:t>
+            </a:r>
+          </a:p>
+        </p:txBody>
+      </p:sp>
+      <p:sp>
+        <p:nvSpPr>
+          <p:cNvPr id="29" name="Rectangle 28"/>
+          <p:cNvSpPr/>
+          <p:nvPr/>
+        </p:nvSpPr>
+        <p:spPr>
+          <a:xfrm>
+            <a:off x="731520" y="4480560"/>
+            <a:ext cx="13624560" cy="411480"/>
+          </a:xfrm>
+          <a:prstGeom prst="rect">
+            <a:avLst/>
+          </a:prstGeom>
+          <a:solidFill>
+            <a:srgbClr val="C0392B"/>
+          </a:solidFill>
+          <a:ln>
+            <a:noFill/>
+          </a:ln>
+        </p:spPr>
+        <p:style>
+          <a:lnRef idx="1">
+            <a:schemeClr val="accent1"/>
+          </a:lnRef>
+          <a:fillRef idx="3">
+            <a:schemeClr val="accent1"/>
+          </a:fillRef>
+          <a:effectRef idx="2">
+            <a:schemeClr val="accent1"/>
+          </a:effectRef>
+          <a:fontRef idx="minor">
+            <a:schemeClr val="lt1"/>
+          </a:fontRef>
+        </p:style>
+        <p:txBody>
+          <a:bodyPr rtlCol="0" anchor="ctr" wrap="square" lIns="50800" rIns="50800" tIns="25400" bIns="25400"/>
+          <a:lstStyle/>
+          <a:p>
+            <a:pPr algn="ctr"/>
+            <a:r>
+              <a:rPr sz="1200" b="1">
+                <a:solidFill>
+                  <a:srgbClr val="FFFFFF"/>
+                </a:solidFill>
+                <a:latin typeface="Meiryo"/>
+              </a:rPr>
+              <a:t>この攻撃に対する効果</a:t>
+            </a:r>
+          </a:p>
+        </p:txBody>
+      </p:sp>
+      <p:sp>
+        <p:nvSpPr>
+          <p:cNvPr id="30" name="Rectangle 29"/>
+          <p:cNvSpPr/>
+          <p:nvPr/>
+        </p:nvSpPr>
+        <p:spPr>
+          <a:xfrm>
+            <a:off x="731520" y="4937760"/>
+            <a:ext cx="6583680" cy="320040"/>
+          </a:xfrm>
+          <a:prstGeom prst="rect">
+            <a:avLst/>
+          </a:prstGeom>
+          <a:solidFill>
+            <a:srgbClr val="27AE60"/>
+          </a:solidFill>
+          <a:ln>
+            <a:noFill/>
+          </a:ln>
+        </p:spPr>
+        <p:style>
+          <a:lnRef idx="1">
+            <a:schemeClr val="accent1"/>
+          </a:lnRef>
+          <a:fillRef idx="3">
+            <a:schemeClr val="accent1"/>
+          </a:fillRef>
+          <a:effectRef idx="2">
+            <a:schemeClr val="accent1"/>
+          </a:effectRef>
+          <a:fontRef idx="minor">
+            <a:schemeClr val="lt1"/>
+          </a:fontRef>
+        </p:style>
+        <p:txBody>
+          <a:bodyPr rtlCol="0" anchor="ctr" wrap="square" lIns="50800" rIns="50800" tIns="25400" bIns="25400"/>
+          <a:lstStyle/>
+          <a:p>
+            <a:pPr algn="ctr"/>
+            <a:r>
+              <a:rPr sz="1000" b="1">
+                <a:solidFill>
+                  <a:srgbClr val="FFFFFF"/>
+                </a:solidFill>
+                <a:latin typeface="Meiryo"/>
+              </a:rPr>
+              <a:t>AppLocker許可リスト（設定例）</a:t>
+            </a:r>
+          </a:p>
+        </p:txBody>
+      </p:sp>
+      <p:sp>
+        <p:nvSpPr>
+          <p:cNvPr id="31" name="Rectangle 30"/>
+          <p:cNvSpPr/>
+          <p:nvPr/>
+        </p:nvSpPr>
+        <p:spPr>
+          <a:xfrm>
+            <a:off x="731520" y="5257800"/>
+            <a:ext cx="6583680" cy="274320"/>
+          </a:xfrm>
+          <a:prstGeom prst="rect">
+            <a:avLst/>
+          </a:prstGeom>
+          <a:solidFill>
+            <a:srgbClr val="EAFAF1"/>
+          </a:solidFill>
+          <a:ln w="25400">
+            <a:solidFill>
+              <a:srgbClr val="27AE60"/>
+            </a:solidFill>
+          </a:ln>
+        </p:spPr>
+        <p:style>
+          <a:lnRef idx="1">
+            <a:schemeClr val="accent1"/>
+          </a:lnRef>
+          <a:fillRef idx="3">
+            <a:schemeClr val="accent1"/>
+          </a:fillRef>
+          <a:effectRef idx="2">
+            <a:schemeClr val="accent1"/>
+          </a:effectRef>
+          <a:fontRef idx="minor">
+            <a:schemeClr val="lt1"/>
+          </a:fontRef>
+        </p:style>
+        <p:txBody>
+          <a:bodyPr rtlCol="0" anchor="ctr" wrap="square" lIns="63500" rIns="50800" tIns="38100" bIns="38100"/>
+          <a:lstStyle/>
+          <a:p>
+            <a:pPr algn="l"/>
+            <a:r>
+              <a:rPr sz="900" b="0">
+                <a:solidFill>
+                  <a:srgbClr val="27AE60"/>
+                </a:solidFill>
+                <a:latin typeface="Meiryo"/>
+              </a:rPr>
+              <a:t>✅ Microsoft Office</a:t>
+            </a:r>
+          </a:p>
+        </p:txBody>
+      </p:sp>
+      <p:sp>
+        <p:nvSpPr>
+          <p:cNvPr id="32" name="Rectangle 31"/>
+          <p:cNvSpPr/>
+          <p:nvPr/>
+        </p:nvSpPr>
+        <p:spPr>
+          <a:xfrm>
+            <a:off x="731520" y="5532120"/>
+            <a:ext cx="6583680" cy="274320"/>
+          </a:xfrm>
+          <a:prstGeom prst="rect">
+            <a:avLst/>
+          </a:prstGeom>
+          <a:solidFill>
+            <a:srgbClr val="EAFAF1"/>
+          </a:solidFill>
+          <a:ln w="25400">
+            <a:solidFill>
+              <a:srgbClr val="27AE60"/>
+            </a:solidFill>
+          </a:ln>
+        </p:spPr>
+        <p:style>
+          <a:lnRef idx="1">
+            <a:schemeClr val="accent1"/>
+          </a:lnRef>
+          <a:fillRef idx="3">
+            <a:schemeClr val="accent1"/>
+          </a:fillRef>
+          <a:effectRef idx="2">
+            <a:schemeClr val="accent1"/>
+          </a:effectRef>
+          <a:fontRef idx="minor">
+            <a:schemeClr val="lt1"/>
+          </a:fontRef>
+        </p:style>
+        <p:txBody>
+          <a:bodyPr rtlCol="0" anchor="ctr" wrap="square" lIns="63500" rIns="50800" tIns="38100" bIns="38100"/>
+          <a:lstStyle/>
+          <a:p>
+            <a:pPr algn="l"/>
+            <a:r>
+              <a:rPr sz="900" b="0">
+                <a:solidFill>
+                  <a:srgbClr val="27AE60"/>
+                </a:solidFill>
+                <a:latin typeface="Meiryo"/>
+              </a:rPr>
+              <a:t>✅ 業務アプリA, B, C</a:t>
+            </a:r>
+          </a:p>
+        </p:txBody>
+      </p:sp>
+      <p:sp>
+        <p:nvSpPr>
+          <p:cNvPr id="33" name="Rectangle 32"/>
+          <p:cNvSpPr/>
+          <p:nvPr/>
+        </p:nvSpPr>
+        <p:spPr>
+          <a:xfrm>
+            <a:off x="731520" y="5806440"/>
+            <a:ext cx="6583680" cy="274320"/>
+          </a:xfrm>
+          <a:prstGeom prst="rect">
+            <a:avLst/>
+          </a:prstGeom>
+          <a:solidFill>
+            <a:srgbClr val="EAFAF1"/>
+          </a:solidFill>
+          <a:ln w="25400">
+            <a:solidFill>
+              <a:srgbClr val="27AE60"/>
+            </a:solidFill>
+          </a:ln>
+        </p:spPr>
+        <p:style>
+          <a:lnRef idx="1">
+            <a:schemeClr val="accent1"/>
+          </a:lnRef>
+          <a:fillRef idx="3">
+            <a:schemeClr val="accent1"/>
+          </a:fillRef>
+          <a:effectRef idx="2">
+            <a:schemeClr val="accent1"/>
+          </a:effectRef>
+          <a:fontRef idx="minor">
+            <a:schemeClr val="lt1"/>
+          </a:fontRef>
+        </p:style>
+        <p:txBody>
+          <a:bodyPr rtlCol="0" anchor="ctr" wrap="square" lIns="63500" rIns="50800" tIns="38100" bIns="38100"/>
+          <a:lstStyle/>
+          <a:p>
+            <a:pPr algn="l"/>
+            <a:r>
+              <a:rPr sz="900" b="0">
+                <a:solidFill>
+                  <a:srgbClr val="27AE60"/>
+                </a:solidFill>
+                <a:latin typeface="Meiryo"/>
+              </a:rPr>
+              <a:t>✅ Rapport（IBM署名）</a:t>
+            </a:r>
+          </a:p>
+        </p:txBody>
+      </p:sp>
+      <p:sp>
+        <p:nvSpPr>
+          <p:cNvPr id="34" name="Rectangle 33"/>
+          <p:cNvSpPr/>
+          <p:nvPr/>
+        </p:nvSpPr>
+        <p:spPr>
+          <a:xfrm>
+            <a:off x="731520" y="6080760"/>
+            <a:ext cx="6583680" cy="274320"/>
+          </a:xfrm>
+          <a:prstGeom prst="rect">
+            <a:avLst/>
+          </a:prstGeom>
+          <a:solidFill>
+            <a:srgbClr val="FDEDEC"/>
+          </a:solidFill>
+          <a:ln w="25400">
+            <a:solidFill>
+              <a:srgbClr val="C0392B"/>
+            </a:solidFill>
+          </a:ln>
+        </p:spPr>
+        <p:style>
+          <a:lnRef idx="1">
+            <a:schemeClr val="accent1"/>
+          </a:lnRef>
+          <a:fillRef idx="3">
+            <a:schemeClr val="accent1"/>
+          </a:fillRef>
+          <a:effectRef idx="2">
+            <a:schemeClr val="accent1"/>
+          </a:effectRef>
+          <a:fontRef idx="minor">
+            <a:schemeClr val="lt1"/>
+          </a:fontRef>
+        </p:style>
+        <p:txBody>
+          <a:bodyPr rtlCol="0" anchor="ctr" wrap="square" lIns="63500" rIns="50800" tIns="38100" bIns="38100"/>
+          <a:lstStyle/>
+          <a:p>
+            <a:pPr algn="l"/>
+            <a:r>
+              <a:rPr sz="900" b="1">
+                <a:solidFill>
+                  <a:srgbClr val="C0392B"/>
+                </a:solidFill>
+                <a:latin typeface="Meiryo"/>
+              </a:rPr>
+              <a:t>❌ それ以外すべて → 実行拒否</a:t>
+            </a:r>
+          </a:p>
+        </p:txBody>
+      </p:sp>
+      <p:sp>
+        <p:nvSpPr>
+          <p:cNvPr id="35" name="Rectangle 34"/>
+          <p:cNvSpPr/>
+          <p:nvPr/>
+        </p:nvSpPr>
+        <p:spPr>
+          <a:xfrm>
+            <a:off x="7772400" y="4937760"/>
+            <a:ext cx="6400800" cy="320040"/>
+          </a:xfrm>
+          <a:prstGeom prst="rect">
+            <a:avLst/>
+          </a:prstGeom>
+          <a:solidFill>
+            <a:srgbClr val="C0392B"/>
+          </a:solidFill>
+          <a:ln>
+            <a:noFill/>
+          </a:ln>
+        </p:spPr>
+        <p:style>
+          <a:lnRef idx="1">
+            <a:schemeClr val="accent1"/>
+          </a:lnRef>
+          <a:fillRef idx="3">
+            <a:schemeClr val="accent1"/>
+          </a:fillRef>
+          <a:effectRef idx="2">
+            <a:schemeClr val="accent1"/>
+          </a:effectRef>
+          <a:fontRef idx="minor">
+            <a:schemeClr val="lt1"/>
+          </a:fontRef>
+        </p:style>
+        <p:txBody>
+          <a:bodyPr rtlCol="0" anchor="ctr" wrap="square" lIns="50800" rIns="50800" tIns="25400" bIns="25400"/>
+          <a:lstStyle/>
+          <a:p>
+            <a:pPr algn="ctr"/>
+            <a:r>
+              <a:rPr sz="1000" b="1">
+                <a:solidFill>
+                  <a:srgbClr val="FFFFFF"/>
+                </a:solidFill>
+                <a:latin typeface="Meiryo"/>
+              </a:rPr>
+              <a:t>攻撃時の流れ</a:t>
+            </a:r>
+          </a:p>
+        </p:txBody>
+      </p:sp>
+      <p:sp>
+        <p:nvSpPr>
+          <p:cNvPr id="36" name="Rectangle 35"/>
+          <p:cNvSpPr/>
+          <p:nvPr/>
+        </p:nvSpPr>
+        <p:spPr>
+          <a:xfrm>
+            <a:off x="7772400" y="5257800"/>
+            <a:ext cx="6400800" cy="320040"/>
+          </a:xfrm>
+          <a:prstGeom prst="rect">
+            <a:avLst/>
+          </a:prstGeom>
+          <a:solidFill>
+            <a:srgbClr val="FDF2E9"/>
+          </a:solidFill>
+          <a:ln w="25400">
+            <a:solidFill>
+              <a:srgbClr val="E67E22"/>
+            </a:solidFill>
+          </a:ln>
+        </p:spPr>
+        <p:style>
+          <a:lnRef idx="1">
+            <a:schemeClr val="accent1"/>
+          </a:lnRef>
+          <a:fillRef idx="3">
+            <a:schemeClr val="accent1"/>
+          </a:fillRef>
+          <a:effectRef idx="2">
+            <a:schemeClr val="accent1"/>
+          </a:effectRef>
+          <a:fontRef idx="minor">
+            <a:schemeClr val="lt1"/>
+          </a:fontRef>
+        </p:style>
+        <p:txBody>
+          <a:bodyPr rtlCol="0" anchor="ctr" wrap="square" lIns="63500" rIns="50800" tIns="38100" bIns="38100"/>
+          <a:lstStyle/>
+          <a:p>
+            <a:pPr algn="l"/>
+            <a:r>
+              <a:rPr sz="900" b="0">
+                <a:solidFill>
+                  <a:srgbClr val="222222"/>
+                </a:solidFill>
+                <a:latin typeface="Meiryo"/>
+              </a:rPr>
+              <a:t>犯人「実行するをクリックしてください」</a:t>
+            </a:r>
+          </a:p>
+        </p:txBody>
+      </p:sp>
+      <p:sp>
+        <p:nvSpPr>
+          <p:cNvPr id="37" name="Rectangle 36"/>
+          <p:cNvSpPr/>
+          <p:nvPr/>
+        </p:nvSpPr>
+        <p:spPr>
+          <a:xfrm>
+            <a:off x="7772400" y="5605272"/>
+            <a:ext cx="6400800" cy="320040"/>
+          </a:xfrm>
+          <a:prstGeom prst="rect">
+            <a:avLst/>
+          </a:prstGeom>
+          <a:solidFill>
+            <a:srgbClr val="EAFAF1"/>
+          </a:solidFill>
+          <a:ln w="25400">
+            <a:solidFill>
+              <a:srgbClr val="27AE60"/>
+            </a:solidFill>
+          </a:ln>
+        </p:spPr>
+        <p:style>
+          <a:lnRef idx="1">
+            <a:schemeClr val="accent1"/>
+          </a:lnRef>
+          <a:fillRef idx="3">
+            <a:schemeClr val="accent1"/>
+          </a:fillRef>
+          <a:effectRef idx="2">
+            <a:schemeClr val="accent1"/>
+          </a:effectRef>
+          <a:fontRef idx="minor">
+            <a:schemeClr val="lt1"/>
+          </a:fontRef>
+        </p:style>
+        <p:txBody>
+          <a:bodyPr rtlCol="0" anchor="ctr" wrap="square" lIns="63500" rIns="50800" tIns="38100" bIns="38100"/>
+          <a:lstStyle/>
+          <a:p>
+            <a:pPr algn="l"/>
+            <a:r>
+              <a:rPr sz="900" b="0">
+                <a:solidFill>
+                  <a:srgbClr val="222222"/>
+                </a:solidFill>
+                <a:latin typeface="Meiryo"/>
+              </a:rPr>
+              <a:t>被害者がクリック</a:t>
+            </a:r>
+          </a:p>
+        </p:txBody>
+      </p:sp>
+      <p:sp>
+        <p:nvSpPr>
+          <p:cNvPr id="38" name="Rectangle 37"/>
+          <p:cNvSpPr/>
+          <p:nvPr/>
+        </p:nvSpPr>
+        <p:spPr>
+          <a:xfrm>
+            <a:off x="7772400" y="5952744"/>
+            <a:ext cx="6400800" cy="320040"/>
+          </a:xfrm>
+          <a:prstGeom prst="rect">
+            <a:avLst/>
+          </a:prstGeom>
+          <a:solidFill>
+            <a:srgbClr val="27AE60"/>
+          </a:solidFill>
+          <a:ln w="25400">
+            <a:solidFill>
+              <a:srgbClr val="27AE60"/>
+            </a:solidFill>
+          </a:ln>
+        </p:spPr>
+        <p:style>
+          <a:lnRef idx="1">
+            <a:schemeClr val="accent1"/>
+          </a:lnRef>
+          <a:fillRef idx="3">
+            <a:schemeClr val="accent1"/>
+          </a:fillRef>
+          <a:effectRef idx="2">
+            <a:schemeClr val="accent1"/>
+          </a:effectRef>
+          <a:fontRef idx="minor">
+            <a:schemeClr val="lt1"/>
+          </a:fontRef>
+        </p:style>
+        <p:txBody>
+          <a:bodyPr rtlCol="0" anchor="ctr" wrap="square" lIns="63500" rIns="50800" tIns="38100" bIns="38100"/>
+          <a:lstStyle/>
+          <a:p>
+            <a:pPr algn="l"/>
+            <a:r>
+              <a:rPr sz="900" b="1">
+                <a:solidFill>
+                  <a:srgbClr val="FFFFFF"/>
+                </a:solidFill>
+                <a:latin typeface="Meiryo"/>
+              </a:rPr>
+              <a:t>OS「このアプリは組織のポリシーにより実行できません」</a:t>
+            </a:r>
+          </a:p>
+        </p:txBody>
+      </p:sp>
+      <p:sp>
+        <p:nvSpPr>
+          <p:cNvPr id="39" name="Rectangle 38"/>
+          <p:cNvSpPr/>
+          <p:nvPr/>
+        </p:nvSpPr>
+        <p:spPr>
+          <a:xfrm>
+            <a:off x="7772400" y="6300216"/>
+            <a:ext cx="6400800" cy="320040"/>
+          </a:xfrm>
+          <a:prstGeom prst="rect">
+            <a:avLst/>
+          </a:prstGeom>
+          <a:solidFill>
+            <a:srgbClr val="222222"/>
+          </a:solidFill>
+          <a:ln w="25400">
+            <a:solidFill>
+              <a:srgbClr val="222222"/>
+            </a:solidFill>
+          </a:ln>
+        </p:spPr>
+        <p:style>
+          <a:lnRef idx="1">
+            <a:schemeClr val="accent1"/>
+          </a:lnRef>
+          <a:fillRef idx="3">
+            <a:schemeClr val="accent1"/>
+          </a:fillRef>
+          <a:effectRef idx="2">
+            <a:schemeClr val="accent1"/>
+          </a:effectRef>
+          <a:fontRef idx="minor">
+            <a:schemeClr val="lt1"/>
+          </a:fontRef>
+        </p:style>
+        <p:txBody>
+          <a:bodyPr rtlCol="0" anchor="ctr" wrap="square" lIns="63500" rIns="50800" tIns="38100" bIns="38100"/>
+          <a:lstStyle/>
+          <a:p>
+            <a:pPr algn="l"/>
+            <a:r>
+              <a:rPr sz="900" b="1">
+                <a:solidFill>
+                  <a:srgbClr val="FFFFFF"/>
+                </a:solidFill>
+                <a:latin typeface="Meiryo"/>
+              </a:rPr>
+              <a:t>犯人が何を言っても突破不可能 ★</a:t>
+            </a:r>
+          </a:p>
+        </p:txBody>
+      </p:sp>
+      <p:sp>
+        <p:nvSpPr>
+          <p:cNvPr id="40" name="Rectangle 39"/>
+          <p:cNvSpPr/>
+          <p:nvPr/>
+        </p:nvSpPr>
+        <p:spPr>
+          <a:xfrm>
+            <a:off x="731520" y="6766560"/>
+            <a:ext cx="4480560" cy="777240"/>
+          </a:xfrm>
+          <a:prstGeom prst="rect">
+            <a:avLst/>
+          </a:prstGeom>
+          <a:solidFill>
+            <a:srgbClr val="27AE60"/>
+          </a:solidFill>
+          <a:ln>
+            <a:noFill/>
+          </a:ln>
+        </p:spPr>
+        <p:style>
+          <a:lnRef idx="1">
+            <a:schemeClr val="accent1"/>
+          </a:lnRef>
+          <a:fillRef idx="3">
+            <a:schemeClr val="accent1"/>
+          </a:fillRef>
+          <a:effectRef idx="2">
+            <a:schemeClr val="accent1"/>
+          </a:effectRef>
+          <a:fontRef idx="minor">
+            <a:schemeClr val="lt1"/>
+          </a:fontRef>
+        </p:style>
+        <p:txBody>
+          <a:bodyPr rtlCol="0" anchor="ctr" wrap="square" lIns="50800" rIns="50800" tIns="25400" bIns="25400"/>
+          <a:lstStyle/>
+          <a:p>
+            <a:pPr algn="ctr"/>
+            <a:r>
+              <a:rPr sz="100" b="1">
+                <a:solidFill>
+                  <a:srgbClr val="FFFFFF"/>
+                </a:solidFill>
+                <a:latin typeface="Meiryo"/>
+              </a:rPr>
+              <a:t/>
+            </a:r>
+          </a:p>
+        </p:txBody>
+      </p:sp>
+      <p:sp>
+        <p:nvSpPr>
+          <p:cNvPr id="41" name="TextBox 40"/>
+          <p:cNvSpPr txBox="1"/>
+          <p:nvPr/>
+        </p:nvSpPr>
+        <p:spPr>
+          <a:xfrm>
+            <a:off x="914400" y="6812280"/>
+            <a:ext cx="4114800" cy="685800"/>
+          </a:xfrm>
+          <a:prstGeom prst="rect">
+            <a:avLst/>
+          </a:prstGeom>
+          <a:noFill/>
+        </p:spPr>
+        <p:txBody>
+          <a:bodyPr wrap="square" lIns="50800" rIns="50800" tIns="38100" bIns="38100"/>
+          <a:lstStyle/>
+          <a:p>
+            <a:pPr algn="l"/>
+            <a:r>
+              <a:rPr sz="1200" b="1">
+                <a:solidFill>
+                  <a:srgbClr val="FFFFFF"/>
+                </a:solidFill>
+                <a:latin typeface="Meiryo"/>
+              </a:rPr>
+              <a:t>追加コスト：ゼロ
+追加ソフト：不要
+必要な作業：ポリシー設定のみ</a:t>
+            </a:r>
+          </a:p>
+        </p:txBody>
+      </p:sp>
+      <p:sp>
+        <p:nvSpPr>
+          <p:cNvPr id="42" name="Rectangle 41"/>
+          <p:cNvSpPr/>
+          <p:nvPr/>
+        </p:nvSpPr>
+        <p:spPr>
+          <a:xfrm>
+            <a:off x="5486400" y="6766560"/>
+            <a:ext cx="4572000" cy="777240"/>
+          </a:xfrm>
+          <a:prstGeom prst="rect">
+            <a:avLst/>
+          </a:prstGeom>
+          <a:solidFill>
+            <a:srgbClr val="C0392B"/>
+          </a:solidFill>
+          <a:ln>
+            <a:noFill/>
+          </a:ln>
+        </p:spPr>
+        <p:style>
+          <a:lnRef idx="1">
+            <a:schemeClr val="accent1"/>
+          </a:lnRef>
+          <a:fillRef idx="3">
+            <a:schemeClr val="accent1"/>
+          </a:fillRef>
+          <a:effectRef idx="2">
+            <a:schemeClr val="accent1"/>
+          </a:effectRef>
+          <a:fontRef idx="minor">
+            <a:schemeClr val="lt1"/>
+          </a:fontRef>
+        </p:style>
+        <p:txBody>
+          <a:bodyPr rtlCol="0" anchor="ctr" wrap="square" lIns="50800" rIns="50800" tIns="25400" bIns="25400"/>
+          <a:lstStyle/>
+          <a:p>
+            <a:pPr algn="ctr"/>
+            <a:r>
+              <a:rPr sz="100" b="1">
+                <a:solidFill>
+                  <a:srgbClr val="FFFFFF"/>
+                </a:solidFill>
+                <a:latin typeface="Meiryo"/>
+              </a:rPr>
+              <a:t/>
+            </a:r>
+          </a:p>
+        </p:txBody>
+      </p:sp>
+      <p:sp>
+        <p:nvSpPr>
+          <p:cNvPr id="43" name="TextBox 42"/>
+          <p:cNvSpPr txBox="1"/>
+          <p:nvPr/>
+        </p:nvSpPr>
+        <p:spPr>
+          <a:xfrm>
+            <a:off x="5669280" y="6812280"/>
+            <a:ext cx="4206240" cy="685800"/>
+          </a:xfrm>
+          <a:prstGeom prst="rect">
+            <a:avLst/>
+          </a:prstGeom>
+          <a:noFill/>
+        </p:spPr>
+        <p:txBody>
+          <a:bodyPr wrap="square" lIns="50800" rIns="50800" tIns="38100" bIns="38100"/>
+          <a:lstStyle/>
+          <a:p>
+            <a:pPr algn="l"/>
+            <a:r>
+              <a:rPr sz="1200" b="1">
+                <a:solidFill>
+                  <a:srgbClr val="FFFFFF"/>
+                </a:solidFill>
+                <a:latin typeface="Meiryo"/>
+              </a:rPr>
+              <a:t>電話で回避できない
+管理者権限がないと
+ポリシー変更できない</a:t>
+            </a:r>
+          </a:p>
+        </p:txBody>
+      </p:sp>
+      <p:sp>
+        <p:nvSpPr>
+          <p:cNvPr id="44" name="Rectangle 43"/>
+          <p:cNvSpPr/>
+          <p:nvPr/>
+        </p:nvSpPr>
+        <p:spPr>
+          <a:xfrm>
+            <a:off x="10332720" y="6766560"/>
+            <a:ext cx="4023360" cy="777240"/>
+          </a:xfrm>
+          <a:prstGeom prst="rect">
+            <a:avLst/>
+          </a:prstGeom>
+          <a:solidFill>
+            <a:srgbClr val="222222"/>
+          </a:solidFill>
+          <a:ln>
+            <a:noFill/>
+          </a:ln>
+        </p:spPr>
+        <p:style>
+          <a:lnRef idx="1">
+            <a:schemeClr val="accent1"/>
+          </a:lnRef>
+          <a:fillRef idx="3">
+            <a:schemeClr val="accent1"/>
+          </a:fillRef>
+          <a:effectRef idx="2">
+            <a:schemeClr val="accent1"/>
+          </a:effectRef>
+          <a:fontRef idx="minor">
+            <a:schemeClr val="lt1"/>
+          </a:fontRef>
+        </p:style>
+        <p:txBody>
+          <a:bodyPr rtlCol="0" anchor="ctr" wrap="square" lIns="50800" rIns="50800" tIns="25400" bIns="25400"/>
+          <a:lstStyle/>
+          <a:p>
+            <a:pPr algn="ctr"/>
+            <a:r>
+              <a:rPr sz="100" b="1">
+                <a:solidFill>
+                  <a:srgbClr val="FFFFFF"/>
+                </a:solidFill>
+                <a:latin typeface="Meiryo"/>
+              </a:rPr>
+              <a:t/>
+            </a:r>
+          </a:p>
+        </p:txBody>
+      </p:sp>
+      <p:sp>
+        <p:nvSpPr>
+          <p:cNvPr id="45" name="TextBox 44"/>
+          <p:cNvSpPr txBox="1"/>
+          <p:nvPr/>
+        </p:nvSpPr>
+        <p:spPr>
+          <a:xfrm>
+            <a:off x="10515600" y="6812280"/>
+            <a:ext cx="3657600" cy="685800"/>
+          </a:xfrm>
+          <a:prstGeom prst="rect">
+            <a:avLst/>
+          </a:prstGeom>
+          <a:noFill/>
+        </p:spPr>
+        <p:txBody>
+          <a:bodyPr wrap="square" lIns="50800" rIns="50800" tIns="38100" bIns="38100"/>
+          <a:lstStyle/>
+          <a:p>
+            <a:pPr algn="l"/>
+            <a:r>
+              <a:rPr sz="1200" b="1">
+                <a:solidFill>
+                  <a:srgbClr val="FFFFFF"/>
+                </a:solidFill>
+                <a:latin typeface="Meiryo"/>
+              </a:rPr>
+              <a:t>DMARCと並ぶ
+2つ目の確実な
+技術的対策</a:t>
+            </a:r>
+          </a:p>
+        </p:txBody>
+      </p:sp>
+      <p:sp>
+        <p:nvSpPr>
+          <p:cNvPr id="46" name="Rectangle 45"/>
+          <p:cNvSpPr/>
+          <p:nvPr/>
+        </p:nvSpPr>
+        <p:spPr>
+          <a:xfrm>
+            <a:off x="731520" y="7772400"/>
+            <a:ext cx="13624560" cy="502920"/>
+          </a:xfrm>
+          <a:prstGeom prst="rect">
+            <a:avLst/>
+          </a:prstGeom>
+          <a:solidFill>
+            <a:srgbClr val="222222"/>
+          </a:solidFill>
+          <a:ln>
+            <a:noFill/>
+          </a:ln>
+        </p:spPr>
+        <p:style>
+          <a:lnRef idx="1">
+            <a:schemeClr val="accent1"/>
+          </a:lnRef>
+          <a:fillRef idx="3">
+            <a:schemeClr val="accent1"/>
+          </a:fillRef>
+          <a:effectRef idx="2">
+            <a:schemeClr val="accent1"/>
+          </a:effectRef>
+          <a:fontRef idx="minor">
+            <a:schemeClr val="lt1"/>
+          </a:fontRef>
+        </p:style>
+        <p:txBody>
+          <a:bodyPr rtlCol="0" anchor="ctr" wrap="square" lIns="50800" rIns="50800" tIns="25400" bIns="25400"/>
+          <a:lstStyle/>
+          <a:p>
+            <a:pPr algn="ctr"/>
+            <a:r>
+              <a:rPr sz="1100" b="1">
+                <a:solidFill>
+                  <a:srgbClr val="FFFFFF"/>
+                </a:solidFill>
+                <a:latin typeface="Meiryo"/>
+              </a:rPr>
+              <a:t>Kill Chainを技術的に切れるポイント：④ DMARC p=reject（メール遮断）＋ ⑥ AppLocker/WDAC（実行阻止）— どちらも標準搭載・追加コストゼロ</a:t>
+            </a:r>
+          </a:p>
+        </p:txBody>
+      </p:sp>
+      <p:sp>
+        <p:nvSpPr>
+          <p:cNvPr id="47" name="TextBox 46"/>
+          <p:cNvSpPr txBox="1"/>
+          <p:nvPr/>
+        </p:nvSpPr>
+        <p:spPr>
+          <a:xfrm>
+            <a:off x="9144000" y="10378440"/>
+            <a:ext cx="5943600" cy="228600"/>
+          </a:xfrm>
+          <a:prstGeom prst="rect">
+            <a:avLst/>
+          </a:prstGeom>
+          <a:noFill/>
+        </p:spPr>
+        <p:txBody>
+          <a:bodyPr wrap="square" lIns="50800" rIns="50800" tIns="38100" bIns="38100"/>
+          <a:lstStyle/>
+          <a:p>
+            <a:pPr algn="r"/>
+            <a:r>
+              <a:rPr sz="700" b="0">
+                <a:solidFill>
+                  <a:srgbClr val="888888"/>
+                </a:solidFill>
+                <a:latin typeface="Meiryo"/>
+              </a:rPr>
+              <a:t>Fraud Kill Chain — ホワイトリスト型アプリ制御</a:t>
             </a:r>
           </a:p>
         </p:txBody>

</xml_diff>

<commit_message>
Add slide 12: dumping responsibility on customers doesn't work
Every defense so far has been delegated to customers who lack IT
capability. Banks must own DMARC config and actively support
AppLocker setup, not just tell customers to do it themselves.

https://claude.ai/code/session_01F7t8LKifK43o6sCdF2a3gQ
</commit_message>
<xml_diff>
--- a/Fraud_Kill_Chain.pptx
+++ b/Fraud_Kill_Chain.pptx
@@ -16,6 +16,7 @@
     <p:sldId id="264" r:id="rId15"/>
     <p:sldId id="265" r:id="rId16"/>
     <p:sldId id="266" r:id="rId17"/>
+    <p:sldId id="267" r:id="rId18"/>
   </p:sldIdLst>
   <p:sldSz cx="15124176" cy="10689336" type="screen4x3"/>
   <p:notesSz cx="6858000" cy="9144000"/>
@@ -12769,6 +12770,2691 @@
                 <a:latin typeface="Meiryo"/>
               </a:rPr>
               <a:t>Fraud Kill Chain — ホワイトリスト型アプリ制御</a:t>
+            </a:r>
+          </a:p>
+        </p:txBody>
+      </p:sp>
+    </p:spTree>
+  </p:cSld>
+  <p:clrMapOvr>
+    <a:masterClrMapping/>
+  </p:clrMapOvr>
+</p:sld>
+</file>
+
+<file path=ppt/slides/slide12.xml><?xml version="1.0" encoding="utf-8"?>
+<p:sld xmlns:a="http://schemas.openxmlformats.org/drawingml/2006/main" xmlns:p="http://schemas.openxmlformats.org/presentationml/2006/main" xmlns:r="http://schemas.openxmlformats.org/officeDocument/2006/relationships">
+  <p:cSld>
+    <p:bg>
+      <p:bgPr>
+        <a:solidFill>
+          <a:srgbClr val="F5F5F5"/>
+        </a:solidFill>
+        <a:effectLst/>
+      </p:bgPr>
+    </p:bg>
+    <p:spTree>
+      <p:nvGrpSpPr>
+        <p:cNvPr id="1" name=""/>
+        <p:cNvGrpSpPr/>
+        <p:nvPr/>
+      </p:nvGrpSpPr>
+      <p:grpSpPr/>
+      <p:sp>
+        <p:nvSpPr>
+          <p:cNvPr id="2" name="TextBox 1"/>
+          <p:cNvSpPr txBox="1"/>
+          <p:nvPr/>
+        </p:nvSpPr>
+        <p:spPr>
+          <a:xfrm>
+            <a:off x="0" y="182880"/>
+            <a:ext cx="15124176" cy="548640"/>
+          </a:xfrm>
+          <a:prstGeom prst="rect">
+            <a:avLst/>
+          </a:prstGeom>
+          <a:noFill/>
+        </p:spPr>
+        <p:txBody>
+          <a:bodyPr wrap="square" lIns="50800" rIns="50800" tIns="38100" bIns="38100"/>
+          <a:lstStyle/>
+          <a:p>
+            <a:pPr algn="ctr"/>
+            <a:r>
+              <a:rPr sz="2200" b="1">
+                <a:solidFill>
+                  <a:srgbClr val="C0392B"/>
+                </a:solidFill>
+                <a:latin typeface="Meiryo"/>
+              </a:rPr>
+              <a:t>「顧客の問題」にしている限り、この攻撃は止まらない</a:t>
+            </a:r>
+          </a:p>
+        </p:txBody>
+      </p:sp>
+      <p:sp>
+        <p:nvSpPr>
+          <p:cNvPr id="3" name="TextBox 2"/>
+          <p:cNvSpPr txBox="1"/>
+          <p:nvPr/>
+        </p:nvSpPr>
+        <p:spPr>
+          <a:xfrm>
+            <a:off x="0" y="640080"/>
+            <a:ext cx="15124176" cy="365760"/>
+          </a:xfrm>
+          <a:prstGeom prst="rect">
+            <a:avLst/>
+          </a:prstGeom>
+          <a:noFill/>
+        </p:spPr>
+        <p:txBody>
+          <a:bodyPr wrap="square" lIns="50800" rIns="50800" tIns="38100" bIns="38100"/>
+          <a:lstStyle/>
+          <a:p>
+            <a:pPr algn="ctr"/>
+            <a:r>
+              <a:rPr sz="1100" b="0">
+                <a:solidFill>
+                  <a:srgbClr val="888888"/>
+                </a:solidFill>
+                <a:latin typeface="Meiryo"/>
+              </a:rPr>
+              <a:t>全ての対策が「顧客にやってね」で丸投げされている。DMARCも AppLockerも同じ構図。</a:t>
+            </a:r>
+          </a:p>
+        </p:txBody>
+      </p:sp>
+      <p:sp>
+        <p:nvSpPr>
+          <p:cNvPr id="4" name="Rectangle 3"/>
+          <p:cNvSpPr/>
+          <p:nvPr/>
+        </p:nvSpPr>
+        <p:spPr>
+          <a:xfrm>
+            <a:off x="731520" y="1051560"/>
+            <a:ext cx="13624560" cy="411480"/>
+          </a:xfrm>
+          <a:prstGeom prst="rect">
+            <a:avLst/>
+          </a:prstGeom>
+          <a:solidFill>
+            <a:srgbClr val="222222"/>
+          </a:solidFill>
+          <a:ln>
+            <a:noFill/>
+          </a:ln>
+        </p:spPr>
+        <p:style>
+          <a:lnRef idx="1">
+            <a:schemeClr val="accent1"/>
+          </a:lnRef>
+          <a:fillRef idx="3">
+            <a:schemeClr val="accent1"/>
+          </a:fillRef>
+          <a:effectRef idx="2">
+            <a:schemeClr val="accent1"/>
+          </a:effectRef>
+          <a:fontRef idx="minor">
+            <a:schemeClr val="lt1"/>
+          </a:fontRef>
+        </p:style>
+        <p:txBody>
+          <a:bodyPr rtlCol="0" anchor="ctr" wrap="square" lIns="50800" rIns="50800" tIns="25400" bIns="25400"/>
+          <a:lstStyle/>
+          <a:p>
+            <a:pPr algn="ctr"/>
+            <a:r>
+              <a:rPr sz="1300" b="1">
+                <a:solidFill>
+                  <a:srgbClr val="FFFFFF"/>
+                </a:solidFill>
+                <a:latin typeface="Meiryo"/>
+              </a:rPr>
+              <a:t>対策の責任はどこにあるか？</a:t>
+            </a:r>
+          </a:p>
+        </p:txBody>
+      </p:sp>
+      <p:sp>
+        <p:nvSpPr>
+          <p:cNvPr id="5" name="Rectangle 4"/>
+          <p:cNvSpPr/>
+          <p:nvPr/>
+        </p:nvSpPr>
+        <p:spPr>
+          <a:xfrm>
+            <a:off x="731520" y="1463039"/>
+            <a:ext cx="2743200" cy="365760"/>
+          </a:xfrm>
+          <a:prstGeom prst="rect">
+            <a:avLst/>
+          </a:prstGeom>
+          <a:solidFill>
+            <a:srgbClr val="34495E"/>
+          </a:solidFill>
+          <a:ln>
+            <a:noFill/>
+          </a:ln>
+        </p:spPr>
+        <p:style>
+          <a:lnRef idx="1">
+            <a:schemeClr val="accent1"/>
+          </a:lnRef>
+          <a:fillRef idx="3">
+            <a:schemeClr val="accent1"/>
+          </a:fillRef>
+          <a:effectRef idx="2">
+            <a:schemeClr val="accent1"/>
+          </a:effectRef>
+          <a:fontRef idx="minor">
+            <a:schemeClr val="lt1"/>
+          </a:fontRef>
+        </p:style>
+        <p:txBody>
+          <a:bodyPr rtlCol="0" anchor="ctr" wrap="square" lIns="50800" rIns="50800" tIns="25400" bIns="25400"/>
+          <a:lstStyle/>
+          <a:p>
+            <a:pPr algn="ctr"/>
+            <a:r>
+              <a:rPr sz="900" b="1">
+                <a:solidFill>
+                  <a:srgbClr val="FFFFFF"/>
+                </a:solidFill>
+                <a:latin typeface="Meiryo"/>
+              </a:rPr>
+              <a:t>対策</a:t>
+            </a:r>
+          </a:p>
+        </p:txBody>
+      </p:sp>
+      <p:sp>
+        <p:nvSpPr>
+          <p:cNvPr id="6" name="Rectangle 5"/>
+          <p:cNvSpPr/>
+          <p:nvPr/>
+        </p:nvSpPr>
+        <p:spPr>
+          <a:xfrm>
+            <a:off x="3474720" y="1463039"/>
+            <a:ext cx="2743200" cy="365760"/>
+          </a:xfrm>
+          <a:prstGeom prst="rect">
+            <a:avLst/>
+          </a:prstGeom>
+          <a:solidFill>
+            <a:srgbClr val="34495E"/>
+          </a:solidFill>
+          <a:ln>
+            <a:noFill/>
+          </a:ln>
+        </p:spPr>
+        <p:style>
+          <a:lnRef idx="1">
+            <a:schemeClr val="accent1"/>
+          </a:lnRef>
+          <a:fillRef idx="3">
+            <a:schemeClr val="accent1"/>
+          </a:fillRef>
+          <a:effectRef idx="2">
+            <a:schemeClr val="accent1"/>
+          </a:effectRef>
+          <a:fontRef idx="minor">
+            <a:schemeClr val="lt1"/>
+          </a:fontRef>
+        </p:style>
+        <p:txBody>
+          <a:bodyPr rtlCol="0" anchor="ctr" wrap="square" lIns="50800" rIns="50800" tIns="25400" bIns="25400"/>
+          <a:lstStyle/>
+          <a:p>
+            <a:pPr algn="ctr"/>
+            <a:r>
+              <a:rPr sz="900" b="1">
+                <a:solidFill>
+                  <a:srgbClr val="FFFFFF"/>
+                </a:solidFill>
+                <a:latin typeface="Meiryo"/>
+              </a:rPr>
+              <a:t>設定する場所</a:t>
+            </a:r>
+          </a:p>
+        </p:txBody>
+      </p:sp>
+      <p:sp>
+        <p:nvSpPr>
+          <p:cNvPr id="7" name="Rectangle 6"/>
+          <p:cNvSpPr/>
+          <p:nvPr/>
+        </p:nvSpPr>
+        <p:spPr>
+          <a:xfrm>
+            <a:off x="6217920" y="1463039"/>
+            <a:ext cx="2743200" cy="365760"/>
+          </a:xfrm>
+          <a:prstGeom prst="rect">
+            <a:avLst/>
+          </a:prstGeom>
+          <a:solidFill>
+            <a:srgbClr val="34495E"/>
+          </a:solidFill>
+          <a:ln>
+            <a:noFill/>
+          </a:ln>
+        </p:spPr>
+        <p:style>
+          <a:lnRef idx="1">
+            <a:schemeClr val="accent1"/>
+          </a:lnRef>
+          <a:fillRef idx="3">
+            <a:schemeClr val="accent1"/>
+          </a:fillRef>
+          <a:effectRef idx="2">
+            <a:schemeClr val="accent1"/>
+          </a:effectRef>
+          <a:fontRef idx="minor">
+            <a:schemeClr val="lt1"/>
+          </a:fontRef>
+        </p:style>
+        <p:txBody>
+          <a:bodyPr rtlCol="0" anchor="ctr" wrap="square" lIns="50800" rIns="50800" tIns="25400" bIns="25400"/>
+          <a:lstStyle/>
+          <a:p>
+            <a:pPr algn="ctr"/>
+            <a:r>
+              <a:rPr sz="900" b="1">
+                <a:solidFill>
+                  <a:srgbClr val="FFFFFF"/>
+                </a:solidFill>
+                <a:latin typeface="Meiryo"/>
+              </a:rPr>
+              <a:t>設定する人</a:t>
+            </a:r>
+          </a:p>
+        </p:txBody>
+      </p:sp>
+      <p:sp>
+        <p:nvSpPr>
+          <p:cNvPr id="8" name="Rectangle 7"/>
+          <p:cNvSpPr/>
+          <p:nvPr/>
+        </p:nvSpPr>
+        <p:spPr>
+          <a:xfrm>
+            <a:off x="8961120" y="1463039"/>
+            <a:ext cx="5394960" cy="365760"/>
+          </a:xfrm>
+          <a:prstGeom prst="rect">
+            <a:avLst/>
+          </a:prstGeom>
+          <a:solidFill>
+            <a:srgbClr val="34495E"/>
+          </a:solidFill>
+          <a:ln>
+            <a:noFill/>
+          </a:ln>
+        </p:spPr>
+        <p:style>
+          <a:lnRef idx="1">
+            <a:schemeClr val="accent1"/>
+          </a:lnRef>
+          <a:fillRef idx="3">
+            <a:schemeClr val="accent1"/>
+          </a:fillRef>
+          <a:effectRef idx="2">
+            <a:schemeClr val="accent1"/>
+          </a:effectRef>
+          <a:fontRef idx="minor">
+            <a:schemeClr val="lt1"/>
+          </a:fontRef>
+        </p:style>
+        <p:txBody>
+          <a:bodyPr rtlCol="0" anchor="ctr" wrap="square" lIns="50800" rIns="50800" tIns="25400" bIns="25400"/>
+          <a:lstStyle/>
+          <a:p>
+            <a:pPr algn="ctr"/>
+            <a:r>
+              <a:rPr sz="900" b="1">
+                <a:solidFill>
+                  <a:srgbClr val="FFFFFF"/>
+                </a:solidFill>
+                <a:latin typeface="Meiryo"/>
+              </a:rPr>
+              <a:t>責任</a:t>
+            </a:r>
+          </a:p>
+        </p:txBody>
+      </p:sp>
+      <p:sp>
+        <p:nvSpPr>
+          <p:cNvPr id="9" name="Rectangle 8"/>
+          <p:cNvSpPr/>
+          <p:nvPr/>
+        </p:nvSpPr>
+        <p:spPr>
+          <a:xfrm>
+            <a:off x="731520" y="1828800"/>
+            <a:ext cx="2743200" cy="411480"/>
+          </a:xfrm>
+          <a:prstGeom prst="rect">
+            <a:avLst/>
+          </a:prstGeom>
+          <a:solidFill>
+            <a:srgbClr val="FFFFFF"/>
+          </a:solidFill>
+          <a:ln w="25400">
+            <a:solidFill>
+              <a:srgbClr val="2980B9"/>
+            </a:solidFill>
+          </a:ln>
+        </p:spPr>
+        <p:style>
+          <a:lnRef idx="1">
+            <a:schemeClr val="accent1"/>
+          </a:lnRef>
+          <a:fillRef idx="3">
+            <a:schemeClr val="accent1"/>
+          </a:fillRef>
+          <a:effectRef idx="2">
+            <a:schemeClr val="accent1"/>
+          </a:effectRef>
+          <a:fontRef idx="minor">
+            <a:schemeClr val="lt1"/>
+          </a:fontRef>
+        </p:style>
+        <p:txBody>
+          <a:bodyPr rtlCol="0" anchor="ctr" wrap="square" lIns="63500" rIns="50800" tIns="38100" bIns="38100"/>
+          <a:lstStyle/>
+          <a:p>
+            <a:pPr algn="l"/>
+            <a:r>
+              <a:rPr sz="1000" b="1">
+                <a:solidFill>
+                  <a:srgbClr val="222222"/>
+                </a:solidFill>
+                <a:latin typeface="Meiryo"/>
+              </a:rPr>
+              <a:t>DMARC p=reject</a:t>
+            </a:r>
+          </a:p>
+        </p:txBody>
+      </p:sp>
+      <p:sp>
+        <p:nvSpPr>
+          <p:cNvPr id="10" name="Rectangle 9"/>
+          <p:cNvSpPr/>
+          <p:nvPr/>
+        </p:nvSpPr>
+        <p:spPr>
+          <a:xfrm>
+            <a:off x="3474720" y="1828800"/>
+            <a:ext cx="2743200" cy="411480"/>
+          </a:xfrm>
+          <a:prstGeom prst="rect">
+            <a:avLst/>
+          </a:prstGeom>
+          <a:solidFill>
+            <a:srgbClr val="FFFFFF"/>
+          </a:solidFill>
+          <a:ln w="25400">
+            <a:solidFill>
+              <a:srgbClr val="CCCCCC"/>
+            </a:solidFill>
+          </a:ln>
+        </p:spPr>
+        <p:style>
+          <a:lnRef idx="1">
+            <a:schemeClr val="accent1"/>
+          </a:lnRef>
+          <a:fillRef idx="3">
+            <a:schemeClr val="accent1"/>
+          </a:fillRef>
+          <a:effectRef idx="2">
+            <a:schemeClr val="accent1"/>
+          </a:effectRef>
+          <a:fontRef idx="minor">
+            <a:schemeClr val="lt1"/>
+          </a:fontRef>
+        </p:style>
+        <p:txBody>
+          <a:bodyPr rtlCol="0" anchor="ctr" wrap="square" lIns="63500" rIns="50800" tIns="38100" bIns="38100"/>
+          <a:lstStyle/>
+          <a:p>
+            <a:pPr algn="l"/>
+            <a:r>
+              <a:rPr sz="900" b="0">
+                <a:solidFill>
+                  <a:srgbClr val="222222"/>
+                </a:solidFill>
+                <a:latin typeface="Meiryo"/>
+              </a:rPr>
+              <a:t>銀行のメールサーバ</a:t>
+            </a:r>
+          </a:p>
+        </p:txBody>
+      </p:sp>
+      <p:sp>
+        <p:nvSpPr>
+          <p:cNvPr id="11" name="Rectangle 10"/>
+          <p:cNvSpPr/>
+          <p:nvPr/>
+        </p:nvSpPr>
+        <p:spPr>
+          <a:xfrm>
+            <a:off x="6217920" y="1828800"/>
+            <a:ext cx="2743200" cy="411480"/>
+          </a:xfrm>
+          <a:prstGeom prst="rect">
+            <a:avLst/>
+          </a:prstGeom>
+          <a:solidFill>
+            <a:srgbClr val="FFFFFF"/>
+          </a:solidFill>
+          <a:ln w="25400">
+            <a:solidFill>
+              <a:srgbClr val="CCCCCC"/>
+            </a:solidFill>
+          </a:ln>
+        </p:spPr>
+        <p:style>
+          <a:lnRef idx="1">
+            <a:schemeClr val="accent1"/>
+          </a:lnRef>
+          <a:fillRef idx="3">
+            <a:schemeClr val="accent1"/>
+          </a:fillRef>
+          <a:effectRef idx="2">
+            <a:schemeClr val="accent1"/>
+          </a:effectRef>
+          <a:fontRef idx="minor">
+            <a:schemeClr val="lt1"/>
+          </a:fontRef>
+        </p:style>
+        <p:txBody>
+          <a:bodyPr rtlCol="0" anchor="ctr" wrap="square" lIns="63500" rIns="50800" tIns="38100" bIns="38100"/>
+          <a:lstStyle/>
+          <a:p>
+            <a:pPr algn="l"/>
+            <a:r>
+              <a:rPr sz="900" b="0">
+                <a:solidFill>
+                  <a:srgbClr val="222222"/>
+                </a:solidFill>
+                <a:latin typeface="Meiryo"/>
+              </a:rPr>
+              <a:t>銀行のIT部門</a:t>
+            </a:r>
+          </a:p>
+        </p:txBody>
+      </p:sp>
+      <p:sp>
+        <p:nvSpPr>
+          <p:cNvPr id="12" name="Rectangle 11"/>
+          <p:cNvSpPr/>
+          <p:nvPr/>
+        </p:nvSpPr>
+        <p:spPr>
+          <a:xfrm>
+            <a:off x="8961120" y="1828800"/>
+            <a:ext cx="5394960" cy="411480"/>
+          </a:xfrm>
+          <a:prstGeom prst="rect">
+            <a:avLst/>
+          </a:prstGeom>
+          <a:solidFill>
+            <a:srgbClr val="FFFFFF"/>
+          </a:solidFill>
+          <a:ln w="25400">
+            <a:solidFill>
+              <a:srgbClr val="2980B9"/>
+            </a:solidFill>
+          </a:ln>
+        </p:spPr>
+        <p:style>
+          <a:lnRef idx="1">
+            <a:schemeClr val="accent1"/>
+          </a:lnRef>
+          <a:fillRef idx="3">
+            <a:schemeClr val="accent1"/>
+          </a:fillRef>
+          <a:effectRef idx="2">
+            <a:schemeClr val="accent1"/>
+          </a:effectRef>
+          <a:fontRef idx="minor">
+            <a:schemeClr val="lt1"/>
+          </a:fontRef>
+        </p:style>
+        <p:txBody>
+          <a:bodyPr rtlCol="0" anchor="ctr" wrap="square" lIns="63500" rIns="50800" tIns="38100" bIns="38100"/>
+          <a:lstStyle/>
+          <a:p>
+            <a:pPr algn="l"/>
+            <a:r>
+              <a:rPr sz="900" b="1">
+                <a:solidFill>
+                  <a:srgbClr val="222222"/>
+                </a:solidFill>
+                <a:latin typeface="Meiryo"/>
+              </a:rPr>
+              <a:t>100%銀行側の問題。顧客は何もできない。</a:t>
+            </a:r>
+          </a:p>
+        </p:txBody>
+      </p:sp>
+      <p:sp>
+        <p:nvSpPr>
+          <p:cNvPr id="13" name="Rectangle 12"/>
+          <p:cNvSpPr/>
+          <p:nvPr/>
+        </p:nvSpPr>
+        <p:spPr>
+          <a:xfrm>
+            <a:off x="731520" y="2240280"/>
+            <a:ext cx="2743200" cy="411480"/>
+          </a:xfrm>
+          <a:prstGeom prst="rect">
+            <a:avLst/>
+          </a:prstGeom>
+          <a:solidFill>
+            <a:srgbClr val="FFFFFF"/>
+          </a:solidFill>
+          <a:ln w="25400">
+            <a:solidFill>
+              <a:srgbClr val="E67E22"/>
+            </a:solidFill>
+          </a:ln>
+        </p:spPr>
+        <p:style>
+          <a:lnRef idx="1">
+            <a:schemeClr val="accent1"/>
+          </a:lnRef>
+          <a:fillRef idx="3">
+            <a:schemeClr val="accent1"/>
+          </a:fillRef>
+          <a:effectRef idx="2">
+            <a:schemeClr val="accent1"/>
+          </a:effectRef>
+          <a:fontRef idx="minor">
+            <a:schemeClr val="lt1"/>
+          </a:fontRef>
+        </p:style>
+        <p:txBody>
+          <a:bodyPr rtlCol="0" anchor="ctr" wrap="square" lIns="63500" rIns="50800" tIns="38100" bIns="38100"/>
+          <a:lstStyle/>
+          <a:p>
+            <a:pPr algn="l"/>
+            <a:r>
+              <a:rPr sz="1000" b="1">
+                <a:solidFill>
+                  <a:srgbClr val="222222"/>
+                </a:solidFill>
+                <a:latin typeface="Meiryo"/>
+              </a:rPr>
+              <a:t>AppLocker/WDAC</a:t>
+            </a:r>
+          </a:p>
+        </p:txBody>
+      </p:sp>
+      <p:sp>
+        <p:nvSpPr>
+          <p:cNvPr id="14" name="Rectangle 13"/>
+          <p:cNvSpPr/>
+          <p:nvPr/>
+        </p:nvSpPr>
+        <p:spPr>
+          <a:xfrm>
+            <a:off x="3474720" y="2240280"/>
+            <a:ext cx="2743200" cy="411480"/>
+          </a:xfrm>
+          <a:prstGeom prst="rect">
+            <a:avLst/>
+          </a:prstGeom>
+          <a:solidFill>
+            <a:srgbClr val="FFFFFF"/>
+          </a:solidFill>
+          <a:ln w="25400">
+            <a:solidFill>
+              <a:srgbClr val="CCCCCC"/>
+            </a:solidFill>
+          </a:ln>
+        </p:spPr>
+        <p:style>
+          <a:lnRef idx="1">
+            <a:schemeClr val="accent1"/>
+          </a:lnRef>
+          <a:fillRef idx="3">
+            <a:schemeClr val="accent1"/>
+          </a:fillRef>
+          <a:effectRef idx="2">
+            <a:schemeClr val="accent1"/>
+          </a:effectRef>
+          <a:fontRef idx="minor">
+            <a:schemeClr val="lt1"/>
+          </a:fontRef>
+        </p:style>
+        <p:txBody>
+          <a:bodyPr rtlCol="0" anchor="ctr" wrap="square" lIns="63500" rIns="50800" tIns="38100" bIns="38100"/>
+          <a:lstStyle/>
+          <a:p>
+            <a:pPr algn="l"/>
+            <a:r>
+              <a:rPr sz="900" b="0">
+                <a:solidFill>
+                  <a:srgbClr val="222222"/>
+                </a:solidFill>
+                <a:latin typeface="Meiryo"/>
+              </a:rPr>
+              <a:t>顧客企業のPC</a:t>
+            </a:r>
+          </a:p>
+        </p:txBody>
+      </p:sp>
+      <p:sp>
+        <p:nvSpPr>
+          <p:cNvPr id="15" name="Rectangle 14"/>
+          <p:cNvSpPr/>
+          <p:nvPr/>
+        </p:nvSpPr>
+        <p:spPr>
+          <a:xfrm>
+            <a:off x="6217920" y="2240280"/>
+            <a:ext cx="2743200" cy="411480"/>
+          </a:xfrm>
+          <a:prstGeom prst="rect">
+            <a:avLst/>
+          </a:prstGeom>
+          <a:solidFill>
+            <a:srgbClr val="FFFFFF"/>
+          </a:solidFill>
+          <a:ln w="25400">
+            <a:solidFill>
+              <a:srgbClr val="CCCCCC"/>
+            </a:solidFill>
+          </a:ln>
+        </p:spPr>
+        <p:style>
+          <a:lnRef idx="1">
+            <a:schemeClr val="accent1"/>
+          </a:lnRef>
+          <a:fillRef idx="3">
+            <a:schemeClr val="accent1"/>
+          </a:fillRef>
+          <a:effectRef idx="2">
+            <a:schemeClr val="accent1"/>
+          </a:effectRef>
+          <a:fontRef idx="minor">
+            <a:schemeClr val="lt1"/>
+          </a:fontRef>
+        </p:style>
+        <p:txBody>
+          <a:bodyPr rtlCol="0" anchor="ctr" wrap="square" lIns="63500" rIns="50800" tIns="38100" bIns="38100"/>
+          <a:lstStyle/>
+          <a:p>
+            <a:pPr algn="l"/>
+            <a:r>
+              <a:rPr sz="900" b="0">
+                <a:solidFill>
+                  <a:srgbClr val="222222"/>
+                </a:solidFill>
+                <a:latin typeface="Meiryo"/>
+              </a:rPr>
+              <a:t>顧客企業のIT部門</a:t>
+            </a:r>
+          </a:p>
+        </p:txBody>
+      </p:sp>
+      <p:sp>
+        <p:nvSpPr>
+          <p:cNvPr id="16" name="Rectangle 15"/>
+          <p:cNvSpPr/>
+          <p:nvPr/>
+        </p:nvSpPr>
+        <p:spPr>
+          <a:xfrm>
+            <a:off x="8961120" y="2240280"/>
+            <a:ext cx="5394960" cy="411480"/>
+          </a:xfrm>
+          <a:prstGeom prst="rect">
+            <a:avLst/>
+          </a:prstGeom>
+          <a:solidFill>
+            <a:srgbClr val="FFFFFF"/>
+          </a:solidFill>
+          <a:ln w="25400">
+            <a:solidFill>
+              <a:srgbClr val="E67E22"/>
+            </a:solidFill>
+          </a:ln>
+        </p:spPr>
+        <p:style>
+          <a:lnRef idx="1">
+            <a:schemeClr val="accent1"/>
+          </a:lnRef>
+          <a:fillRef idx="3">
+            <a:schemeClr val="accent1"/>
+          </a:fillRef>
+          <a:effectRef idx="2">
+            <a:schemeClr val="accent1"/>
+          </a:effectRef>
+          <a:fontRef idx="minor">
+            <a:schemeClr val="lt1"/>
+          </a:fontRef>
+        </p:style>
+        <p:txBody>
+          <a:bodyPr rtlCol="0" anchor="ctr" wrap="square" lIns="63500" rIns="50800" tIns="38100" bIns="38100"/>
+          <a:lstStyle/>
+          <a:p>
+            <a:pPr algn="l"/>
+            <a:r>
+              <a:rPr sz="900" b="1">
+                <a:solidFill>
+                  <a:srgbClr val="222222"/>
+                </a:solidFill>
+                <a:latin typeface="Meiryo"/>
+              </a:rPr>
+              <a:t>顧客企業の問題…に見えるが →</a:t>
+            </a:r>
+          </a:p>
+        </p:txBody>
+      </p:sp>
+      <p:sp>
+        <p:nvSpPr>
+          <p:cNvPr id="17" name="Rectangle 16"/>
+          <p:cNvSpPr/>
+          <p:nvPr/>
+        </p:nvSpPr>
+        <p:spPr>
+          <a:xfrm>
+            <a:off x="731520" y="2880360"/>
+            <a:ext cx="13624560" cy="411480"/>
+          </a:xfrm>
+          <a:prstGeom prst="rect">
+            <a:avLst/>
+          </a:prstGeom>
+          <a:solidFill>
+            <a:srgbClr val="E67E22"/>
+          </a:solidFill>
+          <a:ln>
+            <a:noFill/>
+          </a:ln>
+        </p:spPr>
+        <p:style>
+          <a:lnRef idx="1">
+            <a:schemeClr val="accent1"/>
+          </a:lnRef>
+          <a:fillRef idx="3">
+            <a:schemeClr val="accent1"/>
+          </a:fillRef>
+          <a:effectRef idx="2">
+            <a:schemeClr val="accent1"/>
+          </a:effectRef>
+          <a:fontRef idx="minor">
+            <a:schemeClr val="lt1"/>
+          </a:fontRef>
+        </p:style>
+        <p:txBody>
+          <a:bodyPr rtlCol="0" anchor="ctr" wrap="square" lIns="50800" rIns="50800" tIns="25400" bIns="25400"/>
+          <a:lstStyle/>
+          <a:p>
+            <a:pPr algn="ctr"/>
+            <a:r>
+              <a:rPr sz="1200" b="1">
+                <a:solidFill>
+                  <a:srgbClr val="FFFFFF"/>
+                </a:solidFill>
+                <a:latin typeface="Meiryo"/>
+              </a:rPr>
+              <a:t>BizSTATION利用企業のIT体制 — AppLockerを設定できるか？</a:t>
+            </a:r>
+          </a:p>
+        </p:txBody>
+      </p:sp>
+      <p:sp>
+        <p:nvSpPr>
+          <p:cNvPr id="18" name="Rectangle 17"/>
+          <p:cNvSpPr/>
+          <p:nvPr/>
+        </p:nvSpPr>
+        <p:spPr>
+          <a:xfrm>
+            <a:off x="731520" y="3291840"/>
+            <a:ext cx="2743200" cy="384048"/>
+          </a:xfrm>
+          <a:prstGeom prst="rect">
+            <a:avLst/>
+          </a:prstGeom>
+          <a:solidFill>
+            <a:srgbClr val="FFFFFF"/>
+          </a:solidFill>
+          <a:ln w="25400">
+            <a:solidFill>
+              <a:srgbClr val="CCCCCC"/>
+            </a:solidFill>
+          </a:ln>
+        </p:spPr>
+        <p:style>
+          <a:lnRef idx="1">
+            <a:schemeClr val="accent1"/>
+          </a:lnRef>
+          <a:fillRef idx="3">
+            <a:schemeClr val="accent1"/>
+          </a:fillRef>
+          <a:effectRef idx="2">
+            <a:schemeClr val="accent1"/>
+          </a:effectRef>
+          <a:fontRef idx="minor">
+            <a:schemeClr val="lt1"/>
+          </a:fontRef>
+        </p:style>
+        <p:txBody>
+          <a:bodyPr rtlCol="0" anchor="ctr" wrap="square" lIns="63500" rIns="50800" tIns="38100" bIns="38100"/>
+          <a:lstStyle/>
+          <a:p>
+            <a:pPr algn="l"/>
+            <a:r>
+              <a:rPr sz="1000" b="1">
+                <a:solidFill>
+                  <a:srgbClr val="222222"/>
+                </a:solidFill>
+                <a:latin typeface="Meiryo"/>
+              </a:rPr>
+              <a:t>大企業</a:t>
+            </a:r>
+          </a:p>
+        </p:txBody>
+      </p:sp>
+      <p:sp>
+        <p:nvSpPr>
+          <p:cNvPr id="19" name="Rectangle 18"/>
+          <p:cNvSpPr/>
+          <p:nvPr/>
+        </p:nvSpPr>
+        <p:spPr>
+          <a:xfrm>
+            <a:off x="3474720" y="3291840"/>
+            <a:ext cx="3657600" cy="384048"/>
+          </a:xfrm>
+          <a:prstGeom prst="rect">
+            <a:avLst/>
+          </a:prstGeom>
+          <a:solidFill>
+            <a:srgbClr val="FFFFFF"/>
+          </a:solidFill>
+          <a:ln w="25400">
+            <a:solidFill>
+              <a:srgbClr val="CCCCCC"/>
+            </a:solidFill>
+          </a:ln>
+        </p:spPr>
+        <p:style>
+          <a:lnRef idx="1">
+            <a:schemeClr val="accent1"/>
+          </a:lnRef>
+          <a:fillRef idx="3">
+            <a:schemeClr val="accent1"/>
+          </a:fillRef>
+          <a:effectRef idx="2">
+            <a:schemeClr val="accent1"/>
+          </a:effectRef>
+          <a:fontRef idx="minor">
+            <a:schemeClr val="lt1"/>
+          </a:fontRef>
+        </p:style>
+        <p:txBody>
+          <a:bodyPr rtlCol="0" anchor="ctr" wrap="square" lIns="63500" rIns="50800" tIns="38100" bIns="38100"/>
+          <a:lstStyle/>
+          <a:p>
+            <a:pPr algn="l"/>
+            <a:r>
+              <a:rPr sz="1000" b="0">
+                <a:solidFill>
+                  <a:srgbClr val="222222"/>
+                </a:solidFill>
+                <a:latin typeface="Meiryo"/>
+              </a:rPr>
+              <a:t>情シス部門あり</a:t>
+            </a:r>
+          </a:p>
+        </p:txBody>
+      </p:sp>
+      <p:sp>
+        <p:nvSpPr>
+          <p:cNvPr id="20" name="Rectangle 19"/>
+          <p:cNvSpPr/>
+          <p:nvPr/>
+        </p:nvSpPr>
+        <p:spPr>
+          <a:xfrm>
+            <a:off x="7132320" y="3291840"/>
+            <a:ext cx="4114800" cy="384048"/>
+          </a:xfrm>
+          <a:prstGeom prst="rect">
+            <a:avLst/>
+          </a:prstGeom>
+          <a:solidFill>
+            <a:srgbClr val="27AE60"/>
+          </a:solidFill>
+          <a:ln>
+            <a:noFill/>
+          </a:ln>
+        </p:spPr>
+        <p:style>
+          <a:lnRef idx="1">
+            <a:schemeClr val="accent1"/>
+          </a:lnRef>
+          <a:fillRef idx="3">
+            <a:schemeClr val="accent1"/>
+          </a:fillRef>
+          <a:effectRef idx="2">
+            <a:schemeClr val="accent1"/>
+          </a:effectRef>
+          <a:fontRef idx="minor">
+            <a:schemeClr val="lt1"/>
+          </a:fontRef>
+        </p:style>
+        <p:txBody>
+          <a:bodyPr rtlCol="0" anchor="ctr" wrap="square" lIns="50800" rIns="50800" tIns="25400" bIns="25400"/>
+          <a:lstStyle/>
+          <a:p>
+            <a:pPr algn="ctr"/>
+            <a:r>
+              <a:rPr sz="1000" b="1">
+                <a:solidFill>
+                  <a:srgbClr val="FFFFFF"/>
+                </a:solidFill>
+                <a:latin typeface="Meiryo"/>
+              </a:rPr>
+              <a:t>可能</a:t>
+            </a:r>
+          </a:p>
+        </p:txBody>
+      </p:sp>
+      <p:sp>
+        <p:nvSpPr>
+          <p:cNvPr id="21" name="Rectangle 20"/>
+          <p:cNvSpPr/>
+          <p:nvPr/>
+        </p:nvSpPr>
+        <p:spPr>
+          <a:xfrm>
+            <a:off x="731520" y="3675888"/>
+            <a:ext cx="2743200" cy="384048"/>
+          </a:xfrm>
+          <a:prstGeom prst="rect">
+            <a:avLst/>
+          </a:prstGeom>
+          <a:solidFill>
+            <a:srgbClr val="F9F9F9"/>
+          </a:solidFill>
+          <a:ln w="25400">
+            <a:solidFill>
+              <a:srgbClr val="CCCCCC"/>
+            </a:solidFill>
+          </a:ln>
+        </p:spPr>
+        <p:style>
+          <a:lnRef idx="1">
+            <a:schemeClr val="accent1"/>
+          </a:lnRef>
+          <a:fillRef idx="3">
+            <a:schemeClr val="accent1"/>
+          </a:fillRef>
+          <a:effectRef idx="2">
+            <a:schemeClr val="accent1"/>
+          </a:effectRef>
+          <a:fontRef idx="minor">
+            <a:schemeClr val="lt1"/>
+          </a:fontRef>
+        </p:style>
+        <p:txBody>
+          <a:bodyPr rtlCol="0" anchor="ctr" wrap="square" lIns="63500" rIns="50800" tIns="38100" bIns="38100"/>
+          <a:lstStyle/>
+          <a:p>
+            <a:pPr algn="l"/>
+            <a:r>
+              <a:rPr sz="1000" b="1">
+                <a:solidFill>
+                  <a:srgbClr val="222222"/>
+                </a:solidFill>
+                <a:latin typeface="Meiryo"/>
+              </a:rPr>
+              <a:t>中堅企業</a:t>
+            </a:r>
+          </a:p>
+        </p:txBody>
+      </p:sp>
+      <p:sp>
+        <p:nvSpPr>
+          <p:cNvPr id="22" name="Rectangle 21"/>
+          <p:cNvSpPr/>
+          <p:nvPr/>
+        </p:nvSpPr>
+        <p:spPr>
+          <a:xfrm>
+            <a:off x="3474720" y="3675888"/>
+            <a:ext cx="3657600" cy="384048"/>
+          </a:xfrm>
+          <a:prstGeom prst="rect">
+            <a:avLst/>
+          </a:prstGeom>
+          <a:solidFill>
+            <a:srgbClr val="F9F9F9"/>
+          </a:solidFill>
+          <a:ln w="25400">
+            <a:solidFill>
+              <a:srgbClr val="CCCCCC"/>
+            </a:solidFill>
+          </a:ln>
+        </p:spPr>
+        <p:style>
+          <a:lnRef idx="1">
+            <a:schemeClr val="accent1"/>
+          </a:lnRef>
+          <a:fillRef idx="3">
+            <a:schemeClr val="accent1"/>
+          </a:fillRef>
+          <a:effectRef idx="2">
+            <a:schemeClr val="accent1"/>
+          </a:effectRef>
+          <a:fontRef idx="minor">
+            <a:schemeClr val="lt1"/>
+          </a:fontRef>
+        </p:style>
+        <p:txBody>
+          <a:bodyPr rtlCol="0" anchor="ctr" wrap="square" lIns="63500" rIns="50800" tIns="38100" bIns="38100"/>
+          <a:lstStyle/>
+          <a:p>
+            <a:pPr algn="l"/>
+            <a:r>
+              <a:rPr sz="1000" b="0">
+                <a:solidFill>
+                  <a:srgbClr val="222222"/>
+                </a:solidFill>
+                <a:latin typeface="Meiryo"/>
+              </a:rPr>
+              <a:t>IT担当が1〜2人</a:t>
+            </a:r>
+          </a:p>
+        </p:txBody>
+      </p:sp>
+      <p:sp>
+        <p:nvSpPr>
+          <p:cNvPr id="23" name="Rectangle 22"/>
+          <p:cNvSpPr/>
+          <p:nvPr/>
+        </p:nvSpPr>
+        <p:spPr>
+          <a:xfrm>
+            <a:off x="7132320" y="3675888"/>
+            <a:ext cx="4114800" cy="384048"/>
+          </a:xfrm>
+          <a:prstGeom prst="rect">
+            <a:avLst/>
+          </a:prstGeom>
+          <a:solidFill>
+            <a:srgbClr val="E67E22"/>
+          </a:solidFill>
+          <a:ln>
+            <a:noFill/>
+          </a:ln>
+        </p:spPr>
+        <p:style>
+          <a:lnRef idx="1">
+            <a:schemeClr val="accent1"/>
+          </a:lnRef>
+          <a:fillRef idx="3">
+            <a:schemeClr val="accent1"/>
+          </a:fillRef>
+          <a:effectRef idx="2">
+            <a:schemeClr val="accent1"/>
+          </a:effectRef>
+          <a:fontRef idx="minor">
+            <a:schemeClr val="lt1"/>
+          </a:fontRef>
+        </p:style>
+        <p:txBody>
+          <a:bodyPr rtlCol="0" anchor="ctr" wrap="square" lIns="50800" rIns="50800" tIns="25400" bIns="25400"/>
+          <a:lstStyle/>
+          <a:p>
+            <a:pPr algn="ctr"/>
+            <a:r>
+              <a:rPr sz="1000" b="1">
+                <a:solidFill>
+                  <a:srgbClr val="FFFFFF"/>
+                </a:solidFill>
+                <a:latin typeface="Meiryo"/>
+              </a:rPr>
+              <a:t>厳しい</a:t>
+            </a:r>
+          </a:p>
+        </p:txBody>
+      </p:sp>
+      <p:sp>
+        <p:nvSpPr>
+          <p:cNvPr id="24" name="Rectangle 23"/>
+          <p:cNvSpPr/>
+          <p:nvPr/>
+        </p:nvSpPr>
+        <p:spPr>
+          <a:xfrm>
+            <a:off x="731520" y="4059936"/>
+            <a:ext cx="2743200" cy="384048"/>
+          </a:xfrm>
+          <a:prstGeom prst="rect">
+            <a:avLst/>
+          </a:prstGeom>
+          <a:solidFill>
+            <a:srgbClr val="FFFFFF"/>
+          </a:solidFill>
+          <a:ln w="25400">
+            <a:solidFill>
+              <a:srgbClr val="CCCCCC"/>
+            </a:solidFill>
+          </a:ln>
+        </p:spPr>
+        <p:style>
+          <a:lnRef idx="1">
+            <a:schemeClr val="accent1"/>
+          </a:lnRef>
+          <a:fillRef idx="3">
+            <a:schemeClr val="accent1"/>
+          </a:fillRef>
+          <a:effectRef idx="2">
+            <a:schemeClr val="accent1"/>
+          </a:effectRef>
+          <a:fontRef idx="minor">
+            <a:schemeClr val="lt1"/>
+          </a:fontRef>
+        </p:style>
+        <p:txBody>
+          <a:bodyPr rtlCol="0" anchor="ctr" wrap="square" lIns="63500" rIns="50800" tIns="38100" bIns="38100"/>
+          <a:lstStyle/>
+          <a:p>
+            <a:pPr algn="l"/>
+            <a:r>
+              <a:rPr sz="1000" b="1">
+                <a:solidFill>
+                  <a:srgbClr val="222222"/>
+                </a:solidFill>
+                <a:latin typeface="Meiryo"/>
+              </a:rPr>
+              <a:t>中小企業</a:t>
+            </a:r>
+          </a:p>
+        </p:txBody>
+      </p:sp>
+      <p:sp>
+        <p:nvSpPr>
+          <p:cNvPr id="25" name="Rectangle 24"/>
+          <p:cNvSpPr/>
+          <p:nvPr/>
+        </p:nvSpPr>
+        <p:spPr>
+          <a:xfrm>
+            <a:off x="3474720" y="4059936"/>
+            <a:ext cx="3657600" cy="384048"/>
+          </a:xfrm>
+          <a:prstGeom prst="rect">
+            <a:avLst/>
+          </a:prstGeom>
+          <a:solidFill>
+            <a:srgbClr val="FFFFFF"/>
+          </a:solidFill>
+          <a:ln w="25400">
+            <a:solidFill>
+              <a:srgbClr val="CCCCCC"/>
+            </a:solidFill>
+          </a:ln>
+        </p:spPr>
+        <p:style>
+          <a:lnRef idx="1">
+            <a:schemeClr val="accent1"/>
+          </a:lnRef>
+          <a:fillRef idx="3">
+            <a:schemeClr val="accent1"/>
+          </a:fillRef>
+          <a:effectRef idx="2">
+            <a:schemeClr val="accent1"/>
+          </a:effectRef>
+          <a:fontRef idx="minor">
+            <a:schemeClr val="lt1"/>
+          </a:fontRef>
+        </p:style>
+        <p:txBody>
+          <a:bodyPr rtlCol="0" anchor="ctr" wrap="square" lIns="63500" rIns="50800" tIns="38100" bIns="38100"/>
+          <a:lstStyle/>
+          <a:p>
+            <a:pPr algn="l"/>
+            <a:r>
+              <a:rPr sz="1000" b="0">
+                <a:solidFill>
+                  <a:srgbClr val="222222"/>
+                </a:solidFill>
+                <a:latin typeface="Meiryo"/>
+              </a:rPr>
+              <a:t>IT専任者なし</a:t>
+            </a:r>
+          </a:p>
+        </p:txBody>
+      </p:sp>
+      <p:sp>
+        <p:nvSpPr>
+          <p:cNvPr id="26" name="Rectangle 25"/>
+          <p:cNvSpPr/>
+          <p:nvPr/>
+        </p:nvSpPr>
+        <p:spPr>
+          <a:xfrm>
+            <a:off x="7132320" y="4059936"/>
+            <a:ext cx="4114800" cy="384048"/>
+          </a:xfrm>
+          <a:prstGeom prst="rect">
+            <a:avLst/>
+          </a:prstGeom>
+          <a:solidFill>
+            <a:srgbClr val="C0392B"/>
+          </a:solidFill>
+          <a:ln>
+            <a:noFill/>
+          </a:ln>
+        </p:spPr>
+        <p:style>
+          <a:lnRef idx="1">
+            <a:schemeClr val="accent1"/>
+          </a:lnRef>
+          <a:fillRef idx="3">
+            <a:schemeClr val="accent1"/>
+          </a:fillRef>
+          <a:effectRef idx="2">
+            <a:schemeClr val="accent1"/>
+          </a:effectRef>
+          <a:fontRef idx="minor">
+            <a:schemeClr val="lt1"/>
+          </a:fontRef>
+        </p:style>
+        <p:txBody>
+          <a:bodyPr rtlCol="0" anchor="ctr" wrap="square" lIns="50800" rIns="50800" tIns="25400" bIns="25400"/>
+          <a:lstStyle/>
+          <a:p>
+            <a:pPr algn="ctr"/>
+            <a:r>
+              <a:rPr sz="1000" b="1">
+                <a:solidFill>
+                  <a:srgbClr val="FFFFFF"/>
+                </a:solidFill>
+                <a:latin typeface="Meiryo"/>
+              </a:rPr>
+              <a:t>無理</a:t>
+            </a:r>
+          </a:p>
+        </p:txBody>
+      </p:sp>
+      <p:sp>
+        <p:nvSpPr>
+          <p:cNvPr id="27" name="Rectangle 26"/>
+          <p:cNvSpPr/>
+          <p:nvPr/>
+        </p:nvSpPr>
+        <p:spPr>
+          <a:xfrm>
+            <a:off x="731520" y="4443984"/>
+            <a:ext cx="2743200" cy="384048"/>
+          </a:xfrm>
+          <a:prstGeom prst="rect">
+            <a:avLst/>
+          </a:prstGeom>
+          <a:solidFill>
+            <a:srgbClr val="F9F9F9"/>
+          </a:solidFill>
+          <a:ln w="25400">
+            <a:solidFill>
+              <a:srgbClr val="CCCCCC"/>
+            </a:solidFill>
+          </a:ln>
+        </p:spPr>
+        <p:style>
+          <a:lnRef idx="1">
+            <a:schemeClr val="accent1"/>
+          </a:lnRef>
+          <a:fillRef idx="3">
+            <a:schemeClr val="accent1"/>
+          </a:fillRef>
+          <a:effectRef idx="2">
+            <a:schemeClr val="accent1"/>
+          </a:effectRef>
+          <a:fontRef idx="minor">
+            <a:schemeClr val="lt1"/>
+          </a:fontRef>
+        </p:style>
+        <p:txBody>
+          <a:bodyPr rtlCol="0" anchor="ctr" wrap="square" lIns="63500" rIns="50800" tIns="38100" bIns="38100"/>
+          <a:lstStyle/>
+          <a:p>
+            <a:pPr algn="l"/>
+            <a:r>
+              <a:rPr sz="1000" b="1">
+                <a:solidFill>
+                  <a:srgbClr val="222222"/>
+                </a:solidFill>
+                <a:latin typeface="Meiryo"/>
+              </a:rPr>
+              <a:t>小規模事業者</a:t>
+            </a:r>
+          </a:p>
+        </p:txBody>
+      </p:sp>
+      <p:sp>
+        <p:nvSpPr>
+          <p:cNvPr id="28" name="Rectangle 27"/>
+          <p:cNvSpPr/>
+          <p:nvPr/>
+        </p:nvSpPr>
+        <p:spPr>
+          <a:xfrm>
+            <a:off x="3474720" y="4443984"/>
+            <a:ext cx="3657600" cy="384048"/>
+          </a:xfrm>
+          <a:prstGeom prst="rect">
+            <a:avLst/>
+          </a:prstGeom>
+          <a:solidFill>
+            <a:srgbClr val="F9F9F9"/>
+          </a:solidFill>
+          <a:ln w="25400">
+            <a:solidFill>
+              <a:srgbClr val="CCCCCC"/>
+            </a:solidFill>
+          </a:ln>
+        </p:spPr>
+        <p:style>
+          <a:lnRef idx="1">
+            <a:schemeClr val="accent1"/>
+          </a:lnRef>
+          <a:fillRef idx="3">
+            <a:schemeClr val="accent1"/>
+          </a:fillRef>
+          <a:effectRef idx="2">
+            <a:schemeClr val="accent1"/>
+          </a:effectRef>
+          <a:fontRef idx="minor">
+            <a:schemeClr val="lt1"/>
+          </a:fontRef>
+        </p:style>
+        <p:txBody>
+          <a:bodyPr rtlCol="0" anchor="ctr" wrap="square" lIns="63500" rIns="50800" tIns="38100" bIns="38100"/>
+          <a:lstStyle/>
+          <a:p>
+            <a:pPr algn="l"/>
+            <a:r>
+              <a:rPr sz="1000" b="0">
+                <a:solidFill>
+                  <a:srgbClr val="222222"/>
+                </a:solidFill>
+                <a:latin typeface="Meiryo"/>
+              </a:rPr>
+              <a:t>社長がPC管理</a:t>
+            </a:r>
+          </a:p>
+        </p:txBody>
+      </p:sp>
+      <p:sp>
+        <p:nvSpPr>
+          <p:cNvPr id="29" name="Rectangle 28"/>
+          <p:cNvSpPr/>
+          <p:nvPr/>
+        </p:nvSpPr>
+        <p:spPr>
+          <a:xfrm>
+            <a:off x="7132320" y="4443984"/>
+            <a:ext cx="4114800" cy="384048"/>
+          </a:xfrm>
+          <a:prstGeom prst="rect">
+            <a:avLst/>
+          </a:prstGeom>
+          <a:solidFill>
+            <a:srgbClr val="C0392B"/>
+          </a:solidFill>
+          <a:ln>
+            <a:noFill/>
+          </a:ln>
+        </p:spPr>
+        <p:style>
+          <a:lnRef idx="1">
+            <a:schemeClr val="accent1"/>
+          </a:lnRef>
+          <a:fillRef idx="3">
+            <a:schemeClr val="accent1"/>
+          </a:fillRef>
+          <a:effectRef idx="2">
+            <a:schemeClr val="accent1"/>
+          </a:effectRef>
+          <a:fontRef idx="minor">
+            <a:schemeClr val="lt1"/>
+          </a:fontRef>
+        </p:style>
+        <p:txBody>
+          <a:bodyPr rtlCol="0" anchor="ctr" wrap="square" lIns="50800" rIns="50800" tIns="25400" bIns="25400"/>
+          <a:lstStyle/>
+          <a:p>
+            <a:pPr algn="ctr"/>
+            <a:r>
+              <a:rPr sz="1000" b="1">
+                <a:solidFill>
+                  <a:srgbClr val="FFFFFF"/>
+                </a:solidFill>
+                <a:latin typeface="Meiryo"/>
+              </a:rPr>
+              <a:t>論外</a:t>
+            </a:r>
+          </a:p>
+        </p:txBody>
+      </p:sp>
+      <p:sp>
+        <p:nvSpPr>
+          <p:cNvPr id="30" name="Rectangle 29"/>
+          <p:cNvSpPr/>
+          <p:nvPr/>
+        </p:nvSpPr>
+        <p:spPr>
+          <a:xfrm>
+            <a:off x="731520" y="4937760"/>
+            <a:ext cx="13624560" cy="411480"/>
+          </a:xfrm>
+          <a:prstGeom prst="rect">
+            <a:avLst/>
+          </a:prstGeom>
+          <a:solidFill>
+            <a:srgbClr val="C0392B"/>
+          </a:solidFill>
+          <a:ln>
+            <a:noFill/>
+          </a:ln>
+        </p:spPr>
+        <p:style>
+          <a:lnRef idx="1">
+            <a:schemeClr val="accent1"/>
+          </a:lnRef>
+          <a:fillRef idx="3">
+            <a:schemeClr val="accent1"/>
+          </a:fillRef>
+          <a:effectRef idx="2">
+            <a:schemeClr val="accent1"/>
+          </a:effectRef>
+          <a:fontRef idx="minor">
+            <a:schemeClr val="lt1"/>
+          </a:fontRef>
+        </p:style>
+        <p:txBody>
+          <a:bodyPr rtlCol="0" anchor="ctr" wrap="square" lIns="50800" rIns="50800" tIns="25400" bIns="25400"/>
+          <a:lstStyle/>
+          <a:p>
+            <a:pPr algn="ctr"/>
+            <a:r>
+              <a:rPr sz="1200" b="1">
+                <a:solidFill>
+                  <a:srgbClr val="FFFFFF"/>
+                </a:solidFill>
+                <a:latin typeface="Meiryo"/>
+              </a:rPr>
+              <a:t>すべて同じ構図：「顧客にやってね」で丸投げ → 機能しない</a:t>
+            </a:r>
+          </a:p>
+        </p:txBody>
+      </p:sp>
+      <p:sp>
+        <p:nvSpPr>
+          <p:cNvPr id="31" name="Rectangle 30"/>
+          <p:cNvSpPr/>
+          <p:nvPr/>
+        </p:nvSpPr>
+        <p:spPr>
+          <a:xfrm>
+            <a:off x="731520" y="5349240"/>
+            <a:ext cx="6858000" cy="347472"/>
+          </a:xfrm>
+          <a:prstGeom prst="rect">
+            <a:avLst/>
+          </a:prstGeom>
+          <a:solidFill>
+            <a:srgbClr val="FFFFFF"/>
+          </a:solidFill>
+          <a:ln w="25400">
+            <a:solidFill>
+              <a:srgbClr val="CCCCCC"/>
+            </a:solidFill>
+          </a:ln>
+        </p:spPr>
+        <p:style>
+          <a:lnRef idx="1">
+            <a:schemeClr val="accent1"/>
+          </a:lnRef>
+          <a:fillRef idx="3">
+            <a:schemeClr val="accent1"/>
+          </a:fillRef>
+          <a:effectRef idx="2">
+            <a:schemeClr val="accent1"/>
+          </a:effectRef>
+          <a:fontRef idx="minor">
+            <a:schemeClr val="lt1"/>
+          </a:fontRef>
+        </p:style>
+        <p:txBody>
+          <a:bodyPr rtlCol="0" anchor="ctr" wrap="square" lIns="63500" rIns="50800" tIns="38100" bIns="38100"/>
+          <a:lstStyle/>
+          <a:p>
+            <a:pPr algn="l"/>
+            <a:r>
+              <a:rPr sz="900" b="0">
+                <a:solidFill>
+                  <a:srgbClr val="222222"/>
+                </a:solidFill>
+                <a:latin typeface="Meiryo"/>
+              </a:rPr>
+              <a:t>「メールのリンクをクリックしないで」</a:t>
+            </a:r>
+          </a:p>
+        </p:txBody>
+      </p:sp>
+      <p:sp>
+        <p:nvSpPr>
+          <p:cNvPr id="32" name="Rectangle 31"/>
+          <p:cNvSpPr/>
+          <p:nvPr/>
+        </p:nvSpPr>
+        <p:spPr>
+          <a:xfrm>
+            <a:off x="7589520" y="5349240"/>
+            <a:ext cx="6766560" cy="347472"/>
+          </a:xfrm>
+          <a:prstGeom prst="rect">
+            <a:avLst/>
+          </a:prstGeom>
+          <a:solidFill>
+            <a:srgbClr val="FDEDEC"/>
+          </a:solidFill>
+          <a:ln>
+            <a:noFill/>
+          </a:ln>
+        </p:spPr>
+        <p:style>
+          <a:lnRef idx="1">
+            <a:schemeClr val="accent1"/>
+          </a:lnRef>
+          <a:fillRef idx="3">
+            <a:schemeClr val="accent1"/>
+          </a:fillRef>
+          <a:effectRef idx="2">
+            <a:schemeClr val="accent1"/>
+          </a:effectRef>
+          <a:fontRef idx="minor">
+            <a:schemeClr val="lt1"/>
+          </a:fontRef>
+        </p:style>
+        <p:txBody>
+          <a:bodyPr rtlCol="0" anchor="ctr" wrap="square" lIns="50800" rIns="50800" tIns="25400" bIns="25400"/>
+          <a:lstStyle/>
+          <a:p>
+            <a:pPr algn="ctr"/>
+            <a:r>
+              <a:rPr sz="900" b="1">
+                <a:solidFill>
+                  <a:srgbClr val="C0392B"/>
+                </a:solidFill>
+                <a:latin typeface="Meiryo"/>
+              </a:rPr>
+              <a:t>顧客任せ → 機能しない</a:t>
+            </a:r>
+          </a:p>
+        </p:txBody>
+      </p:sp>
+      <p:sp>
+        <p:nvSpPr>
+          <p:cNvPr id="33" name="Rectangle 32"/>
+          <p:cNvSpPr/>
+          <p:nvPr/>
+        </p:nvSpPr>
+        <p:spPr>
+          <a:xfrm>
+            <a:off x="731520" y="5696712"/>
+            <a:ext cx="6858000" cy="347472"/>
+          </a:xfrm>
+          <a:prstGeom prst="rect">
+            <a:avLst/>
+          </a:prstGeom>
+          <a:solidFill>
+            <a:srgbClr val="F9F9F9"/>
+          </a:solidFill>
+          <a:ln w="25400">
+            <a:solidFill>
+              <a:srgbClr val="CCCCCC"/>
+            </a:solidFill>
+          </a:ln>
+        </p:spPr>
+        <p:style>
+          <a:lnRef idx="1">
+            <a:schemeClr val="accent1"/>
+          </a:lnRef>
+          <a:fillRef idx="3">
+            <a:schemeClr val="accent1"/>
+          </a:fillRef>
+          <a:effectRef idx="2">
+            <a:schemeClr val="accent1"/>
+          </a:effectRef>
+          <a:fontRef idx="minor">
+            <a:schemeClr val="lt1"/>
+          </a:fontRef>
+        </p:style>
+        <p:txBody>
+          <a:bodyPr rtlCol="0" anchor="ctr" wrap="square" lIns="63500" rIns="50800" tIns="38100" bIns="38100"/>
+          <a:lstStyle/>
+          <a:p>
+            <a:pPr algn="l"/>
+            <a:r>
+              <a:rPr sz="900" b="0">
+                <a:solidFill>
+                  <a:srgbClr val="222222"/>
+                </a:solidFill>
+                <a:latin typeface="Meiryo"/>
+              </a:rPr>
+              <a:t>「ブックマークからアクセスして」</a:t>
+            </a:r>
+          </a:p>
+        </p:txBody>
+      </p:sp>
+      <p:sp>
+        <p:nvSpPr>
+          <p:cNvPr id="34" name="Rectangle 33"/>
+          <p:cNvSpPr/>
+          <p:nvPr/>
+        </p:nvSpPr>
+        <p:spPr>
+          <a:xfrm>
+            <a:off x="7589520" y="5696712"/>
+            <a:ext cx="6766560" cy="347472"/>
+          </a:xfrm>
+          <a:prstGeom prst="rect">
+            <a:avLst/>
+          </a:prstGeom>
+          <a:solidFill>
+            <a:srgbClr val="FDEDEC"/>
+          </a:solidFill>
+          <a:ln>
+            <a:noFill/>
+          </a:ln>
+        </p:spPr>
+        <p:style>
+          <a:lnRef idx="1">
+            <a:schemeClr val="accent1"/>
+          </a:lnRef>
+          <a:fillRef idx="3">
+            <a:schemeClr val="accent1"/>
+          </a:fillRef>
+          <a:effectRef idx="2">
+            <a:schemeClr val="accent1"/>
+          </a:effectRef>
+          <a:fontRef idx="minor">
+            <a:schemeClr val="lt1"/>
+          </a:fontRef>
+        </p:style>
+        <p:txBody>
+          <a:bodyPr rtlCol="0" anchor="ctr" wrap="square" lIns="50800" rIns="50800" tIns="25400" bIns="25400"/>
+          <a:lstStyle/>
+          <a:p>
+            <a:pPr algn="ctr"/>
+            <a:r>
+              <a:rPr sz="900" b="1">
+                <a:solidFill>
+                  <a:srgbClr val="C0392B"/>
+                </a:solidFill>
+                <a:latin typeface="Meiryo"/>
+              </a:rPr>
+              <a:t>顧客任せ → 機能しない</a:t>
+            </a:r>
+          </a:p>
+        </p:txBody>
+      </p:sp>
+      <p:sp>
+        <p:nvSpPr>
+          <p:cNvPr id="35" name="Rectangle 34"/>
+          <p:cNvSpPr/>
+          <p:nvPr/>
+        </p:nvSpPr>
+        <p:spPr>
+          <a:xfrm>
+            <a:off x="731520" y="6044184"/>
+            <a:ext cx="6858000" cy="347472"/>
+          </a:xfrm>
+          <a:prstGeom prst="rect">
+            <a:avLst/>
+          </a:prstGeom>
+          <a:solidFill>
+            <a:srgbClr val="FFFFFF"/>
+          </a:solidFill>
+          <a:ln w="25400">
+            <a:solidFill>
+              <a:srgbClr val="CCCCCC"/>
+            </a:solidFill>
+          </a:ln>
+        </p:spPr>
+        <p:style>
+          <a:lnRef idx="1">
+            <a:schemeClr val="accent1"/>
+          </a:lnRef>
+          <a:fillRef idx="3">
+            <a:schemeClr val="accent1"/>
+          </a:fillRef>
+          <a:effectRef idx="2">
+            <a:schemeClr val="accent1"/>
+          </a:effectRef>
+          <a:fontRef idx="minor">
+            <a:schemeClr val="lt1"/>
+          </a:fontRef>
+        </p:style>
+        <p:txBody>
+          <a:bodyPr rtlCol="0" anchor="ctr" wrap="square" lIns="63500" rIns="50800" tIns="38100" bIns="38100"/>
+          <a:lstStyle/>
+          <a:p>
+            <a:pPr algn="l"/>
+            <a:r>
+              <a:rPr sz="900" b="0">
+                <a:solidFill>
+                  <a:srgbClr val="222222"/>
+                </a:solidFill>
+                <a:latin typeface="Meiryo"/>
+              </a:rPr>
+              <a:t>「不明な発行元に注意して」</a:t>
+            </a:r>
+          </a:p>
+        </p:txBody>
+      </p:sp>
+      <p:sp>
+        <p:nvSpPr>
+          <p:cNvPr id="36" name="Rectangle 35"/>
+          <p:cNvSpPr/>
+          <p:nvPr/>
+        </p:nvSpPr>
+        <p:spPr>
+          <a:xfrm>
+            <a:off x="7589520" y="6044184"/>
+            <a:ext cx="6766560" cy="347472"/>
+          </a:xfrm>
+          <a:prstGeom prst="rect">
+            <a:avLst/>
+          </a:prstGeom>
+          <a:solidFill>
+            <a:srgbClr val="FDEDEC"/>
+          </a:solidFill>
+          <a:ln>
+            <a:noFill/>
+          </a:ln>
+        </p:spPr>
+        <p:style>
+          <a:lnRef idx="1">
+            <a:schemeClr val="accent1"/>
+          </a:lnRef>
+          <a:fillRef idx="3">
+            <a:schemeClr val="accent1"/>
+          </a:fillRef>
+          <a:effectRef idx="2">
+            <a:schemeClr val="accent1"/>
+          </a:effectRef>
+          <a:fontRef idx="minor">
+            <a:schemeClr val="lt1"/>
+          </a:fontRef>
+        </p:style>
+        <p:txBody>
+          <a:bodyPr rtlCol="0" anchor="ctr" wrap="square" lIns="50800" rIns="50800" tIns="25400" bIns="25400"/>
+          <a:lstStyle/>
+          <a:p>
+            <a:pPr algn="ctr"/>
+            <a:r>
+              <a:rPr sz="900" b="1">
+                <a:solidFill>
+                  <a:srgbClr val="C0392B"/>
+                </a:solidFill>
+                <a:latin typeface="Meiryo"/>
+              </a:rPr>
+              <a:t>顧客任せ → 機能しない</a:t>
+            </a:r>
+          </a:p>
+        </p:txBody>
+      </p:sp>
+      <p:sp>
+        <p:nvSpPr>
+          <p:cNvPr id="37" name="Rectangle 36"/>
+          <p:cNvSpPr/>
+          <p:nvPr/>
+        </p:nvSpPr>
+        <p:spPr>
+          <a:xfrm>
+            <a:off x="731520" y="6391656"/>
+            <a:ext cx="6858000" cy="347472"/>
+          </a:xfrm>
+          <a:prstGeom prst="rect">
+            <a:avLst/>
+          </a:prstGeom>
+          <a:solidFill>
+            <a:srgbClr val="F9F9F9"/>
+          </a:solidFill>
+          <a:ln w="25400">
+            <a:solidFill>
+              <a:srgbClr val="CCCCCC"/>
+            </a:solidFill>
+          </a:ln>
+        </p:spPr>
+        <p:style>
+          <a:lnRef idx="1">
+            <a:schemeClr val="accent1"/>
+          </a:lnRef>
+          <a:fillRef idx="3">
+            <a:schemeClr val="accent1"/>
+          </a:fillRef>
+          <a:effectRef idx="2">
+            <a:schemeClr val="accent1"/>
+          </a:effectRef>
+          <a:fontRef idx="minor">
+            <a:schemeClr val="lt1"/>
+          </a:fontRef>
+        </p:style>
+        <p:txBody>
+          <a:bodyPr rtlCol="0" anchor="ctr" wrap="square" lIns="63500" rIns="50800" tIns="38100" bIns="38100"/>
+          <a:lstStyle/>
+          <a:p>
+            <a:pPr algn="l"/>
+            <a:r>
+              <a:rPr sz="900" b="0">
+                <a:solidFill>
+                  <a:srgbClr val="222222"/>
+                </a:solidFill>
+                <a:latin typeface="Meiryo"/>
+              </a:rPr>
+              <a:t>「AppLockerを設定してください」</a:t>
+            </a:r>
+          </a:p>
+        </p:txBody>
+      </p:sp>
+      <p:sp>
+        <p:nvSpPr>
+          <p:cNvPr id="38" name="Rectangle 37"/>
+          <p:cNvSpPr/>
+          <p:nvPr/>
+        </p:nvSpPr>
+        <p:spPr>
+          <a:xfrm>
+            <a:off x="7589520" y="6391656"/>
+            <a:ext cx="6766560" cy="347472"/>
+          </a:xfrm>
+          <a:prstGeom prst="rect">
+            <a:avLst/>
+          </a:prstGeom>
+          <a:solidFill>
+            <a:srgbClr val="FDEDEC"/>
+          </a:solidFill>
+          <a:ln>
+            <a:noFill/>
+          </a:ln>
+        </p:spPr>
+        <p:style>
+          <a:lnRef idx="1">
+            <a:schemeClr val="accent1"/>
+          </a:lnRef>
+          <a:fillRef idx="3">
+            <a:schemeClr val="accent1"/>
+          </a:fillRef>
+          <a:effectRef idx="2">
+            <a:schemeClr val="accent1"/>
+          </a:effectRef>
+          <a:fontRef idx="minor">
+            <a:schemeClr val="lt1"/>
+          </a:fontRef>
+        </p:style>
+        <p:txBody>
+          <a:bodyPr rtlCol="0" anchor="ctr" wrap="square" lIns="50800" rIns="50800" tIns="25400" bIns="25400"/>
+          <a:lstStyle/>
+          <a:p>
+            <a:pPr algn="ctr"/>
+            <a:r>
+              <a:rPr sz="900" b="1">
+                <a:solidFill>
+                  <a:srgbClr val="C0392B"/>
+                </a:solidFill>
+                <a:latin typeface="Meiryo"/>
+              </a:rPr>
+              <a:t>顧客任せ → 機能しない</a:t>
+            </a:r>
+          </a:p>
+        </p:txBody>
+      </p:sp>
+      <p:sp>
+        <p:nvSpPr>
+          <p:cNvPr id="39" name="Rectangle 38"/>
+          <p:cNvSpPr/>
+          <p:nvPr/>
+        </p:nvSpPr>
+        <p:spPr>
+          <a:xfrm>
+            <a:off x="731520" y="6858000"/>
+            <a:ext cx="13624560" cy="365760"/>
+          </a:xfrm>
+          <a:prstGeom prst="rect">
+            <a:avLst/>
+          </a:prstGeom>
+          <a:solidFill>
+            <a:srgbClr val="27AE60"/>
+          </a:solidFill>
+          <a:ln>
+            <a:noFill/>
+          </a:ln>
+        </p:spPr>
+        <p:style>
+          <a:lnRef idx="1">
+            <a:schemeClr val="accent1"/>
+          </a:lnRef>
+          <a:fillRef idx="3">
+            <a:schemeClr val="accent1"/>
+          </a:fillRef>
+          <a:effectRef idx="2">
+            <a:schemeClr val="accent1"/>
+          </a:effectRef>
+          <a:fontRef idx="minor">
+            <a:schemeClr val="lt1"/>
+          </a:fontRef>
+        </p:style>
+        <p:txBody>
+          <a:bodyPr rtlCol="0" anchor="ctr" wrap="square" lIns="50800" rIns="50800" tIns="25400" bIns="25400"/>
+          <a:lstStyle/>
+          <a:p>
+            <a:pPr algn="ctr"/>
+            <a:r>
+              <a:rPr sz="1200" b="1">
+                <a:solidFill>
+                  <a:srgbClr val="FFFFFF"/>
+                </a:solidFill>
+                <a:latin typeface="Meiryo"/>
+              </a:rPr>
+              <a:t>銀行がやるべきこと</a:t>
+            </a:r>
+          </a:p>
+        </p:txBody>
+      </p:sp>
+      <p:sp>
+        <p:nvSpPr>
+          <p:cNvPr id="40" name="Rectangle 39"/>
+          <p:cNvSpPr/>
+          <p:nvPr/>
+        </p:nvSpPr>
+        <p:spPr>
+          <a:xfrm>
+            <a:off x="731520" y="7223760"/>
+            <a:ext cx="3200400" cy="365760"/>
+          </a:xfrm>
+          <a:prstGeom prst="rect">
+            <a:avLst/>
+          </a:prstGeom>
+          <a:solidFill>
+            <a:srgbClr val="FFFFFF"/>
+          </a:solidFill>
+          <a:ln w="25400">
+            <a:solidFill>
+              <a:srgbClr val="27AE60"/>
+            </a:solidFill>
+          </a:ln>
+        </p:spPr>
+        <p:style>
+          <a:lnRef idx="1">
+            <a:schemeClr val="accent1"/>
+          </a:lnRef>
+          <a:fillRef idx="3">
+            <a:schemeClr val="accent1"/>
+          </a:fillRef>
+          <a:effectRef idx="2">
+            <a:schemeClr val="accent1"/>
+          </a:effectRef>
+          <a:fontRef idx="minor">
+            <a:schemeClr val="lt1"/>
+          </a:fontRef>
+        </p:style>
+        <p:txBody>
+          <a:bodyPr rtlCol="0" anchor="ctr" wrap="square" lIns="63500" rIns="50800" tIns="38100" bIns="38100"/>
+          <a:lstStyle/>
+          <a:p>
+            <a:pPr algn="l"/>
+            <a:r>
+              <a:rPr sz="900" b="1">
+                <a:solidFill>
+                  <a:srgbClr val="222222"/>
+                </a:solidFill>
+                <a:latin typeface="Meiryo"/>
+              </a:rPr>
+              <a:t>DMARC p=reject</a:t>
+            </a:r>
+          </a:p>
+        </p:txBody>
+      </p:sp>
+      <p:sp>
+        <p:nvSpPr>
+          <p:cNvPr id="41" name="Rectangle 40"/>
+          <p:cNvSpPr/>
+          <p:nvPr/>
+        </p:nvSpPr>
+        <p:spPr>
+          <a:xfrm>
+            <a:off x="3931920" y="7223760"/>
+            <a:ext cx="5029200" cy="365760"/>
+          </a:xfrm>
+          <a:prstGeom prst="rect">
+            <a:avLst/>
+          </a:prstGeom>
+          <a:solidFill>
+            <a:srgbClr val="FFFFFF"/>
+          </a:solidFill>
+          <a:ln w="25400">
+            <a:solidFill>
+              <a:srgbClr val="CCCCCC"/>
+            </a:solidFill>
+          </a:ln>
+        </p:spPr>
+        <p:style>
+          <a:lnRef idx="1">
+            <a:schemeClr val="accent1"/>
+          </a:lnRef>
+          <a:fillRef idx="3">
+            <a:schemeClr val="accent1"/>
+          </a:fillRef>
+          <a:effectRef idx="2">
+            <a:schemeClr val="accent1"/>
+          </a:effectRef>
+          <a:fontRef idx="minor">
+            <a:schemeClr val="lt1"/>
+          </a:fontRef>
+        </p:style>
+        <p:txBody>
+          <a:bodyPr rtlCol="0" anchor="ctr" wrap="square" lIns="63500" rIns="50800" tIns="38100" bIns="38100"/>
+          <a:lstStyle/>
+          <a:p>
+            <a:pPr algn="l"/>
+            <a:r>
+              <a:rPr sz="900" b="0">
+                <a:solidFill>
+                  <a:srgbClr val="222222"/>
+                </a:solidFill>
+                <a:latin typeface="Meiryo"/>
+              </a:rPr>
+              <a:t>銀行が自分で設定する</a:t>
+            </a:r>
+          </a:p>
+        </p:txBody>
+      </p:sp>
+      <p:sp>
+        <p:nvSpPr>
+          <p:cNvPr id="42" name="Rectangle 41"/>
+          <p:cNvSpPr/>
+          <p:nvPr/>
+        </p:nvSpPr>
+        <p:spPr>
+          <a:xfrm>
+            <a:off x="8961120" y="7223760"/>
+            <a:ext cx="5394960" cy="365760"/>
+          </a:xfrm>
+          <a:prstGeom prst="rect">
+            <a:avLst/>
+          </a:prstGeom>
+          <a:solidFill>
+            <a:srgbClr val="FFFFFF"/>
+          </a:solidFill>
+          <a:ln w="25400">
+            <a:solidFill>
+              <a:srgbClr val="27AE60"/>
+            </a:solidFill>
+          </a:ln>
+        </p:spPr>
+        <p:style>
+          <a:lnRef idx="1">
+            <a:schemeClr val="accent1"/>
+          </a:lnRef>
+          <a:fillRef idx="3">
+            <a:schemeClr val="accent1"/>
+          </a:fillRef>
+          <a:effectRef idx="2">
+            <a:schemeClr val="accent1"/>
+          </a:effectRef>
+          <a:fontRef idx="minor">
+            <a:schemeClr val="lt1"/>
+          </a:fontRef>
+        </p:style>
+        <p:txBody>
+          <a:bodyPr rtlCol="0" anchor="ctr" wrap="square" lIns="63500" rIns="50800" tIns="38100" bIns="38100"/>
+          <a:lstStyle/>
+          <a:p>
+            <a:pPr algn="l"/>
+            <a:r>
+              <a:rPr sz="900" b="1">
+                <a:solidFill>
+                  <a:srgbClr val="27AE60"/>
+                </a:solidFill>
+                <a:latin typeface="Meiryo"/>
+              </a:rPr>
+              <a:t>顧客に求めること：なし</a:t>
+            </a:r>
+          </a:p>
+        </p:txBody>
+      </p:sp>
+      <p:sp>
+        <p:nvSpPr>
+          <p:cNvPr id="43" name="Rectangle 42"/>
+          <p:cNvSpPr/>
+          <p:nvPr/>
+        </p:nvSpPr>
+        <p:spPr>
+          <a:xfrm>
+            <a:off x="731520" y="7589520"/>
+            <a:ext cx="3200400" cy="365760"/>
+          </a:xfrm>
+          <a:prstGeom prst="rect">
+            <a:avLst/>
+          </a:prstGeom>
+          <a:solidFill>
+            <a:srgbClr val="F9F9F9"/>
+          </a:solidFill>
+          <a:ln w="25400">
+            <a:solidFill>
+              <a:srgbClr val="27AE60"/>
+            </a:solidFill>
+          </a:ln>
+        </p:spPr>
+        <p:style>
+          <a:lnRef idx="1">
+            <a:schemeClr val="accent1"/>
+          </a:lnRef>
+          <a:fillRef idx="3">
+            <a:schemeClr val="accent1"/>
+          </a:fillRef>
+          <a:effectRef idx="2">
+            <a:schemeClr val="accent1"/>
+          </a:effectRef>
+          <a:fontRef idx="minor">
+            <a:schemeClr val="lt1"/>
+          </a:fontRef>
+        </p:style>
+        <p:txBody>
+          <a:bodyPr rtlCol="0" anchor="ctr" wrap="square" lIns="63500" rIns="50800" tIns="38100" bIns="38100"/>
+          <a:lstStyle/>
+          <a:p>
+            <a:pPr algn="l"/>
+            <a:r>
+              <a:rPr sz="900" b="1">
+                <a:solidFill>
+                  <a:srgbClr val="222222"/>
+                </a:solidFill>
+                <a:latin typeface="Meiryo"/>
+              </a:rPr>
+              <a:t>AppLocker/WDAC設定支援</a:t>
+            </a:r>
+          </a:p>
+        </p:txBody>
+      </p:sp>
+      <p:sp>
+        <p:nvSpPr>
+          <p:cNvPr id="44" name="Rectangle 43"/>
+          <p:cNvSpPr/>
+          <p:nvPr/>
+        </p:nvSpPr>
+        <p:spPr>
+          <a:xfrm>
+            <a:off x="3931920" y="7589520"/>
+            <a:ext cx="5029200" cy="365760"/>
+          </a:xfrm>
+          <a:prstGeom prst="rect">
+            <a:avLst/>
+          </a:prstGeom>
+          <a:solidFill>
+            <a:srgbClr val="F9F9F9"/>
+          </a:solidFill>
+          <a:ln w="25400">
+            <a:solidFill>
+              <a:srgbClr val="CCCCCC"/>
+            </a:solidFill>
+          </a:ln>
+        </p:spPr>
+        <p:style>
+          <a:lnRef idx="1">
+            <a:schemeClr val="accent1"/>
+          </a:lnRef>
+          <a:fillRef idx="3">
+            <a:schemeClr val="accent1"/>
+          </a:fillRef>
+          <a:effectRef idx="2">
+            <a:schemeClr val="accent1"/>
+          </a:effectRef>
+          <a:fontRef idx="minor">
+            <a:schemeClr val="lt1"/>
+          </a:fontRef>
+        </p:style>
+        <p:txBody>
+          <a:bodyPr rtlCol="0" anchor="ctr" wrap="square" lIns="63500" rIns="50800" tIns="38100" bIns="38100"/>
+          <a:lstStyle/>
+          <a:p>
+            <a:pPr algn="l"/>
+            <a:r>
+              <a:rPr sz="900" b="0">
+                <a:solidFill>
+                  <a:srgbClr val="222222"/>
+                </a:solidFill>
+                <a:latin typeface="Meiryo"/>
+              </a:rPr>
+              <a:t>BizSTATION契約時に設定を支援する</a:t>
+            </a:r>
+          </a:p>
+        </p:txBody>
+      </p:sp>
+      <p:sp>
+        <p:nvSpPr>
+          <p:cNvPr id="45" name="Rectangle 44"/>
+          <p:cNvSpPr/>
+          <p:nvPr/>
+        </p:nvSpPr>
+        <p:spPr>
+          <a:xfrm>
+            <a:off x="8961120" y="7589520"/>
+            <a:ext cx="5394960" cy="365760"/>
+          </a:xfrm>
+          <a:prstGeom prst="rect">
+            <a:avLst/>
+          </a:prstGeom>
+          <a:solidFill>
+            <a:srgbClr val="F9F9F9"/>
+          </a:solidFill>
+          <a:ln w="25400">
+            <a:solidFill>
+              <a:srgbClr val="27AE60"/>
+            </a:solidFill>
+          </a:ln>
+        </p:spPr>
+        <p:style>
+          <a:lnRef idx="1">
+            <a:schemeClr val="accent1"/>
+          </a:lnRef>
+          <a:fillRef idx="3">
+            <a:schemeClr val="accent1"/>
+          </a:fillRef>
+          <a:effectRef idx="2">
+            <a:schemeClr val="accent1"/>
+          </a:effectRef>
+          <a:fontRef idx="minor">
+            <a:schemeClr val="lt1"/>
+          </a:fontRef>
+        </p:style>
+        <p:txBody>
+          <a:bodyPr rtlCol="0" anchor="ctr" wrap="square" lIns="63500" rIns="50800" tIns="38100" bIns="38100"/>
+          <a:lstStyle/>
+          <a:p>
+            <a:pPr algn="l"/>
+            <a:r>
+              <a:rPr sz="900" b="1">
+                <a:solidFill>
+                  <a:srgbClr val="27AE60"/>
+                </a:solidFill>
+                <a:latin typeface="Meiryo"/>
+              </a:rPr>
+              <a:t>顧客に求めること：なし</a:t>
+            </a:r>
+          </a:p>
+        </p:txBody>
+      </p:sp>
+      <p:sp>
+        <p:nvSpPr>
+          <p:cNvPr id="46" name="Rectangle 45"/>
+          <p:cNvSpPr/>
+          <p:nvPr/>
+        </p:nvSpPr>
+        <p:spPr>
+          <a:xfrm>
+            <a:off x="731520" y="7955280"/>
+            <a:ext cx="3200400" cy="365760"/>
+          </a:xfrm>
+          <a:prstGeom prst="rect">
+            <a:avLst/>
+          </a:prstGeom>
+          <a:solidFill>
+            <a:srgbClr val="FFFFFF"/>
+          </a:solidFill>
+          <a:ln w="25400">
+            <a:solidFill>
+              <a:srgbClr val="27AE60"/>
+            </a:solidFill>
+          </a:ln>
+        </p:spPr>
+        <p:style>
+          <a:lnRef idx="1">
+            <a:schemeClr val="accent1"/>
+          </a:lnRef>
+          <a:fillRef idx="3">
+            <a:schemeClr val="accent1"/>
+          </a:fillRef>
+          <a:effectRef idx="2">
+            <a:schemeClr val="accent1"/>
+          </a:effectRef>
+          <a:fontRef idx="minor">
+            <a:schemeClr val="lt1"/>
+          </a:fontRef>
+        </p:style>
+        <p:txBody>
+          <a:bodyPr rtlCol="0" anchor="ctr" wrap="square" lIns="63500" rIns="50800" tIns="38100" bIns="38100"/>
+          <a:lstStyle/>
+          <a:p>
+            <a:pPr algn="l"/>
+            <a:r>
+              <a:rPr sz="900" b="1">
+                <a:solidFill>
+                  <a:srgbClr val="222222"/>
+                </a:solidFill>
+                <a:latin typeface="Meiryo"/>
+              </a:rPr>
+              <a:t>初期設定ツール提供</a:t>
+            </a:r>
+          </a:p>
+        </p:txBody>
+      </p:sp>
+      <p:sp>
+        <p:nvSpPr>
+          <p:cNvPr id="47" name="Rectangle 46"/>
+          <p:cNvSpPr/>
+          <p:nvPr/>
+        </p:nvSpPr>
+        <p:spPr>
+          <a:xfrm>
+            <a:off x="3931920" y="7955280"/>
+            <a:ext cx="5029200" cy="365760"/>
+          </a:xfrm>
+          <a:prstGeom prst="rect">
+            <a:avLst/>
+          </a:prstGeom>
+          <a:solidFill>
+            <a:srgbClr val="FFFFFF"/>
+          </a:solidFill>
+          <a:ln w="25400">
+            <a:solidFill>
+              <a:srgbClr val="CCCCCC"/>
+            </a:solidFill>
+          </a:ln>
+        </p:spPr>
+        <p:style>
+          <a:lnRef idx="1">
+            <a:schemeClr val="accent1"/>
+          </a:lnRef>
+          <a:fillRef idx="3">
+            <a:schemeClr val="accent1"/>
+          </a:fillRef>
+          <a:effectRef idx="2">
+            <a:schemeClr val="accent1"/>
+          </a:effectRef>
+          <a:fontRef idx="minor">
+            <a:schemeClr val="lt1"/>
+          </a:fontRef>
+        </p:style>
+        <p:txBody>
+          <a:bodyPr rtlCol="0" anchor="ctr" wrap="square" lIns="63500" rIns="50800" tIns="38100" bIns="38100"/>
+          <a:lstStyle/>
+          <a:p>
+            <a:pPr algn="l"/>
+            <a:r>
+              <a:rPr sz="900" b="0">
+                <a:solidFill>
+                  <a:srgbClr val="222222"/>
+                </a:solidFill>
+                <a:latin typeface="Meiryo"/>
+              </a:rPr>
+              <a:t>ワンクリックで設定完了するツール</a:t>
+            </a:r>
+          </a:p>
+        </p:txBody>
+      </p:sp>
+      <p:sp>
+        <p:nvSpPr>
+          <p:cNvPr id="48" name="Rectangle 47"/>
+          <p:cNvSpPr/>
+          <p:nvPr/>
+        </p:nvSpPr>
+        <p:spPr>
+          <a:xfrm>
+            <a:off x="8961120" y="7955280"/>
+            <a:ext cx="5394960" cy="365760"/>
+          </a:xfrm>
+          <a:prstGeom prst="rect">
+            <a:avLst/>
+          </a:prstGeom>
+          <a:solidFill>
+            <a:srgbClr val="FFFFFF"/>
+          </a:solidFill>
+          <a:ln w="25400">
+            <a:solidFill>
+              <a:srgbClr val="27AE60"/>
+            </a:solidFill>
+          </a:ln>
+        </p:spPr>
+        <p:style>
+          <a:lnRef idx="1">
+            <a:schemeClr val="accent1"/>
+          </a:lnRef>
+          <a:fillRef idx="3">
+            <a:schemeClr val="accent1"/>
+          </a:fillRef>
+          <a:effectRef idx="2">
+            <a:schemeClr val="accent1"/>
+          </a:effectRef>
+          <a:fontRef idx="minor">
+            <a:schemeClr val="lt1"/>
+          </a:fontRef>
+        </p:style>
+        <p:txBody>
+          <a:bodyPr rtlCol="0" anchor="ctr" wrap="square" lIns="63500" rIns="50800" tIns="38100" bIns="38100"/>
+          <a:lstStyle/>
+          <a:p>
+            <a:pPr algn="l"/>
+            <a:r>
+              <a:rPr sz="900" b="1">
+                <a:solidFill>
+                  <a:srgbClr val="27AE60"/>
+                </a:solidFill>
+                <a:latin typeface="Meiryo"/>
+              </a:rPr>
+              <a:t>実行するだけ</a:t>
+            </a:r>
+          </a:p>
+        </p:txBody>
+      </p:sp>
+      <p:sp>
+        <p:nvSpPr>
+          <p:cNvPr id="49" name="Rectangle 48"/>
+          <p:cNvSpPr/>
+          <p:nvPr/>
+        </p:nvSpPr>
+        <p:spPr>
+          <a:xfrm>
+            <a:off x="731520" y="8321040"/>
+            <a:ext cx="3200400" cy="365760"/>
+          </a:xfrm>
+          <a:prstGeom prst="rect">
+            <a:avLst/>
+          </a:prstGeom>
+          <a:solidFill>
+            <a:srgbClr val="F9F9F9"/>
+          </a:solidFill>
+          <a:ln w="25400">
+            <a:solidFill>
+              <a:srgbClr val="27AE60"/>
+            </a:solidFill>
+          </a:ln>
+        </p:spPr>
+        <p:style>
+          <a:lnRef idx="1">
+            <a:schemeClr val="accent1"/>
+          </a:lnRef>
+          <a:fillRef idx="3">
+            <a:schemeClr val="accent1"/>
+          </a:fillRef>
+          <a:effectRef idx="2">
+            <a:schemeClr val="accent1"/>
+          </a:effectRef>
+          <a:fontRef idx="minor">
+            <a:schemeClr val="lt1"/>
+          </a:fontRef>
+        </p:style>
+        <p:txBody>
+          <a:bodyPr rtlCol="0" anchor="ctr" wrap="square" lIns="63500" rIns="50800" tIns="38100" bIns="38100"/>
+          <a:lstStyle/>
+          <a:p>
+            <a:pPr algn="l"/>
+            <a:r>
+              <a:rPr sz="900" b="1">
+                <a:solidFill>
+                  <a:srgbClr val="222222"/>
+                </a:solidFill>
+                <a:latin typeface="Meiryo"/>
+              </a:rPr>
+              <a:t>BizSTATION利用条件に含める</a:t>
+            </a:r>
+          </a:p>
+        </p:txBody>
+      </p:sp>
+      <p:sp>
+        <p:nvSpPr>
+          <p:cNvPr id="50" name="Rectangle 49"/>
+          <p:cNvSpPr/>
+          <p:nvPr/>
+        </p:nvSpPr>
+        <p:spPr>
+          <a:xfrm>
+            <a:off x="3931920" y="8321040"/>
+            <a:ext cx="5029200" cy="365760"/>
+          </a:xfrm>
+          <a:prstGeom prst="rect">
+            <a:avLst/>
+          </a:prstGeom>
+          <a:solidFill>
+            <a:srgbClr val="F9F9F9"/>
+          </a:solidFill>
+          <a:ln w="25400">
+            <a:solidFill>
+              <a:srgbClr val="CCCCCC"/>
+            </a:solidFill>
+          </a:ln>
+        </p:spPr>
+        <p:style>
+          <a:lnRef idx="1">
+            <a:schemeClr val="accent1"/>
+          </a:lnRef>
+          <a:fillRef idx="3">
+            <a:schemeClr val="accent1"/>
+          </a:fillRef>
+          <a:effectRef idx="2">
+            <a:schemeClr val="accent1"/>
+          </a:effectRef>
+          <a:fontRef idx="minor">
+            <a:schemeClr val="lt1"/>
+          </a:fontRef>
+        </p:style>
+        <p:txBody>
+          <a:bodyPr rtlCol="0" anchor="ctr" wrap="square" lIns="63500" rIns="50800" tIns="38100" bIns="38100"/>
+          <a:lstStyle/>
+          <a:p>
+            <a:pPr algn="l"/>
+            <a:r>
+              <a:rPr sz="900" b="0">
+                <a:solidFill>
+                  <a:srgbClr val="222222"/>
+                </a:solidFill>
+                <a:latin typeface="Meiryo"/>
+              </a:rPr>
+              <a:t>アプリ制御を契約要件にする</a:t>
+            </a:r>
+          </a:p>
+        </p:txBody>
+      </p:sp>
+      <p:sp>
+        <p:nvSpPr>
+          <p:cNvPr id="51" name="Rectangle 50"/>
+          <p:cNvSpPr/>
+          <p:nvPr/>
+        </p:nvSpPr>
+        <p:spPr>
+          <a:xfrm>
+            <a:off x="8961120" y="8321040"/>
+            <a:ext cx="5394960" cy="365760"/>
+          </a:xfrm>
+          <a:prstGeom prst="rect">
+            <a:avLst/>
+          </a:prstGeom>
+          <a:solidFill>
+            <a:srgbClr val="F9F9F9"/>
+          </a:solidFill>
+          <a:ln w="25400">
+            <a:solidFill>
+              <a:srgbClr val="27AE60"/>
+            </a:solidFill>
+          </a:ln>
+        </p:spPr>
+        <p:style>
+          <a:lnRef idx="1">
+            <a:schemeClr val="accent1"/>
+          </a:lnRef>
+          <a:fillRef idx="3">
+            <a:schemeClr val="accent1"/>
+          </a:fillRef>
+          <a:effectRef idx="2">
+            <a:schemeClr val="accent1"/>
+          </a:effectRef>
+          <a:fontRef idx="minor">
+            <a:schemeClr val="lt1"/>
+          </a:fontRef>
+        </p:style>
+        <p:txBody>
+          <a:bodyPr rtlCol="0" anchor="ctr" wrap="square" lIns="63500" rIns="50800" tIns="38100" bIns="38100"/>
+          <a:lstStyle/>
+          <a:p>
+            <a:pPr algn="l"/>
+            <a:r>
+              <a:rPr sz="900" b="1">
+                <a:solidFill>
+                  <a:srgbClr val="27AE60"/>
+                </a:solidFill>
+                <a:latin typeface="Meiryo"/>
+              </a:rPr>
+              <a:t>IT業者に設定を依頼</a:t>
+            </a:r>
+          </a:p>
+        </p:txBody>
+      </p:sp>
+      <p:sp>
+        <p:nvSpPr>
+          <p:cNvPr id="52" name="TextBox 51"/>
+          <p:cNvSpPr txBox="1"/>
+          <p:nvPr/>
+        </p:nvSpPr>
+        <p:spPr>
+          <a:xfrm>
+            <a:off x="9144000" y="10378440"/>
+            <a:ext cx="5943600" cy="228600"/>
+          </a:xfrm>
+          <a:prstGeom prst="rect">
+            <a:avLst/>
+          </a:prstGeom>
+          <a:noFill/>
+        </p:spPr>
+        <p:txBody>
+          <a:bodyPr wrap="square" lIns="50800" rIns="50800" tIns="38100" bIns="38100"/>
+          <a:lstStyle/>
+          <a:p>
+            <a:pPr algn="r"/>
+            <a:r>
+              <a:rPr sz="700" b="0">
+                <a:solidFill>
+                  <a:srgbClr val="888888"/>
+                </a:solidFill>
+                <a:latin typeface="Meiryo"/>
+              </a:rPr>
+              <a:t>Fraud Kill Chain — 責任の所在</a:t>
             </a:r>
           </a:p>
         </p:txBody>

</xml_diff>

<commit_message>
Add slides 13-14: red screen PC lockout and dual-device attack
Slide 13: Red screen serves three roles — seals PC, hides attacker
ops, keeps victim waiting. Detectable by EDR/NW but same pattern:
SMBs don't have it.

Slide 14: Dual-device attack harvests all 5 auth factors in one
screen (impossible in legit BizSTATION). OTP timing exploited via
real-time phone coordination. Personal phones evade corporate security.

https://claude.ai/code/session_01F7t8LKifK43o6sCdF2a3gQ
</commit_message>
<xml_diff>
--- a/Fraud_Kill_Chain.pptx
+++ b/Fraud_Kill_Chain.pptx
@@ -17,6 +17,8 @@
     <p:sldId id="265" r:id="rId16"/>
     <p:sldId id="266" r:id="rId17"/>
     <p:sldId id="267" r:id="rId18"/>
+    <p:sldId id="268" r:id="rId19"/>
+    <p:sldId id="269" r:id="rId20"/>
   </p:sldIdLst>
   <p:sldSz cx="15124176" cy="10689336" type="screen4x3"/>
   <p:notesSz cx="6858000" cy="9144000"/>
@@ -15455,6 +15457,2279 @@
                 <a:latin typeface="Meiryo"/>
               </a:rPr>
               <a:t>Fraud Kill Chain — 責任の所在</a:t>
+            </a:r>
+          </a:p>
+        </p:txBody>
+      </p:sp>
+    </p:spTree>
+  </p:cSld>
+  <p:clrMapOvr>
+    <a:masterClrMapping/>
+  </p:clrMapOvr>
+</p:sld>
+</file>
+
+<file path=ppt/slides/slide13.xml><?xml version="1.0" encoding="utf-8"?>
+<p:sld xmlns:a="http://schemas.openxmlformats.org/drawingml/2006/main" xmlns:p="http://schemas.openxmlformats.org/presentationml/2006/main" xmlns:r="http://schemas.openxmlformats.org/officeDocument/2006/relationships">
+  <p:cSld>
+    <p:bg>
+      <p:bgPr>
+        <a:solidFill>
+          <a:srgbClr val="F5F5F5"/>
+        </a:solidFill>
+        <a:effectLst/>
+      </p:bgPr>
+    </p:bg>
+    <p:spTree>
+      <p:nvGrpSpPr>
+        <p:cNvPr id="1" name=""/>
+        <p:cNvGrpSpPr/>
+        <p:nvPr/>
+      </p:nvGrpSpPr>
+      <p:grpSpPr/>
+      <p:sp>
+        <p:nvSpPr>
+          <p:cNvPr id="2" name="TextBox 1"/>
+          <p:cNvSpPr txBox="1"/>
+          <p:nvPr/>
+        </p:nvSpPr>
+        <p:spPr>
+          <a:xfrm>
+            <a:off x="0" y="182880"/>
+            <a:ext cx="15124176" cy="548640"/>
+          </a:xfrm>
+          <a:prstGeom prst="rect">
+            <a:avLst/>
+          </a:prstGeom>
+          <a:noFill/>
+        </p:spPr>
+        <p:txBody>
+          <a:bodyPr wrap="square" lIns="50800" rIns="50800" tIns="38100" bIns="38100"/>
+          <a:lstStyle/>
+          <a:p>
+            <a:pPr algn="ctr"/>
+            <a:r>
+              <a:rPr sz="2200" b="1">
+                <a:solidFill>
+                  <a:srgbClr val="C0392B"/>
+                </a:solidFill>
+                <a:latin typeface="Meiryo"/>
+              </a:rPr>
+              <a:t>手順⑦ 赤い画面 — PCを封印し、犯人の操作を隠す</a:t>
+            </a:r>
+          </a:p>
+        </p:txBody>
+      </p:sp>
+      <p:sp>
+        <p:nvSpPr>
+          <p:cNvPr id="3" name="Rectangle 2"/>
+          <p:cNvSpPr/>
+          <p:nvPr/>
+        </p:nvSpPr>
+        <p:spPr>
+          <a:xfrm>
+            <a:off x="731520" y="777240"/>
+            <a:ext cx="13624560" cy="1005840"/>
+          </a:xfrm>
+          <a:prstGeom prst="rect">
+            <a:avLst/>
+          </a:prstGeom>
+          <a:solidFill>
+            <a:srgbClr val="C0392B"/>
+          </a:solidFill>
+          <a:ln>
+            <a:noFill/>
+          </a:ln>
+        </p:spPr>
+        <p:style>
+          <a:lnRef idx="1">
+            <a:schemeClr val="accent1"/>
+          </a:lnRef>
+          <a:fillRef idx="3">
+            <a:schemeClr val="accent1"/>
+          </a:fillRef>
+          <a:effectRef idx="2">
+            <a:schemeClr val="accent1"/>
+          </a:effectRef>
+          <a:fontRef idx="minor">
+            <a:schemeClr val="lt1"/>
+          </a:fontRef>
+        </p:style>
+        <p:txBody>
+          <a:bodyPr rtlCol="0" anchor="ctr" wrap="square" lIns="50800" rIns="50800" tIns="25400" bIns="25400"/>
+          <a:lstStyle/>
+          <a:p>
+            <a:pPr algn="ctr"/>
+            <a:r>
+              <a:rPr sz="100" b="1">
+                <a:solidFill>
+                  <a:srgbClr val="FFFFFF"/>
+                </a:solidFill>
+                <a:latin typeface="Meiryo"/>
+              </a:rPr>
+              <a:t/>
+            </a:r>
+          </a:p>
+        </p:txBody>
+      </p:sp>
+      <p:sp>
+        <p:nvSpPr>
+          <p:cNvPr id="4" name="TextBox 3"/>
+          <p:cNvSpPr txBox="1"/>
+          <p:nvPr/>
+        </p:nvSpPr>
+        <p:spPr>
+          <a:xfrm>
+            <a:off x="1188720" y="868680"/>
+            <a:ext cx="12710160" cy="868680"/>
+          </a:xfrm>
+          <a:prstGeom prst="rect">
+            <a:avLst/>
+          </a:prstGeom>
+          <a:noFill/>
+        </p:spPr>
+        <p:txBody>
+          <a:bodyPr wrap="square" lIns="50800" rIns="50800" tIns="38100" bIns="38100"/>
+          <a:lstStyle/>
+          <a:p>
+            <a:pPr algn="l"/>
+            <a:r>
+              <a:rPr sz="1100" b="1">
+                <a:solidFill>
+                  <a:srgbClr val="FFFFFF"/>
+                </a:solidFill>
+                <a:latin typeface="Meiryo"/>
+              </a:rPr>
+              <a:t>『Mバンく　現在セキュリティ保護強化に伴うシステム更新ならびに、お客さま情報の確認、更新処理を実施しております。処理完了までの間一時的に画面が遅延または停止する場合がありますが、正常な処理となりますのでそのままお待ちくださいますようお願い申し上げます。』</a:t>
+            </a:r>
+          </a:p>
+        </p:txBody>
+      </p:sp>
+      <p:sp>
+        <p:nvSpPr>
+          <p:cNvPr id="5" name="Rectangle 4"/>
+          <p:cNvSpPr/>
+          <p:nvPr/>
+        </p:nvSpPr>
+        <p:spPr>
+          <a:xfrm>
+            <a:off x="731520" y="1920240"/>
+            <a:ext cx="13624560" cy="365760"/>
+          </a:xfrm>
+          <a:prstGeom prst="rect">
+            <a:avLst/>
+          </a:prstGeom>
+          <a:solidFill>
+            <a:srgbClr val="222222"/>
+          </a:solidFill>
+          <a:ln>
+            <a:noFill/>
+          </a:ln>
+        </p:spPr>
+        <p:style>
+          <a:lnRef idx="1">
+            <a:schemeClr val="accent1"/>
+          </a:lnRef>
+          <a:fillRef idx="3">
+            <a:schemeClr val="accent1"/>
+          </a:fillRef>
+          <a:effectRef idx="2">
+            <a:schemeClr val="accent1"/>
+          </a:effectRef>
+          <a:fontRef idx="minor">
+            <a:schemeClr val="lt1"/>
+          </a:fontRef>
+        </p:style>
+        <p:txBody>
+          <a:bodyPr rtlCol="0" anchor="ctr" wrap="square" lIns="50800" rIns="50800" tIns="25400" bIns="25400"/>
+          <a:lstStyle/>
+          <a:p>
+            <a:pPr algn="ctr"/>
+            <a:r>
+              <a:rPr sz="1200" b="1">
+                <a:solidFill>
+                  <a:srgbClr val="FFFFFF"/>
+                </a:solidFill>
+                <a:latin typeface="Meiryo"/>
+              </a:rPr>
+              <a:t>赤い画面の3つの役割</a:t>
+            </a:r>
+          </a:p>
+        </p:txBody>
+      </p:sp>
+      <p:sp>
+        <p:nvSpPr>
+          <p:cNvPr id="6" name="Rectangle 5"/>
+          <p:cNvSpPr/>
+          <p:nvPr/>
+        </p:nvSpPr>
+        <p:spPr>
+          <a:xfrm>
+            <a:off x="731520" y="2286000"/>
+            <a:ext cx="3657600" cy="502920"/>
+          </a:xfrm>
+          <a:prstGeom prst="rect">
+            <a:avLst/>
+          </a:prstGeom>
+          <a:solidFill>
+            <a:srgbClr val="C0392B"/>
+          </a:solidFill>
+          <a:ln>
+            <a:noFill/>
+          </a:ln>
+        </p:spPr>
+        <p:style>
+          <a:lnRef idx="1">
+            <a:schemeClr val="accent1"/>
+          </a:lnRef>
+          <a:fillRef idx="3">
+            <a:schemeClr val="accent1"/>
+          </a:fillRef>
+          <a:effectRef idx="2">
+            <a:schemeClr val="accent1"/>
+          </a:effectRef>
+          <a:fontRef idx="minor">
+            <a:schemeClr val="lt1"/>
+          </a:fontRef>
+        </p:style>
+        <p:txBody>
+          <a:bodyPr rtlCol="0" anchor="ctr" wrap="square" lIns="50800" rIns="50800" tIns="25400" bIns="25400"/>
+          <a:lstStyle/>
+          <a:p>
+            <a:pPr algn="ctr"/>
+            <a:r>
+              <a:rPr sz="1000" b="1">
+                <a:solidFill>
+                  <a:srgbClr val="FFFFFF"/>
+                </a:solidFill>
+                <a:latin typeface="Meiryo"/>
+              </a:rPr>
+              <a:t>① PCを「封印」する</a:t>
+            </a:r>
+          </a:p>
+        </p:txBody>
+      </p:sp>
+      <p:sp>
+        <p:nvSpPr>
+          <p:cNvPr id="7" name="Rectangle 6"/>
+          <p:cNvSpPr/>
+          <p:nvPr/>
+        </p:nvSpPr>
+        <p:spPr>
+          <a:xfrm>
+            <a:off x="4389120" y="2286000"/>
+            <a:ext cx="9966960" cy="502920"/>
+          </a:xfrm>
+          <a:prstGeom prst="rect">
+            <a:avLst/>
+          </a:prstGeom>
+          <a:solidFill>
+            <a:srgbClr val="FFFFFF"/>
+          </a:solidFill>
+          <a:ln w="25400">
+            <a:solidFill>
+              <a:srgbClr val="C0392B"/>
+            </a:solidFill>
+          </a:ln>
+        </p:spPr>
+        <p:style>
+          <a:lnRef idx="1">
+            <a:schemeClr val="accent1"/>
+          </a:lnRef>
+          <a:fillRef idx="3">
+            <a:schemeClr val="accent1"/>
+          </a:fillRef>
+          <a:effectRef idx="2">
+            <a:schemeClr val="accent1"/>
+          </a:effectRef>
+          <a:fontRef idx="minor">
+            <a:schemeClr val="lt1"/>
+          </a:fontRef>
+        </p:style>
+        <p:txBody>
+          <a:bodyPr rtlCol="0" anchor="ctr" wrap="square" lIns="63500" rIns="50800" tIns="38100" bIns="38100"/>
+          <a:lstStyle/>
+          <a:p>
+            <a:pPr algn="l"/>
+            <a:r>
+              <a:rPr sz="1000" b="0">
+                <a:solidFill>
+                  <a:srgbClr val="222222"/>
+                </a:solidFill>
+                <a:latin typeface="Meiryo"/>
+              </a:rPr>
+              <a:t>被害者はPCを操作できない。BizSTATIONで自分で確認することも不可能。</a:t>
+            </a:r>
+          </a:p>
+        </p:txBody>
+      </p:sp>
+      <p:sp>
+        <p:nvSpPr>
+          <p:cNvPr id="8" name="Rectangle 7"/>
+          <p:cNvSpPr/>
+          <p:nvPr/>
+        </p:nvSpPr>
+        <p:spPr>
+          <a:xfrm>
+            <a:off x="731520" y="2788920"/>
+            <a:ext cx="3657600" cy="502920"/>
+          </a:xfrm>
+          <a:prstGeom prst="rect">
+            <a:avLst/>
+          </a:prstGeom>
+          <a:solidFill>
+            <a:srgbClr val="222222"/>
+          </a:solidFill>
+          <a:ln>
+            <a:noFill/>
+          </a:ln>
+        </p:spPr>
+        <p:style>
+          <a:lnRef idx="1">
+            <a:schemeClr val="accent1"/>
+          </a:lnRef>
+          <a:fillRef idx="3">
+            <a:schemeClr val="accent1"/>
+          </a:fillRef>
+          <a:effectRef idx="2">
+            <a:schemeClr val="accent1"/>
+          </a:effectRef>
+          <a:fontRef idx="minor">
+            <a:schemeClr val="lt1"/>
+          </a:fontRef>
+        </p:style>
+        <p:txBody>
+          <a:bodyPr rtlCol="0" anchor="ctr" wrap="square" lIns="50800" rIns="50800" tIns="25400" bIns="25400"/>
+          <a:lstStyle/>
+          <a:p>
+            <a:pPr algn="ctr"/>
+            <a:r>
+              <a:rPr sz="1000" b="1">
+                <a:solidFill>
+                  <a:srgbClr val="FFFFFF"/>
+                </a:solidFill>
+                <a:latin typeface="Meiryo"/>
+              </a:rPr>
+              <a:t>② 犯人の操作を隠す</a:t>
+            </a:r>
+          </a:p>
+        </p:txBody>
+      </p:sp>
+      <p:sp>
+        <p:nvSpPr>
+          <p:cNvPr id="9" name="Rectangle 8"/>
+          <p:cNvSpPr/>
+          <p:nvPr/>
+        </p:nvSpPr>
+        <p:spPr>
+          <a:xfrm>
+            <a:off x="4389120" y="2788920"/>
+            <a:ext cx="9966960" cy="502920"/>
+          </a:xfrm>
+          <a:prstGeom prst="rect">
+            <a:avLst/>
+          </a:prstGeom>
+          <a:solidFill>
+            <a:srgbClr val="FFFFFF"/>
+          </a:solidFill>
+          <a:ln w="25400">
+            <a:solidFill>
+              <a:srgbClr val="222222"/>
+            </a:solidFill>
+          </a:ln>
+        </p:spPr>
+        <p:style>
+          <a:lnRef idx="1">
+            <a:schemeClr val="accent1"/>
+          </a:lnRef>
+          <a:fillRef idx="3">
+            <a:schemeClr val="accent1"/>
+          </a:fillRef>
+          <a:effectRef idx="2">
+            <a:schemeClr val="accent1"/>
+          </a:effectRef>
+          <a:fontRef idx="minor">
+            <a:schemeClr val="lt1"/>
+          </a:fontRef>
+        </p:style>
+        <p:txBody>
+          <a:bodyPr rtlCol="0" anchor="ctr" wrap="square" lIns="63500" rIns="50800" tIns="38100" bIns="38100"/>
+          <a:lstStyle/>
+          <a:p>
+            <a:pPr algn="l"/>
+            <a:r>
+              <a:rPr sz="1000" b="0">
+                <a:solidFill>
+                  <a:srgbClr val="222222"/>
+                </a:solidFill>
+                <a:latin typeface="Meiryo"/>
+              </a:rPr>
+              <a:t>赤い画面の裏でScreenConnect経由のPC操作が進行。被害者には見えない。</a:t>
+            </a:r>
+          </a:p>
+        </p:txBody>
+      </p:sp>
+      <p:sp>
+        <p:nvSpPr>
+          <p:cNvPr id="10" name="Rectangle 9"/>
+          <p:cNvSpPr/>
+          <p:nvPr/>
+        </p:nvSpPr>
+        <p:spPr>
+          <a:xfrm>
+            <a:off x="731520" y="3291840"/>
+            <a:ext cx="3657600" cy="502920"/>
+          </a:xfrm>
+          <a:prstGeom prst="rect">
+            <a:avLst/>
+          </a:prstGeom>
+          <a:solidFill>
+            <a:srgbClr val="E67E22"/>
+          </a:solidFill>
+          <a:ln>
+            <a:noFill/>
+          </a:ln>
+        </p:spPr>
+        <p:style>
+          <a:lnRef idx="1">
+            <a:schemeClr val="accent1"/>
+          </a:lnRef>
+          <a:fillRef idx="3">
+            <a:schemeClr val="accent1"/>
+          </a:fillRef>
+          <a:effectRef idx="2">
+            <a:schemeClr val="accent1"/>
+          </a:effectRef>
+          <a:fontRef idx="minor">
+            <a:schemeClr val="lt1"/>
+          </a:fontRef>
+        </p:style>
+        <p:txBody>
+          <a:bodyPr rtlCol="0" anchor="ctr" wrap="square" lIns="50800" rIns="50800" tIns="25400" bIns="25400"/>
+          <a:lstStyle/>
+          <a:p>
+            <a:pPr algn="ctr"/>
+            <a:r>
+              <a:rPr sz="1000" b="1">
+                <a:solidFill>
+                  <a:srgbClr val="FFFFFF"/>
+                </a:solidFill>
+                <a:latin typeface="Meiryo"/>
+              </a:rPr>
+              <a:t>③ 被害者を「待機」させる</a:t>
+            </a:r>
+          </a:p>
+        </p:txBody>
+      </p:sp>
+      <p:sp>
+        <p:nvSpPr>
+          <p:cNvPr id="11" name="Rectangle 10"/>
+          <p:cNvSpPr/>
+          <p:nvPr/>
+        </p:nvSpPr>
+        <p:spPr>
+          <a:xfrm>
+            <a:off x="4389120" y="3291840"/>
+            <a:ext cx="9966960" cy="502920"/>
+          </a:xfrm>
+          <a:prstGeom prst="rect">
+            <a:avLst/>
+          </a:prstGeom>
+          <a:solidFill>
+            <a:srgbClr val="FFFFFF"/>
+          </a:solidFill>
+          <a:ln w="25400">
+            <a:solidFill>
+              <a:srgbClr val="E67E22"/>
+            </a:solidFill>
+          </a:ln>
+        </p:spPr>
+        <p:style>
+          <a:lnRef idx="1">
+            <a:schemeClr val="accent1"/>
+          </a:lnRef>
+          <a:fillRef idx="3">
+            <a:schemeClr val="accent1"/>
+          </a:fillRef>
+          <a:effectRef idx="2">
+            <a:schemeClr val="accent1"/>
+          </a:effectRef>
+          <a:fontRef idx="minor">
+            <a:schemeClr val="lt1"/>
+          </a:fontRef>
+        </p:style>
+        <p:txBody>
+          <a:bodyPr rtlCol="0" anchor="ctr" wrap="square" lIns="63500" rIns="50800" tIns="38100" bIns="38100"/>
+          <a:lstStyle/>
+          <a:p>
+            <a:pPr algn="l"/>
+            <a:r>
+              <a:rPr sz="1000" b="0">
+                <a:solidFill>
+                  <a:srgbClr val="222222"/>
+                </a:solidFill>
+                <a:latin typeface="Meiryo"/>
+              </a:rPr>
+              <a:t>「処理完了までお待ちください」→ 異常を見ても「正常」と信じて待つ。</a:t>
+            </a:r>
+          </a:p>
+        </p:txBody>
+      </p:sp>
+      <p:sp>
+        <p:nvSpPr>
+          <p:cNvPr id="12" name="Rectangle 11"/>
+          <p:cNvSpPr/>
+          <p:nvPr/>
+        </p:nvSpPr>
+        <p:spPr>
+          <a:xfrm>
+            <a:off x="731520" y="3886200"/>
+            <a:ext cx="13624560" cy="411480"/>
+          </a:xfrm>
+          <a:prstGeom prst="rect">
+            <a:avLst/>
+          </a:prstGeom>
+          <a:solidFill>
+            <a:srgbClr val="C0392B"/>
+          </a:solidFill>
+          <a:ln>
+            <a:noFill/>
+          </a:ln>
+        </p:spPr>
+        <p:style>
+          <a:lnRef idx="1">
+            <a:schemeClr val="accent1"/>
+          </a:lnRef>
+          <a:fillRef idx="3">
+            <a:schemeClr val="accent1"/>
+          </a:fillRef>
+          <a:effectRef idx="2">
+            <a:schemeClr val="accent1"/>
+          </a:effectRef>
+          <a:fontRef idx="minor">
+            <a:schemeClr val="lt1"/>
+          </a:fontRef>
+        </p:style>
+        <p:txBody>
+          <a:bodyPr rtlCol="0" anchor="ctr" wrap="square" lIns="50800" rIns="50800" tIns="25400" bIns="25400"/>
+          <a:lstStyle/>
+          <a:p>
+            <a:pPr algn="ctr"/>
+            <a:r>
+              <a:rPr sz="1200" b="1">
+                <a:solidFill>
+                  <a:srgbClr val="FFFFFF"/>
+                </a:solidFill>
+                <a:latin typeface="Meiryo"/>
+              </a:rPr>
+              <a:t>⚠ 破綻ポイント：銀行のシステム更新で顧客PCの画面が赤くなることはありえない</a:t>
+            </a:r>
+          </a:p>
+        </p:txBody>
+      </p:sp>
+      <p:sp>
+        <p:nvSpPr>
+          <p:cNvPr id="13" name="TextBox 12"/>
+          <p:cNvSpPr txBox="1"/>
+          <p:nvPr/>
+        </p:nvSpPr>
+        <p:spPr>
+          <a:xfrm>
+            <a:off x="731520" y="4325112"/>
+            <a:ext cx="13624560" cy="274320"/>
+          </a:xfrm>
+          <a:prstGeom prst="rect">
+            <a:avLst/>
+          </a:prstGeom>
+          <a:noFill/>
+        </p:spPr>
+        <p:txBody>
+          <a:bodyPr wrap="square" lIns="50800" rIns="50800" tIns="38100" bIns="38100"/>
+          <a:lstStyle/>
+          <a:p>
+            <a:pPr algn="l"/>
+            <a:r>
+              <a:rPr sz="900" b="0">
+                <a:solidFill>
+                  <a:srgbClr val="888888"/>
+                </a:solidFill>
+                <a:latin typeface="Meiryo"/>
+              </a:rPr>
+              <a:t>IBのシステム更新はサーバー側の処理。顧客PCの画面が止まるわけがない。→ 手順②からの信頼の蓄積で気づけない。</a:t>
+            </a:r>
+          </a:p>
+        </p:txBody>
+      </p:sp>
+      <p:sp>
+        <p:nvSpPr>
+          <p:cNvPr id="14" name="Rectangle 13"/>
+          <p:cNvSpPr/>
+          <p:nvPr/>
+        </p:nvSpPr>
+        <p:spPr>
+          <a:xfrm>
+            <a:off x="731520" y="4709160"/>
+            <a:ext cx="13624560" cy="365760"/>
+          </a:xfrm>
+          <a:prstGeom prst="rect">
+            <a:avLst/>
+          </a:prstGeom>
+          <a:solidFill>
+            <a:srgbClr val="27AE60"/>
+          </a:solidFill>
+          <a:ln>
+            <a:noFill/>
+          </a:ln>
+        </p:spPr>
+        <p:style>
+          <a:lnRef idx="1">
+            <a:schemeClr val="accent1"/>
+          </a:lnRef>
+          <a:fillRef idx="3">
+            <a:schemeClr val="accent1"/>
+          </a:fillRef>
+          <a:effectRef idx="2">
+            <a:schemeClr val="accent1"/>
+          </a:effectRef>
+          <a:fontRef idx="minor">
+            <a:schemeClr val="lt1"/>
+          </a:fontRef>
+        </p:style>
+        <p:txBody>
+          <a:bodyPr rtlCol="0" anchor="ctr" wrap="square" lIns="50800" rIns="50800" tIns="25400" bIns="25400"/>
+          <a:lstStyle/>
+          <a:p>
+            <a:pPr algn="ctr"/>
+            <a:r>
+              <a:rPr sz="1200" b="1">
+                <a:solidFill>
+                  <a:srgbClr val="FFFFFF"/>
+                </a:solidFill>
+                <a:latin typeface="Meiryo"/>
+              </a:rPr>
+              <a:t>企業側で検知できるポイント</a:t>
+            </a:r>
+          </a:p>
+        </p:txBody>
+      </p:sp>
+      <p:sp>
+        <p:nvSpPr>
+          <p:cNvPr id="15" name="Rectangle 14"/>
+          <p:cNvSpPr/>
+          <p:nvPr/>
+        </p:nvSpPr>
+        <p:spPr>
+          <a:xfrm>
+            <a:off x="731520" y="5074920"/>
+            <a:ext cx="6858000" cy="347472"/>
+          </a:xfrm>
+          <a:prstGeom prst="rect">
+            <a:avLst/>
+          </a:prstGeom>
+          <a:solidFill>
+            <a:srgbClr val="FFFFFF"/>
+          </a:solidFill>
+          <a:ln w="25400">
+            <a:solidFill>
+              <a:srgbClr val="27AE60"/>
+            </a:solidFill>
+          </a:ln>
+        </p:spPr>
+        <p:style>
+          <a:lnRef idx="1">
+            <a:schemeClr val="accent1"/>
+          </a:lnRef>
+          <a:fillRef idx="3">
+            <a:schemeClr val="accent1"/>
+          </a:fillRef>
+          <a:effectRef idx="2">
+            <a:schemeClr val="accent1"/>
+          </a:effectRef>
+          <a:fontRef idx="minor">
+            <a:schemeClr val="lt1"/>
+          </a:fontRef>
+        </p:style>
+        <p:txBody>
+          <a:bodyPr rtlCol="0" anchor="ctr" wrap="square" lIns="63500" rIns="50800" tIns="38100" bIns="38100"/>
+          <a:lstStyle/>
+          <a:p>
+            <a:pPr algn="l"/>
+            <a:r>
+              <a:rPr sz="900" b="1">
+                <a:solidFill>
+                  <a:srgbClr val="222222"/>
+                </a:solidFill>
+                <a:latin typeface="Meiryo"/>
+              </a:rPr>
+              <a:t>ScreenConnectのプロセス検知</a:t>
+            </a:r>
+          </a:p>
+        </p:txBody>
+      </p:sp>
+      <p:sp>
+        <p:nvSpPr>
+          <p:cNvPr id="16" name="Rectangle 15"/>
+          <p:cNvSpPr/>
+          <p:nvPr/>
+        </p:nvSpPr>
+        <p:spPr>
+          <a:xfrm>
+            <a:off x="7589520" y="5074920"/>
+            <a:ext cx="6766560" cy="347472"/>
+          </a:xfrm>
+          <a:prstGeom prst="rect">
+            <a:avLst/>
+          </a:prstGeom>
+          <a:solidFill>
+            <a:srgbClr val="FFFFFF"/>
+          </a:solidFill>
+          <a:ln w="25400">
+            <a:solidFill>
+              <a:srgbClr val="CCCCCC"/>
+            </a:solidFill>
+          </a:ln>
+        </p:spPr>
+        <p:style>
+          <a:lnRef idx="1">
+            <a:schemeClr val="accent1"/>
+          </a:lnRef>
+          <a:fillRef idx="3">
+            <a:schemeClr val="accent1"/>
+          </a:fillRef>
+          <a:effectRef idx="2">
+            <a:schemeClr val="accent1"/>
+          </a:effectRef>
+          <a:fontRef idx="minor">
+            <a:schemeClr val="lt1"/>
+          </a:fontRef>
+        </p:style>
+        <p:txBody>
+          <a:bodyPr rtlCol="0" anchor="ctr" wrap="square" lIns="63500" rIns="50800" tIns="38100" bIns="38100"/>
+          <a:lstStyle/>
+          <a:p>
+            <a:pPr algn="l"/>
+            <a:r>
+              <a:rPr sz="900" b="0">
+                <a:solidFill>
+                  <a:srgbClr val="222222"/>
+                </a:solidFill>
+                <a:latin typeface="Meiryo"/>
+              </a:rPr>
+              <a:t>EDRで検知可能</a:t>
+            </a:r>
+          </a:p>
+        </p:txBody>
+      </p:sp>
+      <p:sp>
+        <p:nvSpPr>
+          <p:cNvPr id="17" name="Rectangle 16"/>
+          <p:cNvSpPr/>
+          <p:nvPr/>
+        </p:nvSpPr>
+        <p:spPr>
+          <a:xfrm>
+            <a:off x="731520" y="5422392"/>
+            <a:ext cx="6858000" cy="347472"/>
+          </a:xfrm>
+          <a:prstGeom prst="rect">
+            <a:avLst/>
+          </a:prstGeom>
+          <a:solidFill>
+            <a:srgbClr val="F9F9F9"/>
+          </a:solidFill>
+          <a:ln w="25400">
+            <a:solidFill>
+              <a:srgbClr val="27AE60"/>
+            </a:solidFill>
+          </a:ln>
+        </p:spPr>
+        <p:style>
+          <a:lnRef idx="1">
+            <a:schemeClr val="accent1"/>
+          </a:lnRef>
+          <a:fillRef idx="3">
+            <a:schemeClr val="accent1"/>
+          </a:fillRef>
+          <a:effectRef idx="2">
+            <a:schemeClr val="accent1"/>
+          </a:effectRef>
+          <a:fontRef idx="minor">
+            <a:schemeClr val="lt1"/>
+          </a:fontRef>
+        </p:style>
+        <p:txBody>
+          <a:bodyPr rtlCol="0" anchor="ctr" wrap="square" lIns="63500" rIns="50800" tIns="38100" bIns="38100"/>
+          <a:lstStyle/>
+          <a:p>
+            <a:pPr algn="l"/>
+            <a:r>
+              <a:rPr sz="900" b="1">
+                <a:solidFill>
+                  <a:srgbClr val="222222"/>
+                </a:solidFill>
+                <a:latin typeface="Meiryo"/>
+              </a:rPr>
+              <a:t>C2サーバへの不審な通信</a:t>
+            </a:r>
+          </a:p>
+        </p:txBody>
+      </p:sp>
+      <p:sp>
+        <p:nvSpPr>
+          <p:cNvPr id="18" name="Rectangle 17"/>
+          <p:cNvSpPr/>
+          <p:nvPr/>
+        </p:nvSpPr>
+        <p:spPr>
+          <a:xfrm>
+            <a:off x="7589520" y="5422392"/>
+            <a:ext cx="6766560" cy="347472"/>
+          </a:xfrm>
+          <a:prstGeom prst="rect">
+            <a:avLst/>
+          </a:prstGeom>
+          <a:solidFill>
+            <a:srgbClr val="F9F9F9"/>
+          </a:solidFill>
+          <a:ln w="25400">
+            <a:solidFill>
+              <a:srgbClr val="CCCCCC"/>
+            </a:solidFill>
+          </a:ln>
+        </p:spPr>
+        <p:style>
+          <a:lnRef idx="1">
+            <a:schemeClr val="accent1"/>
+          </a:lnRef>
+          <a:fillRef idx="3">
+            <a:schemeClr val="accent1"/>
+          </a:fillRef>
+          <a:effectRef idx="2">
+            <a:schemeClr val="accent1"/>
+          </a:effectRef>
+          <a:fontRef idx="minor">
+            <a:schemeClr val="lt1"/>
+          </a:fontRef>
+        </p:style>
+        <p:txBody>
+          <a:bodyPr rtlCol="0" anchor="ctr" wrap="square" lIns="63500" rIns="50800" tIns="38100" bIns="38100"/>
+          <a:lstStyle/>
+          <a:p>
+            <a:pPr algn="l"/>
+            <a:r>
+              <a:rPr sz="900" b="0">
+                <a:solidFill>
+                  <a:srgbClr val="222222"/>
+                </a:solidFill>
+                <a:latin typeface="Meiryo"/>
+              </a:rPr>
+              <a:t>NW監視/プロキシで検知可能</a:t>
+            </a:r>
+          </a:p>
+        </p:txBody>
+      </p:sp>
+      <p:sp>
+        <p:nvSpPr>
+          <p:cNvPr id="19" name="Rectangle 18"/>
+          <p:cNvSpPr/>
+          <p:nvPr/>
+        </p:nvSpPr>
+        <p:spPr>
+          <a:xfrm>
+            <a:off x="731520" y="5769864"/>
+            <a:ext cx="6858000" cy="347472"/>
+          </a:xfrm>
+          <a:prstGeom prst="rect">
+            <a:avLst/>
+          </a:prstGeom>
+          <a:solidFill>
+            <a:srgbClr val="FFFFFF"/>
+          </a:solidFill>
+          <a:ln w="25400">
+            <a:solidFill>
+              <a:srgbClr val="27AE60"/>
+            </a:solidFill>
+          </a:ln>
+        </p:spPr>
+        <p:style>
+          <a:lnRef idx="1">
+            <a:schemeClr val="accent1"/>
+          </a:lnRef>
+          <a:fillRef idx="3">
+            <a:schemeClr val="accent1"/>
+          </a:fillRef>
+          <a:effectRef idx="2">
+            <a:schemeClr val="accent1"/>
+          </a:effectRef>
+          <a:fontRef idx="minor">
+            <a:schemeClr val="lt1"/>
+          </a:fontRef>
+        </p:style>
+        <p:txBody>
+          <a:bodyPr rtlCol="0" anchor="ctr" wrap="square" lIns="63500" rIns="50800" tIns="38100" bIns="38100"/>
+          <a:lstStyle/>
+          <a:p>
+            <a:pPr algn="l"/>
+            <a:r>
+              <a:rPr sz="900" b="1">
+                <a:solidFill>
+                  <a:srgbClr val="222222"/>
+                </a:solidFill>
+                <a:latin typeface="Meiryo"/>
+              </a:rPr>
+              <a:t>リモートデスクトップ系の異常セッション</a:t>
+            </a:r>
+          </a:p>
+        </p:txBody>
+      </p:sp>
+      <p:sp>
+        <p:nvSpPr>
+          <p:cNvPr id="20" name="Rectangle 19"/>
+          <p:cNvSpPr/>
+          <p:nvPr/>
+        </p:nvSpPr>
+        <p:spPr>
+          <a:xfrm>
+            <a:off x="7589520" y="5769864"/>
+            <a:ext cx="6766560" cy="347472"/>
+          </a:xfrm>
+          <a:prstGeom prst="rect">
+            <a:avLst/>
+          </a:prstGeom>
+          <a:solidFill>
+            <a:srgbClr val="FFFFFF"/>
+          </a:solidFill>
+          <a:ln w="25400">
+            <a:solidFill>
+              <a:srgbClr val="CCCCCC"/>
+            </a:solidFill>
+          </a:ln>
+        </p:spPr>
+        <p:style>
+          <a:lnRef idx="1">
+            <a:schemeClr val="accent1"/>
+          </a:lnRef>
+          <a:fillRef idx="3">
+            <a:schemeClr val="accent1"/>
+          </a:fillRef>
+          <a:effectRef idx="2">
+            <a:schemeClr val="accent1"/>
+          </a:effectRef>
+          <a:fontRef idx="minor">
+            <a:schemeClr val="lt1"/>
+          </a:fontRef>
+        </p:style>
+        <p:txBody>
+          <a:bodyPr rtlCol="0" anchor="ctr" wrap="square" lIns="63500" rIns="50800" tIns="38100" bIns="38100"/>
+          <a:lstStyle/>
+          <a:p>
+            <a:pPr algn="l"/>
+            <a:r>
+              <a:rPr sz="900" b="0">
+                <a:solidFill>
+                  <a:srgbClr val="222222"/>
+                </a:solidFill>
+                <a:latin typeface="Meiryo"/>
+              </a:rPr>
+              <a:t>SIEMで検知可能</a:t>
+            </a:r>
+          </a:p>
+        </p:txBody>
+      </p:sp>
+      <p:sp>
+        <p:nvSpPr>
+          <p:cNvPr id="21" name="Rectangle 20"/>
+          <p:cNvSpPr/>
+          <p:nvPr/>
+        </p:nvSpPr>
+        <p:spPr>
+          <a:xfrm>
+            <a:off x="731520" y="6172200"/>
+            <a:ext cx="13624560" cy="457200"/>
+          </a:xfrm>
+          <a:prstGeom prst="rect">
+            <a:avLst/>
+          </a:prstGeom>
+          <a:solidFill>
+            <a:srgbClr val="222222"/>
+          </a:solidFill>
+          <a:ln>
+            <a:noFill/>
+          </a:ln>
+        </p:spPr>
+        <p:style>
+          <a:lnRef idx="1">
+            <a:schemeClr val="accent1"/>
+          </a:lnRef>
+          <a:fillRef idx="3">
+            <a:schemeClr val="accent1"/>
+          </a:fillRef>
+          <a:effectRef idx="2">
+            <a:schemeClr val="accent1"/>
+          </a:effectRef>
+          <a:fontRef idx="minor">
+            <a:schemeClr val="lt1"/>
+          </a:fontRef>
+        </p:style>
+        <p:txBody>
+          <a:bodyPr rtlCol="0" anchor="ctr" wrap="square" lIns="50800" rIns="50800" tIns="25400" bIns="25400"/>
+          <a:lstStyle/>
+          <a:p>
+            <a:pPr algn="ctr"/>
+            <a:r>
+              <a:rPr sz="1200" b="1">
+                <a:solidFill>
+                  <a:srgbClr val="FFFFFF"/>
+                </a:solidFill>
+                <a:latin typeface="Meiryo"/>
+              </a:rPr>
+              <a:t>同じ構図：EDR/NW監視があれば検知可能 → しかし中小企業にはない → また「顧客の問題」になる</a:t>
+            </a:r>
+          </a:p>
+        </p:txBody>
+      </p:sp>
+      <p:sp>
+        <p:nvSpPr>
+          <p:cNvPr id="22" name="TextBox 21"/>
+          <p:cNvSpPr txBox="1"/>
+          <p:nvPr/>
+        </p:nvSpPr>
+        <p:spPr>
+          <a:xfrm>
+            <a:off x="9144000" y="10378440"/>
+            <a:ext cx="5943600" cy="228600"/>
+          </a:xfrm>
+          <a:prstGeom prst="rect">
+            <a:avLst/>
+          </a:prstGeom>
+          <a:noFill/>
+        </p:spPr>
+        <p:txBody>
+          <a:bodyPr wrap="square" lIns="50800" rIns="50800" tIns="38100" bIns="38100"/>
+          <a:lstStyle/>
+          <a:p>
+            <a:pPr algn="r"/>
+            <a:r>
+              <a:rPr sz="700" b="0">
+                <a:solidFill>
+                  <a:srgbClr val="888888"/>
+                </a:solidFill>
+                <a:latin typeface="Meiryo"/>
+              </a:rPr>
+              <a:t>Fraud Kill Chain — 手順⑦ 赤い画面</a:t>
+            </a:r>
+          </a:p>
+        </p:txBody>
+      </p:sp>
+    </p:spTree>
+  </p:cSld>
+  <p:clrMapOvr>
+    <a:masterClrMapping/>
+  </p:clrMapOvr>
+</p:sld>
+</file>
+
+<file path=ppt/slides/slide14.xml><?xml version="1.0" encoding="utf-8"?>
+<p:sld xmlns:a="http://schemas.openxmlformats.org/drawingml/2006/main" xmlns:p="http://schemas.openxmlformats.org/presentationml/2006/main" xmlns:r="http://schemas.openxmlformats.org/officeDocument/2006/relationships">
+  <p:cSld>
+    <p:bg>
+      <p:bgPr>
+        <a:solidFill>
+          <a:srgbClr val="F5F5F5"/>
+        </a:solidFill>
+        <a:effectLst/>
+      </p:bgPr>
+    </p:bg>
+    <p:spTree>
+      <p:nvGrpSpPr>
+        <p:cNvPr id="1" name=""/>
+        <p:cNvGrpSpPr/>
+        <p:nvPr/>
+      </p:nvGrpSpPr>
+      <p:grpSpPr/>
+      <p:sp>
+        <p:nvSpPr>
+          <p:cNvPr id="2" name="TextBox 1"/>
+          <p:cNvSpPr txBox="1"/>
+          <p:nvPr/>
+        </p:nvSpPr>
+        <p:spPr>
+          <a:xfrm>
+            <a:off x="0" y="182880"/>
+            <a:ext cx="15124176" cy="548640"/>
+          </a:xfrm>
+          <a:prstGeom prst="rect">
+            <a:avLst/>
+          </a:prstGeom>
+          <a:noFill/>
+        </p:spPr>
+        <p:txBody>
+          <a:bodyPr wrap="square" lIns="50800" rIns="50800" tIns="38100" bIns="38100"/>
+          <a:lstStyle/>
+          <a:p>
+            <a:pPr algn="ctr"/>
+            <a:r>
+              <a:rPr sz="2000" b="1">
+                <a:solidFill>
+                  <a:srgbClr val="C0392B"/>
+                </a:solidFill>
+                <a:latin typeface="Meiryo"/>
+              </a:rPr>
+              <a:t>手順⑧ デュアルデバイス攻撃 — 会社PCを封じ、個人スマホで認証を奪う</a:t>
+            </a:r>
+          </a:p>
+        </p:txBody>
+      </p:sp>
+      <p:sp>
+        <p:nvSpPr>
+          <p:cNvPr id="3" name="Rectangle 2"/>
+          <p:cNvSpPr/>
+          <p:nvPr/>
+        </p:nvSpPr>
+        <p:spPr>
+          <a:xfrm>
+            <a:off x="731520" y="777240"/>
+            <a:ext cx="6583680" cy="365760"/>
+          </a:xfrm>
+          <a:prstGeom prst="rect">
+            <a:avLst/>
+          </a:prstGeom>
+          <a:solidFill>
+            <a:srgbClr val="222222"/>
+          </a:solidFill>
+          <a:ln>
+            <a:noFill/>
+          </a:ln>
+        </p:spPr>
+        <p:style>
+          <a:lnRef idx="1">
+            <a:schemeClr val="accent1"/>
+          </a:lnRef>
+          <a:fillRef idx="3">
+            <a:schemeClr val="accent1"/>
+          </a:fillRef>
+          <a:effectRef idx="2">
+            <a:schemeClr val="accent1"/>
+          </a:effectRef>
+          <a:fontRef idx="minor">
+            <a:schemeClr val="lt1"/>
+          </a:fontRef>
+        </p:style>
+        <p:txBody>
+          <a:bodyPr rtlCol="0" anchor="ctr" wrap="square" lIns="50800" rIns="50800" tIns="25400" bIns="25400"/>
+          <a:lstStyle/>
+          <a:p>
+            <a:pPr algn="ctr"/>
+            <a:r>
+              <a:rPr sz="1100" b="1">
+                <a:solidFill>
+                  <a:srgbClr val="FFFFFF"/>
+                </a:solidFill>
+                <a:latin typeface="Meiryo"/>
+              </a:rPr>
+              <a:t>会社PC（封印済み）</a:t>
+            </a:r>
+          </a:p>
+        </p:txBody>
+      </p:sp>
+      <p:sp>
+        <p:nvSpPr>
+          <p:cNvPr id="4" name="Rectangle 3"/>
+          <p:cNvSpPr/>
+          <p:nvPr/>
+        </p:nvSpPr>
+        <p:spPr>
+          <a:xfrm>
+            <a:off x="731520" y="1143000"/>
+            <a:ext cx="6583680" cy="640080"/>
+          </a:xfrm>
+          <a:prstGeom prst="rect">
+            <a:avLst/>
+          </a:prstGeom>
+          <a:solidFill>
+            <a:srgbClr val="FDEDEC"/>
+          </a:solidFill>
+          <a:ln w="25400">
+            <a:solidFill>
+              <a:srgbClr val="C0392B"/>
+            </a:solidFill>
+          </a:ln>
+        </p:spPr>
+        <p:style>
+          <a:lnRef idx="1">
+            <a:schemeClr val="accent1"/>
+          </a:lnRef>
+          <a:fillRef idx="3">
+            <a:schemeClr val="accent1"/>
+          </a:fillRef>
+          <a:effectRef idx="2">
+            <a:schemeClr val="accent1"/>
+          </a:effectRef>
+          <a:fontRef idx="minor">
+            <a:schemeClr val="lt1"/>
+          </a:fontRef>
+        </p:style>
+        <p:txBody>
+          <a:bodyPr rtlCol="0" anchor="ctr" wrap="square" lIns="63500" rIns="50800" tIns="38100" bIns="38100"/>
+          <a:lstStyle/>
+          <a:p>
+            <a:pPr algn="l"/>
+            <a:r>
+              <a:rPr sz="900" b="0">
+                <a:solidFill>
+                  <a:srgbClr val="222222"/>
+                </a:solidFill>
+                <a:latin typeface="Meiryo"/>
+              </a:rPr>
+              <a:t>赤い画面で封印 → 確認手段なし
+犯人がScreenConnect経由で操作中
+→ BizSTATIONにアクセスし送金準備</a:t>
+            </a:r>
+          </a:p>
+        </p:txBody>
+      </p:sp>
+      <p:sp>
+        <p:nvSpPr>
+          <p:cNvPr id="5" name="Rectangle 4"/>
+          <p:cNvSpPr/>
+          <p:nvPr/>
+        </p:nvSpPr>
+        <p:spPr>
+          <a:xfrm>
+            <a:off x="7772400" y="777240"/>
+            <a:ext cx="6400800" cy="365760"/>
+          </a:xfrm>
+          <a:prstGeom prst="rect">
+            <a:avLst/>
+          </a:prstGeom>
+          <a:solidFill>
+            <a:srgbClr val="8E44AD"/>
+          </a:solidFill>
+          <a:ln>
+            <a:noFill/>
+          </a:ln>
+        </p:spPr>
+        <p:style>
+          <a:lnRef idx="1">
+            <a:schemeClr val="accent1"/>
+          </a:lnRef>
+          <a:fillRef idx="3">
+            <a:schemeClr val="accent1"/>
+          </a:fillRef>
+          <a:effectRef idx="2">
+            <a:schemeClr val="accent1"/>
+          </a:effectRef>
+          <a:fontRef idx="minor">
+            <a:schemeClr val="lt1"/>
+          </a:fontRef>
+        </p:style>
+        <p:txBody>
+          <a:bodyPr rtlCol="0" anchor="ctr" wrap="square" lIns="50800" rIns="50800" tIns="25400" bIns="25400"/>
+          <a:lstStyle/>
+          <a:p>
+            <a:pPr algn="ctr"/>
+            <a:r>
+              <a:rPr sz="1100" b="1">
+                <a:solidFill>
+                  <a:srgbClr val="FFFFFF"/>
+                </a:solidFill>
+                <a:latin typeface="Meiryo"/>
+              </a:rPr>
+              <a:t>個人スマホ（標的）</a:t>
+            </a:r>
+          </a:p>
+        </p:txBody>
+      </p:sp>
+      <p:sp>
+        <p:nvSpPr>
+          <p:cNvPr id="6" name="Rectangle 5"/>
+          <p:cNvSpPr/>
+          <p:nvPr/>
+        </p:nvSpPr>
+        <p:spPr>
+          <a:xfrm>
+            <a:off x="7772400" y="1143000"/>
+            <a:ext cx="6400800" cy="640080"/>
+          </a:xfrm>
+          <a:prstGeom prst="rect">
+            <a:avLst/>
+          </a:prstGeom>
+          <a:solidFill>
+            <a:srgbClr val="F4ECF7"/>
+          </a:solidFill>
+          <a:ln w="25400">
+            <a:solidFill>
+              <a:srgbClr val="8E44AD"/>
+            </a:solidFill>
+          </a:ln>
+        </p:spPr>
+        <p:style>
+          <a:lnRef idx="1">
+            <a:schemeClr val="accent1"/>
+          </a:lnRef>
+          <a:fillRef idx="3">
+            <a:schemeClr val="accent1"/>
+          </a:fillRef>
+          <a:effectRef idx="2">
+            <a:schemeClr val="accent1"/>
+          </a:effectRef>
+          <a:fontRef idx="minor">
+            <a:schemeClr val="lt1"/>
+          </a:fontRef>
+        </p:style>
+        <p:txBody>
+          <a:bodyPr rtlCol="0" anchor="ctr" wrap="square" lIns="63500" rIns="50800" tIns="38100" bIns="38100"/>
+          <a:lstStyle/>
+          <a:p>
+            <a:pPr algn="l"/>
+            <a:r>
+              <a:rPr sz="900" b="0">
+                <a:solidFill>
+                  <a:srgbClr val="222222"/>
+                </a:solidFill>
+                <a:latin typeface="Meiryo"/>
+              </a:rPr>
+              <a:t>SMS受信 → リンクをクリック
+偽の認証画面が表示される
+→ 認証情報5要素を入力させられる</a:t>
+            </a:r>
+          </a:p>
+        </p:txBody>
+      </p:sp>
+      <p:sp>
+        <p:nvSpPr>
+          <p:cNvPr id="7" name="Rectangle 6"/>
+          <p:cNvSpPr/>
+          <p:nvPr/>
+        </p:nvSpPr>
+        <p:spPr>
+          <a:xfrm>
+            <a:off x="731520" y="1965960"/>
+            <a:ext cx="13624560" cy="365760"/>
+          </a:xfrm>
+          <a:prstGeom prst="rect">
+            <a:avLst/>
+          </a:prstGeom>
+          <a:solidFill>
+            <a:srgbClr val="222222"/>
+          </a:solidFill>
+          <a:ln>
+            <a:noFill/>
+          </a:ln>
+        </p:spPr>
+        <p:style>
+          <a:lnRef idx="1">
+            <a:schemeClr val="accent1"/>
+          </a:lnRef>
+          <a:fillRef idx="3">
+            <a:schemeClr val="accent1"/>
+          </a:fillRef>
+          <a:effectRef idx="2">
+            <a:schemeClr val="accent1"/>
+          </a:effectRef>
+          <a:fontRef idx="minor">
+            <a:schemeClr val="lt1"/>
+          </a:fontRef>
+        </p:style>
+        <p:txBody>
+          <a:bodyPr rtlCol="0" anchor="ctr" wrap="square" lIns="50800" rIns="50800" tIns="25400" bIns="25400"/>
+          <a:lstStyle/>
+          <a:p>
+            <a:pPr algn="ctr"/>
+            <a:r>
+              <a:rPr sz="1200" b="1">
+                <a:solidFill>
+                  <a:srgbClr val="FFFFFF"/>
+                </a:solidFill>
+                <a:latin typeface="Meiryo"/>
+              </a:rPr>
+              <a:t>なぜ個人スマホに切り替えるのか</a:t>
+            </a:r>
+          </a:p>
+        </p:txBody>
+      </p:sp>
+      <p:sp>
+        <p:nvSpPr>
+          <p:cNvPr id="8" name="Rectangle 7"/>
+          <p:cNvSpPr/>
+          <p:nvPr/>
+        </p:nvSpPr>
+        <p:spPr>
+          <a:xfrm>
+            <a:off x="731520" y="2331720"/>
+            <a:ext cx="3200400" cy="411480"/>
+          </a:xfrm>
+          <a:prstGeom prst="rect">
+            <a:avLst/>
+          </a:prstGeom>
+          <a:solidFill>
+            <a:srgbClr val="C0392B"/>
+          </a:solidFill>
+          <a:ln>
+            <a:noFill/>
+          </a:ln>
+        </p:spPr>
+        <p:style>
+          <a:lnRef idx="1">
+            <a:schemeClr val="accent1"/>
+          </a:lnRef>
+          <a:fillRef idx="3">
+            <a:schemeClr val="accent1"/>
+          </a:fillRef>
+          <a:effectRef idx="2">
+            <a:schemeClr val="accent1"/>
+          </a:effectRef>
+          <a:fontRef idx="minor">
+            <a:schemeClr val="lt1"/>
+          </a:fontRef>
+        </p:style>
+        <p:txBody>
+          <a:bodyPr rtlCol="0" anchor="ctr" wrap="square" lIns="50800" rIns="50800" tIns="25400" bIns="25400"/>
+          <a:lstStyle/>
+          <a:p>
+            <a:pPr algn="ctr"/>
+            <a:r>
+              <a:rPr sz="900" b="1">
+                <a:solidFill>
+                  <a:srgbClr val="FFFFFF"/>
+                </a:solidFill>
+                <a:latin typeface="Meiryo"/>
+              </a:rPr>
+              <a:t>会社PCが使えない</a:t>
+            </a:r>
+          </a:p>
+        </p:txBody>
+      </p:sp>
+      <p:sp>
+        <p:nvSpPr>
+          <p:cNvPr id="9" name="Rectangle 8"/>
+          <p:cNvSpPr/>
+          <p:nvPr/>
+        </p:nvSpPr>
+        <p:spPr>
+          <a:xfrm>
+            <a:off x="3931920" y="2331720"/>
+            <a:ext cx="10424160" cy="411480"/>
+          </a:xfrm>
+          <a:prstGeom prst="rect">
+            <a:avLst/>
+          </a:prstGeom>
+          <a:solidFill>
+            <a:srgbClr val="FFFFFF"/>
+          </a:solidFill>
+          <a:ln w="25400">
+            <a:solidFill>
+              <a:srgbClr val="CCCCCC"/>
+            </a:solidFill>
+          </a:ln>
+        </p:spPr>
+        <p:style>
+          <a:lnRef idx="1">
+            <a:schemeClr val="accent1"/>
+          </a:lnRef>
+          <a:fillRef idx="3">
+            <a:schemeClr val="accent1"/>
+          </a:fillRef>
+          <a:effectRef idx="2">
+            <a:schemeClr val="accent1"/>
+          </a:effectRef>
+          <a:fontRef idx="minor">
+            <a:schemeClr val="lt1"/>
+          </a:fontRef>
+        </p:style>
+        <p:txBody>
+          <a:bodyPr rtlCol="0" anchor="ctr" wrap="square" lIns="63500" rIns="50800" tIns="38100" bIns="38100"/>
+          <a:lstStyle/>
+          <a:p>
+            <a:pPr algn="l"/>
+            <a:r>
+              <a:rPr sz="900" b="0">
+                <a:solidFill>
+                  <a:srgbClr val="222222"/>
+                </a:solidFill>
+                <a:latin typeface="Meiryo"/>
+              </a:rPr>
+              <a:t>赤い画面で封印済み。犯人が操作中。</a:t>
+            </a:r>
+          </a:p>
+        </p:txBody>
+      </p:sp>
+      <p:sp>
+        <p:nvSpPr>
+          <p:cNvPr id="10" name="Rectangle 9"/>
+          <p:cNvSpPr/>
+          <p:nvPr/>
+        </p:nvSpPr>
+        <p:spPr>
+          <a:xfrm>
+            <a:off x="731520" y="2743200"/>
+            <a:ext cx="3200400" cy="411480"/>
+          </a:xfrm>
+          <a:prstGeom prst="rect">
+            <a:avLst/>
+          </a:prstGeom>
+          <a:solidFill>
+            <a:srgbClr val="E67E22"/>
+          </a:solidFill>
+          <a:ln>
+            <a:noFill/>
+          </a:ln>
+        </p:spPr>
+        <p:style>
+          <a:lnRef idx="1">
+            <a:schemeClr val="accent1"/>
+          </a:lnRef>
+          <a:fillRef idx="3">
+            <a:schemeClr val="accent1"/>
+          </a:fillRef>
+          <a:effectRef idx="2">
+            <a:schemeClr val="accent1"/>
+          </a:effectRef>
+          <a:fontRef idx="minor">
+            <a:schemeClr val="lt1"/>
+          </a:fontRef>
+        </p:style>
+        <p:txBody>
+          <a:bodyPr rtlCol="0" anchor="ctr" wrap="square" lIns="50800" rIns="50800" tIns="25400" bIns="25400"/>
+          <a:lstStyle/>
+          <a:p>
+            <a:pPr algn="ctr"/>
+            <a:r>
+              <a:rPr sz="900" b="1">
+                <a:solidFill>
+                  <a:srgbClr val="FFFFFF"/>
+                </a:solidFill>
+                <a:latin typeface="Meiryo"/>
+              </a:rPr>
+              <a:t>企業セキュリティの回避</a:t>
+            </a:r>
+          </a:p>
+        </p:txBody>
+      </p:sp>
+      <p:sp>
+        <p:nvSpPr>
+          <p:cNvPr id="11" name="Rectangle 10"/>
+          <p:cNvSpPr/>
+          <p:nvPr/>
+        </p:nvSpPr>
+        <p:spPr>
+          <a:xfrm>
+            <a:off x="3931920" y="2743200"/>
+            <a:ext cx="10424160" cy="411480"/>
+          </a:xfrm>
+          <a:prstGeom prst="rect">
+            <a:avLst/>
+          </a:prstGeom>
+          <a:solidFill>
+            <a:srgbClr val="FFFFFF"/>
+          </a:solidFill>
+          <a:ln w="25400">
+            <a:solidFill>
+              <a:srgbClr val="CCCCCC"/>
+            </a:solidFill>
+          </a:ln>
+        </p:spPr>
+        <p:style>
+          <a:lnRef idx="1">
+            <a:schemeClr val="accent1"/>
+          </a:lnRef>
+          <a:fillRef idx="3">
+            <a:schemeClr val="accent1"/>
+          </a:fillRef>
+          <a:effectRef idx="2">
+            <a:schemeClr val="accent1"/>
+          </a:effectRef>
+          <a:fontRef idx="minor">
+            <a:schemeClr val="lt1"/>
+          </a:fontRef>
+        </p:style>
+        <p:txBody>
+          <a:bodyPr rtlCol="0" anchor="ctr" wrap="square" lIns="63500" rIns="50800" tIns="38100" bIns="38100"/>
+          <a:lstStyle/>
+          <a:p>
+            <a:pPr algn="l"/>
+            <a:r>
+              <a:rPr sz="900" b="0">
+                <a:solidFill>
+                  <a:srgbClr val="222222"/>
+                </a:solidFill>
+                <a:latin typeface="Meiryo"/>
+              </a:rPr>
+              <a:t>会社PCのEDR/プロキシを回避。個人スマホにはない。</a:t>
+            </a:r>
+          </a:p>
+        </p:txBody>
+      </p:sp>
+      <p:sp>
+        <p:nvSpPr>
+          <p:cNvPr id="12" name="Rectangle 11"/>
+          <p:cNvSpPr/>
+          <p:nvPr/>
+        </p:nvSpPr>
+        <p:spPr>
+          <a:xfrm>
+            <a:off x="731520" y="3154679"/>
+            <a:ext cx="3200400" cy="411480"/>
+          </a:xfrm>
+          <a:prstGeom prst="rect">
+            <a:avLst/>
+          </a:prstGeom>
+          <a:solidFill>
+            <a:srgbClr val="2980B9"/>
+          </a:solidFill>
+          <a:ln>
+            <a:noFill/>
+          </a:ln>
+        </p:spPr>
+        <p:style>
+          <a:lnRef idx="1">
+            <a:schemeClr val="accent1"/>
+          </a:lnRef>
+          <a:fillRef idx="3">
+            <a:schemeClr val="accent1"/>
+          </a:fillRef>
+          <a:effectRef idx="2">
+            <a:schemeClr val="accent1"/>
+          </a:effectRef>
+          <a:fontRef idx="minor">
+            <a:schemeClr val="lt1"/>
+          </a:fontRef>
+        </p:style>
+        <p:txBody>
+          <a:bodyPr rtlCol="0" anchor="ctr" wrap="square" lIns="50800" rIns="50800" tIns="25400" bIns="25400"/>
+          <a:lstStyle/>
+          <a:p>
+            <a:pPr algn="ctr"/>
+            <a:r>
+              <a:rPr sz="900" b="1">
+                <a:solidFill>
+                  <a:srgbClr val="FFFFFF"/>
+                </a:solidFill>
+                <a:latin typeface="Meiryo"/>
+              </a:rPr>
+              <a:t>SMS認証は個人端末が前提</a:t>
+            </a:r>
+          </a:p>
+        </p:txBody>
+      </p:sp>
+      <p:sp>
+        <p:nvSpPr>
+          <p:cNvPr id="13" name="Rectangle 12"/>
+          <p:cNvSpPr/>
+          <p:nvPr/>
+        </p:nvSpPr>
+        <p:spPr>
+          <a:xfrm>
+            <a:off x="3931920" y="3154679"/>
+            <a:ext cx="10424160" cy="411480"/>
+          </a:xfrm>
+          <a:prstGeom prst="rect">
+            <a:avLst/>
+          </a:prstGeom>
+          <a:solidFill>
+            <a:srgbClr val="FFFFFF"/>
+          </a:solidFill>
+          <a:ln w="25400">
+            <a:solidFill>
+              <a:srgbClr val="CCCCCC"/>
+            </a:solidFill>
+          </a:ln>
+        </p:spPr>
+        <p:style>
+          <a:lnRef idx="1">
+            <a:schemeClr val="accent1"/>
+          </a:lnRef>
+          <a:fillRef idx="3">
+            <a:schemeClr val="accent1"/>
+          </a:fillRef>
+          <a:effectRef idx="2">
+            <a:schemeClr val="accent1"/>
+          </a:effectRef>
+          <a:fontRef idx="minor">
+            <a:schemeClr val="lt1"/>
+          </a:fontRef>
+        </p:style>
+        <p:txBody>
+          <a:bodyPr rtlCol="0" anchor="ctr" wrap="square" lIns="63500" rIns="50800" tIns="38100" bIns="38100"/>
+          <a:lstStyle/>
+          <a:p>
+            <a:pPr algn="l"/>
+            <a:r>
+              <a:rPr sz="900" b="0">
+                <a:solidFill>
+                  <a:srgbClr val="222222"/>
+                </a:solidFill>
+                <a:latin typeface="Meiryo"/>
+              </a:rPr>
+              <a:t>「携帯にSMSが届く」は自然な流れ。</a:t>
+            </a:r>
+          </a:p>
+        </p:txBody>
+      </p:sp>
+      <p:sp>
+        <p:nvSpPr>
+          <p:cNvPr id="14" name="Rectangle 13"/>
+          <p:cNvSpPr/>
+          <p:nvPr/>
+        </p:nvSpPr>
+        <p:spPr>
+          <a:xfrm>
+            <a:off x="731520" y="3566160"/>
+            <a:ext cx="3200400" cy="411480"/>
+          </a:xfrm>
+          <a:prstGeom prst="rect">
+            <a:avLst/>
+          </a:prstGeom>
+          <a:solidFill>
+            <a:srgbClr val="8E44AD"/>
+          </a:solidFill>
+          <a:ln>
+            <a:noFill/>
+          </a:ln>
+        </p:spPr>
+        <p:style>
+          <a:lnRef idx="1">
+            <a:schemeClr val="accent1"/>
+          </a:lnRef>
+          <a:fillRef idx="3">
+            <a:schemeClr val="accent1"/>
+          </a:fillRef>
+          <a:effectRef idx="2">
+            <a:schemeClr val="accent1"/>
+          </a:effectRef>
+          <a:fontRef idx="minor">
+            <a:schemeClr val="lt1"/>
+          </a:fontRef>
+        </p:style>
+        <p:txBody>
+          <a:bodyPr rtlCol="0" anchor="ctr" wrap="square" lIns="50800" rIns="50800" tIns="25400" bIns="25400"/>
+          <a:lstStyle/>
+          <a:p>
+            <a:pPr algn="ctr"/>
+            <a:r>
+              <a:rPr sz="900" b="1">
+                <a:solidFill>
+                  <a:srgbClr val="FFFFFF"/>
+                </a:solidFill>
+                <a:latin typeface="Meiryo"/>
+              </a:rPr>
+              <a:t>2デバイス同時制御</a:t>
+            </a:r>
+          </a:p>
+        </p:txBody>
+      </p:sp>
+      <p:sp>
+        <p:nvSpPr>
+          <p:cNvPr id="15" name="Rectangle 14"/>
+          <p:cNvSpPr/>
+          <p:nvPr/>
+        </p:nvSpPr>
+        <p:spPr>
+          <a:xfrm>
+            <a:off x="3931920" y="3566160"/>
+            <a:ext cx="10424160" cy="411480"/>
+          </a:xfrm>
+          <a:prstGeom prst="rect">
+            <a:avLst/>
+          </a:prstGeom>
+          <a:solidFill>
+            <a:srgbClr val="FFFFFF"/>
+          </a:solidFill>
+          <a:ln w="25400">
+            <a:solidFill>
+              <a:srgbClr val="CCCCCC"/>
+            </a:solidFill>
+          </a:ln>
+        </p:spPr>
+        <p:style>
+          <a:lnRef idx="1">
+            <a:schemeClr val="accent1"/>
+          </a:lnRef>
+          <a:fillRef idx="3">
+            <a:schemeClr val="accent1"/>
+          </a:fillRef>
+          <a:effectRef idx="2">
+            <a:schemeClr val="accent1"/>
+          </a:effectRef>
+          <a:fontRef idx="minor">
+            <a:schemeClr val="lt1"/>
+          </a:fontRef>
+        </p:style>
+        <p:txBody>
+          <a:bodyPr rtlCol="0" anchor="ctr" wrap="square" lIns="63500" rIns="50800" tIns="38100" bIns="38100"/>
+          <a:lstStyle/>
+          <a:p>
+            <a:pPr algn="l"/>
+            <a:r>
+              <a:rPr sz="900" b="0">
+                <a:solidFill>
+                  <a:srgbClr val="222222"/>
+                </a:solidFill>
+                <a:latin typeface="Meiryo"/>
+              </a:rPr>
+              <a:t>PCは遠隔操作、スマホは電話で指示。両方が犯人の支配下。</a:t>
+            </a:r>
+          </a:p>
+        </p:txBody>
+      </p:sp>
+      <p:sp>
+        <p:nvSpPr>
+          <p:cNvPr id="16" name="Rectangle 15"/>
+          <p:cNvSpPr/>
+          <p:nvPr/>
+        </p:nvSpPr>
+        <p:spPr>
+          <a:xfrm>
+            <a:off x="731520" y="4069079"/>
+            <a:ext cx="13624560" cy="365760"/>
+          </a:xfrm>
+          <a:prstGeom prst="rect">
+            <a:avLst/>
+          </a:prstGeom>
+          <a:solidFill>
+            <a:srgbClr val="C0392B"/>
+          </a:solidFill>
+          <a:ln>
+            <a:noFill/>
+          </a:ln>
+        </p:spPr>
+        <p:style>
+          <a:lnRef idx="1">
+            <a:schemeClr val="accent1"/>
+          </a:lnRef>
+          <a:fillRef idx="3">
+            <a:schemeClr val="accent1"/>
+          </a:fillRef>
+          <a:effectRef idx="2">
+            <a:schemeClr val="accent1"/>
+          </a:effectRef>
+          <a:fontRef idx="minor">
+            <a:schemeClr val="lt1"/>
+          </a:fontRef>
+        </p:style>
+        <p:txBody>
+          <a:bodyPr rtlCol="0" anchor="ctr" wrap="square" lIns="50800" rIns="50800" tIns="25400" bIns="25400"/>
+          <a:lstStyle/>
+          <a:p>
+            <a:pPr algn="ctr"/>
+            <a:r>
+              <a:rPr sz="1100" b="1">
+                <a:solidFill>
+                  <a:srgbClr val="FFFFFF"/>
+                </a:solidFill>
+                <a:latin typeface="Meiryo"/>
+              </a:rPr>
+              <a:t>⚠ 破綻ポイント：5つの認証情報を一画面で入力させること自体がありえない</a:t>
+            </a:r>
+          </a:p>
+        </p:txBody>
+      </p:sp>
+      <p:sp>
+        <p:nvSpPr>
+          <p:cNvPr id="17" name="Rectangle 16"/>
+          <p:cNvSpPr/>
+          <p:nvPr/>
+        </p:nvSpPr>
+        <p:spPr>
+          <a:xfrm>
+            <a:off x="731520" y="4480559"/>
+            <a:ext cx="6583680" cy="320040"/>
+          </a:xfrm>
+          <a:prstGeom prst="rect">
+            <a:avLst/>
+          </a:prstGeom>
+          <a:solidFill>
+            <a:srgbClr val="27AE60"/>
+          </a:solidFill>
+          <a:ln>
+            <a:noFill/>
+          </a:ln>
+        </p:spPr>
+        <p:style>
+          <a:lnRef idx="1">
+            <a:schemeClr val="accent1"/>
+          </a:lnRef>
+          <a:fillRef idx="3">
+            <a:schemeClr val="accent1"/>
+          </a:fillRef>
+          <a:effectRef idx="2">
+            <a:schemeClr val="accent1"/>
+          </a:effectRef>
+          <a:fontRef idx="minor">
+            <a:schemeClr val="lt1"/>
+          </a:fontRef>
+        </p:style>
+        <p:txBody>
+          <a:bodyPr rtlCol="0" anchor="ctr" wrap="square" lIns="50800" rIns="50800" tIns="25400" bIns="25400"/>
+          <a:lstStyle/>
+          <a:p>
+            <a:pPr algn="ctr"/>
+            <a:r>
+              <a:rPr sz="1000" b="1">
+                <a:solidFill>
+                  <a:srgbClr val="FFFFFF"/>
+                </a:solidFill>
+                <a:latin typeface="Meiryo"/>
+              </a:rPr>
+              <a:t>正規のBizSTATION</a:t>
+            </a:r>
+          </a:p>
+        </p:txBody>
+      </p:sp>
+      <p:sp>
+        <p:nvSpPr>
+          <p:cNvPr id="18" name="Rectangle 17"/>
+          <p:cNvSpPr/>
+          <p:nvPr/>
+        </p:nvSpPr>
+        <p:spPr>
+          <a:xfrm>
+            <a:off x="731520" y="4800599"/>
+            <a:ext cx="6583680" cy="640080"/>
+          </a:xfrm>
+          <a:prstGeom prst="rect">
+            <a:avLst/>
+          </a:prstGeom>
+          <a:solidFill>
+            <a:srgbClr val="FFFFFF"/>
+          </a:solidFill>
+          <a:ln w="25400">
+            <a:solidFill>
+              <a:srgbClr val="27AE60"/>
+            </a:solidFill>
+          </a:ln>
+        </p:spPr>
+        <p:style>
+          <a:lnRef idx="1">
+            <a:schemeClr val="accent1"/>
+          </a:lnRef>
+          <a:fillRef idx="3">
+            <a:schemeClr val="accent1"/>
+          </a:fillRef>
+          <a:effectRef idx="2">
+            <a:schemeClr val="accent1"/>
+          </a:effectRef>
+          <a:fontRef idx="minor">
+            <a:schemeClr val="lt1"/>
+          </a:fontRef>
+        </p:style>
+        <p:txBody>
+          <a:bodyPr rtlCol="0" anchor="ctr" wrap="square" lIns="63500" rIns="50800" tIns="38100" bIns="38100"/>
+          <a:lstStyle/>
+          <a:p>
+            <a:pPr algn="l"/>
+            <a:r>
+              <a:rPr sz="900" b="0">
+                <a:solidFill>
+                  <a:srgbClr val="222222"/>
+                </a:solidFill>
+                <a:latin typeface="Meiryo"/>
+              </a:rPr>
+              <a:t>ステップ1：契約者番号 + 利用者ID → 入力
+ステップ2：ログインPW → 入力
+ステップ3：取引時にOTP → 入力（段階的）</a:t>
+            </a:r>
+          </a:p>
+        </p:txBody>
+      </p:sp>
+      <p:sp>
+        <p:nvSpPr>
+          <p:cNvPr id="19" name="Rectangle 18"/>
+          <p:cNvSpPr/>
+          <p:nvPr/>
+        </p:nvSpPr>
+        <p:spPr>
+          <a:xfrm>
+            <a:off x="7772400" y="4480559"/>
+            <a:ext cx="6400800" cy="320040"/>
+          </a:xfrm>
+          <a:prstGeom prst="rect">
+            <a:avLst/>
+          </a:prstGeom>
+          <a:solidFill>
+            <a:srgbClr val="C0392B"/>
+          </a:solidFill>
+          <a:ln>
+            <a:noFill/>
+          </a:ln>
+        </p:spPr>
+        <p:style>
+          <a:lnRef idx="1">
+            <a:schemeClr val="accent1"/>
+          </a:lnRef>
+          <a:fillRef idx="3">
+            <a:schemeClr val="accent1"/>
+          </a:fillRef>
+          <a:effectRef idx="2">
+            <a:schemeClr val="accent1"/>
+          </a:effectRef>
+          <a:fontRef idx="minor">
+            <a:schemeClr val="lt1"/>
+          </a:fontRef>
+        </p:style>
+        <p:txBody>
+          <a:bodyPr rtlCol="0" anchor="ctr" wrap="square" lIns="50800" rIns="50800" tIns="25400" bIns="25400"/>
+          <a:lstStyle/>
+          <a:p>
+            <a:pPr algn="ctr"/>
+            <a:r>
+              <a:rPr sz="1000" b="1">
+                <a:solidFill>
+                  <a:srgbClr val="FFFFFF"/>
+                </a:solidFill>
+                <a:latin typeface="Meiryo"/>
+              </a:rPr>
+              <a:t>この攻撃</a:t>
+            </a:r>
+          </a:p>
+        </p:txBody>
+      </p:sp>
+      <p:sp>
+        <p:nvSpPr>
+          <p:cNvPr id="20" name="Rectangle 19"/>
+          <p:cNvSpPr/>
+          <p:nvPr/>
+        </p:nvSpPr>
+        <p:spPr>
+          <a:xfrm>
+            <a:off x="7772400" y="4800599"/>
+            <a:ext cx="6400800" cy="640080"/>
+          </a:xfrm>
+          <a:prstGeom prst="rect">
+            <a:avLst/>
+          </a:prstGeom>
+          <a:solidFill>
+            <a:srgbClr val="FDEDEC"/>
+          </a:solidFill>
+          <a:ln w="25400">
+            <a:solidFill>
+              <a:srgbClr val="C0392B"/>
+            </a:solidFill>
+          </a:ln>
+        </p:spPr>
+        <p:style>
+          <a:lnRef idx="1">
+            <a:schemeClr val="accent1"/>
+          </a:lnRef>
+          <a:fillRef idx="3">
+            <a:schemeClr val="accent1"/>
+          </a:fillRef>
+          <a:effectRef idx="2">
+            <a:schemeClr val="accent1"/>
+          </a:effectRef>
+          <a:fontRef idx="minor">
+            <a:schemeClr val="lt1"/>
+          </a:fontRef>
+        </p:style>
+        <p:txBody>
+          <a:bodyPr rtlCol="0" anchor="ctr" wrap="square" lIns="63500" rIns="50800" tIns="38100" bIns="38100"/>
+          <a:lstStyle/>
+          <a:p>
+            <a:pPr algn="l"/>
+            <a:r>
+              <a:rPr sz="900" b="1">
+                <a:solidFill>
+                  <a:srgbClr val="C0392B"/>
+                </a:solidFill>
+                <a:latin typeface="Meiryo"/>
+              </a:rPr>
+              <a:t>1画面で全部入力：
+契約者番号 / 利用者ID / ログインPW / 取引実行PW / OTP
+→ 5要素を一括。正規ではありえない。</a:t>
+            </a:r>
+          </a:p>
+        </p:txBody>
+      </p:sp>
+      <p:sp>
+        <p:nvSpPr>
+          <p:cNvPr id="21" name="Rectangle 20"/>
+          <p:cNvSpPr/>
+          <p:nvPr/>
+        </p:nvSpPr>
+        <p:spPr>
+          <a:xfrm>
+            <a:off x="731520" y="5577840"/>
+            <a:ext cx="13624560" cy="365760"/>
+          </a:xfrm>
+          <a:prstGeom prst="rect">
+            <a:avLst/>
+          </a:prstGeom>
+          <a:solidFill>
+            <a:srgbClr val="222222"/>
+          </a:solidFill>
+          <a:ln>
+            <a:noFill/>
+          </a:ln>
+        </p:spPr>
+        <p:style>
+          <a:lnRef idx="1">
+            <a:schemeClr val="accent1"/>
+          </a:lnRef>
+          <a:fillRef idx="3">
+            <a:schemeClr val="accent1"/>
+          </a:fillRef>
+          <a:effectRef idx="2">
+            <a:schemeClr val="accent1"/>
+          </a:effectRef>
+          <a:fontRef idx="minor">
+            <a:schemeClr val="lt1"/>
+          </a:fontRef>
+        </p:style>
+        <p:txBody>
+          <a:bodyPr rtlCol="0" anchor="ctr" wrap="square" lIns="50800" rIns="50800" tIns="25400" bIns="25400"/>
+          <a:lstStyle/>
+          <a:p>
+            <a:pPr algn="ctr"/>
+            <a:r>
+              <a:rPr sz="1100" b="1">
+                <a:solidFill>
+                  <a:srgbClr val="FFFFFF"/>
+                </a:solidFill>
+                <a:latin typeface="Meiryo"/>
+              </a:rPr>
+              <a:t>OTPの時間制限が犯人に有利に働く — リアルタイムだから成立する</a:t>
+            </a:r>
+          </a:p>
+        </p:txBody>
+      </p:sp>
+      <p:sp>
+        <p:nvSpPr>
+          <p:cNvPr id="22" name="Rectangle 21"/>
+          <p:cNvSpPr/>
+          <p:nvPr/>
+        </p:nvSpPr>
+        <p:spPr>
+          <a:xfrm>
+            <a:off x="731520" y="5943600"/>
+            <a:ext cx="13624560" cy="640080"/>
+          </a:xfrm>
+          <a:prstGeom prst="rect">
+            <a:avLst/>
+          </a:prstGeom>
+          <a:solidFill>
+            <a:srgbClr val="FFFFFF"/>
+          </a:solidFill>
+          <a:ln w="25400">
+            <a:solidFill>
+              <a:srgbClr val="222222"/>
+            </a:solidFill>
+          </a:ln>
+        </p:spPr>
+        <p:style>
+          <a:lnRef idx="1">
+            <a:schemeClr val="accent1"/>
+          </a:lnRef>
+          <a:fillRef idx="3">
+            <a:schemeClr val="accent1"/>
+          </a:fillRef>
+          <a:effectRef idx="2">
+            <a:schemeClr val="accent1"/>
+          </a:effectRef>
+          <a:fontRef idx="minor">
+            <a:schemeClr val="lt1"/>
+          </a:fontRef>
+        </p:style>
+        <p:txBody>
+          <a:bodyPr rtlCol="0" anchor="ctr" wrap="square" lIns="63500" rIns="50800" tIns="38100" bIns="38100"/>
+          <a:lstStyle/>
+          <a:p>
+            <a:pPr algn="l"/>
+            <a:r>
+              <a:rPr sz="900" b="0">
+                <a:solidFill>
+                  <a:srgbClr val="222222"/>
+                </a:solidFill>
+                <a:latin typeface="Meiryo"/>
+              </a:rPr>
+              <a:t>① 犯人：裏でBizSTATIONにアクセス → OTP入力画面まで進む
+② 犯人：電話で「OTPを入力してください」→ 被害者がスマホに入力
+③ 犯人：入力されたOTP（有効期限30〜60秒）を即座に使用 → 送金実行
+→ 電話をつないだままだからリアルタイムにできる</a:t>
+            </a:r>
+          </a:p>
+        </p:txBody>
+      </p:sp>
+      <p:sp>
+        <p:nvSpPr>
+          <p:cNvPr id="23" name="Rectangle 22"/>
+          <p:cNvSpPr/>
+          <p:nvPr/>
+        </p:nvSpPr>
+        <p:spPr>
+          <a:xfrm>
+            <a:off x="731520" y="6720840"/>
+            <a:ext cx="13624560" cy="457200"/>
+          </a:xfrm>
+          <a:prstGeom prst="rect">
+            <a:avLst/>
+          </a:prstGeom>
+          <a:solidFill>
+            <a:srgbClr val="222222"/>
+          </a:solidFill>
+          <a:ln>
+            <a:noFill/>
+          </a:ln>
+        </p:spPr>
+        <p:style>
+          <a:lnRef idx="1">
+            <a:schemeClr val="accent1"/>
+          </a:lnRef>
+          <a:fillRef idx="3">
+            <a:schemeClr val="accent1"/>
+          </a:fillRef>
+          <a:effectRef idx="2">
+            <a:schemeClr val="accent1"/>
+          </a:effectRef>
+          <a:fontRef idx="minor">
+            <a:schemeClr val="lt1"/>
+          </a:fontRef>
+        </p:style>
+        <p:txBody>
+          <a:bodyPr rtlCol="0" anchor="ctr" wrap="square" lIns="50800" rIns="50800" tIns="25400" bIns="25400"/>
+          <a:lstStyle/>
+          <a:p>
+            <a:pPr algn="ctr"/>
+            <a:r>
+              <a:rPr sz="1200" b="1">
+                <a:solidFill>
+                  <a:srgbClr val="FFFFFF"/>
+                </a:solidFill>
+                <a:latin typeface="Meiryo"/>
+              </a:rPr>
+              <a:t>同じ構図：個人スマホは企業セキュリティの管轄外 → 「顧客の問題」→ 対策されない</a:t>
+            </a:r>
+          </a:p>
+        </p:txBody>
+      </p:sp>
+      <p:sp>
+        <p:nvSpPr>
+          <p:cNvPr id="24" name="TextBox 23"/>
+          <p:cNvSpPr txBox="1"/>
+          <p:nvPr/>
+        </p:nvSpPr>
+        <p:spPr>
+          <a:xfrm>
+            <a:off x="9144000" y="10378440"/>
+            <a:ext cx="5943600" cy="228600"/>
+          </a:xfrm>
+          <a:prstGeom prst="rect">
+            <a:avLst/>
+          </a:prstGeom>
+          <a:noFill/>
+        </p:spPr>
+        <p:txBody>
+          <a:bodyPr wrap="square" lIns="50800" rIns="50800" tIns="38100" bIns="38100"/>
+          <a:lstStyle/>
+          <a:p>
+            <a:pPr algn="r"/>
+            <a:r>
+              <a:rPr sz="700" b="0">
+                <a:solidFill>
+                  <a:srgbClr val="888888"/>
+                </a:solidFill>
+                <a:latin typeface="Meiryo"/>
+              </a:rPr>
+              <a:t>Fraud Kill Chain — 手順⑧ デュアルデバイス攻撃</a:t>
             </a:r>
           </a:p>
         </p:txBody>

</xml_diff>

<commit_message>
Add slides 15-16: wire transfer via victim PC + final summary
Slide 15: Attacker routes through victim's PC to spoof IP, bypassing
location-based detection. Bank confirmation calls also fail because
victim believes they initiated the transfer.

Slide 16: Full summary — 10 elements identical to legitimate banking,
6 differences require expert knowledge. 3 technical cut points exist
at zero cost. Root cause: banks delegate everything to customers.

https://claude.ai/code/session_01F7t8LKifK43o6sCdF2a3gQ
</commit_message>
<xml_diff>
--- a/Fraud_Kill_Chain.pptx
+++ b/Fraud_Kill_Chain.pptx
@@ -19,6 +19,8 @@
     <p:sldId id="267" r:id="rId18"/>
     <p:sldId id="268" r:id="rId19"/>
     <p:sldId id="269" r:id="rId20"/>
+    <p:sldId id="270" r:id="rId21"/>
+    <p:sldId id="271" r:id="rId22"/>
   </p:sldIdLst>
   <p:sldSz cx="15124176" cy="10689336" type="screen4x3"/>
   <p:notesSz cx="6858000" cy="9144000"/>
@@ -17730,6 +17732,3787 @@
                 <a:latin typeface="Meiryo"/>
               </a:rPr>
               <a:t>Fraud Kill Chain — 手順⑧ デュアルデバイス攻撃</a:t>
+            </a:r>
+          </a:p>
+        </p:txBody>
+      </p:sp>
+    </p:spTree>
+  </p:cSld>
+  <p:clrMapOvr>
+    <a:masterClrMapping/>
+  </p:clrMapOvr>
+</p:sld>
+</file>
+
+<file path=ppt/slides/slide15.xml><?xml version="1.0" encoding="utf-8"?>
+<p:sld xmlns:a="http://schemas.openxmlformats.org/drawingml/2006/main" xmlns:p="http://schemas.openxmlformats.org/presentationml/2006/main" xmlns:r="http://schemas.openxmlformats.org/officeDocument/2006/relationships">
+  <p:cSld>
+    <p:bg>
+      <p:bgPr>
+        <a:solidFill>
+          <a:srgbClr val="F5F5F5"/>
+        </a:solidFill>
+        <a:effectLst/>
+      </p:bgPr>
+    </p:bg>
+    <p:spTree>
+      <p:nvGrpSpPr>
+        <p:cNvPr id="1" name=""/>
+        <p:cNvGrpSpPr/>
+        <p:nvPr/>
+      </p:nvGrpSpPr>
+      <p:grpSpPr/>
+      <p:sp>
+        <p:nvSpPr>
+          <p:cNvPr id="2" name="TextBox 1"/>
+          <p:cNvSpPr txBox="1"/>
+          <p:nvPr/>
+        </p:nvSpPr>
+        <p:spPr>
+          <a:xfrm>
+            <a:off x="0" y="182880"/>
+            <a:ext cx="15124176" cy="548640"/>
+          </a:xfrm>
+          <a:prstGeom prst="rect">
+            <a:avLst/>
+          </a:prstGeom>
+          <a:noFill/>
+        </p:spPr>
+        <p:txBody>
+          <a:bodyPr wrap="square" lIns="50800" rIns="50800" tIns="38100" bIns="38100"/>
+          <a:lstStyle/>
+          <a:p>
+            <a:pPr algn="ctr"/>
+            <a:r>
+              <a:rPr sz="2000" b="1">
+                <a:solidFill>
+                  <a:srgbClr val="C0392B"/>
+                </a:solidFill>
+                <a:latin typeface="Meiryo"/>
+              </a:rPr>
+              <a:t>手順⑨ 不正送金 — 被害者のPCを経由しIPアドレスを偽装する</a:t>
+            </a:r>
+          </a:p>
+        </p:txBody>
+      </p:sp>
+      <p:sp>
+        <p:nvSpPr>
+          <p:cNvPr id="3" name="Rectangle 2"/>
+          <p:cNvSpPr/>
+          <p:nvPr/>
+        </p:nvSpPr>
+        <p:spPr>
+          <a:xfrm>
+            <a:off x="731520" y="777240"/>
+            <a:ext cx="6583680" cy="365760"/>
+          </a:xfrm>
+          <a:prstGeom prst="rect">
+            <a:avLst/>
+          </a:prstGeom>
+          <a:solidFill>
+            <a:srgbClr val="C0392B"/>
+          </a:solidFill>
+          <a:ln>
+            <a:noFill/>
+          </a:ln>
+        </p:spPr>
+        <p:style>
+          <a:lnRef idx="1">
+            <a:schemeClr val="accent1"/>
+          </a:lnRef>
+          <a:fillRef idx="3">
+            <a:schemeClr val="accent1"/>
+          </a:fillRef>
+          <a:effectRef idx="2">
+            <a:schemeClr val="accent1"/>
+          </a:effectRef>
+          <a:fontRef idx="minor">
+            <a:schemeClr val="lt1"/>
+          </a:fontRef>
+        </p:style>
+        <p:txBody>
+          <a:bodyPr rtlCol="0" anchor="ctr" wrap="square" lIns="50800" rIns="50800" tIns="25400" bIns="25400"/>
+          <a:lstStyle/>
+          <a:p>
+            <a:pPr algn="ctr"/>
+            <a:r>
+              <a:rPr sz="1000" b="1">
+                <a:solidFill>
+                  <a:srgbClr val="FFFFFF"/>
+                </a:solidFill>
+                <a:latin typeface="Meiryo"/>
+              </a:rPr>
+              <a:t>犯人のPCからアクセスした場合</a:t>
+            </a:r>
+          </a:p>
+        </p:txBody>
+      </p:sp>
+      <p:sp>
+        <p:nvSpPr>
+          <p:cNvPr id="4" name="Rectangle 3"/>
+          <p:cNvSpPr/>
+          <p:nvPr/>
+        </p:nvSpPr>
+        <p:spPr>
+          <a:xfrm>
+            <a:off x="731520" y="1143000"/>
+            <a:ext cx="6583680" cy="502920"/>
+          </a:xfrm>
+          <a:prstGeom prst="rect">
+            <a:avLst/>
+          </a:prstGeom>
+          <a:solidFill>
+            <a:srgbClr val="FDEDEC"/>
+          </a:solidFill>
+          <a:ln w="25400">
+            <a:solidFill>
+              <a:srgbClr val="C0392B"/>
+            </a:solidFill>
+          </a:ln>
+        </p:spPr>
+        <p:style>
+          <a:lnRef idx="1">
+            <a:schemeClr val="accent1"/>
+          </a:lnRef>
+          <a:fillRef idx="3">
+            <a:schemeClr val="accent1"/>
+          </a:fillRef>
+          <a:effectRef idx="2">
+            <a:schemeClr val="accent1"/>
+          </a:effectRef>
+          <a:fontRef idx="minor">
+            <a:schemeClr val="lt1"/>
+          </a:fontRef>
+        </p:style>
+        <p:txBody>
+          <a:bodyPr rtlCol="0" anchor="ctr" wrap="square" lIns="63500" rIns="50800" tIns="38100" bIns="38100"/>
+          <a:lstStyle/>
+          <a:p>
+            <a:pPr algn="l"/>
+            <a:r>
+              <a:rPr sz="900" b="0">
+                <a:solidFill>
+                  <a:srgbClr val="222222"/>
+                </a:solidFill>
+                <a:latin typeface="Meiryo"/>
+              </a:rPr>
+              <a:t>IPアドレスが被害者企業と異なる
+→ 銀行側で「いつもと違う場所」と検知される可能性</a:t>
+            </a:r>
+          </a:p>
+        </p:txBody>
+      </p:sp>
+      <p:sp>
+        <p:nvSpPr>
+          <p:cNvPr id="5" name="Rectangle 4"/>
+          <p:cNvSpPr/>
+          <p:nvPr/>
+        </p:nvSpPr>
+        <p:spPr>
+          <a:xfrm>
+            <a:off x="7772400" y="777240"/>
+            <a:ext cx="6400800" cy="365760"/>
+          </a:xfrm>
+          <a:prstGeom prst="rect">
+            <a:avLst/>
+          </a:prstGeom>
+          <a:solidFill>
+            <a:srgbClr val="222222"/>
+          </a:solidFill>
+          <a:ln>
+            <a:noFill/>
+          </a:ln>
+        </p:spPr>
+        <p:style>
+          <a:lnRef idx="1">
+            <a:schemeClr val="accent1"/>
+          </a:lnRef>
+          <a:fillRef idx="3">
+            <a:schemeClr val="accent1"/>
+          </a:fillRef>
+          <a:effectRef idx="2">
+            <a:schemeClr val="accent1"/>
+          </a:effectRef>
+          <a:fontRef idx="minor">
+            <a:schemeClr val="lt1"/>
+          </a:fontRef>
+        </p:style>
+        <p:txBody>
+          <a:bodyPr rtlCol="0" anchor="ctr" wrap="square" lIns="50800" rIns="50800" tIns="25400" bIns="25400"/>
+          <a:lstStyle/>
+          <a:p>
+            <a:pPr algn="ctr"/>
+            <a:r>
+              <a:rPr sz="1000" b="1">
+                <a:solidFill>
+                  <a:srgbClr val="FFFFFF"/>
+                </a:solidFill>
+                <a:latin typeface="Meiryo"/>
+              </a:rPr>
+              <a:t>被害者のPC経由でアクセスした場合</a:t>
+            </a:r>
+          </a:p>
+        </p:txBody>
+      </p:sp>
+      <p:sp>
+        <p:nvSpPr>
+          <p:cNvPr id="6" name="Rectangle 5"/>
+          <p:cNvSpPr/>
+          <p:nvPr/>
+        </p:nvSpPr>
+        <p:spPr>
+          <a:xfrm>
+            <a:off x="7772400" y="1143000"/>
+            <a:ext cx="6400800" cy="502920"/>
+          </a:xfrm>
+          <a:prstGeom prst="rect">
+            <a:avLst/>
+          </a:prstGeom>
+          <a:solidFill>
+            <a:srgbClr val="FFFFFF"/>
+          </a:solidFill>
+          <a:ln w="25400">
+            <a:solidFill>
+              <a:srgbClr val="222222"/>
+            </a:solidFill>
+          </a:ln>
+        </p:spPr>
+        <p:style>
+          <a:lnRef idx="1">
+            <a:schemeClr val="accent1"/>
+          </a:lnRef>
+          <a:fillRef idx="3">
+            <a:schemeClr val="accent1"/>
+          </a:fillRef>
+          <a:effectRef idx="2">
+            <a:schemeClr val="accent1"/>
+          </a:effectRef>
+          <a:fontRef idx="minor">
+            <a:schemeClr val="lt1"/>
+          </a:fontRef>
+        </p:style>
+        <p:txBody>
+          <a:bodyPr rtlCol="0" anchor="ctr" wrap="square" lIns="63500" rIns="50800" tIns="38100" bIns="38100"/>
+          <a:lstStyle/>
+          <a:p>
+            <a:pPr algn="l"/>
+            <a:r>
+              <a:rPr sz="900" b="0">
+                <a:solidFill>
+                  <a:srgbClr val="222222"/>
+                </a:solidFill>
+                <a:latin typeface="Meiryo"/>
+              </a:rPr>
+              <a:t>IPアドレスは被害者企業のもの
+→ 銀行から見ると「いつもの場所からのアクセス」</a:t>
+            </a:r>
+          </a:p>
+        </p:txBody>
+      </p:sp>
+      <p:sp>
+        <p:nvSpPr>
+          <p:cNvPr id="7" name="Rectangle 6"/>
+          <p:cNvSpPr/>
+          <p:nvPr/>
+        </p:nvSpPr>
+        <p:spPr>
+          <a:xfrm>
+            <a:off x="731520" y="1874519"/>
+            <a:ext cx="13624560" cy="365760"/>
+          </a:xfrm>
+          <a:prstGeom prst="rect">
+            <a:avLst/>
+          </a:prstGeom>
+          <a:solidFill>
+            <a:srgbClr val="222222"/>
+          </a:solidFill>
+          <a:ln>
+            <a:noFill/>
+          </a:ln>
+        </p:spPr>
+        <p:style>
+          <a:lnRef idx="1">
+            <a:schemeClr val="accent1"/>
+          </a:lnRef>
+          <a:fillRef idx="3">
+            <a:schemeClr val="accent1"/>
+          </a:fillRef>
+          <a:effectRef idx="2">
+            <a:schemeClr val="accent1"/>
+          </a:effectRef>
+          <a:fontRef idx="minor">
+            <a:schemeClr val="lt1"/>
+          </a:fontRef>
+        </p:style>
+        <p:txBody>
+          <a:bodyPr rtlCol="0" anchor="ctr" wrap="square" lIns="50800" rIns="50800" tIns="25400" bIns="25400"/>
+          <a:lstStyle/>
+          <a:p>
+            <a:pPr algn="ctr"/>
+            <a:r>
+              <a:rPr sz="1200" b="1">
+                <a:solidFill>
+                  <a:srgbClr val="FFFFFF"/>
+                </a:solidFill>
+                <a:latin typeface="Meiryo"/>
+              </a:rPr>
+              <a:t>銀行側の振る舞い検知 — すり抜ける項目と検知できる項目</a:t>
+            </a:r>
+          </a:p>
+        </p:txBody>
+      </p:sp>
+      <p:sp>
+        <p:nvSpPr>
+          <p:cNvPr id="8" name="Rectangle 7"/>
+          <p:cNvSpPr/>
+          <p:nvPr/>
+        </p:nvSpPr>
+        <p:spPr>
+          <a:xfrm>
+            <a:off x="731520" y="2240279"/>
+            <a:ext cx="2286000" cy="347472"/>
+          </a:xfrm>
+          <a:prstGeom prst="rect">
+            <a:avLst/>
+          </a:prstGeom>
+          <a:solidFill>
+            <a:srgbClr val="34495E"/>
+          </a:solidFill>
+          <a:ln>
+            <a:noFill/>
+          </a:ln>
+        </p:spPr>
+        <p:style>
+          <a:lnRef idx="1">
+            <a:schemeClr val="accent1"/>
+          </a:lnRef>
+          <a:fillRef idx="3">
+            <a:schemeClr val="accent1"/>
+          </a:fillRef>
+          <a:effectRef idx="2">
+            <a:schemeClr val="accent1"/>
+          </a:effectRef>
+          <a:fontRef idx="minor">
+            <a:schemeClr val="lt1"/>
+          </a:fontRef>
+        </p:style>
+        <p:txBody>
+          <a:bodyPr rtlCol="0" anchor="ctr" wrap="square" lIns="50800" rIns="50800" tIns="25400" bIns="25400"/>
+          <a:lstStyle/>
+          <a:p>
+            <a:pPr algn="ctr"/>
+            <a:r>
+              <a:rPr sz="900" b="1">
+                <a:solidFill>
+                  <a:srgbClr val="FFFFFF"/>
+                </a:solidFill>
+                <a:latin typeface="Meiryo"/>
+              </a:rPr>
+              <a:t>検知項目</a:t>
+            </a:r>
+          </a:p>
+        </p:txBody>
+      </p:sp>
+      <p:sp>
+        <p:nvSpPr>
+          <p:cNvPr id="9" name="Rectangle 8"/>
+          <p:cNvSpPr/>
+          <p:nvPr/>
+        </p:nvSpPr>
+        <p:spPr>
+          <a:xfrm>
+            <a:off x="3017520" y="2240279"/>
+            <a:ext cx="2743200" cy="347472"/>
+          </a:xfrm>
+          <a:prstGeom prst="rect">
+            <a:avLst/>
+          </a:prstGeom>
+          <a:solidFill>
+            <a:srgbClr val="34495E"/>
+          </a:solidFill>
+          <a:ln>
+            <a:noFill/>
+          </a:ln>
+        </p:spPr>
+        <p:style>
+          <a:lnRef idx="1">
+            <a:schemeClr val="accent1"/>
+          </a:lnRef>
+          <a:fillRef idx="3">
+            <a:schemeClr val="accent1"/>
+          </a:fillRef>
+          <a:effectRef idx="2">
+            <a:schemeClr val="accent1"/>
+          </a:effectRef>
+          <a:fontRef idx="minor">
+            <a:schemeClr val="lt1"/>
+          </a:fontRef>
+        </p:style>
+        <p:txBody>
+          <a:bodyPr rtlCol="0" anchor="ctr" wrap="square" lIns="50800" rIns="50800" tIns="25400" bIns="25400"/>
+          <a:lstStyle/>
+          <a:p>
+            <a:pPr algn="ctr"/>
+            <a:r>
+              <a:rPr sz="900" b="1">
+                <a:solidFill>
+                  <a:srgbClr val="FFFFFF"/>
+                </a:solidFill>
+                <a:latin typeface="Meiryo"/>
+              </a:rPr>
+              <a:t>正常</a:t>
+            </a:r>
+          </a:p>
+        </p:txBody>
+      </p:sp>
+      <p:sp>
+        <p:nvSpPr>
+          <p:cNvPr id="10" name="Rectangle 9"/>
+          <p:cNvSpPr/>
+          <p:nvPr/>
+        </p:nvSpPr>
+        <p:spPr>
+          <a:xfrm>
+            <a:off x="5760720" y="2240279"/>
+            <a:ext cx="3200400" cy="347472"/>
+          </a:xfrm>
+          <a:prstGeom prst="rect">
+            <a:avLst/>
+          </a:prstGeom>
+          <a:solidFill>
+            <a:srgbClr val="34495E"/>
+          </a:solidFill>
+          <a:ln>
+            <a:noFill/>
+          </a:ln>
+        </p:spPr>
+        <p:style>
+          <a:lnRef idx="1">
+            <a:schemeClr val="accent1"/>
+          </a:lnRef>
+          <a:fillRef idx="3">
+            <a:schemeClr val="accent1"/>
+          </a:fillRef>
+          <a:effectRef idx="2">
+            <a:schemeClr val="accent1"/>
+          </a:effectRef>
+          <a:fontRef idx="minor">
+            <a:schemeClr val="lt1"/>
+          </a:fontRef>
+        </p:style>
+        <p:txBody>
+          <a:bodyPr rtlCol="0" anchor="ctr" wrap="square" lIns="50800" rIns="50800" tIns="25400" bIns="25400"/>
+          <a:lstStyle/>
+          <a:p>
+            <a:pPr algn="ctr"/>
+            <a:r>
+              <a:rPr sz="900" b="1">
+                <a:solidFill>
+                  <a:srgbClr val="FFFFFF"/>
+                </a:solidFill>
+                <a:latin typeface="Meiryo"/>
+              </a:rPr>
+              <a:t>この攻撃</a:t>
+            </a:r>
+          </a:p>
+        </p:txBody>
+      </p:sp>
+      <p:sp>
+        <p:nvSpPr>
+          <p:cNvPr id="11" name="Rectangle 10"/>
+          <p:cNvSpPr/>
+          <p:nvPr/>
+        </p:nvSpPr>
+        <p:spPr>
+          <a:xfrm>
+            <a:off x="8961120" y="2240279"/>
+            <a:ext cx="2743200" cy="347472"/>
+          </a:xfrm>
+          <a:prstGeom prst="rect">
+            <a:avLst/>
+          </a:prstGeom>
+          <a:solidFill>
+            <a:srgbClr val="34495E"/>
+          </a:solidFill>
+          <a:ln>
+            <a:noFill/>
+          </a:ln>
+        </p:spPr>
+        <p:style>
+          <a:lnRef idx="1">
+            <a:schemeClr val="accent1"/>
+          </a:lnRef>
+          <a:fillRef idx="3">
+            <a:schemeClr val="accent1"/>
+          </a:fillRef>
+          <a:effectRef idx="2">
+            <a:schemeClr val="accent1"/>
+          </a:effectRef>
+          <a:fontRef idx="minor">
+            <a:schemeClr val="lt1"/>
+          </a:fontRef>
+        </p:style>
+        <p:txBody>
+          <a:bodyPr rtlCol="0" anchor="ctr" wrap="square" lIns="50800" rIns="50800" tIns="25400" bIns="25400"/>
+          <a:lstStyle/>
+          <a:p>
+            <a:pPr algn="ctr"/>
+            <a:r>
+              <a:rPr sz="900" b="1">
+                <a:solidFill>
+                  <a:srgbClr val="FFFFFF"/>
+                </a:solidFill>
+                <a:latin typeface="Meiryo"/>
+              </a:rPr>
+              <a:t>結果</a:t>
+            </a:r>
+          </a:p>
+        </p:txBody>
+      </p:sp>
+      <p:sp>
+        <p:nvSpPr>
+          <p:cNvPr id="12" name="Rectangle 11"/>
+          <p:cNvSpPr/>
+          <p:nvPr/>
+        </p:nvSpPr>
+        <p:spPr>
+          <a:xfrm>
+            <a:off x="11704320" y="2240279"/>
+            <a:ext cx="2651760" cy="347472"/>
+          </a:xfrm>
+          <a:prstGeom prst="rect">
+            <a:avLst/>
+          </a:prstGeom>
+          <a:solidFill>
+            <a:srgbClr val="34495E"/>
+          </a:solidFill>
+          <a:ln>
+            <a:noFill/>
+          </a:ln>
+        </p:spPr>
+        <p:style>
+          <a:lnRef idx="1">
+            <a:schemeClr val="accent1"/>
+          </a:lnRef>
+          <a:fillRef idx="3">
+            <a:schemeClr val="accent1"/>
+          </a:fillRef>
+          <a:effectRef idx="2">
+            <a:schemeClr val="accent1"/>
+          </a:effectRef>
+          <a:fontRef idx="minor">
+            <a:schemeClr val="lt1"/>
+          </a:fontRef>
+        </p:style>
+        <p:txBody>
+          <a:bodyPr rtlCol="0" anchor="ctr" wrap="square" lIns="50800" rIns="50800" tIns="25400" bIns="25400"/>
+          <a:lstStyle/>
+          <a:p>
+            <a:pPr algn="ctr"/>
+            <a:r>
+              <a:rPr sz="900" b="1">
+                <a:solidFill>
+                  <a:srgbClr val="FFFFFF"/>
+                </a:solidFill>
+                <a:latin typeface="Meiryo"/>
+              </a:rPr>
+              <a:t/>
+            </a:r>
+          </a:p>
+        </p:txBody>
+      </p:sp>
+      <p:sp>
+        <p:nvSpPr>
+          <p:cNvPr id="13" name="Rectangle 12"/>
+          <p:cNvSpPr/>
+          <p:nvPr/>
+        </p:nvSpPr>
+        <p:spPr>
+          <a:xfrm>
+            <a:off x="731520" y="2587752"/>
+            <a:ext cx="2286000" cy="365760"/>
+          </a:xfrm>
+          <a:prstGeom prst="rect">
+            <a:avLst/>
+          </a:prstGeom>
+          <a:solidFill>
+            <a:srgbClr val="FFFFFF"/>
+          </a:solidFill>
+          <a:ln w="25400">
+            <a:solidFill>
+              <a:srgbClr val="CCCCCC"/>
+            </a:solidFill>
+          </a:ln>
+        </p:spPr>
+        <p:style>
+          <a:lnRef idx="1">
+            <a:schemeClr val="accent1"/>
+          </a:lnRef>
+          <a:fillRef idx="3">
+            <a:schemeClr val="accent1"/>
+          </a:fillRef>
+          <a:effectRef idx="2">
+            <a:schemeClr val="accent1"/>
+          </a:effectRef>
+          <a:fontRef idx="minor">
+            <a:schemeClr val="lt1"/>
+          </a:fontRef>
+        </p:style>
+        <p:txBody>
+          <a:bodyPr rtlCol="0" anchor="ctr" wrap="square" lIns="63500" rIns="50800" tIns="38100" bIns="38100"/>
+          <a:lstStyle/>
+          <a:p>
+            <a:pPr algn="l"/>
+            <a:r>
+              <a:rPr sz="900" b="1">
+                <a:solidFill>
+                  <a:srgbClr val="222222"/>
+                </a:solidFill>
+                <a:latin typeface="Meiryo"/>
+              </a:rPr>
+              <a:t>IPアドレス</a:t>
+            </a:r>
+          </a:p>
+        </p:txBody>
+      </p:sp>
+      <p:sp>
+        <p:nvSpPr>
+          <p:cNvPr id="14" name="Rectangle 13"/>
+          <p:cNvSpPr/>
+          <p:nvPr/>
+        </p:nvSpPr>
+        <p:spPr>
+          <a:xfrm>
+            <a:off x="3017520" y="2587752"/>
+            <a:ext cx="2743200" cy="365760"/>
+          </a:xfrm>
+          <a:prstGeom prst="rect">
+            <a:avLst/>
+          </a:prstGeom>
+          <a:solidFill>
+            <a:srgbClr val="FFFFFF"/>
+          </a:solidFill>
+          <a:ln w="25400">
+            <a:solidFill>
+              <a:srgbClr val="CCCCCC"/>
+            </a:solidFill>
+          </a:ln>
+        </p:spPr>
+        <p:style>
+          <a:lnRef idx="1">
+            <a:schemeClr val="accent1"/>
+          </a:lnRef>
+          <a:fillRef idx="3">
+            <a:schemeClr val="accent1"/>
+          </a:fillRef>
+          <a:effectRef idx="2">
+            <a:schemeClr val="accent1"/>
+          </a:effectRef>
+          <a:fontRef idx="minor">
+            <a:schemeClr val="lt1"/>
+          </a:fontRef>
+        </p:style>
+        <p:txBody>
+          <a:bodyPr rtlCol="0" anchor="ctr" wrap="square" lIns="63500" rIns="50800" tIns="38100" bIns="38100"/>
+          <a:lstStyle/>
+          <a:p>
+            <a:pPr algn="l"/>
+            <a:r>
+              <a:rPr sz="900" b="0">
+                <a:solidFill>
+                  <a:srgbClr val="222222"/>
+                </a:solidFill>
+                <a:latin typeface="Meiryo"/>
+              </a:rPr>
+              <a:t>いつもの場所</a:t>
+            </a:r>
+          </a:p>
+        </p:txBody>
+      </p:sp>
+      <p:sp>
+        <p:nvSpPr>
+          <p:cNvPr id="15" name="Rectangle 14"/>
+          <p:cNvSpPr/>
+          <p:nvPr/>
+        </p:nvSpPr>
+        <p:spPr>
+          <a:xfrm>
+            <a:off x="5760720" y="2587752"/>
+            <a:ext cx="3200400" cy="365760"/>
+          </a:xfrm>
+          <a:prstGeom prst="rect">
+            <a:avLst/>
+          </a:prstGeom>
+          <a:solidFill>
+            <a:srgbClr val="FFFFFF"/>
+          </a:solidFill>
+          <a:ln w="25400">
+            <a:solidFill>
+              <a:srgbClr val="CCCCCC"/>
+            </a:solidFill>
+          </a:ln>
+        </p:spPr>
+        <p:style>
+          <a:lnRef idx="1">
+            <a:schemeClr val="accent1"/>
+          </a:lnRef>
+          <a:fillRef idx="3">
+            <a:schemeClr val="accent1"/>
+          </a:fillRef>
+          <a:effectRef idx="2">
+            <a:schemeClr val="accent1"/>
+          </a:effectRef>
+          <a:fontRef idx="minor">
+            <a:schemeClr val="lt1"/>
+          </a:fontRef>
+        </p:style>
+        <p:txBody>
+          <a:bodyPr rtlCol="0" anchor="ctr" wrap="square" lIns="63500" rIns="50800" tIns="38100" bIns="38100"/>
+          <a:lstStyle/>
+          <a:p>
+            <a:pPr algn="l"/>
+            <a:r>
+              <a:rPr sz="900" b="0">
+                <a:solidFill>
+                  <a:srgbClr val="222222"/>
+                </a:solidFill>
+                <a:latin typeface="Meiryo"/>
+              </a:rPr>
+              <a:t>いつもの場所（PC経由）</a:t>
+            </a:r>
+          </a:p>
+        </p:txBody>
+      </p:sp>
+      <p:sp>
+        <p:nvSpPr>
+          <p:cNvPr id="16" name="Rectangle 15"/>
+          <p:cNvSpPr/>
+          <p:nvPr/>
+        </p:nvSpPr>
+        <p:spPr>
+          <a:xfrm>
+            <a:off x="8961120" y="2587752"/>
+            <a:ext cx="5394960" cy="365760"/>
+          </a:xfrm>
+          <a:prstGeom prst="rect">
+            <a:avLst/>
+          </a:prstGeom>
+          <a:solidFill>
+            <a:srgbClr val="FDEDEC"/>
+          </a:solidFill>
+          <a:ln>
+            <a:noFill/>
+          </a:ln>
+        </p:spPr>
+        <p:style>
+          <a:lnRef idx="1">
+            <a:schemeClr val="accent1"/>
+          </a:lnRef>
+          <a:fillRef idx="3">
+            <a:schemeClr val="accent1"/>
+          </a:fillRef>
+          <a:effectRef idx="2">
+            <a:schemeClr val="accent1"/>
+          </a:effectRef>
+          <a:fontRef idx="minor">
+            <a:schemeClr val="lt1"/>
+          </a:fontRef>
+        </p:style>
+        <p:txBody>
+          <a:bodyPr rtlCol="0" anchor="ctr" wrap="square" lIns="50800" rIns="50800" tIns="25400" bIns="25400"/>
+          <a:lstStyle/>
+          <a:p>
+            <a:pPr algn="ctr"/>
+            <a:r>
+              <a:rPr sz="900" b="1">
+                <a:solidFill>
+                  <a:srgbClr val="C0392B"/>
+                </a:solidFill>
+                <a:latin typeface="Meiryo"/>
+              </a:rPr>
+              <a:t>すり抜ける</a:t>
+            </a:r>
+          </a:p>
+        </p:txBody>
+      </p:sp>
+      <p:sp>
+        <p:nvSpPr>
+          <p:cNvPr id="17" name="Rectangle 16"/>
+          <p:cNvSpPr/>
+          <p:nvPr/>
+        </p:nvSpPr>
+        <p:spPr>
+          <a:xfrm>
+            <a:off x="731520" y="2953512"/>
+            <a:ext cx="2286000" cy="365760"/>
+          </a:xfrm>
+          <a:prstGeom prst="rect">
+            <a:avLst/>
+          </a:prstGeom>
+          <a:solidFill>
+            <a:srgbClr val="F9F9F9"/>
+          </a:solidFill>
+          <a:ln w="25400">
+            <a:solidFill>
+              <a:srgbClr val="CCCCCC"/>
+            </a:solidFill>
+          </a:ln>
+        </p:spPr>
+        <p:style>
+          <a:lnRef idx="1">
+            <a:schemeClr val="accent1"/>
+          </a:lnRef>
+          <a:fillRef idx="3">
+            <a:schemeClr val="accent1"/>
+          </a:fillRef>
+          <a:effectRef idx="2">
+            <a:schemeClr val="accent1"/>
+          </a:effectRef>
+          <a:fontRef idx="minor">
+            <a:schemeClr val="lt1"/>
+          </a:fontRef>
+        </p:style>
+        <p:txBody>
+          <a:bodyPr rtlCol="0" anchor="ctr" wrap="square" lIns="63500" rIns="50800" tIns="38100" bIns="38100"/>
+          <a:lstStyle/>
+          <a:p>
+            <a:pPr algn="l"/>
+            <a:r>
+              <a:rPr sz="900" b="1">
+                <a:solidFill>
+                  <a:srgbClr val="222222"/>
+                </a:solidFill>
+                <a:latin typeface="Meiryo"/>
+              </a:rPr>
+              <a:t>時間帯</a:t>
+            </a:r>
+          </a:p>
+        </p:txBody>
+      </p:sp>
+      <p:sp>
+        <p:nvSpPr>
+          <p:cNvPr id="18" name="Rectangle 17"/>
+          <p:cNvSpPr/>
+          <p:nvPr/>
+        </p:nvSpPr>
+        <p:spPr>
+          <a:xfrm>
+            <a:off x="3017520" y="2953512"/>
+            <a:ext cx="2743200" cy="365760"/>
+          </a:xfrm>
+          <a:prstGeom prst="rect">
+            <a:avLst/>
+          </a:prstGeom>
+          <a:solidFill>
+            <a:srgbClr val="F9F9F9"/>
+          </a:solidFill>
+          <a:ln w="25400">
+            <a:solidFill>
+              <a:srgbClr val="CCCCCC"/>
+            </a:solidFill>
+          </a:ln>
+        </p:spPr>
+        <p:style>
+          <a:lnRef idx="1">
+            <a:schemeClr val="accent1"/>
+          </a:lnRef>
+          <a:fillRef idx="3">
+            <a:schemeClr val="accent1"/>
+          </a:fillRef>
+          <a:effectRef idx="2">
+            <a:schemeClr val="accent1"/>
+          </a:effectRef>
+          <a:fontRef idx="minor">
+            <a:schemeClr val="lt1"/>
+          </a:fontRef>
+        </p:style>
+        <p:txBody>
+          <a:bodyPr rtlCol="0" anchor="ctr" wrap="square" lIns="63500" rIns="50800" tIns="38100" bIns="38100"/>
+          <a:lstStyle/>
+          <a:p>
+            <a:pPr algn="l"/>
+            <a:r>
+              <a:rPr sz="900" b="0">
+                <a:solidFill>
+                  <a:srgbClr val="222222"/>
+                </a:solidFill>
+                <a:latin typeface="Meiryo"/>
+              </a:rPr>
+              <a:t>業務時間内</a:t>
+            </a:r>
+          </a:p>
+        </p:txBody>
+      </p:sp>
+      <p:sp>
+        <p:nvSpPr>
+          <p:cNvPr id="19" name="Rectangle 18"/>
+          <p:cNvSpPr/>
+          <p:nvPr/>
+        </p:nvSpPr>
+        <p:spPr>
+          <a:xfrm>
+            <a:off x="5760720" y="2953512"/>
+            <a:ext cx="3200400" cy="365760"/>
+          </a:xfrm>
+          <a:prstGeom prst="rect">
+            <a:avLst/>
+          </a:prstGeom>
+          <a:solidFill>
+            <a:srgbClr val="F9F9F9"/>
+          </a:solidFill>
+          <a:ln w="25400">
+            <a:solidFill>
+              <a:srgbClr val="CCCCCC"/>
+            </a:solidFill>
+          </a:ln>
+        </p:spPr>
+        <p:style>
+          <a:lnRef idx="1">
+            <a:schemeClr val="accent1"/>
+          </a:lnRef>
+          <a:fillRef idx="3">
+            <a:schemeClr val="accent1"/>
+          </a:fillRef>
+          <a:effectRef idx="2">
+            <a:schemeClr val="accent1"/>
+          </a:effectRef>
+          <a:fontRef idx="minor">
+            <a:schemeClr val="lt1"/>
+          </a:fontRef>
+        </p:style>
+        <p:txBody>
+          <a:bodyPr rtlCol="0" anchor="ctr" wrap="square" lIns="63500" rIns="50800" tIns="38100" bIns="38100"/>
+          <a:lstStyle/>
+          <a:p>
+            <a:pPr algn="l"/>
+            <a:r>
+              <a:rPr sz="900" b="0">
+                <a:solidFill>
+                  <a:srgbClr val="222222"/>
+                </a:solidFill>
+                <a:latin typeface="Meiryo"/>
+              </a:rPr>
+              <a:t>業務時間内（電話中）</a:t>
+            </a:r>
+          </a:p>
+        </p:txBody>
+      </p:sp>
+      <p:sp>
+        <p:nvSpPr>
+          <p:cNvPr id="20" name="Rectangle 19"/>
+          <p:cNvSpPr/>
+          <p:nvPr/>
+        </p:nvSpPr>
+        <p:spPr>
+          <a:xfrm>
+            <a:off x="8961120" y="2953512"/>
+            <a:ext cx="5394960" cy="365760"/>
+          </a:xfrm>
+          <a:prstGeom prst="rect">
+            <a:avLst/>
+          </a:prstGeom>
+          <a:solidFill>
+            <a:srgbClr val="FDEDEC"/>
+          </a:solidFill>
+          <a:ln>
+            <a:noFill/>
+          </a:ln>
+        </p:spPr>
+        <p:style>
+          <a:lnRef idx="1">
+            <a:schemeClr val="accent1"/>
+          </a:lnRef>
+          <a:fillRef idx="3">
+            <a:schemeClr val="accent1"/>
+          </a:fillRef>
+          <a:effectRef idx="2">
+            <a:schemeClr val="accent1"/>
+          </a:effectRef>
+          <a:fontRef idx="minor">
+            <a:schemeClr val="lt1"/>
+          </a:fontRef>
+        </p:style>
+        <p:txBody>
+          <a:bodyPr rtlCol="0" anchor="ctr" wrap="square" lIns="50800" rIns="50800" tIns="25400" bIns="25400"/>
+          <a:lstStyle/>
+          <a:p>
+            <a:pPr algn="ctr"/>
+            <a:r>
+              <a:rPr sz="900" b="1">
+                <a:solidFill>
+                  <a:srgbClr val="C0392B"/>
+                </a:solidFill>
+                <a:latin typeface="Meiryo"/>
+              </a:rPr>
+              <a:t>すり抜ける</a:t>
+            </a:r>
+          </a:p>
+        </p:txBody>
+      </p:sp>
+      <p:sp>
+        <p:nvSpPr>
+          <p:cNvPr id="21" name="Rectangle 20"/>
+          <p:cNvSpPr/>
+          <p:nvPr/>
+        </p:nvSpPr>
+        <p:spPr>
+          <a:xfrm>
+            <a:off x="731520" y="3319272"/>
+            <a:ext cx="2286000" cy="365760"/>
+          </a:xfrm>
+          <a:prstGeom prst="rect">
+            <a:avLst/>
+          </a:prstGeom>
+          <a:solidFill>
+            <a:srgbClr val="FFFFFF"/>
+          </a:solidFill>
+          <a:ln w="25400">
+            <a:solidFill>
+              <a:srgbClr val="CCCCCC"/>
+            </a:solidFill>
+          </a:ln>
+        </p:spPr>
+        <p:style>
+          <a:lnRef idx="1">
+            <a:schemeClr val="accent1"/>
+          </a:lnRef>
+          <a:fillRef idx="3">
+            <a:schemeClr val="accent1"/>
+          </a:fillRef>
+          <a:effectRef idx="2">
+            <a:schemeClr val="accent1"/>
+          </a:effectRef>
+          <a:fontRef idx="minor">
+            <a:schemeClr val="lt1"/>
+          </a:fontRef>
+        </p:style>
+        <p:txBody>
+          <a:bodyPr rtlCol="0" anchor="ctr" wrap="square" lIns="63500" rIns="50800" tIns="38100" bIns="38100"/>
+          <a:lstStyle/>
+          <a:p>
+            <a:pPr algn="l"/>
+            <a:r>
+              <a:rPr sz="900" b="1">
+                <a:solidFill>
+                  <a:srgbClr val="222222"/>
+                </a:solidFill>
+                <a:latin typeface="Meiryo"/>
+              </a:rPr>
+              <a:t>送金先口座</a:t>
+            </a:r>
+          </a:p>
+        </p:txBody>
+      </p:sp>
+      <p:sp>
+        <p:nvSpPr>
+          <p:cNvPr id="22" name="Rectangle 21"/>
+          <p:cNvSpPr/>
+          <p:nvPr/>
+        </p:nvSpPr>
+        <p:spPr>
+          <a:xfrm>
+            <a:off x="3017520" y="3319272"/>
+            <a:ext cx="2743200" cy="365760"/>
+          </a:xfrm>
+          <a:prstGeom prst="rect">
+            <a:avLst/>
+          </a:prstGeom>
+          <a:solidFill>
+            <a:srgbClr val="FFFFFF"/>
+          </a:solidFill>
+          <a:ln w="25400">
+            <a:solidFill>
+              <a:srgbClr val="CCCCCC"/>
+            </a:solidFill>
+          </a:ln>
+        </p:spPr>
+        <p:style>
+          <a:lnRef idx="1">
+            <a:schemeClr val="accent1"/>
+          </a:lnRef>
+          <a:fillRef idx="3">
+            <a:schemeClr val="accent1"/>
+          </a:fillRef>
+          <a:effectRef idx="2">
+            <a:schemeClr val="accent1"/>
+          </a:effectRef>
+          <a:fontRef idx="minor">
+            <a:schemeClr val="lt1"/>
+          </a:fontRef>
+        </p:style>
+        <p:txBody>
+          <a:bodyPr rtlCol="0" anchor="ctr" wrap="square" lIns="63500" rIns="50800" tIns="38100" bIns="38100"/>
+          <a:lstStyle/>
+          <a:p>
+            <a:pPr algn="l"/>
+            <a:r>
+              <a:rPr sz="900" b="0">
+                <a:solidFill>
+                  <a:srgbClr val="222222"/>
+                </a:solidFill>
+                <a:latin typeface="Meiryo"/>
+              </a:rPr>
+              <a:t>取引先</a:t>
+            </a:r>
+          </a:p>
+        </p:txBody>
+      </p:sp>
+      <p:sp>
+        <p:nvSpPr>
+          <p:cNvPr id="23" name="Rectangle 22"/>
+          <p:cNvSpPr/>
+          <p:nvPr/>
+        </p:nvSpPr>
+        <p:spPr>
+          <a:xfrm>
+            <a:off x="5760720" y="3319272"/>
+            <a:ext cx="3200400" cy="365760"/>
+          </a:xfrm>
+          <a:prstGeom prst="rect">
+            <a:avLst/>
+          </a:prstGeom>
+          <a:solidFill>
+            <a:srgbClr val="FFFFFF"/>
+          </a:solidFill>
+          <a:ln w="25400">
+            <a:solidFill>
+              <a:srgbClr val="CCCCCC"/>
+            </a:solidFill>
+          </a:ln>
+        </p:spPr>
+        <p:style>
+          <a:lnRef idx="1">
+            <a:schemeClr val="accent1"/>
+          </a:lnRef>
+          <a:fillRef idx="3">
+            <a:schemeClr val="accent1"/>
+          </a:fillRef>
+          <a:effectRef idx="2">
+            <a:schemeClr val="accent1"/>
+          </a:effectRef>
+          <a:fontRef idx="minor">
+            <a:schemeClr val="lt1"/>
+          </a:fontRef>
+        </p:style>
+        <p:txBody>
+          <a:bodyPr rtlCol="0" anchor="ctr" wrap="square" lIns="63500" rIns="50800" tIns="38100" bIns="38100"/>
+          <a:lstStyle/>
+          <a:p>
+            <a:pPr algn="l"/>
+            <a:r>
+              <a:rPr sz="900" b="0">
+                <a:solidFill>
+                  <a:srgbClr val="222222"/>
+                </a:solidFill>
+                <a:latin typeface="Meiryo"/>
+              </a:rPr>
+              <a:t>初めての口座</a:t>
+            </a:r>
+          </a:p>
+        </p:txBody>
+      </p:sp>
+      <p:sp>
+        <p:nvSpPr>
+          <p:cNvPr id="24" name="Rectangle 23"/>
+          <p:cNvSpPr/>
+          <p:nvPr/>
+        </p:nvSpPr>
+        <p:spPr>
+          <a:xfrm>
+            <a:off x="8961120" y="3319272"/>
+            <a:ext cx="5394960" cy="365760"/>
+          </a:xfrm>
+          <a:prstGeom prst="rect">
+            <a:avLst/>
+          </a:prstGeom>
+          <a:solidFill>
+            <a:srgbClr val="EAFAF1"/>
+          </a:solidFill>
+          <a:ln>
+            <a:noFill/>
+          </a:ln>
+        </p:spPr>
+        <p:style>
+          <a:lnRef idx="1">
+            <a:schemeClr val="accent1"/>
+          </a:lnRef>
+          <a:fillRef idx="3">
+            <a:schemeClr val="accent1"/>
+          </a:fillRef>
+          <a:effectRef idx="2">
+            <a:schemeClr val="accent1"/>
+          </a:effectRef>
+          <a:fontRef idx="minor">
+            <a:schemeClr val="lt1"/>
+          </a:fontRef>
+        </p:style>
+        <p:txBody>
+          <a:bodyPr rtlCol="0" anchor="ctr" wrap="square" lIns="50800" rIns="50800" tIns="25400" bIns="25400"/>
+          <a:lstStyle/>
+          <a:p>
+            <a:pPr algn="ctr"/>
+            <a:r>
+              <a:rPr sz="900" b="1">
+                <a:solidFill>
+                  <a:srgbClr val="27AE60"/>
+                </a:solidFill>
+                <a:latin typeface="Meiryo"/>
+              </a:rPr>
+              <a:t>検知できる ★</a:t>
+            </a:r>
+          </a:p>
+        </p:txBody>
+      </p:sp>
+      <p:sp>
+        <p:nvSpPr>
+          <p:cNvPr id="25" name="Rectangle 24"/>
+          <p:cNvSpPr/>
+          <p:nvPr/>
+        </p:nvSpPr>
+        <p:spPr>
+          <a:xfrm>
+            <a:off x="731520" y="3685032"/>
+            <a:ext cx="2286000" cy="365760"/>
+          </a:xfrm>
+          <a:prstGeom prst="rect">
+            <a:avLst/>
+          </a:prstGeom>
+          <a:solidFill>
+            <a:srgbClr val="F9F9F9"/>
+          </a:solidFill>
+          <a:ln w="25400">
+            <a:solidFill>
+              <a:srgbClr val="CCCCCC"/>
+            </a:solidFill>
+          </a:ln>
+        </p:spPr>
+        <p:style>
+          <a:lnRef idx="1">
+            <a:schemeClr val="accent1"/>
+          </a:lnRef>
+          <a:fillRef idx="3">
+            <a:schemeClr val="accent1"/>
+          </a:fillRef>
+          <a:effectRef idx="2">
+            <a:schemeClr val="accent1"/>
+          </a:effectRef>
+          <a:fontRef idx="minor">
+            <a:schemeClr val="lt1"/>
+          </a:fontRef>
+        </p:style>
+        <p:txBody>
+          <a:bodyPr rtlCol="0" anchor="ctr" wrap="square" lIns="63500" rIns="50800" tIns="38100" bIns="38100"/>
+          <a:lstStyle/>
+          <a:p>
+            <a:pPr algn="l"/>
+            <a:r>
+              <a:rPr sz="900" b="1">
+                <a:solidFill>
+                  <a:srgbClr val="222222"/>
+                </a:solidFill>
+                <a:latin typeface="Meiryo"/>
+              </a:rPr>
+              <a:t>送金金額</a:t>
+            </a:r>
+          </a:p>
+        </p:txBody>
+      </p:sp>
+      <p:sp>
+        <p:nvSpPr>
+          <p:cNvPr id="26" name="Rectangle 25"/>
+          <p:cNvSpPr/>
+          <p:nvPr/>
+        </p:nvSpPr>
+        <p:spPr>
+          <a:xfrm>
+            <a:off x="3017520" y="3685032"/>
+            <a:ext cx="2743200" cy="365760"/>
+          </a:xfrm>
+          <a:prstGeom prst="rect">
+            <a:avLst/>
+          </a:prstGeom>
+          <a:solidFill>
+            <a:srgbClr val="F9F9F9"/>
+          </a:solidFill>
+          <a:ln w="25400">
+            <a:solidFill>
+              <a:srgbClr val="CCCCCC"/>
+            </a:solidFill>
+          </a:ln>
+        </p:spPr>
+        <p:style>
+          <a:lnRef idx="1">
+            <a:schemeClr val="accent1"/>
+          </a:lnRef>
+          <a:fillRef idx="3">
+            <a:schemeClr val="accent1"/>
+          </a:fillRef>
+          <a:effectRef idx="2">
+            <a:schemeClr val="accent1"/>
+          </a:effectRef>
+          <a:fontRef idx="minor">
+            <a:schemeClr val="lt1"/>
+          </a:fontRef>
+        </p:style>
+        <p:txBody>
+          <a:bodyPr rtlCol="0" anchor="ctr" wrap="square" lIns="63500" rIns="50800" tIns="38100" bIns="38100"/>
+          <a:lstStyle/>
+          <a:p>
+            <a:pPr algn="l"/>
+            <a:r>
+              <a:rPr sz="900" b="0">
+                <a:solidFill>
+                  <a:srgbClr val="222222"/>
+                </a:solidFill>
+                <a:latin typeface="Meiryo"/>
+              </a:rPr>
+              <a:t>通常範囲</a:t>
+            </a:r>
+          </a:p>
+        </p:txBody>
+      </p:sp>
+      <p:sp>
+        <p:nvSpPr>
+          <p:cNvPr id="27" name="Rectangle 26"/>
+          <p:cNvSpPr/>
+          <p:nvPr/>
+        </p:nvSpPr>
+        <p:spPr>
+          <a:xfrm>
+            <a:off x="5760720" y="3685032"/>
+            <a:ext cx="3200400" cy="365760"/>
+          </a:xfrm>
+          <a:prstGeom prst="rect">
+            <a:avLst/>
+          </a:prstGeom>
+          <a:solidFill>
+            <a:srgbClr val="F9F9F9"/>
+          </a:solidFill>
+          <a:ln w="25400">
+            <a:solidFill>
+              <a:srgbClr val="CCCCCC"/>
+            </a:solidFill>
+          </a:ln>
+        </p:spPr>
+        <p:style>
+          <a:lnRef idx="1">
+            <a:schemeClr val="accent1"/>
+          </a:lnRef>
+          <a:fillRef idx="3">
+            <a:schemeClr val="accent1"/>
+          </a:fillRef>
+          <a:effectRef idx="2">
+            <a:schemeClr val="accent1"/>
+          </a:effectRef>
+          <a:fontRef idx="minor">
+            <a:schemeClr val="lt1"/>
+          </a:fontRef>
+        </p:style>
+        <p:txBody>
+          <a:bodyPr rtlCol="0" anchor="ctr" wrap="square" lIns="63500" rIns="50800" tIns="38100" bIns="38100"/>
+          <a:lstStyle/>
+          <a:p>
+            <a:pPr algn="l"/>
+            <a:r>
+              <a:rPr sz="900" b="0">
+                <a:solidFill>
+                  <a:srgbClr val="222222"/>
+                </a:solidFill>
+                <a:latin typeface="Meiryo"/>
+              </a:rPr>
+              <a:t>通常より大きい可能性</a:t>
+            </a:r>
+          </a:p>
+        </p:txBody>
+      </p:sp>
+      <p:sp>
+        <p:nvSpPr>
+          <p:cNvPr id="28" name="Rectangle 27"/>
+          <p:cNvSpPr/>
+          <p:nvPr/>
+        </p:nvSpPr>
+        <p:spPr>
+          <a:xfrm>
+            <a:off x="8961120" y="3685032"/>
+            <a:ext cx="5394960" cy="365760"/>
+          </a:xfrm>
+          <a:prstGeom prst="rect">
+            <a:avLst/>
+          </a:prstGeom>
+          <a:solidFill>
+            <a:srgbClr val="EAFAF1"/>
+          </a:solidFill>
+          <a:ln>
+            <a:noFill/>
+          </a:ln>
+        </p:spPr>
+        <p:style>
+          <a:lnRef idx="1">
+            <a:schemeClr val="accent1"/>
+          </a:lnRef>
+          <a:fillRef idx="3">
+            <a:schemeClr val="accent1"/>
+          </a:fillRef>
+          <a:effectRef idx="2">
+            <a:schemeClr val="accent1"/>
+          </a:effectRef>
+          <a:fontRef idx="minor">
+            <a:schemeClr val="lt1"/>
+          </a:fontRef>
+        </p:style>
+        <p:txBody>
+          <a:bodyPr rtlCol="0" anchor="ctr" wrap="square" lIns="50800" rIns="50800" tIns="25400" bIns="25400"/>
+          <a:lstStyle/>
+          <a:p>
+            <a:pPr algn="ctr"/>
+            <a:r>
+              <a:rPr sz="900" b="1">
+                <a:solidFill>
+                  <a:srgbClr val="27AE60"/>
+                </a:solidFill>
+                <a:latin typeface="Meiryo"/>
+              </a:rPr>
+              <a:t>検知できる ★</a:t>
+            </a:r>
+          </a:p>
+        </p:txBody>
+      </p:sp>
+      <p:sp>
+        <p:nvSpPr>
+          <p:cNvPr id="29" name="Rectangle 28"/>
+          <p:cNvSpPr/>
+          <p:nvPr/>
+        </p:nvSpPr>
+        <p:spPr>
+          <a:xfrm>
+            <a:off x="731520" y="4050791"/>
+            <a:ext cx="2286000" cy="365760"/>
+          </a:xfrm>
+          <a:prstGeom prst="rect">
+            <a:avLst/>
+          </a:prstGeom>
+          <a:solidFill>
+            <a:srgbClr val="FFFFFF"/>
+          </a:solidFill>
+          <a:ln w="25400">
+            <a:solidFill>
+              <a:srgbClr val="CCCCCC"/>
+            </a:solidFill>
+          </a:ln>
+        </p:spPr>
+        <p:style>
+          <a:lnRef idx="1">
+            <a:schemeClr val="accent1"/>
+          </a:lnRef>
+          <a:fillRef idx="3">
+            <a:schemeClr val="accent1"/>
+          </a:fillRef>
+          <a:effectRef idx="2">
+            <a:schemeClr val="accent1"/>
+          </a:effectRef>
+          <a:fontRef idx="minor">
+            <a:schemeClr val="lt1"/>
+          </a:fontRef>
+        </p:style>
+        <p:txBody>
+          <a:bodyPr rtlCol="0" anchor="ctr" wrap="square" lIns="63500" rIns="50800" tIns="38100" bIns="38100"/>
+          <a:lstStyle/>
+          <a:p>
+            <a:pPr algn="l"/>
+            <a:r>
+              <a:rPr sz="900" b="1">
+                <a:solidFill>
+                  <a:srgbClr val="222222"/>
+                </a:solidFill>
+                <a:latin typeface="Meiryo"/>
+              </a:rPr>
+              <a:t>操作速度</a:t>
+            </a:r>
+          </a:p>
+        </p:txBody>
+      </p:sp>
+      <p:sp>
+        <p:nvSpPr>
+          <p:cNvPr id="30" name="Rectangle 29"/>
+          <p:cNvSpPr/>
+          <p:nvPr/>
+        </p:nvSpPr>
+        <p:spPr>
+          <a:xfrm>
+            <a:off x="3017520" y="4050791"/>
+            <a:ext cx="2743200" cy="365760"/>
+          </a:xfrm>
+          <a:prstGeom prst="rect">
+            <a:avLst/>
+          </a:prstGeom>
+          <a:solidFill>
+            <a:srgbClr val="FFFFFF"/>
+          </a:solidFill>
+          <a:ln w="25400">
+            <a:solidFill>
+              <a:srgbClr val="CCCCCC"/>
+            </a:solidFill>
+          </a:ln>
+        </p:spPr>
+        <p:style>
+          <a:lnRef idx="1">
+            <a:schemeClr val="accent1"/>
+          </a:lnRef>
+          <a:fillRef idx="3">
+            <a:schemeClr val="accent1"/>
+          </a:fillRef>
+          <a:effectRef idx="2">
+            <a:schemeClr val="accent1"/>
+          </a:effectRef>
+          <a:fontRef idx="minor">
+            <a:schemeClr val="lt1"/>
+          </a:fontRef>
+        </p:style>
+        <p:txBody>
+          <a:bodyPr rtlCol="0" anchor="ctr" wrap="square" lIns="63500" rIns="50800" tIns="38100" bIns="38100"/>
+          <a:lstStyle/>
+          <a:p>
+            <a:pPr algn="l"/>
+            <a:r>
+              <a:rPr sz="900" b="0">
+                <a:solidFill>
+                  <a:srgbClr val="222222"/>
+                </a:solidFill>
+                <a:latin typeface="Meiryo"/>
+              </a:rPr>
+              <a:t>人間の速度</a:t>
+            </a:r>
+          </a:p>
+        </p:txBody>
+      </p:sp>
+      <p:sp>
+        <p:nvSpPr>
+          <p:cNvPr id="31" name="Rectangle 30"/>
+          <p:cNvSpPr/>
+          <p:nvPr/>
+        </p:nvSpPr>
+        <p:spPr>
+          <a:xfrm>
+            <a:off x="5760720" y="4050791"/>
+            <a:ext cx="3200400" cy="365760"/>
+          </a:xfrm>
+          <a:prstGeom prst="rect">
+            <a:avLst/>
+          </a:prstGeom>
+          <a:solidFill>
+            <a:srgbClr val="FFFFFF"/>
+          </a:solidFill>
+          <a:ln w="25400">
+            <a:solidFill>
+              <a:srgbClr val="CCCCCC"/>
+            </a:solidFill>
+          </a:ln>
+        </p:spPr>
+        <p:style>
+          <a:lnRef idx="1">
+            <a:schemeClr val="accent1"/>
+          </a:lnRef>
+          <a:fillRef idx="3">
+            <a:schemeClr val="accent1"/>
+          </a:fillRef>
+          <a:effectRef idx="2">
+            <a:schemeClr val="accent1"/>
+          </a:effectRef>
+          <a:fontRef idx="minor">
+            <a:schemeClr val="lt1"/>
+          </a:fontRef>
+        </p:style>
+        <p:txBody>
+          <a:bodyPr rtlCol="0" anchor="ctr" wrap="square" lIns="63500" rIns="50800" tIns="38100" bIns="38100"/>
+          <a:lstStyle/>
+          <a:p>
+            <a:pPr algn="l"/>
+            <a:r>
+              <a:rPr sz="900" b="0">
+                <a:solidFill>
+                  <a:srgbClr val="222222"/>
+                </a:solidFill>
+                <a:latin typeface="Meiryo"/>
+              </a:rPr>
+              <a:t>異常に速い可能性</a:t>
+            </a:r>
+          </a:p>
+        </p:txBody>
+      </p:sp>
+      <p:sp>
+        <p:nvSpPr>
+          <p:cNvPr id="32" name="Rectangle 31"/>
+          <p:cNvSpPr/>
+          <p:nvPr/>
+        </p:nvSpPr>
+        <p:spPr>
+          <a:xfrm>
+            <a:off x="8961120" y="4050791"/>
+            <a:ext cx="5394960" cy="365760"/>
+          </a:xfrm>
+          <a:prstGeom prst="rect">
+            <a:avLst/>
+          </a:prstGeom>
+          <a:solidFill>
+            <a:srgbClr val="EAFAF1"/>
+          </a:solidFill>
+          <a:ln>
+            <a:noFill/>
+          </a:ln>
+        </p:spPr>
+        <p:style>
+          <a:lnRef idx="1">
+            <a:schemeClr val="accent1"/>
+          </a:lnRef>
+          <a:fillRef idx="3">
+            <a:schemeClr val="accent1"/>
+          </a:fillRef>
+          <a:effectRef idx="2">
+            <a:schemeClr val="accent1"/>
+          </a:effectRef>
+          <a:fontRef idx="minor">
+            <a:schemeClr val="lt1"/>
+          </a:fontRef>
+        </p:style>
+        <p:txBody>
+          <a:bodyPr rtlCol="0" anchor="ctr" wrap="square" lIns="50800" rIns="50800" tIns="25400" bIns="25400"/>
+          <a:lstStyle/>
+          <a:p>
+            <a:pPr algn="ctr"/>
+            <a:r>
+              <a:rPr sz="900" b="1">
+                <a:solidFill>
+                  <a:srgbClr val="27AE60"/>
+                </a:solidFill>
+                <a:latin typeface="Meiryo"/>
+              </a:rPr>
+              <a:t>検知できる ★</a:t>
+            </a:r>
+          </a:p>
+        </p:txBody>
+      </p:sp>
+      <p:sp>
+        <p:nvSpPr>
+          <p:cNvPr id="33" name="Rectangle 32"/>
+          <p:cNvSpPr/>
+          <p:nvPr/>
+        </p:nvSpPr>
+        <p:spPr>
+          <a:xfrm>
+            <a:off x="731520" y="4526279"/>
+            <a:ext cx="13624560" cy="365760"/>
+          </a:xfrm>
+          <a:prstGeom prst="rect">
+            <a:avLst/>
+          </a:prstGeom>
+          <a:solidFill>
+            <a:srgbClr val="E67E22"/>
+          </a:solidFill>
+          <a:ln>
+            <a:noFill/>
+          </a:ln>
+        </p:spPr>
+        <p:style>
+          <a:lnRef idx="1">
+            <a:schemeClr val="accent1"/>
+          </a:lnRef>
+          <a:fillRef idx="3">
+            <a:schemeClr val="accent1"/>
+          </a:fillRef>
+          <a:effectRef idx="2">
+            <a:schemeClr val="accent1"/>
+          </a:effectRef>
+          <a:fontRef idx="minor">
+            <a:schemeClr val="lt1"/>
+          </a:fontRef>
+        </p:style>
+        <p:txBody>
+          <a:bodyPr rtlCol="0" anchor="ctr" wrap="square" lIns="50800" rIns="50800" tIns="25400" bIns="25400"/>
+          <a:lstStyle/>
+          <a:p>
+            <a:pPr algn="ctr"/>
+            <a:r>
+              <a:rPr sz="1200" b="1">
+                <a:solidFill>
+                  <a:srgbClr val="FFFFFF"/>
+                </a:solidFill>
+                <a:latin typeface="Meiryo"/>
+              </a:rPr>
+              <a:t>銀行の追加認証（電話確認）すら機能しない</a:t>
+            </a:r>
+          </a:p>
+        </p:txBody>
+      </p:sp>
+      <p:sp>
+        <p:nvSpPr>
+          <p:cNvPr id="34" name="Rectangle 33"/>
+          <p:cNvSpPr/>
+          <p:nvPr/>
+        </p:nvSpPr>
+        <p:spPr>
+          <a:xfrm>
+            <a:off x="731520" y="4892040"/>
+            <a:ext cx="13624560" cy="640080"/>
+          </a:xfrm>
+          <a:prstGeom prst="rect">
+            <a:avLst/>
+          </a:prstGeom>
+          <a:solidFill>
+            <a:srgbClr val="FFFFFF"/>
+          </a:solidFill>
+          <a:ln w="25400">
+            <a:solidFill>
+              <a:srgbClr val="E67E22"/>
+            </a:solidFill>
+          </a:ln>
+        </p:spPr>
+        <p:style>
+          <a:lnRef idx="1">
+            <a:schemeClr val="accent1"/>
+          </a:lnRef>
+          <a:fillRef idx="3">
+            <a:schemeClr val="accent1"/>
+          </a:fillRef>
+          <a:effectRef idx="2">
+            <a:schemeClr val="accent1"/>
+          </a:effectRef>
+          <a:fontRef idx="minor">
+            <a:schemeClr val="lt1"/>
+          </a:fontRef>
+        </p:style>
+        <p:txBody>
+          <a:bodyPr rtlCol="0" anchor="ctr" wrap="square" lIns="63500" rIns="50800" tIns="38100" bIns="38100"/>
+          <a:lstStyle/>
+          <a:p>
+            <a:pPr algn="l"/>
+            <a:r>
+              <a:rPr sz="900" b="0">
+                <a:solidFill>
+                  <a:srgbClr val="222222"/>
+                </a:solidFill>
+                <a:latin typeface="Meiryo"/>
+              </a:rPr>
+              <a:t>銀行「送金確認のためお電話しました」→ 被害者は犯人との電話がつながったまま → 出られない
+仮に出たとしても → 「はい、自分で送金しました」と答える（自分が攻撃されていることに気づいていない）</a:t>
+            </a:r>
+          </a:p>
+        </p:txBody>
+      </p:sp>
+      <p:sp>
+        <p:nvSpPr>
+          <p:cNvPr id="35" name="TextBox 34"/>
+          <p:cNvSpPr txBox="1"/>
+          <p:nvPr/>
+        </p:nvSpPr>
+        <p:spPr>
+          <a:xfrm>
+            <a:off x="9144000" y="10378440"/>
+            <a:ext cx="5943600" cy="228600"/>
+          </a:xfrm>
+          <a:prstGeom prst="rect">
+            <a:avLst/>
+          </a:prstGeom>
+          <a:noFill/>
+        </p:spPr>
+        <p:txBody>
+          <a:bodyPr wrap="square" lIns="50800" rIns="50800" tIns="38100" bIns="38100"/>
+          <a:lstStyle/>
+          <a:p>
+            <a:pPr algn="r"/>
+            <a:r>
+              <a:rPr sz="700" b="0">
+                <a:solidFill>
+                  <a:srgbClr val="888888"/>
+                </a:solidFill>
+                <a:latin typeface="Meiryo"/>
+              </a:rPr>
+              <a:t>Fraud Kill Chain — 手順⑨ 不正送金</a:t>
+            </a:r>
+          </a:p>
+        </p:txBody>
+      </p:sp>
+    </p:spTree>
+  </p:cSld>
+  <p:clrMapOvr>
+    <a:masterClrMapping/>
+  </p:clrMapOvr>
+</p:sld>
+</file>
+
+<file path=ppt/slides/slide16.xml><?xml version="1.0" encoding="utf-8"?>
+<p:sld xmlns:a="http://schemas.openxmlformats.org/drawingml/2006/main" xmlns:p="http://schemas.openxmlformats.org/presentationml/2006/main" xmlns:r="http://schemas.openxmlformats.org/officeDocument/2006/relationships">
+  <p:cSld>
+    <p:bg>
+      <p:bgPr>
+        <a:solidFill>
+          <a:srgbClr val="F5F5F5"/>
+        </a:solidFill>
+        <a:effectLst/>
+      </p:bgPr>
+    </p:bg>
+    <p:spTree>
+      <p:nvGrpSpPr>
+        <p:cNvPr id="1" name=""/>
+        <p:cNvGrpSpPr/>
+        <p:nvPr/>
+      </p:nvGrpSpPr>
+      <p:grpSpPr/>
+      <p:sp>
+        <p:nvSpPr>
+          <p:cNvPr id="2" name="TextBox 1"/>
+          <p:cNvSpPr txBox="1"/>
+          <p:nvPr/>
+        </p:nvSpPr>
+        <p:spPr>
+          <a:xfrm>
+            <a:off x="0" y="137160"/>
+            <a:ext cx="15124176" cy="457200"/>
+          </a:xfrm>
+          <a:prstGeom prst="rect">
+            <a:avLst/>
+          </a:prstGeom>
+          <a:noFill/>
+        </p:spPr>
+        <p:txBody>
+          <a:bodyPr wrap="square" lIns="50800" rIns="50800" tIns="38100" bIns="38100"/>
+          <a:lstStyle/>
+          <a:p>
+            <a:pPr algn="ctr"/>
+            <a:r>
+              <a:rPr sz="2400" b="1">
+                <a:solidFill>
+                  <a:srgbClr val="C0392B"/>
+                </a:solidFill>
+                <a:latin typeface="Meiryo"/>
+              </a:rPr>
+              <a:t>総括：正規の銀行体験を99%再現した攻撃</a:t>
+            </a:r>
+          </a:p>
+        </p:txBody>
+      </p:sp>
+      <p:sp>
+        <p:nvSpPr>
+          <p:cNvPr id="3" name="Rectangle 2"/>
+          <p:cNvSpPr/>
+          <p:nvPr/>
+        </p:nvSpPr>
+        <p:spPr>
+          <a:xfrm>
+            <a:off x="731520" y="640080"/>
+            <a:ext cx="6583680" cy="365760"/>
+          </a:xfrm>
+          <a:prstGeom prst="rect">
+            <a:avLst/>
+          </a:prstGeom>
+          <a:solidFill>
+            <a:srgbClr val="27AE60"/>
+          </a:solidFill>
+          <a:ln>
+            <a:noFill/>
+          </a:ln>
+        </p:spPr>
+        <p:style>
+          <a:lnRef idx="1">
+            <a:schemeClr val="accent1"/>
+          </a:lnRef>
+          <a:fillRef idx="3">
+            <a:schemeClr val="accent1"/>
+          </a:fillRef>
+          <a:effectRef idx="2">
+            <a:schemeClr val="accent1"/>
+          </a:effectRef>
+          <a:fontRef idx="minor">
+            <a:schemeClr val="lt1"/>
+          </a:fontRef>
+        </p:style>
+        <p:txBody>
+          <a:bodyPr rtlCol="0" anchor="ctr" wrap="square" lIns="50800" rIns="50800" tIns="25400" bIns="25400"/>
+          <a:lstStyle/>
+          <a:p>
+            <a:pPr algn="ctr"/>
+            <a:r>
+              <a:rPr sz="1200" b="1">
+                <a:solidFill>
+                  <a:srgbClr val="FFFFFF"/>
+                </a:solidFill>
+                <a:latin typeface="Meiryo"/>
+              </a:rPr>
+              <a:t>正規と同じもの（10個）</a:t>
+            </a:r>
+          </a:p>
+        </p:txBody>
+      </p:sp>
+      <p:sp>
+        <p:nvSpPr>
+          <p:cNvPr id="4" name="Rectangle 3"/>
+          <p:cNvSpPr/>
+          <p:nvPr/>
+        </p:nvSpPr>
+        <p:spPr>
+          <a:xfrm>
+            <a:off x="731520" y="1005840"/>
+            <a:ext cx="6583680" cy="274320"/>
+          </a:xfrm>
+          <a:prstGeom prst="rect">
+            <a:avLst/>
+          </a:prstGeom>
+          <a:solidFill>
+            <a:srgbClr val="EAFAF1"/>
+          </a:solidFill>
+          <a:ln w="25400">
+            <a:solidFill>
+              <a:srgbClr val="27AE60"/>
+            </a:solidFill>
+          </a:ln>
+        </p:spPr>
+        <p:style>
+          <a:lnRef idx="1">
+            <a:schemeClr val="accent1"/>
+          </a:lnRef>
+          <a:fillRef idx="3">
+            <a:schemeClr val="accent1"/>
+          </a:fillRef>
+          <a:effectRef idx="2">
+            <a:schemeClr val="accent1"/>
+          </a:effectRef>
+          <a:fontRef idx="minor">
+            <a:schemeClr val="lt1"/>
+          </a:fontRef>
+        </p:style>
+        <p:txBody>
+          <a:bodyPr rtlCol="0" anchor="ctr" wrap="square" lIns="63500" rIns="50800" tIns="38100" bIns="38100"/>
+          <a:lstStyle/>
+          <a:p>
+            <a:pPr algn="l"/>
+            <a:r>
+              <a:rPr sz="800" b="0">
+                <a:solidFill>
+                  <a:srgbClr val="27AE60"/>
+                </a:solidFill>
+                <a:latin typeface="Meiryo"/>
+              </a:rPr>
+              <a:t>✅ 自動音声の振り分け</a:t>
+            </a:r>
+          </a:p>
+        </p:txBody>
+      </p:sp>
+      <p:sp>
+        <p:nvSpPr>
+          <p:cNvPr id="5" name="Rectangle 4"/>
+          <p:cNvSpPr/>
+          <p:nvPr/>
+        </p:nvSpPr>
+        <p:spPr>
+          <a:xfrm>
+            <a:off x="731520" y="1280160"/>
+            <a:ext cx="6583680" cy="274320"/>
+          </a:xfrm>
+          <a:prstGeom prst="rect">
+            <a:avLst/>
+          </a:prstGeom>
+          <a:solidFill>
+            <a:srgbClr val="EAFAF1"/>
+          </a:solidFill>
+          <a:ln w="25400">
+            <a:solidFill>
+              <a:srgbClr val="27AE60"/>
+            </a:solidFill>
+          </a:ln>
+        </p:spPr>
+        <p:style>
+          <a:lnRef idx="1">
+            <a:schemeClr val="accent1"/>
+          </a:lnRef>
+          <a:fillRef idx="3">
+            <a:schemeClr val="accent1"/>
+          </a:fillRef>
+          <a:effectRef idx="2">
+            <a:schemeClr val="accent1"/>
+          </a:effectRef>
+          <a:fontRef idx="minor">
+            <a:schemeClr val="lt1"/>
+          </a:fontRef>
+        </p:style>
+        <p:txBody>
+          <a:bodyPr rtlCol="0" anchor="ctr" wrap="square" lIns="63500" rIns="50800" tIns="38100" bIns="38100"/>
+          <a:lstStyle/>
+          <a:p>
+            <a:pPr algn="l"/>
+            <a:r>
+              <a:rPr sz="800" b="0">
+                <a:solidFill>
+                  <a:srgbClr val="27AE60"/>
+                </a:solidFill>
+                <a:latin typeface="Meiryo"/>
+              </a:rPr>
+              <a:t>✅ 担当者との電話対応</a:t>
+            </a:r>
+          </a:p>
+        </p:txBody>
+      </p:sp>
+      <p:sp>
+        <p:nvSpPr>
+          <p:cNvPr id="6" name="Rectangle 5"/>
+          <p:cNvSpPr/>
+          <p:nvPr/>
+        </p:nvSpPr>
+        <p:spPr>
+          <a:xfrm>
+            <a:off x="731520" y="1554480"/>
+            <a:ext cx="6583680" cy="274320"/>
+          </a:xfrm>
+          <a:prstGeom prst="rect">
+            <a:avLst/>
+          </a:prstGeom>
+          <a:solidFill>
+            <a:srgbClr val="EAFAF1"/>
+          </a:solidFill>
+          <a:ln w="25400">
+            <a:solidFill>
+              <a:srgbClr val="27AE60"/>
+            </a:solidFill>
+          </a:ln>
+        </p:spPr>
+        <p:style>
+          <a:lnRef idx="1">
+            <a:schemeClr val="accent1"/>
+          </a:lnRef>
+          <a:fillRef idx="3">
+            <a:schemeClr val="accent1"/>
+          </a:fillRef>
+          <a:effectRef idx="2">
+            <a:schemeClr val="accent1"/>
+          </a:effectRef>
+          <a:fontRef idx="minor">
+            <a:schemeClr val="lt1"/>
+          </a:fontRef>
+        </p:style>
+        <p:txBody>
+          <a:bodyPr rtlCol="0" anchor="ctr" wrap="square" lIns="63500" rIns="50800" tIns="38100" bIns="38100"/>
+          <a:lstStyle/>
+          <a:p>
+            <a:pPr algn="l"/>
+            <a:r>
+              <a:rPr sz="800" b="0">
+                <a:solidFill>
+                  <a:srgbClr val="27AE60"/>
+                </a:solidFill>
+                <a:latin typeface="Meiryo"/>
+              </a:rPr>
+              <a:t>✅ 「郵送した」「口座制限」のセリフ</a:t>
+            </a:r>
+          </a:p>
+        </p:txBody>
+      </p:sp>
+      <p:sp>
+        <p:nvSpPr>
+          <p:cNvPr id="7" name="Rectangle 6"/>
+          <p:cNvSpPr/>
+          <p:nvPr/>
+        </p:nvSpPr>
+        <p:spPr>
+          <a:xfrm>
+            <a:off x="731520" y="1828800"/>
+            <a:ext cx="6583680" cy="274320"/>
+          </a:xfrm>
+          <a:prstGeom prst="rect">
+            <a:avLst/>
+          </a:prstGeom>
+          <a:solidFill>
+            <a:srgbClr val="EAFAF1"/>
+          </a:solidFill>
+          <a:ln w="25400">
+            <a:solidFill>
+              <a:srgbClr val="27AE60"/>
+            </a:solidFill>
+          </a:ln>
+        </p:spPr>
+        <p:style>
+          <a:lnRef idx="1">
+            <a:schemeClr val="accent1"/>
+          </a:lnRef>
+          <a:fillRef idx="3">
+            <a:schemeClr val="accent1"/>
+          </a:fillRef>
+          <a:effectRef idx="2">
+            <a:schemeClr val="accent1"/>
+          </a:effectRef>
+          <a:fontRef idx="minor">
+            <a:schemeClr val="lt1"/>
+          </a:fontRef>
+        </p:style>
+        <p:txBody>
+          <a:bodyPr rtlCol="0" anchor="ctr" wrap="square" lIns="63500" rIns="50800" tIns="38100" bIns="38100"/>
+          <a:lstStyle/>
+          <a:p>
+            <a:pPr algn="l"/>
+            <a:r>
+              <a:rPr sz="800" b="0">
+                <a:solidFill>
+                  <a:srgbClr val="27AE60"/>
+                </a:solidFill>
+                <a:latin typeface="Meiryo"/>
+              </a:rPr>
+              <a:t>✅ メールのデザイン（Bizデザイン）</a:t>
+            </a:r>
+          </a:p>
+        </p:txBody>
+      </p:sp>
+      <p:sp>
+        <p:nvSpPr>
+          <p:cNvPr id="8" name="Rectangle 7"/>
+          <p:cNvSpPr/>
+          <p:nvPr/>
+        </p:nvSpPr>
+        <p:spPr>
+          <a:xfrm>
+            <a:off x="731520" y="2103120"/>
+            <a:ext cx="6583680" cy="274320"/>
+          </a:xfrm>
+          <a:prstGeom prst="rect">
+            <a:avLst/>
+          </a:prstGeom>
+          <a:solidFill>
+            <a:srgbClr val="EAFAF1"/>
+          </a:solidFill>
+          <a:ln w="25400">
+            <a:solidFill>
+              <a:srgbClr val="27AE60"/>
+            </a:solidFill>
+          </a:ln>
+        </p:spPr>
+        <p:style>
+          <a:lnRef idx="1">
+            <a:schemeClr val="accent1"/>
+          </a:lnRef>
+          <a:fillRef idx="3">
+            <a:schemeClr val="accent1"/>
+          </a:fillRef>
+          <a:effectRef idx="2">
+            <a:schemeClr val="accent1"/>
+          </a:effectRef>
+          <a:fontRef idx="minor">
+            <a:schemeClr val="lt1"/>
+          </a:fontRef>
+        </p:style>
+        <p:txBody>
+          <a:bodyPr rtlCol="0" anchor="ctr" wrap="square" lIns="63500" rIns="50800" tIns="38100" bIns="38100"/>
+          <a:lstStyle/>
+          <a:p>
+            <a:pPr algn="l"/>
+            <a:r>
+              <a:rPr sz="800" b="0">
+                <a:solidFill>
+                  <a:srgbClr val="27AE60"/>
+                </a:solidFill>
+                <a:latin typeface="Meiryo"/>
+              </a:rPr>
+              <a:t>✅ メールの件名（実在する案内と同じ）</a:t>
+            </a:r>
+          </a:p>
+        </p:txBody>
+      </p:sp>
+      <p:sp>
+        <p:nvSpPr>
+          <p:cNvPr id="9" name="Rectangle 8"/>
+          <p:cNvSpPr/>
+          <p:nvPr/>
+        </p:nvSpPr>
+        <p:spPr>
+          <a:xfrm>
+            <a:off x="731520" y="2377440"/>
+            <a:ext cx="6583680" cy="274320"/>
+          </a:xfrm>
+          <a:prstGeom prst="rect">
+            <a:avLst/>
+          </a:prstGeom>
+          <a:solidFill>
+            <a:srgbClr val="EAFAF1"/>
+          </a:solidFill>
+          <a:ln w="25400">
+            <a:solidFill>
+              <a:srgbClr val="27AE60"/>
+            </a:solidFill>
+          </a:ln>
+        </p:spPr>
+        <p:style>
+          <a:lnRef idx="1">
+            <a:schemeClr val="accent1"/>
+          </a:lnRef>
+          <a:fillRef idx="3">
+            <a:schemeClr val="accent1"/>
+          </a:fillRef>
+          <a:effectRef idx="2">
+            <a:schemeClr val="accent1"/>
+          </a:effectRef>
+          <a:fontRef idx="minor">
+            <a:schemeClr val="lt1"/>
+          </a:fontRef>
+        </p:style>
+        <p:txBody>
+          <a:bodyPr rtlCol="0" anchor="ctr" wrap="square" lIns="63500" rIns="50800" tIns="38100" bIns="38100"/>
+          <a:lstStyle/>
+          <a:p>
+            <a:pPr algn="l"/>
+            <a:r>
+              <a:rPr sz="800" b="0">
+                <a:solidFill>
+                  <a:srgbClr val="27AE60"/>
+                </a:solidFill>
+                <a:latin typeface="Meiryo"/>
+              </a:rPr>
+              <a:t>✅ Webページのデザイン</a:t>
+            </a:r>
+          </a:p>
+        </p:txBody>
+      </p:sp>
+      <p:sp>
+        <p:nvSpPr>
+          <p:cNvPr id="10" name="Rectangle 9"/>
+          <p:cNvSpPr/>
+          <p:nvPr/>
+        </p:nvSpPr>
+        <p:spPr>
+          <a:xfrm>
+            <a:off x="731520" y="2651760"/>
+            <a:ext cx="6583680" cy="274320"/>
+          </a:xfrm>
+          <a:prstGeom prst="rect">
+            <a:avLst/>
+          </a:prstGeom>
+          <a:solidFill>
+            <a:srgbClr val="EAFAF1"/>
+          </a:solidFill>
+          <a:ln w="25400">
+            <a:solidFill>
+              <a:srgbClr val="27AE60"/>
+            </a:solidFill>
+          </a:ln>
+        </p:spPr>
+        <p:style>
+          <a:lnRef idx="1">
+            <a:schemeClr val="accent1"/>
+          </a:lnRef>
+          <a:fillRef idx="3">
+            <a:schemeClr val="accent1"/>
+          </a:fillRef>
+          <a:effectRef idx="2">
+            <a:schemeClr val="accent1"/>
+          </a:effectRef>
+          <a:fontRef idx="minor">
+            <a:schemeClr val="lt1"/>
+          </a:fontRef>
+        </p:style>
+        <p:txBody>
+          <a:bodyPr rtlCol="0" anchor="ctr" wrap="square" lIns="63500" rIns="50800" tIns="38100" bIns="38100"/>
+          <a:lstStyle/>
+          <a:p>
+            <a:pPr algn="l"/>
+            <a:r>
+              <a:rPr sz="800" b="0">
+                <a:solidFill>
+                  <a:srgbClr val="27AE60"/>
+                </a:solidFill>
+                <a:latin typeface="Meiryo"/>
+              </a:rPr>
+              <a:t>✅ 赤い画面の色（ブランドカラー）</a:t>
+            </a:r>
+          </a:p>
+        </p:txBody>
+      </p:sp>
+      <p:sp>
+        <p:nvSpPr>
+          <p:cNvPr id="11" name="Rectangle 10"/>
+          <p:cNvSpPr/>
+          <p:nvPr/>
+        </p:nvSpPr>
+        <p:spPr>
+          <a:xfrm>
+            <a:off x="731520" y="2926080"/>
+            <a:ext cx="6583680" cy="274320"/>
+          </a:xfrm>
+          <a:prstGeom prst="rect">
+            <a:avLst/>
+          </a:prstGeom>
+          <a:solidFill>
+            <a:srgbClr val="EAFAF1"/>
+          </a:solidFill>
+          <a:ln w="25400">
+            <a:solidFill>
+              <a:srgbClr val="27AE60"/>
+            </a:solidFill>
+          </a:ln>
+        </p:spPr>
+        <p:style>
+          <a:lnRef idx="1">
+            <a:schemeClr val="accent1"/>
+          </a:lnRef>
+          <a:fillRef idx="3">
+            <a:schemeClr val="accent1"/>
+          </a:fillRef>
+          <a:effectRef idx="2">
+            <a:schemeClr val="accent1"/>
+          </a:effectRef>
+          <a:fontRef idx="minor">
+            <a:schemeClr val="lt1"/>
+          </a:fontRef>
+        </p:style>
+        <p:txBody>
+          <a:bodyPr rtlCol="0" anchor="ctr" wrap="square" lIns="63500" rIns="50800" tIns="38100" bIns="38100"/>
+          <a:lstStyle/>
+          <a:p>
+            <a:pPr algn="l"/>
+            <a:r>
+              <a:rPr sz="800" b="0">
+                <a:solidFill>
+                  <a:srgbClr val="27AE60"/>
+                </a:solidFill>
+                <a:latin typeface="Meiryo"/>
+              </a:rPr>
+              <a:t>✅ 赤い画面の文言（銀行の丁寧語）</a:t>
+            </a:r>
+          </a:p>
+        </p:txBody>
+      </p:sp>
+      <p:sp>
+        <p:nvSpPr>
+          <p:cNvPr id="12" name="Rectangle 11"/>
+          <p:cNvSpPr/>
+          <p:nvPr/>
+        </p:nvSpPr>
+        <p:spPr>
+          <a:xfrm>
+            <a:off x="731520" y="3200400"/>
+            <a:ext cx="6583680" cy="274320"/>
+          </a:xfrm>
+          <a:prstGeom prst="rect">
+            <a:avLst/>
+          </a:prstGeom>
+          <a:solidFill>
+            <a:srgbClr val="EAFAF1"/>
+          </a:solidFill>
+          <a:ln w="25400">
+            <a:solidFill>
+              <a:srgbClr val="27AE60"/>
+            </a:solidFill>
+          </a:ln>
+        </p:spPr>
+        <p:style>
+          <a:lnRef idx="1">
+            <a:schemeClr val="accent1"/>
+          </a:lnRef>
+          <a:fillRef idx="3">
+            <a:schemeClr val="accent1"/>
+          </a:fillRef>
+          <a:effectRef idx="2">
+            <a:schemeClr val="accent1"/>
+          </a:effectRef>
+          <a:fontRef idx="minor">
+            <a:schemeClr val="lt1"/>
+          </a:fontRef>
+        </p:style>
+        <p:txBody>
+          <a:bodyPr rtlCol="0" anchor="ctr" wrap="square" lIns="63500" rIns="50800" tIns="38100" bIns="38100"/>
+          <a:lstStyle/>
+          <a:p>
+            <a:pPr algn="l"/>
+            <a:r>
+              <a:rPr sz="800" b="0">
+                <a:solidFill>
+                  <a:srgbClr val="27AE60"/>
+                </a:solidFill>
+                <a:latin typeface="Meiryo"/>
+              </a:rPr>
+              <a:t>✅ SMS認証の流れ</a:t>
+            </a:r>
+          </a:p>
+        </p:txBody>
+      </p:sp>
+      <p:sp>
+        <p:nvSpPr>
+          <p:cNvPr id="13" name="Rectangle 12"/>
+          <p:cNvSpPr/>
+          <p:nvPr/>
+        </p:nvSpPr>
+        <p:spPr>
+          <a:xfrm>
+            <a:off x="731520" y="3474720"/>
+            <a:ext cx="6583680" cy="274320"/>
+          </a:xfrm>
+          <a:prstGeom prst="rect">
+            <a:avLst/>
+          </a:prstGeom>
+          <a:solidFill>
+            <a:srgbClr val="EAFAF1"/>
+          </a:solidFill>
+          <a:ln w="25400">
+            <a:solidFill>
+              <a:srgbClr val="27AE60"/>
+            </a:solidFill>
+          </a:ln>
+        </p:spPr>
+        <p:style>
+          <a:lnRef idx="1">
+            <a:schemeClr val="accent1"/>
+          </a:lnRef>
+          <a:fillRef idx="3">
+            <a:schemeClr val="accent1"/>
+          </a:fillRef>
+          <a:effectRef idx="2">
+            <a:schemeClr val="accent1"/>
+          </a:effectRef>
+          <a:fontRef idx="minor">
+            <a:schemeClr val="lt1"/>
+          </a:fontRef>
+        </p:style>
+        <p:txBody>
+          <a:bodyPr rtlCol="0" anchor="ctr" wrap="square" lIns="63500" rIns="50800" tIns="38100" bIns="38100"/>
+          <a:lstStyle/>
+          <a:p>
+            <a:pPr algn="l"/>
+            <a:r>
+              <a:rPr sz="800" b="0">
+                <a:solidFill>
+                  <a:srgbClr val="27AE60"/>
+                </a:solidFill>
+                <a:latin typeface="Meiryo"/>
+              </a:rPr>
+              <a:t>✅ セキュリティソフト推奨（Rapportは実在）</a:t>
+            </a:r>
+          </a:p>
+        </p:txBody>
+      </p:sp>
+      <p:sp>
+        <p:nvSpPr>
+          <p:cNvPr id="14" name="Rectangle 13"/>
+          <p:cNvSpPr/>
+          <p:nvPr/>
+        </p:nvSpPr>
+        <p:spPr>
+          <a:xfrm>
+            <a:off x="7772400" y="640080"/>
+            <a:ext cx="6400800" cy="365760"/>
+          </a:xfrm>
+          <a:prstGeom prst="rect">
+            <a:avLst/>
+          </a:prstGeom>
+          <a:solidFill>
+            <a:srgbClr val="C0392B"/>
+          </a:solidFill>
+          <a:ln>
+            <a:noFill/>
+          </a:ln>
+        </p:spPr>
+        <p:style>
+          <a:lnRef idx="1">
+            <a:schemeClr val="accent1"/>
+          </a:lnRef>
+          <a:fillRef idx="3">
+            <a:schemeClr val="accent1"/>
+          </a:fillRef>
+          <a:effectRef idx="2">
+            <a:schemeClr val="accent1"/>
+          </a:effectRef>
+          <a:fontRef idx="minor">
+            <a:schemeClr val="lt1"/>
+          </a:fontRef>
+        </p:style>
+        <p:txBody>
+          <a:bodyPr rtlCol="0" anchor="ctr" wrap="square" lIns="50800" rIns="50800" tIns="25400" bIns="25400"/>
+          <a:lstStyle/>
+          <a:p>
+            <a:pPr algn="ctr"/>
+            <a:r>
+              <a:rPr sz="1200" b="1">
+                <a:solidFill>
+                  <a:srgbClr val="FFFFFF"/>
+                </a:solidFill>
+                <a:latin typeface="Meiryo"/>
+              </a:rPr>
+              <a:t>正規と違うもの（6個）</a:t>
+            </a:r>
+          </a:p>
+        </p:txBody>
+      </p:sp>
+      <p:sp>
+        <p:nvSpPr>
+          <p:cNvPr id="15" name="Rectangle 14"/>
+          <p:cNvSpPr/>
+          <p:nvPr/>
+        </p:nvSpPr>
+        <p:spPr>
+          <a:xfrm>
+            <a:off x="7772400" y="1005840"/>
+            <a:ext cx="2926080" cy="457200"/>
+          </a:xfrm>
+          <a:prstGeom prst="rect">
+            <a:avLst/>
+          </a:prstGeom>
+          <a:solidFill>
+            <a:srgbClr val="FDEDEC"/>
+          </a:solidFill>
+          <a:ln w="25400">
+            <a:solidFill>
+              <a:srgbClr val="C0392B"/>
+            </a:solidFill>
+          </a:ln>
+        </p:spPr>
+        <p:style>
+          <a:lnRef idx="1">
+            <a:schemeClr val="accent1"/>
+          </a:lnRef>
+          <a:fillRef idx="3">
+            <a:schemeClr val="accent1"/>
+          </a:fillRef>
+          <a:effectRef idx="2">
+            <a:schemeClr val="accent1"/>
+          </a:effectRef>
+          <a:fontRef idx="minor">
+            <a:schemeClr val="lt1"/>
+          </a:fontRef>
+        </p:style>
+        <p:txBody>
+          <a:bodyPr rtlCol="0" anchor="ctr" wrap="square" lIns="63500" rIns="50800" tIns="38100" bIns="38100"/>
+          <a:lstStyle/>
+          <a:p>
+            <a:pPr algn="l"/>
+            <a:r>
+              <a:rPr sz="800" b="1">
+                <a:solidFill>
+                  <a:srgbClr val="C0392B"/>
+                </a:solidFill>
+                <a:latin typeface="Meiryo"/>
+              </a:rPr>
+              <a:t>❌ メアドを聞く</a:t>
+            </a:r>
+          </a:p>
+        </p:txBody>
+      </p:sp>
+      <p:sp>
+        <p:nvSpPr>
+          <p:cNvPr id="16" name="Rectangle 15"/>
+          <p:cNvSpPr/>
+          <p:nvPr/>
+        </p:nvSpPr>
+        <p:spPr>
+          <a:xfrm>
+            <a:off x="10698480" y="1005840"/>
+            <a:ext cx="3474720" cy="457200"/>
+          </a:xfrm>
+          <a:prstGeom prst="rect">
+            <a:avLst/>
+          </a:prstGeom>
+          <a:solidFill>
+            <a:srgbClr val="FFFFFF"/>
+          </a:solidFill>
+          <a:ln w="25400">
+            <a:solidFill>
+              <a:srgbClr val="CCCCCC"/>
+            </a:solidFill>
+          </a:ln>
+        </p:spPr>
+        <p:style>
+          <a:lnRef idx="1">
+            <a:schemeClr val="accent1"/>
+          </a:lnRef>
+          <a:fillRef idx="3">
+            <a:schemeClr val="accent1"/>
+          </a:fillRef>
+          <a:effectRef idx="2">
+            <a:schemeClr val="accent1"/>
+          </a:effectRef>
+          <a:fontRef idx="minor">
+            <a:schemeClr val="lt1"/>
+          </a:fontRef>
+        </p:style>
+        <p:txBody>
+          <a:bodyPr rtlCol="0" anchor="ctr" wrap="square" lIns="63500" rIns="50800" tIns="38100" bIns="38100"/>
+          <a:lstStyle/>
+          <a:p>
+            <a:pPr algn="l"/>
+            <a:r>
+              <a:rPr sz="800" b="0">
+                <a:solidFill>
+                  <a:srgbClr val="888888"/>
+                </a:solidFill>
+                <a:latin typeface="Meiryo"/>
+              </a:rPr>
+              <a:t>登録済みなので聞かない</a:t>
+            </a:r>
+          </a:p>
+        </p:txBody>
+      </p:sp>
+      <p:sp>
+        <p:nvSpPr>
+          <p:cNvPr id="17" name="Rectangle 16"/>
+          <p:cNvSpPr/>
+          <p:nvPr/>
+        </p:nvSpPr>
+        <p:spPr>
+          <a:xfrm>
+            <a:off x="7772400" y="1463040"/>
+            <a:ext cx="2926080" cy="457200"/>
+          </a:xfrm>
+          <a:prstGeom prst="rect">
+            <a:avLst/>
+          </a:prstGeom>
+          <a:solidFill>
+            <a:srgbClr val="FDEDEC"/>
+          </a:solidFill>
+          <a:ln w="25400">
+            <a:solidFill>
+              <a:srgbClr val="C0392B"/>
+            </a:solidFill>
+          </a:ln>
+        </p:spPr>
+        <p:style>
+          <a:lnRef idx="1">
+            <a:schemeClr val="accent1"/>
+          </a:lnRef>
+          <a:fillRef idx="3">
+            <a:schemeClr val="accent1"/>
+          </a:fillRef>
+          <a:effectRef idx="2">
+            <a:schemeClr val="accent1"/>
+          </a:effectRef>
+          <a:fontRef idx="minor">
+            <a:schemeClr val="lt1"/>
+          </a:fontRef>
+        </p:style>
+        <p:txBody>
+          <a:bodyPr rtlCol="0" anchor="ctr" wrap="square" lIns="63500" rIns="50800" tIns="38100" bIns="38100"/>
+          <a:lstStyle/>
+          <a:p>
+            <a:pPr algn="l"/>
+            <a:r>
+              <a:rPr sz="800" b="1">
+                <a:solidFill>
+                  <a:srgbClr val="C0392B"/>
+                </a:solidFill>
+                <a:latin typeface="Meiryo"/>
+              </a:rPr>
+              <a:t>❌ 迷惑フォルダを見て</a:t>
+            </a:r>
+          </a:p>
+        </p:txBody>
+      </p:sp>
+      <p:sp>
+        <p:nvSpPr>
+          <p:cNvPr id="18" name="Rectangle 17"/>
+          <p:cNvSpPr/>
+          <p:nvPr/>
+        </p:nvSpPr>
+        <p:spPr>
+          <a:xfrm>
+            <a:off x="10698480" y="1463040"/>
+            <a:ext cx="3474720" cy="457200"/>
+          </a:xfrm>
+          <a:prstGeom prst="rect">
+            <a:avLst/>
+          </a:prstGeom>
+          <a:solidFill>
+            <a:srgbClr val="FFFFFF"/>
+          </a:solidFill>
+          <a:ln w="25400">
+            <a:solidFill>
+              <a:srgbClr val="CCCCCC"/>
+            </a:solidFill>
+          </a:ln>
+        </p:spPr>
+        <p:style>
+          <a:lnRef idx="1">
+            <a:schemeClr val="accent1"/>
+          </a:lnRef>
+          <a:fillRef idx="3">
+            <a:schemeClr val="accent1"/>
+          </a:fillRef>
+          <a:effectRef idx="2">
+            <a:schemeClr val="accent1"/>
+          </a:effectRef>
+          <a:fontRef idx="minor">
+            <a:schemeClr val="lt1"/>
+          </a:fontRef>
+        </p:style>
+        <p:txBody>
+          <a:bodyPr rtlCol="0" anchor="ctr" wrap="square" lIns="63500" rIns="50800" tIns="38100" bIns="38100"/>
+          <a:lstStyle/>
+          <a:p>
+            <a:pPr algn="l"/>
+            <a:r>
+              <a:rPr sz="800" b="0">
+                <a:solidFill>
+                  <a:srgbClr val="888888"/>
+                </a:solidFill>
+                <a:latin typeface="Meiryo"/>
+              </a:rPr>
+              <a:t>正規メールは入らない</a:t>
+            </a:r>
+          </a:p>
+        </p:txBody>
+      </p:sp>
+      <p:sp>
+        <p:nvSpPr>
+          <p:cNvPr id="19" name="Rectangle 18"/>
+          <p:cNvSpPr/>
+          <p:nvPr/>
+        </p:nvSpPr>
+        <p:spPr>
+          <a:xfrm>
+            <a:off x="7772400" y="1920240"/>
+            <a:ext cx="2926080" cy="457200"/>
+          </a:xfrm>
+          <a:prstGeom prst="rect">
+            <a:avLst/>
+          </a:prstGeom>
+          <a:solidFill>
+            <a:srgbClr val="FDEDEC"/>
+          </a:solidFill>
+          <a:ln w="25400">
+            <a:solidFill>
+              <a:srgbClr val="C0392B"/>
+            </a:solidFill>
+          </a:ln>
+        </p:spPr>
+        <p:style>
+          <a:lnRef idx="1">
+            <a:schemeClr val="accent1"/>
+          </a:lnRef>
+          <a:fillRef idx="3">
+            <a:schemeClr val="accent1"/>
+          </a:fillRef>
+          <a:effectRef idx="2">
+            <a:schemeClr val="accent1"/>
+          </a:effectRef>
+          <a:fontRef idx="minor">
+            <a:schemeClr val="lt1"/>
+          </a:fontRef>
+        </p:style>
+        <p:txBody>
+          <a:bodyPr rtlCol="0" anchor="ctr" wrap="square" lIns="63500" rIns="50800" tIns="38100" bIns="38100"/>
+          <a:lstStyle/>
+          <a:p>
+            <a:pPr algn="l"/>
+            <a:r>
+              <a:rPr sz="800" b="1">
+                <a:solidFill>
+                  <a:srgbClr val="C0392B"/>
+                </a:solidFill>
+                <a:latin typeface="Meiryo"/>
+              </a:rPr>
+              <a:t>❌ メールにURL</a:t>
+            </a:r>
+          </a:p>
+        </p:txBody>
+      </p:sp>
+      <p:sp>
+        <p:nvSpPr>
+          <p:cNvPr id="20" name="Rectangle 19"/>
+          <p:cNvSpPr/>
+          <p:nvPr/>
+        </p:nvSpPr>
+        <p:spPr>
+          <a:xfrm>
+            <a:off x="10698480" y="1920240"/>
+            <a:ext cx="3474720" cy="457200"/>
+          </a:xfrm>
+          <a:prstGeom prst="rect">
+            <a:avLst/>
+          </a:prstGeom>
+          <a:solidFill>
+            <a:srgbClr val="FFFFFF"/>
+          </a:solidFill>
+          <a:ln w="25400">
+            <a:solidFill>
+              <a:srgbClr val="CCCCCC"/>
+            </a:solidFill>
+          </a:ln>
+        </p:spPr>
+        <p:style>
+          <a:lnRef idx="1">
+            <a:schemeClr val="accent1"/>
+          </a:lnRef>
+          <a:fillRef idx="3">
+            <a:schemeClr val="accent1"/>
+          </a:fillRef>
+          <a:effectRef idx="2">
+            <a:schemeClr val="accent1"/>
+          </a:effectRef>
+          <a:fontRef idx="minor">
+            <a:schemeClr val="lt1"/>
+          </a:fontRef>
+        </p:style>
+        <p:txBody>
+          <a:bodyPr rtlCol="0" anchor="ctr" wrap="square" lIns="63500" rIns="50800" tIns="38100" bIns="38100"/>
+          <a:lstStyle/>
+          <a:p>
+            <a:pPr algn="l"/>
+            <a:r>
+              <a:rPr sz="800" b="0">
+                <a:solidFill>
+                  <a:srgbClr val="888888"/>
+                </a:solidFill>
+                <a:latin typeface="Meiryo"/>
+              </a:rPr>
+              <a:t>金融庁が禁止</a:t>
+            </a:r>
+          </a:p>
+        </p:txBody>
+      </p:sp>
+      <p:sp>
+        <p:nvSpPr>
+          <p:cNvPr id="21" name="Rectangle 20"/>
+          <p:cNvSpPr/>
+          <p:nvPr/>
+        </p:nvSpPr>
+        <p:spPr>
+          <a:xfrm>
+            <a:off x="7772400" y="2377440"/>
+            <a:ext cx="2926080" cy="457200"/>
+          </a:xfrm>
+          <a:prstGeom prst="rect">
+            <a:avLst/>
+          </a:prstGeom>
+          <a:solidFill>
+            <a:srgbClr val="FDEDEC"/>
+          </a:solidFill>
+          <a:ln w="25400">
+            <a:solidFill>
+              <a:srgbClr val="C0392B"/>
+            </a:solidFill>
+          </a:ln>
+        </p:spPr>
+        <p:style>
+          <a:lnRef idx="1">
+            <a:schemeClr val="accent1"/>
+          </a:lnRef>
+          <a:fillRef idx="3">
+            <a:schemeClr val="accent1"/>
+          </a:fillRef>
+          <a:effectRef idx="2">
+            <a:schemeClr val="accent1"/>
+          </a:effectRef>
+          <a:fontRef idx="minor">
+            <a:schemeClr val="lt1"/>
+          </a:fontRef>
+        </p:style>
+        <p:txBody>
+          <a:bodyPr rtlCol="0" anchor="ctr" wrap="square" lIns="63500" rIns="50800" tIns="38100" bIns="38100"/>
+          <a:lstStyle/>
+          <a:p>
+            <a:pPr algn="l"/>
+            <a:r>
+              <a:rPr sz="800" b="1">
+                <a:solidFill>
+                  <a:srgbClr val="C0392B"/>
+                </a:solidFill>
+                <a:latin typeface="Meiryo"/>
+              </a:rPr>
+              <a:t>❌ 不明な発行元でも実行して</a:t>
+            </a:r>
+          </a:p>
+        </p:txBody>
+      </p:sp>
+      <p:sp>
+        <p:nvSpPr>
+          <p:cNvPr id="22" name="Rectangle 21"/>
+          <p:cNvSpPr/>
+          <p:nvPr/>
+        </p:nvSpPr>
+        <p:spPr>
+          <a:xfrm>
+            <a:off x="10698480" y="2377440"/>
+            <a:ext cx="3474720" cy="457200"/>
+          </a:xfrm>
+          <a:prstGeom prst="rect">
+            <a:avLst/>
+          </a:prstGeom>
+          <a:solidFill>
+            <a:srgbClr val="FFFFFF"/>
+          </a:solidFill>
+          <a:ln w="25400">
+            <a:solidFill>
+              <a:srgbClr val="CCCCCC"/>
+            </a:solidFill>
+          </a:ln>
+        </p:spPr>
+        <p:style>
+          <a:lnRef idx="1">
+            <a:schemeClr val="accent1"/>
+          </a:lnRef>
+          <a:fillRef idx="3">
+            <a:schemeClr val="accent1"/>
+          </a:fillRef>
+          <a:effectRef idx="2">
+            <a:schemeClr val="accent1"/>
+          </a:effectRef>
+          <a:fontRef idx="minor">
+            <a:schemeClr val="lt1"/>
+          </a:fontRef>
+        </p:style>
+        <p:txBody>
+          <a:bodyPr rtlCol="0" anchor="ctr" wrap="square" lIns="63500" rIns="50800" tIns="38100" bIns="38100"/>
+          <a:lstStyle/>
+          <a:p>
+            <a:pPr algn="l"/>
+            <a:r>
+              <a:rPr sz="800" b="0">
+                <a:solidFill>
+                  <a:srgbClr val="888888"/>
+                </a:solidFill>
+                <a:latin typeface="Meiryo"/>
+              </a:rPr>
+              <a:t>正規ソフトは署名済み</a:t>
+            </a:r>
+          </a:p>
+        </p:txBody>
+      </p:sp>
+      <p:sp>
+        <p:nvSpPr>
+          <p:cNvPr id="23" name="Rectangle 22"/>
+          <p:cNvSpPr/>
+          <p:nvPr/>
+        </p:nvSpPr>
+        <p:spPr>
+          <a:xfrm>
+            <a:off x="7772400" y="2834640"/>
+            <a:ext cx="2926080" cy="457200"/>
+          </a:xfrm>
+          <a:prstGeom prst="rect">
+            <a:avLst/>
+          </a:prstGeom>
+          <a:solidFill>
+            <a:srgbClr val="FDEDEC"/>
+          </a:solidFill>
+          <a:ln w="25400">
+            <a:solidFill>
+              <a:srgbClr val="C0392B"/>
+            </a:solidFill>
+          </a:ln>
+        </p:spPr>
+        <p:style>
+          <a:lnRef idx="1">
+            <a:schemeClr val="accent1"/>
+          </a:lnRef>
+          <a:fillRef idx="3">
+            <a:schemeClr val="accent1"/>
+          </a:fillRef>
+          <a:effectRef idx="2">
+            <a:schemeClr val="accent1"/>
+          </a:effectRef>
+          <a:fontRef idx="minor">
+            <a:schemeClr val="lt1"/>
+          </a:fontRef>
+        </p:style>
+        <p:txBody>
+          <a:bodyPr rtlCol="0" anchor="ctr" wrap="square" lIns="63500" rIns="50800" tIns="38100" bIns="38100"/>
+          <a:lstStyle/>
+          <a:p>
+            <a:pPr algn="l"/>
+            <a:r>
+              <a:rPr sz="800" b="1">
+                <a:solidFill>
+                  <a:srgbClr val="C0392B"/>
+                </a:solidFill>
+                <a:latin typeface="Meiryo"/>
+              </a:rPr>
+              <a:t>❌ 携帯番号を聞く</a:t>
+            </a:r>
+          </a:p>
+        </p:txBody>
+      </p:sp>
+      <p:sp>
+        <p:nvSpPr>
+          <p:cNvPr id="24" name="Rectangle 23"/>
+          <p:cNvSpPr/>
+          <p:nvPr/>
+        </p:nvSpPr>
+        <p:spPr>
+          <a:xfrm>
+            <a:off x="10698480" y="2834640"/>
+            <a:ext cx="3474720" cy="457200"/>
+          </a:xfrm>
+          <a:prstGeom prst="rect">
+            <a:avLst/>
+          </a:prstGeom>
+          <a:solidFill>
+            <a:srgbClr val="FFFFFF"/>
+          </a:solidFill>
+          <a:ln w="25400">
+            <a:solidFill>
+              <a:srgbClr val="CCCCCC"/>
+            </a:solidFill>
+          </a:ln>
+        </p:spPr>
+        <p:style>
+          <a:lnRef idx="1">
+            <a:schemeClr val="accent1"/>
+          </a:lnRef>
+          <a:fillRef idx="3">
+            <a:schemeClr val="accent1"/>
+          </a:fillRef>
+          <a:effectRef idx="2">
+            <a:schemeClr val="accent1"/>
+          </a:effectRef>
+          <a:fontRef idx="minor">
+            <a:schemeClr val="lt1"/>
+          </a:fontRef>
+        </p:style>
+        <p:txBody>
+          <a:bodyPr rtlCol="0" anchor="ctr" wrap="square" lIns="63500" rIns="50800" tIns="38100" bIns="38100"/>
+          <a:lstStyle/>
+          <a:p>
+            <a:pPr algn="l"/>
+            <a:r>
+              <a:rPr sz="800" b="0">
+                <a:solidFill>
+                  <a:srgbClr val="888888"/>
+                </a:solidFill>
+                <a:latin typeface="Meiryo"/>
+              </a:rPr>
+              <a:t>登録済みなので聞かない</a:t>
+            </a:r>
+          </a:p>
+        </p:txBody>
+      </p:sp>
+      <p:sp>
+        <p:nvSpPr>
+          <p:cNvPr id="25" name="Rectangle 24"/>
+          <p:cNvSpPr/>
+          <p:nvPr/>
+        </p:nvSpPr>
+        <p:spPr>
+          <a:xfrm>
+            <a:off x="7772400" y="3291840"/>
+            <a:ext cx="2926080" cy="457200"/>
+          </a:xfrm>
+          <a:prstGeom prst="rect">
+            <a:avLst/>
+          </a:prstGeom>
+          <a:solidFill>
+            <a:srgbClr val="FDEDEC"/>
+          </a:solidFill>
+          <a:ln w="25400">
+            <a:solidFill>
+              <a:srgbClr val="C0392B"/>
+            </a:solidFill>
+          </a:ln>
+        </p:spPr>
+        <p:style>
+          <a:lnRef idx="1">
+            <a:schemeClr val="accent1"/>
+          </a:lnRef>
+          <a:fillRef idx="3">
+            <a:schemeClr val="accent1"/>
+          </a:fillRef>
+          <a:effectRef idx="2">
+            <a:schemeClr val="accent1"/>
+          </a:effectRef>
+          <a:fontRef idx="minor">
+            <a:schemeClr val="lt1"/>
+          </a:fontRef>
+        </p:style>
+        <p:txBody>
+          <a:bodyPr rtlCol="0" anchor="ctr" wrap="square" lIns="63500" rIns="50800" tIns="38100" bIns="38100"/>
+          <a:lstStyle/>
+          <a:p>
+            <a:pPr algn="l"/>
+            <a:r>
+              <a:rPr sz="800" b="1">
+                <a:solidFill>
+                  <a:srgbClr val="C0392B"/>
+                </a:solidFill>
+                <a:latin typeface="Meiryo"/>
+              </a:rPr>
+              <a:t>❌ 5要素一括入力</a:t>
+            </a:r>
+          </a:p>
+        </p:txBody>
+      </p:sp>
+      <p:sp>
+        <p:nvSpPr>
+          <p:cNvPr id="26" name="Rectangle 25"/>
+          <p:cNvSpPr/>
+          <p:nvPr/>
+        </p:nvSpPr>
+        <p:spPr>
+          <a:xfrm>
+            <a:off x="10698480" y="3291840"/>
+            <a:ext cx="3474720" cy="457200"/>
+          </a:xfrm>
+          <a:prstGeom prst="rect">
+            <a:avLst/>
+          </a:prstGeom>
+          <a:solidFill>
+            <a:srgbClr val="FFFFFF"/>
+          </a:solidFill>
+          <a:ln w="25400">
+            <a:solidFill>
+              <a:srgbClr val="CCCCCC"/>
+            </a:solidFill>
+          </a:ln>
+        </p:spPr>
+        <p:style>
+          <a:lnRef idx="1">
+            <a:schemeClr val="accent1"/>
+          </a:lnRef>
+          <a:fillRef idx="3">
+            <a:schemeClr val="accent1"/>
+          </a:fillRef>
+          <a:effectRef idx="2">
+            <a:schemeClr val="accent1"/>
+          </a:effectRef>
+          <a:fontRef idx="minor">
+            <a:schemeClr val="lt1"/>
+          </a:fontRef>
+        </p:style>
+        <p:txBody>
+          <a:bodyPr rtlCol="0" anchor="ctr" wrap="square" lIns="63500" rIns="50800" tIns="38100" bIns="38100"/>
+          <a:lstStyle/>
+          <a:p>
+            <a:pPr algn="l"/>
+            <a:r>
+              <a:rPr sz="800" b="0">
+                <a:solidFill>
+                  <a:srgbClr val="888888"/>
+                </a:solidFill>
+                <a:latin typeface="Meiryo"/>
+              </a:rPr>
+              <a:t>段階的に認証する</a:t>
+            </a:r>
+          </a:p>
+        </p:txBody>
+      </p:sp>
+      <p:sp>
+        <p:nvSpPr>
+          <p:cNvPr id="27" name="TextBox 26"/>
+          <p:cNvSpPr txBox="1"/>
+          <p:nvPr/>
+        </p:nvSpPr>
+        <p:spPr>
+          <a:xfrm>
+            <a:off x="7772400" y="3840480"/>
+            <a:ext cx="6400800" cy="457200"/>
+          </a:xfrm>
+          <a:prstGeom prst="rect">
+            <a:avLst/>
+          </a:prstGeom>
+          <a:noFill/>
+        </p:spPr>
+        <p:txBody>
+          <a:bodyPr wrap="square" lIns="50800" rIns="50800" tIns="38100" bIns="38100"/>
+          <a:lstStyle/>
+          <a:p>
+            <a:pPr algn="l"/>
+            <a:r>
+              <a:rPr sz="900" b="0">
+                <a:solidFill>
+                  <a:srgbClr val="888888"/>
+                </a:solidFill>
+                <a:latin typeface="Meiryo"/>
+              </a:rPr>
+              <a:t>6個全て専門知識がないと気づけない。
+唯一「不明な発行元」だけがOSの警告で
+気づけるが、犯人のレベルアップで消える。</a:t>
+            </a:r>
+          </a:p>
+        </p:txBody>
+      </p:sp>
+      <p:sp>
+        <p:nvSpPr>
+          <p:cNvPr id="28" name="Rectangle 27"/>
+          <p:cNvSpPr/>
+          <p:nvPr/>
+        </p:nvSpPr>
+        <p:spPr>
+          <a:xfrm>
+            <a:off x="731520" y="4480560"/>
+            <a:ext cx="13624560" cy="365760"/>
+          </a:xfrm>
+          <a:prstGeom prst="rect">
+            <a:avLst/>
+          </a:prstGeom>
+          <a:solidFill>
+            <a:srgbClr val="C0392B"/>
+          </a:solidFill>
+          <a:ln>
+            <a:noFill/>
+          </a:ln>
+        </p:spPr>
+        <p:style>
+          <a:lnRef idx="1">
+            <a:schemeClr val="accent1"/>
+          </a:lnRef>
+          <a:fillRef idx="3">
+            <a:schemeClr val="accent1"/>
+          </a:fillRef>
+          <a:effectRef idx="2">
+            <a:schemeClr val="accent1"/>
+          </a:effectRef>
+          <a:fontRef idx="minor">
+            <a:schemeClr val="lt1"/>
+          </a:fontRef>
+        </p:style>
+        <p:txBody>
+          <a:bodyPr rtlCol="0" anchor="ctr" wrap="square" lIns="50800" rIns="50800" tIns="25400" bIns="25400"/>
+          <a:lstStyle/>
+          <a:p>
+            <a:pPr algn="ctr"/>
+            <a:r>
+              <a:rPr sz="1100" b="1">
+                <a:solidFill>
+                  <a:srgbClr val="FFFFFF"/>
+                </a:solidFill>
+                <a:latin typeface="Meiryo"/>
+              </a:rPr>
+              <a:t>犯人が言う「銀行が絶対に言わないセリフ」5つ → 全て手順②の恐怖で無効化される</a:t>
+            </a:r>
+          </a:p>
+        </p:txBody>
+      </p:sp>
+      <p:sp>
+        <p:nvSpPr>
+          <p:cNvPr id="29" name="Rectangle 28"/>
+          <p:cNvSpPr/>
+          <p:nvPr/>
+        </p:nvSpPr>
+        <p:spPr>
+          <a:xfrm>
+            <a:off x="731520" y="4937760"/>
+            <a:ext cx="13624560" cy="365760"/>
+          </a:xfrm>
+          <a:prstGeom prst="rect">
+            <a:avLst/>
+          </a:prstGeom>
+          <a:solidFill>
+            <a:srgbClr val="27AE60"/>
+          </a:solidFill>
+          <a:ln>
+            <a:noFill/>
+          </a:ln>
+        </p:spPr>
+        <p:style>
+          <a:lnRef idx="1">
+            <a:schemeClr val="accent1"/>
+          </a:lnRef>
+          <a:fillRef idx="3">
+            <a:schemeClr val="accent1"/>
+          </a:fillRef>
+          <a:effectRef idx="2">
+            <a:schemeClr val="accent1"/>
+          </a:effectRef>
+          <a:fontRef idx="minor">
+            <a:schemeClr val="lt1"/>
+          </a:fontRef>
+        </p:style>
+        <p:txBody>
+          <a:bodyPr rtlCol="0" anchor="ctr" wrap="square" lIns="50800" rIns="50800" tIns="25400" bIns="25400"/>
+          <a:lstStyle/>
+          <a:p>
+            <a:pPr algn="ctr"/>
+            <a:r>
+              <a:rPr sz="1100" b="1">
+                <a:solidFill>
+                  <a:srgbClr val="FFFFFF"/>
+                </a:solidFill>
+                <a:latin typeface="Meiryo"/>
+              </a:rPr>
+              <a:t>技術的にKill Chainを切れるポイント3つ → 全て既存ツール・追加コストゼロ・顧客に依存しない</a:t>
+            </a:r>
+          </a:p>
+        </p:txBody>
+      </p:sp>
+      <p:sp>
+        <p:nvSpPr>
+          <p:cNvPr id="30" name="Rectangle 29"/>
+          <p:cNvSpPr/>
+          <p:nvPr/>
+        </p:nvSpPr>
+        <p:spPr>
+          <a:xfrm>
+            <a:off x="731520" y="5303520"/>
+            <a:ext cx="3657600" cy="320040"/>
+          </a:xfrm>
+          <a:prstGeom prst="rect">
+            <a:avLst/>
+          </a:prstGeom>
+          <a:solidFill>
+            <a:srgbClr val="EAFAF1"/>
+          </a:solidFill>
+          <a:ln w="25400">
+            <a:solidFill>
+              <a:srgbClr val="27AE60"/>
+            </a:solidFill>
+          </a:ln>
+        </p:spPr>
+        <p:style>
+          <a:lnRef idx="1">
+            <a:schemeClr val="accent1"/>
+          </a:lnRef>
+          <a:fillRef idx="3">
+            <a:schemeClr val="accent1"/>
+          </a:fillRef>
+          <a:effectRef idx="2">
+            <a:schemeClr val="accent1"/>
+          </a:effectRef>
+          <a:fontRef idx="minor">
+            <a:schemeClr val="lt1"/>
+          </a:fontRef>
+        </p:style>
+        <p:txBody>
+          <a:bodyPr rtlCol="0" anchor="ctr" wrap="square" lIns="63500" rIns="50800" tIns="38100" bIns="38100"/>
+          <a:lstStyle/>
+          <a:p>
+            <a:pPr algn="l"/>
+            <a:r>
+              <a:rPr sz="900" b="1">
+                <a:solidFill>
+                  <a:srgbClr val="222222"/>
+                </a:solidFill>
+                <a:latin typeface="Meiryo"/>
+              </a:rPr>
+              <a:t>④ DMARC p=reject</a:t>
+            </a:r>
+          </a:p>
+        </p:txBody>
+      </p:sp>
+      <p:sp>
+        <p:nvSpPr>
+          <p:cNvPr id="31" name="Rectangle 30"/>
+          <p:cNvSpPr/>
+          <p:nvPr/>
+        </p:nvSpPr>
+        <p:spPr>
+          <a:xfrm>
+            <a:off x="4389120" y="5303520"/>
+            <a:ext cx="9966960" cy="320040"/>
+          </a:xfrm>
+          <a:prstGeom prst="rect">
+            <a:avLst/>
+          </a:prstGeom>
+          <a:solidFill>
+            <a:srgbClr val="EAFAF1"/>
+          </a:solidFill>
+          <a:ln w="25400">
+            <a:solidFill>
+              <a:srgbClr val="CCCCCC"/>
+            </a:solidFill>
+          </a:ln>
+        </p:spPr>
+        <p:style>
+          <a:lnRef idx="1">
+            <a:schemeClr val="accent1"/>
+          </a:lnRef>
+          <a:fillRef idx="3">
+            <a:schemeClr val="accent1"/>
+          </a:fillRef>
+          <a:effectRef idx="2">
+            <a:schemeClr val="accent1"/>
+          </a:effectRef>
+          <a:fontRef idx="minor">
+            <a:schemeClr val="lt1"/>
+          </a:fontRef>
+        </p:style>
+        <p:txBody>
+          <a:bodyPr rtlCol="0" anchor="ctr" wrap="square" lIns="63500" rIns="50800" tIns="38100" bIns="38100"/>
+          <a:lstStyle/>
+          <a:p>
+            <a:pPr algn="l"/>
+            <a:r>
+              <a:rPr sz="900" b="0">
+                <a:solidFill>
+                  <a:srgbClr val="222222"/>
+                </a:solidFill>
+                <a:latin typeface="Meiryo"/>
+              </a:rPr>
+              <a:t>メール遮断（銀行側で完結）</a:t>
+            </a:r>
+          </a:p>
+        </p:txBody>
+      </p:sp>
+      <p:sp>
+        <p:nvSpPr>
+          <p:cNvPr id="32" name="Rectangle 31"/>
+          <p:cNvSpPr/>
+          <p:nvPr/>
+        </p:nvSpPr>
+        <p:spPr>
+          <a:xfrm>
+            <a:off x="731520" y="5623560"/>
+            <a:ext cx="3657600" cy="320040"/>
+          </a:xfrm>
+          <a:prstGeom prst="rect">
+            <a:avLst/>
+          </a:prstGeom>
+          <a:solidFill>
+            <a:srgbClr val="EAFAF1"/>
+          </a:solidFill>
+          <a:ln w="25400">
+            <a:solidFill>
+              <a:srgbClr val="27AE60"/>
+            </a:solidFill>
+          </a:ln>
+        </p:spPr>
+        <p:style>
+          <a:lnRef idx="1">
+            <a:schemeClr val="accent1"/>
+          </a:lnRef>
+          <a:fillRef idx="3">
+            <a:schemeClr val="accent1"/>
+          </a:fillRef>
+          <a:effectRef idx="2">
+            <a:schemeClr val="accent1"/>
+          </a:effectRef>
+          <a:fontRef idx="minor">
+            <a:schemeClr val="lt1"/>
+          </a:fontRef>
+        </p:style>
+        <p:txBody>
+          <a:bodyPr rtlCol="0" anchor="ctr" wrap="square" lIns="63500" rIns="50800" tIns="38100" bIns="38100"/>
+          <a:lstStyle/>
+          <a:p>
+            <a:pPr algn="l"/>
+            <a:r>
+              <a:rPr sz="900" b="1">
+                <a:solidFill>
+                  <a:srgbClr val="222222"/>
+                </a:solidFill>
+                <a:latin typeface="Meiryo"/>
+              </a:rPr>
+              <a:t>⑥ AppLocker/WDAC</a:t>
+            </a:r>
+          </a:p>
+        </p:txBody>
+      </p:sp>
+      <p:sp>
+        <p:nvSpPr>
+          <p:cNvPr id="33" name="Rectangle 32"/>
+          <p:cNvSpPr/>
+          <p:nvPr/>
+        </p:nvSpPr>
+        <p:spPr>
+          <a:xfrm>
+            <a:off x="4389120" y="5623560"/>
+            <a:ext cx="9966960" cy="320040"/>
+          </a:xfrm>
+          <a:prstGeom prst="rect">
+            <a:avLst/>
+          </a:prstGeom>
+          <a:solidFill>
+            <a:srgbClr val="EAFAF1"/>
+          </a:solidFill>
+          <a:ln w="25400">
+            <a:solidFill>
+              <a:srgbClr val="CCCCCC"/>
+            </a:solidFill>
+          </a:ln>
+        </p:spPr>
+        <p:style>
+          <a:lnRef idx="1">
+            <a:schemeClr val="accent1"/>
+          </a:lnRef>
+          <a:fillRef idx="3">
+            <a:schemeClr val="accent1"/>
+          </a:fillRef>
+          <a:effectRef idx="2">
+            <a:schemeClr val="accent1"/>
+          </a:effectRef>
+          <a:fontRef idx="minor">
+            <a:schemeClr val="lt1"/>
+          </a:fontRef>
+        </p:style>
+        <p:txBody>
+          <a:bodyPr rtlCol="0" anchor="ctr" wrap="square" lIns="63500" rIns="50800" tIns="38100" bIns="38100"/>
+          <a:lstStyle/>
+          <a:p>
+            <a:pPr algn="l"/>
+            <a:r>
+              <a:rPr sz="900" b="0">
+                <a:solidFill>
+                  <a:srgbClr val="222222"/>
+                </a:solidFill>
+                <a:latin typeface="Meiryo"/>
+              </a:rPr>
+              <a:t>msi実行阻止（Windows標準搭載）</a:t>
+            </a:r>
+          </a:p>
+        </p:txBody>
+      </p:sp>
+      <p:sp>
+        <p:nvSpPr>
+          <p:cNvPr id="34" name="Rectangle 33"/>
+          <p:cNvSpPr/>
+          <p:nvPr/>
+        </p:nvSpPr>
+        <p:spPr>
+          <a:xfrm>
+            <a:off x="731520" y="5943600"/>
+            <a:ext cx="3657600" cy="320040"/>
+          </a:xfrm>
+          <a:prstGeom prst="rect">
+            <a:avLst/>
+          </a:prstGeom>
+          <a:solidFill>
+            <a:srgbClr val="EAFAF1"/>
+          </a:solidFill>
+          <a:ln w="25400">
+            <a:solidFill>
+              <a:srgbClr val="27AE60"/>
+            </a:solidFill>
+          </a:ln>
+        </p:spPr>
+        <p:style>
+          <a:lnRef idx="1">
+            <a:schemeClr val="accent1"/>
+          </a:lnRef>
+          <a:fillRef idx="3">
+            <a:schemeClr val="accent1"/>
+          </a:fillRef>
+          <a:effectRef idx="2">
+            <a:schemeClr val="accent1"/>
+          </a:effectRef>
+          <a:fontRef idx="minor">
+            <a:schemeClr val="lt1"/>
+          </a:fontRef>
+        </p:style>
+        <p:txBody>
+          <a:bodyPr rtlCol="0" anchor="ctr" wrap="square" lIns="63500" rIns="50800" tIns="38100" bIns="38100"/>
+          <a:lstStyle/>
+          <a:p>
+            <a:pPr algn="l"/>
+            <a:r>
+              <a:rPr sz="900" b="1">
+                <a:solidFill>
+                  <a:srgbClr val="222222"/>
+                </a:solidFill>
+                <a:latin typeface="Meiryo"/>
+              </a:rPr>
+              <a:t>⑦⑨ EDR/振る舞い検知</a:t>
+            </a:r>
+          </a:p>
+        </p:txBody>
+      </p:sp>
+      <p:sp>
+        <p:nvSpPr>
+          <p:cNvPr id="35" name="Rectangle 34"/>
+          <p:cNvSpPr/>
+          <p:nvPr/>
+        </p:nvSpPr>
+        <p:spPr>
+          <a:xfrm>
+            <a:off x="4389120" y="5943600"/>
+            <a:ext cx="9966960" cy="320040"/>
+          </a:xfrm>
+          <a:prstGeom prst="rect">
+            <a:avLst/>
+          </a:prstGeom>
+          <a:solidFill>
+            <a:srgbClr val="EAFAF1"/>
+          </a:solidFill>
+          <a:ln w="25400">
+            <a:solidFill>
+              <a:srgbClr val="CCCCCC"/>
+            </a:solidFill>
+          </a:ln>
+        </p:spPr>
+        <p:style>
+          <a:lnRef idx="1">
+            <a:schemeClr val="accent1"/>
+          </a:lnRef>
+          <a:fillRef idx="3">
+            <a:schemeClr val="accent1"/>
+          </a:fillRef>
+          <a:effectRef idx="2">
+            <a:schemeClr val="accent1"/>
+          </a:effectRef>
+          <a:fontRef idx="minor">
+            <a:schemeClr val="lt1"/>
+          </a:fontRef>
+        </p:style>
+        <p:txBody>
+          <a:bodyPr rtlCol="0" anchor="ctr" wrap="square" lIns="63500" rIns="50800" tIns="38100" bIns="38100"/>
+          <a:lstStyle/>
+          <a:p>
+            <a:pPr algn="l"/>
+            <a:r>
+              <a:rPr sz="900" b="0">
+                <a:solidFill>
+                  <a:srgbClr val="222222"/>
+                </a:solidFill>
+                <a:latin typeface="Meiryo"/>
+              </a:rPr>
+              <a:t>ScreenConnect通信＋異常送金検知</a:t>
+            </a:r>
+          </a:p>
+        </p:txBody>
+      </p:sp>
+      <p:sp>
+        <p:nvSpPr>
+          <p:cNvPr id="36" name="Rectangle 35"/>
+          <p:cNvSpPr/>
+          <p:nvPr/>
+        </p:nvSpPr>
+        <p:spPr>
+          <a:xfrm>
+            <a:off x="731520" y="6355080"/>
+            <a:ext cx="13624560" cy="365760"/>
+          </a:xfrm>
+          <a:prstGeom prst="rect">
+            <a:avLst/>
+          </a:prstGeom>
+          <a:solidFill>
+            <a:srgbClr val="E67E22"/>
+          </a:solidFill>
+          <a:ln>
+            <a:noFill/>
+          </a:ln>
+        </p:spPr>
+        <p:style>
+          <a:lnRef idx="1">
+            <a:schemeClr val="accent1"/>
+          </a:lnRef>
+          <a:fillRef idx="3">
+            <a:schemeClr val="accent1"/>
+          </a:fillRef>
+          <a:effectRef idx="2">
+            <a:schemeClr val="accent1"/>
+          </a:effectRef>
+          <a:fontRef idx="minor">
+            <a:schemeClr val="lt1"/>
+          </a:fontRef>
+        </p:style>
+        <p:txBody>
+          <a:bodyPr rtlCol="0" anchor="ctr" wrap="square" lIns="50800" rIns="50800" tIns="25400" bIns="25400"/>
+          <a:lstStyle/>
+          <a:p>
+            <a:pPr algn="ctr"/>
+            <a:r>
+              <a:rPr sz="1200" b="1">
+                <a:solidFill>
+                  <a:srgbClr val="FFFFFF"/>
+                </a:solidFill>
+                <a:latin typeface="Meiryo"/>
+              </a:rPr>
+              <a:t>全ての対策が「顧客にやってね」で丸投げされ、機能していない</a:t>
+            </a:r>
+          </a:p>
+        </p:txBody>
+      </p:sp>
+      <p:sp>
+        <p:nvSpPr>
+          <p:cNvPr id="37" name="Rectangle 36"/>
+          <p:cNvSpPr/>
+          <p:nvPr/>
+        </p:nvSpPr>
+        <p:spPr>
+          <a:xfrm>
+            <a:off x="731520" y="6812280"/>
+            <a:ext cx="13624560" cy="548640"/>
+          </a:xfrm>
+          <a:prstGeom prst="rect">
+            <a:avLst/>
+          </a:prstGeom>
+          <a:solidFill>
+            <a:srgbClr val="222222"/>
+          </a:solidFill>
+          <a:ln>
+            <a:noFill/>
+          </a:ln>
+        </p:spPr>
+        <p:style>
+          <a:lnRef idx="1">
+            <a:schemeClr val="accent1"/>
+          </a:lnRef>
+          <a:fillRef idx="3">
+            <a:schemeClr val="accent1"/>
+          </a:fillRef>
+          <a:effectRef idx="2">
+            <a:schemeClr val="accent1"/>
+          </a:effectRef>
+          <a:fontRef idx="minor">
+            <a:schemeClr val="lt1"/>
+          </a:fontRef>
+        </p:style>
+        <p:txBody>
+          <a:bodyPr rtlCol="0" anchor="ctr" wrap="square" lIns="50800" rIns="50800" tIns="25400" bIns="25400"/>
+          <a:lstStyle/>
+          <a:p>
+            <a:pPr algn="ctr"/>
+            <a:r>
+              <a:rPr sz="100" b="1">
+                <a:solidFill>
+                  <a:srgbClr val="FFFFFF"/>
+                </a:solidFill>
+                <a:latin typeface="Meiryo"/>
+              </a:rPr>
+              <a:t/>
+            </a:r>
+          </a:p>
+        </p:txBody>
+      </p:sp>
+      <p:sp>
+        <p:nvSpPr>
+          <p:cNvPr id="38" name="TextBox 37"/>
+          <p:cNvSpPr txBox="1"/>
+          <p:nvPr/>
+        </p:nvSpPr>
+        <p:spPr>
+          <a:xfrm>
+            <a:off x="1005840" y="6839712"/>
+            <a:ext cx="13075920" cy="502920"/>
+          </a:xfrm>
+          <a:prstGeom prst="rect">
+            <a:avLst/>
+          </a:prstGeom>
+          <a:noFill/>
+        </p:spPr>
+        <p:txBody>
+          <a:bodyPr wrap="square" lIns="50800" rIns="50800" tIns="38100" bIns="38100"/>
+          <a:lstStyle/>
+          <a:p>
+            <a:pPr algn="ctr"/>
+            <a:r>
+              <a:rPr sz="1300" b="1">
+                <a:solidFill>
+                  <a:srgbClr val="FFFFFF"/>
+                </a:solidFill>
+                <a:latin typeface="Meiryo"/>
+              </a:rPr>
+              <a:t>最終結論：この攻撃が成立している根本原因は、犯人の巧みさではなく
+「既にある対策を設定していない」「全てを顧客の問題にしている」こと。
+銀行側が技術的対策を実装すれば、この攻撃は成立しなくなる。</a:t>
+            </a:r>
+          </a:p>
+        </p:txBody>
+      </p:sp>
+      <p:sp>
+        <p:nvSpPr>
+          <p:cNvPr id="39" name="TextBox 38"/>
+          <p:cNvSpPr txBox="1"/>
+          <p:nvPr/>
+        </p:nvSpPr>
+        <p:spPr>
+          <a:xfrm>
+            <a:off x="9144000" y="10378440"/>
+            <a:ext cx="5943600" cy="228600"/>
+          </a:xfrm>
+          <a:prstGeom prst="rect">
+            <a:avLst/>
+          </a:prstGeom>
+          <a:noFill/>
+        </p:spPr>
+        <p:txBody>
+          <a:bodyPr wrap="square" lIns="50800" rIns="50800" tIns="38100" bIns="38100"/>
+          <a:lstStyle/>
+          <a:p>
+            <a:pPr algn="r"/>
+            <a:r>
+              <a:rPr sz="700" b="0">
+                <a:solidFill>
+                  <a:srgbClr val="888888"/>
+                </a:solidFill>
+                <a:latin typeface="Meiryo"/>
+              </a:rPr>
+              <a:t>Fraud Kill Chain — 総括</a:t>
             </a:r>
           </a:p>
         </p:txBody>

</xml_diff>

<commit_message>
Add slides 17-18 + Word update: SMB one-man-op target + weekly updates
Slide 17: Attack targets one-person operations where the owner has
full approval authority and no one to consult. All defense points
vanish with no colleagues, no IT staff, no separate approver.

Slide 18: Attackers run weekly PDCA on scripts. Awareness campaigns
take weeks/months to ship while scripts evolve every 7 days. Only
technical controls are scenario-independent.

https://claude.ai/code/session_01F7t8LKifK43o6sCdF2a3gQ
</commit_message>
<xml_diff>
--- a/Fraud_Kill_Chain.pptx
+++ b/Fraud_Kill_Chain.pptx
@@ -21,6 +21,8 @@
     <p:sldId id="269" r:id="rId20"/>
     <p:sldId id="270" r:id="rId21"/>
     <p:sldId id="271" r:id="rId22"/>
+    <p:sldId id="272" r:id="rId23"/>
+    <p:sldId id="273" r:id="rId24"/>
   </p:sldIdLst>
   <p:sldSz cx="15124176" cy="10689336" type="screen4x3"/>
   <p:notesSz cx="6858000" cy="9144000"/>
@@ -21513,6 +21515,4172 @@
                 <a:latin typeface="Meiryo"/>
               </a:rPr>
               <a:t>Fraud Kill Chain — 総括</a:t>
+            </a:r>
+          </a:p>
+        </p:txBody>
+      </p:sp>
+    </p:spTree>
+  </p:cSld>
+  <p:clrMapOvr>
+    <a:masterClrMapping/>
+  </p:clrMapOvr>
+</p:sld>
+</file>
+
+<file path=ppt/slides/slide17.xml><?xml version="1.0" encoding="utf-8"?>
+<p:sld xmlns:a="http://schemas.openxmlformats.org/drawingml/2006/main" xmlns:p="http://schemas.openxmlformats.org/presentationml/2006/main" xmlns:r="http://schemas.openxmlformats.org/officeDocument/2006/relationships">
+  <p:cSld>
+    <p:bg>
+      <p:bgPr>
+        <a:solidFill>
+          <a:srgbClr val="F5F5F5"/>
+        </a:solidFill>
+        <a:effectLst/>
+      </p:bgPr>
+    </p:bg>
+    <p:spTree>
+      <p:nvGrpSpPr>
+        <p:cNvPr id="1" name=""/>
+        <p:cNvGrpSpPr/>
+        <p:nvPr/>
+      </p:nvGrpSpPr>
+      <p:grpSpPr/>
+      <p:sp>
+        <p:nvSpPr>
+          <p:cNvPr id="2" name="TextBox 1"/>
+          <p:cNvSpPr txBox="1"/>
+          <p:nvPr/>
+        </p:nvSpPr>
+        <p:spPr>
+          <a:xfrm>
+            <a:off x="0" y="182880"/>
+            <a:ext cx="15124176" cy="548640"/>
+          </a:xfrm>
+          <a:prstGeom prst="rect">
+            <a:avLst/>
+          </a:prstGeom>
+          <a:noFill/>
+        </p:spPr>
+        <p:txBody>
+          <a:bodyPr wrap="square" lIns="50800" rIns="50800" tIns="38100" bIns="38100"/>
+          <a:lstStyle/>
+          <a:p>
+            <a:pPr algn="ctr"/>
+            <a:r>
+              <a:rPr sz="2400" b="1">
+                <a:solidFill>
+                  <a:srgbClr val="C0392B"/>
+                </a:solidFill>
+                <a:latin typeface="Meiryo"/>
+              </a:rPr>
+              <a:t>真のターゲット：ワンオペの零細企業</a:t>
+            </a:r>
+          </a:p>
+        </p:txBody>
+      </p:sp>
+      <p:sp>
+        <p:nvSpPr>
+          <p:cNvPr id="3" name="TextBox 2"/>
+          <p:cNvSpPr txBox="1"/>
+          <p:nvPr/>
+        </p:nvSpPr>
+        <p:spPr>
+          <a:xfrm>
+            <a:off x="0" y="640080"/>
+            <a:ext cx="15124176" cy="365760"/>
+          </a:xfrm>
+          <a:prstGeom prst="rect">
+            <a:avLst/>
+          </a:prstGeom>
+          <a:noFill/>
+        </p:spPr>
+        <p:txBody>
+          <a:bodyPr wrap="square" lIns="50800" rIns="50800" tIns="38100" bIns="38100"/>
+          <a:lstStyle/>
+          <a:p>
+            <a:pPr algn="ctr"/>
+            <a:r>
+              <a:rPr sz="1100" b="0">
+                <a:solidFill>
+                  <a:srgbClr val="888888"/>
+                </a:solidFill>
+                <a:latin typeface="Meiryo"/>
+              </a:rPr>
+              <a:t>「承認実行権限を持っている方は1を」— 犯人は最初からワンオペの社長を狙い撃ちしている。</a:t>
+            </a:r>
+          </a:p>
+        </p:txBody>
+      </p:sp>
+      <p:sp>
+        <p:nvSpPr>
+          <p:cNvPr id="4" name="Rectangle 3"/>
+          <p:cNvSpPr/>
+          <p:nvPr/>
+        </p:nvSpPr>
+        <p:spPr>
+          <a:xfrm>
+            <a:off x="731520" y="1051560"/>
+            <a:ext cx="13624560" cy="365760"/>
+          </a:xfrm>
+          <a:prstGeom prst="rect">
+            <a:avLst/>
+          </a:prstGeom>
+          <a:solidFill>
+            <a:srgbClr val="222222"/>
+          </a:solidFill>
+          <a:ln>
+            <a:noFill/>
+          </a:ln>
+        </p:spPr>
+        <p:style>
+          <a:lnRef idx="1">
+            <a:schemeClr val="accent1"/>
+          </a:lnRef>
+          <a:fillRef idx="3">
+            <a:schemeClr val="accent1"/>
+          </a:fillRef>
+          <a:effectRef idx="2">
+            <a:schemeClr val="accent1"/>
+          </a:effectRef>
+          <a:fontRef idx="minor">
+            <a:schemeClr val="lt1"/>
+          </a:fontRef>
+        </p:style>
+        <p:txBody>
+          <a:bodyPr rtlCol="0" anchor="ctr" wrap="square" lIns="50800" rIns="50800" tIns="25400" bIns="25400"/>
+          <a:lstStyle/>
+          <a:p>
+            <a:pPr algn="ctr"/>
+            <a:r>
+              <a:rPr sz="1200" b="1">
+                <a:solidFill>
+                  <a:srgbClr val="FFFFFF"/>
+                </a:solidFill>
+                <a:latin typeface="Meiryo"/>
+              </a:rPr>
+              <a:t>企業規模別の送金フロー — チェック機能の有無</a:t>
+            </a:r>
+          </a:p>
+        </p:txBody>
+      </p:sp>
+      <p:sp>
+        <p:nvSpPr>
+          <p:cNvPr id="5" name="Rectangle 4"/>
+          <p:cNvSpPr/>
+          <p:nvPr/>
+        </p:nvSpPr>
+        <p:spPr>
+          <a:xfrm>
+            <a:off x="731520" y="1417319"/>
+            <a:ext cx="1828800" cy="457200"/>
+          </a:xfrm>
+          <a:prstGeom prst="rect">
+            <a:avLst/>
+          </a:prstGeom>
+          <a:solidFill>
+            <a:srgbClr val="FFFFFF"/>
+          </a:solidFill>
+          <a:ln w="25400">
+            <a:solidFill>
+              <a:srgbClr val="27AE60"/>
+            </a:solidFill>
+          </a:ln>
+        </p:spPr>
+        <p:style>
+          <a:lnRef idx="1">
+            <a:schemeClr val="accent1"/>
+          </a:lnRef>
+          <a:fillRef idx="3">
+            <a:schemeClr val="accent1"/>
+          </a:fillRef>
+          <a:effectRef idx="2">
+            <a:schemeClr val="accent1"/>
+          </a:effectRef>
+          <a:fontRef idx="minor">
+            <a:schemeClr val="lt1"/>
+          </a:fontRef>
+        </p:style>
+        <p:txBody>
+          <a:bodyPr rtlCol="0" anchor="ctr" wrap="square" lIns="63500" rIns="50800" tIns="38100" bIns="38100"/>
+          <a:lstStyle/>
+          <a:p>
+            <a:pPr algn="l"/>
+            <a:r>
+              <a:rPr sz="1000" b="1">
+                <a:solidFill>
+                  <a:srgbClr val="222222"/>
+                </a:solidFill>
+                <a:latin typeface="Meiryo"/>
+              </a:rPr>
+              <a:t>大企業</a:t>
+            </a:r>
+          </a:p>
+        </p:txBody>
+      </p:sp>
+      <p:sp>
+        <p:nvSpPr>
+          <p:cNvPr id="6" name="Rectangle 5"/>
+          <p:cNvSpPr/>
+          <p:nvPr/>
+        </p:nvSpPr>
+        <p:spPr>
+          <a:xfrm>
+            <a:off x="2560320" y="1417319"/>
+            <a:ext cx="5029200" cy="457200"/>
+          </a:xfrm>
+          <a:prstGeom prst="rect">
+            <a:avLst/>
+          </a:prstGeom>
+          <a:solidFill>
+            <a:srgbClr val="FFFFFF"/>
+          </a:solidFill>
+          <a:ln w="25400">
+            <a:solidFill>
+              <a:srgbClr val="CCCCCC"/>
+            </a:solidFill>
+          </a:ln>
+        </p:spPr>
+        <p:style>
+          <a:lnRef idx="1">
+            <a:schemeClr val="accent1"/>
+          </a:lnRef>
+          <a:fillRef idx="3">
+            <a:schemeClr val="accent1"/>
+          </a:fillRef>
+          <a:effectRef idx="2">
+            <a:schemeClr val="accent1"/>
+          </a:effectRef>
+          <a:fontRef idx="minor">
+            <a:schemeClr val="lt1"/>
+          </a:fontRef>
+        </p:style>
+        <p:txBody>
+          <a:bodyPr rtlCol="0" anchor="ctr" wrap="square" lIns="63500" rIns="50800" tIns="38100" bIns="38100"/>
+          <a:lstStyle/>
+          <a:p>
+            <a:pPr algn="l"/>
+            <a:r>
+              <a:rPr sz="900" b="0">
+                <a:solidFill>
+                  <a:srgbClr val="222222"/>
+                </a:solidFill>
+                <a:latin typeface="Meiryo"/>
+              </a:rPr>
+              <a:t>担当者が作成 → 上長が承認 → 別の承認者が実行</a:t>
+            </a:r>
+          </a:p>
+        </p:txBody>
+      </p:sp>
+      <p:sp>
+        <p:nvSpPr>
+          <p:cNvPr id="7" name="Rectangle 6"/>
+          <p:cNvSpPr/>
+          <p:nvPr/>
+        </p:nvSpPr>
+        <p:spPr>
+          <a:xfrm>
+            <a:off x="7589520" y="1417319"/>
+            <a:ext cx="2286000" cy="457200"/>
+          </a:xfrm>
+          <a:prstGeom prst="rect">
+            <a:avLst/>
+          </a:prstGeom>
+          <a:solidFill>
+            <a:srgbClr val="FFFFFF"/>
+          </a:solidFill>
+          <a:ln w="25400">
+            <a:solidFill>
+              <a:srgbClr val="CCCCCC"/>
+            </a:solidFill>
+          </a:ln>
+        </p:spPr>
+        <p:style>
+          <a:lnRef idx="1">
+            <a:schemeClr val="accent1"/>
+          </a:lnRef>
+          <a:fillRef idx="3">
+            <a:schemeClr val="accent1"/>
+          </a:fillRef>
+          <a:effectRef idx="2">
+            <a:schemeClr val="accent1"/>
+          </a:effectRef>
+          <a:fontRef idx="minor">
+            <a:schemeClr val="lt1"/>
+          </a:fontRef>
+        </p:style>
+        <p:txBody>
+          <a:bodyPr rtlCol="0" anchor="ctr" wrap="square" lIns="63500" rIns="50800" tIns="38100" bIns="38100"/>
+          <a:lstStyle/>
+          <a:p>
+            <a:pPr algn="l"/>
+            <a:r>
+              <a:rPr sz="900" b="1">
+                <a:solidFill>
+                  <a:srgbClr val="222222"/>
+                </a:solidFill>
+                <a:latin typeface="Meiryo"/>
+              </a:rPr>
+              <a:t>3人が関与</a:t>
+            </a:r>
+          </a:p>
+        </p:txBody>
+      </p:sp>
+      <p:sp>
+        <p:nvSpPr>
+          <p:cNvPr id="8" name="Rectangle 7"/>
+          <p:cNvSpPr/>
+          <p:nvPr/>
+        </p:nvSpPr>
+        <p:spPr>
+          <a:xfrm>
+            <a:off x="9875520" y="1417319"/>
+            <a:ext cx="4480560" cy="457200"/>
+          </a:xfrm>
+          <a:prstGeom prst="rect">
+            <a:avLst/>
+          </a:prstGeom>
+          <a:solidFill>
+            <a:srgbClr val="27AE60"/>
+          </a:solidFill>
+          <a:ln>
+            <a:noFill/>
+          </a:ln>
+        </p:spPr>
+        <p:style>
+          <a:lnRef idx="1">
+            <a:schemeClr val="accent1"/>
+          </a:lnRef>
+          <a:fillRef idx="3">
+            <a:schemeClr val="accent1"/>
+          </a:fillRef>
+          <a:effectRef idx="2">
+            <a:schemeClr val="accent1"/>
+          </a:effectRef>
+          <a:fontRef idx="minor">
+            <a:schemeClr val="lt1"/>
+          </a:fontRef>
+        </p:style>
+        <p:txBody>
+          <a:bodyPr rtlCol="0" anchor="ctr" wrap="square" lIns="50800" rIns="50800" tIns="25400" bIns="25400"/>
+          <a:lstStyle/>
+          <a:p>
+            <a:pPr algn="ctr"/>
+            <a:r>
+              <a:rPr sz="900" b="1">
+                <a:solidFill>
+                  <a:srgbClr val="FFFFFF"/>
+                </a:solidFill>
+                <a:latin typeface="Meiryo"/>
+              </a:rPr>
+              <a:t>1人が騙されても止まる</a:t>
+            </a:r>
+          </a:p>
+        </p:txBody>
+      </p:sp>
+      <p:sp>
+        <p:nvSpPr>
+          <p:cNvPr id="9" name="Rectangle 8"/>
+          <p:cNvSpPr/>
+          <p:nvPr/>
+        </p:nvSpPr>
+        <p:spPr>
+          <a:xfrm>
+            <a:off x="731520" y="1874519"/>
+            <a:ext cx="1828800" cy="457200"/>
+          </a:xfrm>
+          <a:prstGeom prst="rect">
+            <a:avLst/>
+          </a:prstGeom>
+          <a:solidFill>
+            <a:srgbClr val="FFFFFF"/>
+          </a:solidFill>
+          <a:ln w="25400">
+            <a:solidFill>
+              <a:srgbClr val="E67E22"/>
+            </a:solidFill>
+          </a:ln>
+        </p:spPr>
+        <p:style>
+          <a:lnRef idx="1">
+            <a:schemeClr val="accent1"/>
+          </a:lnRef>
+          <a:fillRef idx="3">
+            <a:schemeClr val="accent1"/>
+          </a:fillRef>
+          <a:effectRef idx="2">
+            <a:schemeClr val="accent1"/>
+          </a:effectRef>
+          <a:fontRef idx="minor">
+            <a:schemeClr val="lt1"/>
+          </a:fontRef>
+        </p:style>
+        <p:txBody>
+          <a:bodyPr rtlCol="0" anchor="ctr" wrap="square" lIns="63500" rIns="50800" tIns="38100" bIns="38100"/>
+          <a:lstStyle/>
+          <a:p>
+            <a:pPr algn="l"/>
+            <a:r>
+              <a:rPr sz="1000" b="1">
+                <a:solidFill>
+                  <a:srgbClr val="222222"/>
+                </a:solidFill>
+                <a:latin typeface="Meiryo"/>
+              </a:rPr>
+              <a:t>中小企業</a:t>
+            </a:r>
+          </a:p>
+        </p:txBody>
+      </p:sp>
+      <p:sp>
+        <p:nvSpPr>
+          <p:cNvPr id="10" name="Rectangle 9"/>
+          <p:cNvSpPr/>
+          <p:nvPr/>
+        </p:nvSpPr>
+        <p:spPr>
+          <a:xfrm>
+            <a:off x="2560320" y="1874519"/>
+            <a:ext cx="5029200" cy="457200"/>
+          </a:xfrm>
+          <a:prstGeom prst="rect">
+            <a:avLst/>
+          </a:prstGeom>
+          <a:solidFill>
+            <a:srgbClr val="FFFFFF"/>
+          </a:solidFill>
+          <a:ln w="25400">
+            <a:solidFill>
+              <a:srgbClr val="CCCCCC"/>
+            </a:solidFill>
+          </a:ln>
+        </p:spPr>
+        <p:style>
+          <a:lnRef idx="1">
+            <a:schemeClr val="accent1"/>
+          </a:lnRef>
+          <a:fillRef idx="3">
+            <a:schemeClr val="accent1"/>
+          </a:fillRef>
+          <a:effectRef idx="2">
+            <a:schemeClr val="accent1"/>
+          </a:effectRef>
+          <a:fontRef idx="minor">
+            <a:schemeClr val="lt1"/>
+          </a:fontRef>
+        </p:style>
+        <p:txBody>
+          <a:bodyPr rtlCol="0" anchor="ctr" wrap="square" lIns="63500" rIns="50800" tIns="38100" bIns="38100"/>
+          <a:lstStyle/>
+          <a:p>
+            <a:pPr algn="l"/>
+            <a:r>
+              <a:rPr sz="900" b="0">
+                <a:solidFill>
+                  <a:srgbClr val="222222"/>
+                </a:solidFill>
+                <a:latin typeface="Meiryo"/>
+              </a:rPr>
+              <a:t>担当者が作成 → 上長が承認</a:t>
+            </a:r>
+          </a:p>
+        </p:txBody>
+      </p:sp>
+      <p:sp>
+        <p:nvSpPr>
+          <p:cNvPr id="11" name="Rectangle 10"/>
+          <p:cNvSpPr/>
+          <p:nvPr/>
+        </p:nvSpPr>
+        <p:spPr>
+          <a:xfrm>
+            <a:off x="7589520" y="1874519"/>
+            <a:ext cx="2286000" cy="457200"/>
+          </a:xfrm>
+          <a:prstGeom prst="rect">
+            <a:avLst/>
+          </a:prstGeom>
+          <a:solidFill>
+            <a:srgbClr val="FFFFFF"/>
+          </a:solidFill>
+          <a:ln w="25400">
+            <a:solidFill>
+              <a:srgbClr val="CCCCCC"/>
+            </a:solidFill>
+          </a:ln>
+        </p:spPr>
+        <p:style>
+          <a:lnRef idx="1">
+            <a:schemeClr val="accent1"/>
+          </a:lnRef>
+          <a:fillRef idx="3">
+            <a:schemeClr val="accent1"/>
+          </a:fillRef>
+          <a:effectRef idx="2">
+            <a:schemeClr val="accent1"/>
+          </a:effectRef>
+          <a:fontRef idx="minor">
+            <a:schemeClr val="lt1"/>
+          </a:fontRef>
+        </p:style>
+        <p:txBody>
+          <a:bodyPr rtlCol="0" anchor="ctr" wrap="square" lIns="63500" rIns="50800" tIns="38100" bIns="38100"/>
+          <a:lstStyle/>
+          <a:p>
+            <a:pPr algn="l"/>
+            <a:r>
+              <a:rPr sz="900" b="1">
+                <a:solidFill>
+                  <a:srgbClr val="222222"/>
+                </a:solidFill>
+                <a:latin typeface="Meiryo"/>
+              </a:rPr>
+              <a:t>2人が関与</a:t>
+            </a:r>
+          </a:p>
+        </p:txBody>
+      </p:sp>
+      <p:sp>
+        <p:nvSpPr>
+          <p:cNvPr id="12" name="Rectangle 11"/>
+          <p:cNvSpPr/>
+          <p:nvPr/>
+        </p:nvSpPr>
+        <p:spPr>
+          <a:xfrm>
+            <a:off x="9875520" y="1874519"/>
+            <a:ext cx="4480560" cy="457200"/>
+          </a:xfrm>
+          <a:prstGeom prst="rect">
+            <a:avLst/>
+          </a:prstGeom>
+          <a:solidFill>
+            <a:srgbClr val="E67E22"/>
+          </a:solidFill>
+          <a:ln>
+            <a:noFill/>
+          </a:ln>
+        </p:spPr>
+        <p:style>
+          <a:lnRef idx="1">
+            <a:schemeClr val="accent1"/>
+          </a:lnRef>
+          <a:fillRef idx="3">
+            <a:schemeClr val="accent1"/>
+          </a:fillRef>
+          <a:effectRef idx="2">
+            <a:schemeClr val="accent1"/>
+          </a:effectRef>
+          <a:fontRef idx="minor">
+            <a:schemeClr val="lt1"/>
+          </a:fontRef>
+        </p:style>
+        <p:txBody>
+          <a:bodyPr rtlCol="0" anchor="ctr" wrap="square" lIns="50800" rIns="50800" tIns="25400" bIns="25400"/>
+          <a:lstStyle/>
+          <a:p>
+            <a:pPr algn="ctr"/>
+            <a:r>
+              <a:rPr sz="900" b="1">
+                <a:solidFill>
+                  <a:srgbClr val="FFFFFF"/>
+                </a:solidFill>
+                <a:latin typeface="Meiryo"/>
+              </a:rPr>
+              <a:t>まだチェック機能がある</a:t>
+            </a:r>
+          </a:p>
+        </p:txBody>
+      </p:sp>
+      <p:sp>
+        <p:nvSpPr>
+          <p:cNvPr id="13" name="Rectangle 12"/>
+          <p:cNvSpPr/>
+          <p:nvPr/>
+        </p:nvSpPr>
+        <p:spPr>
+          <a:xfrm>
+            <a:off x="731520" y="2331720"/>
+            <a:ext cx="1828800" cy="457200"/>
+          </a:xfrm>
+          <a:prstGeom prst="rect">
+            <a:avLst/>
+          </a:prstGeom>
+          <a:solidFill>
+            <a:srgbClr val="FFFFFF"/>
+          </a:solidFill>
+          <a:ln w="25400">
+            <a:solidFill>
+              <a:srgbClr val="C0392B"/>
+            </a:solidFill>
+          </a:ln>
+        </p:spPr>
+        <p:style>
+          <a:lnRef idx="1">
+            <a:schemeClr val="accent1"/>
+          </a:lnRef>
+          <a:fillRef idx="3">
+            <a:schemeClr val="accent1"/>
+          </a:fillRef>
+          <a:effectRef idx="2">
+            <a:schemeClr val="accent1"/>
+          </a:effectRef>
+          <a:fontRef idx="minor">
+            <a:schemeClr val="lt1"/>
+          </a:fontRef>
+        </p:style>
+        <p:txBody>
+          <a:bodyPr rtlCol="0" anchor="ctr" wrap="square" lIns="63500" rIns="50800" tIns="38100" bIns="38100"/>
+          <a:lstStyle/>
+          <a:p>
+            <a:pPr algn="l"/>
+            <a:r>
+              <a:rPr sz="1000" b="1">
+                <a:solidFill>
+                  <a:srgbClr val="222222"/>
+                </a:solidFill>
+                <a:latin typeface="Meiryo"/>
+              </a:rPr>
+              <a:t>零細企業</a:t>
+            </a:r>
+          </a:p>
+        </p:txBody>
+      </p:sp>
+      <p:sp>
+        <p:nvSpPr>
+          <p:cNvPr id="14" name="Rectangle 13"/>
+          <p:cNvSpPr/>
+          <p:nvPr/>
+        </p:nvSpPr>
+        <p:spPr>
+          <a:xfrm>
+            <a:off x="2560320" y="2331720"/>
+            <a:ext cx="5029200" cy="457200"/>
+          </a:xfrm>
+          <a:prstGeom prst="rect">
+            <a:avLst/>
+          </a:prstGeom>
+          <a:solidFill>
+            <a:srgbClr val="FFFFFF"/>
+          </a:solidFill>
+          <a:ln w="25400">
+            <a:solidFill>
+              <a:srgbClr val="CCCCCC"/>
+            </a:solidFill>
+          </a:ln>
+        </p:spPr>
+        <p:style>
+          <a:lnRef idx="1">
+            <a:schemeClr val="accent1"/>
+          </a:lnRef>
+          <a:fillRef idx="3">
+            <a:schemeClr val="accent1"/>
+          </a:fillRef>
+          <a:effectRef idx="2">
+            <a:schemeClr val="accent1"/>
+          </a:effectRef>
+          <a:fontRef idx="minor">
+            <a:schemeClr val="lt1"/>
+          </a:fontRef>
+        </p:style>
+        <p:txBody>
+          <a:bodyPr rtlCol="0" anchor="ctr" wrap="square" lIns="63500" rIns="50800" tIns="38100" bIns="38100"/>
+          <a:lstStyle/>
+          <a:p>
+            <a:pPr algn="l"/>
+            <a:r>
+              <a:rPr sz="900" b="0">
+                <a:solidFill>
+                  <a:srgbClr val="222222"/>
+                </a:solidFill>
+                <a:latin typeface="Meiryo"/>
+              </a:rPr>
+              <a:t>社長が作成 → 社長が承認 → 社長が実行</a:t>
+            </a:r>
+          </a:p>
+        </p:txBody>
+      </p:sp>
+      <p:sp>
+        <p:nvSpPr>
+          <p:cNvPr id="15" name="Rectangle 14"/>
+          <p:cNvSpPr/>
+          <p:nvPr/>
+        </p:nvSpPr>
+        <p:spPr>
+          <a:xfrm>
+            <a:off x="7589520" y="2331720"/>
+            <a:ext cx="2286000" cy="457200"/>
+          </a:xfrm>
+          <a:prstGeom prst="rect">
+            <a:avLst/>
+          </a:prstGeom>
+          <a:solidFill>
+            <a:srgbClr val="FFFFFF"/>
+          </a:solidFill>
+          <a:ln w="25400">
+            <a:solidFill>
+              <a:srgbClr val="CCCCCC"/>
+            </a:solidFill>
+          </a:ln>
+        </p:spPr>
+        <p:style>
+          <a:lnRef idx="1">
+            <a:schemeClr val="accent1"/>
+          </a:lnRef>
+          <a:fillRef idx="3">
+            <a:schemeClr val="accent1"/>
+          </a:fillRef>
+          <a:effectRef idx="2">
+            <a:schemeClr val="accent1"/>
+          </a:effectRef>
+          <a:fontRef idx="minor">
+            <a:schemeClr val="lt1"/>
+          </a:fontRef>
+        </p:style>
+        <p:txBody>
+          <a:bodyPr rtlCol="0" anchor="ctr" wrap="square" lIns="63500" rIns="50800" tIns="38100" bIns="38100"/>
+          <a:lstStyle/>
+          <a:p>
+            <a:pPr algn="l"/>
+            <a:r>
+              <a:rPr sz="900" b="1">
+                <a:solidFill>
+                  <a:srgbClr val="222222"/>
+                </a:solidFill>
+                <a:latin typeface="Meiryo"/>
+              </a:rPr>
+              <a:t>1人（ワンオペ）</a:t>
+            </a:r>
+          </a:p>
+        </p:txBody>
+      </p:sp>
+      <p:sp>
+        <p:nvSpPr>
+          <p:cNvPr id="16" name="Rectangle 15"/>
+          <p:cNvSpPr/>
+          <p:nvPr/>
+        </p:nvSpPr>
+        <p:spPr>
+          <a:xfrm>
+            <a:off x="9875520" y="2331720"/>
+            <a:ext cx="4480560" cy="457200"/>
+          </a:xfrm>
+          <a:prstGeom prst="rect">
+            <a:avLst/>
+          </a:prstGeom>
+          <a:solidFill>
+            <a:srgbClr val="C0392B"/>
+          </a:solidFill>
+          <a:ln>
+            <a:noFill/>
+          </a:ln>
+        </p:spPr>
+        <p:style>
+          <a:lnRef idx="1">
+            <a:schemeClr val="accent1"/>
+          </a:lnRef>
+          <a:fillRef idx="3">
+            <a:schemeClr val="accent1"/>
+          </a:fillRef>
+          <a:effectRef idx="2">
+            <a:schemeClr val="accent1"/>
+          </a:effectRef>
+          <a:fontRef idx="minor">
+            <a:schemeClr val="lt1"/>
+          </a:fontRef>
+        </p:style>
+        <p:txBody>
+          <a:bodyPr rtlCol="0" anchor="ctr" wrap="square" lIns="50800" rIns="50800" tIns="25400" bIns="25400"/>
+          <a:lstStyle/>
+          <a:p>
+            <a:pPr algn="ctr"/>
+            <a:r>
+              <a:rPr sz="900" b="1">
+                <a:solidFill>
+                  <a:srgbClr val="FFFFFF"/>
+                </a:solidFill>
+                <a:latin typeface="Meiryo"/>
+              </a:rPr>
+              <a:t>チェック機能ゼロ</a:t>
+            </a:r>
+          </a:p>
+        </p:txBody>
+      </p:sp>
+      <p:sp>
+        <p:nvSpPr>
+          <p:cNvPr id="17" name="Rectangle 16"/>
+          <p:cNvSpPr/>
+          <p:nvPr/>
+        </p:nvSpPr>
+        <p:spPr>
+          <a:xfrm>
+            <a:off x="731520" y="2880360"/>
+            <a:ext cx="13624560" cy="365760"/>
+          </a:xfrm>
+          <a:prstGeom prst="rect">
+            <a:avLst/>
+          </a:prstGeom>
+          <a:solidFill>
+            <a:srgbClr val="C0392B"/>
+          </a:solidFill>
+          <a:ln>
+            <a:noFill/>
+          </a:ln>
+        </p:spPr>
+        <p:style>
+          <a:lnRef idx="1">
+            <a:schemeClr val="accent1"/>
+          </a:lnRef>
+          <a:fillRef idx="3">
+            <a:schemeClr val="accent1"/>
+          </a:fillRef>
+          <a:effectRef idx="2">
+            <a:schemeClr val="accent1"/>
+          </a:effectRef>
+          <a:fontRef idx="minor">
+            <a:schemeClr val="lt1"/>
+          </a:fontRef>
+        </p:style>
+        <p:txBody>
+          <a:bodyPr rtlCol="0" anchor="ctr" wrap="square" lIns="50800" rIns="50800" tIns="25400" bIns="25400"/>
+          <a:lstStyle/>
+          <a:p>
+            <a:pPr algn="ctr"/>
+            <a:r>
+              <a:rPr sz="1200" b="1">
+                <a:solidFill>
+                  <a:srgbClr val="FFFFFF"/>
+                </a:solidFill>
+                <a:latin typeface="Meiryo"/>
+              </a:rPr>
+              <a:t>ワンオペだと全ての防御ポイントが消滅する</a:t>
+            </a:r>
+          </a:p>
+        </p:txBody>
+      </p:sp>
+      <p:sp>
+        <p:nvSpPr>
+          <p:cNvPr id="18" name="Rectangle 17"/>
+          <p:cNvSpPr/>
+          <p:nvPr/>
+        </p:nvSpPr>
+        <p:spPr>
+          <a:xfrm>
+            <a:off x="731520" y="3246120"/>
+            <a:ext cx="3200400" cy="347472"/>
+          </a:xfrm>
+          <a:prstGeom prst="rect">
+            <a:avLst/>
+          </a:prstGeom>
+          <a:solidFill>
+            <a:srgbClr val="34495E"/>
+          </a:solidFill>
+          <a:ln>
+            <a:noFill/>
+          </a:ln>
+        </p:spPr>
+        <p:style>
+          <a:lnRef idx="1">
+            <a:schemeClr val="accent1"/>
+          </a:lnRef>
+          <a:fillRef idx="3">
+            <a:schemeClr val="accent1"/>
+          </a:fillRef>
+          <a:effectRef idx="2">
+            <a:schemeClr val="accent1"/>
+          </a:effectRef>
+          <a:fontRef idx="minor">
+            <a:schemeClr val="lt1"/>
+          </a:fontRef>
+        </p:style>
+        <p:txBody>
+          <a:bodyPr rtlCol="0" anchor="ctr" wrap="square" lIns="50800" rIns="50800" tIns="25400" bIns="25400"/>
+          <a:lstStyle/>
+          <a:p>
+            <a:pPr algn="ctr"/>
+            <a:r>
+              <a:rPr sz="900" b="1">
+                <a:solidFill>
+                  <a:srgbClr val="FFFFFF"/>
+                </a:solidFill>
+                <a:latin typeface="Meiryo"/>
+              </a:rPr>
+              <a:t>防御ポイント</a:t>
+            </a:r>
+          </a:p>
+        </p:txBody>
+      </p:sp>
+      <p:sp>
+        <p:nvSpPr>
+          <p:cNvPr id="19" name="Rectangle 18"/>
+          <p:cNvSpPr/>
+          <p:nvPr/>
+        </p:nvSpPr>
+        <p:spPr>
+          <a:xfrm>
+            <a:off x="3931920" y="3246120"/>
+            <a:ext cx="4754880" cy="347472"/>
+          </a:xfrm>
+          <a:prstGeom prst="rect">
+            <a:avLst/>
+          </a:prstGeom>
+          <a:solidFill>
+            <a:srgbClr val="34495E"/>
+          </a:solidFill>
+          <a:ln>
+            <a:noFill/>
+          </a:ln>
+        </p:spPr>
+        <p:style>
+          <a:lnRef idx="1">
+            <a:schemeClr val="accent1"/>
+          </a:lnRef>
+          <a:fillRef idx="3">
+            <a:schemeClr val="accent1"/>
+          </a:fillRef>
+          <a:effectRef idx="2">
+            <a:schemeClr val="accent1"/>
+          </a:effectRef>
+          <a:fontRef idx="minor">
+            <a:schemeClr val="lt1"/>
+          </a:fontRef>
+        </p:style>
+        <p:txBody>
+          <a:bodyPr rtlCol="0" anchor="ctr" wrap="square" lIns="50800" rIns="50800" tIns="25400" bIns="25400"/>
+          <a:lstStyle/>
+          <a:p>
+            <a:pPr algn="ctr"/>
+            <a:r>
+              <a:rPr sz="900" b="1">
+                <a:solidFill>
+                  <a:srgbClr val="FFFFFF"/>
+                </a:solidFill>
+                <a:latin typeface="Meiryo"/>
+              </a:rPr>
+              <a:t>複数人体制</a:t>
+            </a:r>
+          </a:p>
+        </p:txBody>
+      </p:sp>
+      <p:sp>
+        <p:nvSpPr>
+          <p:cNvPr id="20" name="Rectangle 19"/>
+          <p:cNvSpPr/>
+          <p:nvPr/>
+        </p:nvSpPr>
+        <p:spPr>
+          <a:xfrm>
+            <a:off x="8686800" y="3246120"/>
+            <a:ext cx="5669280" cy="347472"/>
+          </a:xfrm>
+          <a:prstGeom prst="rect">
+            <a:avLst/>
+          </a:prstGeom>
+          <a:solidFill>
+            <a:srgbClr val="34495E"/>
+          </a:solidFill>
+          <a:ln>
+            <a:noFill/>
+          </a:ln>
+        </p:spPr>
+        <p:style>
+          <a:lnRef idx="1">
+            <a:schemeClr val="accent1"/>
+          </a:lnRef>
+          <a:fillRef idx="3">
+            <a:schemeClr val="accent1"/>
+          </a:fillRef>
+          <a:effectRef idx="2">
+            <a:schemeClr val="accent1"/>
+          </a:effectRef>
+          <a:fontRef idx="minor">
+            <a:schemeClr val="lt1"/>
+          </a:fontRef>
+        </p:style>
+        <p:txBody>
+          <a:bodyPr rtlCol="0" anchor="ctr" wrap="square" lIns="50800" rIns="50800" tIns="25400" bIns="25400"/>
+          <a:lstStyle/>
+          <a:p>
+            <a:pPr algn="ctr"/>
+            <a:r>
+              <a:rPr sz="900" b="1">
+                <a:solidFill>
+                  <a:srgbClr val="FFFFFF"/>
+                </a:solidFill>
+                <a:latin typeface="Meiryo"/>
+              </a:rPr>
+              <a:t>ワンオペ</a:t>
+            </a:r>
+          </a:p>
+        </p:txBody>
+      </p:sp>
+      <p:sp>
+        <p:nvSpPr>
+          <p:cNvPr id="21" name="Rectangle 20"/>
+          <p:cNvSpPr/>
+          <p:nvPr/>
+        </p:nvSpPr>
+        <p:spPr>
+          <a:xfrm>
+            <a:off x="731520" y="3593591"/>
+            <a:ext cx="3200400" cy="365760"/>
+          </a:xfrm>
+          <a:prstGeom prst="rect">
+            <a:avLst/>
+          </a:prstGeom>
+          <a:solidFill>
+            <a:srgbClr val="FFFFFF"/>
+          </a:solidFill>
+          <a:ln w="25400">
+            <a:solidFill>
+              <a:srgbClr val="CCCCCC"/>
+            </a:solidFill>
+          </a:ln>
+        </p:spPr>
+        <p:style>
+          <a:lnRef idx="1">
+            <a:schemeClr val="accent1"/>
+          </a:lnRef>
+          <a:fillRef idx="3">
+            <a:schemeClr val="accent1"/>
+          </a:fillRef>
+          <a:effectRef idx="2">
+            <a:schemeClr val="accent1"/>
+          </a:effectRef>
+          <a:fontRef idx="minor">
+            <a:schemeClr val="lt1"/>
+          </a:fontRef>
+        </p:style>
+        <p:txBody>
+          <a:bodyPr rtlCol="0" anchor="ctr" wrap="square" lIns="63500" rIns="50800" tIns="38100" bIns="38100"/>
+          <a:lstStyle/>
+          <a:p>
+            <a:pPr algn="l"/>
+            <a:r>
+              <a:rPr sz="900" b="1">
+                <a:solidFill>
+                  <a:srgbClr val="222222"/>
+                </a:solidFill>
+                <a:latin typeface="Meiryo"/>
+              </a:rPr>
+              <a:t>「メアド教えて」に違和感</a:t>
+            </a:r>
+          </a:p>
+        </p:txBody>
+      </p:sp>
+      <p:sp>
+        <p:nvSpPr>
+          <p:cNvPr id="22" name="Rectangle 21"/>
+          <p:cNvSpPr/>
+          <p:nvPr/>
+        </p:nvSpPr>
+        <p:spPr>
+          <a:xfrm>
+            <a:off x="3931920" y="3593591"/>
+            <a:ext cx="4754880" cy="365760"/>
+          </a:xfrm>
+          <a:prstGeom prst="rect">
+            <a:avLst/>
+          </a:prstGeom>
+          <a:solidFill>
+            <a:srgbClr val="FFFFFF"/>
+          </a:solidFill>
+          <a:ln w="25400">
+            <a:solidFill>
+              <a:srgbClr val="27AE60"/>
+            </a:solidFill>
+          </a:ln>
+        </p:spPr>
+        <p:style>
+          <a:lnRef idx="1">
+            <a:schemeClr val="accent1"/>
+          </a:lnRef>
+          <a:fillRef idx="3">
+            <a:schemeClr val="accent1"/>
+          </a:fillRef>
+          <a:effectRef idx="2">
+            <a:schemeClr val="accent1"/>
+          </a:effectRef>
+          <a:fontRef idx="minor">
+            <a:schemeClr val="lt1"/>
+          </a:fontRef>
+        </p:style>
+        <p:txBody>
+          <a:bodyPr rtlCol="0" anchor="ctr" wrap="square" lIns="63500" rIns="50800" tIns="38100" bIns="38100"/>
+          <a:lstStyle/>
+          <a:p>
+            <a:pPr algn="l"/>
+            <a:r>
+              <a:rPr sz="900" b="0">
+                <a:solidFill>
+                  <a:srgbClr val="222222"/>
+                </a:solidFill>
+                <a:latin typeface="Meiryo"/>
+              </a:rPr>
+              <a:t>同僚に相談できる</a:t>
+            </a:r>
+          </a:p>
+        </p:txBody>
+      </p:sp>
+      <p:sp>
+        <p:nvSpPr>
+          <p:cNvPr id="23" name="Rectangle 22"/>
+          <p:cNvSpPr/>
+          <p:nvPr/>
+        </p:nvSpPr>
+        <p:spPr>
+          <a:xfrm>
+            <a:off x="8686800" y="3593591"/>
+            <a:ext cx="5669280" cy="365760"/>
+          </a:xfrm>
+          <a:prstGeom prst="rect">
+            <a:avLst/>
+          </a:prstGeom>
+          <a:solidFill>
+            <a:srgbClr val="FDEDEC"/>
+          </a:solidFill>
+          <a:ln>
+            <a:noFill/>
+          </a:ln>
+        </p:spPr>
+        <p:style>
+          <a:lnRef idx="1">
+            <a:schemeClr val="accent1"/>
+          </a:lnRef>
+          <a:fillRef idx="3">
+            <a:schemeClr val="accent1"/>
+          </a:fillRef>
+          <a:effectRef idx="2">
+            <a:schemeClr val="accent1"/>
+          </a:effectRef>
+          <a:fontRef idx="minor">
+            <a:schemeClr val="lt1"/>
+          </a:fontRef>
+        </p:style>
+        <p:txBody>
+          <a:bodyPr rtlCol="0" anchor="ctr" wrap="square" lIns="50800" rIns="50800" tIns="25400" bIns="25400"/>
+          <a:lstStyle/>
+          <a:p>
+            <a:pPr algn="l"/>
+            <a:r>
+              <a:rPr sz="900" b="1">
+                <a:solidFill>
+                  <a:srgbClr val="C0392B"/>
+                </a:solidFill>
+                <a:latin typeface="Meiryo"/>
+              </a:rPr>
+              <a:t>相談相手がいない</a:t>
+            </a:r>
+          </a:p>
+        </p:txBody>
+      </p:sp>
+      <p:sp>
+        <p:nvSpPr>
+          <p:cNvPr id="24" name="Rectangle 23"/>
+          <p:cNvSpPr/>
+          <p:nvPr/>
+        </p:nvSpPr>
+        <p:spPr>
+          <a:xfrm>
+            <a:off x="731520" y="3959352"/>
+            <a:ext cx="3200400" cy="365760"/>
+          </a:xfrm>
+          <a:prstGeom prst="rect">
+            <a:avLst/>
+          </a:prstGeom>
+          <a:solidFill>
+            <a:srgbClr val="F9F9F9"/>
+          </a:solidFill>
+          <a:ln w="25400">
+            <a:solidFill>
+              <a:srgbClr val="CCCCCC"/>
+            </a:solidFill>
+          </a:ln>
+        </p:spPr>
+        <p:style>
+          <a:lnRef idx="1">
+            <a:schemeClr val="accent1"/>
+          </a:lnRef>
+          <a:fillRef idx="3">
+            <a:schemeClr val="accent1"/>
+          </a:fillRef>
+          <a:effectRef idx="2">
+            <a:schemeClr val="accent1"/>
+          </a:effectRef>
+          <a:fontRef idx="minor">
+            <a:schemeClr val="lt1"/>
+          </a:fontRef>
+        </p:style>
+        <p:txBody>
+          <a:bodyPr rtlCol="0" anchor="ctr" wrap="square" lIns="63500" rIns="50800" tIns="38100" bIns="38100"/>
+          <a:lstStyle/>
+          <a:p>
+            <a:pPr algn="l"/>
+            <a:r>
+              <a:rPr sz="900" b="1">
+                <a:solidFill>
+                  <a:srgbClr val="222222"/>
+                </a:solidFill>
+                <a:latin typeface="Meiryo"/>
+              </a:rPr>
+              <a:t>不明な発行元の警告</a:t>
+            </a:r>
+          </a:p>
+        </p:txBody>
+      </p:sp>
+      <p:sp>
+        <p:nvSpPr>
+          <p:cNvPr id="25" name="Rectangle 24"/>
+          <p:cNvSpPr/>
+          <p:nvPr/>
+        </p:nvSpPr>
+        <p:spPr>
+          <a:xfrm>
+            <a:off x="3931920" y="3959352"/>
+            <a:ext cx="4754880" cy="365760"/>
+          </a:xfrm>
+          <a:prstGeom prst="rect">
+            <a:avLst/>
+          </a:prstGeom>
+          <a:solidFill>
+            <a:srgbClr val="F9F9F9"/>
+          </a:solidFill>
+          <a:ln w="25400">
+            <a:solidFill>
+              <a:srgbClr val="27AE60"/>
+            </a:solidFill>
+          </a:ln>
+        </p:spPr>
+        <p:style>
+          <a:lnRef idx="1">
+            <a:schemeClr val="accent1"/>
+          </a:lnRef>
+          <a:fillRef idx="3">
+            <a:schemeClr val="accent1"/>
+          </a:fillRef>
+          <a:effectRef idx="2">
+            <a:schemeClr val="accent1"/>
+          </a:effectRef>
+          <a:fontRef idx="minor">
+            <a:schemeClr val="lt1"/>
+          </a:fontRef>
+        </p:style>
+        <p:txBody>
+          <a:bodyPr rtlCol="0" anchor="ctr" wrap="square" lIns="63500" rIns="50800" tIns="38100" bIns="38100"/>
+          <a:lstStyle/>
+          <a:p>
+            <a:pPr algn="l"/>
+            <a:r>
+              <a:rPr sz="900" b="0">
+                <a:solidFill>
+                  <a:srgbClr val="222222"/>
+                </a:solidFill>
+                <a:latin typeface="Meiryo"/>
+              </a:rPr>
+              <a:t>IT担当に確認できる</a:t>
+            </a:r>
+          </a:p>
+        </p:txBody>
+      </p:sp>
+      <p:sp>
+        <p:nvSpPr>
+          <p:cNvPr id="26" name="Rectangle 25"/>
+          <p:cNvSpPr/>
+          <p:nvPr/>
+        </p:nvSpPr>
+        <p:spPr>
+          <a:xfrm>
+            <a:off x="8686800" y="3959352"/>
+            <a:ext cx="5669280" cy="365760"/>
+          </a:xfrm>
+          <a:prstGeom prst="rect">
+            <a:avLst/>
+          </a:prstGeom>
+          <a:solidFill>
+            <a:srgbClr val="FDEDEC"/>
+          </a:solidFill>
+          <a:ln>
+            <a:noFill/>
+          </a:ln>
+        </p:spPr>
+        <p:style>
+          <a:lnRef idx="1">
+            <a:schemeClr val="accent1"/>
+          </a:lnRef>
+          <a:fillRef idx="3">
+            <a:schemeClr val="accent1"/>
+          </a:fillRef>
+          <a:effectRef idx="2">
+            <a:schemeClr val="accent1"/>
+          </a:effectRef>
+          <a:fontRef idx="minor">
+            <a:schemeClr val="lt1"/>
+          </a:fontRef>
+        </p:style>
+        <p:txBody>
+          <a:bodyPr rtlCol="0" anchor="ctr" wrap="square" lIns="50800" rIns="50800" tIns="25400" bIns="25400"/>
+          <a:lstStyle/>
+          <a:p>
+            <a:pPr algn="l"/>
+            <a:r>
+              <a:rPr sz="900" b="1">
+                <a:solidFill>
+                  <a:srgbClr val="C0392B"/>
+                </a:solidFill>
+                <a:latin typeface="Meiryo"/>
+              </a:rPr>
+              <a:t>IT担当がいない</a:t>
+            </a:r>
+          </a:p>
+        </p:txBody>
+      </p:sp>
+      <p:sp>
+        <p:nvSpPr>
+          <p:cNvPr id="27" name="Rectangle 26"/>
+          <p:cNvSpPr/>
+          <p:nvPr/>
+        </p:nvSpPr>
+        <p:spPr>
+          <a:xfrm>
+            <a:off x="731520" y="4325112"/>
+            <a:ext cx="3200400" cy="365760"/>
+          </a:xfrm>
+          <a:prstGeom prst="rect">
+            <a:avLst/>
+          </a:prstGeom>
+          <a:solidFill>
+            <a:srgbClr val="FFFFFF"/>
+          </a:solidFill>
+          <a:ln w="25400">
+            <a:solidFill>
+              <a:srgbClr val="CCCCCC"/>
+            </a:solidFill>
+          </a:ln>
+        </p:spPr>
+        <p:style>
+          <a:lnRef idx="1">
+            <a:schemeClr val="accent1"/>
+          </a:lnRef>
+          <a:fillRef idx="3">
+            <a:schemeClr val="accent1"/>
+          </a:fillRef>
+          <a:effectRef idx="2">
+            <a:schemeClr val="accent1"/>
+          </a:effectRef>
+          <a:fontRef idx="minor">
+            <a:schemeClr val="lt1"/>
+          </a:fontRef>
+        </p:style>
+        <p:txBody>
+          <a:bodyPr rtlCol="0" anchor="ctr" wrap="square" lIns="63500" rIns="50800" tIns="38100" bIns="38100"/>
+          <a:lstStyle/>
+          <a:p>
+            <a:pPr algn="l"/>
+            <a:r>
+              <a:rPr sz="900" b="1">
+                <a:solidFill>
+                  <a:srgbClr val="222222"/>
+                </a:solidFill>
+                <a:latin typeface="Meiryo"/>
+              </a:rPr>
+              <a:t>送金の承認</a:t>
+            </a:r>
+          </a:p>
+        </p:txBody>
+      </p:sp>
+      <p:sp>
+        <p:nvSpPr>
+          <p:cNvPr id="28" name="Rectangle 27"/>
+          <p:cNvSpPr/>
+          <p:nvPr/>
+        </p:nvSpPr>
+        <p:spPr>
+          <a:xfrm>
+            <a:off x="3931920" y="4325112"/>
+            <a:ext cx="4754880" cy="365760"/>
+          </a:xfrm>
+          <a:prstGeom prst="rect">
+            <a:avLst/>
+          </a:prstGeom>
+          <a:solidFill>
+            <a:srgbClr val="FFFFFF"/>
+          </a:solidFill>
+          <a:ln w="25400">
+            <a:solidFill>
+              <a:srgbClr val="27AE60"/>
+            </a:solidFill>
+          </a:ln>
+        </p:spPr>
+        <p:style>
+          <a:lnRef idx="1">
+            <a:schemeClr val="accent1"/>
+          </a:lnRef>
+          <a:fillRef idx="3">
+            <a:schemeClr val="accent1"/>
+          </a:fillRef>
+          <a:effectRef idx="2">
+            <a:schemeClr val="accent1"/>
+          </a:effectRef>
+          <a:fontRef idx="minor">
+            <a:schemeClr val="lt1"/>
+          </a:fontRef>
+        </p:style>
+        <p:txBody>
+          <a:bodyPr rtlCol="0" anchor="ctr" wrap="square" lIns="63500" rIns="50800" tIns="38100" bIns="38100"/>
+          <a:lstStyle/>
+          <a:p>
+            <a:pPr algn="l"/>
+            <a:r>
+              <a:rPr sz="900" b="0">
+                <a:solidFill>
+                  <a:srgbClr val="222222"/>
+                </a:solidFill>
+                <a:latin typeface="Meiryo"/>
+              </a:rPr>
+              <a:t>別の承認者が止める</a:t>
+            </a:r>
+          </a:p>
+        </p:txBody>
+      </p:sp>
+      <p:sp>
+        <p:nvSpPr>
+          <p:cNvPr id="29" name="Rectangle 28"/>
+          <p:cNvSpPr/>
+          <p:nvPr/>
+        </p:nvSpPr>
+        <p:spPr>
+          <a:xfrm>
+            <a:off x="8686800" y="4325112"/>
+            <a:ext cx="5669280" cy="365760"/>
+          </a:xfrm>
+          <a:prstGeom prst="rect">
+            <a:avLst/>
+          </a:prstGeom>
+          <a:solidFill>
+            <a:srgbClr val="FDEDEC"/>
+          </a:solidFill>
+          <a:ln>
+            <a:noFill/>
+          </a:ln>
+        </p:spPr>
+        <p:style>
+          <a:lnRef idx="1">
+            <a:schemeClr val="accent1"/>
+          </a:lnRef>
+          <a:fillRef idx="3">
+            <a:schemeClr val="accent1"/>
+          </a:fillRef>
+          <a:effectRef idx="2">
+            <a:schemeClr val="accent1"/>
+          </a:effectRef>
+          <a:fontRef idx="minor">
+            <a:schemeClr val="lt1"/>
+          </a:fontRef>
+        </p:style>
+        <p:txBody>
+          <a:bodyPr rtlCol="0" anchor="ctr" wrap="square" lIns="50800" rIns="50800" tIns="25400" bIns="25400"/>
+          <a:lstStyle/>
+          <a:p>
+            <a:pPr algn="l"/>
+            <a:r>
+              <a:rPr sz="900" b="1">
+                <a:solidFill>
+                  <a:srgbClr val="C0392B"/>
+                </a:solidFill>
+                <a:latin typeface="Meiryo"/>
+              </a:rPr>
+              <a:t>自分で承認してしまう</a:t>
+            </a:r>
+          </a:p>
+        </p:txBody>
+      </p:sp>
+      <p:sp>
+        <p:nvSpPr>
+          <p:cNvPr id="30" name="Rectangle 29"/>
+          <p:cNvSpPr/>
+          <p:nvPr/>
+        </p:nvSpPr>
+        <p:spPr>
+          <a:xfrm>
+            <a:off x="731520" y="4690872"/>
+            <a:ext cx="3200400" cy="365760"/>
+          </a:xfrm>
+          <a:prstGeom prst="rect">
+            <a:avLst/>
+          </a:prstGeom>
+          <a:solidFill>
+            <a:srgbClr val="F9F9F9"/>
+          </a:solidFill>
+          <a:ln w="25400">
+            <a:solidFill>
+              <a:srgbClr val="CCCCCC"/>
+            </a:solidFill>
+          </a:ln>
+        </p:spPr>
+        <p:style>
+          <a:lnRef idx="1">
+            <a:schemeClr val="accent1"/>
+          </a:lnRef>
+          <a:fillRef idx="3">
+            <a:schemeClr val="accent1"/>
+          </a:fillRef>
+          <a:effectRef idx="2">
+            <a:schemeClr val="accent1"/>
+          </a:effectRef>
+          <a:fontRef idx="minor">
+            <a:schemeClr val="lt1"/>
+          </a:fontRef>
+        </p:style>
+        <p:txBody>
+          <a:bodyPr rtlCol="0" anchor="ctr" wrap="square" lIns="63500" rIns="50800" tIns="38100" bIns="38100"/>
+          <a:lstStyle/>
+          <a:p>
+            <a:pPr algn="l"/>
+            <a:r>
+              <a:rPr sz="900" b="1">
+                <a:solidFill>
+                  <a:srgbClr val="222222"/>
+                </a:solidFill>
+                <a:latin typeface="Meiryo"/>
+              </a:rPr>
+              <a:t>電話中に確認</a:t>
+            </a:r>
+          </a:p>
+        </p:txBody>
+      </p:sp>
+      <p:sp>
+        <p:nvSpPr>
+          <p:cNvPr id="31" name="Rectangle 30"/>
+          <p:cNvSpPr/>
+          <p:nvPr/>
+        </p:nvSpPr>
+        <p:spPr>
+          <a:xfrm>
+            <a:off x="3931920" y="4690872"/>
+            <a:ext cx="4754880" cy="365760"/>
+          </a:xfrm>
+          <a:prstGeom prst="rect">
+            <a:avLst/>
+          </a:prstGeom>
+          <a:solidFill>
+            <a:srgbClr val="F9F9F9"/>
+          </a:solidFill>
+          <a:ln w="25400">
+            <a:solidFill>
+              <a:srgbClr val="27AE60"/>
+            </a:solidFill>
+          </a:ln>
+        </p:spPr>
+        <p:style>
+          <a:lnRef idx="1">
+            <a:schemeClr val="accent1"/>
+          </a:lnRef>
+          <a:fillRef idx="3">
+            <a:schemeClr val="accent1"/>
+          </a:fillRef>
+          <a:effectRef idx="2">
+            <a:schemeClr val="accent1"/>
+          </a:effectRef>
+          <a:fontRef idx="minor">
+            <a:schemeClr val="lt1"/>
+          </a:fontRef>
+        </p:style>
+        <p:txBody>
+          <a:bodyPr rtlCol="0" anchor="ctr" wrap="square" lIns="63500" rIns="50800" tIns="38100" bIns="38100"/>
+          <a:lstStyle/>
+          <a:p>
+            <a:pPr algn="l"/>
+            <a:r>
+              <a:rPr sz="900" b="0">
+                <a:solidFill>
+                  <a:srgbClr val="222222"/>
+                </a:solidFill>
+                <a:latin typeface="Meiryo"/>
+              </a:rPr>
+              <a:t>他の人が銀行に電話できる</a:t>
+            </a:r>
+          </a:p>
+        </p:txBody>
+      </p:sp>
+      <p:sp>
+        <p:nvSpPr>
+          <p:cNvPr id="32" name="Rectangle 31"/>
+          <p:cNvSpPr/>
+          <p:nvPr/>
+        </p:nvSpPr>
+        <p:spPr>
+          <a:xfrm>
+            <a:off x="8686800" y="4690872"/>
+            <a:ext cx="5669280" cy="365760"/>
+          </a:xfrm>
+          <a:prstGeom prst="rect">
+            <a:avLst/>
+          </a:prstGeom>
+          <a:solidFill>
+            <a:srgbClr val="FDEDEC"/>
+          </a:solidFill>
+          <a:ln>
+            <a:noFill/>
+          </a:ln>
+        </p:spPr>
+        <p:style>
+          <a:lnRef idx="1">
+            <a:schemeClr val="accent1"/>
+          </a:lnRef>
+          <a:fillRef idx="3">
+            <a:schemeClr val="accent1"/>
+          </a:fillRef>
+          <a:effectRef idx="2">
+            <a:schemeClr val="accent1"/>
+          </a:effectRef>
+          <a:fontRef idx="minor">
+            <a:schemeClr val="lt1"/>
+          </a:fontRef>
+        </p:style>
+        <p:txBody>
+          <a:bodyPr rtlCol="0" anchor="ctr" wrap="square" lIns="50800" rIns="50800" tIns="25400" bIns="25400"/>
+          <a:lstStyle/>
+          <a:p>
+            <a:pPr algn="l"/>
+            <a:r>
+              <a:rPr sz="900" b="1">
+                <a:solidFill>
+                  <a:srgbClr val="C0392B"/>
+                </a:solidFill>
+                <a:latin typeface="Meiryo"/>
+              </a:rPr>
+              <a:t>自分しかいない</a:t>
+            </a:r>
+          </a:p>
+        </p:txBody>
+      </p:sp>
+      <p:sp>
+        <p:nvSpPr>
+          <p:cNvPr id="33" name="Rectangle 32"/>
+          <p:cNvSpPr/>
+          <p:nvPr/>
+        </p:nvSpPr>
+        <p:spPr>
+          <a:xfrm>
+            <a:off x="731520" y="5056631"/>
+            <a:ext cx="3200400" cy="365760"/>
+          </a:xfrm>
+          <a:prstGeom prst="rect">
+            <a:avLst/>
+          </a:prstGeom>
+          <a:solidFill>
+            <a:srgbClr val="FFFFFF"/>
+          </a:solidFill>
+          <a:ln w="25400">
+            <a:solidFill>
+              <a:srgbClr val="CCCCCC"/>
+            </a:solidFill>
+          </a:ln>
+        </p:spPr>
+        <p:style>
+          <a:lnRef idx="1">
+            <a:schemeClr val="accent1"/>
+          </a:lnRef>
+          <a:fillRef idx="3">
+            <a:schemeClr val="accent1"/>
+          </a:fillRef>
+          <a:effectRef idx="2">
+            <a:schemeClr val="accent1"/>
+          </a:effectRef>
+          <a:fontRef idx="minor">
+            <a:schemeClr val="lt1"/>
+          </a:fontRef>
+        </p:style>
+        <p:txBody>
+          <a:bodyPr rtlCol="0" anchor="ctr" wrap="square" lIns="63500" rIns="50800" tIns="38100" bIns="38100"/>
+          <a:lstStyle/>
+          <a:p>
+            <a:pPr algn="l"/>
+            <a:r>
+              <a:rPr sz="900" b="1">
+                <a:solidFill>
+                  <a:srgbClr val="222222"/>
+                </a:solidFill>
+                <a:latin typeface="Meiryo"/>
+              </a:rPr>
+              <a:t>事後の発覚</a:t>
+            </a:r>
+          </a:p>
+        </p:txBody>
+      </p:sp>
+      <p:sp>
+        <p:nvSpPr>
+          <p:cNvPr id="34" name="Rectangle 33"/>
+          <p:cNvSpPr/>
+          <p:nvPr/>
+        </p:nvSpPr>
+        <p:spPr>
+          <a:xfrm>
+            <a:off x="3931920" y="5056631"/>
+            <a:ext cx="4754880" cy="365760"/>
+          </a:xfrm>
+          <a:prstGeom prst="rect">
+            <a:avLst/>
+          </a:prstGeom>
+          <a:solidFill>
+            <a:srgbClr val="FFFFFF"/>
+          </a:solidFill>
+          <a:ln w="25400">
+            <a:solidFill>
+              <a:srgbClr val="27AE60"/>
+            </a:solidFill>
+          </a:ln>
+        </p:spPr>
+        <p:style>
+          <a:lnRef idx="1">
+            <a:schemeClr val="accent1"/>
+          </a:lnRef>
+          <a:fillRef idx="3">
+            <a:schemeClr val="accent1"/>
+          </a:fillRef>
+          <a:effectRef idx="2">
+            <a:schemeClr val="accent1"/>
+          </a:effectRef>
+          <a:fontRef idx="minor">
+            <a:schemeClr val="lt1"/>
+          </a:fontRef>
+        </p:style>
+        <p:txBody>
+          <a:bodyPr rtlCol="0" anchor="ctr" wrap="square" lIns="63500" rIns="50800" tIns="38100" bIns="38100"/>
+          <a:lstStyle/>
+          <a:p>
+            <a:pPr algn="l"/>
+            <a:r>
+              <a:rPr sz="900" b="0">
+                <a:solidFill>
+                  <a:srgbClr val="222222"/>
+                </a:solidFill>
+                <a:latin typeface="Meiryo"/>
+              </a:rPr>
+              <a:t>経理が不審な送金に気づく</a:t>
+            </a:r>
+          </a:p>
+        </p:txBody>
+      </p:sp>
+      <p:sp>
+        <p:nvSpPr>
+          <p:cNvPr id="35" name="Rectangle 34"/>
+          <p:cNvSpPr/>
+          <p:nvPr/>
+        </p:nvSpPr>
+        <p:spPr>
+          <a:xfrm>
+            <a:off x="8686800" y="5056631"/>
+            <a:ext cx="5669280" cy="365760"/>
+          </a:xfrm>
+          <a:prstGeom prst="rect">
+            <a:avLst/>
+          </a:prstGeom>
+          <a:solidFill>
+            <a:srgbClr val="FDEDEC"/>
+          </a:solidFill>
+          <a:ln>
+            <a:noFill/>
+          </a:ln>
+        </p:spPr>
+        <p:style>
+          <a:lnRef idx="1">
+            <a:schemeClr val="accent1"/>
+          </a:lnRef>
+          <a:fillRef idx="3">
+            <a:schemeClr val="accent1"/>
+          </a:fillRef>
+          <a:effectRef idx="2">
+            <a:schemeClr val="accent1"/>
+          </a:effectRef>
+          <a:fontRef idx="minor">
+            <a:schemeClr val="lt1"/>
+          </a:fontRef>
+        </p:style>
+        <p:txBody>
+          <a:bodyPr rtlCol="0" anchor="ctr" wrap="square" lIns="50800" rIns="50800" tIns="25400" bIns="25400"/>
+          <a:lstStyle/>
+          <a:p>
+            <a:pPr algn="l"/>
+            <a:r>
+              <a:rPr sz="900" b="1">
+                <a:solidFill>
+                  <a:srgbClr val="C0392B"/>
+                </a:solidFill>
+                <a:latin typeface="Meiryo"/>
+              </a:rPr>
+              <a:t>自分が経理</a:t>
+            </a:r>
+          </a:p>
+        </p:txBody>
+      </p:sp>
+      <p:sp>
+        <p:nvSpPr>
+          <p:cNvPr id="36" name="Rectangle 35"/>
+          <p:cNvSpPr/>
+          <p:nvPr/>
+        </p:nvSpPr>
+        <p:spPr>
+          <a:xfrm>
+            <a:off x="731520" y="5532120"/>
+            <a:ext cx="13624560" cy="365760"/>
+          </a:xfrm>
+          <a:prstGeom prst="rect">
+            <a:avLst/>
+          </a:prstGeom>
+          <a:solidFill>
+            <a:srgbClr val="222222"/>
+          </a:solidFill>
+          <a:ln>
+            <a:noFill/>
+          </a:ln>
+        </p:spPr>
+        <p:style>
+          <a:lnRef idx="1">
+            <a:schemeClr val="accent1"/>
+          </a:lnRef>
+          <a:fillRef idx="3">
+            <a:schemeClr val="accent1"/>
+          </a:fillRef>
+          <a:effectRef idx="2">
+            <a:schemeClr val="accent1"/>
+          </a:effectRef>
+          <a:fontRef idx="minor">
+            <a:schemeClr val="lt1"/>
+          </a:fontRef>
+        </p:style>
+        <p:txBody>
+          <a:bodyPr rtlCol="0" anchor="ctr" wrap="square" lIns="50800" rIns="50800" tIns="25400" bIns="25400"/>
+          <a:lstStyle/>
+          <a:p>
+            <a:pPr algn="ctr"/>
+            <a:r>
+              <a:rPr sz="1200" b="1">
+                <a:solidFill>
+                  <a:srgbClr val="FFFFFF"/>
+                </a:solidFill>
+                <a:latin typeface="Meiryo"/>
+              </a:rPr>
+              <a:t>犯人の攻撃設計は最初からワンオペ零細企業を想定している</a:t>
+            </a:r>
+          </a:p>
+        </p:txBody>
+      </p:sp>
+      <p:sp>
+        <p:nvSpPr>
+          <p:cNvPr id="37" name="Rectangle 36"/>
+          <p:cNvSpPr/>
+          <p:nvPr/>
+        </p:nvSpPr>
+        <p:spPr>
+          <a:xfrm>
+            <a:off x="731520" y="5897880"/>
+            <a:ext cx="4572000" cy="347472"/>
+          </a:xfrm>
+          <a:prstGeom prst="rect">
+            <a:avLst/>
+          </a:prstGeom>
+          <a:solidFill>
+            <a:srgbClr val="FFFFFF"/>
+          </a:solidFill>
+          <a:ln w="25400">
+            <a:solidFill>
+              <a:srgbClr val="C0392B"/>
+            </a:solidFill>
+          </a:ln>
+        </p:spPr>
+        <p:style>
+          <a:lnRef idx="1">
+            <a:schemeClr val="accent1"/>
+          </a:lnRef>
+          <a:fillRef idx="3">
+            <a:schemeClr val="accent1"/>
+          </a:fillRef>
+          <a:effectRef idx="2">
+            <a:schemeClr val="accent1"/>
+          </a:effectRef>
+          <a:fontRef idx="minor">
+            <a:schemeClr val="lt1"/>
+          </a:fontRef>
+        </p:style>
+        <p:txBody>
+          <a:bodyPr rtlCol="0" anchor="ctr" wrap="square" lIns="63500" rIns="50800" tIns="38100" bIns="38100"/>
+          <a:lstStyle/>
+          <a:p>
+            <a:pPr algn="l"/>
+            <a:r>
+              <a:rPr sz="900" b="1">
+                <a:solidFill>
+                  <a:srgbClr val="222222"/>
+                </a:solidFill>
+                <a:latin typeface="Meiryo"/>
+              </a:rPr>
+              <a:t>「承認実行権限を持っている方」</a:t>
+            </a:r>
+          </a:p>
+        </p:txBody>
+      </p:sp>
+      <p:sp>
+        <p:nvSpPr>
+          <p:cNvPr id="38" name="Rectangle 37"/>
+          <p:cNvSpPr/>
+          <p:nvPr/>
+        </p:nvSpPr>
+        <p:spPr>
+          <a:xfrm>
+            <a:off x="5303520" y="5897880"/>
+            <a:ext cx="9052560" cy="347472"/>
+          </a:xfrm>
+          <a:prstGeom prst="rect">
+            <a:avLst/>
+          </a:prstGeom>
+          <a:solidFill>
+            <a:srgbClr val="FFFFFF"/>
+          </a:solidFill>
+          <a:ln w="25400">
+            <a:solidFill>
+              <a:srgbClr val="CCCCCC"/>
+            </a:solidFill>
+          </a:ln>
+        </p:spPr>
+        <p:style>
+          <a:lnRef idx="1">
+            <a:schemeClr val="accent1"/>
+          </a:lnRef>
+          <a:fillRef idx="3">
+            <a:schemeClr val="accent1"/>
+          </a:fillRef>
+          <a:effectRef idx="2">
+            <a:schemeClr val="accent1"/>
+          </a:effectRef>
+          <a:fontRef idx="minor">
+            <a:schemeClr val="lt1"/>
+          </a:fontRef>
+        </p:style>
+        <p:txBody>
+          <a:bodyPr rtlCol="0" anchor="ctr" wrap="square" lIns="63500" rIns="50800" tIns="38100" bIns="38100"/>
+          <a:lstStyle/>
+          <a:p>
+            <a:pPr algn="l"/>
+            <a:r>
+              <a:rPr sz="900" b="0">
+                <a:solidFill>
+                  <a:srgbClr val="222222"/>
+                </a:solidFill>
+                <a:latin typeface="Meiryo"/>
+              </a:rPr>
+              <a:t>ワンオペの社長を自動選別</a:t>
+            </a:r>
+          </a:p>
+        </p:txBody>
+      </p:sp>
+      <p:sp>
+        <p:nvSpPr>
+          <p:cNvPr id="39" name="Rectangle 38"/>
+          <p:cNvSpPr/>
+          <p:nvPr/>
+        </p:nvSpPr>
+        <p:spPr>
+          <a:xfrm>
+            <a:off x="731520" y="6245352"/>
+            <a:ext cx="4572000" cy="347472"/>
+          </a:xfrm>
+          <a:prstGeom prst="rect">
+            <a:avLst/>
+          </a:prstGeom>
+          <a:solidFill>
+            <a:srgbClr val="F9F9F9"/>
+          </a:solidFill>
+          <a:ln w="25400">
+            <a:solidFill>
+              <a:srgbClr val="C0392B"/>
+            </a:solidFill>
+          </a:ln>
+        </p:spPr>
+        <p:style>
+          <a:lnRef idx="1">
+            <a:schemeClr val="accent1"/>
+          </a:lnRef>
+          <a:fillRef idx="3">
+            <a:schemeClr val="accent1"/>
+          </a:fillRef>
+          <a:effectRef idx="2">
+            <a:schemeClr val="accent1"/>
+          </a:effectRef>
+          <a:fontRef idx="minor">
+            <a:schemeClr val="lt1"/>
+          </a:fontRef>
+        </p:style>
+        <p:txBody>
+          <a:bodyPr rtlCol="0" anchor="ctr" wrap="square" lIns="63500" rIns="50800" tIns="38100" bIns="38100"/>
+          <a:lstStyle/>
+          <a:p>
+            <a:pPr algn="l"/>
+            <a:r>
+              <a:rPr sz="900" b="1">
+                <a:solidFill>
+                  <a:srgbClr val="222222"/>
+                </a:solidFill>
+                <a:latin typeface="Meiryo"/>
+              </a:rPr>
+              <a:t>電話をつないだまま</a:t>
+            </a:r>
+          </a:p>
+        </p:txBody>
+      </p:sp>
+      <p:sp>
+        <p:nvSpPr>
+          <p:cNvPr id="40" name="Rectangle 39"/>
+          <p:cNvSpPr/>
+          <p:nvPr/>
+        </p:nvSpPr>
+        <p:spPr>
+          <a:xfrm>
+            <a:off x="5303520" y="6245352"/>
+            <a:ext cx="9052560" cy="347472"/>
+          </a:xfrm>
+          <a:prstGeom prst="rect">
+            <a:avLst/>
+          </a:prstGeom>
+          <a:solidFill>
+            <a:srgbClr val="F9F9F9"/>
+          </a:solidFill>
+          <a:ln w="25400">
+            <a:solidFill>
+              <a:srgbClr val="CCCCCC"/>
+            </a:solidFill>
+          </a:ln>
+        </p:spPr>
+        <p:style>
+          <a:lnRef idx="1">
+            <a:schemeClr val="accent1"/>
+          </a:lnRef>
+          <a:fillRef idx="3">
+            <a:schemeClr val="accent1"/>
+          </a:fillRef>
+          <a:effectRef idx="2">
+            <a:schemeClr val="accent1"/>
+          </a:effectRef>
+          <a:fontRef idx="minor">
+            <a:schemeClr val="lt1"/>
+          </a:fontRef>
+        </p:style>
+        <p:txBody>
+          <a:bodyPr rtlCol="0" anchor="ctr" wrap="square" lIns="63500" rIns="50800" tIns="38100" bIns="38100"/>
+          <a:lstStyle/>
+          <a:p>
+            <a:pPr algn="l"/>
+            <a:r>
+              <a:rPr sz="900" b="0">
+                <a:solidFill>
+                  <a:srgbClr val="222222"/>
+                </a:solidFill>
+                <a:latin typeface="Meiryo"/>
+              </a:rPr>
+              <a:t>相談相手がいない状況を利用</a:t>
+            </a:r>
+          </a:p>
+        </p:txBody>
+      </p:sp>
+      <p:sp>
+        <p:nvSpPr>
+          <p:cNvPr id="41" name="Rectangle 40"/>
+          <p:cNvSpPr/>
+          <p:nvPr/>
+        </p:nvSpPr>
+        <p:spPr>
+          <a:xfrm>
+            <a:off x="731520" y="6592824"/>
+            <a:ext cx="4572000" cy="347472"/>
+          </a:xfrm>
+          <a:prstGeom prst="rect">
+            <a:avLst/>
+          </a:prstGeom>
+          <a:solidFill>
+            <a:srgbClr val="FFFFFF"/>
+          </a:solidFill>
+          <a:ln w="25400">
+            <a:solidFill>
+              <a:srgbClr val="C0392B"/>
+            </a:solidFill>
+          </a:ln>
+        </p:spPr>
+        <p:style>
+          <a:lnRef idx="1">
+            <a:schemeClr val="accent1"/>
+          </a:lnRef>
+          <a:fillRef idx="3">
+            <a:schemeClr val="accent1"/>
+          </a:fillRef>
+          <a:effectRef idx="2">
+            <a:schemeClr val="accent1"/>
+          </a:effectRef>
+          <a:fontRef idx="minor">
+            <a:schemeClr val="lt1"/>
+          </a:fontRef>
+        </p:style>
+        <p:txBody>
+          <a:bodyPr rtlCol="0" anchor="ctr" wrap="square" lIns="63500" rIns="50800" tIns="38100" bIns="38100"/>
+          <a:lstStyle/>
+          <a:p>
+            <a:pPr algn="l"/>
+            <a:r>
+              <a:rPr sz="900" b="1">
+                <a:solidFill>
+                  <a:srgbClr val="222222"/>
+                </a:solidFill>
+                <a:latin typeface="Meiryo"/>
+              </a:rPr>
+              <a:t>幅広に架電</a:t>
+            </a:r>
+          </a:p>
+        </p:txBody>
+      </p:sp>
+      <p:sp>
+        <p:nvSpPr>
+          <p:cNvPr id="42" name="Rectangle 41"/>
+          <p:cNvSpPr/>
+          <p:nvPr/>
+        </p:nvSpPr>
+        <p:spPr>
+          <a:xfrm>
+            <a:off x="5303520" y="6592824"/>
+            <a:ext cx="9052560" cy="347472"/>
+          </a:xfrm>
+          <a:prstGeom prst="rect">
+            <a:avLst/>
+          </a:prstGeom>
+          <a:solidFill>
+            <a:srgbClr val="FFFFFF"/>
+          </a:solidFill>
+          <a:ln w="25400">
+            <a:solidFill>
+              <a:srgbClr val="CCCCCC"/>
+            </a:solidFill>
+          </a:ln>
+        </p:spPr>
+        <p:style>
+          <a:lnRef idx="1">
+            <a:schemeClr val="accent1"/>
+          </a:lnRef>
+          <a:fillRef idx="3">
+            <a:schemeClr val="accent1"/>
+          </a:fillRef>
+          <a:effectRef idx="2">
+            <a:schemeClr val="accent1"/>
+          </a:effectRef>
+          <a:fontRef idx="minor">
+            <a:schemeClr val="lt1"/>
+          </a:fontRef>
+        </p:style>
+        <p:txBody>
+          <a:bodyPr rtlCol="0" anchor="ctr" wrap="square" lIns="63500" rIns="50800" tIns="38100" bIns="38100"/>
+          <a:lstStyle/>
+          <a:p>
+            <a:pPr algn="l"/>
+            <a:r>
+              <a:rPr sz="900" b="0">
+                <a:solidFill>
+                  <a:srgbClr val="222222"/>
+                </a:solidFill>
+                <a:latin typeface="Meiryo"/>
+              </a:rPr>
+              <a:t>零細企業の数は圧倒的に多い</a:t>
+            </a:r>
+          </a:p>
+        </p:txBody>
+      </p:sp>
+      <p:sp>
+        <p:nvSpPr>
+          <p:cNvPr id="43" name="Rectangle 42"/>
+          <p:cNvSpPr/>
+          <p:nvPr/>
+        </p:nvSpPr>
+        <p:spPr>
+          <a:xfrm>
+            <a:off x="731520" y="6940296"/>
+            <a:ext cx="4572000" cy="347472"/>
+          </a:xfrm>
+          <a:prstGeom prst="rect">
+            <a:avLst/>
+          </a:prstGeom>
+          <a:solidFill>
+            <a:srgbClr val="F9F9F9"/>
+          </a:solidFill>
+          <a:ln w="25400">
+            <a:solidFill>
+              <a:srgbClr val="C0392B"/>
+            </a:solidFill>
+          </a:ln>
+        </p:spPr>
+        <p:style>
+          <a:lnRef idx="1">
+            <a:schemeClr val="accent1"/>
+          </a:lnRef>
+          <a:fillRef idx="3">
+            <a:schemeClr val="accent1"/>
+          </a:fillRef>
+          <a:effectRef idx="2">
+            <a:schemeClr val="accent1"/>
+          </a:effectRef>
+          <a:fontRef idx="minor">
+            <a:schemeClr val="lt1"/>
+          </a:fontRef>
+        </p:style>
+        <p:txBody>
+          <a:bodyPr rtlCol="0" anchor="ctr" wrap="square" lIns="63500" rIns="50800" tIns="38100" bIns="38100"/>
+          <a:lstStyle/>
+          <a:p>
+            <a:pPr algn="l"/>
+            <a:r>
+              <a:rPr sz="900" b="1">
+                <a:solidFill>
+                  <a:srgbClr val="222222"/>
+                </a:solidFill>
+                <a:latin typeface="Meiryo"/>
+              </a:rPr>
+              <a:t>1件数百万〜数千万円</a:t>
+            </a:r>
+          </a:p>
+        </p:txBody>
+      </p:sp>
+      <p:sp>
+        <p:nvSpPr>
+          <p:cNvPr id="44" name="Rectangle 43"/>
+          <p:cNvSpPr/>
+          <p:nvPr/>
+        </p:nvSpPr>
+        <p:spPr>
+          <a:xfrm>
+            <a:off x="5303520" y="6940296"/>
+            <a:ext cx="9052560" cy="347472"/>
+          </a:xfrm>
+          <a:prstGeom prst="rect">
+            <a:avLst/>
+          </a:prstGeom>
+          <a:solidFill>
+            <a:srgbClr val="F9F9F9"/>
+          </a:solidFill>
+          <a:ln w="25400">
+            <a:solidFill>
+              <a:srgbClr val="CCCCCC"/>
+            </a:solidFill>
+          </a:ln>
+        </p:spPr>
+        <p:style>
+          <a:lnRef idx="1">
+            <a:schemeClr val="accent1"/>
+          </a:lnRef>
+          <a:fillRef idx="3">
+            <a:schemeClr val="accent1"/>
+          </a:fillRef>
+          <a:effectRef idx="2">
+            <a:schemeClr val="accent1"/>
+          </a:effectRef>
+          <a:fontRef idx="minor">
+            <a:schemeClr val="lt1"/>
+          </a:fontRef>
+        </p:style>
+        <p:txBody>
+          <a:bodyPr rtlCol="0" anchor="ctr" wrap="square" lIns="63500" rIns="50800" tIns="38100" bIns="38100"/>
+          <a:lstStyle/>
+          <a:p>
+            <a:pPr algn="l"/>
+            <a:r>
+              <a:rPr sz="900" b="0">
+                <a:solidFill>
+                  <a:srgbClr val="222222"/>
+                </a:solidFill>
+                <a:latin typeface="Meiryo"/>
+              </a:rPr>
+              <a:t>零細でも十分なリターン</a:t>
+            </a:r>
+          </a:p>
+        </p:txBody>
+      </p:sp>
+      <p:sp>
+        <p:nvSpPr>
+          <p:cNvPr id="45" name="Rectangle 44"/>
+          <p:cNvSpPr/>
+          <p:nvPr/>
+        </p:nvSpPr>
+        <p:spPr>
+          <a:xfrm>
+            <a:off x="731520" y="7315200"/>
+            <a:ext cx="13624560" cy="502920"/>
+          </a:xfrm>
+          <a:prstGeom prst="rect">
+            <a:avLst/>
+          </a:prstGeom>
+          <a:solidFill>
+            <a:srgbClr val="222222"/>
+          </a:solidFill>
+          <a:ln>
+            <a:noFill/>
+          </a:ln>
+        </p:spPr>
+        <p:style>
+          <a:lnRef idx="1">
+            <a:schemeClr val="accent1"/>
+          </a:lnRef>
+          <a:fillRef idx="3">
+            <a:schemeClr val="accent1"/>
+          </a:fillRef>
+          <a:effectRef idx="2">
+            <a:schemeClr val="accent1"/>
+          </a:effectRef>
+          <a:fontRef idx="minor">
+            <a:schemeClr val="lt1"/>
+          </a:fontRef>
+        </p:style>
+        <p:txBody>
+          <a:bodyPr rtlCol="0" anchor="ctr" wrap="square" lIns="50800" rIns="50800" tIns="25400" bIns="25400"/>
+          <a:lstStyle/>
+          <a:p>
+            <a:pPr algn="ctr"/>
+            <a:r>
+              <a:rPr sz="1100" b="1">
+                <a:solidFill>
+                  <a:srgbClr val="FFFFFF"/>
+                </a:solidFill>
+                <a:latin typeface="Meiryo"/>
+              </a:rPr>
+              <a:t>零細企業は「セキュリティ体制なし＋ワンオペ＋相談相手なし＋承認チェックなし」
+— 犯人にとって最も効率の良いターゲット。銀行側の技術的対策なしでは守れない。</a:t>
+            </a:r>
+          </a:p>
+        </p:txBody>
+      </p:sp>
+      <p:sp>
+        <p:nvSpPr>
+          <p:cNvPr id="46" name="TextBox 45"/>
+          <p:cNvSpPr txBox="1"/>
+          <p:nvPr/>
+        </p:nvSpPr>
+        <p:spPr>
+          <a:xfrm>
+            <a:off x="9144000" y="10378440"/>
+            <a:ext cx="5943600" cy="228600"/>
+          </a:xfrm>
+          <a:prstGeom prst="rect">
+            <a:avLst/>
+          </a:prstGeom>
+          <a:noFill/>
+        </p:spPr>
+        <p:txBody>
+          <a:bodyPr wrap="square" lIns="50800" rIns="50800" tIns="38100" bIns="38100"/>
+          <a:lstStyle/>
+          <a:p>
+            <a:pPr algn="r"/>
+            <a:r>
+              <a:rPr sz="700" b="0">
+                <a:solidFill>
+                  <a:srgbClr val="888888"/>
+                </a:solidFill>
+                <a:latin typeface="Meiryo"/>
+              </a:rPr>
+              <a:t>Fraud Kill Chain — 零細企業ワンオペの脆弱性</a:t>
+            </a:r>
+          </a:p>
+        </p:txBody>
+      </p:sp>
+    </p:spTree>
+  </p:cSld>
+  <p:clrMapOvr>
+    <a:masterClrMapping/>
+  </p:clrMapOvr>
+</p:sld>
+</file>
+
+<file path=ppt/slides/slide18.xml><?xml version="1.0" encoding="utf-8"?>
+<p:sld xmlns:a="http://schemas.openxmlformats.org/drawingml/2006/main" xmlns:p="http://schemas.openxmlformats.org/presentationml/2006/main" xmlns:r="http://schemas.openxmlformats.org/officeDocument/2006/relationships">
+  <p:cSld>
+    <p:bg>
+      <p:bgPr>
+        <a:solidFill>
+          <a:srgbClr val="F5F5F5"/>
+        </a:solidFill>
+        <a:effectLst/>
+      </p:bgPr>
+    </p:bg>
+    <p:spTree>
+      <p:nvGrpSpPr>
+        <p:cNvPr id="1" name=""/>
+        <p:cNvGrpSpPr/>
+        <p:nvPr/>
+      </p:nvGrpSpPr>
+      <p:grpSpPr/>
+      <p:sp>
+        <p:nvSpPr>
+          <p:cNvPr id="2" name="TextBox 1"/>
+          <p:cNvSpPr txBox="1"/>
+          <p:nvPr/>
+        </p:nvSpPr>
+        <p:spPr>
+          <a:xfrm>
+            <a:off x="0" y="182880"/>
+            <a:ext cx="15124176" cy="548640"/>
+          </a:xfrm>
+          <a:prstGeom prst="rect">
+            <a:avLst/>
+          </a:prstGeom>
+          <a:noFill/>
+        </p:spPr>
+        <p:txBody>
+          <a:bodyPr wrap="square" lIns="50800" rIns="50800" tIns="38100" bIns="38100"/>
+          <a:lstStyle/>
+          <a:p>
+            <a:pPr algn="ctr"/>
+            <a:r>
+              <a:rPr sz="2200" b="1">
+                <a:solidFill>
+                  <a:srgbClr val="C0392B"/>
+                </a:solidFill>
+                <a:latin typeface="Meiryo"/>
+              </a:rPr>
+              <a:t>週次でシナリオ更新 — 注意喚起は構造的に追いつけない</a:t>
+            </a:r>
+          </a:p>
+        </p:txBody>
+      </p:sp>
+      <p:sp>
+        <p:nvSpPr>
+          <p:cNvPr id="3" name="Rectangle 2"/>
+          <p:cNvSpPr/>
+          <p:nvPr/>
+        </p:nvSpPr>
+        <p:spPr>
+          <a:xfrm>
+            <a:off x="731520" y="777240"/>
+            <a:ext cx="13624560" cy="365760"/>
+          </a:xfrm>
+          <a:prstGeom prst="rect">
+            <a:avLst/>
+          </a:prstGeom>
+          <a:solidFill>
+            <a:srgbClr val="222222"/>
+          </a:solidFill>
+          <a:ln>
+            <a:noFill/>
+          </a:ln>
+        </p:spPr>
+        <p:style>
+          <a:lnRef idx="1">
+            <a:schemeClr val="accent1"/>
+          </a:lnRef>
+          <a:fillRef idx="3">
+            <a:schemeClr val="accent1"/>
+          </a:fillRef>
+          <a:effectRef idx="2">
+            <a:schemeClr val="accent1"/>
+          </a:effectRef>
+          <a:fontRef idx="minor">
+            <a:schemeClr val="lt1"/>
+          </a:fontRef>
+        </p:style>
+        <p:txBody>
+          <a:bodyPr rtlCol="0" anchor="ctr" wrap="square" lIns="50800" rIns="50800" tIns="25400" bIns="25400"/>
+          <a:lstStyle/>
+          <a:p>
+            <a:pPr algn="ctr"/>
+            <a:r>
+              <a:rPr sz="1300" b="1">
+                <a:solidFill>
+                  <a:srgbClr val="FFFFFF"/>
+                </a:solidFill>
+                <a:latin typeface="Meiryo"/>
+              </a:rPr>
+              <a:t>犯人は組織的にPDCAを回している</a:t>
+            </a:r>
+          </a:p>
+        </p:txBody>
+      </p:sp>
+      <p:sp>
+        <p:nvSpPr>
+          <p:cNvPr id="4" name="Rectangle 3"/>
+          <p:cNvSpPr/>
+          <p:nvPr/>
+        </p:nvSpPr>
+        <p:spPr>
+          <a:xfrm>
+            <a:off x="731520" y="1143000"/>
+            <a:ext cx="1828800" cy="457200"/>
+          </a:xfrm>
+          <a:prstGeom prst="rect">
+            <a:avLst/>
+          </a:prstGeom>
+          <a:solidFill>
+            <a:srgbClr val="2980B9"/>
+          </a:solidFill>
+          <a:ln>
+            <a:noFill/>
+          </a:ln>
+        </p:spPr>
+        <p:style>
+          <a:lnRef idx="1">
+            <a:schemeClr val="accent1"/>
+          </a:lnRef>
+          <a:fillRef idx="3">
+            <a:schemeClr val="accent1"/>
+          </a:fillRef>
+          <a:effectRef idx="2">
+            <a:schemeClr val="accent1"/>
+          </a:effectRef>
+          <a:fontRef idx="minor">
+            <a:schemeClr val="lt1"/>
+          </a:fontRef>
+        </p:style>
+        <p:txBody>
+          <a:bodyPr rtlCol="0" anchor="ctr" wrap="square" lIns="50800" rIns="50800" tIns="25400" bIns="25400"/>
+          <a:lstStyle/>
+          <a:p>
+            <a:pPr algn="ctr"/>
+            <a:r>
+              <a:rPr sz="1200" b="1">
+                <a:solidFill>
+                  <a:srgbClr val="FFFFFF"/>
+                </a:solidFill>
+                <a:latin typeface="Meiryo"/>
+              </a:rPr>
+              <a:t>Plan</a:t>
+            </a:r>
+          </a:p>
+        </p:txBody>
+      </p:sp>
+      <p:sp>
+        <p:nvSpPr>
+          <p:cNvPr id="5" name="Rectangle 4"/>
+          <p:cNvSpPr/>
+          <p:nvPr/>
+        </p:nvSpPr>
+        <p:spPr>
+          <a:xfrm>
+            <a:off x="2560320" y="1143000"/>
+            <a:ext cx="5486400" cy="457200"/>
+          </a:xfrm>
+          <a:prstGeom prst="rect">
+            <a:avLst/>
+          </a:prstGeom>
+          <a:solidFill>
+            <a:srgbClr val="FFFFFF"/>
+          </a:solidFill>
+          <a:ln w="25400">
+            <a:solidFill>
+              <a:srgbClr val="CCCCCC"/>
+            </a:solidFill>
+          </a:ln>
+        </p:spPr>
+        <p:style>
+          <a:lnRef idx="1">
+            <a:schemeClr val="accent1"/>
+          </a:lnRef>
+          <a:fillRef idx="3">
+            <a:schemeClr val="accent1"/>
+          </a:fillRef>
+          <a:effectRef idx="2">
+            <a:schemeClr val="accent1"/>
+          </a:effectRef>
+          <a:fontRef idx="minor">
+            <a:schemeClr val="lt1"/>
+          </a:fontRef>
+        </p:style>
+        <p:txBody>
+          <a:bodyPr rtlCol="0" anchor="ctr" wrap="square" lIns="63500" rIns="50800" tIns="38100" bIns="38100"/>
+          <a:lstStyle/>
+          <a:p>
+            <a:pPr algn="l"/>
+            <a:r>
+              <a:rPr sz="1000" b="0">
+                <a:solidFill>
+                  <a:srgbClr val="222222"/>
+                </a:solidFill>
+                <a:latin typeface="Meiryo"/>
+              </a:rPr>
+              <a:t>新しいシナリオを設計</a:t>
+            </a:r>
+          </a:p>
+        </p:txBody>
+      </p:sp>
+      <p:sp>
+        <p:nvSpPr>
+          <p:cNvPr id="6" name="Rectangle 5"/>
+          <p:cNvSpPr/>
+          <p:nvPr/>
+        </p:nvSpPr>
+        <p:spPr>
+          <a:xfrm>
+            <a:off x="8046720" y="1143000"/>
+            <a:ext cx="6309360" cy="457200"/>
+          </a:xfrm>
+          <a:prstGeom prst="rect">
+            <a:avLst/>
+          </a:prstGeom>
+          <a:solidFill>
+            <a:srgbClr val="F9F9F9"/>
+          </a:solidFill>
+          <a:ln w="25400">
+            <a:solidFill>
+              <a:srgbClr val="CCCCCC"/>
+            </a:solidFill>
+          </a:ln>
+        </p:spPr>
+        <p:style>
+          <a:lnRef idx="1">
+            <a:schemeClr val="accent1"/>
+          </a:lnRef>
+          <a:fillRef idx="3">
+            <a:schemeClr val="accent1"/>
+          </a:fillRef>
+          <a:effectRef idx="2">
+            <a:schemeClr val="accent1"/>
+          </a:effectRef>
+          <a:fontRef idx="minor">
+            <a:schemeClr val="lt1"/>
+          </a:fontRef>
+        </p:style>
+        <p:txBody>
+          <a:bodyPr rtlCol="0" anchor="ctr" wrap="square" lIns="63500" rIns="50800" tIns="38100" bIns="38100"/>
+          <a:lstStyle/>
+          <a:p>
+            <a:pPr algn="l"/>
+            <a:r>
+              <a:rPr sz="1000" b="0">
+                <a:solidFill>
+                  <a:srgbClr val="888888"/>
+                </a:solidFill>
+                <a:latin typeface="Meiryo"/>
+              </a:rPr>
+              <a:t>先週の失敗を改善</a:t>
+            </a:r>
+          </a:p>
+        </p:txBody>
+      </p:sp>
+      <p:sp>
+        <p:nvSpPr>
+          <p:cNvPr id="7" name="Rectangle 6"/>
+          <p:cNvSpPr/>
+          <p:nvPr/>
+        </p:nvSpPr>
+        <p:spPr>
+          <a:xfrm>
+            <a:off x="731520" y="1600200"/>
+            <a:ext cx="1828800" cy="457200"/>
+          </a:xfrm>
+          <a:prstGeom prst="rect">
+            <a:avLst/>
+          </a:prstGeom>
+          <a:solidFill>
+            <a:srgbClr val="27AE60"/>
+          </a:solidFill>
+          <a:ln>
+            <a:noFill/>
+          </a:ln>
+        </p:spPr>
+        <p:style>
+          <a:lnRef idx="1">
+            <a:schemeClr val="accent1"/>
+          </a:lnRef>
+          <a:fillRef idx="3">
+            <a:schemeClr val="accent1"/>
+          </a:fillRef>
+          <a:effectRef idx="2">
+            <a:schemeClr val="accent1"/>
+          </a:effectRef>
+          <a:fontRef idx="minor">
+            <a:schemeClr val="lt1"/>
+          </a:fontRef>
+        </p:style>
+        <p:txBody>
+          <a:bodyPr rtlCol="0" anchor="ctr" wrap="square" lIns="50800" rIns="50800" tIns="25400" bIns="25400"/>
+          <a:lstStyle/>
+          <a:p>
+            <a:pPr algn="ctr"/>
+            <a:r>
+              <a:rPr sz="1200" b="1">
+                <a:solidFill>
+                  <a:srgbClr val="FFFFFF"/>
+                </a:solidFill>
+                <a:latin typeface="Meiryo"/>
+              </a:rPr>
+              <a:t>Do</a:t>
+            </a:r>
+          </a:p>
+        </p:txBody>
+      </p:sp>
+      <p:sp>
+        <p:nvSpPr>
+          <p:cNvPr id="8" name="Rectangle 7"/>
+          <p:cNvSpPr/>
+          <p:nvPr/>
+        </p:nvSpPr>
+        <p:spPr>
+          <a:xfrm>
+            <a:off x="2560320" y="1600200"/>
+            <a:ext cx="5486400" cy="457200"/>
+          </a:xfrm>
+          <a:prstGeom prst="rect">
+            <a:avLst/>
+          </a:prstGeom>
+          <a:solidFill>
+            <a:srgbClr val="FFFFFF"/>
+          </a:solidFill>
+          <a:ln w="25400">
+            <a:solidFill>
+              <a:srgbClr val="CCCCCC"/>
+            </a:solidFill>
+          </a:ln>
+        </p:spPr>
+        <p:style>
+          <a:lnRef idx="1">
+            <a:schemeClr val="accent1"/>
+          </a:lnRef>
+          <a:fillRef idx="3">
+            <a:schemeClr val="accent1"/>
+          </a:fillRef>
+          <a:effectRef idx="2">
+            <a:schemeClr val="accent1"/>
+          </a:effectRef>
+          <a:fontRef idx="minor">
+            <a:schemeClr val="lt1"/>
+          </a:fontRef>
+        </p:style>
+        <p:txBody>
+          <a:bodyPr rtlCol="0" anchor="ctr" wrap="square" lIns="63500" rIns="50800" tIns="38100" bIns="38100"/>
+          <a:lstStyle/>
+          <a:p>
+            <a:pPr algn="l"/>
+            <a:r>
+              <a:rPr sz="1000" b="0">
+                <a:solidFill>
+                  <a:srgbClr val="222222"/>
+                </a:solidFill>
+                <a:latin typeface="Meiryo"/>
+              </a:rPr>
+              <a:t>大量架電で実行</a:t>
+            </a:r>
+          </a:p>
+        </p:txBody>
+      </p:sp>
+      <p:sp>
+        <p:nvSpPr>
+          <p:cNvPr id="9" name="Rectangle 8"/>
+          <p:cNvSpPr/>
+          <p:nvPr/>
+        </p:nvSpPr>
+        <p:spPr>
+          <a:xfrm>
+            <a:off x="8046720" y="1600200"/>
+            <a:ext cx="6309360" cy="457200"/>
+          </a:xfrm>
+          <a:prstGeom prst="rect">
+            <a:avLst/>
+          </a:prstGeom>
+          <a:solidFill>
+            <a:srgbClr val="F9F9F9"/>
+          </a:solidFill>
+          <a:ln w="25400">
+            <a:solidFill>
+              <a:srgbClr val="CCCCCC"/>
+            </a:solidFill>
+          </a:ln>
+        </p:spPr>
+        <p:style>
+          <a:lnRef idx="1">
+            <a:schemeClr val="accent1"/>
+          </a:lnRef>
+          <a:fillRef idx="3">
+            <a:schemeClr val="accent1"/>
+          </a:fillRef>
+          <a:effectRef idx="2">
+            <a:schemeClr val="accent1"/>
+          </a:effectRef>
+          <a:fontRef idx="minor">
+            <a:schemeClr val="lt1"/>
+          </a:fontRef>
+        </p:style>
+        <p:txBody>
+          <a:bodyPr rtlCol="0" anchor="ctr" wrap="square" lIns="63500" rIns="50800" tIns="38100" bIns="38100"/>
+          <a:lstStyle/>
+          <a:p>
+            <a:pPr algn="l"/>
+            <a:r>
+              <a:rPr sz="1000" b="0">
+                <a:solidFill>
+                  <a:srgbClr val="888888"/>
+                </a:solidFill>
+                <a:latin typeface="Meiryo"/>
+              </a:rPr>
+              <a:t>零細企業を含め幅広に</a:t>
+            </a:r>
+          </a:p>
+        </p:txBody>
+      </p:sp>
+      <p:sp>
+        <p:nvSpPr>
+          <p:cNvPr id="10" name="Rectangle 9"/>
+          <p:cNvSpPr/>
+          <p:nvPr/>
+        </p:nvSpPr>
+        <p:spPr>
+          <a:xfrm>
+            <a:off x="731520" y="2057400"/>
+            <a:ext cx="1828800" cy="457200"/>
+          </a:xfrm>
+          <a:prstGeom prst="rect">
+            <a:avLst/>
+          </a:prstGeom>
+          <a:solidFill>
+            <a:srgbClr val="E67E22"/>
+          </a:solidFill>
+          <a:ln>
+            <a:noFill/>
+          </a:ln>
+        </p:spPr>
+        <p:style>
+          <a:lnRef idx="1">
+            <a:schemeClr val="accent1"/>
+          </a:lnRef>
+          <a:fillRef idx="3">
+            <a:schemeClr val="accent1"/>
+          </a:fillRef>
+          <a:effectRef idx="2">
+            <a:schemeClr val="accent1"/>
+          </a:effectRef>
+          <a:fontRef idx="minor">
+            <a:schemeClr val="lt1"/>
+          </a:fontRef>
+        </p:style>
+        <p:txBody>
+          <a:bodyPr rtlCol="0" anchor="ctr" wrap="square" lIns="50800" rIns="50800" tIns="25400" bIns="25400"/>
+          <a:lstStyle/>
+          <a:p>
+            <a:pPr algn="ctr"/>
+            <a:r>
+              <a:rPr sz="1200" b="1">
+                <a:solidFill>
+                  <a:srgbClr val="FFFFFF"/>
+                </a:solidFill>
+                <a:latin typeface="Meiryo"/>
+              </a:rPr>
+              <a:t>Check</a:t>
+            </a:r>
+          </a:p>
+        </p:txBody>
+      </p:sp>
+      <p:sp>
+        <p:nvSpPr>
+          <p:cNvPr id="11" name="Rectangle 10"/>
+          <p:cNvSpPr/>
+          <p:nvPr/>
+        </p:nvSpPr>
+        <p:spPr>
+          <a:xfrm>
+            <a:off x="2560320" y="2057400"/>
+            <a:ext cx="5486400" cy="457200"/>
+          </a:xfrm>
+          <a:prstGeom prst="rect">
+            <a:avLst/>
+          </a:prstGeom>
+          <a:solidFill>
+            <a:srgbClr val="FFFFFF"/>
+          </a:solidFill>
+          <a:ln w="25400">
+            <a:solidFill>
+              <a:srgbClr val="CCCCCC"/>
+            </a:solidFill>
+          </a:ln>
+        </p:spPr>
+        <p:style>
+          <a:lnRef idx="1">
+            <a:schemeClr val="accent1"/>
+          </a:lnRef>
+          <a:fillRef idx="3">
+            <a:schemeClr val="accent1"/>
+          </a:fillRef>
+          <a:effectRef idx="2">
+            <a:schemeClr val="accent1"/>
+          </a:effectRef>
+          <a:fontRef idx="minor">
+            <a:schemeClr val="lt1"/>
+          </a:fontRef>
+        </p:style>
+        <p:txBody>
+          <a:bodyPr rtlCol="0" anchor="ctr" wrap="square" lIns="63500" rIns="50800" tIns="38100" bIns="38100"/>
+          <a:lstStyle/>
+          <a:p>
+            <a:pPr algn="l"/>
+            <a:r>
+              <a:rPr sz="1000" b="0">
+                <a:solidFill>
+                  <a:srgbClr val="222222"/>
+                </a:solidFill>
+                <a:latin typeface="Meiryo"/>
+              </a:rPr>
+              <a:t>成功率・失敗ポイントを分析</a:t>
+            </a:r>
+          </a:p>
+        </p:txBody>
+      </p:sp>
+      <p:sp>
+        <p:nvSpPr>
+          <p:cNvPr id="12" name="Rectangle 11"/>
+          <p:cNvSpPr/>
+          <p:nvPr/>
+        </p:nvSpPr>
+        <p:spPr>
+          <a:xfrm>
+            <a:off x="8046720" y="2057400"/>
+            <a:ext cx="6309360" cy="457200"/>
+          </a:xfrm>
+          <a:prstGeom prst="rect">
+            <a:avLst/>
+          </a:prstGeom>
+          <a:solidFill>
+            <a:srgbClr val="F9F9F9"/>
+          </a:solidFill>
+          <a:ln w="25400">
+            <a:solidFill>
+              <a:srgbClr val="CCCCCC"/>
+            </a:solidFill>
+          </a:ln>
+        </p:spPr>
+        <p:style>
+          <a:lnRef idx="1">
+            <a:schemeClr val="accent1"/>
+          </a:lnRef>
+          <a:fillRef idx="3">
+            <a:schemeClr val="accent1"/>
+          </a:fillRef>
+          <a:effectRef idx="2">
+            <a:schemeClr val="accent1"/>
+          </a:effectRef>
+          <a:fontRef idx="minor">
+            <a:schemeClr val="lt1"/>
+          </a:fontRef>
+        </p:style>
+        <p:txBody>
+          <a:bodyPr rtlCol="0" anchor="ctr" wrap="square" lIns="63500" rIns="50800" tIns="38100" bIns="38100"/>
+          <a:lstStyle/>
+          <a:p>
+            <a:pPr algn="l"/>
+            <a:r>
+              <a:rPr sz="1000" b="0">
+                <a:solidFill>
+                  <a:srgbClr val="888888"/>
+                </a:solidFill>
+                <a:latin typeface="Meiryo"/>
+              </a:rPr>
+              <a:t>どの手順で止まったか</a:t>
+            </a:r>
+          </a:p>
+        </p:txBody>
+      </p:sp>
+      <p:sp>
+        <p:nvSpPr>
+          <p:cNvPr id="13" name="Rectangle 12"/>
+          <p:cNvSpPr/>
+          <p:nvPr/>
+        </p:nvSpPr>
+        <p:spPr>
+          <a:xfrm>
+            <a:off x="731520" y="2514600"/>
+            <a:ext cx="1828800" cy="457200"/>
+          </a:xfrm>
+          <a:prstGeom prst="rect">
+            <a:avLst/>
+          </a:prstGeom>
+          <a:solidFill>
+            <a:srgbClr val="C0392B"/>
+          </a:solidFill>
+          <a:ln>
+            <a:noFill/>
+          </a:ln>
+        </p:spPr>
+        <p:style>
+          <a:lnRef idx="1">
+            <a:schemeClr val="accent1"/>
+          </a:lnRef>
+          <a:fillRef idx="3">
+            <a:schemeClr val="accent1"/>
+          </a:fillRef>
+          <a:effectRef idx="2">
+            <a:schemeClr val="accent1"/>
+          </a:effectRef>
+          <a:fontRef idx="minor">
+            <a:schemeClr val="lt1"/>
+          </a:fontRef>
+        </p:style>
+        <p:txBody>
+          <a:bodyPr rtlCol="0" anchor="ctr" wrap="square" lIns="50800" rIns="50800" tIns="25400" bIns="25400"/>
+          <a:lstStyle/>
+          <a:p>
+            <a:pPr algn="ctr"/>
+            <a:r>
+              <a:rPr sz="1200" b="1">
+                <a:solidFill>
+                  <a:srgbClr val="FFFFFF"/>
+                </a:solidFill>
+                <a:latin typeface="Meiryo"/>
+              </a:rPr>
+              <a:t>Act</a:t>
+            </a:r>
+          </a:p>
+        </p:txBody>
+      </p:sp>
+      <p:sp>
+        <p:nvSpPr>
+          <p:cNvPr id="14" name="Rectangle 13"/>
+          <p:cNvSpPr/>
+          <p:nvPr/>
+        </p:nvSpPr>
+        <p:spPr>
+          <a:xfrm>
+            <a:off x="2560320" y="2514600"/>
+            <a:ext cx="5486400" cy="457200"/>
+          </a:xfrm>
+          <a:prstGeom prst="rect">
+            <a:avLst/>
+          </a:prstGeom>
+          <a:solidFill>
+            <a:srgbClr val="FFFFFF"/>
+          </a:solidFill>
+          <a:ln w="25400">
+            <a:solidFill>
+              <a:srgbClr val="CCCCCC"/>
+            </a:solidFill>
+          </a:ln>
+        </p:spPr>
+        <p:style>
+          <a:lnRef idx="1">
+            <a:schemeClr val="accent1"/>
+          </a:lnRef>
+          <a:fillRef idx="3">
+            <a:schemeClr val="accent1"/>
+          </a:fillRef>
+          <a:effectRef idx="2">
+            <a:schemeClr val="accent1"/>
+          </a:effectRef>
+          <a:fontRef idx="minor">
+            <a:schemeClr val="lt1"/>
+          </a:fontRef>
+        </p:style>
+        <p:txBody>
+          <a:bodyPr rtlCol="0" anchor="ctr" wrap="square" lIns="63500" rIns="50800" tIns="38100" bIns="38100"/>
+          <a:lstStyle/>
+          <a:p>
+            <a:pPr algn="l"/>
+            <a:r>
+              <a:rPr sz="1000" b="0">
+                <a:solidFill>
+                  <a:srgbClr val="222222"/>
+                </a:solidFill>
+                <a:latin typeface="Meiryo"/>
+              </a:rPr>
+              <a:t>翌週シナリオを改善</a:t>
+            </a:r>
+          </a:p>
+        </p:txBody>
+      </p:sp>
+      <p:sp>
+        <p:nvSpPr>
+          <p:cNvPr id="15" name="Rectangle 14"/>
+          <p:cNvSpPr/>
+          <p:nvPr/>
+        </p:nvSpPr>
+        <p:spPr>
+          <a:xfrm>
+            <a:off x="8046720" y="2514600"/>
+            <a:ext cx="6309360" cy="457200"/>
+          </a:xfrm>
+          <a:prstGeom prst="rect">
+            <a:avLst/>
+          </a:prstGeom>
+          <a:solidFill>
+            <a:srgbClr val="F9F9F9"/>
+          </a:solidFill>
+          <a:ln w="25400">
+            <a:solidFill>
+              <a:srgbClr val="CCCCCC"/>
+            </a:solidFill>
+          </a:ln>
+        </p:spPr>
+        <p:style>
+          <a:lnRef idx="1">
+            <a:schemeClr val="accent1"/>
+          </a:lnRef>
+          <a:fillRef idx="3">
+            <a:schemeClr val="accent1"/>
+          </a:fillRef>
+          <a:effectRef idx="2">
+            <a:schemeClr val="accent1"/>
+          </a:effectRef>
+          <a:fontRef idx="minor">
+            <a:schemeClr val="lt1"/>
+          </a:fontRef>
+        </p:style>
+        <p:txBody>
+          <a:bodyPr rtlCol="0" anchor="ctr" wrap="square" lIns="63500" rIns="50800" tIns="38100" bIns="38100"/>
+          <a:lstStyle/>
+          <a:p>
+            <a:pPr algn="l"/>
+            <a:r>
+              <a:rPr sz="1000" b="0">
+                <a:solidFill>
+                  <a:srgbClr val="888888"/>
+                </a:solidFill>
+                <a:latin typeface="Meiryo"/>
+              </a:rPr>
+              <a:t>破綻ポイントを潰す</a:t>
+            </a:r>
+          </a:p>
+        </p:txBody>
+      </p:sp>
+      <p:sp>
+        <p:nvSpPr>
+          <p:cNvPr id="16" name="Rectangle 15"/>
+          <p:cNvSpPr/>
+          <p:nvPr/>
+        </p:nvSpPr>
+        <p:spPr>
+          <a:xfrm>
+            <a:off x="731520" y="3063240"/>
+            <a:ext cx="13624560" cy="365760"/>
+          </a:xfrm>
+          <a:prstGeom prst="rect">
+            <a:avLst/>
+          </a:prstGeom>
+          <a:solidFill>
+            <a:srgbClr val="E67E22"/>
+          </a:solidFill>
+          <a:ln>
+            <a:noFill/>
+          </a:ln>
+        </p:spPr>
+        <p:style>
+          <a:lnRef idx="1">
+            <a:schemeClr val="accent1"/>
+          </a:lnRef>
+          <a:fillRef idx="3">
+            <a:schemeClr val="accent1"/>
+          </a:fillRef>
+          <a:effectRef idx="2">
+            <a:schemeClr val="accent1"/>
+          </a:effectRef>
+          <a:fontRef idx="minor">
+            <a:schemeClr val="lt1"/>
+          </a:fontRef>
+        </p:style>
+        <p:txBody>
+          <a:bodyPr rtlCol="0" anchor="ctr" wrap="square" lIns="50800" rIns="50800" tIns="25400" bIns="25400"/>
+          <a:lstStyle/>
+          <a:p>
+            <a:pPr algn="ctr"/>
+            <a:r>
+              <a:rPr sz="1200" b="1">
+                <a:solidFill>
+                  <a:srgbClr val="FFFFFF"/>
+                </a:solidFill>
+                <a:latin typeface="Meiryo"/>
+              </a:rPr>
+              <a:t>シナリオ改善の例 — 破綻ポイントを毎週潰していく</a:t>
+            </a:r>
+          </a:p>
+        </p:txBody>
+      </p:sp>
+      <p:sp>
+        <p:nvSpPr>
+          <p:cNvPr id="17" name="Rectangle 16"/>
+          <p:cNvSpPr/>
+          <p:nvPr/>
+        </p:nvSpPr>
+        <p:spPr>
+          <a:xfrm>
+            <a:off x="731520" y="3429000"/>
+            <a:ext cx="5029200" cy="365760"/>
+          </a:xfrm>
+          <a:prstGeom prst="rect">
+            <a:avLst/>
+          </a:prstGeom>
+          <a:solidFill>
+            <a:srgbClr val="FFFFFF"/>
+          </a:solidFill>
+          <a:ln w="25400">
+            <a:solidFill>
+              <a:srgbClr val="E67E22"/>
+            </a:solidFill>
+          </a:ln>
+        </p:spPr>
+        <p:style>
+          <a:lnRef idx="1">
+            <a:schemeClr val="accent1"/>
+          </a:lnRef>
+          <a:fillRef idx="3">
+            <a:schemeClr val="accent1"/>
+          </a:fillRef>
+          <a:effectRef idx="2">
+            <a:schemeClr val="accent1"/>
+          </a:effectRef>
+          <a:fontRef idx="minor">
+            <a:schemeClr val="lt1"/>
+          </a:fontRef>
+        </p:style>
+        <p:txBody>
+          <a:bodyPr rtlCol="0" anchor="ctr" wrap="square" lIns="63500" rIns="50800" tIns="38100" bIns="38100"/>
+          <a:lstStyle/>
+          <a:p>
+            <a:pPr algn="l"/>
+            <a:r>
+              <a:rPr sz="900" b="1">
+                <a:solidFill>
+                  <a:srgbClr val="222222"/>
+                </a:solidFill>
+                <a:latin typeface="Meiryo"/>
+              </a:rPr>
+              <a:t>「メアドを聞いたら怪しまれた」</a:t>
+            </a:r>
+          </a:p>
+        </p:txBody>
+      </p:sp>
+      <p:sp>
+        <p:nvSpPr>
+          <p:cNvPr id="18" name="Rectangle 17"/>
+          <p:cNvSpPr/>
+          <p:nvPr/>
+        </p:nvSpPr>
+        <p:spPr>
+          <a:xfrm>
+            <a:off x="5760720" y="3429000"/>
+            <a:ext cx="8595360" cy="365760"/>
+          </a:xfrm>
+          <a:prstGeom prst="rect">
+            <a:avLst/>
+          </a:prstGeom>
+          <a:solidFill>
+            <a:srgbClr val="FFFFFF"/>
+          </a:solidFill>
+          <a:ln w="25400">
+            <a:solidFill>
+              <a:srgbClr val="CCCCCC"/>
+            </a:solidFill>
+          </a:ln>
+        </p:spPr>
+        <p:style>
+          <a:lnRef idx="1">
+            <a:schemeClr val="accent1"/>
+          </a:lnRef>
+          <a:fillRef idx="3">
+            <a:schemeClr val="accent1"/>
+          </a:fillRef>
+          <a:effectRef idx="2">
+            <a:schemeClr val="accent1"/>
+          </a:effectRef>
+          <a:fontRef idx="minor">
+            <a:schemeClr val="lt1"/>
+          </a:fontRef>
+        </p:style>
+        <p:txBody>
+          <a:bodyPr rtlCol="0" anchor="ctr" wrap="square" lIns="63500" rIns="50800" tIns="38100" bIns="38100"/>
+          <a:lstStyle/>
+          <a:p>
+            <a:pPr algn="l"/>
+            <a:r>
+              <a:rPr sz="900" b="0">
+                <a:solidFill>
+                  <a:srgbClr val="222222"/>
+                </a:solidFill>
+                <a:latin typeface="Meiryo"/>
+              </a:rPr>
+              <a:t>翌週は別の聞き方にする / 入手済みルートを優先</a:t>
+            </a:r>
+          </a:p>
+        </p:txBody>
+      </p:sp>
+      <p:sp>
+        <p:nvSpPr>
+          <p:cNvPr id="19" name="Rectangle 18"/>
+          <p:cNvSpPr/>
+          <p:nvPr/>
+        </p:nvSpPr>
+        <p:spPr>
+          <a:xfrm>
+            <a:off x="731520" y="3794760"/>
+            <a:ext cx="5029200" cy="365760"/>
+          </a:xfrm>
+          <a:prstGeom prst="rect">
+            <a:avLst/>
+          </a:prstGeom>
+          <a:solidFill>
+            <a:srgbClr val="F9F9F9"/>
+          </a:solidFill>
+          <a:ln w="25400">
+            <a:solidFill>
+              <a:srgbClr val="E67E22"/>
+            </a:solidFill>
+          </a:ln>
+        </p:spPr>
+        <p:style>
+          <a:lnRef idx="1">
+            <a:schemeClr val="accent1"/>
+          </a:lnRef>
+          <a:fillRef idx="3">
+            <a:schemeClr val="accent1"/>
+          </a:fillRef>
+          <a:effectRef idx="2">
+            <a:schemeClr val="accent1"/>
+          </a:effectRef>
+          <a:fontRef idx="minor">
+            <a:schemeClr val="lt1"/>
+          </a:fontRef>
+        </p:style>
+        <p:txBody>
+          <a:bodyPr rtlCol="0" anchor="ctr" wrap="square" lIns="63500" rIns="50800" tIns="38100" bIns="38100"/>
+          <a:lstStyle/>
+          <a:p>
+            <a:pPr algn="l"/>
+            <a:r>
+              <a:rPr sz="900" b="1">
+                <a:solidFill>
+                  <a:srgbClr val="222222"/>
+                </a:solidFill>
+                <a:latin typeface="Meiryo"/>
+              </a:rPr>
+              <a:t>「不明な発行元で止まった」</a:t>
+            </a:r>
+          </a:p>
+        </p:txBody>
+      </p:sp>
+      <p:sp>
+        <p:nvSpPr>
+          <p:cNvPr id="20" name="Rectangle 19"/>
+          <p:cNvSpPr/>
+          <p:nvPr/>
+        </p:nvSpPr>
+        <p:spPr>
+          <a:xfrm>
+            <a:off x="5760720" y="3794760"/>
+            <a:ext cx="8595360" cy="365760"/>
+          </a:xfrm>
+          <a:prstGeom prst="rect">
+            <a:avLst/>
+          </a:prstGeom>
+          <a:solidFill>
+            <a:srgbClr val="F9F9F9"/>
+          </a:solidFill>
+          <a:ln w="25400">
+            <a:solidFill>
+              <a:srgbClr val="CCCCCC"/>
+            </a:solidFill>
+          </a:ln>
+        </p:spPr>
+        <p:style>
+          <a:lnRef idx="1">
+            <a:schemeClr val="accent1"/>
+          </a:lnRef>
+          <a:fillRef idx="3">
+            <a:schemeClr val="accent1"/>
+          </a:fillRef>
+          <a:effectRef idx="2">
+            <a:schemeClr val="accent1"/>
+          </a:effectRef>
+          <a:fontRef idx="minor">
+            <a:schemeClr val="lt1"/>
+          </a:fontRef>
+        </p:style>
+        <p:txBody>
+          <a:bodyPr rtlCol="0" anchor="ctr" wrap="square" lIns="63500" rIns="50800" tIns="38100" bIns="38100"/>
+          <a:lstStyle/>
+          <a:p>
+            <a:pPr algn="l"/>
+            <a:r>
+              <a:rPr sz="900" b="0">
+                <a:solidFill>
+                  <a:srgbClr val="222222"/>
+                </a:solidFill>
+                <a:latin typeface="Meiryo"/>
+              </a:rPr>
+              <a:t>翌週は証明書を用意する</a:t>
+            </a:r>
+          </a:p>
+        </p:txBody>
+      </p:sp>
+      <p:sp>
+        <p:nvSpPr>
+          <p:cNvPr id="21" name="Rectangle 20"/>
+          <p:cNvSpPr/>
+          <p:nvPr/>
+        </p:nvSpPr>
+        <p:spPr>
+          <a:xfrm>
+            <a:off x="731520" y="4160520"/>
+            <a:ext cx="5029200" cy="365760"/>
+          </a:xfrm>
+          <a:prstGeom prst="rect">
+            <a:avLst/>
+          </a:prstGeom>
+          <a:solidFill>
+            <a:srgbClr val="FFFFFF"/>
+          </a:solidFill>
+          <a:ln w="25400">
+            <a:solidFill>
+              <a:srgbClr val="E67E22"/>
+            </a:solidFill>
+          </a:ln>
+        </p:spPr>
+        <p:style>
+          <a:lnRef idx="1">
+            <a:schemeClr val="accent1"/>
+          </a:lnRef>
+          <a:fillRef idx="3">
+            <a:schemeClr val="accent1"/>
+          </a:fillRef>
+          <a:effectRef idx="2">
+            <a:schemeClr val="accent1"/>
+          </a:effectRef>
+          <a:fontRef idx="minor">
+            <a:schemeClr val="lt1"/>
+          </a:fontRef>
+        </p:style>
+        <p:txBody>
+          <a:bodyPr rtlCol="0" anchor="ctr" wrap="square" lIns="63500" rIns="50800" tIns="38100" bIns="38100"/>
+          <a:lstStyle/>
+          <a:p>
+            <a:pPr algn="l"/>
+            <a:r>
+              <a:rPr sz="900" b="1">
+                <a:solidFill>
+                  <a:srgbClr val="222222"/>
+                </a:solidFill>
+                <a:latin typeface="Meiryo"/>
+              </a:rPr>
+              <a:t>「迷惑フォルダで止まった」</a:t>
+            </a:r>
+          </a:p>
+        </p:txBody>
+      </p:sp>
+      <p:sp>
+        <p:nvSpPr>
+          <p:cNvPr id="22" name="Rectangle 21"/>
+          <p:cNvSpPr/>
+          <p:nvPr/>
+        </p:nvSpPr>
+        <p:spPr>
+          <a:xfrm>
+            <a:off x="5760720" y="4160520"/>
+            <a:ext cx="8595360" cy="365760"/>
+          </a:xfrm>
+          <a:prstGeom prst="rect">
+            <a:avLst/>
+          </a:prstGeom>
+          <a:solidFill>
+            <a:srgbClr val="FFFFFF"/>
+          </a:solidFill>
+          <a:ln w="25400">
+            <a:solidFill>
+              <a:srgbClr val="CCCCCC"/>
+            </a:solidFill>
+          </a:ln>
+        </p:spPr>
+        <p:style>
+          <a:lnRef idx="1">
+            <a:schemeClr val="accent1"/>
+          </a:lnRef>
+          <a:fillRef idx="3">
+            <a:schemeClr val="accent1"/>
+          </a:fillRef>
+          <a:effectRef idx="2">
+            <a:schemeClr val="accent1"/>
+          </a:effectRef>
+          <a:fontRef idx="minor">
+            <a:schemeClr val="lt1"/>
+          </a:fontRef>
+        </p:style>
+        <p:txBody>
+          <a:bodyPr rtlCol="0" anchor="ctr" wrap="square" lIns="63500" rIns="50800" tIns="38100" bIns="38100"/>
+          <a:lstStyle/>
+          <a:p>
+            <a:pPr algn="l"/>
+            <a:r>
+              <a:rPr sz="900" b="0">
+                <a:solidFill>
+                  <a:srgbClr val="222222"/>
+                </a:solidFill>
+                <a:latin typeface="Meiryo"/>
+              </a:rPr>
+              <a:t>翌週はトーク改善する</a:t>
+            </a:r>
+          </a:p>
+        </p:txBody>
+      </p:sp>
+      <p:sp>
+        <p:nvSpPr>
+          <p:cNvPr id="23" name="Rectangle 22"/>
+          <p:cNvSpPr/>
+          <p:nvPr/>
+        </p:nvSpPr>
+        <p:spPr>
+          <a:xfrm>
+            <a:off x="731520" y="4526280"/>
+            <a:ext cx="5029200" cy="365760"/>
+          </a:xfrm>
+          <a:prstGeom prst="rect">
+            <a:avLst/>
+          </a:prstGeom>
+          <a:solidFill>
+            <a:srgbClr val="F9F9F9"/>
+          </a:solidFill>
+          <a:ln w="25400">
+            <a:solidFill>
+              <a:srgbClr val="E67E22"/>
+            </a:solidFill>
+          </a:ln>
+        </p:spPr>
+        <p:style>
+          <a:lnRef idx="1">
+            <a:schemeClr val="accent1"/>
+          </a:lnRef>
+          <a:fillRef idx="3">
+            <a:schemeClr val="accent1"/>
+          </a:fillRef>
+          <a:effectRef idx="2">
+            <a:schemeClr val="accent1"/>
+          </a:effectRef>
+          <a:fontRef idx="minor">
+            <a:schemeClr val="lt1"/>
+          </a:fontRef>
+        </p:style>
+        <p:txBody>
+          <a:bodyPr rtlCol="0" anchor="ctr" wrap="square" lIns="63500" rIns="50800" tIns="38100" bIns="38100"/>
+          <a:lstStyle/>
+          <a:p>
+            <a:pPr algn="l"/>
+            <a:r>
+              <a:rPr sz="900" b="1">
+                <a:solidFill>
+                  <a:srgbClr val="222222"/>
+                </a:solidFill>
+                <a:latin typeface="Meiryo"/>
+              </a:rPr>
+              <a:t>「赤い画面で不審がられた」</a:t>
+            </a:r>
+          </a:p>
+        </p:txBody>
+      </p:sp>
+      <p:sp>
+        <p:nvSpPr>
+          <p:cNvPr id="24" name="Rectangle 23"/>
+          <p:cNvSpPr/>
+          <p:nvPr/>
+        </p:nvSpPr>
+        <p:spPr>
+          <a:xfrm>
+            <a:off x="5760720" y="4526280"/>
+            <a:ext cx="8595360" cy="365760"/>
+          </a:xfrm>
+          <a:prstGeom prst="rect">
+            <a:avLst/>
+          </a:prstGeom>
+          <a:solidFill>
+            <a:srgbClr val="F9F9F9"/>
+          </a:solidFill>
+          <a:ln w="25400">
+            <a:solidFill>
+              <a:srgbClr val="CCCCCC"/>
+            </a:solidFill>
+          </a:ln>
+        </p:spPr>
+        <p:style>
+          <a:lnRef idx="1">
+            <a:schemeClr val="accent1"/>
+          </a:lnRef>
+          <a:fillRef idx="3">
+            <a:schemeClr val="accent1"/>
+          </a:fillRef>
+          <a:effectRef idx="2">
+            <a:schemeClr val="accent1"/>
+          </a:effectRef>
+          <a:fontRef idx="minor">
+            <a:schemeClr val="lt1"/>
+          </a:fontRef>
+        </p:style>
+        <p:txBody>
+          <a:bodyPr rtlCol="0" anchor="ctr" wrap="square" lIns="63500" rIns="50800" tIns="38100" bIns="38100"/>
+          <a:lstStyle/>
+          <a:p>
+            <a:pPr algn="l"/>
+            <a:r>
+              <a:rPr sz="900" b="0">
+                <a:solidFill>
+                  <a:srgbClr val="222222"/>
+                </a:solidFill>
+                <a:latin typeface="Meiryo"/>
+              </a:rPr>
+              <a:t>翌週は画面デザインを変える</a:t>
+            </a:r>
+          </a:p>
+        </p:txBody>
+      </p:sp>
+      <p:sp>
+        <p:nvSpPr>
+          <p:cNvPr id="25" name="Rectangle 24"/>
+          <p:cNvSpPr/>
+          <p:nvPr/>
+        </p:nvSpPr>
+        <p:spPr>
+          <a:xfrm>
+            <a:off x="731520" y="5029200"/>
+            <a:ext cx="13624560" cy="365760"/>
+          </a:xfrm>
+          <a:prstGeom prst="rect">
+            <a:avLst/>
+          </a:prstGeom>
+          <a:solidFill>
+            <a:srgbClr val="222222"/>
+          </a:solidFill>
+          <a:ln>
+            <a:noFill/>
+          </a:ln>
+        </p:spPr>
+        <p:style>
+          <a:lnRef idx="1">
+            <a:schemeClr val="accent1"/>
+          </a:lnRef>
+          <a:fillRef idx="3">
+            <a:schemeClr val="accent1"/>
+          </a:fillRef>
+          <a:effectRef idx="2">
+            <a:schemeClr val="accent1"/>
+          </a:effectRef>
+          <a:fontRef idx="minor">
+            <a:schemeClr val="lt1"/>
+          </a:fontRef>
+        </p:style>
+        <p:txBody>
+          <a:bodyPr rtlCol="0" anchor="ctr" wrap="square" lIns="50800" rIns="50800" tIns="25400" bIns="25400"/>
+          <a:lstStyle/>
+          <a:p>
+            <a:pPr algn="ctr"/>
+            <a:r>
+              <a:rPr sz="1200" b="1">
+                <a:solidFill>
+                  <a:srgbClr val="FFFFFF"/>
+                </a:solidFill>
+                <a:latin typeface="Meiryo"/>
+              </a:rPr>
+              <a:t>注意喚起 vs シナリオ更新のスピード — 非対称性</a:t>
+            </a:r>
+          </a:p>
+        </p:txBody>
+      </p:sp>
+      <p:sp>
+        <p:nvSpPr>
+          <p:cNvPr id="26" name="Rectangle 25"/>
+          <p:cNvSpPr/>
+          <p:nvPr/>
+        </p:nvSpPr>
+        <p:spPr>
+          <a:xfrm>
+            <a:off x="731520" y="5440680"/>
+            <a:ext cx="6583680" cy="320040"/>
+          </a:xfrm>
+          <a:prstGeom prst="rect">
+            <a:avLst/>
+          </a:prstGeom>
+          <a:solidFill>
+            <a:srgbClr val="EEEEEE"/>
+          </a:solidFill>
+          <a:ln>
+            <a:noFill/>
+          </a:ln>
+        </p:spPr>
+        <p:style>
+          <a:lnRef idx="1">
+            <a:schemeClr val="accent1"/>
+          </a:lnRef>
+          <a:fillRef idx="3">
+            <a:schemeClr val="accent1"/>
+          </a:fillRef>
+          <a:effectRef idx="2">
+            <a:schemeClr val="accent1"/>
+          </a:effectRef>
+          <a:fontRef idx="minor">
+            <a:schemeClr val="lt1"/>
+          </a:fontRef>
+        </p:style>
+        <p:txBody>
+          <a:bodyPr rtlCol="0" anchor="ctr" wrap="square" lIns="50800" rIns="50800" tIns="25400" bIns="25400"/>
+          <a:lstStyle/>
+          <a:p>
+            <a:pPr algn="ctr"/>
+            <a:r>
+              <a:rPr sz="1000" b="1">
+                <a:solidFill>
+                  <a:srgbClr val="222222"/>
+                </a:solidFill>
+                <a:latin typeface="Meiryo"/>
+              </a:rPr>
+              <a:t>銀行側の注意喚起</a:t>
+            </a:r>
+          </a:p>
+        </p:txBody>
+      </p:sp>
+      <p:sp>
+        <p:nvSpPr>
+          <p:cNvPr id="27" name="Rectangle 26"/>
+          <p:cNvSpPr/>
+          <p:nvPr/>
+        </p:nvSpPr>
+        <p:spPr>
+          <a:xfrm>
+            <a:off x="731520" y="5760720"/>
+            <a:ext cx="6583680" cy="548640"/>
+          </a:xfrm>
+          <a:prstGeom prst="rect">
+            <a:avLst/>
+          </a:prstGeom>
+          <a:solidFill>
+            <a:srgbClr val="FFFFFF"/>
+          </a:solidFill>
+          <a:ln w="25400">
+            <a:solidFill>
+              <a:srgbClr val="CCCCCC"/>
+            </a:solidFill>
+          </a:ln>
+        </p:spPr>
+        <p:style>
+          <a:lnRef idx="1">
+            <a:schemeClr val="accent1"/>
+          </a:lnRef>
+          <a:fillRef idx="3">
+            <a:schemeClr val="accent1"/>
+          </a:fillRef>
+          <a:effectRef idx="2">
+            <a:schemeClr val="accent1"/>
+          </a:effectRef>
+          <a:fontRef idx="minor">
+            <a:schemeClr val="lt1"/>
+          </a:fontRef>
+        </p:style>
+        <p:txBody>
+          <a:bodyPr rtlCol="0" anchor="ctr" wrap="square" lIns="63500" rIns="50800" tIns="38100" bIns="38100"/>
+          <a:lstStyle/>
+          <a:p>
+            <a:pPr algn="l"/>
+            <a:r>
+              <a:rPr sz="1000" b="0">
+                <a:solidFill>
+                  <a:srgbClr val="222222"/>
+                </a:solidFill>
+                <a:latin typeface="Meiryo"/>
+              </a:rPr>
+              <a:t>作成 → 社内審査 → 顧客に配信
+→ 数週間〜数ヶ月</a:t>
+            </a:r>
+          </a:p>
+        </p:txBody>
+      </p:sp>
+      <p:sp>
+        <p:nvSpPr>
+          <p:cNvPr id="28" name="Rectangle 27"/>
+          <p:cNvSpPr/>
+          <p:nvPr/>
+        </p:nvSpPr>
+        <p:spPr>
+          <a:xfrm>
+            <a:off x="7772400" y="5440680"/>
+            <a:ext cx="6400800" cy="320040"/>
+          </a:xfrm>
+          <a:prstGeom prst="rect">
+            <a:avLst/>
+          </a:prstGeom>
+          <a:solidFill>
+            <a:srgbClr val="C0392B"/>
+          </a:solidFill>
+          <a:ln>
+            <a:noFill/>
+          </a:ln>
+        </p:spPr>
+        <p:style>
+          <a:lnRef idx="1">
+            <a:schemeClr val="accent1"/>
+          </a:lnRef>
+          <a:fillRef idx="3">
+            <a:schemeClr val="accent1"/>
+          </a:fillRef>
+          <a:effectRef idx="2">
+            <a:schemeClr val="accent1"/>
+          </a:effectRef>
+          <a:fontRef idx="minor">
+            <a:schemeClr val="lt1"/>
+          </a:fontRef>
+        </p:style>
+        <p:txBody>
+          <a:bodyPr rtlCol="0" anchor="ctr" wrap="square" lIns="50800" rIns="50800" tIns="25400" bIns="25400"/>
+          <a:lstStyle/>
+          <a:p>
+            <a:pPr algn="ctr"/>
+            <a:r>
+              <a:rPr sz="1000" b="1">
+                <a:solidFill>
+                  <a:srgbClr val="FFFFFF"/>
+                </a:solidFill>
+                <a:latin typeface="Meiryo"/>
+              </a:rPr>
+              <a:t>犯人のシナリオ更新</a:t>
+            </a:r>
+          </a:p>
+        </p:txBody>
+      </p:sp>
+      <p:sp>
+        <p:nvSpPr>
+          <p:cNvPr id="29" name="Rectangle 28"/>
+          <p:cNvSpPr/>
+          <p:nvPr/>
+        </p:nvSpPr>
+        <p:spPr>
+          <a:xfrm>
+            <a:off x="7772400" y="5760720"/>
+            <a:ext cx="6400800" cy="548640"/>
+          </a:xfrm>
+          <a:prstGeom prst="rect">
+            <a:avLst/>
+          </a:prstGeom>
+          <a:solidFill>
+            <a:srgbClr val="FDEDEC"/>
+          </a:solidFill>
+          <a:ln w="25400">
+            <a:solidFill>
+              <a:srgbClr val="C0392B"/>
+            </a:solidFill>
+          </a:ln>
+        </p:spPr>
+        <p:style>
+          <a:lnRef idx="1">
+            <a:schemeClr val="accent1"/>
+          </a:lnRef>
+          <a:fillRef idx="3">
+            <a:schemeClr val="accent1"/>
+          </a:fillRef>
+          <a:effectRef idx="2">
+            <a:schemeClr val="accent1"/>
+          </a:effectRef>
+          <a:fontRef idx="minor">
+            <a:schemeClr val="lt1"/>
+          </a:fontRef>
+        </p:style>
+        <p:txBody>
+          <a:bodyPr rtlCol="0" anchor="ctr" wrap="square" lIns="63500" rIns="50800" tIns="38100" bIns="38100"/>
+          <a:lstStyle/>
+          <a:p>
+            <a:pPr algn="l"/>
+            <a:r>
+              <a:rPr sz="1000" b="1">
+                <a:solidFill>
+                  <a:srgbClr val="C0392B"/>
+                </a:solidFill>
+                <a:latin typeface="Meiryo"/>
+              </a:rPr>
+              <a:t>先週の結果を分析 → シナリオ修正 → 翌週実行
+→ 1週間</a:t>
+            </a:r>
+          </a:p>
+        </p:txBody>
+      </p:sp>
+      <p:sp>
+        <p:nvSpPr>
+          <p:cNvPr id="30" name="Rectangle 29"/>
+          <p:cNvSpPr/>
+          <p:nvPr/>
+        </p:nvSpPr>
+        <p:spPr>
+          <a:xfrm>
+            <a:off x="731520" y="6400800"/>
+            <a:ext cx="13624560" cy="365760"/>
+          </a:xfrm>
+          <a:prstGeom prst="rect">
+            <a:avLst/>
+          </a:prstGeom>
+          <a:solidFill>
+            <a:srgbClr val="C0392B"/>
+          </a:solidFill>
+          <a:ln>
+            <a:noFill/>
+          </a:ln>
+        </p:spPr>
+        <p:style>
+          <a:lnRef idx="1">
+            <a:schemeClr val="accent1"/>
+          </a:lnRef>
+          <a:fillRef idx="3">
+            <a:schemeClr val="accent1"/>
+          </a:fillRef>
+          <a:effectRef idx="2">
+            <a:schemeClr val="accent1"/>
+          </a:effectRef>
+          <a:fontRef idx="minor">
+            <a:schemeClr val="lt1"/>
+          </a:fontRef>
+        </p:style>
+        <p:txBody>
+          <a:bodyPr rtlCol="0" anchor="ctr" wrap="square" lIns="50800" rIns="50800" tIns="25400" bIns="25400"/>
+          <a:lstStyle/>
+          <a:p>
+            <a:pPr algn="ctr"/>
+            <a:r>
+              <a:rPr sz="1200" b="1">
+                <a:solidFill>
+                  <a:srgbClr val="FFFFFF"/>
+                </a:solidFill>
+                <a:latin typeface="Meiryo"/>
+              </a:rPr>
+              <a:t>銀行が1つのパターンに対応する間に、犯人は4〜8回シナリオを更新している</a:t>
+            </a:r>
+          </a:p>
+        </p:txBody>
+      </p:sp>
+      <p:sp>
+        <p:nvSpPr>
+          <p:cNvPr id="31" name="Rectangle 30"/>
+          <p:cNvSpPr/>
+          <p:nvPr/>
+        </p:nvSpPr>
+        <p:spPr>
+          <a:xfrm>
+            <a:off x="731520" y="6949440"/>
+            <a:ext cx="6583680" cy="320040"/>
+          </a:xfrm>
+          <a:prstGeom prst="rect">
+            <a:avLst/>
+          </a:prstGeom>
+          <a:solidFill>
+            <a:srgbClr val="C0392B"/>
+          </a:solidFill>
+          <a:ln>
+            <a:noFill/>
+          </a:ln>
+        </p:spPr>
+        <p:style>
+          <a:lnRef idx="1">
+            <a:schemeClr val="accent1"/>
+          </a:lnRef>
+          <a:fillRef idx="3">
+            <a:schemeClr val="accent1"/>
+          </a:fillRef>
+          <a:effectRef idx="2">
+            <a:schemeClr val="accent1"/>
+          </a:effectRef>
+          <a:fontRef idx="minor">
+            <a:schemeClr val="lt1"/>
+          </a:fontRef>
+        </p:style>
+        <p:txBody>
+          <a:bodyPr rtlCol="0" anchor="ctr" wrap="square" lIns="50800" rIns="50800" tIns="25400" bIns="25400"/>
+          <a:lstStyle/>
+          <a:p>
+            <a:pPr algn="ctr"/>
+            <a:r>
+              <a:rPr sz="1000" b="1">
+                <a:solidFill>
+                  <a:srgbClr val="FFFFFF"/>
+                </a:solidFill>
+                <a:latin typeface="Meiryo"/>
+              </a:rPr>
+              <a:t>シナリオに依存する防御 = 追いつけない</a:t>
+            </a:r>
+          </a:p>
+        </p:txBody>
+      </p:sp>
+      <p:sp>
+        <p:nvSpPr>
+          <p:cNvPr id="32" name="Rectangle 31"/>
+          <p:cNvSpPr/>
+          <p:nvPr/>
+        </p:nvSpPr>
+        <p:spPr>
+          <a:xfrm>
+            <a:off x="7772400" y="6949440"/>
+            <a:ext cx="6400800" cy="320040"/>
+          </a:xfrm>
+          <a:prstGeom prst="rect">
+            <a:avLst/>
+          </a:prstGeom>
+          <a:solidFill>
+            <a:srgbClr val="27AE60"/>
+          </a:solidFill>
+          <a:ln>
+            <a:noFill/>
+          </a:ln>
+        </p:spPr>
+        <p:style>
+          <a:lnRef idx="1">
+            <a:schemeClr val="accent1"/>
+          </a:lnRef>
+          <a:fillRef idx="3">
+            <a:schemeClr val="accent1"/>
+          </a:fillRef>
+          <a:effectRef idx="2">
+            <a:schemeClr val="accent1"/>
+          </a:effectRef>
+          <a:fontRef idx="minor">
+            <a:schemeClr val="lt1"/>
+          </a:fontRef>
+        </p:style>
+        <p:txBody>
+          <a:bodyPr rtlCol="0" anchor="ctr" wrap="square" lIns="50800" rIns="50800" tIns="25400" bIns="25400"/>
+          <a:lstStyle/>
+          <a:p>
+            <a:pPr algn="ctr"/>
+            <a:r>
+              <a:rPr sz="1000" b="1">
+                <a:solidFill>
+                  <a:srgbClr val="FFFFFF"/>
+                </a:solidFill>
+                <a:latin typeface="Meiryo"/>
+              </a:rPr>
+              <a:t>シナリオに依存しない防御 = 常に有効</a:t>
+            </a:r>
+          </a:p>
+        </p:txBody>
+      </p:sp>
+      <p:sp>
+        <p:nvSpPr>
+          <p:cNvPr id="33" name="Rectangle 32"/>
+          <p:cNvSpPr/>
+          <p:nvPr/>
+        </p:nvSpPr>
+        <p:spPr>
+          <a:xfrm>
+            <a:off x="731520" y="7269480"/>
+            <a:ext cx="6583680" cy="594360"/>
+          </a:xfrm>
+          <a:prstGeom prst="rect">
+            <a:avLst/>
+          </a:prstGeom>
+          <a:solidFill>
+            <a:srgbClr val="FFFFFF"/>
+          </a:solidFill>
+          <a:ln w="25400">
+            <a:solidFill>
+              <a:srgbClr val="C0392B"/>
+            </a:solidFill>
+          </a:ln>
+        </p:spPr>
+        <p:style>
+          <a:lnRef idx="1">
+            <a:schemeClr val="accent1"/>
+          </a:lnRef>
+          <a:fillRef idx="3">
+            <a:schemeClr val="accent1"/>
+          </a:fillRef>
+          <a:effectRef idx="2">
+            <a:schemeClr val="accent1"/>
+          </a:effectRef>
+          <a:fontRef idx="minor">
+            <a:schemeClr val="lt1"/>
+          </a:fontRef>
+        </p:style>
+        <p:txBody>
+          <a:bodyPr rtlCol="0" anchor="ctr" wrap="square" lIns="63500" rIns="50800" tIns="38100" bIns="38100"/>
+          <a:lstStyle/>
+          <a:p>
+            <a:pPr algn="l"/>
+            <a:r>
+              <a:rPr sz="900" b="0">
+                <a:solidFill>
+                  <a:srgbClr val="C0392B"/>
+                </a:solidFill>
+                <a:latin typeface="Meiryo"/>
+              </a:rPr>
+              <a:t>❌ 注意喚起
+❌ パターンマッチ
+❌ セキュリティ教育</a:t>
+            </a:r>
+          </a:p>
+        </p:txBody>
+      </p:sp>
+      <p:sp>
+        <p:nvSpPr>
+          <p:cNvPr id="34" name="Rectangle 33"/>
+          <p:cNvSpPr/>
+          <p:nvPr/>
+        </p:nvSpPr>
+        <p:spPr>
+          <a:xfrm>
+            <a:off x="7772400" y="7269480"/>
+            <a:ext cx="6400800" cy="594360"/>
+          </a:xfrm>
+          <a:prstGeom prst="rect">
+            <a:avLst/>
+          </a:prstGeom>
+          <a:solidFill>
+            <a:srgbClr val="FFFFFF"/>
+          </a:solidFill>
+          <a:ln w="25400">
+            <a:solidFill>
+              <a:srgbClr val="27AE60"/>
+            </a:solidFill>
+          </a:ln>
+        </p:spPr>
+        <p:style>
+          <a:lnRef idx="1">
+            <a:schemeClr val="accent1"/>
+          </a:lnRef>
+          <a:fillRef idx="3">
+            <a:schemeClr val="accent1"/>
+          </a:fillRef>
+          <a:effectRef idx="2">
+            <a:schemeClr val="accent1"/>
+          </a:effectRef>
+          <a:fontRef idx="minor">
+            <a:schemeClr val="lt1"/>
+          </a:fontRef>
+        </p:style>
+        <p:txBody>
+          <a:bodyPr rtlCol="0" anchor="ctr" wrap="square" lIns="63500" rIns="50800" tIns="38100" bIns="38100"/>
+          <a:lstStyle/>
+          <a:p>
+            <a:pPr algn="l"/>
+            <a:r>
+              <a:rPr sz="900" b="0">
+                <a:solidFill>
+                  <a:srgbClr val="27AE60"/>
+                </a:solidFill>
+                <a:latin typeface="Meiryo"/>
+              </a:rPr>
+              <a:t>✅ DMARC p=reject → シナリオが何であれ偽メールは届かない
+✅ AppLocker → シナリオが何であれ未許可アプリは実行できない
+✅ 技術的対策だけが「シナリオに依存しない防御」</a:t>
+            </a:r>
+          </a:p>
+        </p:txBody>
+      </p:sp>
+      <p:sp>
+        <p:nvSpPr>
+          <p:cNvPr id="35" name="TextBox 34"/>
+          <p:cNvSpPr txBox="1"/>
+          <p:nvPr/>
+        </p:nvSpPr>
+        <p:spPr>
+          <a:xfrm>
+            <a:off x="9144000" y="10378440"/>
+            <a:ext cx="5943600" cy="228600"/>
+          </a:xfrm>
+          <a:prstGeom prst="rect">
+            <a:avLst/>
+          </a:prstGeom>
+          <a:noFill/>
+        </p:spPr>
+        <p:txBody>
+          <a:bodyPr wrap="square" lIns="50800" rIns="50800" tIns="38100" bIns="38100"/>
+          <a:lstStyle/>
+          <a:p>
+            <a:pPr algn="r"/>
+            <a:r>
+              <a:rPr sz="700" b="0">
+                <a:solidFill>
+                  <a:srgbClr val="888888"/>
+                </a:solidFill>
+                <a:latin typeface="Meiryo"/>
+              </a:rPr>
+              <a:t>Fraud Kill Chain — 週次シナリオ更新と防御の非対称性</a:t>
             </a:r>
           </a:p>
         </p:txBody>

</xml_diff>

<commit_message>
Add real-time transfer block analysis and BEC classification
Why transfers can't be stopped in real-time (5 reasons), and how
this attack differs from BEC. Correctly classified as Vishing-origin
ATO fraud, not email compromise. Added to both Word and PowerPoint.

https://claude.ai/code/session_01F7t8LKifK43o6sCdF2a3gQ
</commit_message>
<xml_diff>
--- a/Fraud_Kill_Chain.pptx
+++ b/Fraud_Kill_Chain.pptx
@@ -23,6 +23,8 @@
     <p:sldId id="271" r:id="rId22"/>
     <p:sldId id="272" r:id="rId23"/>
     <p:sldId id="273" r:id="rId24"/>
+    <p:sldId id="274" r:id="rId25"/>
+    <p:sldId id="275" r:id="rId26"/>
   </p:sldIdLst>
   <p:sldSz cx="15124176" cy="10689336" type="screen4x3"/>
   <p:notesSz cx="6858000" cy="9144000"/>
@@ -25693,6 +25695,765 @@
 </p:sld>
 </file>
 
+<file path=ppt/slides/slide19.xml><?xml version="1.0" encoding="utf-8"?>
+<p:sld xmlns:a="http://schemas.openxmlformats.org/drawingml/2006/main" xmlns:p="http://schemas.openxmlformats.org/presentationml/2006/main" xmlns:r="http://schemas.openxmlformats.org/officeDocument/2006/relationships">
+  <p:cSld>
+    <p:bg>
+      <p:bgPr>
+        <a:solidFill>
+          <a:srgbClr val="F5F5F5"/>
+        </a:solidFill>
+        <a:effectLst/>
+      </p:bgPr>
+    </p:bg>
+    <p:spTree>
+      <p:nvGrpSpPr>
+        <p:cNvPr id="1" name=""/>
+        <p:cNvGrpSpPr/>
+        <p:nvPr/>
+      </p:nvGrpSpPr>
+      <p:grpSpPr/>
+      <p:sp>
+        <p:nvSpPr>
+          <p:cNvPr id="2" name="TextBox 1"/>
+          <p:cNvSpPr txBox="1"/>
+          <p:nvPr/>
+        </p:nvSpPr>
+        <p:spPr>
+          <a:xfrm>
+            <a:off x="0" y="182880"/>
+            <a:ext cx="15124176" cy="548640"/>
+          </a:xfrm>
+          <a:prstGeom prst="rect">
+            <a:avLst/>
+          </a:prstGeom>
+          <a:noFill/>
+        </p:spPr>
+        <p:txBody>
+          <a:bodyPr wrap="square" lIns="50800" rIns="50800" tIns="38100" bIns="38100"/>
+          <a:lstStyle/>
+          <a:p>
+            <a:pPr algn="ctr"/>
+            <a:r>
+              <a:rPr sz="2400" b="1">
+                <a:solidFill>
+                  <a:srgbClr val="C0392B"/>
+                </a:solidFill>
+                <a:latin typeface="Meiryo"/>
+              </a:rPr>
+              <a:t>振込を即時に止められない理由</a:t>
+            </a:r>
+          </a:p>
+        </p:txBody>
+      </p:sp>
+      <p:sp>
+        <p:nvSpPr>
+          <p:cNvPr id="3" name="TextBox 2"/>
+          <p:cNvSpPr txBox="1"/>
+          <p:nvPr/>
+        </p:nvSpPr>
+        <p:spPr>
+          <a:xfrm>
+            <a:off x="0" y="640080"/>
+            <a:ext cx="15124176" cy="365760"/>
+          </a:xfrm>
+          <a:prstGeom prst="rect">
+            <a:avLst/>
+          </a:prstGeom>
+          <a:noFill/>
+        </p:spPr>
+        <p:txBody>
+          <a:bodyPr wrap="square" lIns="50800" rIns="50800" tIns="38100" bIns="38100"/>
+          <a:lstStyle/>
+          <a:p>
+            <a:pPr algn="ctr"/>
+            <a:r>
+              <a:rPr sz="1100" b="0">
+                <a:solidFill>
+                  <a:srgbClr val="888888"/>
+                </a:solidFill>
+                <a:latin typeface="Meiryo"/>
+              </a:rPr>
+              <a:t>「速い・高額・自動・即着金」という法人IBの利便性が、そのまま攻撃の通り道になっている。</a:t>
+            </a:r>
+          </a:p>
+        </p:txBody>
+      </p:sp>
+      <p:sp>
+        <p:nvSpPr>
+          <p:cNvPr id="4" name="Rectangle 3"/>
+          <p:cNvSpPr/>
+          <p:nvPr/>
+        </p:nvSpPr>
+        <p:spPr>
+          <a:xfrm>
+            <a:off x="731520" y="1097280"/>
+            <a:ext cx="13624560" cy="365760"/>
+          </a:xfrm>
+          <a:prstGeom prst="rect">
+            <a:avLst/>
+          </a:prstGeom>
+          <a:solidFill>
+            <a:srgbClr val="222222"/>
+          </a:solidFill>
+          <a:ln>
+            <a:noFill/>
+          </a:ln>
+        </p:spPr>
+        <p:style>
+          <a:lnRef idx="1">
+            <a:schemeClr val="accent1"/>
+          </a:lnRef>
+          <a:fillRef idx="3">
+            <a:schemeClr val="accent1"/>
+          </a:fillRef>
+          <a:effectRef idx="2">
+            <a:schemeClr val="accent1"/>
+          </a:effectRef>
+          <a:fontRef idx="minor">
+            <a:schemeClr val="lt1"/>
+          </a:fontRef>
+        </p:style>
+        <p:txBody>
+          <a:bodyPr rtlCol="0" anchor="ctr" wrap="square" lIns="50800" rIns="50800" tIns="25400" bIns="25400"/>
+          <a:lstStyle/>
+          <a:p>
+            <a:pPr algn="ctr"/>
+            <a:r>
+              <a:rPr sz="1100" b="1">
+                <a:solidFill>
+                  <a:srgbClr val="FFFFFF"/>
+                </a:solidFill>
+                <a:latin typeface="Meiryo"/>
+              </a:rPr>
+              <a:t>理由1：振込時点では「正規の取引」と判別不能</a:t>
+            </a:r>
+          </a:p>
+        </p:txBody>
+      </p:sp>
+      <p:sp>
+        <p:nvSpPr>
+          <p:cNvPr id="5" name="Rectangle 4"/>
+          <p:cNvSpPr/>
+          <p:nvPr/>
+        </p:nvSpPr>
+        <p:spPr>
+          <a:xfrm>
+            <a:off x="731520" y="1463040"/>
+            <a:ext cx="13624560" cy="384048"/>
+          </a:xfrm>
+          <a:prstGeom prst="rect">
+            <a:avLst/>
+          </a:prstGeom>
+          <a:solidFill>
+            <a:srgbClr val="FFFFFF"/>
+          </a:solidFill>
+          <a:ln w="25400">
+            <a:solidFill>
+              <a:srgbClr val="CCCCCC"/>
+            </a:solidFill>
+          </a:ln>
+        </p:spPr>
+        <p:style>
+          <a:lnRef idx="1">
+            <a:schemeClr val="accent1"/>
+          </a:lnRef>
+          <a:fillRef idx="3">
+            <a:schemeClr val="accent1"/>
+          </a:fillRef>
+          <a:effectRef idx="2">
+            <a:schemeClr val="accent1"/>
+          </a:effectRef>
+          <a:fontRef idx="minor">
+            <a:schemeClr val="lt1"/>
+          </a:fontRef>
+        </p:style>
+        <p:txBody>
+          <a:bodyPr rtlCol="0" anchor="ctr" wrap="square" lIns="63500" rIns="50800" tIns="38100" bIns="38100"/>
+          <a:lstStyle/>
+          <a:p>
+            <a:pPr algn="l"/>
+            <a:r>
+              <a:rPr sz="900" b="0">
+                <a:solidFill>
+                  <a:srgbClr val="222222"/>
+                </a:solidFill>
+                <a:latin typeface="Meiryo"/>
+              </a:rPr>
+              <a:t>正しい認証情報・OTP・本人のアカウント・いつものIP（PC経由）→「本人による正規の振込」としか見えず、止める根拠がない</a:t>
+            </a:r>
+          </a:p>
+        </p:txBody>
+      </p:sp>
+      <p:sp>
+        <p:nvSpPr>
+          <p:cNvPr id="6" name="Rectangle 5"/>
+          <p:cNvSpPr/>
+          <p:nvPr/>
+        </p:nvSpPr>
+        <p:spPr>
+          <a:xfrm>
+            <a:off x="731520" y="1874519"/>
+            <a:ext cx="13624560" cy="365760"/>
+          </a:xfrm>
+          <a:prstGeom prst="rect">
+            <a:avLst/>
+          </a:prstGeom>
+          <a:solidFill>
+            <a:srgbClr val="222222"/>
+          </a:solidFill>
+          <a:ln>
+            <a:noFill/>
+          </a:ln>
+        </p:spPr>
+        <p:style>
+          <a:lnRef idx="1">
+            <a:schemeClr val="accent1"/>
+          </a:lnRef>
+          <a:fillRef idx="3">
+            <a:schemeClr val="accent1"/>
+          </a:fillRef>
+          <a:effectRef idx="2">
+            <a:schemeClr val="accent1"/>
+          </a:effectRef>
+          <a:fontRef idx="minor">
+            <a:schemeClr val="lt1"/>
+          </a:fontRef>
+        </p:style>
+        <p:txBody>
+          <a:bodyPr rtlCol="0" anchor="ctr" wrap="square" lIns="50800" rIns="50800" tIns="25400" bIns="25400"/>
+          <a:lstStyle/>
+          <a:p>
+            <a:pPr algn="ctr"/>
+            <a:r>
+              <a:rPr sz="1100" b="1">
+                <a:solidFill>
+                  <a:srgbClr val="FFFFFF"/>
+                </a:solidFill>
+                <a:latin typeface="Meiryo"/>
+              </a:rPr>
+              <a:t>理由2：振込限度額の範囲内なら自動で通る</a:t>
+            </a:r>
+          </a:p>
+        </p:txBody>
+      </p:sp>
+      <p:sp>
+        <p:nvSpPr>
+          <p:cNvPr id="7" name="Rectangle 6"/>
+          <p:cNvSpPr/>
+          <p:nvPr/>
+        </p:nvSpPr>
+        <p:spPr>
+          <a:xfrm>
+            <a:off x="731520" y="2240279"/>
+            <a:ext cx="13624560" cy="384048"/>
+          </a:xfrm>
+          <a:prstGeom prst="rect">
+            <a:avLst/>
+          </a:prstGeom>
+          <a:solidFill>
+            <a:srgbClr val="FFFFFF"/>
+          </a:solidFill>
+          <a:ln w="25400">
+            <a:solidFill>
+              <a:srgbClr val="CCCCCC"/>
+            </a:solidFill>
+          </a:ln>
+        </p:spPr>
+        <p:style>
+          <a:lnRef idx="1">
+            <a:schemeClr val="accent1"/>
+          </a:lnRef>
+          <a:fillRef idx="3">
+            <a:schemeClr val="accent1"/>
+          </a:fillRef>
+          <a:effectRef idx="2">
+            <a:schemeClr val="accent1"/>
+          </a:effectRef>
+          <a:fontRef idx="minor">
+            <a:schemeClr val="lt1"/>
+          </a:fontRef>
+        </p:style>
+        <p:txBody>
+          <a:bodyPr rtlCol="0" anchor="ctr" wrap="square" lIns="63500" rIns="50800" tIns="38100" bIns="38100"/>
+          <a:lstStyle/>
+          <a:p>
+            <a:pPr algn="l"/>
+            <a:r>
+              <a:rPr sz="900" b="0">
+                <a:solidFill>
+                  <a:srgbClr val="222222"/>
+                </a:solidFill>
+                <a:latin typeface="Meiryo"/>
+              </a:rPr>
+              <a:t>法人IBの限度額は高額。範囲内ならシステムが自動承認し、人間のチェックが入らず数秒で送金完了</a:t>
+            </a:r>
+          </a:p>
+        </p:txBody>
+      </p:sp>
+      <p:sp>
+        <p:nvSpPr>
+          <p:cNvPr id="8" name="Rectangle 7"/>
+          <p:cNvSpPr/>
+          <p:nvPr/>
+        </p:nvSpPr>
+        <p:spPr>
+          <a:xfrm>
+            <a:off x="731520" y="2651760"/>
+            <a:ext cx="13624560" cy="365760"/>
+          </a:xfrm>
+          <a:prstGeom prst="rect">
+            <a:avLst/>
+          </a:prstGeom>
+          <a:solidFill>
+            <a:srgbClr val="222222"/>
+          </a:solidFill>
+          <a:ln>
+            <a:noFill/>
+          </a:ln>
+        </p:spPr>
+        <p:style>
+          <a:lnRef idx="1">
+            <a:schemeClr val="accent1"/>
+          </a:lnRef>
+          <a:fillRef idx="3">
+            <a:schemeClr val="accent1"/>
+          </a:fillRef>
+          <a:effectRef idx="2">
+            <a:schemeClr val="accent1"/>
+          </a:effectRef>
+          <a:fontRef idx="minor">
+            <a:schemeClr val="lt1"/>
+          </a:fontRef>
+        </p:style>
+        <p:txBody>
+          <a:bodyPr rtlCol="0" anchor="ctr" wrap="square" lIns="50800" rIns="50800" tIns="25400" bIns="25400"/>
+          <a:lstStyle/>
+          <a:p>
+            <a:pPr algn="ctr"/>
+            <a:r>
+              <a:rPr sz="1100" b="1">
+                <a:solidFill>
+                  <a:srgbClr val="FFFFFF"/>
+                </a:solidFill>
+                <a:latin typeface="Meiryo"/>
+              </a:rPr>
+              <a:t>理由3：全銀システムは「即時送金」が前提</a:t>
+            </a:r>
+          </a:p>
+        </p:txBody>
+      </p:sp>
+      <p:sp>
+        <p:nvSpPr>
+          <p:cNvPr id="9" name="Rectangle 8"/>
+          <p:cNvSpPr/>
+          <p:nvPr/>
+        </p:nvSpPr>
+        <p:spPr>
+          <a:xfrm>
+            <a:off x="731520" y="3017520"/>
+            <a:ext cx="13624560" cy="384048"/>
+          </a:xfrm>
+          <a:prstGeom prst="rect">
+            <a:avLst/>
+          </a:prstGeom>
+          <a:solidFill>
+            <a:srgbClr val="FFFFFF"/>
+          </a:solidFill>
+          <a:ln w="25400">
+            <a:solidFill>
+              <a:srgbClr val="CCCCCC"/>
+            </a:solidFill>
+          </a:ln>
+        </p:spPr>
+        <p:style>
+          <a:lnRef idx="1">
+            <a:schemeClr val="accent1"/>
+          </a:lnRef>
+          <a:fillRef idx="3">
+            <a:schemeClr val="accent1"/>
+          </a:fillRef>
+          <a:effectRef idx="2">
+            <a:schemeClr val="accent1"/>
+          </a:effectRef>
+          <a:fontRef idx="minor">
+            <a:schemeClr val="lt1"/>
+          </a:fontRef>
+        </p:style>
+        <p:txBody>
+          <a:bodyPr rtlCol="0" anchor="ctr" wrap="square" lIns="63500" rIns="50800" tIns="38100" bIns="38100"/>
+          <a:lstStyle/>
+          <a:p>
+            <a:pPr algn="l"/>
+            <a:r>
+              <a:rPr sz="900" b="0">
+                <a:solidFill>
+                  <a:srgbClr val="222222"/>
+                </a:solidFill>
+                <a:latin typeface="Meiryo"/>
+              </a:rPr>
+              <a:t>モアタイムシステムで24時間即時着金。「ちょっと待った」ができず、着金した瞬間に引き出し可能</a:t>
+            </a:r>
+          </a:p>
+        </p:txBody>
+      </p:sp>
+      <p:sp>
+        <p:nvSpPr>
+          <p:cNvPr id="10" name="Rectangle 9"/>
+          <p:cNvSpPr/>
+          <p:nvPr/>
+        </p:nvSpPr>
+        <p:spPr>
+          <a:xfrm>
+            <a:off x="731520" y="3429000"/>
+            <a:ext cx="13624560" cy="365760"/>
+          </a:xfrm>
+          <a:prstGeom prst="rect">
+            <a:avLst/>
+          </a:prstGeom>
+          <a:solidFill>
+            <a:srgbClr val="222222"/>
+          </a:solidFill>
+          <a:ln>
+            <a:noFill/>
+          </a:ln>
+        </p:spPr>
+        <p:style>
+          <a:lnRef idx="1">
+            <a:schemeClr val="accent1"/>
+          </a:lnRef>
+          <a:fillRef idx="3">
+            <a:schemeClr val="accent1"/>
+          </a:fillRef>
+          <a:effectRef idx="2">
+            <a:schemeClr val="accent1"/>
+          </a:effectRef>
+          <a:fontRef idx="minor">
+            <a:schemeClr val="lt1"/>
+          </a:fontRef>
+        </p:style>
+        <p:txBody>
+          <a:bodyPr rtlCol="0" anchor="ctr" wrap="square" lIns="50800" rIns="50800" tIns="25400" bIns="25400"/>
+          <a:lstStyle/>
+          <a:p>
+            <a:pPr algn="ctr"/>
+            <a:r>
+              <a:rPr sz="1100" b="1">
+                <a:solidFill>
+                  <a:srgbClr val="FFFFFF"/>
+                </a:solidFill>
+                <a:latin typeface="Meiryo"/>
+              </a:rPr>
+              <a:t>理由4：着金後すぐ資金が分散される（マネロン）</a:t>
+            </a:r>
+          </a:p>
+        </p:txBody>
+      </p:sp>
+      <p:sp>
+        <p:nvSpPr>
+          <p:cNvPr id="11" name="Rectangle 10"/>
+          <p:cNvSpPr/>
+          <p:nvPr/>
+        </p:nvSpPr>
+        <p:spPr>
+          <a:xfrm>
+            <a:off x="731520" y="3794760"/>
+            <a:ext cx="13624560" cy="384048"/>
+          </a:xfrm>
+          <a:prstGeom prst="rect">
+            <a:avLst/>
+          </a:prstGeom>
+          <a:solidFill>
+            <a:srgbClr val="FFFFFF"/>
+          </a:solidFill>
+          <a:ln w="25400">
+            <a:solidFill>
+              <a:srgbClr val="CCCCCC"/>
+            </a:solidFill>
+          </a:ln>
+        </p:spPr>
+        <p:style>
+          <a:lnRef idx="1">
+            <a:schemeClr val="accent1"/>
+          </a:lnRef>
+          <a:fillRef idx="3">
+            <a:schemeClr val="accent1"/>
+          </a:fillRef>
+          <a:effectRef idx="2">
+            <a:schemeClr val="accent1"/>
+          </a:effectRef>
+          <a:fontRef idx="minor">
+            <a:schemeClr val="lt1"/>
+          </a:fontRef>
+        </p:style>
+        <p:txBody>
+          <a:bodyPr rtlCol="0" anchor="ctr" wrap="square" lIns="63500" rIns="50800" tIns="38100" bIns="38100"/>
+          <a:lstStyle/>
+          <a:p>
+            <a:pPr algn="l"/>
+            <a:r>
+              <a:rPr sz="900" b="0">
+                <a:solidFill>
+                  <a:srgbClr val="222222"/>
+                </a:solidFill>
+                <a:latin typeface="Meiryo"/>
+              </a:rPr>
+              <a:t>出し子の口座へ着金 → 即ATM出金/別口座/暗号資産へ → 数分で資金が消え、組戻しが間に合わない</a:t>
+            </a:r>
+          </a:p>
+        </p:txBody>
+      </p:sp>
+      <p:sp>
+        <p:nvSpPr>
+          <p:cNvPr id="12" name="Rectangle 11"/>
+          <p:cNvSpPr/>
+          <p:nvPr/>
+        </p:nvSpPr>
+        <p:spPr>
+          <a:xfrm>
+            <a:off x="731520" y="4206240"/>
+            <a:ext cx="13624560" cy="365760"/>
+          </a:xfrm>
+          <a:prstGeom prst="rect">
+            <a:avLst/>
+          </a:prstGeom>
+          <a:solidFill>
+            <a:srgbClr val="222222"/>
+          </a:solidFill>
+          <a:ln>
+            <a:noFill/>
+          </a:ln>
+        </p:spPr>
+        <p:style>
+          <a:lnRef idx="1">
+            <a:schemeClr val="accent1"/>
+          </a:lnRef>
+          <a:fillRef idx="3">
+            <a:schemeClr val="accent1"/>
+          </a:fillRef>
+          <a:effectRef idx="2">
+            <a:schemeClr val="accent1"/>
+          </a:effectRef>
+          <a:fontRef idx="minor">
+            <a:schemeClr val="lt1"/>
+          </a:fontRef>
+        </p:style>
+        <p:txBody>
+          <a:bodyPr rtlCol="0" anchor="ctr" wrap="square" lIns="50800" rIns="50800" tIns="25400" bIns="25400"/>
+          <a:lstStyle/>
+          <a:p>
+            <a:pPr algn="ctr"/>
+            <a:r>
+              <a:rPr sz="1100" b="1">
+                <a:solidFill>
+                  <a:srgbClr val="FFFFFF"/>
+                </a:solidFill>
+                <a:latin typeface="Meiryo"/>
+              </a:rPr>
+              <a:t>理由5：被害者が攻撃に気づくのが遅い</a:t>
+            </a:r>
+          </a:p>
+        </p:txBody>
+      </p:sp>
+      <p:sp>
+        <p:nvSpPr>
+          <p:cNvPr id="13" name="Rectangle 12"/>
+          <p:cNvSpPr/>
+          <p:nvPr/>
+        </p:nvSpPr>
+        <p:spPr>
+          <a:xfrm>
+            <a:off x="731520" y="4572000"/>
+            <a:ext cx="13624560" cy="384048"/>
+          </a:xfrm>
+          <a:prstGeom prst="rect">
+            <a:avLst/>
+          </a:prstGeom>
+          <a:solidFill>
+            <a:srgbClr val="FFFFFF"/>
+          </a:solidFill>
+          <a:ln w="25400">
+            <a:solidFill>
+              <a:srgbClr val="CCCCCC"/>
+            </a:solidFill>
+          </a:ln>
+        </p:spPr>
+        <p:style>
+          <a:lnRef idx="1">
+            <a:schemeClr val="accent1"/>
+          </a:lnRef>
+          <a:fillRef idx="3">
+            <a:schemeClr val="accent1"/>
+          </a:fillRef>
+          <a:effectRef idx="2">
+            <a:schemeClr val="accent1"/>
+          </a:effectRef>
+          <a:fontRef idx="minor">
+            <a:schemeClr val="lt1"/>
+          </a:fontRef>
+        </p:style>
+        <p:txBody>
+          <a:bodyPr rtlCol="0" anchor="ctr" wrap="square" lIns="63500" rIns="50800" tIns="38100" bIns="38100"/>
+          <a:lstStyle/>
+          <a:p>
+            <a:pPr algn="l"/>
+            <a:r>
+              <a:rPr sz="900" b="0">
+                <a:solidFill>
+                  <a:srgbClr val="222222"/>
+                </a:solidFill>
+                <a:latin typeface="Meiryo"/>
+              </a:rPr>
+              <a:t>「銀行の手続きをした」と思っており、通報が数時間〜数日遅れる。その間に資金は完全に消える</a:t>
+            </a:r>
+          </a:p>
+        </p:txBody>
+      </p:sp>
+      <p:sp>
+        <p:nvSpPr>
+          <p:cNvPr id="14" name="Rectangle 13"/>
+          <p:cNvSpPr/>
+          <p:nvPr/>
+        </p:nvSpPr>
+        <p:spPr>
+          <a:xfrm>
+            <a:off x="731520" y="5074920"/>
+            <a:ext cx="13624560" cy="411480"/>
+          </a:xfrm>
+          <a:prstGeom prst="rect">
+            <a:avLst/>
+          </a:prstGeom>
+          <a:solidFill>
+            <a:srgbClr val="C0392B"/>
+          </a:solidFill>
+          <a:ln>
+            <a:noFill/>
+          </a:ln>
+        </p:spPr>
+        <p:style>
+          <a:lnRef idx="1">
+            <a:schemeClr val="accent1"/>
+          </a:lnRef>
+          <a:fillRef idx="3">
+            <a:schemeClr val="accent1"/>
+          </a:fillRef>
+          <a:effectRef idx="2">
+            <a:schemeClr val="accent1"/>
+          </a:effectRef>
+          <a:fontRef idx="minor">
+            <a:schemeClr val="lt1"/>
+          </a:fontRef>
+        </p:style>
+        <p:txBody>
+          <a:bodyPr rtlCol="0" anchor="ctr" wrap="square" lIns="50800" rIns="50800" tIns="25400" bIns="25400"/>
+          <a:lstStyle/>
+          <a:p>
+            <a:pPr algn="ctr"/>
+            <a:r>
+              <a:rPr sz="1200" b="1">
+                <a:solidFill>
+                  <a:srgbClr val="FFFFFF"/>
+                </a:solidFill>
+                <a:latin typeface="Meiryo"/>
+              </a:rPr>
+              <a:t>送金の瞬間：正規と区別できない → 送金直後：資金が即分散 → 被害認識：本人が気づかない</a:t>
+            </a:r>
+          </a:p>
+        </p:txBody>
+      </p:sp>
+      <p:sp>
+        <p:nvSpPr>
+          <p:cNvPr id="15" name="Rectangle 14"/>
+          <p:cNvSpPr/>
+          <p:nvPr/>
+        </p:nvSpPr>
+        <p:spPr>
+          <a:xfrm>
+            <a:off x="731520" y="5532120"/>
+            <a:ext cx="13624560" cy="457200"/>
+          </a:xfrm>
+          <a:prstGeom prst="rect">
+            <a:avLst/>
+          </a:prstGeom>
+          <a:solidFill>
+            <a:srgbClr val="27AE60"/>
+          </a:solidFill>
+          <a:ln>
+            <a:noFill/>
+          </a:ln>
+        </p:spPr>
+        <p:style>
+          <a:lnRef idx="1">
+            <a:schemeClr val="accent1"/>
+          </a:lnRef>
+          <a:fillRef idx="3">
+            <a:schemeClr val="accent1"/>
+          </a:fillRef>
+          <a:effectRef idx="2">
+            <a:schemeClr val="accent1"/>
+          </a:effectRef>
+          <a:fontRef idx="minor">
+            <a:schemeClr val="lt1"/>
+          </a:fontRef>
+        </p:style>
+        <p:txBody>
+          <a:bodyPr rtlCol="0" anchor="ctr" wrap="square" lIns="50800" rIns="50800" tIns="25400" bIns="25400"/>
+          <a:lstStyle/>
+          <a:p>
+            <a:pPr algn="ctr"/>
+            <a:r>
+              <a:rPr sz="1200" b="1">
+                <a:solidFill>
+                  <a:srgbClr val="FFFFFF"/>
+                </a:solidFill>
+                <a:latin typeface="Meiryo"/>
+              </a:rPr>
+              <a:t>事後に止めるのは不可能。振込の手前（手順④⑥）で止めるか、「初回送金先は着金保留」の仕組みが必要。</a:t>
+            </a:r>
+          </a:p>
+        </p:txBody>
+      </p:sp>
+      <p:sp>
+        <p:nvSpPr>
+          <p:cNvPr id="16" name="TextBox 15"/>
+          <p:cNvSpPr txBox="1"/>
+          <p:nvPr/>
+        </p:nvSpPr>
+        <p:spPr>
+          <a:xfrm>
+            <a:off x="9144000" y="10378440"/>
+            <a:ext cx="5943600" cy="228600"/>
+          </a:xfrm>
+          <a:prstGeom prst="rect">
+            <a:avLst/>
+          </a:prstGeom>
+          <a:noFill/>
+        </p:spPr>
+        <p:txBody>
+          <a:bodyPr wrap="square" lIns="50800" rIns="50800" tIns="38100" bIns="38100"/>
+          <a:lstStyle/>
+          <a:p>
+            <a:pPr algn="r"/>
+            <a:r>
+              <a:rPr sz="700" b="0">
+                <a:solidFill>
+                  <a:srgbClr val="888888"/>
+                </a:solidFill>
+                <a:latin typeface="Meiryo"/>
+              </a:rPr>
+              <a:t>Fraud Kill Chain — 振込を即時に止められない理由</a:t>
+            </a:r>
+          </a:p>
+        </p:txBody>
+      </p:sp>
+    </p:spTree>
+  </p:cSld>
+  <p:clrMapOvr>
+    <a:masterClrMapping/>
+  </p:clrMapOvr>
+</p:sld>
+</file>
+
 <file path=ppt/slides/slide2.xml><?xml version="1.0" encoding="utf-8"?>
 <p:sld xmlns:a="http://schemas.openxmlformats.org/drawingml/2006/main" xmlns:p="http://schemas.openxmlformats.org/presentationml/2006/main" xmlns:r="http://schemas.openxmlformats.org/officeDocument/2006/relationships">
   <p:cSld>
@@ -26850,6 +27611,1416 @@
                 <a:latin typeface="Meiryo"/>
               </a:rPr>
               <a:t>Fraud Kill Chain — 銀行の正規フローとの類似性</a:t>
+            </a:r>
+          </a:p>
+        </p:txBody>
+      </p:sp>
+    </p:spTree>
+  </p:cSld>
+  <p:clrMapOvr>
+    <a:masterClrMapping/>
+  </p:clrMapOvr>
+</p:sld>
+</file>
+
+<file path=ppt/slides/slide20.xml><?xml version="1.0" encoding="utf-8"?>
+<p:sld xmlns:a="http://schemas.openxmlformats.org/drawingml/2006/main" xmlns:p="http://schemas.openxmlformats.org/presentationml/2006/main" xmlns:r="http://schemas.openxmlformats.org/officeDocument/2006/relationships">
+  <p:cSld>
+    <p:bg>
+      <p:bgPr>
+        <a:solidFill>
+          <a:srgbClr val="F5F5F5"/>
+        </a:solidFill>
+        <a:effectLst/>
+      </p:bgPr>
+    </p:bg>
+    <p:spTree>
+      <p:nvGrpSpPr>
+        <p:cNvPr id="1" name=""/>
+        <p:cNvGrpSpPr/>
+        <p:nvPr/>
+      </p:nvGrpSpPr>
+      <p:grpSpPr/>
+      <p:sp>
+        <p:nvSpPr>
+          <p:cNvPr id="2" name="TextBox 1"/>
+          <p:cNvSpPr txBox="1"/>
+          <p:nvPr/>
+        </p:nvSpPr>
+        <p:spPr>
+          <a:xfrm>
+            <a:off x="0" y="182880"/>
+            <a:ext cx="15124176" cy="548640"/>
+          </a:xfrm>
+          <a:prstGeom prst="rect">
+            <a:avLst/>
+          </a:prstGeom>
+          <a:noFill/>
+        </p:spPr>
+        <p:txBody>
+          <a:bodyPr wrap="square" lIns="50800" rIns="50800" tIns="38100" bIns="38100"/>
+          <a:lstStyle/>
+          <a:p>
+            <a:pPr algn="ctr"/>
+            <a:r>
+              <a:rPr sz="2400" b="1">
+                <a:solidFill>
+                  <a:srgbClr val="C0392B"/>
+                </a:solidFill>
+                <a:latin typeface="Meiryo"/>
+              </a:rPr>
+              <a:t>BEC（ビジネスメール詐欺）との違い</a:t>
+            </a:r>
+          </a:p>
+        </p:txBody>
+      </p:sp>
+      <p:sp>
+        <p:nvSpPr>
+          <p:cNvPr id="3" name="TextBox 2"/>
+          <p:cNvSpPr txBox="1"/>
+          <p:nvPr/>
+        </p:nvSpPr>
+        <p:spPr>
+          <a:xfrm>
+            <a:off x="0" y="640080"/>
+            <a:ext cx="15124176" cy="365760"/>
+          </a:xfrm>
+          <a:prstGeom prst="rect">
+            <a:avLst/>
+          </a:prstGeom>
+          <a:noFill/>
+        </p:spPr>
+        <p:txBody>
+          <a:bodyPr wrap="square" lIns="50800" rIns="50800" tIns="38100" bIns="38100"/>
+          <a:lstStyle/>
+          <a:p>
+            <a:pPr algn="ctr"/>
+            <a:r>
+              <a:rPr sz="1100" b="0">
+                <a:solidFill>
+                  <a:srgbClr val="888888"/>
+                </a:solidFill>
+                <a:latin typeface="Meiryo"/>
+              </a:rPr>
+              <a:t>今回のKill Chainは典型的なBECではなく、別系統の攻撃。BEC＝メール侵害が起点。</a:t>
+            </a:r>
+          </a:p>
+        </p:txBody>
+      </p:sp>
+      <p:sp>
+        <p:nvSpPr>
+          <p:cNvPr id="4" name="Rectangle 3"/>
+          <p:cNvSpPr/>
+          <p:nvPr/>
+        </p:nvSpPr>
+        <p:spPr>
+          <a:xfrm>
+            <a:off x="731520" y="1097280"/>
+            <a:ext cx="13624560" cy="365760"/>
+          </a:xfrm>
+          <a:prstGeom prst="rect">
+            <a:avLst/>
+          </a:prstGeom>
+          <a:solidFill>
+            <a:srgbClr val="222222"/>
+          </a:solidFill>
+          <a:ln>
+            <a:noFill/>
+          </a:ln>
+        </p:spPr>
+        <p:style>
+          <a:lnRef idx="1">
+            <a:schemeClr val="accent1"/>
+          </a:lnRef>
+          <a:fillRef idx="3">
+            <a:schemeClr val="accent1"/>
+          </a:fillRef>
+          <a:effectRef idx="2">
+            <a:schemeClr val="accent1"/>
+          </a:effectRef>
+          <a:fontRef idx="minor">
+            <a:schemeClr val="lt1"/>
+          </a:fontRef>
+        </p:style>
+        <p:txBody>
+          <a:bodyPr rtlCol="0" anchor="ctr" wrap="square" lIns="50800" rIns="50800" tIns="25400" bIns="25400"/>
+          <a:lstStyle/>
+          <a:p>
+            <a:pPr algn="ctr"/>
+            <a:r>
+              <a:rPr sz="1200" b="1">
+                <a:solidFill>
+                  <a:srgbClr val="FFFFFF"/>
+                </a:solidFill>
+                <a:latin typeface="Meiryo"/>
+              </a:rPr>
+              <a:t>BEC vs 今回のKill Chain</a:t>
+            </a:r>
+          </a:p>
+        </p:txBody>
+      </p:sp>
+      <p:sp>
+        <p:nvSpPr>
+          <p:cNvPr id="5" name="Rectangle 4"/>
+          <p:cNvSpPr/>
+          <p:nvPr/>
+        </p:nvSpPr>
+        <p:spPr>
+          <a:xfrm>
+            <a:off x="731520" y="1463040"/>
+            <a:ext cx="3200400" cy="365760"/>
+          </a:xfrm>
+          <a:prstGeom prst="rect">
+            <a:avLst/>
+          </a:prstGeom>
+          <a:solidFill>
+            <a:srgbClr val="34495E"/>
+          </a:solidFill>
+          <a:ln>
+            <a:noFill/>
+          </a:ln>
+        </p:spPr>
+        <p:style>
+          <a:lnRef idx="1">
+            <a:schemeClr val="accent1"/>
+          </a:lnRef>
+          <a:fillRef idx="3">
+            <a:schemeClr val="accent1"/>
+          </a:fillRef>
+          <a:effectRef idx="2">
+            <a:schemeClr val="accent1"/>
+          </a:effectRef>
+          <a:fontRef idx="minor">
+            <a:schemeClr val="lt1"/>
+          </a:fontRef>
+        </p:style>
+        <p:txBody>
+          <a:bodyPr rtlCol="0" anchor="ctr" wrap="square" lIns="50800" rIns="50800" tIns="25400" bIns="25400"/>
+          <a:lstStyle/>
+          <a:p>
+            <a:pPr algn="ctr"/>
+            <a:r>
+              <a:rPr sz="1000" b="1">
+                <a:solidFill>
+                  <a:srgbClr val="FFFFFF"/>
+                </a:solidFill>
+                <a:latin typeface="Meiryo"/>
+              </a:rPr>
+              <a:t>判定軸</a:t>
+            </a:r>
+          </a:p>
+        </p:txBody>
+      </p:sp>
+      <p:sp>
+        <p:nvSpPr>
+          <p:cNvPr id="6" name="Rectangle 5"/>
+          <p:cNvSpPr/>
+          <p:nvPr/>
+        </p:nvSpPr>
+        <p:spPr>
+          <a:xfrm>
+            <a:off x="3931920" y="1463040"/>
+            <a:ext cx="5212080" cy="365760"/>
+          </a:xfrm>
+          <a:prstGeom prst="rect">
+            <a:avLst/>
+          </a:prstGeom>
+          <a:solidFill>
+            <a:srgbClr val="34495E"/>
+          </a:solidFill>
+          <a:ln>
+            <a:noFill/>
+          </a:ln>
+        </p:spPr>
+        <p:style>
+          <a:lnRef idx="1">
+            <a:schemeClr val="accent1"/>
+          </a:lnRef>
+          <a:fillRef idx="3">
+            <a:schemeClr val="accent1"/>
+          </a:fillRef>
+          <a:effectRef idx="2">
+            <a:schemeClr val="accent1"/>
+          </a:effectRef>
+          <a:fontRef idx="minor">
+            <a:schemeClr val="lt1"/>
+          </a:fontRef>
+        </p:style>
+        <p:txBody>
+          <a:bodyPr rtlCol="0" anchor="ctr" wrap="square" lIns="50800" rIns="50800" tIns="25400" bIns="25400"/>
+          <a:lstStyle/>
+          <a:p>
+            <a:pPr algn="ctr"/>
+            <a:r>
+              <a:rPr sz="1000" b="1">
+                <a:solidFill>
+                  <a:srgbClr val="FFFFFF"/>
+                </a:solidFill>
+                <a:latin typeface="Meiryo"/>
+              </a:rPr>
+              <a:t>BEC（従来）</a:t>
+            </a:r>
+          </a:p>
+        </p:txBody>
+      </p:sp>
+      <p:sp>
+        <p:nvSpPr>
+          <p:cNvPr id="7" name="Rectangle 6"/>
+          <p:cNvSpPr/>
+          <p:nvPr/>
+        </p:nvSpPr>
+        <p:spPr>
+          <a:xfrm>
+            <a:off x="9144000" y="1463040"/>
+            <a:ext cx="5212080" cy="365760"/>
+          </a:xfrm>
+          <a:prstGeom prst="rect">
+            <a:avLst/>
+          </a:prstGeom>
+          <a:solidFill>
+            <a:srgbClr val="34495E"/>
+          </a:solidFill>
+          <a:ln>
+            <a:noFill/>
+          </a:ln>
+        </p:spPr>
+        <p:style>
+          <a:lnRef idx="1">
+            <a:schemeClr val="accent1"/>
+          </a:lnRef>
+          <a:fillRef idx="3">
+            <a:schemeClr val="accent1"/>
+          </a:fillRef>
+          <a:effectRef idx="2">
+            <a:schemeClr val="accent1"/>
+          </a:effectRef>
+          <a:fontRef idx="minor">
+            <a:schemeClr val="lt1"/>
+          </a:fontRef>
+        </p:style>
+        <p:txBody>
+          <a:bodyPr rtlCol="0" anchor="ctr" wrap="square" lIns="50800" rIns="50800" tIns="25400" bIns="25400"/>
+          <a:lstStyle/>
+          <a:p>
+            <a:pPr algn="ctr"/>
+            <a:r>
+              <a:rPr sz="1000" b="1">
+                <a:solidFill>
+                  <a:srgbClr val="FFFFFF"/>
+                </a:solidFill>
+                <a:latin typeface="Meiryo"/>
+              </a:rPr>
+              <a:t>今回のKill Chain</a:t>
+            </a:r>
+          </a:p>
+        </p:txBody>
+      </p:sp>
+      <p:sp>
+        <p:nvSpPr>
+          <p:cNvPr id="8" name="Rectangle 7"/>
+          <p:cNvSpPr/>
+          <p:nvPr/>
+        </p:nvSpPr>
+        <p:spPr>
+          <a:xfrm>
+            <a:off x="731520" y="1828800"/>
+            <a:ext cx="3200400" cy="411480"/>
+          </a:xfrm>
+          <a:prstGeom prst="rect">
+            <a:avLst/>
+          </a:prstGeom>
+          <a:solidFill>
+            <a:srgbClr val="FFFFFF"/>
+          </a:solidFill>
+          <a:ln w="25400">
+            <a:solidFill>
+              <a:srgbClr val="CCCCCC"/>
+            </a:solidFill>
+          </a:ln>
+        </p:spPr>
+        <p:style>
+          <a:lnRef idx="1">
+            <a:schemeClr val="accent1"/>
+          </a:lnRef>
+          <a:fillRef idx="3">
+            <a:schemeClr val="accent1"/>
+          </a:fillRef>
+          <a:effectRef idx="2">
+            <a:schemeClr val="accent1"/>
+          </a:effectRef>
+          <a:fontRef idx="minor">
+            <a:schemeClr val="lt1"/>
+          </a:fontRef>
+        </p:style>
+        <p:txBody>
+          <a:bodyPr rtlCol="0" anchor="ctr" wrap="square" lIns="63500" rIns="50800" tIns="38100" bIns="38100"/>
+          <a:lstStyle/>
+          <a:p>
+            <a:pPr algn="l"/>
+            <a:r>
+              <a:rPr sz="900" b="1">
+                <a:solidFill>
+                  <a:srgbClr val="222222"/>
+                </a:solidFill>
+                <a:latin typeface="Meiryo"/>
+              </a:rPr>
+              <a:t>起点</a:t>
+            </a:r>
+          </a:p>
+        </p:txBody>
+      </p:sp>
+      <p:sp>
+        <p:nvSpPr>
+          <p:cNvPr id="9" name="Rectangle 8"/>
+          <p:cNvSpPr/>
+          <p:nvPr/>
+        </p:nvSpPr>
+        <p:spPr>
+          <a:xfrm>
+            <a:off x="3931920" y="1828800"/>
+            <a:ext cx="5212080" cy="411480"/>
+          </a:xfrm>
+          <a:prstGeom prst="rect">
+            <a:avLst/>
+          </a:prstGeom>
+          <a:solidFill>
+            <a:srgbClr val="FFFFFF"/>
+          </a:solidFill>
+          <a:ln w="25400">
+            <a:solidFill>
+              <a:srgbClr val="CCCCCC"/>
+            </a:solidFill>
+          </a:ln>
+        </p:spPr>
+        <p:style>
+          <a:lnRef idx="1">
+            <a:schemeClr val="accent1"/>
+          </a:lnRef>
+          <a:fillRef idx="3">
+            <a:schemeClr val="accent1"/>
+          </a:fillRef>
+          <a:effectRef idx="2">
+            <a:schemeClr val="accent1"/>
+          </a:effectRef>
+          <a:fontRef idx="minor">
+            <a:schemeClr val="lt1"/>
+          </a:fontRef>
+        </p:style>
+        <p:txBody>
+          <a:bodyPr rtlCol="0" anchor="ctr" wrap="square" lIns="63500" rIns="50800" tIns="38100" bIns="38100"/>
+          <a:lstStyle/>
+          <a:p>
+            <a:pPr algn="l"/>
+            <a:r>
+              <a:rPr sz="900" b="0">
+                <a:solidFill>
+                  <a:srgbClr val="222222"/>
+                </a:solidFill>
+                <a:latin typeface="Meiryo"/>
+              </a:rPr>
+              <a:t>メールの侵害・なりすまし（必須）</a:t>
+            </a:r>
+          </a:p>
+        </p:txBody>
+      </p:sp>
+      <p:sp>
+        <p:nvSpPr>
+          <p:cNvPr id="10" name="Rectangle 9"/>
+          <p:cNvSpPr/>
+          <p:nvPr/>
+        </p:nvSpPr>
+        <p:spPr>
+          <a:xfrm>
+            <a:off x="9144000" y="1828800"/>
+            <a:ext cx="5212080" cy="411480"/>
+          </a:xfrm>
+          <a:prstGeom prst="rect">
+            <a:avLst/>
+          </a:prstGeom>
+          <a:solidFill>
+            <a:srgbClr val="FFFFFF"/>
+          </a:solidFill>
+          <a:ln w="25400">
+            <a:solidFill>
+              <a:srgbClr val="C0392B"/>
+            </a:solidFill>
+          </a:ln>
+        </p:spPr>
+        <p:style>
+          <a:lnRef idx="1">
+            <a:schemeClr val="accent1"/>
+          </a:lnRef>
+          <a:fillRef idx="3">
+            <a:schemeClr val="accent1"/>
+          </a:fillRef>
+          <a:effectRef idx="2">
+            <a:schemeClr val="accent1"/>
+          </a:effectRef>
+          <a:fontRef idx="minor">
+            <a:schemeClr val="lt1"/>
+          </a:fontRef>
+        </p:style>
+        <p:txBody>
+          <a:bodyPr rtlCol="0" anchor="ctr" wrap="square" lIns="63500" rIns="50800" tIns="38100" bIns="38100"/>
+          <a:lstStyle/>
+          <a:p>
+            <a:pPr algn="l"/>
+            <a:r>
+              <a:rPr sz="900" b="1">
+                <a:solidFill>
+                  <a:srgbClr val="C0392B"/>
+                </a:solidFill>
+                <a:latin typeface="Meiryo"/>
+              </a:rPr>
+              <a:t>電話（自動音声の架電）</a:t>
+            </a:r>
+          </a:p>
+        </p:txBody>
+      </p:sp>
+      <p:sp>
+        <p:nvSpPr>
+          <p:cNvPr id="11" name="Rectangle 10"/>
+          <p:cNvSpPr/>
+          <p:nvPr/>
+        </p:nvSpPr>
+        <p:spPr>
+          <a:xfrm>
+            <a:off x="731520" y="2240280"/>
+            <a:ext cx="3200400" cy="411480"/>
+          </a:xfrm>
+          <a:prstGeom prst="rect">
+            <a:avLst/>
+          </a:prstGeom>
+          <a:solidFill>
+            <a:srgbClr val="F9F9F9"/>
+          </a:solidFill>
+          <a:ln w="25400">
+            <a:solidFill>
+              <a:srgbClr val="CCCCCC"/>
+            </a:solidFill>
+          </a:ln>
+        </p:spPr>
+        <p:style>
+          <a:lnRef idx="1">
+            <a:schemeClr val="accent1"/>
+          </a:lnRef>
+          <a:fillRef idx="3">
+            <a:schemeClr val="accent1"/>
+          </a:fillRef>
+          <a:effectRef idx="2">
+            <a:schemeClr val="accent1"/>
+          </a:effectRef>
+          <a:fontRef idx="minor">
+            <a:schemeClr val="lt1"/>
+          </a:fontRef>
+        </p:style>
+        <p:txBody>
+          <a:bodyPr rtlCol="0" anchor="ctr" wrap="square" lIns="63500" rIns="50800" tIns="38100" bIns="38100"/>
+          <a:lstStyle/>
+          <a:p>
+            <a:pPr algn="l"/>
+            <a:r>
+              <a:rPr sz="900" b="1">
+                <a:solidFill>
+                  <a:srgbClr val="222222"/>
+                </a:solidFill>
+                <a:latin typeface="Meiryo"/>
+              </a:rPr>
+              <a:t>主な手段</a:t>
+            </a:r>
+          </a:p>
+        </p:txBody>
+      </p:sp>
+      <p:sp>
+        <p:nvSpPr>
+          <p:cNvPr id="12" name="Rectangle 11"/>
+          <p:cNvSpPr/>
+          <p:nvPr/>
+        </p:nvSpPr>
+        <p:spPr>
+          <a:xfrm>
+            <a:off x="3931920" y="2240280"/>
+            <a:ext cx="5212080" cy="411480"/>
+          </a:xfrm>
+          <a:prstGeom prst="rect">
+            <a:avLst/>
+          </a:prstGeom>
+          <a:solidFill>
+            <a:srgbClr val="F9F9F9"/>
+          </a:solidFill>
+          <a:ln w="25400">
+            <a:solidFill>
+              <a:srgbClr val="CCCCCC"/>
+            </a:solidFill>
+          </a:ln>
+        </p:spPr>
+        <p:style>
+          <a:lnRef idx="1">
+            <a:schemeClr val="accent1"/>
+          </a:lnRef>
+          <a:fillRef idx="3">
+            <a:schemeClr val="accent1"/>
+          </a:fillRef>
+          <a:effectRef idx="2">
+            <a:schemeClr val="accent1"/>
+          </a:effectRef>
+          <a:fontRef idx="minor">
+            <a:schemeClr val="lt1"/>
+          </a:fontRef>
+        </p:style>
+        <p:txBody>
+          <a:bodyPr rtlCol="0" anchor="ctr" wrap="square" lIns="63500" rIns="50800" tIns="38100" bIns="38100"/>
+          <a:lstStyle/>
+          <a:p>
+            <a:pPr algn="l"/>
+            <a:r>
+              <a:rPr sz="900" b="0">
+                <a:solidFill>
+                  <a:srgbClr val="222222"/>
+                </a:solidFill>
+                <a:latin typeface="Meiryo"/>
+              </a:rPr>
+              <a:t>偽の送金指示メール</a:t>
+            </a:r>
+          </a:p>
+        </p:txBody>
+      </p:sp>
+      <p:sp>
+        <p:nvSpPr>
+          <p:cNvPr id="13" name="Rectangle 12"/>
+          <p:cNvSpPr/>
+          <p:nvPr/>
+        </p:nvSpPr>
+        <p:spPr>
+          <a:xfrm>
+            <a:off x="9144000" y="2240280"/>
+            <a:ext cx="5212080" cy="411480"/>
+          </a:xfrm>
+          <a:prstGeom prst="rect">
+            <a:avLst/>
+          </a:prstGeom>
+          <a:solidFill>
+            <a:srgbClr val="F9F9F9"/>
+          </a:solidFill>
+          <a:ln w="25400">
+            <a:solidFill>
+              <a:srgbClr val="C0392B"/>
+            </a:solidFill>
+          </a:ln>
+        </p:spPr>
+        <p:style>
+          <a:lnRef idx="1">
+            <a:schemeClr val="accent1"/>
+          </a:lnRef>
+          <a:fillRef idx="3">
+            <a:schemeClr val="accent1"/>
+          </a:fillRef>
+          <a:effectRef idx="2">
+            <a:schemeClr val="accent1"/>
+          </a:effectRef>
+          <a:fontRef idx="minor">
+            <a:schemeClr val="lt1"/>
+          </a:fontRef>
+        </p:style>
+        <p:txBody>
+          <a:bodyPr rtlCol="0" anchor="ctr" wrap="square" lIns="63500" rIns="50800" tIns="38100" bIns="38100"/>
+          <a:lstStyle/>
+          <a:p>
+            <a:pPr algn="l"/>
+            <a:r>
+              <a:rPr sz="900" b="1">
+                <a:solidFill>
+                  <a:srgbClr val="C0392B"/>
+                </a:solidFill>
+                <a:latin typeface="Meiryo"/>
+              </a:rPr>
+              <a:t>偽サイト＋リモート操作（ScreenConnect）</a:t>
+            </a:r>
+          </a:p>
+        </p:txBody>
+      </p:sp>
+      <p:sp>
+        <p:nvSpPr>
+          <p:cNvPr id="14" name="Rectangle 13"/>
+          <p:cNvSpPr/>
+          <p:nvPr/>
+        </p:nvSpPr>
+        <p:spPr>
+          <a:xfrm>
+            <a:off x="731520" y="2651760"/>
+            <a:ext cx="3200400" cy="411480"/>
+          </a:xfrm>
+          <a:prstGeom prst="rect">
+            <a:avLst/>
+          </a:prstGeom>
+          <a:solidFill>
+            <a:srgbClr val="FFFFFF"/>
+          </a:solidFill>
+          <a:ln w="25400">
+            <a:solidFill>
+              <a:srgbClr val="CCCCCC"/>
+            </a:solidFill>
+          </a:ln>
+        </p:spPr>
+        <p:style>
+          <a:lnRef idx="1">
+            <a:schemeClr val="accent1"/>
+          </a:lnRef>
+          <a:fillRef idx="3">
+            <a:schemeClr val="accent1"/>
+          </a:fillRef>
+          <a:effectRef idx="2">
+            <a:schemeClr val="accent1"/>
+          </a:effectRef>
+          <a:fontRef idx="minor">
+            <a:schemeClr val="lt1"/>
+          </a:fontRef>
+        </p:style>
+        <p:txBody>
+          <a:bodyPr rtlCol="0" anchor="ctr" wrap="square" lIns="63500" rIns="50800" tIns="38100" bIns="38100"/>
+          <a:lstStyle/>
+          <a:p>
+            <a:pPr algn="l"/>
+            <a:r>
+              <a:rPr sz="900" b="1">
+                <a:solidFill>
+                  <a:srgbClr val="222222"/>
+                </a:solidFill>
+                <a:latin typeface="Meiryo"/>
+              </a:rPr>
+              <a:t>誰が送金するか</a:t>
+            </a:r>
+          </a:p>
+        </p:txBody>
+      </p:sp>
+      <p:sp>
+        <p:nvSpPr>
+          <p:cNvPr id="15" name="Rectangle 14"/>
+          <p:cNvSpPr/>
+          <p:nvPr/>
+        </p:nvSpPr>
+        <p:spPr>
+          <a:xfrm>
+            <a:off x="3931920" y="2651760"/>
+            <a:ext cx="5212080" cy="411480"/>
+          </a:xfrm>
+          <a:prstGeom prst="rect">
+            <a:avLst/>
+          </a:prstGeom>
+          <a:solidFill>
+            <a:srgbClr val="FFFFFF"/>
+          </a:solidFill>
+          <a:ln w="25400">
+            <a:solidFill>
+              <a:srgbClr val="CCCCCC"/>
+            </a:solidFill>
+          </a:ln>
+        </p:spPr>
+        <p:style>
+          <a:lnRef idx="1">
+            <a:schemeClr val="accent1"/>
+          </a:lnRef>
+          <a:fillRef idx="3">
+            <a:schemeClr val="accent1"/>
+          </a:fillRef>
+          <a:effectRef idx="2">
+            <a:schemeClr val="accent1"/>
+          </a:effectRef>
+          <a:fontRef idx="minor">
+            <a:schemeClr val="lt1"/>
+          </a:fontRef>
+        </p:style>
+        <p:txBody>
+          <a:bodyPr rtlCol="0" anchor="ctr" wrap="square" lIns="63500" rIns="50800" tIns="38100" bIns="38100"/>
+          <a:lstStyle/>
+          <a:p>
+            <a:pPr algn="l"/>
+            <a:r>
+              <a:rPr sz="900" b="0">
+                <a:solidFill>
+                  <a:srgbClr val="222222"/>
+                </a:solidFill>
+                <a:latin typeface="Meiryo"/>
+              </a:rPr>
+              <a:t>被害者自身が騙されて送金</a:t>
+            </a:r>
+          </a:p>
+        </p:txBody>
+      </p:sp>
+      <p:sp>
+        <p:nvSpPr>
+          <p:cNvPr id="16" name="Rectangle 15"/>
+          <p:cNvSpPr/>
+          <p:nvPr/>
+        </p:nvSpPr>
+        <p:spPr>
+          <a:xfrm>
+            <a:off x="9144000" y="2651760"/>
+            <a:ext cx="5212080" cy="411480"/>
+          </a:xfrm>
+          <a:prstGeom prst="rect">
+            <a:avLst/>
+          </a:prstGeom>
+          <a:solidFill>
+            <a:srgbClr val="FFFFFF"/>
+          </a:solidFill>
+          <a:ln w="25400">
+            <a:solidFill>
+              <a:srgbClr val="C0392B"/>
+            </a:solidFill>
+          </a:ln>
+        </p:spPr>
+        <p:style>
+          <a:lnRef idx="1">
+            <a:schemeClr val="accent1"/>
+          </a:lnRef>
+          <a:fillRef idx="3">
+            <a:schemeClr val="accent1"/>
+          </a:fillRef>
+          <a:effectRef idx="2">
+            <a:schemeClr val="accent1"/>
+          </a:effectRef>
+          <a:fontRef idx="minor">
+            <a:schemeClr val="lt1"/>
+          </a:fontRef>
+        </p:style>
+        <p:txBody>
+          <a:bodyPr rtlCol="0" anchor="ctr" wrap="square" lIns="63500" rIns="50800" tIns="38100" bIns="38100"/>
+          <a:lstStyle/>
+          <a:p>
+            <a:pPr algn="l"/>
+            <a:r>
+              <a:rPr sz="900" b="1">
+                <a:solidFill>
+                  <a:srgbClr val="C0392B"/>
+                </a:solidFill>
+                <a:latin typeface="Meiryo"/>
+              </a:rPr>
+              <a:t>犯人が遠隔操作で送金</a:t>
+            </a:r>
+          </a:p>
+        </p:txBody>
+      </p:sp>
+      <p:sp>
+        <p:nvSpPr>
+          <p:cNvPr id="17" name="Rectangle 16"/>
+          <p:cNvSpPr/>
+          <p:nvPr/>
+        </p:nvSpPr>
+        <p:spPr>
+          <a:xfrm>
+            <a:off x="731520" y="3063240"/>
+            <a:ext cx="3200400" cy="411480"/>
+          </a:xfrm>
+          <a:prstGeom prst="rect">
+            <a:avLst/>
+          </a:prstGeom>
+          <a:solidFill>
+            <a:srgbClr val="F9F9F9"/>
+          </a:solidFill>
+          <a:ln w="25400">
+            <a:solidFill>
+              <a:srgbClr val="CCCCCC"/>
+            </a:solidFill>
+          </a:ln>
+        </p:spPr>
+        <p:style>
+          <a:lnRef idx="1">
+            <a:schemeClr val="accent1"/>
+          </a:lnRef>
+          <a:fillRef idx="3">
+            <a:schemeClr val="accent1"/>
+          </a:fillRef>
+          <a:effectRef idx="2">
+            <a:schemeClr val="accent1"/>
+          </a:effectRef>
+          <a:fontRef idx="minor">
+            <a:schemeClr val="lt1"/>
+          </a:fontRef>
+        </p:style>
+        <p:txBody>
+          <a:bodyPr rtlCol="0" anchor="ctr" wrap="square" lIns="63500" rIns="50800" tIns="38100" bIns="38100"/>
+          <a:lstStyle/>
+          <a:p>
+            <a:pPr algn="l"/>
+            <a:r>
+              <a:rPr sz="900" b="1">
+                <a:solidFill>
+                  <a:srgbClr val="222222"/>
+                </a:solidFill>
+                <a:latin typeface="Meiryo"/>
+              </a:rPr>
+              <a:t>認証情報</a:t>
+            </a:r>
+          </a:p>
+        </p:txBody>
+      </p:sp>
+      <p:sp>
+        <p:nvSpPr>
+          <p:cNvPr id="18" name="Rectangle 17"/>
+          <p:cNvSpPr/>
+          <p:nvPr/>
+        </p:nvSpPr>
+        <p:spPr>
+          <a:xfrm>
+            <a:off x="3931920" y="3063240"/>
+            <a:ext cx="5212080" cy="411480"/>
+          </a:xfrm>
+          <a:prstGeom prst="rect">
+            <a:avLst/>
+          </a:prstGeom>
+          <a:solidFill>
+            <a:srgbClr val="F9F9F9"/>
+          </a:solidFill>
+          <a:ln w="25400">
+            <a:solidFill>
+              <a:srgbClr val="CCCCCC"/>
+            </a:solidFill>
+          </a:ln>
+        </p:spPr>
+        <p:style>
+          <a:lnRef idx="1">
+            <a:schemeClr val="accent1"/>
+          </a:lnRef>
+          <a:fillRef idx="3">
+            <a:schemeClr val="accent1"/>
+          </a:fillRef>
+          <a:effectRef idx="2">
+            <a:schemeClr val="accent1"/>
+          </a:effectRef>
+          <a:fontRef idx="minor">
+            <a:schemeClr val="lt1"/>
+          </a:fontRef>
+        </p:style>
+        <p:txBody>
+          <a:bodyPr rtlCol="0" anchor="ctr" wrap="square" lIns="63500" rIns="50800" tIns="38100" bIns="38100"/>
+          <a:lstStyle/>
+          <a:p>
+            <a:pPr algn="l"/>
+            <a:r>
+              <a:rPr sz="900" b="0">
+                <a:solidFill>
+                  <a:srgbClr val="222222"/>
+                </a:solidFill>
+                <a:latin typeface="Meiryo"/>
+              </a:rPr>
+              <a:t>盗まない（送金を指示するだけ）</a:t>
+            </a:r>
+          </a:p>
+        </p:txBody>
+      </p:sp>
+      <p:sp>
+        <p:nvSpPr>
+          <p:cNvPr id="19" name="Rectangle 18"/>
+          <p:cNvSpPr/>
+          <p:nvPr/>
+        </p:nvSpPr>
+        <p:spPr>
+          <a:xfrm>
+            <a:off x="9144000" y="3063240"/>
+            <a:ext cx="5212080" cy="411480"/>
+          </a:xfrm>
+          <a:prstGeom prst="rect">
+            <a:avLst/>
+          </a:prstGeom>
+          <a:solidFill>
+            <a:srgbClr val="F9F9F9"/>
+          </a:solidFill>
+          <a:ln w="25400">
+            <a:solidFill>
+              <a:srgbClr val="C0392B"/>
+            </a:solidFill>
+          </a:ln>
+        </p:spPr>
+        <p:style>
+          <a:lnRef idx="1">
+            <a:schemeClr val="accent1"/>
+          </a:lnRef>
+          <a:fillRef idx="3">
+            <a:schemeClr val="accent1"/>
+          </a:fillRef>
+          <a:effectRef idx="2">
+            <a:schemeClr val="accent1"/>
+          </a:effectRef>
+          <a:fontRef idx="minor">
+            <a:schemeClr val="lt1"/>
+          </a:fontRef>
+        </p:style>
+        <p:txBody>
+          <a:bodyPr rtlCol="0" anchor="ctr" wrap="square" lIns="63500" rIns="50800" tIns="38100" bIns="38100"/>
+          <a:lstStyle/>
+          <a:p>
+            <a:pPr algn="l"/>
+            <a:r>
+              <a:rPr sz="900" b="1">
+                <a:solidFill>
+                  <a:srgbClr val="C0392B"/>
+                </a:solidFill>
+                <a:latin typeface="Meiryo"/>
+              </a:rPr>
+              <a:t>全認証情報を窃取</a:t>
+            </a:r>
+          </a:p>
+        </p:txBody>
+      </p:sp>
+      <p:sp>
+        <p:nvSpPr>
+          <p:cNvPr id="20" name="Rectangle 19"/>
+          <p:cNvSpPr/>
+          <p:nvPr/>
+        </p:nvSpPr>
+        <p:spPr>
+          <a:xfrm>
+            <a:off x="731520" y="3474720"/>
+            <a:ext cx="3200400" cy="411480"/>
+          </a:xfrm>
+          <a:prstGeom prst="rect">
+            <a:avLst/>
+          </a:prstGeom>
+          <a:solidFill>
+            <a:srgbClr val="FFFFFF"/>
+          </a:solidFill>
+          <a:ln w="25400">
+            <a:solidFill>
+              <a:srgbClr val="CCCCCC"/>
+            </a:solidFill>
+          </a:ln>
+        </p:spPr>
+        <p:style>
+          <a:lnRef idx="1">
+            <a:schemeClr val="accent1"/>
+          </a:lnRef>
+          <a:fillRef idx="3">
+            <a:schemeClr val="accent1"/>
+          </a:fillRef>
+          <a:effectRef idx="2">
+            <a:schemeClr val="accent1"/>
+          </a:effectRef>
+          <a:fontRef idx="minor">
+            <a:schemeClr val="lt1"/>
+          </a:fontRef>
+        </p:style>
+        <p:txBody>
+          <a:bodyPr rtlCol="0" anchor="ctr" wrap="square" lIns="63500" rIns="50800" tIns="38100" bIns="38100"/>
+          <a:lstStyle/>
+          <a:p>
+            <a:pPr algn="l"/>
+            <a:r>
+              <a:rPr sz="900" b="1">
+                <a:solidFill>
+                  <a:srgbClr val="222222"/>
+                </a:solidFill>
+                <a:latin typeface="Meiryo"/>
+              </a:rPr>
+              <a:t>なりすまし対象</a:t>
+            </a:r>
+          </a:p>
+        </p:txBody>
+      </p:sp>
+      <p:sp>
+        <p:nvSpPr>
+          <p:cNvPr id="21" name="Rectangle 20"/>
+          <p:cNvSpPr/>
+          <p:nvPr/>
+        </p:nvSpPr>
+        <p:spPr>
+          <a:xfrm>
+            <a:off x="3931920" y="3474720"/>
+            <a:ext cx="5212080" cy="411480"/>
+          </a:xfrm>
+          <a:prstGeom prst="rect">
+            <a:avLst/>
+          </a:prstGeom>
+          <a:solidFill>
+            <a:srgbClr val="FFFFFF"/>
+          </a:solidFill>
+          <a:ln w="25400">
+            <a:solidFill>
+              <a:srgbClr val="CCCCCC"/>
+            </a:solidFill>
+          </a:ln>
+        </p:spPr>
+        <p:style>
+          <a:lnRef idx="1">
+            <a:schemeClr val="accent1"/>
+          </a:lnRef>
+          <a:fillRef idx="3">
+            <a:schemeClr val="accent1"/>
+          </a:fillRef>
+          <a:effectRef idx="2">
+            <a:schemeClr val="accent1"/>
+          </a:effectRef>
+          <a:fontRef idx="minor">
+            <a:schemeClr val="lt1"/>
+          </a:fontRef>
+        </p:style>
+        <p:txBody>
+          <a:bodyPr rtlCol="0" anchor="ctr" wrap="square" lIns="63500" rIns="50800" tIns="38100" bIns="38100"/>
+          <a:lstStyle/>
+          <a:p>
+            <a:pPr algn="l"/>
+            <a:r>
+              <a:rPr sz="900" b="0">
+                <a:solidFill>
+                  <a:srgbClr val="222222"/>
+                </a:solidFill>
+                <a:latin typeface="Meiryo"/>
+              </a:rPr>
+              <a:t>経営者・取引先</a:t>
+            </a:r>
+          </a:p>
+        </p:txBody>
+      </p:sp>
+      <p:sp>
+        <p:nvSpPr>
+          <p:cNvPr id="22" name="Rectangle 21"/>
+          <p:cNvSpPr/>
+          <p:nvPr/>
+        </p:nvSpPr>
+        <p:spPr>
+          <a:xfrm>
+            <a:off x="9144000" y="3474720"/>
+            <a:ext cx="5212080" cy="411480"/>
+          </a:xfrm>
+          <a:prstGeom prst="rect">
+            <a:avLst/>
+          </a:prstGeom>
+          <a:solidFill>
+            <a:srgbClr val="FFFFFF"/>
+          </a:solidFill>
+          <a:ln w="25400">
+            <a:solidFill>
+              <a:srgbClr val="C0392B"/>
+            </a:solidFill>
+          </a:ln>
+        </p:spPr>
+        <p:style>
+          <a:lnRef idx="1">
+            <a:schemeClr val="accent1"/>
+          </a:lnRef>
+          <a:fillRef idx="3">
+            <a:schemeClr val="accent1"/>
+          </a:fillRef>
+          <a:effectRef idx="2">
+            <a:schemeClr val="accent1"/>
+          </a:effectRef>
+          <a:fontRef idx="minor">
+            <a:schemeClr val="lt1"/>
+          </a:fontRef>
+        </p:style>
+        <p:txBody>
+          <a:bodyPr rtlCol="0" anchor="ctr" wrap="square" lIns="63500" rIns="50800" tIns="38100" bIns="38100"/>
+          <a:lstStyle/>
+          <a:p>
+            <a:pPr algn="l"/>
+            <a:r>
+              <a:rPr sz="900" b="1">
+                <a:solidFill>
+                  <a:srgbClr val="C0392B"/>
+                </a:solidFill>
+                <a:latin typeface="Meiryo"/>
+              </a:rPr>
+              <a:t>銀行</a:t>
+            </a:r>
+          </a:p>
+        </p:txBody>
+      </p:sp>
+      <p:sp>
+        <p:nvSpPr>
+          <p:cNvPr id="23" name="Rectangle 22"/>
+          <p:cNvSpPr/>
+          <p:nvPr/>
+        </p:nvSpPr>
+        <p:spPr>
+          <a:xfrm>
+            <a:off x="731520" y="4023360"/>
+            <a:ext cx="13624560" cy="365760"/>
+          </a:xfrm>
+          <a:prstGeom prst="rect">
+            <a:avLst/>
+          </a:prstGeom>
+          <a:solidFill>
+            <a:srgbClr val="222222"/>
+          </a:solidFill>
+          <a:ln>
+            <a:noFill/>
+          </a:ln>
+        </p:spPr>
+        <p:style>
+          <a:lnRef idx="1">
+            <a:schemeClr val="accent1"/>
+          </a:lnRef>
+          <a:fillRef idx="3">
+            <a:schemeClr val="accent1"/>
+          </a:fillRef>
+          <a:effectRef idx="2">
+            <a:schemeClr val="accent1"/>
+          </a:effectRef>
+          <a:fontRef idx="minor">
+            <a:schemeClr val="lt1"/>
+          </a:fontRef>
+        </p:style>
+        <p:txBody>
+          <a:bodyPr rtlCol="0" anchor="ctr" wrap="square" lIns="50800" rIns="50800" tIns="25400" bIns="25400"/>
+          <a:lstStyle/>
+          <a:p>
+            <a:pPr algn="ctr"/>
+            <a:r>
+              <a:rPr sz="1200" b="1">
+                <a:solidFill>
+                  <a:srgbClr val="FFFFFF"/>
+                </a:solidFill>
+                <a:latin typeface="Meiryo"/>
+              </a:rPr>
+              <a:t>今回の攻撃の正しい分類</a:t>
+            </a:r>
+          </a:p>
+        </p:txBody>
+      </p:sp>
+      <p:sp>
+        <p:nvSpPr>
+          <p:cNvPr id="24" name="Rectangle 23"/>
+          <p:cNvSpPr/>
+          <p:nvPr/>
+        </p:nvSpPr>
+        <p:spPr>
+          <a:xfrm>
+            <a:off x="731520" y="4434840"/>
+            <a:ext cx="13624560" cy="548640"/>
+          </a:xfrm>
+          <a:prstGeom prst="rect">
+            <a:avLst/>
+          </a:prstGeom>
+          <a:solidFill>
+            <a:srgbClr val="FFFFFF"/>
+          </a:solidFill>
+          <a:ln w="25400">
+            <a:solidFill>
+              <a:srgbClr val="CCCCCC"/>
+            </a:solidFill>
+          </a:ln>
+        </p:spPr>
+        <p:style>
+          <a:lnRef idx="1">
+            <a:schemeClr val="accent1"/>
+          </a:lnRef>
+          <a:fillRef idx="3">
+            <a:schemeClr val="accent1"/>
+          </a:fillRef>
+          <a:effectRef idx="2">
+            <a:schemeClr val="accent1"/>
+          </a:effectRef>
+          <a:fontRef idx="minor">
+            <a:schemeClr val="lt1"/>
+          </a:fontRef>
+        </p:style>
+        <p:txBody>
+          <a:bodyPr rtlCol="0" anchor="ctr" wrap="square" lIns="63500" rIns="50800" tIns="38100" bIns="38100"/>
+          <a:lstStyle/>
+          <a:p>
+            <a:pPr algn="l"/>
+            <a:r>
+              <a:rPr sz="1000" b="0">
+                <a:solidFill>
+                  <a:srgbClr val="222222"/>
+                </a:solidFill>
+                <a:latin typeface="Meiryo"/>
+              </a:rPr>
+              <a:t>「Vishing（ボイスフィッシング）」＋「RAT（リモートアクセスツール）悪用」＋「リアルタイムフィッシング（認証情報窃取）」の複合攻撃
+近い概念：Tech Support Scam（テクサポ詐欺）/ Bank Helpdesk Fraud / ATO（口座乗っ取り）</a:t>
+            </a:r>
+          </a:p>
+        </p:txBody>
+      </p:sp>
+      <p:sp>
+        <p:nvSpPr>
+          <p:cNvPr id="25" name="Rectangle 24"/>
+          <p:cNvSpPr/>
+          <p:nvPr/>
+        </p:nvSpPr>
+        <p:spPr>
+          <a:xfrm>
+            <a:off x="731520" y="5074920"/>
+            <a:ext cx="13624560" cy="457200"/>
+          </a:xfrm>
+          <a:prstGeom prst="rect">
+            <a:avLst/>
+          </a:prstGeom>
+          <a:solidFill>
+            <a:srgbClr val="C0392B"/>
+          </a:solidFill>
+          <a:ln>
+            <a:noFill/>
+          </a:ln>
+        </p:spPr>
+        <p:style>
+          <a:lnRef idx="1">
+            <a:schemeClr val="accent1"/>
+          </a:lnRef>
+          <a:fillRef idx="3">
+            <a:schemeClr val="accent1"/>
+          </a:fillRef>
+          <a:effectRef idx="2">
+            <a:schemeClr val="accent1"/>
+          </a:effectRef>
+          <a:fontRef idx="minor">
+            <a:schemeClr val="lt1"/>
+          </a:fontRef>
+        </p:style>
+        <p:txBody>
+          <a:bodyPr rtlCol="0" anchor="ctr" wrap="square" lIns="50800" rIns="50800" tIns="25400" bIns="25400"/>
+          <a:lstStyle/>
+          <a:p>
+            <a:pPr algn="ctr"/>
+            <a:r>
+              <a:rPr sz="1400" b="1">
+                <a:solidFill>
+                  <a:srgbClr val="FFFFFF"/>
+                </a:solidFill>
+                <a:latin typeface="Meiryo"/>
+              </a:rPr>
+              <a:t>最も正確な分類：「Vishing起点のATO（口座乗っ取り）型不正送金」</a:t>
+            </a:r>
+          </a:p>
+        </p:txBody>
+      </p:sp>
+      <p:sp>
+        <p:nvSpPr>
+          <p:cNvPr id="26" name="Rectangle 25"/>
+          <p:cNvSpPr/>
+          <p:nvPr/>
+        </p:nvSpPr>
+        <p:spPr>
+          <a:xfrm>
+            <a:off x="731520" y="5715000"/>
+            <a:ext cx="13624560" cy="365760"/>
+          </a:xfrm>
+          <a:prstGeom prst="rect">
+            <a:avLst/>
+          </a:prstGeom>
+          <a:solidFill>
+            <a:srgbClr val="E67E22"/>
+          </a:solidFill>
+          <a:ln>
+            <a:noFill/>
+          </a:ln>
+        </p:spPr>
+        <p:style>
+          <a:lnRef idx="1">
+            <a:schemeClr val="accent1"/>
+          </a:lnRef>
+          <a:fillRef idx="3">
+            <a:schemeClr val="accent1"/>
+          </a:fillRef>
+          <a:effectRef idx="2">
+            <a:schemeClr val="accent1"/>
+          </a:effectRef>
+          <a:fontRef idx="minor">
+            <a:schemeClr val="lt1"/>
+          </a:fontRef>
+        </p:style>
+        <p:txBody>
+          <a:bodyPr rtlCol="0" anchor="ctr" wrap="square" lIns="50800" rIns="50800" tIns="25400" bIns="25400"/>
+          <a:lstStyle/>
+          <a:p>
+            <a:pPr algn="ctr"/>
+            <a:r>
+              <a:rPr sz="1200" b="1">
+                <a:solidFill>
+                  <a:srgbClr val="FFFFFF"/>
+                </a:solidFill>
+                <a:latin typeface="Meiryo"/>
+              </a:rPr>
+              <a:t>今回の攻撃がBECより厄介な点</a:t>
+            </a:r>
+          </a:p>
+        </p:txBody>
+      </p:sp>
+      <p:sp>
+        <p:nvSpPr>
+          <p:cNvPr id="27" name="Rectangle 26"/>
+          <p:cNvSpPr/>
+          <p:nvPr/>
+        </p:nvSpPr>
+        <p:spPr>
+          <a:xfrm>
+            <a:off x="731520" y="6126480"/>
+            <a:ext cx="13624560" cy="777240"/>
+          </a:xfrm>
+          <a:prstGeom prst="rect">
+            <a:avLst/>
+          </a:prstGeom>
+          <a:solidFill>
+            <a:srgbClr val="FFFFFF"/>
+          </a:solidFill>
+          <a:ln w="25400">
+            <a:solidFill>
+              <a:srgbClr val="E67E22"/>
+            </a:solidFill>
+          </a:ln>
+        </p:spPr>
+        <p:style>
+          <a:lnRef idx="1">
+            <a:schemeClr val="accent1"/>
+          </a:lnRef>
+          <a:fillRef idx="3">
+            <a:schemeClr val="accent1"/>
+          </a:fillRef>
+          <a:effectRef idx="2">
+            <a:schemeClr val="accent1"/>
+          </a:effectRef>
+          <a:fontRef idx="minor">
+            <a:schemeClr val="lt1"/>
+          </a:fontRef>
+        </p:style>
+        <p:txBody>
+          <a:bodyPr rtlCol="0" anchor="ctr" wrap="square" lIns="63500" rIns="50800" tIns="38100" bIns="38100"/>
+          <a:lstStyle/>
+          <a:p>
+            <a:pPr algn="l"/>
+            <a:r>
+              <a:rPr sz="1000" b="0">
+                <a:solidFill>
+                  <a:srgbClr val="222222"/>
+                </a:solidFill>
+                <a:latin typeface="Meiryo"/>
+              </a:rPr>
+              <a:t>• BECは「送金指示を疑う」教育で一定防げる（「口座変更は電話で確認」等）
+• 今回は被害者が銀行の手続きだと信じているので、疑うきっかけがない
+• BECは人が送金するが、今回は犯人が直接送金するので止められない</a:t>
+            </a:r>
+          </a:p>
+        </p:txBody>
+      </p:sp>
+      <p:sp>
+        <p:nvSpPr>
+          <p:cNvPr id="28" name="TextBox 27"/>
+          <p:cNvSpPr txBox="1"/>
+          <p:nvPr/>
+        </p:nvSpPr>
+        <p:spPr>
+          <a:xfrm>
+            <a:off x="9144000" y="10378440"/>
+            <a:ext cx="5943600" cy="228600"/>
+          </a:xfrm>
+          <a:prstGeom prst="rect">
+            <a:avLst/>
+          </a:prstGeom>
+          <a:noFill/>
+        </p:spPr>
+        <p:txBody>
+          <a:bodyPr wrap="square" lIns="50800" rIns="50800" tIns="38100" bIns="38100"/>
+          <a:lstStyle/>
+          <a:p>
+            <a:pPr algn="r"/>
+            <a:r>
+              <a:rPr sz="700" b="0">
+                <a:solidFill>
+                  <a:srgbClr val="888888"/>
+                </a:solidFill>
+                <a:latin typeface="Meiryo"/>
+              </a:rPr>
+              <a:t>Fraud Kill Chain — BECとの違いと攻撃分類</a:t>
             </a:r>
           </a:p>
         </p:txBody>

</xml_diff>